<commit_message>
feat: agregar axe DevTools + templates de Issues + eliminar corrección obligatoria
- PPT actualizado: agrega axe DevTools como herramienta de auditoría
- PPT actualizado: aclara que NO se requiere aplicar correcciones en código
- Nueva carpeta .github/ISSUE_TEMPLATE/ con 4 templates (rendimiento, mantenimiento, accesibilidad, general)
- Instrucciones y checklist actualizados
- README plantilla actualizado
- Rúbrica PPTX regenerada
</commit_message>
<xml_diff>
--- a/EVALUACION_PRACTICA_01.pptx
+++ b/EVALUACION_PRACTICA_01.pptx
@@ -3557,7 +3557,7 @@
           <a:p>
             <a:pPr algn="l"/>
             <a:r>
-              <a:rPr sz="2200" b="0">
+              <a:rPr sz="2000" b="0">
                 <a:solidFill>
                   <a:srgbClr val="2A2A2A"/>
                 </a:solidFill>
@@ -3569,7 +3569,7 @@
           <a:p>
             <a:pPr algn="l"/>
             <a:r>
-              <a:rPr sz="2200" b="0">
+              <a:rPr sz="2000" b="0">
                 <a:solidFill>
                   <a:srgbClr val="2A2A2A"/>
                 </a:solidFill>
@@ -3581,7 +3581,7 @@
           <a:p>
             <a:pPr algn="l"/>
             <a:r>
-              <a:rPr sz="2200" b="0">
+              <a:rPr sz="2000" b="0">
                 <a:solidFill>
                   <a:srgbClr val="2A2A2A"/>
                 </a:solidFill>
@@ -3593,13 +3593,13 @@
           <a:p>
             <a:pPr algn="l"/>
             <a:r>
-              <a:rPr sz="2200" b="0">
+              <a:rPr sz="2000" b="0">
                 <a:solidFill>
                   <a:srgbClr val="2A2A2A"/>
                 </a:solidFill>
                 <a:latin typeface="Calibri"/>
               </a:rPr>
-              <a:t>☐ Corregí al menos 1 problema</a:t>
+              <a:t>☐ Cada Issue usa un template</a:t>
             </a:r>
           </a:p>
         </p:txBody>
@@ -3628,49 +3628,49 @@
           <a:p>
             <a:pPr algn="l"/>
             <a:r>
-              <a:rPr sz="2200" b="0">
+              <a:rPr sz="2000" b="0">
                 <a:solidFill>
                   <a:srgbClr val="2A2A2A"/>
                 </a:solidFill>
                 <a:latin typeface="Calibri"/>
               </a:rPr>
-              <a:t>☐ Hice commit y push</a:t>
-            </a:r>
-          </a:p>
-          <a:p>
-            <a:pPr algn="l"/>
-            <a:r>
-              <a:rPr sz="2200" b="0">
+              <a:t>☐ Cada Issue tiene todas las secciones</a:t>
+            </a:r>
+          </a:p>
+          <a:p>
+            <a:pPr algn="l"/>
+            <a:r>
+              <a:rPr sz="2000" b="0">
                 <a:solidFill>
                   <a:srgbClr val="2A2A2A"/>
                 </a:solidFill>
                 <a:latin typeface="Calibri"/>
               </a:rPr>
+              <a:t>☐ Soluciones propuestas en texto</a:t>
+            </a:r>
+          </a:p>
+          <a:p>
+            <a:pPr algn="l"/>
+            <a:r>
+              <a:rPr sz="2000" b="0">
+                <a:solidFill>
+                  <a:srgbClr val="2A2A2A"/>
+                </a:solidFill>
+                <a:latin typeface="Calibri"/>
+              </a:rPr>
               <a:t>☐ README completo</a:t>
             </a:r>
           </a:p>
           <a:p>
             <a:pPr algn="l"/>
             <a:r>
-              <a:rPr sz="2200" b="0">
+              <a:rPr sz="2000" b="0">
                 <a:solidFill>
                   <a:srgbClr val="2A2A2A"/>
                 </a:solidFill>
                 <a:latin typeface="Calibri"/>
               </a:rPr>
-              <a:t>☐ URLs registradas en el README</a:t>
-            </a:r>
-          </a:p>
-          <a:p>
-            <a:pPr algn="l"/>
-            <a:r>
-              <a:rPr sz="2200" b="0">
-                <a:solidFill>
-                  <a:srgbClr val="2A2A2A"/>
-                </a:solidFill>
-                <a:latin typeface="Calibri"/>
-              </a:rPr>
-              <a:t>☐ Datos del estudiante completos</a:t>
+              <a:t>☐ URLs y datos del estudiante</a:t>
             </a:r>
           </a:p>
         </p:txBody>
@@ -4045,7 +4045,7 @@
           <a:p>
             <a:pPr algn="l"/>
             <a:r>
-              <a:rPr sz="1800" b="1">
+              <a:rPr sz="1600" b="1">
                 <a:solidFill>
                   <a:srgbClr val="2A2A2A"/>
                 </a:solidFill>
@@ -4057,7 +4057,7 @@
           <a:p>
             <a:pPr algn="l"/>
             <a:r>
-              <a:rPr sz="1800" b="0">
+              <a:rPr sz="1600" b="0">
                 <a:solidFill>
                   <a:srgbClr val="2A2A2A"/>
                 </a:solidFill>
@@ -4069,7 +4069,7 @@
           <a:p>
             <a:pPr algn="l"/>
             <a:r>
-              <a:rPr sz="1800" b="0">
+              <a:rPr sz="1600" b="0">
                 <a:solidFill>
                   <a:srgbClr val="2A2A2A"/>
                 </a:solidFill>
@@ -4081,7 +4081,7 @@
           <a:p>
             <a:pPr algn="l"/>
             <a:r>
-              <a:rPr sz="1800" b="0">
+              <a:rPr sz="1600" b="0">
                 <a:solidFill>
                   <a:srgbClr val="2A2A2A"/>
                 </a:solidFill>
@@ -4093,7 +4093,7 @@
           <a:p>
             <a:pPr algn="l"/>
             <a:r>
-              <a:rPr sz="1800" b="0">
+              <a:rPr sz="1600" b="0">
                 <a:solidFill>
                   <a:srgbClr val="2A2A2A"/>
                 </a:solidFill>
@@ -4105,7 +4105,7 @@
           <a:p>
             <a:pPr algn="l"/>
             <a:r>
-              <a:rPr sz="1800" b="0">
+              <a:rPr sz="1600" b="0">
                 <a:solidFill>
                   <a:srgbClr val="2A2A2A"/>
                 </a:solidFill>
@@ -4117,13 +4117,25 @@
           <a:p>
             <a:pPr algn="l"/>
             <a:r>
-              <a:rPr sz="1800" b="0">
+              <a:rPr sz="1600" b="0">
                 <a:solidFill>
                   <a:srgbClr val="2A2A2A"/>
                 </a:solidFill>
                 <a:latin typeface="Calibri"/>
               </a:rPr>
-              <a:t>• GitHub Issues</a:t>
+              <a:t>• axe DevTools (accesibilidad)</a:t>
+            </a:r>
+          </a:p>
+          <a:p>
+            <a:pPr algn="l"/>
+            <a:r>
+              <a:rPr sz="1600" b="0">
+                <a:solidFill>
+                  <a:srgbClr val="2A2A2A"/>
+                </a:solidFill>
+                <a:latin typeface="Calibri"/>
+              </a:rPr>
+              <a:t>• GitHub Issues (con templates)</a:t>
             </a:r>
           </a:p>
         </p:txBody>
@@ -4152,7 +4164,7 @@
           <a:p>
             <a:pPr algn="l"/>
             <a:r>
-              <a:rPr sz="1800" b="1">
+              <a:rPr sz="1600" b="1">
                 <a:solidFill>
                   <a:srgbClr val="2A2A2A"/>
                 </a:solidFill>
@@ -4164,7 +4176,7 @@
           <a:p>
             <a:pPr algn="l"/>
             <a:r>
-              <a:rPr sz="1800" b="0">
+              <a:rPr sz="1600" b="0">
                 <a:solidFill>
                   <a:srgbClr val="2A2A2A"/>
                 </a:solidFill>
@@ -4176,7 +4188,7 @@
           <a:p>
             <a:pPr algn="l"/>
             <a:r>
-              <a:rPr sz="1800" b="0">
+              <a:rPr sz="1600" b="0">
                 <a:solidFill>
                   <a:srgbClr val="2A2A2A"/>
                 </a:solidFill>
@@ -4188,7 +4200,7 @@
           <a:p>
             <a:pPr algn="l"/>
             <a:r>
-              <a:rPr sz="1800" b="0">
+              <a:rPr sz="1600" b="0">
                 <a:solidFill>
                   <a:srgbClr val="2A2A2A"/>
                 </a:solidFill>
@@ -4200,7 +4212,7 @@
           <a:p>
             <a:pPr algn="l"/>
             <a:r>
-              <a:rPr sz="1800" b="0">
+              <a:rPr sz="1600" b="0">
                 <a:solidFill>
                   <a:srgbClr val="2A2A2A"/>
                 </a:solidFill>
@@ -4212,7 +4224,7 @@
           <a:p>
             <a:pPr algn="l"/>
             <a:r>
-              <a:rPr sz="1800" b="0">
+              <a:rPr sz="1600" b="0">
                 <a:solidFill>
                   <a:srgbClr val="2A2A2A"/>
                 </a:solidFill>
@@ -4224,7 +4236,7 @@
           <a:p>
             <a:pPr algn="l"/>
             <a:r>
-              <a:rPr sz="1800" b="0">
+              <a:rPr sz="1600" b="0">
                 <a:solidFill>
                   <a:srgbClr val="2A2A2A"/>
                 </a:solidFill>
@@ -4304,13 +4316,13 @@
           <a:p>
             <a:pPr algn="ctr"/>
             <a:r>
-              <a:rPr sz="1600" b="1">
+              <a:rPr sz="1400" b="1">
                 <a:solidFill>
                   <a:srgbClr val="065A82"/>
                 </a:solidFill>
                 <a:latin typeface="Calibri"/>
               </a:rPr>
-              <a:t>❌ No se evalúa programación avanzada ni frameworks complejos.</a:t>
+              <a:t>❌ No se evalúa programación avanzada ni aplicar correcciones en código.</a:t>
             </a:r>
           </a:p>
         </p:txBody>
@@ -4998,7 +5010,8 @@
                 </a:solidFill>
                 <a:latin typeface="Calibri"/>
               </a:rPr>
-              <a:t>Auditar</a:t>
+              <a:t>Auditar
++axe</a:t>
             </a:r>
           </a:p>
         </p:txBody>
@@ -5241,8 +5254,8 @@
                 </a:solidFill>
                 <a:latin typeface="Calibri"/>
               </a:rPr>
-              <a:t>Corregir
-1</a:t>
+              <a:t>Documentar
+solución</a:t>
             </a:r>
           </a:p>
         </p:txBody>
@@ -5413,7 +5426,7 @@
         <p:spPr>
           <a:xfrm>
             <a:off x="457200" y="4572000"/>
-            <a:ext cx="10972800" cy="1828800"/>
+            <a:ext cx="10972800" cy="1371600"/>
           </a:xfrm>
           <a:prstGeom prst="rect">
             <a:avLst/>
@@ -5428,7 +5441,7 @@
           <a:p>
             <a:pPr algn="l"/>
             <a:r>
-              <a:rPr sz="1600" b="0">
+              <a:rPr sz="1400" b="0">
                 <a:solidFill>
                   <a:srgbClr val="2A2A2A"/>
                 </a:solidFill>
@@ -5440,27 +5453,72 @@
           <a:p>
             <a:pPr algn="l"/>
             <a:r>
-              <a:rPr sz="1600" b="0">
+              <a:rPr sz="1400" b="0">
                 <a:solidFill>
                   <a:srgbClr val="2A2A2A"/>
                 </a:solidFill>
                 <a:latin typeface="Calibri"/>
               </a:rPr>
-              <a:t>Issues: 20 min   •   Corrección: 15 min   •   README: 15 min   •   Verificación: 5 min</a:t>
-            </a:r>
-          </a:p>
-        </p:txBody>
-      </p:sp>
-      <p:sp>
-        <p:nvSpPr>
-          <p:cNvPr id="28" name="TextBox 27"/>
+              <a:t>Issues: 20 min   •   Documentar solución: 10 min   •   README: 15 min   •   Verificación: 5 min</a:t>
+            </a:r>
+          </a:p>
+        </p:txBody>
+      </p:sp>
+      <p:sp>
+        <p:nvSpPr>
+          <p:cNvPr id="28" name="Rounded Rectangle 27"/>
+          <p:cNvSpPr/>
+          <p:nvPr/>
+        </p:nvSpPr>
+        <p:spPr>
+          <a:xfrm>
+            <a:off x="640080" y="5760720"/>
+            <a:ext cx="10972800" cy="457200"/>
+          </a:xfrm>
+          <a:prstGeom prst="roundRect">
+            <a:avLst/>
+          </a:prstGeom>
+          <a:solidFill>
+            <a:srgbClr val="FFF3CD"/>
+          </a:solidFill>
+          <a:ln>
+            <a:solidFill>
+              <a:srgbClr val="E6A23E"/>
+            </a:solidFill>
+          </a:ln>
+        </p:spPr>
+        <p:style>
+          <a:lnRef idx="1">
+            <a:schemeClr val="accent1"/>
+          </a:lnRef>
+          <a:fillRef idx="3">
+            <a:schemeClr val="accent1"/>
+          </a:fillRef>
+          <a:effectRef idx="2">
+            <a:schemeClr val="accent1"/>
+          </a:effectRef>
+          <a:fontRef idx="minor">
+            <a:schemeClr val="lt1"/>
+          </a:fontRef>
+        </p:style>
+        <p:txBody>
+          <a:bodyPr rtlCol="0" anchor="ctr"/>
+          <a:lstStyle/>
+          <a:p>
+            <a:pPr algn="ctr"/>
+          </a:p>
+        </p:txBody>
+      </p:sp>
+      <p:sp>
+        <p:nvSpPr>
+          <p:cNvPr id="29" name="TextBox 28"/>
           <p:cNvSpPr txBox="1"/>
           <p:nvPr/>
         </p:nvSpPr>
         <p:spPr>
           <a:xfrm>
-            <a:off x="457200" y="6400800"/>
-            <a:ext cx="5486400" cy="365760"/>
+            <a:off x="640080" y="5806440"/>
+            <a:ext cx="10972800" cy="365760"/>
           </a:xfrm>
           <a:prstGeom prst="rect">
             <a:avLst/>
@@ -5473,6 +5531,41 @@
           </a:bodyPr>
           <a:lstStyle/>
           <a:p>
+            <a:pPr algn="ctr"/>
+            <a:r>
+              <a:rPr sz="1300" b="1">
+                <a:solidFill>
+                  <a:srgbClr val="924E0E"/>
+                </a:solidFill>
+                <a:latin typeface="Calibri"/>
+              </a:rPr>
+              <a:t>⚠️  No es necesario aplicar las correcciones. Basta con especificar la solución en el texto de cada Issue.</a:t>
+            </a:r>
+          </a:p>
+        </p:txBody>
+      </p:sp>
+      <p:sp>
+        <p:nvSpPr>
+          <p:cNvPr id="30" name="TextBox 29"/>
+          <p:cNvSpPr txBox="1"/>
+          <p:nvPr/>
+        </p:nvSpPr>
+        <p:spPr>
+          <a:xfrm>
+            <a:off x="457200" y="6400800"/>
+            <a:ext cx="5486400" cy="365760"/>
+          </a:xfrm>
+          <a:prstGeom prst="rect">
+            <a:avLst/>
+          </a:prstGeom>
+          <a:noFill/>
+        </p:spPr>
+        <p:txBody>
+          <a:bodyPr wrap="square">
+            <a:spAutoFit/>
+          </a:bodyPr>
+          <a:lstStyle/>
+          <a:p>
             <a:pPr algn="l"/>
             <a:r>
               <a:rPr sz="1000" b="0">
@@ -5488,7 +5581,7 @@
       </p:sp>
       <p:sp>
         <p:nvSpPr>
-          <p:cNvPr id="29" name="TextBox 28"/>
+          <p:cNvPr id="31" name="TextBox 30"/>
           <p:cNvSpPr txBox="1"/>
           <p:nvPr/>
         </p:nvSpPr>
@@ -6883,7 +6976,7 @@
         <p:spPr>
           <a:xfrm>
             <a:off x="822960" y="1737360"/>
-            <a:ext cx="5486400" cy="2743200"/>
+            <a:ext cx="5486400" cy="3200400"/>
           </a:xfrm>
           <a:prstGeom prst="rect">
             <a:avLst/>
@@ -6898,7 +6991,7 @@
           <a:p>
             <a:pPr algn="l"/>
             <a:r>
-              <a:rPr sz="1600" b="1">
+              <a:rPr sz="1400" b="1">
                 <a:solidFill>
                   <a:srgbClr val="2A2A2A"/>
                 </a:solidFill>
@@ -6910,7 +7003,7 @@
           <a:p>
             <a:pPr algn="l"/>
             <a:r>
-              <a:rPr sz="1600" b="0">
+              <a:rPr sz="1400" b="0">
                 <a:solidFill>
                   <a:srgbClr val="2A2A2A"/>
                 </a:solidFill>
@@ -6922,7 +7015,7 @@
           <a:p>
             <a:pPr algn="l"/>
             <a:r>
-              <a:rPr sz="1600" b="0">
+              <a:rPr sz="1400" b="0">
                 <a:solidFill>
                   <a:srgbClr val="2A2A2A"/>
                 </a:solidFill>
@@ -6934,7 +7027,7 @@
           <a:p>
             <a:pPr algn="l"/>
             <a:r>
-              <a:rPr sz="1600" b="0">
+              <a:rPr sz="1400" b="0">
                 <a:solidFill>
                   <a:srgbClr val="2A2A2A"/>
                 </a:solidFill>
@@ -6946,19 +7039,19 @@
           <a:p>
             <a:pPr algn="l"/>
             <a:r>
-              <a:rPr sz="1600" b="1">
+              <a:rPr sz="1400" b="1">
                 <a:solidFill>
                   <a:srgbClr val="2A2A2A"/>
                 </a:solidFill>
                 <a:latin typeface="Calibri"/>
               </a:rPr>
-              <a:t>💡 Lighthouse</a:t>
-            </a:r>
-          </a:p>
-          <a:p>
-            <a:pPr algn="l"/>
-            <a:r>
-              <a:rPr sz="1600" b="0">
+              <a:t>💡 Lighthouse (DevTools)</a:t>
+            </a:r>
+          </a:p>
+          <a:p>
+            <a:pPr algn="l"/>
+            <a:r>
+              <a:rPr sz="1400" b="0">
                 <a:solidFill>
                   <a:srgbClr val="2A2A2A"/>
                 </a:solidFill>
@@ -6970,7 +7063,7 @@
           <a:p>
             <a:pPr algn="l"/>
             <a:r>
-              <a:rPr sz="1600" b="0">
+              <a:rPr sz="1400" b="0">
                 <a:solidFill>
                   <a:srgbClr val="2A2A2A"/>
                 </a:solidFill>
@@ -6983,14 +7076,145 @@
       </p:sp>
       <p:sp>
         <p:nvSpPr>
-          <p:cNvPr id="8" name="Rounded Rectangle 7"/>
+          <p:cNvPr id="8" name="TextBox 7"/>
+          <p:cNvSpPr txBox="1"/>
+          <p:nvPr/>
+        </p:nvSpPr>
+        <p:spPr>
+          <a:xfrm>
+            <a:off x="6400800" y="1737360"/>
+            <a:ext cx="5303520" cy="3200400"/>
+          </a:xfrm>
+          <a:prstGeom prst="rect">
+            <a:avLst/>
+          </a:prstGeom>
+          <a:noFill/>
+        </p:spPr>
+        <p:txBody>
+          <a:bodyPr wrap="square">
+            <a:spAutoFit/>
+          </a:bodyPr>
+          <a:lstStyle/>
+          <a:p>
+            <a:pPr algn="l"/>
+            <a:r>
+              <a:rPr sz="1400" b="1">
+                <a:solidFill>
+                  <a:srgbClr val="2A2A2A"/>
+                </a:solidFill>
+                <a:latin typeface="Calibri"/>
+              </a:rPr>
+              <a:t>♿ axe DevTools (extensión)</a:t>
+            </a:r>
+          </a:p>
+          <a:p>
+            <a:pPr algn="l"/>
+            <a:r>
+              <a:rPr sz="1400" b="0">
+                <a:solidFill>
+                  <a:srgbClr val="2A2A2A"/>
+                </a:solidFill>
+                <a:latin typeface="Calibri"/>
+              </a:rPr>
+              <a:t>• Pestaña axe DevTools</a:t>
+            </a:r>
+          </a:p>
+          <a:p>
+            <a:pPr algn="l"/>
+            <a:r>
+              <a:rPr sz="1400" b="0">
+                <a:solidFill>
+                  <a:srgbClr val="2A2A2A"/>
+                </a:solidFill>
+                <a:latin typeface="Calibri"/>
+              </a:rPr>
+              <a:t>• Scan ALL of my page</a:t>
+            </a:r>
+          </a:p>
+          <a:p>
+            <a:pPr algn="l"/>
+            <a:r>
+              <a:rPr sz="1400" b="0">
+                <a:solidFill>
+                  <a:srgbClr val="2A2A2A"/>
+                </a:solidFill>
+                <a:latin typeface="Calibri"/>
+              </a:rPr>
+              <a:t>• Detecta accesibilidad</a:t>
+            </a:r>
+          </a:p>
+          <a:p>
+            <a:pPr algn="l"/>
+            <a:r>
+              <a:rPr sz="1400" b="0">
+                <a:solidFill>
+                  <a:srgbClr val="2A2A2A"/>
+                </a:solidFill>
+                <a:latin typeface="Calibri"/>
+              </a:rPr>
+              <a:t>  (alt, contraste, ARIA, etc.)</a:t>
+            </a:r>
+          </a:p>
+          <a:p>
+            <a:pPr algn="l"/>
+            <a:r>
+              <a:rPr sz="1400" b="0">
+                <a:solidFill>
+                  <a:srgbClr val="2A2A2A"/>
+                </a:solidFill>
+                <a:latin typeface="Calibri"/>
+              </a:rPr>
+              <a:t/>
+            </a:r>
+          </a:p>
+          <a:p>
+            <a:pPr algn="l"/>
+            <a:r>
+              <a:rPr sz="1400" b="1">
+                <a:solidFill>
+                  <a:srgbClr val="2A2A2A"/>
+                </a:solidFill>
+                <a:latin typeface="Calibri"/>
+              </a:rPr>
+              <a:t>Si no tienes la extensión:</a:t>
+            </a:r>
+          </a:p>
+          <a:p>
+            <a:pPr algn="l"/>
+            <a:r>
+              <a:rPr sz="1400" b="0">
+                <a:solidFill>
+                  <a:srgbClr val="2A2A2A"/>
+                </a:solidFill>
+                <a:latin typeface="Calibri"/>
+              </a:rPr>
+              <a:t>• chromewebstore → buscar</a:t>
+            </a:r>
+          </a:p>
+          <a:p>
+            <a:pPr algn="l"/>
+            <a:r>
+              <a:rPr sz="1400" b="0">
+                <a:solidFill>
+                  <a:srgbClr val="2A2A2A"/>
+                </a:solidFill>
+                <a:latin typeface="Calibri"/>
+              </a:rPr>
+              <a:t>  "axe DevTools"</a:t>
+            </a:r>
+          </a:p>
+        </p:txBody>
+      </p:sp>
+      <p:sp>
+        <p:nvSpPr>
+          <p:cNvPr id="9" name="Rounded Rectangle 8"/>
           <p:cNvSpPr/>
           <p:nvPr/>
         </p:nvSpPr>
         <p:spPr>
           <a:xfrm>
-            <a:off x="6675120" y="1737360"/>
-            <a:ext cx="5029200" cy="2743200"/>
+            <a:off x="640080" y="4937760"/>
+            <a:ext cx="10972800" cy="731520"/>
           </a:xfrm>
           <a:prstGeom prst="roundRect">
             <a:avLst/>
@@ -7028,14 +7252,14 @@
       </p:sp>
       <p:sp>
         <p:nvSpPr>
-          <p:cNvPr id="9" name="TextBox 8"/>
+          <p:cNvPr id="10" name="TextBox 9"/>
           <p:cNvSpPr txBox="1"/>
           <p:nvPr/>
         </p:nvSpPr>
         <p:spPr>
           <a:xfrm>
-            <a:off x="6858000" y="1874519"/>
-            <a:ext cx="4754880" cy="2560320"/>
+            <a:off x="822960" y="4983480"/>
+            <a:ext cx="10607040" cy="640080"/>
           </a:xfrm>
           <a:prstGeom prst="rect">
             <a:avLst/>
@@ -7052,109 +7276,25 @@
             <a:r>
               <a:rPr sz="1400" b="1">
                 <a:solidFill>
-                  <a:srgbClr val="2A2A2A"/>
-                </a:solidFill>
-                <a:latin typeface="Calibri"/>
-              </a:rPr>
-              <a:t>🎯 Objetivo</a:t>
-            </a:r>
-          </a:p>
-          <a:p>
-            <a:pPr algn="l"/>
-            <a:r>
-              <a:rPr sz="1400" b="0">
-                <a:solidFill>
-                  <a:srgbClr val="2A2A2A"/>
-                </a:solidFill>
-                <a:latin typeface="Calibri"/>
-              </a:rPr>
-              <a:t>Encontrar 3 problemas reales.</a:t>
-            </a:r>
-          </a:p>
-          <a:p>
-            <a:pPr algn="l"/>
-            <a:r>
-              <a:rPr sz="1400" b="0">
-                <a:solidFill>
-                  <a:srgbClr val="2A2A2A"/>
-                </a:solidFill>
-                <a:latin typeface="Calibri"/>
-              </a:rPr>
-              <a:t/>
-            </a:r>
-          </a:p>
-          <a:p>
-            <a:pPr algn="l"/>
-            <a:r>
-              <a:rPr sz="1400" b="1">
-                <a:solidFill>
-                  <a:srgbClr val="2A2A2A"/>
-                </a:solidFill>
-                <a:latin typeface="Calibri"/>
-              </a:rPr>
-              <a:t>Tipos posibles:</a:t>
-            </a:r>
-          </a:p>
-          <a:p>
-            <a:pPr algn="l"/>
-            <a:r>
-              <a:rPr sz="1400" b="0">
-                <a:solidFill>
-                  <a:srgbClr val="2A2A2A"/>
-                </a:solidFill>
-                <a:latin typeface="Calibri"/>
-              </a:rPr>
-              <a:t>• Rendimiento (imágenes, scripts, métricas)</a:t>
-            </a:r>
-          </a:p>
-          <a:p>
-            <a:pPr algn="l"/>
-            <a:r>
-              <a:rPr sz="1400" b="0">
-                <a:solidFill>
-                  <a:srgbClr val="2A2A2A"/>
-                </a:solidFill>
-                <a:latin typeface="Calibri"/>
-              </a:rPr>
-              <a:t>• Mantenimiento (dependencias)</a:t>
-            </a:r>
-          </a:p>
-          <a:p>
-            <a:pPr algn="l"/>
-            <a:r>
-              <a:rPr sz="1400" b="0">
-                <a:solidFill>
-                  <a:srgbClr val="2A2A2A"/>
-                </a:solidFill>
-                <a:latin typeface="Calibri"/>
-              </a:rPr>
-              <a:t>• Seguridad básica</a:t>
-            </a:r>
-          </a:p>
-          <a:p>
-            <a:pPr algn="l"/>
-            <a:r>
-              <a:rPr sz="1400" b="0">
-                <a:solidFill>
-                  <a:srgbClr val="2A2A2A"/>
-                </a:solidFill>
-                <a:latin typeface="Calibri"/>
-              </a:rPr>
-              <a:t>• Administración (documentación)</a:t>
-            </a:r>
-          </a:p>
-        </p:txBody>
-      </p:sp>
-      <p:sp>
-        <p:nvSpPr>
-          <p:cNvPr id="10" name="Rounded Rectangle 9"/>
+                  <a:srgbClr val="065A82"/>
+                </a:solidFill>
+                <a:latin typeface="Calibri"/>
+              </a:rPr>
+              <a:t>🎯 Objetivo: encontrar 3 problemas reales (rendimiento, accesibilidad, mantenimiento, seguridad básica, administración).</a:t>
+            </a:r>
+          </a:p>
+        </p:txBody>
+      </p:sp>
+      <p:sp>
+        <p:nvSpPr>
+          <p:cNvPr id="11" name="Rounded Rectangle 10"/>
           <p:cNvSpPr/>
           <p:nvPr/>
         </p:nvSpPr>
         <p:spPr>
           <a:xfrm>
-            <a:off x="640080" y="5669280"/>
-            <a:ext cx="10972800" cy="548640"/>
+            <a:off x="640080" y="5852160"/>
+            <a:ext cx="10972800" cy="457200"/>
           </a:xfrm>
           <a:prstGeom prst="roundRect">
             <a:avLst/>
@@ -7192,13 +7332,13 @@
       </p:sp>
       <p:sp>
         <p:nvSpPr>
-          <p:cNvPr id="11" name="TextBox 10"/>
+          <p:cNvPr id="12" name="TextBox 11"/>
           <p:cNvSpPr txBox="1"/>
           <p:nvPr/>
         </p:nvSpPr>
         <p:spPr>
           <a:xfrm>
-            <a:off x="640080" y="5760720"/>
+            <a:off x="640080" y="5897880"/>
             <a:ext cx="10972800" cy="365760"/>
           </a:xfrm>
           <a:prstGeom prst="rect">
@@ -7214,20 +7354,20 @@
           <a:p>
             <a:pPr algn="ctr"/>
             <a:r>
-              <a:rPr sz="1400" b="1">
+              <a:rPr sz="1300" b="1">
                 <a:solidFill>
                   <a:srgbClr val="065A82"/>
                 </a:solidFill>
                 <a:latin typeface="Calibri"/>
               </a:rPr>
-              <a:t>💡 No necesitas una puntuación perfecta de Lighthouse. Solo identificar problemas reales.</a:t>
-            </a:r>
-          </a:p>
-        </p:txBody>
-      </p:sp>
-      <p:sp>
-        <p:nvSpPr>
-          <p:cNvPr id="12" name="TextBox 11"/>
+              <a:t>💡 No necesitas puntuación perfecta de Lighthouse. Solo identificar problemas reales.</a:t>
+            </a:r>
+          </a:p>
+        </p:txBody>
+      </p:sp>
+      <p:sp>
+        <p:nvSpPr>
+          <p:cNvPr id="13" name="TextBox 12"/>
           <p:cNvSpPr txBox="1"/>
           <p:nvPr/>
         </p:nvSpPr>
@@ -7262,7 +7402,7 @@
       </p:sp>
       <p:sp>
         <p:nvSpPr>
-          <p:cNvPr id="13" name="TextBox 12"/>
+          <p:cNvPr id="14" name="TextBox 13"/>
           <p:cNvSpPr txBox="1"/>
           <p:nvPr/>
         </p:nvSpPr>
@@ -7464,7 +7604,7 @@
                 </a:solidFill>
                 <a:latin typeface="Calibri"/>
               </a:rPr>
-              <a:t>⏱ 20 minutos</a:t>
+              <a:t>⏱ 20 minutos  •  Usa los templates del repo</a:t>
             </a:r>
           </a:p>
         </p:txBody>
@@ -7478,7 +7618,7 @@
         <p:spPr>
           <a:xfrm>
             <a:off x="640080" y="1280160"/>
-            <a:ext cx="10972800" cy="1188720"/>
+            <a:ext cx="10972800" cy="822960"/>
           </a:xfrm>
           <a:prstGeom prst="rect">
             <a:avLst/>
@@ -7493,39 +7633,98 @@
           <a:p>
             <a:pPr algn="l"/>
             <a:r>
-              <a:rPr sz="1800" b="1">
+              <a:rPr sz="1500" b="1">
                 <a:solidFill>
                   <a:srgbClr val="2A2A2A"/>
                 </a:solidFill>
                 <a:latin typeface="Calibri"/>
               </a:rPr>
-              <a:t>Crear EXACTAMENTE 3 Issues, una por cada problema detectado.</a:t>
-            </a:r>
-          </a:p>
-          <a:p>
-            <a:pPr algn="l"/>
-            <a:r>
-              <a:rPr sz="1800" b="0">
+              <a:t>Crear EXACTAMENTE 3 Issues usando los templates de .github/ISSUE_TEMPLATE/:</a:t>
+            </a:r>
+          </a:p>
+        </p:txBody>
+      </p:sp>
+      <p:sp>
+        <p:nvSpPr>
+          <p:cNvPr id="7" name="TextBox 6"/>
+          <p:cNvSpPr txBox="1"/>
+          <p:nvPr/>
+        </p:nvSpPr>
+        <p:spPr>
+          <a:xfrm>
+            <a:off x="822960" y="1783080"/>
+            <a:ext cx="10972800" cy="1097280"/>
+          </a:xfrm>
+          <a:prstGeom prst="rect">
+            <a:avLst/>
+          </a:prstGeom>
+          <a:noFill/>
+        </p:spPr>
+        <p:txBody>
+          <a:bodyPr wrap="square">
+            <a:spAutoFit/>
+          </a:bodyPr>
+          <a:lstStyle/>
+          <a:p>
+            <a:pPr algn="l"/>
+            <a:r>
+              <a:rPr sz="1400" b="0">
                 <a:solidFill>
                   <a:srgbClr val="2A2A2A"/>
                 </a:solidFill>
                 <a:latin typeface="Calibri"/>
               </a:rPr>
-              <a:t>Cada Issue debe tener todas las secciones del formato:</a:t>
-            </a:r>
-          </a:p>
-        </p:txBody>
-      </p:sp>
-      <p:sp>
-        <p:nvSpPr>
-          <p:cNvPr id="7" name="Rounded Rectangle 6"/>
+              <a:t>📊 rendimiento.md     →  hallazgos de performance / Lighthouse</a:t>
+            </a:r>
+          </a:p>
+          <a:p>
+            <a:pPr algn="l"/>
+            <a:r>
+              <a:rPr sz="1400" b="0">
+                <a:solidFill>
+                  <a:srgbClr val="2A2A2A"/>
+                </a:solidFill>
+                <a:latin typeface="Calibri"/>
+              </a:rPr>
+              <a:t>🔧 mantenimiento.md   →  hallazgos de dependencias / seguridad</a:t>
+            </a:r>
+          </a:p>
+          <a:p>
+            <a:pPr algn="l"/>
+            <a:r>
+              <a:rPr sz="1400" b="0">
+                <a:solidFill>
+                  <a:srgbClr val="2A2A2A"/>
+                </a:solidFill>
+                <a:latin typeface="Calibri"/>
+              </a:rPr>
+              <a:t>♿ accesibilidad.md   →  hallazgos de axe DevTools</a:t>
+            </a:r>
+          </a:p>
+          <a:p>
+            <a:pPr algn="l"/>
+            <a:r>
+              <a:rPr sz="1400" b="0">
+                <a:solidFill>
+                  <a:srgbClr val="2A2A2A"/>
+                </a:solidFill>
+                <a:latin typeface="Calibri"/>
+              </a:rPr>
+              <a:t>📝 general.md         →  cualquier otro hallazgo</a:t>
+            </a:r>
+          </a:p>
+        </p:txBody>
+      </p:sp>
+      <p:sp>
+        <p:nvSpPr>
+          <p:cNvPr id="8" name="Rounded Rectangle 7"/>
           <p:cNvSpPr/>
           <p:nvPr/>
         </p:nvSpPr>
         <p:spPr>
           <a:xfrm>
-            <a:off x="640080" y="2377440"/>
-            <a:ext cx="10972800" cy="3291840"/>
+            <a:off x="640080" y="3017520"/>
+            <a:ext cx="10972800" cy="2743200"/>
           </a:xfrm>
           <a:prstGeom prst="roundRect">
             <a:avLst/>
@@ -7563,14 +7762,14 @@
       </p:sp>
       <p:sp>
         <p:nvSpPr>
-          <p:cNvPr id="8" name="TextBox 7"/>
+          <p:cNvPr id="9" name="TextBox 8"/>
           <p:cNvSpPr txBox="1"/>
           <p:nvPr/>
         </p:nvSpPr>
         <p:spPr>
           <a:xfrm>
-            <a:off x="822960" y="2468880"/>
-            <a:ext cx="10607040" cy="3200400"/>
+            <a:off x="822960" y="3108960"/>
+            <a:ext cx="10607040" cy="2651760"/>
           </a:xfrm>
           <a:prstGeom prst="rect">
             <a:avLst/>
@@ -7585,31 +7784,31 @@
           <a:p>
             <a:pPr algn="l"/>
             <a:r>
-              <a:rPr sz="1400" b="1">
+              <a:rPr sz="1300" b="1">
                 <a:solidFill>
                   <a:srgbClr val="FFFFFF"/>
                 </a:solidFill>
                 <a:latin typeface="Calibri"/>
               </a:rPr>
-              <a:t>### Problema</a:t>
-            </a:r>
-          </a:p>
-          <a:p>
-            <a:pPr algn="l"/>
-            <a:r>
-              <a:rPr sz="1400" b="0">
+              <a:t>### Problema                |   ### Ubicación y reproducción</a:t>
+            </a:r>
+          </a:p>
+          <a:p>
+            <a:pPr algn="l"/>
+            <a:r>
+              <a:rPr sz="1300" b="0">
                 <a:solidFill>
                   <a:srgbClr val="FFFFFF"/>
                 </a:solidFill>
                 <a:latin typeface="Calibri"/>
               </a:rPr>
-              <a:t>¿Qué encontraste?</a:t>
-            </a:r>
-          </a:p>
-          <a:p>
-            <a:pPr algn="l"/>
-            <a:r>
-              <a:rPr sz="1400" b="0">
+              <a:t>¿Qué encontraste?                    ¿Dónde? ¿Cómo comprobarlo?</a:t>
+            </a:r>
+          </a:p>
+          <a:p>
+            <a:pPr algn="l"/>
+            <a:r>
+              <a:rPr sz="1300" b="0">
                 <a:solidFill>
                   <a:srgbClr val="FFFFFF"/>
                 </a:solidFill>
@@ -7621,31 +7820,31 @@
           <a:p>
             <a:pPr algn="l"/>
             <a:r>
-              <a:rPr sz="1400" b="1">
+              <a:rPr sz="1300" b="1">
                 <a:solidFill>
                   <a:srgbClr val="FFFFFF"/>
                 </a:solidFill>
                 <a:latin typeface="Calibri"/>
               </a:rPr>
-              <a:t>### Evidencia</a:t>
-            </a:r>
-          </a:p>
-          <a:p>
-            <a:pPr algn="l"/>
-            <a:r>
-              <a:rPr sz="1400" b="0">
+              <a:t>### Evidencia                |   ### Concepto del curso</a:t>
+            </a:r>
+          </a:p>
+          <a:p>
+            <a:pPr algn="l"/>
+            <a:r>
+              <a:rPr sz="1300" b="0">
                 <a:solidFill>
                   <a:srgbClr val="FFFFFF"/>
                 </a:solidFill>
                 <a:latin typeface="Calibri"/>
               </a:rPr>
-              <a:t>¿Dónde lo encontraste? (Lighthouse, Network, código, package.json, etc.)</a:t>
-            </a:r>
-          </a:p>
-          <a:p>
-            <a:pPr algn="l"/>
-            <a:r>
-              <a:rPr sz="1400" b="0">
+              <a:t>Lighthouse / Network / axe / código   VIVO / RÁPIDO / SEGURO + concepto</a:t>
+            </a:r>
+          </a:p>
+          <a:p>
+            <a:pPr algn="l"/>
+            <a:r>
+              <a:rPr sz="1300" b="0">
                 <a:solidFill>
                   <a:srgbClr val="FFFFFF"/>
                 </a:solidFill>
@@ -7657,121 +7856,49 @@
           <a:p>
             <a:pPr algn="l"/>
             <a:r>
-              <a:rPr sz="1400" b="1">
+              <a:rPr sz="1300" b="1">
                 <a:solidFill>
                   <a:srgbClr val="FFFFFF"/>
                 </a:solidFill>
                 <a:latin typeface="Calibri"/>
               </a:rPr>
-              <a:t>### Impacto</a:t>
-            </a:r>
-          </a:p>
-          <a:p>
-            <a:pPr algn="l"/>
-            <a:r>
-              <a:rPr sz="1400" b="0">
+              <a:t>### Impacto                  |   ### Severidad  +  ### Solución propuesta</a:t>
+            </a:r>
+          </a:p>
+          <a:p>
+            <a:pPr algn="l"/>
+            <a:r>
+              <a:rPr sz="1300" b="0">
                 <a:solidFill>
                   <a:srgbClr val="FFFFFF"/>
                 </a:solidFill>
                 <a:latin typeface="Calibri"/>
               </a:rPr>
-              <a:t>¿Por qué podría ser un problema?</a:t>
-            </a:r>
-          </a:p>
-          <a:p>
-            <a:pPr algn="l"/>
-            <a:r>
-              <a:rPr sz="1400" b="0">
-                <a:solidFill>
-                  <a:srgbClr val="FFFFFF"/>
-                </a:solidFill>
-                <a:latin typeface="Calibri"/>
-              </a:rPr>
-              <a:t/>
-            </a:r>
-          </a:p>
-          <a:p>
-            <a:pPr algn="l"/>
-            <a:r>
-              <a:rPr sz="1400" b="1">
-                <a:solidFill>
-                  <a:srgbClr val="FFFFFF"/>
-                </a:solidFill>
-                <a:latin typeface="Calibri"/>
-              </a:rPr>
-              <a:t>### Solución propuesta</a:t>
-            </a:r>
-          </a:p>
-          <a:p>
-            <a:pPr algn="l"/>
-            <a:r>
-              <a:rPr sz="1400" b="0">
-                <a:solidFill>
-                  <a:srgbClr val="FFFFFF"/>
-                </a:solidFill>
-                <a:latin typeface="Calibri"/>
-              </a:rPr>
-              <a:t>¿Qué debería hacerse?</a:t>
-            </a:r>
-          </a:p>
-          <a:p>
-            <a:pPr algn="l"/>
-            <a:r>
-              <a:rPr sz="1400" b="0">
-                <a:solidFill>
-                  <a:srgbClr val="FFFFFF"/>
-                </a:solidFill>
-                <a:latin typeface="Calibri"/>
-              </a:rPr>
-              <a:t/>
-            </a:r>
-          </a:p>
-          <a:p>
-            <a:pPr algn="l"/>
-            <a:r>
-              <a:rPr sz="1400" b="1">
-                <a:solidFill>
-                  <a:srgbClr val="FFFFFF"/>
-                </a:solidFill>
-                <a:latin typeface="Calibri"/>
-              </a:rPr>
-              <a:t>### Tipo de mantenimiento   |   ### Pilar</a:t>
-            </a:r>
-          </a:p>
-          <a:p>
-            <a:pPr algn="l"/>
-            <a:r>
-              <a:rPr sz="1400" b="0">
-                <a:solidFill>
-                  <a:srgbClr val="FFFFFF"/>
-                </a:solidFill>
-                <a:latin typeface="Calibri"/>
-              </a:rPr>
-              <a:t>Preventivo / Correctivo / Adaptativo / Perfectivo     VIVO / RÁPIDO / SEGURO</a:t>
-            </a:r>
-          </a:p>
-        </p:txBody>
-      </p:sp>
-      <p:sp>
-        <p:nvSpPr>
-          <p:cNvPr id="9" name="Rounded Rectangle 8"/>
+              <a:t>¿A quién afecta?             Baja/Media/Alta + justificación   Describir en texto (no aplicar)</a:t>
+            </a:r>
+          </a:p>
+        </p:txBody>
+      </p:sp>
+      <p:sp>
+        <p:nvSpPr>
+          <p:cNvPr id="10" name="Rounded Rectangle 9"/>
           <p:cNvSpPr/>
           <p:nvPr/>
         </p:nvSpPr>
         <p:spPr>
           <a:xfrm>
-            <a:off x="640080" y="5852160"/>
+            <a:off x="640080" y="5943600"/>
             <a:ext cx="10972800" cy="457200"/>
           </a:xfrm>
           <a:prstGeom prst="roundRect">
             <a:avLst/>
           </a:prstGeom>
           <a:solidFill>
-            <a:srgbClr val="F4F4F4"/>
+            <a:srgbClr val="FFF3CD"/>
           </a:solidFill>
           <a:ln>
             <a:solidFill>
-              <a:srgbClr val="1C7293"/>
+              <a:srgbClr val="E6A23E"/>
             </a:solidFill>
           </a:ln>
         </p:spPr>
@@ -7799,13 +7926,13 @@
       </p:sp>
       <p:sp>
         <p:nvSpPr>
-          <p:cNvPr id="10" name="TextBox 9"/>
+          <p:cNvPr id="11" name="TextBox 10"/>
           <p:cNvSpPr txBox="1"/>
           <p:nvPr/>
         </p:nvSpPr>
         <p:spPr>
           <a:xfrm>
-            <a:off x="640080" y="5897880"/>
+            <a:off x="640080" y="5989320"/>
             <a:ext cx="10972800" cy="365760"/>
           </a:xfrm>
           <a:prstGeom prst="rect">
@@ -7821,9 +7948,9 @@
           <a:p>
             <a:pPr algn="ctr"/>
             <a:r>
-              <a:rPr sz="1400" b="1">
-                <a:solidFill>
-                  <a:srgbClr val="065A82"/>
+              <a:rPr sz="1300" b="1">
+                <a:solidFill>
+                  <a:srgbClr val="924E0E"/>
                 </a:solidFill>
                 <a:latin typeface="Calibri"/>
               </a:rPr>
@@ -7834,7 +7961,7 @@
       </p:sp>
       <p:sp>
         <p:nvSpPr>
-          <p:cNvPr id="11" name="TextBox 10"/>
+          <p:cNvPr id="12" name="TextBox 11"/>
           <p:cNvSpPr txBox="1"/>
           <p:nvPr/>
         </p:nvSpPr>
@@ -7869,7 +7996,7 @@
       </p:sp>
       <p:sp>
         <p:nvSpPr>
-          <p:cNvPr id="12" name="TextBox 11"/>
+          <p:cNvPr id="13" name="TextBox 12"/>
           <p:cNvSpPr txBox="1"/>
           <p:nvPr/>
         </p:nvSpPr>
@@ -8036,7 +8163,7 @@
                 </a:solidFill>
                 <a:latin typeface="Calibri"/>
               </a:rPr>
-              <a:t>Parte 5 · Corregir al menos 1 problema</a:t>
+              <a:t>Parte 5 · Documentar la solución</a:t>
             </a:r>
           </a:p>
         </p:txBody>
@@ -8071,173 +8198,31 @@
                 </a:solidFill>
                 <a:latin typeface="Calibri"/>
               </a:rPr>
-              <a:t>⏱ 15 minutos</a:t>
-            </a:r>
-          </a:p>
-        </p:txBody>
-      </p:sp>
-      <p:sp>
-        <p:nvSpPr>
-          <p:cNvPr id="6" name="TextBox 5"/>
-          <p:cNvSpPr txBox="1"/>
-          <p:nvPr/>
-        </p:nvSpPr>
-        <p:spPr>
-          <a:xfrm>
-            <a:off x="640080" y="1188720"/>
-            <a:ext cx="5486400" cy="365760"/>
-          </a:xfrm>
-          <a:prstGeom prst="rect">
-            <a:avLst/>
-          </a:prstGeom>
-          <a:noFill/>
-        </p:spPr>
-        <p:txBody>
-          <a:bodyPr wrap="square">
-            <a:spAutoFit/>
-          </a:bodyPr>
-          <a:lstStyle/>
-          <a:p>
-            <a:pPr algn="l"/>
-            <a:r>
-              <a:rPr sz="2000" b="1">
-                <a:solidFill>
-                  <a:srgbClr val="065A82"/>
-                </a:solidFill>
-                <a:latin typeface="Calibri"/>
-              </a:rPr>
-              <a:t>Ejemplos válidos:</a:t>
-            </a:r>
-          </a:p>
-        </p:txBody>
-      </p:sp>
-      <p:sp>
-        <p:nvSpPr>
-          <p:cNvPr id="7" name="TextBox 6"/>
-          <p:cNvSpPr txBox="1"/>
-          <p:nvPr/>
-        </p:nvSpPr>
-        <p:spPr>
-          <a:xfrm>
-            <a:off x="822960" y="1645920"/>
-            <a:ext cx="5486400" cy="3657600"/>
-          </a:xfrm>
-          <a:prstGeom prst="rect">
-            <a:avLst/>
-          </a:prstGeom>
-          <a:noFill/>
-        </p:spPr>
-        <p:txBody>
-          <a:bodyPr wrap="square">
-            <a:spAutoFit/>
-          </a:bodyPr>
-          <a:lstStyle/>
-          <a:p>
-            <a:pPr algn="l"/>
-            <a:r>
-              <a:rPr sz="1600" b="0">
-                <a:solidFill>
-                  <a:srgbClr val="2A2A2A"/>
-                </a:solidFill>
-                <a:latin typeface="Calibri"/>
-              </a:rPr>
-              <a:t>• Agregar width / height a una imagen</a:t>
-            </a:r>
-          </a:p>
-          <a:p>
-            <a:pPr algn="l"/>
-            <a:r>
-              <a:rPr sz="1600" b="0">
-                <a:solidFill>
-                  <a:srgbClr val="2A2A2A"/>
-                </a:solidFill>
-                <a:latin typeface="Calibri"/>
-              </a:rPr>
-              <a:t>• Agregar alt a una imagen</a:t>
-            </a:r>
-          </a:p>
-          <a:p>
-            <a:pPr algn="l"/>
-            <a:r>
-              <a:rPr sz="1600" b="0">
-                <a:solidFill>
-                  <a:srgbClr val="2A2A2A"/>
-                </a:solidFill>
-                <a:latin typeface="Calibri"/>
-              </a:rPr>
-              <a:t>• Agregar defer al &lt;script&gt;</a:t>
-            </a:r>
-          </a:p>
-          <a:p>
-            <a:pPr algn="l"/>
-            <a:r>
-              <a:rPr sz="1600" b="0">
-                <a:solidFill>
-                  <a:srgbClr val="2A2A2A"/>
-                </a:solidFill>
-                <a:latin typeface="Calibri"/>
-              </a:rPr>
-              <a:t>• Optimizar una imagen</a:t>
-            </a:r>
-          </a:p>
-          <a:p>
-            <a:pPr algn="l"/>
-            <a:r>
-              <a:rPr sz="1600" b="0">
-                <a:solidFill>
-                  <a:srgbClr val="2A2A2A"/>
-                </a:solidFill>
-                <a:latin typeface="Calibri"/>
-              </a:rPr>
-              <a:t>• Corregir una referencia rota</a:t>
-            </a:r>
-          </a:p>
-          <a:p>
-            <a:pPr algn="l"/>
-            <a:r>
-              <a:rPr sz="1600" b="0">
-                <a:solidFill>
-                  <a:srgbClr val="2A2A2A"/>
-                </a:solidFill>
-                <a:latin typeface="Calibri"/>
-              </a:rPr>
-              <a:t>• Actualizar una dependencia</a:t>
-            </a:r>
-          </a:p>
-          <a:p>
-            <a:pPr algn="l"/>
-            <a:r>
-              <a:rPr sz="1600" b="0">
-                <a:solidFill>
-                  <a:srgbClr val="2A2A2A"/>
-                </a:solidFill>
-                <a:latin typeface="Calibri"/>
-              </a:rPr>
-              <a:t>• Eliminar un recurso innecesario</a:t>
-            </a:r>
-          </a:p>
-        </p:txBody>
-      </p:sp>
-      <p:sp>
-        <p:nvSpPr>
-          <p:cNvPr id="8" name="Rounded Rectangle 7"/>
+              <a:t>⏱ 10 minutos</a:t>
+            </a:r>
+          </a:p>
+        </p:txBody>
+      </p:sp>
+      <p:sp>
+        <p:nvSpPr>
+          <p:cNvPr id="6" name="Rounded Rectangle 5"/>
           <p:cNvSpPr/>
           <p:nvPr/>
         </p:nvSpPr>
         <p:spPr>
           <a:xfrm>
-            <a:off x="6583680" y="1188720"/>
-            <a:ext cx="5120640" cy="4114800"/>
+            <a:off x="640080" y="1280160"/>
+            <a:ext cx="10972800" cy="822960"/>
           </a:xfrm>
           <a:prstGeom prst="roundRect">
             <a:avLst/>
           </a:prstGeom>
           <a:solidFill>
-            <a:srgbClr val="2A2A2A"/>
+            <a:srgbClr val="FFF3CD"/>
           </a:solidFill>
           <a:ln>
             <a:solidFill>
-              <a:srgbClr val="1C7293"/>
+              <a:srgbClr val="E6A23E"/>
             </a:solidFill>
           </a:ln>
         </p:spPr>
@@ -8265,14 +8250,14 @@
       </p:sp>
       <p:sp>
         <p:nvSpPr>
-          <p:cNvPr id="9" name="TextBox 8"/>
+          <p:cNvPr id="7" name="TextBox 6"/>
           <p:cNvSpPr txBox="1"/>
           <p:nvPr/>
         </p:nvSpPr>
         <p:spPr>
           <a:xfrm>
-            <a:off x="6766560" y="1325880"/>
-            <a:ext cx="4754880" cy="3931920"/>
+            <a:off x="822960" y="1417320"/>
+            <a:ext cx="10607040" cy="548640"/>
           </a:xfrm>
           <a:prstGeom prst="rect">
             <a:avLst/>
@@ -8287,180 +8272,28 @@
           <a:p>
             <a:pPr algn="l"/>
             <a:r>
-              <a:rPr sz="1400" b="1">
-                <a:solidFill>
-                  <a:srgbClr val="FFFFFF"/>
-                </a:solidFill>
-                <a:latin typeface="Calibri"/>
-              </a:rPr>
-              <a:t>Después de la corrección:</a:t>
-            </a:r>
-          </a:p>
-          <a:p>
-            <a:pPr algn="l"/>
-            <a:r>
-              <a:rPr sz="1400" b="0">
-                <a:solidFill>
-                  <a:srgbClr val="FFFFFF"/>
-                </a:solidFill>
-                <a:latin typeface="Calibri"/>
-              </a:rPr>
-              <a:t/>
-            </a:r>
-          </a:p>
-          <a:p>
-            <a:pPr algn="l"/>
-            <a:r>
-              <a:rPr sz="1400" b="0">
-                <a:solidFill>
-                  <a:srgbClr val="FFFFFF"/>
-                </a:solidFill>
-                <a:latin typeface="Calibri"/>
-              </a:rPr>
-              <a:t>$ git add .</a:t>
-            </a:r>
-          </a:p>
-          <a:p>
-            <a:pPr algn="l"/>
-            <a:r>
-              <a:rPr sz="1400" b="0">
-                <a:solidFill>
-                  <a:srgbClr val="FFFFFF"/>
-                </a:solidFill>
-                <a:latin typeface="Calibri"/>
-              </a:rPr>
-              <a:t>$ git commit -m "fix: mejora sitio web"</a:t>
-            </a:r>
-          </a:p>
-          <a:p>
-            <a:pPr algn="l"/>
-            <a:r>
-              <a:rPr sz="1400" b="0">
-                <a:solidFill>
-                  <a:srgbClr val="FFFFFF"/>
-                </a:solidFill>
-                <a:latin typeface="Calibri"/>
-              </a:rPr>
-              <a:t>$ git push</a:t>
-            </a:r>
-          </a:p>
-          <a:p>
-            <a:pPr algn="l"/>
-            <a:r>
-              <a:rPr sz="1400" b="0">
-                <a:solidFill>
-                  <a:srgbClr val="FFFFFF"/>
-                </a:solidFill>
-                <a:latin typeface="Calibri"/>
-              </a:rPr>
-              <a:t/>
-            </a:r>
-          </a:p>
-          <a:p>
-            <a:pPr algn="l"/>
-            <a:r>
-              <a:rPr sz="1400" b="1">
-                <a:solidFill>
-                  <a:srgbClr val="FFFFFF"/>
-                </a:solidFill>
-                <a:latin typeface="Calibri"/>
-              </a:rPr>
-              <a:t>Luego:</a:t>
-            </a:r>
-          </a:p>
-          <a:p>
-            <a:pPr algn="l"/>
-            <a:r>
-              <a:rPr sz="1400" b="0">
-                <a:solidFill>
-                  <a:srgbClr val="FFFFFF"/>
-                </a:solidFill>
-                <a:latin typeface="Calibri"/>
-              </a:rPr>
-              <a:t>• Verifica que GitHub Pages siga funcionando</a:t>
-            </a:r>
-          </a:p>
-          <a:p>
-            <a:pPr algn="l"/>
-            <a:r>
-              <a:rPr sz="1400" b="0">
-                <a:solidFill>
-                  <a:srgbClr val="FFFFFF"/>
-                </a:solidFill>
-                <a:latin typeface="Calibri"/>
-              </a:rPr>
-              <a:t>• Actualiza la Issue correspondiente</a:t>
-            </a:r>
-          </a:p>
-          <a:p>
-            <a:pPr algn="l"/>
-            <a:r>
-              <a:rPr sz="1400" b="0">
-                <a:solidFill>
-                  <a:srgbClr val="FFFFFF"/>
-                </a:solidFill>
-                <a:latin typeface="Calibri"/>
-              </a:rPr>
-              <a:t>  (comentario o cierre)</a:t>
-            </a:r>
-          </a:p>
-        </p:txBody>
-      </p:sp>
-      <p:sp>
-        <p:nvSpPr>
-          <p:cNvPr id="10" name="Rounded Rectangle 9"/>
-          <p:cNvSpPr/>
-          <p:nvPr/>
-        </p:nvSpPr>
-        <p:spPr>
-          <a:xfrm>
-            <a:off x="640080" y="5669280"/>
-            <a:ext cx="10972800" cy="548640"/>
-          </a:xfrm>
-          <a:prstGeom prst="roundRect">
-            <a:avLst/>
-          </a:prstGeom>
-          <a:solidFill>
-            <a:srgbClr val="F4F4F4"/>
-          </a:solidFill>
-          <a:ln>
-            <a:solidFill>
-              <a:srgbClr val="1C7293"/>
-            </a:solidFill>
-          </a:ln>
-        </p:spPr>
-        <p:style>
-          <a:lnRef idx="1">
-            <a:schemeClr val="accent1"/>
-          </a:lnRef>
-          <a:fillRef idx="3">
-            <a:schemeClr val="accent1"/>
-          </a:fillRef>
-          <a:effectRef idx="2">
-            <a:schemeClr val="accent1"/>
-          </a:effectRef>
-          <a:fontRef idx="minor">
-            <a:schemeClr val="lt1"/>
-          </a:fontRef>
-        </p:style>
-        <p:txBody>
-          <a:bodyPr rtlCol="0" anchor="ctr"/>
-          <a:lstStyle/>
-          <a:p>
-            <a:pPr algn="ctr"/>
-          </a:p>
-        </p:txBody>
-      </p:sp>
-      <p:sp>
-        <p:nvSpPr>
-          <p:cNvPr id="11" name="TextBox 10"/>
+              <a:rPr sz="1600" b="1">
+                <a:solidFill>
+                  <a:srgbClr val="924E0E"/>
+                </a:solidFill>
+                <a:latin typeface="Calibri"/>
+              </a:rPr>
+              <a:t>⚠️  No es necesario aplicar las correcciones en el código.
+Lo que se evalúa es tu capacidad de ANALIZAR y PROPONER en texto.</a:t>
+            </a:r>
+          </a:p>
+        </p:txBody>
+      </p:sp>
+      <p:sp>
+        <p:nvSpPr>
+          <p:cNvPr id="8" name="TextBox 7"/>
           <p:cNvSpPr txBox="1"/>
           <p:nvPr/>
         </p:nvSpPr>
         <p:spPr>
           <a:xfrm>
-            <a:off x="640080" y="5760720"/>
-            <a:ext cx="10972800" cy="365760"/>
+            <a:off x="640080" y="2468880"/>
+            <a:ext cx="10972800" cy="457200"/>
           </a:xfrm>
           <a:prstGeom prst="rect">
             <a:avLst/>
@@ -8473,29 +8306,29 @@
           </a:bodyPr>
           <a:lstStyle/>
           <a:p>
-            <a:pPr algn="ctr"/>
-            <a:r>
-              <a:rPr sz="1400" b="1">
+            <a:pPr algn="l"/>
+            <a:r>
+              <a:rPr sz="1800" b="1">
                 <a:solidFill>
                   <a:srgbClr val="065A82"/>
                 </a:solidFill>
                 <a:latin typeface="Calibri"/>
               </a:rPr>
-              <a:t>☐ Commit    ☐ Push    ☐ Pages funciona    ☐ Issue actualizada</a:t>
-            </a:r>
-          </a:p>
-        </p:txBody>
-      </p:sp>
-      <p:sp>
-        <p:nvSpPr>
-          <p:cNvPr id="12" name="TextBox 11"/>
+              <a:t>Ejemplos de soluciones propuestas (en texto, no aplicar):</a:t>
+            </a:r>
+          </a:p>
+        </p:txBody>
+      </p:sp>
+      <p:sp>
+        <p:nvSpPr>
+          <p:cNvPr id="9" name="TextBox 8"/>
           <p:cNvSpPr txBox="1"/>
           <p:nvPr/>
         </p:nvSpPr>
         <p:spPr>
           <a:xfrm>
-            <a:off x="457200" y="6400800"/>
-            <a:ext cx="5486400" cy="365760"/>
+            <a:off x="822960" y="3017520"/>
+            <a:ext cx="10972800" cy="2926080"/>
           </a:xfrm>
           <a:prstGeom prst="rect">
             <a:avLst/>
@@ -8510,6 +8343,89 @@
           <a:p>
             <a:pPr algn="l"/>
             <a:r>
+              <a:rPr sz="1400" b="0">
+                <a:solidFill>
+                  <a:srgbClr val="2A2A2A"/>
+                </a:solidFill>
+                <a:latin typeface="Calibri"/>
+              </a:rPr>
+              <a:t>"Agregar atributos width y height a la etiqueta &lt;img&gt; del hero."</a:t>
+            </a:r>
+          </a:p>
+          <a:p>
+            <a:pPr algn="l"/>
+            <a:r>
+              <a:rPr sz="1400" b="0">
+                <a:solidFill>
+                  <a:srgbClr val="2A2A2A"/>
+                </a:solidFill>
+                <a:latin typeface="Calibri"/>
+              </a:rPr>
+              <a:t>"Añadir el atributo defer al &lt;script&gt; para que no sea bloqueante."</a:t>
+            </a:r>
+          </a:p>
+          <a:p>
+            <a:pPr algn="l"/>
+            <a:r>
+              <a:rPr sz="1400" b="0">
+                <a:solidFill>
+                  <a:srgbClr val="2A2A2A"/>
+                </a:solidFill>
+                <a:latin typeface="Calibri"/>
+              </a:rPr>
+              <a:t>"Actualizar jquery a una versión 3.x sin vulnerabilidades conocidas."</a:t>
+            </a:r>
+          </a:p>
+          <a:p>
+            <a:pPr algn="l"/>
+            <a:r>
+              <a:rPr sz="1400" b="0">
+                <a:solidFill>
+                  <a:srgbClr val="2A2A2A"/>
+                </a:solidFill>
+                <a:latin typeface="Calibri"/>
+              </a:rPr>
+              <a:t>"Cambiar el texto del footer por la fecha actual de mantenimiento."</a:t>
+            </a:r>
+          </a:p>
+          <a:p>
+            <a:pPr algn="l"/>
+            <a:r>
+              <a:rPr sz="1400" b="0">
+                <a:solidFill>
+                  <a:srgbClr val="2A2A2A"/>
+                </a:solidFill>
+                <a:latin typeface="Calibri"/>
+              </a:rPr>
+              <a:t>"Agregar atributo alt descriptivo a todas las imágenes del sitio."</a:t>
+            </a:r>
+          </a:p>
+        </p:txBody>
+      </p:sp>
+      <p:sp>
+        <p:nvSpPr>
+          <p:cNvPr id="10" name="TextBox 9"/>
+          <p:cNvSpPr txBox="1"/>
+          <p:nvPr/>
+        </p:nvSpPr>
+        <p:spPr>
+          <a:xfrm>
+            <a:off x="457200" y="6400800"/>
+            <a:ext cx="5486400" cy="365760"/>
+          </a:xfrm>
+          <a:prstGeom prst="rect">
+            <a:avLst/>
+          </a:prstGeom>
+          <a:noFill/>
+        </p:spPr>
+        <p:txBody>
+          <a:bodyPr wrap="square">
+            <a:spAutoFit/>
+          </a:bodyPr>
+          <a:lstStyle/>
+          <a:p>
+            <a:pPr algn="l"/>
+            <a:r>
               <a:rPr sz="1000" b="0">
                 <a:solidFill>
                   <a:srgbClr val="999999"/>
@@ -8523,7 +8439,7 @@
       </p:sp>
       <p:sp>
         <p:nvSpPr>
-          <p:cNvPr id="13" name="TextBox 12"/>
+          <p:cNvPr id="11" name="TextBox 10"/>
           <p:cNvSpPr txBox="1"/>
           <p:nvPr/>
         </p:nvSpPr>
@@ -8789,7 +8705,7 @@
           <a:p>
             <a:pPr algn="l"/>
             <a:r>
-              <a:rPr sz="1800" b="0">
+              <a:rPr sz="1600" b="0">
                 <a:solidFill>
                   <a:srgbClr val="2A2A2A"/>
                 </a:solidFill>
@@ -8801,7 +8717,7 @@
           <a:p>
             <a:pPr algn="l"/>
             <a:r>
-              <a:rPr sz="1800" b="0">
+              <a:rPr sz="1600" b="0">
                 <a:solidFill>
                   <a:srgbClr val="2A2A2A"/>
                 </a:solidFill>
@@ -8813,7 +8729,7 @@
           <a:p>
             <a:pPr algn="l"/>
             <a:r>
-              <a:rPr sz="1800" b="0">
+              <a:rPr sz="1600" b="0">
                 <a:solidFill>
                   <a:srgbClr val="2A2A2A"/>
                 </a:solidFill>
@@ -8825,7 +8741,7 @@
           <a:p>
             <a:pPr algn="l"/>
             <a:r>
-              <a:rPr sz="1800" b="0">
+              <a:rPr sz="1600" b="0">
                 <a:solidFill>
                   <a:srgbClr val="2A2A2A"/>
                 </a:solidFill>
@@ -8837,7 +8753,7 @@
           <a:p>
             <a:pPr algn="l"/>
             <a:r>
-              <a:rPr sz="1800" b="0">
+              <a:rPr sz="1600" b="0">
                 <a:solidFill>
                   <a:srgbClr val="2A2A2A"/>
                 </a:solidFill>
@@ -8872,7 +8788,7 @@
           <a:p>
             <a:pPr algn="l"/>
             <a:r>
-              <a:rPr sz="1800" b="0">
+              <a:rPr sz="1600" b="0">
                 <a:solidFill>
                   <a:srgbClr val="2A2A2A"/>
                 </a:solidFill>
@@ -8884,7 +8800,7 @@
           <a:p>
             <a:pPr algn="l"/>
             <a:r>
-              <a:rPr sz="1800" b="0">
+              <a:rPr sz="1600" b="0">
                 <a:solidFill>
                   <a:srgbClr val="2A2A2A"/>
                 </a:solidFill>
@@ -8896,7 +8812,7 @@
           <a:p>
             <a:pPr algn="l"/>
             <a:r>
-              <a:rPr sz="1800" b="0">
+              <a:rPr sz="1600" b="0">
                 <a:solidFill>
                   <a:srgbClr val="2A2A2A"/>
                 </a:solidFill>
@@ -8908,25 +8824,25 @@
           <a:p>
             <a:pPr algn="l"/>
             <a:r>
-              <a:rPr sz="1800" b="0">
+              <a:rPr sz="1600" b="0">
                 <a:solidFill>
                   <a:srgbClr val="2A2A2A"/>
                 </a:solidFill>
                 <a:latin typeface="Calibri"/>
               </a:rPr>
-              <a:t>• Problema corregido — cuál Issue arreglaste</a:t>
-            </a:r>
-          </a:p>
-          <a:p>
-            <a:pPr algn="l"/>
-            <a:r>
-              <a:rPr sz="1800" b="0">
+              <a:t>• Datos del estudiante + URLs</a:t>
+            </a:r>
+          </a:p>
+          <a:p>
+            <a:pPr algn="l"/>
+            <a:r>
+              <a:rPr sz="1600" b="0">
                 <a:solidFill>
                   <a:srgbClr val="2A2A2A"/>
                 </a:solidFill>
                 <a:latin typeface="Calibri"/>
               </a:rPr>
-              <a:t>• Datos del estudiante + URLs</a:t>
+              <a:t/>
             </a:r>
           </a:p>
         </p:txBody>

</xml_diff>

<commit_message>
feat(issue-templates): nuevo template ENTREGA + config + PPT con URL de issues del docente
- Nuevo template: entrega.yml (nombre, código, URL repo, URL Pages, checklist)
- config.yml: muestra link de contacto directo para crear Issue de entrega
- PPT actualizado con:
  * Slide 3: URLs (sitio base, tu repo, link de entrega con issues/new?template=entrega.yml)
  * Slide 4: Flujo modificado (3 Issues en TU repo + Issue de ENTREGA AQUÍ)
  * Slide 8: Refuerza que los 3 Issues van en TU repo
  * Slide 10 (NUEVA dedicada): Issue de ENTREGA con link directo
  * Slide 11: Checklist final separado en 'tu repo' vs 'repo del docente'
  * Footer: incluye URL de issues del docente
</commit_message>
<xml_diff>
--- a/EVALUACION_PRACTICA_01.pptx
+++ b/EVALUACION_PRACTICA_01.pptx
@@ -3149,7 +3149,7 @@
         </p:nvSpPr>
         <p:spPr>
           <a:xfrm>
-            <a:off x="0" y="5029200"/>
+            <a:off x="0" y="4572000"/>
             <a:ext cx="12191695" cy="45720"/>
           </a:xfrm>
           <a:prstGeom prst="rect">
@@ -3192,7 +3192,7 @@
         </p:nvSpPr>
         <p:spPr>
           <a:xfrm>
-            <a:off x="914400" y="1280160"/>
+            <a:off x="914400" y="1097280"/>
             <a:ext cx="10058400" cy="1097280"/>
           </a:xfrm>
           <a:prstGeom prst="rect">
@@ -3227,7 +3227,7 @@
         </p:nvSpPr>
         <p:spPr>
           <a:xfrm>
-            <a:off x="914400" y="2377440"/>
+            <a:off x="914400" y="2194560"/>
             <a:ext cx="10058400" cy="640080"/>
           </a:xfrm>
           <a:prstGeom prst="rect">
@@ -3262,8 +3262,8 @@
         </p:nvSpPr>
         <p:spPr>
           <a:xfrm>
-            <a:off x="2743200" y="3474720"/>
-            <a:ext cx="6675120" cy="1097280"/>
+            <a:off x="2743200" y="3200400"/>
+            <a:ext cx="6675120" cy="914400"/>
           </a:xfrm>
           <a:prstGeom prst="rect">
             <a:avLst/>
@@ -3278,7 +3278,7 @@
           <a:p>
             <a:pPr algn="ctr"/>
             <a:r>
-              <a:rPr sz="1600" b="1">
+              <a:rPr sz="1500" b="1">
                 <a:solidFill>
                   <a:srgbClr val="FFFFFF"/>
                 </a:solidFill>
@@ -3290,25 +3290,13 @@
           <a:p>
             <a:pPr algn="ctr"/>
             <a:r>
-              <a:rPr sz="1600" b="0">
+              <a:rPr sz="1500" b="0">
                 <a:solidFill>
                   <a:srgbClr val="FFFFFF"/>
                 </a:solidFill>
                 <a:latin typeface="Calibri"/>
               </a:rPr>
-              <a:t>Unidad: 1  •  Duración: 90 minutos</a:t>
-            </a:r>
-          </a:p>
-          <a:p>
-            <a:pPr algn="ctr"/>
-            <a:r>
-              <a:rPr sz="1600" b="0">
-                <a:solidFill>
-                  <a:srgbClr val="FFFFFF"/>
-                </a:solidFill>
-                <a:latin typeface="Calibri"/>
-              </a:rPr>
-              <a:t>Escala: 1–20  •  Aprobado: 14/20</a:t>
+              <a:t>Unidad: 1  •  Duración: 90 minutos  •  Aprobado: 14/20</a:t>
             </a:r>
           </a:p>
         </p:txBody>
@@ -3321,8 +3309,8 @@
         </p:nvSpPr>
         <p:spPr>
           <a:xfrm>
-            <a:off x="2286000" y="5303520"/>
-            <a:ext cx="7589520" cy="548640"/>
+            <a:off x="914400" y="4846320"/>
+            <a:ext cx="10332720" cy="640080"/>
           </a:xfrm>
           <a:prstGeom prst="roundRect">
             <a:avLst/>
@@ -3366,8 +3354,8 @@
         </p:nvSpPr>
         <p:spPr>
           <a:xfrm>
-            <a:off x="2468880" y="5440680"/>
-            <a:ext cx="7223760" cy="457200"/>
+            <a:off x="1097280" y="4983480"/>
+            <a:ext cx="9966960" cy="457200"/>
           </a:xfrm>
           <a:prstGeom prst="rect">
             <a:avLst/>
@@ -3388,7 +3376,7 @@
                 </a:solidFill>
                 <a:latin typeface="Calibri"/>
               </a:rPr>
-              <a:t>📦 REPOSITORIO</a:t>
+              <a:t>📦 REPOSITORIO (sitio base a auditar)</a:t>
             </a:r>
           </a:p>
         </p:txBody>
@@ -3401,8 +3389,8 @@
         </p:nvSpPr>
         <p:spPr>
           <a:xfrm>
-            <a:off x="2468880" y="5897880"/>
-            <a:ext cx="7223760" cy="-91439"/>
+            <a:off x="1097280" y="5486400"/>
+            <a:ext cx="9966960" cy="-91440"/>
           </a:xfrm>
           <a:prstGeom prst="rect">
             <a:avLst/>
@@ -3436,8 +3424,8 @@
         </p:nvSpPr>
         <p:spPr>
           <a:xfrm>
-            <a:off x="2286000" y="5897880"/>
-            <a:ext cx="7589520" cy="548640"/>
+            <a:off x="914400" y="5532120"/>
+            <a:ext cx="10332720" cy="640080"/>
           </a:xfrm>
           <a:prstGeom prst="roundRect">
             <a:avLst/>
@@ -3481,8 +3469,8 @@
         </p:nvSpPr>
         <p:spPr>
           <a:xfrm>
-            <a:off x="2468880" y="6035040"/>
-            <a:ext cx="7223760" cy="457200"/>
+            <a:off x="1097280" y="5669280"/>
+            <a:ext cx="9966960" cy="457200"/>
           </a:xfrm>
           <a:prstGeom prst="rect">
             <a:avLst/>
@@ -3503,7 +3491,7 @@
                 </a:solidFill>
                 <a:latin typeface="Calibri"/>
               </a:rPr>
-              <a:t>🌐 SITIO WEB (GitHub Pages)</a:t>
+              <a:t>🌐 SITIO WEB PÚBLICO (GitHub Pages del sitio base)</a:t>
             </a:r>
           </a:p>
         </p:txBody>
@@ -3516,8 +3504,8 @@
         </p:nvSpPr>
         <p:spPr>
           <a:xfrm>
-            <a:off x="2468880" y="6492240"/>
-            <a:ext cx="7223760" cy="-91439"/>
+            <a:off x="1097280" y="6172200"/>
+            <a:ext cx="9966960" cy="-91440"/>
           </a:xfrm>
           <a:prstGeom prst="rect">
             <a:avLst/>
@@ -3619,7 +3607,7 @@
             <a:avLst/>
           </a:prstGeom>
           <a:solidFill>
-            <a:srgbClr val="065A82"/>
+            <a:srgbClr val="EA580C"/>
           </a:solidFill>
           <a:ln>
             <a:noFill/>
@@ -3677,7 +3665,7 @@
                 </a:solidFill>
                 <a:latin typeface="Calibri"/>
               </a:rPr>
-              <a:t>Parte 6 · Completar el README</a:t>
+              <a:t>📤 Parte 6 · Crear Issue de ENTREGA</a:t>
             </a:r>
           </a:p>
         </p:txBody>
@@ -3708,11 +3696,11 @@
             <a:r>
               <a:rPr sz="1400" b="0">
                 <a:solidFill>
-                  <a:srgbClr val="60A5FA"/>
-                </a:solidFill>
-                <a:latin typeface="Calibri"/>
-              </a:rPr>
-              <a:t>⏱ 15 minutos</a:t>
+                  <a:srgbClr val="FED3B6"/>
+                </a:solidFill>
+                <a:latin typeface="Calibri"/>
+              </a:rPr>
+              <a:t>⏱ 5 minutos  •  Esta Issue se crea en el repo del DOCENTE</a:t>
             </a:r>
           </a:p>
         </p:txBody>
@@ -3725,8 +3713,8 @@
         </p:nvSpPr>
         <p:spPr>
           <a:xfrm>
-            <a:off x="640080" y="1280160"/>
-            <a:ext cx="10972800" cy="457200"/>
+            <a:off x="640080" y="1188720"/>
+            <a:ext cx="10972800" cy="1371600"/>
           </a:xfrm>
           <a:prstGeom prst="rect">
             <a:avLst/>
@@ -3741,27 +3729,132 @@
           <a:p>
             <a:pPr algn="l"/>
             <a:r>
-              <a:rPr sz="2200" b="1">
-                <a:solidFill>
-                  <a:srgbClr val="065A82"/>
-                </a:solidFill>
-                <a:latin typeface="Calibri"/>
-              </a:rPr>
-              <a:t>Secciones a completar:</a:t>
-            </a:r>
-          </a:p>
-        </p:txBody>
-      </p:sp>
-      <p:sp>
-        <p:nvSpPr>
-          <p:cNvPr id="7" name="TextBox 6"/>
+              <a:rPr sz="1400" b="1">
+                <a:solidFill>
+                  <a:srgbClr val="2A2A2A"/>
+                </a:solidFill>
+                <a:latin typeface="Calibri"/>
+              </a:rPr>
+              <a:t>Pasos:</a:t>
+            </a:r>
+          </a:p>
+          <a:p>
+            <a:pPr algn="l"/>
+            <a:r>
+              <a:rPr sz="1400" b="0">
+                <a:solidFill>
+                  <a:srgbClr val="2A2A2A"/>
+                </a:solidFill>
+                <a:latin typeface="Calibri"/>
+              </a:rPr>
+              <a:t>1. Abre el repo del curso en una pestaña nueva:</a:t>
+            </a:r>
+          </a:p>
+          <a:p>
+            <a:pPr algn="l"/>
+            <a:r>
+              <a:rPr sz="1400" b="0">
+                <a:solidFill>
+                  <a:srgbClr val="2A2A2A"/>
+                </a:solidFill>
+                <a:latin typeface="Calibri"/>
+              </a:rPr>
+              <a:t>2. Clic en Issues → New issue</a:t>
+            </a:r>
+          </a:p>
+          <a:p>
+            <a:pPr algn="l"/>
+            <a:r>
+              <a:rPr sz="1400" b="0">
+                <a:solidFill>
+                  <a:srgbClr val="2A2A2A"/>
+                </a:solidFill>
+                <a:latin typeface="Calibri"/>
+              </a:rPr>
+              <a:t>3. Selecciona el template 📤 Entrega de evaluación</a:t>
+            </a:r>
+          </a:p>
+          <a:p>
+            <a:pPr algn="l"/>
+            <a:r>
+              <a:rPr sz="1400" b="0">
+                <a:solidFill>
+                  <a:srgbClr val="2A2A2A"/>
+                </a:solidFill>
+                <a:latin typeface="Calibri"/>
+              </a:rPr>
+              <a:t>4. Completa el formulario: tu nombre, código, URL de tu repo, URL de tu GitHub Pages</a:t>
+            </a:r>
+          </a:p>
+          <a:p>
+            <a:pPr algn="l"/>
+            <a:r>
+              <a:rPr sz="1400" b="0">
+                <a:solidFill>
+                  <a:srgbClr val="2A2A2A"/>
+                </a:solidFill>
+                <a:latin typeface="Calibri"/>
+              </a:rPr>
+              <a:t>5. Clic en Submit (Crear)</a:t>
+            </a:r>
+          </a:p>
+        </p:txBody>
+      </p:sp>
+      <p:sp>
+        <p:nvSpPr>
+          <p:cNvPr id="7" name="Rounded Rectangle 6"/>
+          <p:cNvSpPr/>
+          <p:nvPr/>
+        </p:nvSpPr>
+        <p:spPr>
+          <a:xfrm>
+            <a:off x="640080" y="3657600"/>
+            <a:ext cx="10972800" cy="1280160"/>
+          </a:xfrm>
+          <a:prstGeom prst="roundRect">
+            <a:avLst/>
+          </a:prstGeom>
+          <a:solidFill>
+            <a:srgbClr val="FEF3E6"/>
+          </a:solidFill>
+          <a:ln w="38100">
+            <a:solidFill>
+              <a:srgbClr val="EA580C"/>
+            </a:solidFill>
+          </a:ln>
+        </p:spPr>
+        <p:style>
+          <a:lnRef idx="1">
+            <a:schemeClr val="accent1"/>
+          </a:lnRef>
+          <a:fillRef idx="3">
+            <a:schemeClr val="accent1"/>
+          </a:fillRef>
+          <a:effectRef idx="2">
+            <a:schemeClr val="accent1"/>
+          </a:effectRef>
+          <a:fontRef idx="minor">
+            <a:schemeClr val="lt1"/>
+          </a:fontRef>
+        </p:style>
+        <p:txBody>
+          <a:bodyPr rtlCol="0" anchor="ctr"/>
+          <a:lstStyle/>
+          <a:p>
+            <a:pPr algn="ctr"/>
+          </a:p>
+        </p:txBody>
+      </p:sp>
+      <p:sp>
+        <p:nvSpPr>
+          <p:cNvPr id="8" name="TextBox 7"/>
           <p:cNvSpPr txBox="1"/>
           <p:nvPr/>
         </p:nvSpPr>
         <p:spPr>
           <a:xfrm>
-            <a:off x="822960" y="1828800"/>
-            <a:ext cx="5486400" cy="3657600"/>
+            <a:off x="822960" y="3749039"/>
+            <a:ext cx="10607040" cy="365760"/>
           </a:xfrm>
           <a:prstGeom prst="rect">
             <a:avLst/>
@@ -3774,77 +3867,29 @@
           </a:bodyPr>
           <a:lstStyle/>
           <a:p>
-            <a:pPr algn="l"/>
-            <a:r>
-              <a:rPr sz="1600" b="0">
-                <a:solidFill>
-                  <a:srgbClr val="2A2A2A"/>
-                </a:solidFill>
-                <a:latin typeface="Calibri"/>
-              </a:rPr>
-              <a:t>• VIVO — qué significa, qué métrica</a:t>
-            </a:r>
-          </a:p>
-          <a:p>
-            <a:pPr algn="l"/>
-            <a:r>
-              <a:rPr sz="1600" b="0">
-                <a:solidFill>
-                  <a:srgbClr val="2A2A2A"/>
-                </a:solidFill>
-                <a:latin typeface="Calibri"/>
-              </a:rPr>
-              <a:t>• RÁPIDO — mencionar LCP, INP, CLS o TTFB</a:t>
-            </a:r>
-          </a:p>
-          <a:p>
-            <a:pPr algn="l"/>
-            <a:r>
-              <a:rPr sz="1600" b="0">
-                <a:solidFill>
-                  <a:srgbClr val="2A2A2A"/>
-                </a:solidFill>
-                <a:latin typeface="Calibri"/>
-              </a:rPr>
-              <a:t>• SEGURO — mencionar 2 acciones</a:t>
-            </a:r>
-          </a:p>
-          <a:p>
-            <a:pPr algn="l"/>
-            <a:r>
-              <a:rPr sz="1600" b="0">
-                <a:solidFill>
-                  <a:srgbClr val="2A2A2A"/>
-                </a:solidFill>
-                <a:latin typeface="Calibri"/>
-              </a:rPr>
-              <a:t>• Backup 3-2-1 — explicar</a:t>
-            </a:r>
-          </a:p>
-          <a:p>
-            <a:pPr algn="l"/>
-            <a:r>
-              <a:rPr sz="1600" b="0">
-                <a:solidFill>
-                  <a:srgbClr val="2A2A2A"/>
-                </a:solidFill>
-                <a:latin typeface="Calibri"/>
-              </a:rPr>
-              <a:t>• SLI — proponer un indicador</a:t>
-            </a:r>
-          </a:p>
-        </p:txBody>
-      </p:sp>
-      <p:sp>
-        <p:nvSpPr>
-          <p:cNvPr id="8" name="TextBox 7"/>
+            <a:pPr algn="ctr"/>
+            <a:r>
+              <a:rPr sz="1400" b="1">
+                <a:solidFill>
+                  <a:srgbClr val="EA580C"/>
+                </a:solidFill>
+                <a:latin typeface="Calibri"/>
+              </a:rPr>
+              <a:t>🔗 LINK DIRECTO PARA CREAR EL ISSUE DE ENTREGA:</a:t>
+            </a:r>
+          </a:p>
+        </p:txBody>
+      </p:sp>
+      <p:sp>
+        <p:nvSpPr>
+          <p:cNvPr id="9" name="TextBox 8"/>
           <p:cNvSpPr txBox="1"/>
           <p:nvPr/>
         </p:nvSpPr>
         <p:spPr>
           <a:xfrm>
-            <a:off x="6583680" y="1828800"/>
-            <a:ext cx="5486400" cy="3657600"/>
+            <a:off x="822960" y="4160520"/>
+            <a:ext cx="10607040" cy="457200"/>
           </a:xfrm>
           <a:prstGeom prst="rect">
             <a:avLst/>
@@ -3857,77 +3902,64 @@
           </a:bodyPr>
           <a:lstStyle/>
           <a:p>
-            <a:pPr algn="l"/>
-            <a:r>
-              <a:rPr sz="1600" b="0">
+            <a:pPr algn="ctr"/>
+            <a:r>
+              <a:rPr sz="1400" b="1">
                 <a:solidFill>
                   <a:srgbClr val="2A2A2A"/>
                 </a:solidFill>
-                <a:latin typeface="Calibri"/>
-              </a:rPr>
-              <a:t>• SLO — proponer un objetivo</a:t>
-            </a:r>
-          </a:p>
-          <a:p>
-            <a:pPr algn="l"/>
-            <a:r>
-              <a:rPr sz="1600" b="0">
-                <a:solidFill>
-                  <a:srgbClr val="2A2A2A"/>
-                </a:solidFill>
-                <a:latin typeface="Calibri"/>
-              </a:rPr>
-              <a:t>• SLA — explicar qué es</a:t>
-            </a:r>
-          </a:p>
-          <a:p>
-            <a:pPr algn="l"/>
-            <a:r>
-              <a:rPr sz="1600" b="0">
-                <a:solidFill>
-                  <a:srgbClr val="2A2A2A"/>
-                </a:solidFill>
-                <a:latin typeface="Calibri"/>
-              </a:rPr>
-              <a:t>• Runbook — 4 a 6 pasos para sitio caído</a:t>
-            </a:r>
-          </a:p>
-          <a:p>
-            <a:pPr algn="l"/>
-            <a:r>
-              <a:rPr sz="1600" b="0">
-                <a:solidFill>
-                  <a:srgbClr val="2A2A2A"/>
-                </a:solidFill>
-                <a:latin typeface="Calibri"/>
-              </a:rPr>
-              <a:t>• Datos del estudiante + URLs</a:t>
-            </a:r>
-          </a:p>
-          <a:p>
-            <a:pPr algn="l"/>
-            <a:r>
-              <a:rPr sz="1600" b="0">
-                <a:solidFill>
-                  <a:srgbClr val="2A2A2A"/>
-                </a:solidFill>
-                <a:latin typeface="Calibri"/>
-              </a:rPr>
-              <a:t/>
-            </a:r>
-          </a:p>
-        </p:txBody>
-      </p:sp>
-      <p:sp>
-        <p:nvSpPr>
-          <p:cNvPr id="9" name="Rounded Rectangle 8"/>
+                <a:latin typeface="Consolas"/>
+              </a:rPr>
+              <a:t>https://github.com/KrizRoMe/evaluacion-administracion-web/issues/new?template=entrega.yml</a:t>
+            </a:r>
+          </a:p>
+        </p:txBody>
+      </p:sp>
+      <p:sp>
+        <p:nvSpPr>
+          <p:cNvPr id="10" name="TextBox 9"/>
+          <p:cNvSpPr txBox="1"/>
+          <p:nvPr/>
+        </p:nvSpPr>
+        <p:spPr>
+          <a:xfrm>
+            <a:off x="822960" y="4572000"/>
+            <a:ext cx="10607040" cy="274320"/>
+          </a:xfrm>
+          <a:prstGeom prst="rect">
+            <a:avLst/>
+          </a:prstGeom>
+          <a:noFill/>
+        </p:spPr>
+        <p:txBody>
+          <a:bodyPr wrap="square">
+            <a:spAutoFit/>
+          </a:bodyPr>
+          <a:lstStyle/>
+          <a:p>
+            <a:pPr algn="ctr"/>
+            <a:r>
+              <a:rPr sz="1000" b="0">
+                <a:solidFill>
+                  <a:srgbClr val="999999"/>
+                </a:solidFill>
+                <a:latin typeface="Calibri"/>
+              </a:rPr>
+              <a:t>(también lo encuentras en la pestaña Issues del repo del docente)</a:t>
+            </a:r>
+          </a:p>
+        </p:txBody>
+      </p:sp>
+      <p:sp>
+        <p:nvSpPr>
+          <p:cNvPr id="11" name="Rounded Rectangle 10"/>
           <p:cNvSpPr/>
           <p:nvPr/>
         </p:nvSpPr>
         <p:spPr>
           <a:xfrm>
-            <a:off x="640080" y="5760720"/>
-            <a:ext cx="10972800" cy="457200"/>
+            <a:off x="640080" y="5120640"/>
+            <a:ext cx="10972800" cy="1188720"/>
           </a:xfrm>
           <a:prstGeom prst="roundRect">
             <a:avLst/>
@@ -3965,14 +3997,14 @@
       </p:sp>
       <p:sp>
         <p:nvSpPr>
-          <p:cNvPr id="10" name="TextBox 9"/>
+          <p:cNvPr id="12" name="TextBox 11"/>
           <p:cNvSpPr txBox="1"/>
           <p:nvPr/>
         </p:nvSpPr>
         <p:spPr>
           <a:xfrm>
-            <a:off x="640080" y="5806440"/>
-            <a:ext cx="10972800" cy="365760"/>
+            <a:off x="822960" y="5166360"/>
+            <a:ext cx="10607040" cy="274320"/>
           </a:xfrm>
           <a:prstGeom prst="rect">
             <a:avLst/>
@@ -3985,29 +4017,29 @@
           </a:bodyPr>
           <a:lstStyle/>
           <a:p>
-            <a:pPr algn="ctr"/>
-            <a:r>
-              <a:rPr sz="1400" b="1">
+            <a:pPr algn="l"/>
+            <a:r>
+              <a:rPr sz="1300" b="1">
                 <a:solidFill>
                   <a:srgbClr val="065A82"/>
                 </a:solidFill>
                 <a:latin typeface="Calibri"/>
               </a:rPr>
-              <a:t>💡 No necesitas respuestas perfectas. Explica con tus propias palabras.</a:t>
-            </a:r>
-          </a:p>
-        </p:txBody>
-      </p:sp>
-      <p:sp>
-        <p:nvSpPr>
-          <p:cNvPr id="11" name="TextBox 10"/>
+              <a:t>La Issue de entrega te pide:</a:t>
+            </a:r>
+          </a:p>
+        </p:txBody>
+      </p:sp>
+      <p:sp>
+        <p:nvSpPr>
+          <p:cNvPr id="13" name="TextBox 12"/>
           <p:cNvSpPr txBox="1"/>
           <p:nvPr/>
         </p:nvSpPr>
         <p:spPr>
           <a:xfrm>
-            <a:off x="457200" y="6446520"/>
-            <a:ext cx="6400800" cy="274320"/>
+            <a:off x="1005840" y="5486400"/>
+            <a:ext cx="10424160" cy="822960"/>
           </a:xfrm>
           <a:prstGeom prst="rect">
             <a:avLst/>
@@ -4022,20 +4054,55 @@
           <a:p>
             <a:pPr algn="l"/>
             <a:r>
+              <a:rPr sz="1200" b="0">
+                <a:solidFill>
+                  <a:srgbClr val="2A2A2A"/>
+                </a:solidFill>
+                <a:latin typeface="Calibri"/>
+              </a:rPr>
+              <a:t>• Nombre completo • Código • URL de TU repositorio  •  URL de TU GitHub Pages  •  Checklist de auto-verificación</a:t>
+            </a:r>
+          </a:p>
+        </p:txBody>
+      </p:sp>
+      <p:sp>
+        <p:nvSpPr>
+          <p:cNvPr id="14" name="TextBox 13"/>
+          <p:cNvSpPr txBox="1"/>
+          <p:nvPr/>
+        </p:nvSpPr>
+        <p:spPr>
+          <a:xfrm>
+            <a:off x="457200" y="6446520"/>
+            <a:ext cx="7315200" cy="274320"/>
+          </a:xfrm>
+          <a:prstGeom prst="rect">
+            <a:avLst/>
+          </a:prstGeom>
+          <a:noFill/>
+        </p:spPr>
+        <p:txBody>
+          <a:bodyPr wrap="square">
+            <a:spAutoFit/>
+          </a:bodyPr>
+          <a:lstStyle/>
+          <a:p>
+            <a:pPr algn="l"/>
+            <a:r>
               <a:rPr sz="800" b="0">
                 <a:solidFill>
                   <a:srgbClr val="666666"/>
                 </a:solidFill>
                 <a:latin typeface="Calibri"/>
               </a:rPr>
-              <a:t>📦 Repositorio: github.com/KrizRoMe/evaluacion-administracion-web   •   🌐 Sitio: krizrome.github.io/evaluacion-administracion-web</a:t>
-            </a:r>
-          </a:p>
-        </p:txBody>
-      </p:sp>
-      <p:sp>
-        <p:nvSpPr>
-          <p:cNvPr id="12" name="TextBox 11"/>
+              <a:t>📦 Repo: github.com/KrizRoMe/evaluacion-administracion-web   •   🌐 Web: krizrome.github.io/evaluacion-administracion-web   •   📋 Issues: github.com/KrizRoMe/evaluacion-administracion-web/issues</a:t>
+            </a:r>
+          </a:p>
+        </p:txBody>
+      </p:sp>
+      <p:sp>
+        <p:nvSpPr>
+          <p:cNvPr id="15" name="TextBox 14"/>
           <p:cNvSpPr txBox="1"/>
           <p:nvPr/>
         </p:nvSpPr>
@@ -4202,7 +4269,7 @@
                 </a:solidFill>
                 <a:latin typeface="Calibri"/>
               </a:rPr>
-              <a:t>✅ Checklist final y entrega</a:t>
+              <a:t>✅ Checklist final completo</a:t>
             </a:r>
           </a:p>
         </p:txBody>
@@ -4237,7 +4304,7 @@
                 </a:solidFill>
                 <a:latin typeface="Calibri"/>
               </a:rPr>
-              <a:t>⏱ 5 minutos de verificación</a:t>
+              <a:t>Antes de entregar, verifica TODO</a:t>
             </a:r>
           </a:p>
         </p:txBody>
@@ -4250,8 +4317,8 @@
         </p:nvSpPr>
         <p:spPr>
           <a:xfrm>
-            <a:off x="822960" y="1280160"/>
-            <a:ext cx="5486400" cy="3657600"/>
+            <a:off x="640080" y="1188720"/>
+            <a:ext cx="5486400" cy="365760"/>
           </a:xfrm>
           <a:prstGeom prst="rect">
             <a:avLst/>
@@ -4266,49 +4333,13 @@
           <a:p>
             <a:pPr algn="l"/>
             <a:r>
-              <a:rPr sz="1800" b="0">
-                <a:solidFill>
-                  <a:srgbClr val="2A2A2A"/>
-                </a:solidFill>
-                <a:latin typeface="Calibri"/>
-              </a:rPr>
-              <a:t>☐ Repositorio público</a:t>
-            </a:r>
-          </a:p>
-          <a:p>
-            <a:pPr algn="l"/>
-            <a:r>
-              <a:rPr sz="1800" b="0">
-                <a:solidFill>
-                  <a:srgbClr val="2A2A2A"/>
-                </a:solidFill>
-                <a:latin typeface="Calibri"/>
-              </a:rPr>
-              <a:t>☐ GitHub Pages funciona</a:t>
-            </a:r>
-          </a:p>
-          <a:p>
-            <a:pPr algn="l"/>
-            <a:r>
-              <a:rPr sz="1800" b="0">
-                <a:solidFill>
-                  <a:srgbClr val="2A2A2A"/>
-                </a:solidFill>
-                <a:latin typeface="Calibri"/>
-              </a:rPr>
-              <a:t>☐ Tengo exactamente 3 Issues</a:t>
-            </a:r>
-          </a:p>
-          <a:p>
-            <a:pPr algn="l"/>
-            <a:r>
-              <a:rPr sz="1800" b="0">
-                <a:solidFill>
-                  <a:srgbClr val="2A2A2A"/>
-                </a:solidFill>
-                <a:latin typeface="Calibri"/>
-              </a:rPr>
-              <a:t>☐ Cada Issue usa un template</a:t>
+              <a:rPr sz="1800" b="1">
+                <a:solidFill>
+                  <a:srgbClr val="065A82"/>
+                </a:solidFill>
+                <a:latin typeface="Calibri"/>
+              </a:rPr>
+              <a:t>📦 En TU repositorio:</a:t>
             </a:r>
           </a:p>
         </p:txBody>
@@ -4321,8 +4352,8 @@
         </p:nvSpPr>
         <p:spPr>
           <a:xfrm>
-            <a:off x="6583680" y="1280160"/>
-            <a:ext cx="5486400" cy="3657600"/>
+            <a:off x="822960" y="1645920"/>
+            <a:ext cx="5486400" cy="3200400"/>
           </a:xfrm>
           <a:prstGeom prst="rect">
             <a:avLst/>
@@ -4337,43 +4368,79 @@
           <a:p>
             <a:pPr algn="l"/>
             <a:r>
-              <a:rPr sz="1800" b="0">
+              <a:rPr sz="1400" b="0">
                 <a:solidFill>
                   <a:srgbClr val="2A2A2A"/>
                 </a:solidFill>
                 <a:latin typeface="Calibri"/>
               </a:rPr>
-              <a:t>☐ Cada Issue tiene todas las secciones</a:t>
-            </a:r>
-          </a:p>
-          <a:p>
-            <a:pPr algn="l"/>
-            <a:r>
-              <a:rPr sz="1800" b="0">
+              <a:t>☐ Repo público</a:t>
+            </a:r>
+          </a:p>
+          <a:p>
+            <a:pPr algn="l"/>
+            <a:r>
+              <a:rPr sz="1400" b="0">
                 <a:solidFill>
                   <a:srgbClr val="2A2A2A"/>
                 </a:solidFill>
                 <a:latin typeface="Calibri"/>
               </a:rPr>
-              <a:t>☐ Soluciones propuestas en texto</a:t>
-            </a:r>
-          </a:p>
-          <a:p>
-            <a:pPr algn="l"/>
-            <a:r>
-              <a:rPr sz="1800" b="0">
+              <a:t>☐ GitHub Pages funciona</a:t>
+            </a:r>
+          </a:p>
+          <a:p>
+            <a:pPr algn="l"/>
+            <a:r>
+              <a:rPr sz="1400" b="0">
                 <a:solidFill>
                   <a:srgbClr val="2A2A2A"/>
                 </a:solidFill>
                 <a:latin typeface="Calibri"/>
               </a:rPr>
+              <a:t>☐ EXACTAMENTE 3 Issues creadas</a:t>
+            </a:r>
+          </a:p>
+          <a:p>
+            <a:pPr algn="l"/>
+            <a:r>
+              <a:rPr sz="1400" b="0">
+                <a:solidFill>
+                  <a:srgbClr val="2A2A2A"/>
+                </a:solidFill>
+                <a:latin typeface="Calibri"/>
+              </a:rPr>
+              <a:t>☐ Cada Issue usa un template .yml</a:t>
+            </a:r>
+          </a:p>
+          <a:p>
+            <a:pPr algn="l"/>
+            <a:r>
+              <a:rPr sz="1400" b="0">
+                <a:solidFill>
+                  <a:srgbClr val="2A2A2A"/>
+                </a:solidFill>
+                <a:latin typeface="Calibri"/>
+              </a:rPr>
+              <a:t>☐ Cada Issue completa todas las secciones</a:t>
+            </a:r>
+          </a:p>
+          <a:p>
+            <a:pPr algn="l"/>
+            <a:r>
+              <a:rPr sz="1400" b="0">
+                <a:solidFill>
+                  <a:srgbClr val="2A2A2A"/>
+                </a:solidFill>
+                <a:latin typeface="Calibri"/>
+              </a:rPr>
               <a:t>☐ README completo</a:t>
             </a:r>
           </a:p>
           <a:p>
             <a:pPr algn="l"/>
             <a:r>
-              <a:rPr sz="1800" b="0">
+              <a:rPr sz="1400" b="0">
                 <a:solidFill>
                   <a:srgbClr val="2A2A2A"/>
                 </a:solidFill>
@@ -4386,20 +4453,162 @@
       </p:sp>
       <p:sp>
         <p:nvSpPr>
-          <p:cNvPr id="8" name="Rounded Rectangle 7"/>
+          <p:cNvPr id="8" name="TextBox 7"/>
+          <p:cNvSpPr txBox="1"/>
+          <p:nvPr/>
+        </p:nvSpPr>
+        <p:spPr>
+          <a:xfrm>
+            <a:off x="6217920" y="1188720"/>
+            <a:ext cx="5486400" cy="365760"/>
+          </a:xfrm>
+          <a:prstGeom prst="rect">
+            <a:avLst/>
+          </a:prstGeom>
+          <a:noFill/>
+        </p:spPr>
+        <p:txBody>
+          <a:bodyPr wrap="square">
+            <a:spAutoFit/>
+          </a:bodyPr>
+          <a:lstStyle/>
+          <a:p>
+            <a:pPr algn="l"/>
+            <a:r>
+              <a:rPr sz="1800" b="1">
+                <a:solidFill>
+                  <a:srgbClr val="EA580C"/>
+                </a:solidFill>
+                <a:latin typeface="Calibri"/>
+              </a:rPr>
+              <a:t>📤 En repo del DOCENTE (entrega):</a:t>
+            </a:r>
+          </a:p>
+        </p:txBody>
+      </p:sp>
+      <p:sp>
+        <p:nvSpPr>
+          <p:cNvPr id="9" name="TextBox 8"/>
+          <p:cNvSpPr txBox="1"/>
+          <p:nvPr/>
+        </p:nvSpPr>
+        <p:spPr>
+          <a:xfrm>
+            <a:off x="6400800" y="1645920"/>
+            <a:ext cx="5486400" cy="3200400"/>
+          </a:xfrm>
+          <a:prstGeom prst="rect">
+            <a:avLst/>
+          </a:prstGeom>
+          <a:noFill/>
+        </p:spPr>
+        <p:txBody>
+          <a:bodyPr wrap="square">
+            <a:spAutoFit/>
+          </a:bodyPr>
+          <a:lstStyle/>
+          <a:p>
+            <a:pPr algn="l"/>
+            <a:r>
+              <a:rPr sz="1400" b="0">
+                <a:solidFill>
+                  <a:srgbClr val="2A2A2A"/>
+                </a:solidFill>
+                <a:latin typeface="Calibri"/>
+              </a:rPr>
+              <a:t>☐ Abrí el link de entrega</a:t>
+            </a:r>
+          </a:p>
+          <a:p>
+            <a:pPr algn="l"/>
+            <a:r>
+              <a:rPr sz="1400" b="0">
+                <a:solidFill>
+                  <a:srgbClr val="2A2A2A"/>
+                </a:solidFill>
+                <a:latin typeface="Calibri"/>
+              </a:rPr>
+              <a:t>☐ Seleccioné el template 'Entrega'</a:t>
+            </a:r>
+          </a:p>
+          <a:p>
+            <a:pPr algn="l"/>
+            <a:r>
+              <a:rPr sz="1400" b="0">
+                <a:solidFill>
+                  <a:srgbClr val="2A2A2A"/>
+                </a:solidFill>
+                <a:latin typeface="Calibri"/>
+              </a:rPr>
+              <a:t>☐ Completé nombre, código</a:t>
+            </a:r>
+          </a:p>
+          <a:p>
+            <a:pPr algn="l"/>
+            <a:r>
+              <a:rPr sz="1400" b="0">
+                <a:solidFill>
+                  <a:srgbClr val="2A2A2A"/>
+                </a:solidFill>
+                <a:latin typeface="Calibri"/>
+              </a:rPr>
+              <a:t>☐ Pegué URL de mi repo</a:t>
+            </a:r>
+          </a:p>
+          <a:p>
+            <a:pPr algn="l"/>
+            <a:r>
+              <a:rPr sz="1400" b="0">
+                <a:solidFill>
+                  <a:srgbClr val="2A2A2A"/>
+                </a:solidFill>
+                <a:latin typeface="Calibri"/>
+              </a:rPr>
+              <a:t>☐ Pegué URL de mi GitHub Pages</a:t>
+            </a:r>
+          </a:p>
+          <a:p>
+            <a:pPr algn="l"/>
+            <a:r>
+              <a:rPr sz="1400" b="0">
+                <a:solidFill>
+                  <a:srgbClr val="2A2A2A"/>
+                </a:solidFill>
+                <a:latin typeface="Calibri"/>
+              </a:rPr>
+              <a:t>☐ Marqué el checklist</a:t>
+            </a:r>
+          </a:p>
+          <a:p>
+            <a:pPr algn="l"/>
+            <a:r>
+              <a:rPr sz="1400" b="0">
+                <a:solidFill>
+                  <a:srgbClr val="2A2A2A"/>
+                </a:solidFill>
+                <a:latin typeface="Calibri"/>
+              </a:rPr>
+              <a:t>☐ Envié la Issue</a:t>
+            </a:r>
+          </a:p>
+        </p:txBody>
+      </p:sp>
+      <p:sp>
+        <p:nvSpPr>
+          <p:cNvPr id="10" name="Rounded Rectangle 9"/>
           <p:cNvSpPr/>
           <p:nvPr/>
         </p:nvSpPr>
         <p:spPr>
           <a:xfrm>
-            <a:off x="640080" y="4114800"/>
-            <a:ext cx="10972800" cy="2103120"/>
+            <a:off x="640080" y="4937760"/>
+            <a:ext cx="10972800" cy="1371600"/>
           </a:xfrm>
           <a:prstGeom prst="roundRect">
             <a:avLst/>
           </a:prstGeom>
           <a:solidFill>
-            <a:srgbClr val="065A82"/>
+            <a:srgbClr val="EA580C"/>
           </a:solidFill>
           <a:ln>
             <a:noFill/>
@@ -4429,13 +4638,13 @@
       </p:sp>
       <p:sp>
         <p:nvSpPr>
-          <p:cNvPr id="9" name="TextBox 8"/>
+          <p:cNvPr id="11" name="TextBox 10"/>
           <p:cNvSpPr txBox="1"/>
           <p:nvPr/>
         </p:nvSpPr>
         <p:spPr>
           <a:xfrm>
-            <a:off x="822960" y="4206240"/>
+            <a:off x="822960" y="4983480"/>
             <a:ext cx="10607040" cy="365760"/>
           </a:xfrm>
           <a:prstGeom prst="rect">
@@ -4451,72 +4660,27 @@
           <a:p>
             <a:pPr algn="ctr"/>
             <a:r>
-              <a:rPr sz="2000" b="1">
-                <a:solidFill>
-                  <a:srgbClr val="60A5FA"/>
-                </a:solidFill>
-                <a:latin typeface="Calibri"/>
-              </a:rPr>
-              <a:t>📤 ENTREGAR AL DOCENTE</a:t>
-            </a:r>
-          </a:p>
-        </p:txBody>
-      </p:sp>
-      <p:sp>
-        <p:nvSpPr>
-          <p:cNvPr id="10" name="Rounded Rectangle 9"/>
-          <p:cNvSpPr/>
-          <p:nvPr/>
-        </p:nvSpPr>
-        <p:spPr>
-          <a:xfrm>
-            <a:off x="914400" y="4617720"/>
-            <a:ext cx="10424160" cy="731520"/>
-          </a:xfrm>
-          <a:prstGeom prst="roundRect">
-            <a:avLst/>
-          </a:prstGeom>
-          <a:solidFill>
-            <a:srgbClr val="0E4D70"/>
-          </a:solidFill>
-          <a:ln w="25400">
-            <a:solidFill>
-              <a:srgbClr val="FFFFFF"/>
-            </a:solidFill>
-          </a:ln>
-        </p:spPr>
-        <p:style>
-          <a:lnRef idx="1">
-            <a:schemeClr val="accent1"/>
-          </a:lnRef>
-          <a:fillRef idx="3">
-            <a:schemeClr val="accent1"/>
-          </a:fillRef>
-          <a:effectRef idx="2">
-            <a:schemeClr val="accent1"/>
-          </a:effectRef>
-          <a:fontRef idx="minor">
-            <a:schemeClr val="lt1"/>
-          </a:fontRef>
-        </p:style>
-        <p:txBody>
-          <a:bodyPr rtlCol="0" anchor="ctr"/>
-          <a:lstStyle/>
-          <a:p>
-            <a:pPr algn="ctr"/>
-          </a:p>
-        </p:txBody>
-      </p:sp>
-      <p:sp>
-        <p:nvSpPr>
-          <p:cNvPr id="11" name="TextBox 10"/>
+              <a:rPr sz="1400" b="1">
+                <a:solidFill>
+                  <a:srgbClr val="FFFFFF"/>
+                </a:solidFill>
+                <a:latin typeface="Calibri"/>
+              </a:rPr>
+              <a:t>🔗 ENTREGAR AL DOCENTE — Crear Issue de entrega aquí:</a:t>
+            </a:r>
+          </a:p>
+        </p:txBody>
+      </p:sp>
+      <p:sp>
+        <p:nvSpPr>
+          <p:cNvPr id="12" name="TextBox 11"/>
           <p:cNvSpPr txBox="1"/>
           <p:nvPr/>
         </p:nvSpPr>
         <p:spPr>
           <a:xfrm>
-            <a:off x="1097280" y="4754880"/>
-            <a:ext cx="10058400" cy="457200"/>
+            <a:off x="822960" y="5394960"/>
+            <a:ext cx="10607040" cy="548640"/>
           </a:xfrm>
           <a:prstGeom prst="rect">
             <a:avLst/>
@@ -4529,29 +4693,29 @@
           </a:bodyPr>
           <a:lstStyle/>
           <a:p>
-            <a:pPr algn="l"/>
-            <a:r>
-              <a:rPr sz="1600" b="1">
+            <a:pPr algn="ctr"/>
+            <a:r>
+              <a:rPr sz="1200" b="1">
                 <a:solidFill>
                   <a:srgbClr val="FFFFFF"/>
                 </a:solidFill>
-                <a:latin typeface="Calibri"/>
-              </a:rPr>
-              <a:t>📦 URL de TU repositorio</a:t>
-            </a:r>
-          </a:p>
-        </p:txBody>
-      </p:sp>
-      <p:sp>
-        <p:nvSpPr>
-          <p:cNvPr id="12" name="TextBox 11"/>
+                <a:latin typeface="Consolas"/>
+              </a:rPr>
+              <a:t>https://github.com/KrizRoMe/evaluacion-administracion-web/issues/new?template=entrega.yml</a:t>
+            </a:r>
+          </a:p>
+        </p:txBody>
+      </p:sp>
+      <p:sp>
+        <p:nvSpPr>
+          <p:cNvPr id="13" name="TextBox 12"/>
           <p:cNvSpPr txBox="1"/>
           <p:nvPr/>
         </p:nvSpPr>
         <p:spPr>
           <a:xfrm>
-            <a:off x="1097280" y="5212080"/>
-            <a:ext cx="10058400" cy="91440"/>
+            <a:off x="822960" y="5989320"/>
+            <a:ext cx="10607040" cy="274320"/>
           </a:xfrm>
           <a:prstGeom prst="rect">
             <a:avLst/>
@@ -4564,61 +4728,16 @@
           </a:bodyPr>
           <a:lstStyle/>
           <a:p>
-            <a:pPr algn="l"/>
-            <a:r>
-              <a:rPr sz="1400" b="0">
-                <a:solidFill>
-                  <a:srgbClr val="2A2A2A"/>
-                </a:solidFill>
-                <a:latin typeface="Consolas"/>
-              </a:rPr>
-              <a:t>https://github.com/TU-USUARIO/evaluacion-administracion-web-TU-NOMBRE</a:t>
-            </a:r>
-          </a:p>
-        </p:txBody>
-      </p:sp>
-      <p:sp>
-        <p:nvSpPr>
-          <p:cNvPr id="13" name="Rounded Rectangle 12"/>
-          <p:cNvSpPr/>
-          <p:nvPr/>
-        </p:nvSpPr>
-        <p:spPr>
-          <a:xfrm>
-            <a:off x="914400" y="5440680"/>
-            <a:ext cx="10424160" cy="731520"/>
-          </a:xfrm>
-          <a:prstGeom prst="roundRect">
-            <a:avLst/>
-          </a:prstGeom>
-          <a:solidFill>
-            <a:srgbClr val="0E4D70"/>
-          </a:solidFill>
-          <a:ln w="25400">
-            <a:solidFill>
-              <a:srgbClr val="FFFFFF"/>
-            </a:solidFill>
-          </a:ln>
-        </p:spPr>
-        <p:style>
-          <a:lnRef idx="1">
-            <a:schemeClr val="accent1"/>
-          </a:lnRef>
-          <a:fillRef idx="3">
-            <a:schemeClr val="accent1"/>
-          </a:fillRef>
-          <a:effectRef idx="2">
-            <a:schemeClr val="accent1"/>
-          </a:effectRef>
-          <a:fontRef idx="minor">
-            <a:schemeClr val="lt1"/>
-          </a:fontRef>
-        </p:style>
-        <p:txBody>
-          <a:bodyPr rtlCol="0" anchor="ctr"/>
-          <a:lstStyle/>
-          <a:p>
             <a:pPr algn="ctr"/>
+            <a:r>
+              <a:rPr sz="1100" b="0">
+                <a:solidFill>
+                  <a:srgbClr val="FED3B6"/>
+                </a:solidFill>
+                <a:latin typeface="Calibri"/>
+              </a:rPr>
+              <a:t>📌  Los 3 hallazgos van en TU repo.  La ENTREGA final va AQUÍ.</a:t>
+            </a:r>
           </a:p>
         </p:txBody>
       </p:sp>
@@ -4630,8 +4749,8 @@
         </p:nvSpPr>
         <p:spPr>
           <a:xfrm>
-            <a:off x="1097280" y="5577840"/>
-            <a:ext cx="10058400" cy="457200"/>
+            <a:off x="457200" y="6446520"/>
+            <a:ext cx="7315200" cy="274320"/>
           </a:xfrm>
           <a:prstGeom prst="rect">
             <a:avLst/>
@@ -4646,13 +4765,13 @@
           <a:p>
             <a:pPr algn="l"/>
             <a:r>
-              <a:rPr sz="1600" b="1">
-                <a:solidFill>
-                  <a:srgbClr val="FFFFFF"/>
-                </a:solidFill>
-                <a:latin typeface="Calibri"/>
-              </a:rPr>
-              <a:t>🌐 URL de TU GitHub Pages</a:t>
+              <a:rPr sz="800" b="0">
+                <a:solidFill>
+                  <a:srgbClr val="666666"/>
+                </a:solidFill>
+                <a:latin typeface="Calibri"/>
+              </a:rPr>
+              <a:t>📦 Repo: github.com/KrizRoMe/evaluacion-administracion-web   •   🌐 Web: krizrome.github.io/evaluacion-administracion-web   •   📋 Issues: github.com/KrizRoMe/evaluacion-administracion-web/issues</a:t>
             </a:r>
           </a:p>
         </p:txBody>
@@ -4660,76 +4779,6 @@
       <p:sp>
         <p:nvSpPr>
           <p:cNvPr id="15" name="TextBox 14"/>
-          <p:cNvSpPr txBox="1"/>
-          <p:nvPr/>
-        </p:nvSpPr>
-        <p:spPr>
-          <a:xfrm>
-            <a:off x="1097280" y="6035040"/>
-            <a:ext cx="10058400" cy="91440"/>
-          </a:xfrm>
-          <a:prstGeom prst="rect">
-            <a:avLst/>
-          </a:prstGeom>
-          <a:noFill/>
-        </p:spPr>
-        <p:txBody>
-          <a:bodyPr wrap="square">
-            <a:spAutoFit/>
-          </a:bodyPr>
-          <a:lstStyle/>
-          <a:p>
-            <a:pPr algn="l"/>
-            <a:r>
-              <a:rPr sz="1400" b="0">
-                <a:solidFill>
-                  <a:srgbClr val="2A2A2A"/>
-                </a:solidFill>
-                <a:latin typeface="Consolas"/>
-              </a:rPr>
-              <a:t>https://TU-USUARIO.github.io/evaluacion-administracion-web-TU-NOMBRE/</a:t>
-            </a:r>
-          </a:p>
-        </p:txBody>
-      </p:sp>
-      <p:sp>
-        <p:nvSpPr>
-          <p:cNvPr id="16" name="TextBox 15"/>
-          <p:cNvSpPr txBox="1"/>
-          <p:nvPr/>
-        </p:nvSpPr>
-        <p:spPr>
-          <a:xfrm>
-            <a:off x="457200" y="6446520"/>
-            <a:ext cx="6400800" cy="274320"/>
-          </a:xfrm>
-          <a:prstGeom prst="rect">
-            <a:avLst/>
-          </a:prstGeom>
-          <a:noFill/>
-        </p:spPr>
-        <p:txBody>
-          <a:bodyPr wrap="square">
-            <a:spAutoFit/>
-          </a:bodyPr>
-          <a:lstStyle/>
-          <a:p>
-            <a:pPr algn="l"/>
-            <a:r>
-              <a:rPr sz="800" b="0">
-                <a:solidFill>
-                  <a:srgbClr val="666666"/>
-                </a:solidFill>
-                <a:latin typeface="Calibri"/>
-              </a:rPr>
-              <a:t>📦 Repositorio: github.com/KrizRoMe/evaluacion-administracion-web   •   🌐 Sitio: krizrome.github.io/evaluacion-administracion-web</a:t>
-            </a:r>
-          </a:p>
-        </p:txBody>
-      </p:sp>
-      <p:sp>
-        <p:nvSpPr>
-          <p:cNvPr id="17" name="TextBox 16"/>
           <p:cNvSpPr txBox="1"/>
           <p:nvPr/>
         </p:nvSpPr>
@@ -5251,7 +5300,7 @@
         <p:spPr>
           <a:xfrm>
             <a:off x="457200" y="6446520"/>
-            <a:ext cx="6400800" cy="274320"/>
+            <a:ext cx="7315200" cy="274320"/>
           </a:xfrm>
           <a:prstGeom prst="rect">
             <a:avLst/>
@@ -5272,7 +5321,7 @@
                 </a:solidFill>
                 <a:latin typeface="Calibri"/>
               </a:rPr>
-              <a:t>📦 Repositorio: github.com/KrizRoMe/evaluacion-administracion-web   •   🌐 Sitio: krizrome.github.io/evaluacion-administracion-web</a:t>
+              <a:t>📦 Repo: github.com/KrizRoMe/evaluacion-administracion-web   •   🌐 Web: krizrome.github.io/evaluacion-administracion-web   •   📋 Issues: github.com/KrizRoMe/evaluacion-administracion-web/issues</a:t>
             </a:r>
           </a:p>
         </p:txBody>
@@ -5481,7 +5530,7 @@
                 </a:solidFill>
                 <a:latin typeface="Calibri"/>
               </a:rPr>
-              <a:t>Estas son las URLs que vas a usar y entregar</a:t>
+              <a:t>Sitio base + tu repo + dónde entregar</a:t>
             </a:r>
           </a:p>
         </p:txBody>
@@ -5494,8 +5543,8 @@
         </p:nvSpPr>
         <p:spPr>
           <a:xfrm>
-            <a:off x="640080" y="1280160"/>
-            <a:ext cx="10972800" cy="457200"/>
+            <a:off x="640080" y="1188720"/>
+            <a:ext cx="10972800" cy="365760"/>
           </a:xfrm>
           <a:prstGeom prst="rect">
             <a:avLst/>
@@ -5510,13 +5559,13 @@
           <a:p>
             <a:pPr algn="l"/>
             <a:r>
-              <a:rPr sz="1800" b="1">
+              <a:rPr sz="1600" b="1">
                 <a:solidFill>
                   <a:srgbClr val="065A82"/>
                 </a:solidFill>
                 <a:latin typeface="Calibri"/>
               </a:rPr>
-              <a:t>🌐  Sitio base (código que vas a auditar)</a:t>
+              <a:t>🌐  Sitio base (el código que vas a auditar)</a:t>
             </a:r>
           </a:p>
         </p:txBody>
@@ -5529,8 +5578,8 @@
         </p:nvSpPr>
         <p:spPr>
           <a:xfrm>
-            <a:off x="640080" y="1783080"/>
-            <a:ext cx="10972800" cy="777240"/>
+            <a:off x="640080" y="1600200"/>
+            <a:ext cx="10972800" cy="640080"/>
           </a:xfrm>
           <a:prstGeom prst="roundRect">
             <a:avLst/>
@@ -5574,7 +5623,7 @@
         </p:nvSpPr>
         <p:spPr>
           <a:xfrm>
-            <a:off x="822959" y="1920240"/>
+            <a:off x="822959" y="1737360"/>
             <a:ext cx="10607040" cy="457200"/>
           </a:xfrm>
           <a:prstGeom prst="rect">
@@ -5609,8 +5658,8 @@
         </p:nvSpPr>
         <p:spPr>
           <a:xfrm>
-            <a:off x="822959" y="2377440"/>
-            <a:ext cx="10607040" cy="137160"/>
+            <a:off x="822959" y="2240280"/>
+            <a:ext cx="10607040" cy="-91440"/>
           </a:xfrm>
           <a:prstGeom prst="rect">
             <a:avLst/>
@@ -5644,8 +5693,8 @@
         </p:nvSpPr>
         <p:spPr>
           <a:xfrm>
-            <a:off x="640080" y="2788920"/>
-            <a:ext cx="10972800" cy="457200"/>
+            <a:off x="640080" y="2423160"/>
+            <a:ext cx="10972800" cy="365760"/>
           </a:xfrm>
           <a:prstGeom prst="rect">
             <a:avLst/>
@@ -5660,7 +5709,7 @@
           <a:p>
             <a:pPr algn="l"/>
             <a:r>
-              <a:rPr sz="1800" b="1">
+              <a:rPr sz="1600" b="1">
                 <a:solidFill>
                   <a:srgbClr val="065A82"/>
                 </a:solidFill>
@@ -5679,8 +5728,8 @@
         </p:nvSpPr>
         <p:spPr>
           <a:xfrm>
-            <a:off x="640080" y="3291840"/>
-            <a:ext cx="10972800" cy="777240"/>
+            <a:off x="640080" y="2834640"/>
+            <a:ext cx="10972800" cy="640080"/>
           </a:xfrm>
           <a:prstGeom prst="roundRect">
             <a:avLst/>
@@ -5724,7 +5773,7 @@
         </p:nvSpPr>
         <p:spPr>
           <a:xfrm>
-            <a:off x="822959" y="3429000"/>
+            <a:off x="822959" y="2971800"/>
             <a:ext cx="10607040" cy="457200"/>
           </a:xfrm>
           <a:prstGeom prst="rect">
@@ -5746,7 +5795,7 @@
                 </a:solidFill>
                 <a:latin typeface="Calibri"/>
               </a:rPr>
-              <a:t>Patrón de nombre (reemplaza TU-NOMBRE por tu nombre)</a:t>
+              <a:t>Patrón: reemplaza TU-NOMBRE por tu nombre</a:t>
             </a:r>
           </a:p>
         </p:txBody>
@@ -5759,8 +5808,8 @@
         </p:nvSpPr>
         <p:spPr>
           <a:xfrm>
-            <a:off x="822959" y="3886200"/>
-            <a:ext cx="10607040" cy="137160"/>
+            <a:off x="822959" y="3474720"/>
+            <a:ext cx="10607040" cy="-91440"/>
           </a:xfrm>
           <a:prstGeom prst="rect">
             <a:avLst/>
@@ -5794,8 +5843,8 @@
         </p:nvSpPr>
         <p:spPr>
           <a:xfrm>
-            <a:off x="640080" y="4297680"/>
-            <a:ext cx="10972800" cy="457200"/>
+            <a:off x="640080" y="3657600"/>
+            <a:ext cx="10972800" cy="365760"/>
           </a:xfrm>
           <a:prstGeom prst="rect">
             <a:avLst/>
@@ -5810,7 +5859,7 @@
           <a:p>
             <a:pPr algn="l"/>
             <a:r>
-              <a:rPr sz="1800" b="1">
+              <a:rPr sz="1600" b="1">
                 <a:solidFill>
                   <a:srgbClr val="065A82"/>
                 </a:solidFill>
@@ -5829,8 +5878,8 @@
         </p:nvSpPr>
         <p:spPr>
           <a:xfrm>
-            <a:off x="640080" y="4800600"/>
-            <a:ext cx="10972800" cy="777240"/>
+            <a:off x="640080" y="4069080"/>
+            <a:ext cx="10972800" cy="640080"/>
           </a:xfrm>
           <a:prstGeom prst="roundRect">
             <a:avLst/>
@@ -5874,7 +5923,7 @@
         </p:nvSpPr>
         <p:spPr>
           <a:xfrm>
-            <a:off x="822959" y="4937760"/>
+            <a:off x="822959" y="4206240"/>
             <a:ext cx="10607040" cy="457200"/>
           </a:xfrm>
           <a:prstGeom prst="rect">
@@ -5909,8 +5958,8 @@
         </p:nvSpPr>
         <p:spPr>
           <a:xfrm>
-            <a:off x="822959" y="5394960"/>
-            <a:ext cx="10607040" cy="137160"/>
+            <a:off x="822959" y="4709160"/>
+            <a:ext cx="10607040" cy="-91440"/>
           </a:xfrm>
           <a:prstGeom prst="rect">
             <a:avLst/>
@@ -5938,14 +5987,164 @@
       </p:sp>
       <p:sp>
         <p:nvSpPr>
-          <p:cNvPr id="18" name="Rounded Rectangle 17"/>
+          <p:cNvPr id="18" name="TextBox 17"/>
+          <p:cNvSpPr txBox="1"/>
+          <p:nvPr/>
+        </p:nvSpPr>
+        <p:spPr>
+          <a:xfrm>
+            <a:off x="640080" y="4892040"/>
+            <a:ext cx="10972800" cy="365760"/>
+          </a:xfrm>
+          <a:prstGeom prst="rect">
+            <a:avLst/>
+          </a:prstGeom>
+          <a:noFill/>
+        </p:spPr>
+        <p:txBody>
+          <a:bodyPr wrap="square">
+            <a:spAutoFit/>
+          </a:bodyPr>
+          <a:lstStyle/>
+          <a:p>
+            <a:pPr algn="l"/>
+            <a:r>
+              <a:rPr sz="1600" b="1">
+                <a:solidFill>
+                  <a:srgbClr val="EA580C"/>
+                </a:solidFill>
+                <a:latin typeface="Calibri"/>
+              </a:rPr>
+              <a:t>📤  Dónde entregas tu evaluación (Issue de entrega)</a:t>
+            </a:r>
+          </a:p>
+        </p:txBody>
+      </p:sp>
+      <p:sp>
+        <p:nvSpPr>
+          <p:cNvPr id="19" name="Rounded Rectangle 18"/>
           <p:cNvSpPr/>
           <p:nvPr/>
         </p:nvSpPr>
         <p:spPr>
           <a:xfrm>
-            <a:off x="640080" y="5760720"/>
-            <a:ext cx="10972800" cy="548640"/>
+            <a:off x="640080" y="5303520"/>
+            <a:ext cx="10972800" cy="777240"/>
+          </a:xfrm>
+          <a:prstGeom prst="roundRect">
+            <a:avLst/>
+          </a:prstGeom>
+          <a:solidFill>
+            <a:srgbClr val="FEF3E6"/>
+          </a:solidFill>
+          <a:ln w="25400">
+            <a:solidFill>
+              <a:srgbClr val="EA580C"/>
+            </a:solidFill>
+          </a:ln>
+        </p:spPr>
+        <p:style>
+          <a:lnRef idx="1">
+            <a:schemeClr val="accent1"/>
+          </a:lnRef>
+          <a:fillRef idx="3">
+            <a:schemeClr val="accent1"/>
+          </a:fillRef>
+          <a:effectRef idx="2">
+            <a:schemeClr val="accent1"/>
+          </a:effectRef>
+          <a:fontRef idx="minor">
+            <a:schemeClr val="lt1"/>
+          </a:fontRef>
+        </p:style>
+        <p:txBody>
+          <a:bodyPr rtlCol="0" anchor="ctr"/>
+          <a:lstStyle/>
+          <a:p>
+            <a:pPr algn="ctr"/>
+          </a:p>
+        </p:txBody>
+      </p:sp>
+      <p:sp>
+        <p:nvSpPr>
+          <p:cNvPr id="20" name="TextBox 19"/>
+          <p:cNvSpPr txBox="1"/>
+          <p:nvPr/>
+        </p:nvSpPr>
+        <p:spPr>
+          <a:xfrm>
+            <a:off x="822959" y="5440680"/>
+            <a:ext cx="10607040" cy="457200"/>
+          </a:xfrm>
+          <a:prstGeom prst="rect">
+            <a:avLst/>
+          </a:prstGeom>
+          <a:noFill/>
+        </p:spPr>
+        <p:txBody>
+          <a:bodyPr wrap="square">
+            <a:spAutoFit/>
+          </a:bodyPr>
+          <a:lstStyle/>
+          <a:p>
+            <a:pPr algn="l"/>
+            <a:r>
+              <a:rPr sz="1600" b="1">
+                <a:solidFill>
+                  <a:srgbClr val="EA580C"/>
+                </a:solidFill>
+                <a:latin typeface="Calibri"/>
+              </a:rPr>
+              <a:t>Crea una Issue con el template 'Entrega' en el repo del docente:</a:t>
+            </a:r>
+          </a:p>
+        </p:txBody>
+      </p:sp>
+      <p:sp>
+        <p:nvSpPr>
+          <p:cNvPr id="21" name="TextBox 20"/>
+          <p:cNvSpPr txBox="1"/>
+          <p:nvPr/>
+        </p:nvSpPr>
+        <p:spPr>
+          <a:xfrm>
+            <a:off x="822959" y="5943600"/>
+            <a:ext cx="10607040" cy="45719"/>
+          </a:xfrm>
+          <a:prstGeom prst="rect">
+            <a:avLst/>
+          </a:prstGeom>
+          <a:noFill/>
+        </p:spPr>
+        <p:txBody>
+          <a:bodyPr wrap="square">
+            <a:spAutoFit/>
+          </a:bodyPr>
+          <a:lstStyle/>
+          <a:p>
+            <a:pPr algn="l"/>
+            <a:r>
+              <a:rPr sz="1200" b="0">
+                <a:solidFill>
+                  <a:srgbClr val="2A2A2A"/>
+                </a:solidFill>
+                <a:latin typeface="Consolas"/>
+              </a:rPr>
+              <a:t>https://github.com/KrizRoMe/evaluacion-administracion-web/issues/new?template=entrega.yml</a:t>
+            </a:r>
+          </a:p>
+        </p:txBody>
+      </p:sp>
+      <p:sp>
+        <p:nvSpPr>
+          <p:cNvPr id="22" name="Rounded Rectangle 21"/>
+          <p:cNvSpPr/>
+          <p:nvPr/>
+        </p:nvSpPr>
+        <p:spPr>
+          <a:xfrm>
+            <a:off x="640080" y="6172200"/>
+            <a:ext cx="10972800" cy="274320"/>
           </a:xfrm>
           <a:prstGeom prst="roundRect">
             <a:avLst/>
@@ -5983,14 +6182,14 @@
       </p:sp>
       <p:sp>
         <p:nvSpPr>
-          <p:cNvPr id="19" name="TextBox 18"/>
+          <p:cNvPr id="23" name="TextBox 22"/>
           <p:cNvSpPr txBox="1"/>
           <p:nvPr/>
         </p:nvSpPr>
         <p:spPr>
           <a:xfrm>
-            <a:off x="640080" y="5852160"/>
-            <a:ext cx="10972800" cy="365760"/>
+            <a:off x="640080" y="6217920"/>
+            <a:ext cx="10972800" cy="182880"/>
           </a:xfrm>
           <a:prstGeom prst="rect">
             <a:avLst/>
@@ -6005,27 +6204,27 @@
           <a:p>
             <a:pPr algn="ctr"/>
             <a:r>
-              <a:rPr sz="1400" b="1">
+              <a:rPr sz="1100" b="1">
                 <a:solidFill>
                   <a:srgbClr val="924E0E"/>
                 </a:solidFill>
                 <a:latin typeface="Calibri"/>
               </a:rPr>
-              <a:t>📌 Al final de la evaluación entrega al docente: URL de tu repo + URL de tu GitHub Pages.</a:t>
-            </a:r>
-          </a:p>
-        </p:txBody>
-      </p:sp>
-      <p:sp>
-        <p:nvSpPr>
-          <p:cNvPr id="20" name="TextBox 19"/>
+              <a:t>📌  Los 3 hallazgos se documentan como Issues EN TU REPO.  La entrega final se hace como Issue AQUÍ.</a:t>
+            </a:r>
+          </a:p>
+        </p:txBody>
+      </p:sp>
+      <p:sp>
+        <p:nvSpPr>
+          <p:cNvPr id="24" name="TextBox 23"/>
           <p:cNvSpPr txBox="1"/>
           <p:nvPr/>
         </p:nvSpPr>
         <p:spPr>
           <a:xfrm>
             <a:off x="457200" y="6446520"/>
-            <a:ext cx="6400800" cy="274320"/>
+            <a:ext cx="7315200" cy="274320"/>
           </a:xfrm>
           <a:prstGeom prst="rect">
             <a:avLst/>
@@ -6046,14 +6245,14 @@
                 </a:solidFill>
                 <a:latin typeface="Calibri"/>
               </a:rPr>
-              <a:t>📦 Repositorio: github.com/KrizRoMe/evaluacion-administracion-web   •   🌐 Sitio: krizrome.github.io/evaluacion-administracion-web</a:t>
-            </a:r>
-          </a:p>
-        </p:txBody>
-      </p:sp>
-      <p:sp>
-        <p:nvSpPr>
-          <p:cNvPr id="21" name="TextBox 20"/>
+              <a:t>📦 Repo: github.com/KrizRoMe/evaluacion-administracion-web   •   🌐 Web: krizrome.github.io/evaluacion-administracion-web   •   📋 Issues: github.com/KrizRoMe/evaluacion-administracion-web/issues</a:t>
+            </a:r>
+          </a:p>
+        </p:txBody>
+      </p:sp>
+      <p:sp>
+        <p:nvSpPr>
+          <p:cNvPr id="25" name="TextBox 24"/>
           <p:cNvSpPr txBox="1"/>
           <p:nvPr/>
         </p:nvSpPr>
@@ -6268,8 +6467,8 @@
         </p:nvSpPr>
         <p:spPr>
           <a:xfrm>
-            <a:off x="586587" y="2286000"/>
-            <a:ext cx="1417320" cy="1371600"/>
+            <a:off x="723747" y="2286000"/>
+            <a:ext cx="1417320" cy="1554480"/>
           </a:xfrm>
           <a:prstGeom prst="roundRect">
             <a:avLst/>
@@ -6311,8 +6510,8 @@
         </p:nvSpPr>
         <p:spPr>
           <a:xfrm>
-            <a:off x="586587" y="2606040"/>
-            <a:ext cx="1417320" cy="731520"/>
+            <a:off x="723747" y="2606040"/>
+            <a:ext cx="1417320" cy="914400"/>
           </a:xfrm>
           <a:prstGeom prst="rect">
             <a:avLst/>
@@ -6327,7 +6526,7 @@
           <a:p>
             <a:pPr algn="ctr"/>
             <a:r>
-              <a:rPr sz="1400" b="1">
+              <a:rPr sz="1300" b="1">
                 <a:solidFill>
                   <a:srgbClr val="FFFFFF"/>
                 </a:solidFill>
@@ -6347,8 +6546,8 @@
         </p:nvSpPr>
         <p:spPr>
           <a:xfrm>
-            <a:off x="2022195" y="2834640"/>
-            <a:ext cx="146304" cy="274320"/>
+            <a:off x="2150211" y="2926080"/>
+            <a:ext cx="118872" cy="274320"/>
           </a:xfrm>
           <a:prstGeom prst="rightArrow">
             <a:avLst/>
@@ -6390,8 +6589,8 @@
         </p:nvSpPr>
         <p:spPr>
           <a:xfrm>
-            <a:off x="2186787" y="2286000"/>
-            <a:ext cx="1417320" cy="1371600"/>
+            <a:off x="2278227" y="2286000"/>
+            <a:ext cx="1417320" cy="1554480"/>
           </a:xfrm>
           <a:prstGeom prst="roundRect">
             <a:avLst/>
@@ -6433,8 +6632,8 @@
         </p:nvSpPr>
         <p:spPr>
           <a:xfrm>
-            <a:off x="2186787" y="2606040"/>
-            <a:ext cx="1417320" cy="731520"/>
+            <a:off x="2278227" y="2606040"/>
+            <a:ext cx="1417320" cy="914400"/>
           </a:xfrm>
           <a:prstGeom prst="rect">
             <a:avLst/>
@@ -6449,7 +6648,7 @@
           <a:p>
             <a:pPr algn="ctr"/>
             <a:r>
-              <a:rPr sz="1400" b="1">
+              <a:rPr sz="1300" b="1">
                 <a:solidFill>
                   <a:srgbClr val="FFFFFF"/>
                 </a:solidFill>
@@ -6469,8 +6668,8 @@
         </p:nvSpPr>
         <p:spPr>
           <a:xfrm>
-            <a:off x="3622395" y="2834640"/>
-            <a:ext cx="146304" cy="274320"/>
+            <a:off x="3704691" y="2926080"/>
+            <a:ext cx="118872" cy="274320"/>
           </a:xfrm>
           <a:prstGeom prst="rightArrow">
             <a:avLst/>
@@ -6512,8 +6711,8 @@
         </p:nvSpPr>
         <p:spPr>
           <a:xfrm>
-            <a:off x="3786987" y="2286000"/>
-            <a:ext cx="1417320" cy="1371600"/>
+            <a:off x="3832707" y="2286000"/>
+            <a:ext cx="1417320" cy="1554480"/>
           </a:xfrm>
           <a:prstGeom prst="roundRect">
             <a:avLst/>
@@ -6555,8 +6754,8 @@
         </p:nvSpPr>
         <p:spPr>
           <a:xfrm>
-            <a:off x="3786987" y="2606040"/>
-            <a:ext cx="1417320" cy="731520"/>
+            <a:off x="3832707" y="2606040"/>
+            <a:ext cx="1417320" cy="914400"/>
           </a:xfrm>
           <a:prstGeom prst="rect">
             <a:avLst/>
@@ -6571,7 +6770,7 @@
           <a:p>
             <a:pPr algn="ctr"/>
             <a:r>
-              <a:rPr sz="1400" b="1">
+              <a:rPr sz="1300" b="1">
                 <a:solidFill>
                   <a:srgbClr val="FFFFFF"/>
                 </a:solidFill>
@@ -6591,8 +6790,8 @@
         </p:nvSpPr>
         <p:spPr>
           <a:xfrm>
-            <a:off x="5222595" y="2834640"/>
-            <a:ext cx="146304" cy="274320"/>
+            <a:off x="5259171" y="2926080"/>
+            <a:ext cx="118872" cy="274320"/>
           </a:xfrm>
           <a:prstGeom prst="rightArrow">
             <a:avLst/>
@@ -6635,7 +6834,7 @@
         <p:spPr>
           <a:xfrm>
             <a:off x="5387187" y="2286000"/>
-            <a:ext cx="1417320" cy="1371600"/>
+            <a:ext cx="1417320" cy="1554480"/>
           </a:xfrm>
           <a:prstGeom prst="roundRect">
             <a:avLst/>
@@ -6678,7 +6877,7 @@
         <p:spPr>
           <a:xfrm>
             <a:off x="5387187" y="2606040"/>
-            <a:ext cx="1417320" cy="731520"/>
+            <a:ext cx="1417320" cy="914400"/>
           </a:xfrm>
           <a:prstGeom prst="rect">
             <a:avLst/>
@@ -6693,7 +6892,7 @@
           <a:p>
             <a:pPr algn="ctr"/>
             <a:r>
-              <a:rPr sz="1400" b="1">
+              <a:rPr sz="1300" b="1">
                 <a:solidFill>
                   <a:srgbClr val="FFFFFF"/>
                 </a:solidFill>
@@ -6713,8 +6912,8 @@
         </p:nvSpPr>
         <p:spPr>
           <a:xfrm>
-            <a:off x="6822795" y="2834640"/>
-            <a:ext cx="146304" cy="274320"/>
+            <a:off x="6813651" y="2926080"/>
+            <a:ext cx="118872" cy="274320"/>
           </a:xfrm>
           <a:prstGeom prst="rightArrow">
             <a:avLst/>
@@ -6756,8 +6955,8 @@
         </p:nvSpPr>
         <p:spPr>
           <a:xfrm>
-            <a:off x="6987387" y="2286000"/>
-            <a:ext cx="1417320" cy="1371600"/>
+            <a:off x="6941667" y="2286000"/>
+            <a:ext cx="1417320" cy="1554480"/>
           </a:xfrm>
           <a:prstGeom prst="roundRect">
             <a:avLst/>
@@ -6799,8 +6998,8 @@
         </p:nvSpPr>
         <p:spPr>
           <a:xfrm>
-            <a:off x="6987387" y="2606040"/>
-            <a:ext cx="1417320" cy="731520"/>
+            <a:off x="6941667" y="2606040"/>
+            <a:ext cx="1417320" cy="914400"/>
           </a:xfrm>
           <a:prstGeom prst="rect">
             <a:avLst/>
@@ -6815,14 +7014,14 @@
           <a:p>
             <a:pPr algn="ctr"/>
             <a:r>
-              <a:rPr sz="1400" b="1">
+              <a:rPr sz="1300" b="1">
                 <a:solidFill>
                   <a:srgbClr val="FFFFFF"/>
                 </a:solidFill>
                 <a:latin typeface="Calibri"/>
               </a:rPr>
-              <a:t>3
-Issues</a:t>
+              <a:t>3 Issues
+en TU repo</a:t>
             </a:r>
           </a:p>
         </p:txBody>
@@ -6835,8 +7034,8 @@
         </p:nvSpPr>
         <p:spPr>
           <a:xfrm>
-            <a:off x="8422995" y="2834640"/>
-            <a:ext cx="146304" cy="274320"/>
+            <a:off x="8368131" y="2926080"/>
+            <a:ext cx="118872" cy="274320"/>
           </a:xfrm>
           <a:prstGeom prst="rightArrow">
             <a:avLst/>
@@ -6878,8 +7077,8 @@
         </p:nvSpPr>
         <p:spPr>
           <a:xfrm>
-            <a:off x="8587587" y="2286000"/>
-            <a:ext cx="1417320" cy="1371600"/>
+            <a:off x="8496147" y="2286000"/>
+            <a:ext cx="1417320" cy="1554480"/>
           </a:xfrm>
           <a:prstGeom prst="roundRect">
             <a:avLst/>
@@ -6921,8 +7120,8 @@
         </p:nvSpPr>
         <p:spPr>
           <a:xfrm>
-            <a:off x="8587587" y="2606040"/>
-            <a:ext cx="1417320" cy="731520"/>
+            <a:off x="8496147" y="2606040"/>
+            <a:ext cx="1417320" cy="914400"/>
           </a:xfrm>
           <a:prstGeom prst="rect">
             <a:avLst/>
@@ -6937,14 +7136,13 @@
           <a:p>
             <a:pPr algn="ctr"/>
             <a:r>
-              <a:rPr sz="1400" b="1">
+              <a:rPr sz="1300" b="1">
                 <a:solidFill>
                   <a:srgbClr val="FFFFFF"/>
                 </a:solidFill>
                 <a:latin typeface="Calibri"/>
               </a:rPr>
-              <a:t>Documentar
-solución</a:t>
+              <a:t>README</a:t>
             </a:r>
           </a:p>
         </p:txBody>
@@ -6957,8 +7155,8 @@
         </p:nvSpPr>
         <p:spPr>
           <a:xfrm>
-            <a:off x="10023195" y="2834640"/>
-            <a:ext cx="146304" cy="274320"/>
+            <a:off x="9922611" y="2926080"/>
+            <a:ext cx="118872" cy="274320"/>
           </a:xfrm>
           <a:prstGeom prst="rightArrow">
             <a:avLst/>
@@ -7000,14 +7198,14 @@
         </p:nvSpPr>
         <p:spPr>
           <a:xfrm>
-            <a:off x="10187787" y="2286000"/>
-            <a:ext cx="1417320" cy="1371600"/>
+            <a:off x="10050627" y="2286000"/>
+            <a:ext cx="1417320" cy="1554480"/>
           </a:xfrm>
           <a:prstGeom prst="roundRect">
             <a:avLst/>
           </a:prstGeom>
           <a:solidFill>
-            <a:srgbClr val="065A82"/>
+            <a:srgbClr val="EA580C"/>
           </a:solidFill>
           <a:ln>
             <a:noFill/>
@@ -7043,8 +7241,8 @@
         </p:nvSpPr>
         <p:spPr>
           <a:xfrm>
-            <a:off x="10187787" y="2606040"/>
-            <a:ext cx="1417320" cy="731520"/>
+            <a:off x="10050627" y="2606040"/>
+            <a:ext cx="1417320" cy="914400"/>
           </a:xfrm>
           <a:prstGeom prst="rect">
             <a:avLst/>
@@ -7059,14 +7257,14 @@
           <a:p>
             <a:pPr algn="ctr"/>
             <a:r>
-              <a:rPr sz="1400" b="1">
+              <a:rPr sz="1300" b="1">
                 <a:solidFill>
                   <a:srgbClr val="FFFFFF"/>
                 </a:solidFill>
                 <a:latin typeface="Calibri"/>
               </a:rPr>
-              <a:t>README +
-entrega</a:t>
+              <a:t>Issue de
+entrega AQUÍ</a:t>
             </a:r>
           </a:p>
         </p:txBody>
@@ -7130,7 +7328,7 @@
           <a:p>
             <a:pPr algn="l"/>
             <a:r>
-              <a:rPr sz="1400" b="0">
+              <a:rPr sz="1300" b="0">
                 <a:solidFill>
                   <a:srgbClr val="2A2A2A"/>
                 </a:solidFill>
@@ -7142,13 +7340,13 @@
           <a:p>
             <a:pPr algn="l"/>
             <a:r>
-              <a:rPr sz="1400" b="0">
+              <a:rPr sz="1300" b="0">
                 <a:solidFill>
                   <a:srgbClr val="2A2A2A"/>
                 </a:solidFill>
                 <a:latin typeface="Calibri"/>
               </a:rPr>
-              <a:t>Issues: 20 min   •   Documentar solución: 10 min   •   README: 15 min   •   Verificación: 5 min</a:t>
+              <a:t>Issues (TU repo): 20 min   •   Documentar solución: 10 min   •   README: 15 min   •   Issue de entrega: 5 min</a:t>
             </a:r>
           </a:p>
         </p:txBody>
@@ -7242,7 +7440,7 @@
         <p:spPr>
           <a:xfrm>
             <a:off x="457200" y="6446520"/>
-            <a:ext cx="6400800" cy="274320"/>
+            <a:ext cx="7315200" cy="274320"/>
           </a:xfrm>
           <a:prstGeom prst="rect">
             <a:avLst/>
@@ -7263,7 +7461,7 @@
                 </a:solidFill>
                 <a:latin typeface="Calibri"/>
               </a:rPr>
-              <a:t>📦 Repositorio: github.com/KrizRoMe/evaluacion-administracion-web   •   🌐 Sitio: krizrome.github.io/evaluacion-administracion-web</a:t>
+              <a:t>📦 Repo: github.com/KrizRoMe/evaluacion-administracion-web   •   🌐 Web: krizrome.github.io/evaluacion-administracion-web   •   📋 Issues: github.com/KrizRoMe/evaluacion-administracion-web/issues</a:t>
             </a:r>
           </a:p>
         </p:txBody>
@@ -7873,7 +8071,7 @@
         <p:spPr>
           <a:xfrm>
             <a:off x="457200" y="6446520"/>
-            <a:ext cx="6400800" cy="274320"/>
+            <a:ext cx="7315200" cy="274320"/>
           </a:xfrm>
           <a:prstGeom prst="rect">
             <a:avLst/>
@@ -7894,7 +8092,7 @@
                 </a:solidFill>
                 <a:latin typeface="Calibri"/>
               </a:rPr>
-              <a:t>📦 Repositorio: github.com/KrizRoMe/evaluacion-administracion-web   •   🌐 Sitio: krizrome.github.io/evaluacion-administracion-web</a:t>
+              <a:t>📦 Repo: github.com/KrizRoMe/evaluacion-administracion-web   •   🌐 Web: krizrome.github.io/evaluacion-administracion-web   •   📋 Issues: github.com/KrizRoMe/evaluacion-administracion-web/issues</a:t>
             </a:r>
           </a:p>
         </p:txBody>
@@ -8421,7 +8619,7 @@
         <p:spPr>
           <a:xfrm>
             <a:off x="457200" y="6446520"/>
-            <a:ext cx="6400800" cy="274320"/>
+            <a:ext cx="7315200" cy="274320"/>
           </a:xfrm>
           <a:prstGeom prst="rect">
             <a:avLst/>
@@ -8442,7 +8640,7 @@
                 </a:solidFill>
                 <a:latin typeface="Calibri"/>
               </a:rPr>
-              <a:t>📦 Repositorio: github.com/KrizRoMe/evaluacion-administracion-web   •   🌐 Sitio: krizrome.github.io/evaluacion-administracion-web</a:t>
+              <a:t>📦 Repo: github.com/KrizRoMe/evaluacion-administracion-web   •   🌐 Web: krizrome.github.io/evaluacion-administracion-web   •   📋 Issues: github.com/KrizRoMe/evaluacion-administracion-web/issues</a:t>
             </a:r>
           </a:p>
         </p:txBody>
@@ -9098,7 +9296,7 @@
         <p:spPr>
           <a:xfrm>
             <a:off x="457200" y="6446520"/>
-            <a:ext cx="6400800" cy="274320"/>
+            <a:ext cx="7315200" cy="274320"/>
           </a:xfrm>
           <a:prstGeom prst="rect">
             <a:avLst/>
@@ -9119,7 +9317,7 @@
                 </a:solidFill>
                 <a:latin typeface="Calibri"/>
               </a:rPr>
-              <a:t>📦 Repositorio: github.com/KrizRoMe/evaluacion-administracion-web   •   🌐 Sitio: krizrome.github.io/evaluacion-administracion-web</a:t>
+              <a:t>📦 Repo: github.com/KrizRoMe/evaluacion-administracion-web   •   🌐 Web: krizrome.github.io/evaluacion-administracion-web   •   📋 Issues: github.com/KrizRoMe/evaluacion-administracion-web/issues</a:t>
             </a:r>
           </a:p>
         </p:txBody>
@@ -9293,7 +9491,7 @@
                 </a:solidFill>
                 <a:latin typeface="Calibri"/>
               </a:rPr>
-              <a:t>Parte 4 · Crear 3 GitHub Issues</a:t>
+              <a:t>Parte 4 · Crear 3 Issues en TU repo</a:t>
             </a:r>
           </a:p>
         </p:txBody>
@@ -9328,21 +9526,66 @@
                 </a:solidFill>
                 <a:latin typeface="Calibri"/>
               </a:rPr>
-              <a:t>⏱ 20 minutos  •  Usa los templates del repo</a:t>
-            </a:r>
-          </a:p>
-        </p:txBody>
-      </p:sp>
-      <p:sp>
-        <p:nvSpPr>
-          <p:cNvPr id="6" name="TextBox 5"/>
+              <a:t>⏱ 20 minutos  •  Usa los templates interactivos</a:t>
+            </a:r>
+          </a:p>
+        </p:txBody>
+      </p:sp>
+      <p:sp>
+        <p:nvSpPr>
+          <p:cNvPr id="6" name="Rounded Rectangle 5"/>
+          <p:cNvSpPr/>
+          <p:nvPr/>
+        </p:nvSpPr>
+        <p:spPr>
+          <a:xfrm>
+            <a:off x="640080" y="1188720"/>
+            <a:ext cx="10972800" cy="548640"/>
+          </a:xfrm>
+          <a:prstGeom prst="roundRect">
+            <a:avLst/>
+          </a:prstGeom>
+          <a:solidFill>
+            <a:srgbClr val="E3F2FD"/>
+          </a:solidFill>
+          <a:ln w="25400">
+            <a:solidFill>
+              <a:srgbClr val="1C7293"/>
+            </a:solidFill>
+          </a:ln>
+        </p:spPr>
+        <p:style>
+          <a:lnRef idx="1">
+            <a:schemeClr val="accent1"/>
+          </a:lnRef>
+          <a:fillRef idx="3">
+            <a:schemeClr val="accent1"/>
+          </a:fillRef>
+          <a:effectRef idx="2">
+            <a:schemeClr val="accent1"/>
+          </a:effectRef>
+          <a:fontRef idx="minor">
+            <a:schemeClr val="lt1"/>
+          </a:fontRef>
+        </p:style>
+        <p:txBody>
+          <a:bodyPr rtlCol="0" anchor="ctr"/>
+          <a:lstStyle/>
+          <a:p>
+            <a:pPr algn="ctr"/>
+          </a:p>
+        </p:txBody>
+      </p:sp>
+      <p:sp>
+        <p:nvSpPr>
+          <p:cNvPr id="7" name="TextBox 6"/>
           <p:cNvSpPr txBox="1"/>
           <p:nvPr/>
         </p:nvSpPr>
         <p:spPr>
           <a:xfrm>
             <a:off x="640080" y="1280160"/>
-            <a:ext cx="10972800" cy="822960"/>
+            <a:ext cx="10972800" cy="365760"/>
           </a:xfrm>
           <a:prstGeom prst="rect">
             <a:avLst/>
@@ -9355,29 +9598,29 @@
           </a:bodyPr>
           <a:lstStyle/>
           <a:p>
-            <a:pPr algn="l"/>
+            <a:pPr algn="ctr"/>
             <a:r>
               <a:rPr sz="1500" b="1">
                 <a:solidFill>
-                  <a:srgbClr val="2A2A2A"/>
-                </a:solidFill>
-                <a:latin typeface="Calibri"/>
-              </a:rPr>
-              <a:t>Crear EXACTAMENTE 3 Issues usando los templates de .github/ISSUE_TEMPLATE/:</a:t>
-            </a:r>
-          </a:p>
-        </p:txBody>
-      </p:sp>
-      <p:sp>
-        <p:nvSpPr>
-          <p:cNvPr id="7" name="TextBox 6"/>
+                  <a:srgbClr val="065A82"/>
+                </a:solidFill>
+                <a:latin typeface="Calibri"/>
+              </a:rPr>
+              <a:t>⚠️  Estos 3 Issues se crean en TU PROPIO repositorio, NO en el del docente.</a:t>
+            </a:r>
+          </a:p>
+        </p:txBody>
+      </p:sp>
+      <p:sp>
+        <p:nvSpPr>
+          <p:cNvPr id="8" name="TextBox 7"/>
           <p:cNvSpPr txBox="1"/>
           <p:nvPr/>
         </p:nvSpPr>
         <p:spPr>
           <a:xfrm>
-            <a:off x="822960" y="1783080"/>
-            <a:ext cx="10972800" cy="1097280"/>
+            <a:off x="640080" y="1920240"/>
+            <a:ext cx="10972800" cy="365760"/>
           </a:xfrm>
           <a:prstGeom prst="rect">
             <a:avLst/>
@@ -9392,13 +9635,48 @@
           <a:p>
             <a:pPr algn="l"/>
             <a:r>
+              <a:rPr sz="1500" b="1">
+                <a:solidFill>
+                  <a:srgbClr val="2A2A2A"/>
+                </a:solidFill>
+                <a:latin typeface="Calibri"/>
+              </a:rPr>
+              <a:t>Templates interactivos disponibles (en .github/ISSUE_TEMPLATE/):</a:t>
+            </a:r>
+          </a:p>
+        </p:txBody>
+      </p:sp>
+      <p:sp>
+        <p:nvSpPr>
+          <p:cNvPr id="9" name="TextBox 8"/>
+          <p:cNvSpPr txBox="1"/>
+          <p:nvPr/>
+        </p:nvSpPr>
+        <p:spPr>
+          <a:xfrm>
+            <a:off x="822960" y="2377440"/>
+            <a:ext cx="10972800" cy="1097280"/>
+          </a:xfrm>
+          <a:prstGeom prst="rect">
+            <a:avLst/>
+          </a:prstGeom>
+          <a:noFill/>
+        </p:spPr>
+        <p:txBody>
+          <a:bodyPr wrap="square">
+            <a:spAutoFit/>
+          </a:bodyPr>
+          <a:lstStyle/>
+          <a:p>
+            <a:pPr algn="l"/>
+            <a:r>
               <a:rPr sz="1400" b="0">
                 <a:solidFill>
                   <a:srgbClr val="2A2A2A"/>
                 </a:solidFill>
                 <a:latin typeface="Calibri"/>
               </a:rPr>
-              <a:t>📊 rendimiento.md     →  hallazgos de performance / Lighthouse</a:t>
+              <a:t>📊 rendimiento.yml     →  hallazgos de performance / Lighthouse</a:t>
             </a:r>
           </a:p>
           <a:p>
@@ -9410,7 +9688,7 @@
                 </a:solidFill>
                 <a:latin typeface="Calibri"/>
               </a:rPr>
-              <a:t>🔧 mantenimiento.md   →  hallazgos de dependencias / seguridad</a:t>
+              <a:t>🔧 mantenimiento.yml   →  hallazgos de dependencias / seguridad</a:t>
             </a:r>
           </a:p>
           <a:p>
@@ -9422,7 +9700,7 @@
                 </a:solidFill>
                 <a:latin typeface="Calibri"/>
               </a:rPr>
-              <a:t>♿ accesibilidad.md   →  hallazgos de axe DevTools</a:t>
+              <a:t>♿ accesibilidad.yml   →  hallazgos de axe DevTools</a:t>
             </a:r>
           </a:p>
           <a:p>
@@ -9434,21 +9712,21 @@
                 </a:solidFill>
                 <a:latin typeface="Calibri"/>
               </a:rPr>
-              <a:t>📝 general.md         →  cualquier otro hallazgo</a:t>
-            </a:r>
-          </a:p>
-        </p:txBody>
-      </p:sp>
-      <p:sp>
-        <p:nvSpPr>
-          <p:cNvPr id="8" name="Rounded Rectangle 7"/>
+              <a:t>📝 general.yml         →  cualquier otro hallazgo</a:t>
+            </a:r>
+          </a:p>
+        </p:txBody>
+      </p:sp>
+      <p:sp>
+        <p:nvSpPr>
+          <p:cNvPr id="10" name="Rounded Rectangle 9"/>
           <p:cNvSpPr/>
           <p:nvPr/>
         </p:nvSpPr>
         <p:spPr>
           <a:xfrm>
-            <a:off x="640080" y="3017520"/>
-            <a:ext cx="10972800" cy="2743200"/>
+            <a:off x="640080" y="3657600"/>
+            <a:ext cx="10972800" cy="2377440"/>
           </a:xfrm>
           <a:prstGeom prst="roundRect">
             <a:avLst/>
@@ -9486,14 +9764,14 @@
       </p:sp>
       <p:sp>
         <p:nvSpPr>
-          <p:cNvPr id="9" name="TextBox 8"/>
+          <p:cNvPr id="11" name="TextBox 10"/>
           <p:cNvSpPr txBox="1"/>
           <p:nvPr/>
         </p:nvSpPr>
         <p:spPr>
           <a:xfrm>
-            <a:off x="822960" y="3108960"/>
-            <a:ext cx="10607040" cy="2651760"/>
+            <a:off x="822960" y="3749039"/>
+            <a:ext cx="10607040" cy="2286000"/>
           </a:xfrm>
           <a:prstGeom prst="rect">
             <a:avLst/>
@@ -9514,7 +9792,7 @@
                 </a:solidFill>
                 <a:latin typeface="Calibri"/>
               </a:rPr>
-              <a:t>### Problema                |   ### Ubicación y reproducción</a:t>
+              <a:t>Cada template es un FORMULARIO INTERACTIVO con:</a:t>
             </a:r>
           </a:p>
           <a:p>
@@ -9526,7 +9804,7 @@
                 </a:solidFill>
                 <a:latin typeface="Calibri"/>
               </a:rPr>
-              <a:t>¿Qué encontraste?                    ¿Dónde? ¿Cómo comprobarlo?</a:t>
+              <a:t/>
             </a:r>
           </a:p>
           <a:p>
@@ -9538,19 +9816,19 @@
                 </a:solidFill>
                 <a:latin typeface="Calibri"/>
               </a:rPr>
-              <a:t/>
-            </a:r>
-          </a:p>
-          <a:p>
-            <a:pPr algn="l"/>
-            <a:r>
-              <a:rPr sz="1300" b="1">
+              <a:t>📝 Inputs  →  Problema, Ubicación, Concepto, Justificación</a:t>
+            </a:r>
+          </a:p>
+          <a:p>
+            <a:pPr algn="l"/>
+            <a:r>
+              <a:rPr sz="1300" b="0">
                 <a:solidFill>
                   <a:srgbClr val="FFFFFF"/>
                 </a:solidFill>
                 <a:latin typeface="Calibri"/>
               </a:rPr>
-              <a:t>### Evidencia                |   ### Concepto del curso</a:t>
+              <a:t>📄 Textareas  →  Evidencia, Impacto, Solución propuesta</a:t>
             </a:r>
           </a:p>
           <a:p>
@@ -9562,7 +9840,7 @@
                 </a:solidFill>
                 <a:latin typeface="Calibri"/>
               </a:rPr>
-              <a:t>Lighthouse / Network / axe / código   VIVO / RÁPIDO / SEGURO + concepto</a:t>
+              <a:t>🔽 Dropdowns  →  Pilar, Tipo de mantenimiento, Severidad</a:t>
             </a:r>
           </a:p>
           <a:p>
@@ -9574,90 +9852,33 @@
                 </a:solidFill>
                 <a:latin typeface="Calibri"/>
               </a:rPr>
-              <a:t/>
-            </a:r>
-          </a:p>
-          <a:p>
-            <a:pPr algn="l"/>
-            <a:r>
-              <a:rPr sz="1300" b="1">
+              <a:t>☑️ Checkboxes  →  Principios WCAG, Conceptos múltiples</a:t>
+            </a:r>
+          </a:p>
+          <a:p>
+            <a:pPr algn="l"/>
+            <a:r>
+              <a:rPr sz="1300" b="0">
                 <a:solidFill>
                   <a:srgbClr val="FFFFFF"/>
                 </a:solidFill>
                 <a:latin typeface="Calibri"/>
               </a:rPr>
-              <a:t>### Impacto                  |   ### Severidad  +  ### Solución propuesta</a:t>
-            </a:r>
-          </a:p>
-          <a:p>
-            <a:pPr algn="l"/>
-            <a:r>
-              <a:rPr sz="1300" b="0">
-                <a:solidFill>
-                  <a:srgbClr val="FFFFFF"/>
-                </a:solidFill>
-                <a:latin typeface="Calibri"/>
-              </a:rPr>
-              <a:t>¿A quién afecta?             Baja/Media/Alta + justificación   Describir en texto (no aplicar)</a:t>
-            </a:r>
-          </a:p>
-        </p:txBody>
-      </p:sp>
-      <p:sp>
-        <p:nvSpPr>
-          <p:cNvPr id="10" name="Rounded Rectangle 9"/>
-          <p:cNvSpPr/>
-          <p:nvPr/>
-        </p:nvSpPr>
-        <p:spPr>
-          <a:xfrm>
-            <a:off x="640080" y="5943600"/>
-            <a:ext cx="10972800" cy="457200"/>
-          </a:xfrm>
-          <a:prstGeom prst="roundRect">
-            <a:avLst/>
-          </a:prstGeom>
-          <a:solidFill>
-            <a:srgbClr val="FFF3CD"/>
-          </a:solidFill>
-          <a:ln>
-            <a:solidFill>
-              <a:srgbClr val="E6A23E"/>
-            </a:solidFill>
-          </a:ln>
-        </p:spPr>
-        <p:style>
-          <a:lnRef idx="1">
-            <a:schemeClr val="accent1"/>
-          </a:lnRef>
-          <a:fillRef idx="3">
-            <a:schemeClr val="accent1"/>
-          </a:fillRef>
-          <a:effectRef idx="2">
-            <a:schemeClr val="accent1"/>
-          </a:effectRef>
-          <a:fontRef idx="minor">
-            <a:schemeClr val="lt1"/>
-          </a:fontRef>
-        </p:style>
-        <p:txBody>
-          <a:bodyPr rtlCol="0" anchor="ctr"/>
-          <a:lstStyle/>
-          <a:p>
-            <a:pPr algn="ctr"/>
-          </a:p>
-        </p:txBody>
-      </p:sp>
-      <p:sp>
-        <p:nvSpPr>
-          <p:cNvPr id="11" name="TextBox 10"/>
+              <a:t>⚠️ Validación required  →  No se envía si está vacío</a:t>
+            </a:r>
+          </a:p>
+        </p:txBody>
+      </p:sp>
+      <p:sp>
+        <p:nvSpPr>
+          <p:cNvPr id="12" name="TextBox 11"/>
           <p:cNvSpPr txBox="1"/>
           <p:nvPr/>
         </p:nvSpPr>
         <p:spPr>
           <a:xfrm>
-            <a:off x="640080" y="5989320"/>
-            <a:ext cx="10972800" cy="365760"/>
+            <a:off x="457200" y="6446520"/>
+            <a:ext cx="7315200" cy="274320"/>
           </a:xfrm>
           <a:prstGeom prst="rect">
             <a:avLst/>
@@ -9670,41 +9891,6 @@
           </a:bodyPr>
           <a:lstStyle/>
           <a:p>
-            <a:pPr algn="ctr"/>
-            <a:r>
-              <a:rPr sz="1300" b="1">
-                <a:solidFill>
-                  <a:srgbClr val="924E0E"/>
-                </a:solidFill>
-                <a:latin typeface="Calibri"/>
-              </a:rPr>
-              <a:t>💡 La clasificación se evalúa por la explicación, no por la etiqueta exacta.</a:t>
-            </a:r>
-          </a:p>
-        </p:txBody>
-      </p:sp>
-      <p:sp>
-        <p:nvSpPr>
-          <p:cNvPr id="12" name="TextBox 11"/>
-          <p:cNvSpPr txBox="1"/>
-          <p:nvPr/>
-        </p:nvSpPr>
-        <p:spPr>
-          <a:xfrm>
-            <a:off x="457200" y="6446520"/>
-            <a:ext cx="6400800" cy="274320"/>
-          </a:xfrm>
-          <a:prstGeom prst="rect">
-            <a:avLst/>
-          </a:prstGeom>
-          <a:noFill/>
-        </p:spPr>
-        <p:txBody>
-          <a:bodyPr wrap="square">
-            <a:spAutoFit/>
-          </a:bodyPr>
-          <a:lstStyle/>
-          <a:p>
             <a:pPr algn="l"/>
             <a:r>
               <a:rPr sz="800" b="0">
@@ -9713,7 +9899,7 @@
                 </a:solidFill>
                 <a:latin typeface="Calibri"/>
               </a:rPr>
-              <a:t>📦 Repositorio: github.com/KrizRoMe/evaluacion-administracion-web   •   🌐 Sitio: krizrome.github.io/evaluacion-administracion-web</a:t>
+              <a:t>📦 Repo: github.com/KrizRoMe/evaluacion-administracion-web   •   🌐 Web: krizrome.github.io/evaluacion-administracion-web   •   📋 Issues: github.com/KrizRoMe/evaluacion-administracion-web/issues</a:t>
             </a:r>
           </a:p>
         </p:txBody>
@@ -9887,7 +10073,7 @@
                 </a:solidFill>
                 <a:latin typeface="Calibri"/>
               </a:rPr>
-              <a:t>Parte 5 · Documentar la solución</a:t>
+              <a:t>Parte 5 · Documentar solución + README</a:t>
             </a:r>
           </a:p>
         </p:txBody>
@@ -9922,7 +10108,7 @@
                 </a:solidFill>
                 <a:latin typeface="Calibri"/>
               </a:rPr>
-              <a:t>⏱ 10 minutos</a:t>
+              <a:t>⏱ 25 minutos  •  Sin tocar el código</a:t>
             </a:r>
           </a:p>
         </p:txBody>
@@ -9936,7 +10122,7 @@
         <p:spPr>
           <a:xfrm>
             <a:off x="640080" y="1280160"/>
-            <a:ext cx="10972800" cy="822960"/>
+            <a:ext cx="10972800" cy="640080"/>
           </a:xfrm>
           <a:prstGeom prst="roundRect">
             <a:avLst/>
@@ -9980,8 +10166,8 @@
         </p:nvSpPr>
         <p:spPr>
           <a:xfrm>
-            <a:off x="822960" y="1417320"/>
-            <a:ext cx="10607040" cy="548640"/>
+            <a:off x="822960" y="1371600"/>
+            <a:ext cx="10607040" cy="457200"/>
           </a:xfrm>
           <a:prstGeom prst="rect">
             <a:avLst/>
@@ -9994,16 +10180,15 @@
           </a:bodyPr>
           <a:lstStyle/>
           <a:p>
-            <a:pPr algn="l"/>
-            <a:r>
-              <a:rPr sz="1600" b="1">
+            <a:pPr algn="ctr"/>
+            <a:r>
+              <a:rPr sz="1400" b="1">
                 <a:solidFill>
                   <a:srgbClr val="924E0E"/>
                 </a:solidFill>
                 <a:latin typeface="Calibri"/>
               </a:rPr>
-              <a:t>⚠️  No es necesario aplicar las correcciones en el código.
-Lo que se evalúa es tu capacidad de ANALIZAR y PROPONER en texto.</a:t>
+              <a:t>⚠️  No es necesario aplicar las correcciones en el código. Solo ANALIZAR y PROPONER en texto.</a:t>
             </a:r>
           </a:p>
         </p:txBody>
@@ -10016,8 +10201,8 @@
         </p:nvSpPr>
         <p:spPr>
           <a:xfrm>
-            <a:off x="640080" y="2468880"/>
-            <a:ext cx="10972800" cy="457200"/>
+            <a:off x="640080" y="2103120"/>
+            <a:ext cx="10972800" cy="365760"/>
           </a:xfrm>
           <a:prstGeom prst="rect">
             <a:avLst/>
@@ -10032,13 +10217,13 @@
           <a:p>
             <a:pPr algn="l"/>
             <a:r>
-              <a:rPr sz="1800" b="1">
+              <a:rPr sz="1600" b="1">
                 <a:solidFill>
                   <a:srgbClr val="065A82"/>
                 </a:solidFill>
                 <a:latin typeface="Calibri"/>
               </a:rPr>
-              <a:t>Ejemplos de soluciones propuestas (en texto, no aplicar):</a:t>
+              <a:t>En cada Issue, completa la sección Solución propuesta:</a:t>
             </a:r>
           </a:p>
         </p:txBody>
@@ -10051,8 +10236,8 @@
         </p:nvSpPr>
         <p:spPr>
           <a:xfrm>
-            <a:off x="822960" y="3017520"/>
-            <a:ext cx="10972800" cy="2926080"/>
+            <a:off x="822960" y="2560320"/>
+            <a:ext cx="10972800" cy="1828800"/>
           </a:xfrm>
           <a:prstGeom prst="rect">
             <a:avLst/>
@@ -10067,7 +10252,7 @@
           <a:p>
             <a:pPr algn="l"/>
             <a:r>
-              <a:rPr sz="1400" b="0">
+              <a:rPr sz="1300" b="0">
                 <a:solidFill>
                   <a:srgbClr val="2A2A2A"/>
                 </a:solidFill>
@@ -10079,7 +10264,7 @@
           <a:p>
             <a:pPr algn="l"/>
             <a:r>
-              <a:rPr sz="1400" b="0">
+              <a:rPr sz="1300" b="0">
                 <a:solidFill>
                   <a:srgbClr val="2A2A2A"/>
                 </a:solidFill>
@@ -10091,7 +10276,7 @@
           <a:p>
             <a:pPr algn="l"/>
             <a:r>
-              <a:rPr sz="1400" b="0">
+              <a:rPr sz="1300" b="0">
                 <a:solidFill>
                   <a:srgbClr val="2A2A2A"/>
                 </a:solidFill>
@@ -10103,7 +10288,7 @@
           <a:p>
             <a:pPr algn="l"/>
             <a:r>
-              <a:rPr sz="1400" b="0">
+              <a:rPr sz="1300" b="0">
                 <a:solidFill>
                   <a:srgbClr val="2A2A2A"/>
                 </a:solidFill>
@@ -10115,7 +10300,7 @@
           <a:p>
             <a:pPr algn="l"/>
             <a:r>
-              <a:rPr sz="1400" b="0">
+              <a:rPr sz="1300" b="0">
                 <a:solidFill>
                   <a:srgbClr val="2A2A2A"/>
                 </a:solidFill>
@@ -10128,14 +10313,59 @@
       </p:sp>
       <p:sp>
         <p:nvSpPr>
-          <p:cNvPr id="10" name="TextBox 9"/>
+          <p:cNvPr id="10" name="Rounded Rectangle 9"/>
+          <p:cNvSpPr/>
+          <p:nvPr/>
+        </p:nvSpPr>
+        <p:spPr>
+          <a:xfrm>
+            <a:off x="640080" y="4572000"/>
+            <a:ext cx="10972800" cy="1737360"/>
+          </a:xfrm>
+          <a:prstGeom prst="roundRect">
+            <a:avLst/>
+          </a:prstGeom>
+          <a:solidFill>
+            <a:srgbClr val="E3F2FD"/>
+          </a:solidFill>
+          <a:ln>
+            <a:solidFill>
+              <a:srgbClr val="1C7293"/>
+            </a:solidFill>
+          </a:ln>
+        </p:spPr>
+        <p:style>
+          <a:lnRef idx="1">
+            <a:schemeClr val="accent1"/>
+          </a:lnRef>
+          <a:fillRef idx="3">
+            <a:schemeClr val="accent1"/>
+          </a:fillRef>
+          <a:effectRef idx="2">
+            <a:schemeClr val="accent1"/>
+          </a:effectRef>
+          <a:fontRef idx="minor">
+            <a:schemeClr val="lt1"/>
+          </a:fontRef>
+        </p:style>
+        <p:txBody>
+          <a:bodyPr rtlCol="0" anchor="ctr"/>
+          <a:lstStyle/>
+          <a:p>
+            <a:pPr algn="ctr"/>
+          </a:p>
+        </p:txBody>
+      </p:sp>
+      <p:sp>
+        <p:nvSpPr>
+          <p:cNvPr id="11" name="TextBox 10"/>
           <p:cNvSpPr txBox="1"/>
           <p:nvPr/>
         </p:nvSpPr>
         <p:spPr>
           <a:xfrm>
-            <a:off x="457200" y="6446520"/>
-            <a:ext cx="6400800" cy="274320"/>
+            <a:off x="822960" y="4617720"/>
+            <a:ext cx="10607040" cy="274320"/>
           </a:xfrm>
           <a:prstGeom prst="rect">
             <a:avLst/>
@@ -10150,20 +10380,90 @@
           <a:p>
             <a:pPr algn="l"/>
             <a:r>
+              <a:rPr sz="1400" b="1">
+                <a:solidFill>
+                  <a:srgbClr val="065A82"/>
+                </a:solidFill>
+                <a:latin typeface="Calibri"/>
+              </a:rPr>
+              <a:t>📚 README debe incluir:</a:t>
+            </a:r>
+          </a:p>
+        </p:txBody>
+      </p:sp>
+      <p:sp>
+        <p:nvSpPr>
+          <p:cNvPr id="12" name="TextBox 11"/>
+          <p:cNvSpPr txBox="1"/>
+          <p:nvPr/>
+        </p:nvSpPr>
+        <p:spPr>
+          <a:xfrm>
+            <a:off x="914400" y="4937760"/>
+            <a:ext cx="10424160" cy="1371600"/>
+          </a:xfrm>
+          <a:prstGeom prst="rect">
+            <a:avLst/>
+          </a:prstGeom>
+          <a:noFill/>
+        </p:spPr>
+        <p:txBody>
+          <a:bodyPr wrap="square">
+            <a:spAutoFit/>
+          </a:bodyPr>
+          <a:lstStyle/>
+          <a:p>
+            <a:pPr algn="l"/>
+            <a:r>
+              <a:rPr sz="1200" b="0">
+                <a:solidFill>
+                  <a:srgbClr val="2A2A2A"/>
+                </a:solidFill>
+                <a:latin typeface="Calibri"/>
+              </a:rPr>
+              <a:t>VIVO • RÁPIDO (con LCP/INP/CLS/TTFB) • SEGURO (2 acciones) • Backup 3-2-1 • SLI • SLO • SLA • Runbook (4–6 pasos) • Datos del estudiante + URLs</a:t>
+            </a:r>
+          </a:p>
+        </p:txBody>
+      </p:sp>
+      <p:sp>
+        <p:nvSpPr>
+          <p:cNvPr id="13" name="TextBox 12"/>
+          <p:cNvSpPr txBox="1"/>
+          <p:nvPr/>
+        </p:nvSpPr>
+        <p:spPr>
+          <a:xfrm>
+            <a:off x="457200" y="6446520"/>
+            <a:ext cx="7315200" cy="274320"/>
+          </a:xfrm>
+          <a:prstGeom prst="rect">
+            <a:avLst/>
+          </a:prstGeom>
+          <a:noFill/>
+        </p:spPr>
+        <p:txBody>
+          <a:bodyPr wrap="square">
+            <a:spAutoFit/>
+          </a:bodyPr>
+          <a:lstStyle/>
+          <a:p>
+            <a:pPr algn="l"/>
+            <a:r>
               <a:rPr sz="800" b="0">
                 <a:solidFill>
                   <a:srgbClr val="666666"/>
                 </a:solidFill>
                 <a:latin typeface="Calibri"/>
               </a:rPr>
-              <a:t>📦 Repositorio: github.com/KrizRoMe/evaluacion-administracion-web   •   🌐 Sitio: krizrome.github.io/evaluacion-administracion-web</a:t>
-            </a:r>
-          </a:p>
-        </p:txBody>
-      </p:sp>
-      <p:sp>
-        <p:nvSpPr>
-          <p:cNvPr id="11" name="TextBox 10"/>
+              <a:t>📦 Repo: github.com/KrizRoMe/evaluacion-administracion-web   •   🌐 Web: krizrome.github.io/evaluacion-administracion-web   •   📋 Issues: github.com/KrizRoMe/evaluacion-administracion-web/issues</a:t>
+            </a:r>
+          </a:p>
+        </p:txBody>
+      </p:sp>
+      <p:sp>
+        <p:nvSpPr>
+          <p:cNvPr id="14" name="TextBox 13"/>
           <p:cNvSpPr txBox="1"/>
           <p:nvPr/>
         </p:nvSpPr>

</xml_diff>

<commit_message>
feat: template ENTREGA + PPT con URLs del docente y link de entrega
</commit_message>
<xml_diff>
--- a/EVALUACION_PRACTICA_01.pptx
+++ b/EVALUACION_PRACTICA_01.pptx
@@ -3149,7 +3149,7 @@
         </p:nvSpPr>
         <p:spPr>
           <a:xfrm>
-            <a:off x="0" y="5029200"/>
+            <a:off x="0" y="4572000"/>
             <a:ext cx="12191695" cy="45720"/>
           </a:xfrm>
           <a:prstGeom prst="rect">
@@ -3192,7 +3192,7 @@
         </p:nvSpPr>
         <p:spPr>
           <a:xfrm>
-            <a:off x="914400" y="1280160"/>
+            <a:off x="914400" y="1097280"/>
             <a:ext cx="10058400" cy="1097280"/>
           </a:xfrm>
           <a:prstGeom prst="rect">
@@ -3227,7 +3227,7 @@
         </p:nvSpPr>
         <p:spPr>
           <a:xfrm>
-            <a:off x="914400" y="2377440"/>
+            <a:off x="914400" y="2194560"/>
             <a:ext cx="10058400" cy="640080"/>
           </a:xfrm>
           <a:prstGeom prst="rect">
@@ -3262,8 +3262,8 @@
         </p:nvSpPr>
         <p:spPr>
           <a:xfrm>
-            <a:off x="2743200" y="3474720"/>
-            <a:ext cx="6675120" cy="1097280"/>
+            <a:off x="2743200" y="3200400"/>
+            <a:ext cx="6675120" cy="914400"/>
           </a:xfrm>
           <a:prstGeom prst="rect">
             <a:avLst/>
@@ -3278,7 +3278,7 @@
           <a:p>
             <a:pPr algn="ctr"/>
             <a:r>
-              <a:rPr sz="1600" b="1">
+              <a:rPr sz="1500" b="1">
                 <a:solidFill>
                   <a:srgbClr val="FFFFFF"/>
                 </a:solidFill>
@@ -3290,25 +3290,13 @@
           <a:p>
             <a:pPr algn="ctr"/>
             <a:r>
-              <a:rPr sz="1600" b="0">
+              <a:rPr sz="1500" b="0">
                 <a:solidFill>
                   <a:srgbClr val="FFFFFF"/>
                 </a:solidFill>
                 <a:latin typeface="Calibri"/>
               </a:rPr>
-              <a:t>Unidad: 1  •  Duración: 90 minutos</a:t>
-            </a:r>
-          </a:p>
-          <a:p>
-            <a:pPr algn="ctr"/>
-            <a:r>
-              <a:rPr sz="1600" b="0">
-                <a:solidFill>
-                  <a:srgbClr val="FFFFFF"/>
-                </a:solidFill>
-                <a:latin typeface="Calibri"/>
-              </a:rPr>
-              <a:t>Escala: 1–20  •  Aprobado: 14/20</a:t>
+              <a:t>Unidad: 1  •  Duración: 90 minutos  •  Aprobado: 14/20</a:t>
             </a:r>
           </a:p>
         </p:txBody>
@@ -3321,8 +3309,8 @@
         </p:nvSpPr>
         <p:spPr>
           <a:xfrm>
-            <a:off x="2286000" y="5303520"/>
-            <a:ext cx="7589520" cy="548640"/>
+            <a:off x="914400" y="4846320"/>
+            <a:ext cx="10332720" cy="640080"/>
           </a:xfrm>
           <a:prstGeom prst="roundRect">
             <a:avLst/>
@@ -3366,8 +3354,8 @@
         </p:nvSpPr>
         <p:spPr>
           <a:xfrm>
-            <a:off x="2468880" y="5440680"/>
-            <a:ext cx="7223760" cy="457200"/>
+            <a:off x="1097280" y="4983480"/>
+            <a:ext cx="9966960" cy="457200"/>
           </a:xfrm>
           <a:prstGeom prst="rect">
             <a:avLst/>
@@ -3388,7 +3376,7 @@
                 </a:solidFill>
                 <a:latin typeface="Calibri"/>
               </a:rPr>
-              <a:t>📦 REPOSITORIO</a:t>
+              <a:t>📦 REPOSITORIO (sitio base a auditar)</a:t>
             </a:r>
           </a:p>
         </p:txBody>
@@ -3401,8 +3389,8 @@
         </p:nvSpPr>
         <p:spPr>
           <a:xfrm>
-            <a:off x="2468880" y="5897880"/>
-            <a:ext cx="7223760" cy="-91439"/>
+            <a:off x="1097280" y="5486400"/>
+            <a:ext cx="9966960" cy="-91440"/>
           </a:xfrm>
           <a:prstGeom prst="rect">
             <a:avLst/>
@@ -3436,8 +3424,8 @@
         </p:nvSpPr>
         <p:spPr>
           <a:xfrm>
-            <a:off x="2286000" y="5897880"/>
-            <a:ext cx="7589520" cy="548640"/>
+            <a:off x="914400" y="5532120"/>
+            <a:ext cx="10332720" cy="640080"/>
           </a:xfrm>
           <a:prstGeom prst="roundRect">
             <a:avLst/>
@@ -3481,8 +3469,8 @@
         </p:nvSpPr>
         <p:spPr>
           <a:xfrm>
-            <a:off x="2468880" y="6035040"/>
-            <a:ext cx="7223760" cy="457200"/>
+            <a:off x="1097280" y="5669280"/>
+            <a:ext cx="9966960" cy="457200"/>
           </a:xfrm>
           <a:prstGeom prst="rect">
             <a:avLst/>
@@ -3503,7 +3491,7 @@
                 </a:solidFill>
                 <a:latin typeface="Calibri"/>
               </a:rPr>
-              <a:t>🌐 SITIO WEB (GitHub Pages)</a:t>
+              <a:t>🌐 SITIO WEB PÚBLICO (GitHub Pages del sitio base)</a:t>
             </a:r>
           </a:p>
         </p:txBody>
@@ -3516,8 +3504,8 @@
         </p:nvSpPr>
         <p:spPr>
           <a:xfrm>
-            <a:off x="2468880" y="6492240"/>
-            <a:ext cx="7223760" cy="-91439"/>
+            <a:off x="1097280" y="6172200"/>
+            <a:ext cx="9966960" cy="-91440"/>
           </a:xfrm>
           <a:prstGeom prst="rect">
             <a:avLst/>
@@ -3619,7 +3607,7 @@
             <a:avLst/>
           </a:prstGeom>
           <a:solidFill>
-            <a:srgbClr val="065A82"/>
+            <a:srgbClr val="EA580C"/>
           </a:solidFill>
           <a:ln>
             <a:noFill/>
@@ -3677,7 +3665,7 @@
                 </a:solidFill>
                 <a:latin typeface="Calibri"/>
               </a:rPr>
-              <a:t>Parte 6 · Completar el README</a:t>
+              <a:t>📤 Parte 6 · Crear Issue de ENTREGA</a:t>
             </a:r>
           </a:p>
         </p:txBody>
@@ -3708,11 +3696,11 @@
             <a:r>
               <a:rPr sz="1400" b="0">
                 <a:solidFill>
-                  <a:srgbClr val="60A5FA"/>
-                </a:solidFill>
-                <a:latin typeface="Calibri"/>
-              </a:rPr>
-              <a:t>⏱ 15 minutos</a:t>
+                  <a:srgbClr val="FED3B6"/>
+                </a:solidFill>
+                <a:latin typeface="Calibri"/>
+              </a:rPr>
+              <a:t>⏱ 5 minutos  •  Esta Issue se crea en el repo del DOCENTE</a:t>
             </a:r>
           </a:p>
         </p:txBody>
@@ -3725,8 +3713,8 @@
         </p:nvSpPr>
         <p:spPr>
           <a:xfrm>
-            <a:off x="640080" y="1280160"/>
-            <a:ext cx="10972800" cy="457200"/>
+            <a:off x="640080" y="1188720"/>
+            <a:ext cx="10972800" cy="1371600"/>
           </a:xfrm>
           <a:prstGeom prst="rect">
             <a:avLst/>
@@ -3741,27 +3729,132 @@
           <a:p>
             <a:pPr algn="l"/>
             <a:r>
-              <a:rPr sz="2200" b="1">
-                <a:solidFill>
-                  <a:srgbClr val="065A82"/>
-                </a:solidFill>
-                <a:latin typeface="Calibri"/>
-              </a:rPr>
-              <a:t>Secciones a completar:</a:t>
-            </a:r>
-          </a:p>
-        </p:txBody>
-      </p:sp>
-      <p:sp>
-        <p:nvSpPr>
-          <p:cNvPr id="7" name="TextBox 6"/>
+              <a:rPr sz="1400" b="1">
+                <a:solidFill>
+                  <a:srgbClr val="2A2A2A"/>
+                </a:solidFill>
+                <a:latin typeface="Calibri"/>
+              </a:rPr>
+              <a:t>Pasos:</a:t>
+            </a:r>
+          </a:p>
+          <a:p>
+            <a:pPr algn="l"/>
+            <a:r>
+              <a:rPr sz="1400" b="0">
+                <a:solidFill>
+                  <a:srgbClr val="2A2A2A"/>
+                </a:solidFill>
+                <a:latin typeface="Calibri"/>
+              </a:rPr>
+              <a:t>1. Abre el repo del curso en una pestaña nueva:</a:t>
+            </a:r>
+          </a:p>
+          <a:p>
+            <a:pPr algn="l"/>
+            <a:r>
+              <a:rPr sz="1400" b="0">
+                <a:solidFill>
+                  <a:srgbClr val="2A2A2A"/>
+                </a:solidFill>
+                <a:latin typeface="Calibri"/>
+              </a:rPr>
+              <a:t>2. Clic en Issues → New issue</a:t>
+            </a:r>
+          </a:p>
+          <a:p>
+            <a:pPr algn="l"/>
+            <a:r>
+              <a:rPr sz="1400" b="0">
+                <a:solidFill>
+                  <a:srgbClr val="2A2A2A"/>
+                </a:solidFill>
+                <a:latin typeface="Calibri"/>
+              </a:rPr>
+              <a:t>3. Selecciona el template 📤 Entrega de evaluación</a:t>
+            </a:r>
+          </a:p>
+          <a:p>
+            <a:pPr algn="l"/>
+            <a:r>
+              <a:rPr sz="1400" b="0">
+                <a:solidFill>
+                  <a:srgbClr val="2A2A2A"/>
+                </a:solidFill>
+                <a:latin typeface="Calibri"/>
+              </a:rPr>
+              <a:t>4. Completa el formulario: tu nombre, código, URL de tu repo, URL de tu GitHub Pages</a:t>
+            </a:r>
+          </a:p>
+          <a:p>
+            <a:pPr algn="l"/>
+            <a:r>
+              <a:rPr sz="1400" b="0">
+                <a:solidFill>
+                  <a:srgbClr val="2A2A2A"/>
+                </a:solidFill>
+                <a:latin typeface="Calibri"/>
+              </a:rPr>
+              <a:t>5. Clic en Submit (Crear)</a:t>
+            </a:r>
+          </a:p>
+        </p:txBody>
+      </p:sp>
+      <p:sp>
+        <p:nvSpPr>
+          <p:cNvPr id="7" name="Rounded Rectangle 6"/>
+          <p:cNvSpPr/>
+          <p:nvPr/>
+        </p:nvSpPr>
+        <p:spPr>
+          <a:xfrm>
+            <a:off x="640080" y="3657600"/>
+            <a:ext cx="10972800" cy="1280160"/>
+          </a:xfrm>
+          <a:prstGeom prst="roundRect">
+            <a:avLst/>
+          </a:prstGeom>
+          <a:solidFill>
+            <a:srgbClr val="FEF3E6"/>
+          </a:solidFill>
+          <a:ln w="38100">
+            <a:solidFill>
+              <a:srgbClr val="EA580C"/>
+            </a:solidFill>
+          </a:ln>
+        </p:spPr>
+        <p:style>
+          <a:lnRef idx="1">
+            <a:schemeClr val="accent1"/>
+          </a:lnRef>
+          <a:fillRef idx="3">
+            <a:schemeClr val="accent1"/>
+          </a:fillRef>
+          <a:effectRef idx="2">
+            <a:schemeClr val="accent1"/>
+          </a:effectRef>
+          <a:fontRef idx="minor">
+            <a:schemeClr val="lt1"/>
+          </a:fontRef>
+        </p:style>
+        <p:txBody>
+          <a:bodyPr rtlCol="0" anchor="ctr"/>
+          <a:lstStyle/>
+          <a:p>
+            <a:pPr algn="ctr"/>
+          </a:p>
+        </p:txBody>
+      </p:sp>
+      <p:sp>
+        <p:nvSpPr>
+          <p:cNvPr id="8" name="TextBox 7"/>
           <p:cNvSpPr txBox="1"/>
           <p:nvPr/>
         </p:nvSpPr>
         <p:spPr>
           <a:xfrm>
-            <a:off x="822960" y="1828800"/>
-            <a:ext cx="5486400" cy="3657600"/>
+            <a:off x="822960" y="3749039"/>
+            <a:ext cx="10607040" cy="365760"/>
           </a:xfrm>
           <a:prstGeom prst="rect">
             <a:avLst/>
@@ -3774,77 +3867,29 @@
           </a:bodyPr>
           <a:lstStyle/>
           <a:p>
-            <a:pPr algn="l"/>
-            <a:r>
-              <a:rPr sz="1600" b="0">
-                <a:solidFill>
-                  <a:srgbClr val="2A2A2A"/>
-                </a:solidFill>
-                <a:latin typeface="Calibri"/>
-              </a:rPr>
-              <a:t>• VIVO — qué significa, qué métrica</a:t>
-            </a:r>
-          </a:p>
-          <a:p>
-            <a:pPr algn="l"/>
-            <a:r>
-              <a:rPr sz="1600" b="0">
-                <a:solidFill>
-                  <a:srgbClr val="2A2A2A"/>
-                </a:solidFill>
-                <a:latin typeface="Calibri"/>
-              </a:rPr>
-              <a:t>• RÁPIDO — mencionar LCP, INP, CLS o TTFB</a:t>
-            </a:r>
-          </a:p>
-          <a:p>
-            <a:pPr algn="l"/>
-            <a:r>
-              <a:rPr sz="1600" b="0">
-                <a:solidFill>
-                  <a:srgbClr val="2A2A2A"/>
-                </a:solidFill>
-                <a:latin typeface="Calibri"/>
-              </a:rPr>
-              <a:t>• SEGURO — mencionar 2 acciones</a:t>
-            </a:r>
-          </a:p>
-          <a:p>
-            <a:pPr algn="l"/>
-            <a:r>
-              <a:rPr sz="1600" b="0">
-                <a:solidFill>
-                  <a:srgbClr val="2A2A2A"/>
-                </a:solidFill>
-                <a:latin typeface="Calibri"/>
-              </a:rPr>
-              <a:t>• Backup 3-2-1 — explicar</a:t>
-            </a:r>
-          </a:p>
-          <a:p>
-            <a:pPr algn="l"/>
-            <a:r>
-              <a:rPr sz="1600" b="0">
-                <a:solidFill>
-                  <a:srgbClr val="2A2A2A"/>
-                </a:solidFill>
-                <a:latin typeface="Calibri"/>
-              </a:rPr>
-              <a:t>• SLI — proponer un indicador</a:t>
-            </a:r>
-          </a:p>
-        </p:txBody>
-      </p:sp>
-      <p:sp>
-        <p:nvSpPr>
-          <p:cNvPr id="8" name="TextBox 7"/>
+            <a:pPr algn="ctr"/>
+            <a:r>
+              <a:rPr sz="1400" b="1">
+                <a:solidFill>
+                  <a:srgbClr val="EA580C"/>
+                </a:solidFill>
+                <a:latin typeface="Calibri"/>
+              </a:rPr>
+              <a:t>🔗 LINK DIRECTO PARA CREAR EL ISSUE DE ENTREGA:</a:t>
+            </a:r>
+          </a:p>
+        </p:txBody>
+      </p:sp>
+      <p:sp>
+        <p:nvSpPr>
+          <p:cNvPr id="9" name="TextBox 8"/>
           <p:cNvSpPr txBox="1"/>
           <p:nvPr/>
         </p:nvSpPr>
         <p:spPr>
           <a:xfrm>
-            <a:off x="6583680" y="1828800"/>
-            <a:ext cx="5486400" cy="3657600"/>
+            <a:off x="822960" y="4160520"/>
+            <a:ext cx="10607040" cy="457200"/>
           </a:xfrm>
           <a:prstGeom prst="rect">
             <a:avLst/>
@@ -3857,77 +3902,64 @@
           </a:bodyPr>
           <a:lstStyle/>
           <a:p>
-            <a:pPr algn="l"/>
-            <a:r>
-              <a:rPr sz="1600" b="0">
+            <a:pPr algn="ctr"/>
+            <a:r>
+              <a:rPr sz="1400" b="1">
                 <a:solidFill>
                   <a:srgbClr val="2A2A2A"/>
                 </a:solidFill>
-                <a:latin typeface="Calibri"/>
-              </a:rPr>
-              <a:t>• SLO — proponer un objetivo</a:t>
-            </a:r>
-          </a:p>
-          <a:p>
-            <a:pPr algn="l"/>
-            <a:r>
-              <a:rPr sz="1600" b="0">
-                <a:solidFill>
-                  <a:srgbClr val="2A2A2A"/>
-                </a:solidFill>
-                <a:latin typeface="Calibri"/>
-              </a:rPr>
-              <a:t>• SLA — explicar qué es</a:t>
-            </a:r>
-          </a:p>
-          <a:p>
-            <a:pPr algn="l"/>
-            <a:r>
-              <a:rPr sz="1600" b="0">
-                <a:solidFill>
-                  <a:srgbClr val="2A2A2A"/>
-                </a:solidFill>
-                <a:latin typeface="Calibri"/>
-              </a:rPr>
-              <a:t>• Runbook — 4 a 6 pasos para sitio caído</a:t>
-            </a:r>
-          </a:p>
-          <a:p>
-            <a:pPr algn="l"/>
-            <a:r>
-              <a:rPr sz="1600" b="0">
-                <a:solidFill>
-                  <a:srgbClr val="2A2A2A"/>
-                </a:solidFill>
-                <a:latin typeface="Calibri"/>
-              </a:rPr>
-              <a:t>• Datos del estudiante + URLs</a:t>
-            </a:r>
-          </a:p>
-          <a:p>
-            <a:pPr algn="l"/>
-            <a:r>
-              <a:rPr sz="1600" b="0">
-                <a:solidFill>
-                  <a:srgbClr val="2A2A2A"/>
-                </a:solidFill>
-                <a:latin typeface="Calibri"/>
-              </a:rPr>
-              <a:t/>
-            </a:r>
-          </a:p>
-        </p:txBody>
-      </p:sp>
-      <p:sp>
-        <p:nvSpPr>
-          <p:cNvPr id="9" name="Rounded Rectangle 8"/>
+                <a:latin typeface="Consolas"/>
+              </a:rPr>
+              <a:t>https://github.com/KrizRoMe/evaluacion-administracion-web/issues/new?template=entrega.yml</a:t>
+            </a:r>
+          </a:p>
+        </p:txBody>
+      </p:sp>
+      <p:sp>
+        <p:nvSpPr>
+          <p:cNvPr id="10" name="TextBox 9"/>
+          <p:cNvSpPr txBox="1"/>
+          <p:nvPr/>
+        </p:nvSpPr>
+        <p:spPr>
+          <a:xfrm>
+            <a:off x="822960" y="4572000"/>
+            <a:ext cx="10607040" cy="274320"/>
+          </a:xfrm>
+          <a:prstGeom prst="rect">
+            <a:avLst/>
+          </a:prstGeom>
+          <a:noFill/>
+        </p:spPr>
+        <p:txBody>
+          <a:bodyPr wrap="square">
+            <a:spAutoFit/>
+          </a:bodyPr>
+          <a:lstStyle/>
+          <a:p>
+            <a:pPr algn="ctr"/>
+            <a:r>
+              <a:rPr sz="1000" b="0">
+                <a:solidFill>
+                  <a:srgbClr val="999999"/>
+                </a:solidFill>
+                <a:latin typeface="Calibri"/>
+              </a:rPr>
+              <a:t>(también lo encuentras en la pestaña Issues del repo del docente)</a:t>
+            </a:r>
+          </a:p>
+        </p:txBody>
+      </p:sp>
+      <p:sp>
+        <p:nvSpPr>
+          <p:cNvPr id="11" name="Rounded Rectangle 10"/>
           <p:cNvSpPr/>
           <p:nvPr/>
         </p:nvSpPr>
         <p:spPr>
           <a:xfrm>
-            <a:off x="640080" y="5760720"/>
-            <a:ext cx="10972800" cy="457200"/>
+            <a:off x="640080" y="5120640"/>
+            <a:ext cx="10972800" cy="1188720"/>
           </a:xfrm>
           <a:prstGeom prst="roundRect">
             <a:avLst/>
@@ -3965,14 +3997,14 @@
       </p:sp>
       <p:sp>
         <p:nvSpPr>
-          <p:cNvPr id="10" name="TextBox 9"/>
+          <p:cNvPr id="12" name="TextBox 11"/>
           <p:cNvSpPr txBox="1"/>
           <p:nvPr/>
         </p:nvSpPr>
         <p:spPr>
           <a:xfrm>
-            <a:off x="640080" y="5806440"/>
-            <a:ext cx="10972800" cy="365760"/>
+            <a:off x="822960" y="5166360"/>
+            <a:ext cx="10607040" cy="274320"/>
           </a:xfrm>
           <a:prstGeom prst="rect">
             <a:avLst/>
@@ -3985,29 +4017,29 @@
           </a:bodyPr>
           <a:lstStyle/>
           <a:p>
-            <a:pPr algn="ctr"/>
-            <a:r>
-              <a:rPr sz="1400" b="1">
+            <a:pPr algn="l"/>
+            <a:r>
+              <a:rPr sz="1300" b="1">
                 <a:solidFill>
                   <a:srgbClr val="065A82"/>
                 </a:solidFill>
                 <a:latin typeface="Calibri"/>
               </a:rPr>
-              <a:t>💡 No necesitas respuestas perfectas. Explica con tus propias palabras.</a:t>
-            </a:r>
-          </a:p>
-        </p:txBody>
-      </p:sp>
-      <p:sp>
-        <p:nvSpPr>
-          <p:cNvPr id="11" name="TextBox 10"/>
+              <a:t>La Issue de entrega te pide:</a:t>
+            </a:r>
+          </a:p>
+        </p:txBody>
+      </p:sp>
+      <p:sp>
+        <p:nvSpPr>
+          <p:cNvPr id="13" name="TextBox 12"/>
           <p:cNvSpPr txBox="1"/>
           <p:nvPr/>
         </p:nvSpPr>
         <p:spPr>
           <a:xfrm>
-            <a:off x="457200" y="6446520"/>
-            <a:ext cx="6400800" cy="274320"/>
+            <a:off x="1005840" y="5486400"/>
+            <a:ext cx="10424160" cy="822960"/>
           </a:xfrm>
           <a:prstGeom prst="rect">
             <a:avLst/>
@@ -4022,20 +4054,55 @@
           <a:p>
             <a:pPr algn="l"/>
             <a:r>
+              <a:rPr sz="1200" b="0">
+                <a:solidFill>
+                  <a:srgbClr val="2A2A2A"/>
+                </a:solidFill>
+                <a:latin typeface="Calibri"/>
+              </a:rPr>
+              <a:t>• Nombre completo • Código • URL de TU repositorio  •  URL de TU GitHub Pages  •  Checklist de auto-verificación</a:t>
+            </a:r>
+          </a:p>
+        </p:txBody>
+      </p:sp>
+      <p:sp>
+        <p:nvSpPr>
+          <p:cNvPr id="14" name="TextBox 13"/>
+          <p:cNvSpPr txBox="1"/>
+          <p:nvPr/>
+        </p:nvSpPr>
+        <p:spPr>
+          <a:xfrm>
+            <a:off x="457200" y="6446520"/>
+            <a:ext cx="7315200" cy="274320"/>
+          </a:xfrm>
+          <a:prstGeom prst="rect">
+            <a:avLst/>
+          </a:prstGeom>
+          <a:noFill/>
+        </p:spPr>
+        <p:txBody>
+          <a:bodyPr wrap="square">
+            <a:spAutoFit/>
+          </a:bodyPr>
+          <a:lstStyle/>
+          <a:p>
+            <a:pPr algn="l"/>
+            <a:r>
               <a:rPr sz="800" b="0">
                 <a:solidFill>
                   <a:srgbClr val="666666"/>
                 </a:solidFill>
                 <a:latin typeface="Calibri"/>
               </a:rPr>
-              <a:t>📦 Repositorio: github.com/KrizRoMe/evaluacion-administracion-web   •   🌐 Sitio: krizrome.github.io/evaluacion-administracion-web</a:t>
-            </a:r>
-          </a:p>
-        </p:txBody>
-      </p:sp>
-      <p:sp>
-        <p:nvSpPr>
-          <p:cNvPr id="12" name="TextBox 11"/>
+              <a:t>📦 Repo: github.com/KrizRoMe/evaluacion-administracion-web   •   🌐 Web: krizrome.github.io/evaluacion-administracion-web   •   📋 Issues: github.com/KrizRoMe/evaluacion-administracion-web/issues</a:t>
+            </a:r>
+          </a:p>
+        </p:txBody>
+      </p:sp>
+      <p:sp>
+        <p:nvSpPr>
+          <p:cNvPr id="15" name="TextBox 14"/>
           <p:cNvSpPr txBox="1"/>
           <p:nvPr/>
         </p:nvSpPr>
@@ -4202,7 +4269,7 @@
                 </a:solidFill>
                 <a:latin typeface="Calibri"/>
               </a:rPr>
-              <a:t>✅ Checklist final y entrega</a:t>
+              <a:t>✅ Checklist final completo</a:t>
             </a:r>
           </a:p>
         </p:txBody>
@@ -4237,7 +4304,7 @@
                 </a:solidFill>
                 <a:latin typeface="Calibri"/>
               </a:rPr>
-              <a:t>⏱ 5 minutos de verificación</a:t>
+              <a:t>Antes de entregar, verifica TODO</a:t>
             </a:r>
           </a:p>
         </p:txBody>
@@ -4250,8 +4317,8 @@
         </p:nvSpPr>
         <p:spPr>
           <a:xfrm>
-            <a:off x="822960" y="1280160"/>
-            <a:ext cx="5486400" cy="3657600"/>
+            <a:off x="640080" y="1188720"/>
+            <a:ext cx="5486400" cy="365760"/>
           </a:xfrm>
           <a:prstGeom prst="rect">
             <a:avLst/>
@@ -4266,49 +4333,13 @@
           <a:p>
             <a:pPr algn="l"/>
             <a:r>
-              <a:rPr sz="1800" b="0">
-                <a:solidFill>
-                  <a:srgbClr val="2A2A2A"/>
-                </a:solidFill>
-                <a:latin typeface="Calibri"/>
-              </a:rPr>
-              <a:t>☐ Repositorio público</a:t>
-            </a:r>
-          </a:p>
-          <a:p>
-            <a:pPr algn="l"/>
-            <a:r>
-              <a:rPr sz="1800" b="0">
-                <a:solidFill>
-                  <a:srgbClr val="2A2A2A"/>
-                </a:solidFill>
-                <a:latin typeface="Calibri"/>
-              </a:rPr>
-              <a:t>☐ GitHub Pages funciona</a:t>
-            </a:r>
-          </a:p>
-          <a:p>
-            <a:pPr algn="l"/>
-            <a:r>
-              <a:rPr sz="1800" b="0">
-                <a:solidFill>
-                  <a:srgbClr val="2A2A2A"/>
-                </a:solidFill>
-                <a:latin typeface="Calibri"/>
-              </a:rPr>
-              <a:t>☐ Tengo exactamente 3 Issues</a:t>
-            </a:r>
-          </a:p>
-          <a:p>
-            <a:pPr algn="l"/>
-            <a:r>
-              <a:rPr sz="1800" b="0">
-                <a:solidFill>
-                  <a:srgbClr val="2A2A2A"/>
-                </a:solidFill>
-                <a:latin typeface="Calibri"/>
-              </a:rPr>
-              <a:t>☐ Cada Issue usa un template</a:t>
+              <a:rPr sz="1800" b="1">
+                <a:solidFill>
+                  <a:srgbClr val="065A82"/>
+                </a:solidFill>
+                <a:latin typeface="Calibri"/>
+              </a:rPr>
+              <a:t>📦 En TU repositorio:</a:t>
             </a:r>
           </a:p>
         </p:txBody>
@@ -4321,8 +4352,8 @@
         </p:nvSpPr>
         <p:spPr>
           <a:xfrm>
-            <a:off x="6583680" y="1280160"/>
-            <a:ext cx="5486400" cy="3657600"/>
+            <a:off x="822960" y="1645920"/>
+            <a:ext cx="5486400" cy="3200400"/>
           </a:xfrm>
           <a:prstGeom prst="rect">
             <a:avLst/>
@@ -4337,43 +4368,79 @@
           <a:p>
             <a:pPr algn="l"/>
             <a:r>
-              <a:rPr sz="1800" b="0">
+              <a:rPr sz="1400" b="0">
                 <a:solidFill>
                   <a:srgbClr val="2A2A2A"/>
                 </a:solidFill>
                 <a:latin typeface="Calibri"/>
               </a:rPr>
-              <a:t>☐ Cada Issue tiene todas las secciones</a:t>
-            </a:r>
-          </a:p>
-          <a:p>
-            <a:pPr algn="l"/>
-            <a:r>
-              <a:rPr sz="1800" b="0">
+              <a:t>☐ Repo público</a:t>
+            </a:r>
+          </a:p>
+          <a:p>
+            <a:pPr algn="l"/>
+            <a:r>
+              <a:rPr sz="1400" b="0">
                 <a:solidFill>
                   <a:srgbClr val="2A2A2A"/>
                 </a:solidFill>
                 <a:latin typeface="Calibri"/>
               </a:rPr>
-              <a:t>☐ Soluciones propuestas en texto</a:t>
-            </a:r>
-          </a:p>
-          <a:p>
-            <a:pPr algn="l"/>
-            <a:r>
-              <a:rPr sz="1800" b="0">
+              <a:t>☐ GitHub Pages funciona</a:t>
+            </a:r>
+          </a:p>
+          <a:p>
+            <a:pPr algn="l"/>
+            <a:r>
+              <a:rPr sz="1400" b="0">
                 <a:solidFill>
                   <a:srgbClr val="2A2A2A"/>
                 </a:solidFill>
                 <a:latin typeface="Calibri"/>
               </a:rPr>
+              <a:t>☐ EXACTAMENTE 3 Issues creadas</a:t>
+            </a:r>
+          </a:p>
+          <a:p>
+            <a:pPr algn="l"/>
+            <a:r>
+              <a:rPr sz="1400" b="0">
+                <a:solidFill>
+                  <a:srgbClr val="2A2A2A"/>
+                </a:solidFill>
+                <a:latin typeface="Calibri"/>
+              </a:rPr>
+              <a:t>☐ Cada Issue usa un template .yml</a:t>
+            </a:r>
+          </a:p>
+          <a:p>
+            <a:pPr algn="l"/>
+            <a:r>
+              <a:rPr sz="1400" b="0">
+                <a:solidFill>
+                  <a:srgbClr val="2A2A2A"/>
+                </a:solidFill>
+                <a:latin typeface="Calibri"/>
+              </a:rPr>
+              <a:t>☐ Cada Issue completa todas las secciones</a:t>
+            </a:r>
+          </a:p>
+          <a:p>
+            <a:pPr algn="l"/>
+            <a:r>
+              <a:rPr sz="1400" b="0">
+                <a:solidFill>
+                  <a:srgbClr val="2A2A2A"/>
+                </a:solidFill>
+                <a:latin typeface="Calibri"/>
+              </a:rPr>
               <a:t>☐ README completo</a:t>
             </a:r>
           </a:p>
           <a:p>
             <a:pPr algn="l"/>
             <a:r>
-              <a:rPr sz="1800" b="0">
+              <a:rPr sz="1400" b="0">
                 <a:solidFill>
                   <a:srgbClr val="2A2A2A"/>
                 </a:solidFill>
@@ -4386,20 +4453,162 @@
       </p:sp>
       <p:sp>
         <p:nvSpPr>
-          <p:cNvPr id="8" name="Rounded Rectangle 7"/>
+          <p:cNvPr id="8" name="TextBox 7"/>
+          <p:cNvSpPr txBox="1"/>
+          <p:nvPr/>
+        </p:nvSpPr>
+        <p:spPr>
+          <a:xfrm>
+            <a:off x="6217920" y="1188720"/>
+            <a:ext cx="5486400" cy="365760"/>
+          </a:xfrm>
+          <a:prstGeom prst="rect">
+            <a:avLst/>
+          </a:prstGeom>
+          <a:noFill/>
+        </p:spPr>
+        <p:txBody>
+          <a:bodyPr wrap="square">
+            <a:spAutoFit/>
+          </a:bodyPr>
+          <a:lstStyle/>
+          <a:p>
+            <a:pPr algn="l"/>
+            <a:r>
+              <a:rPr sz="1800" b="1">
+                <a:solidFill>
+                  <a:srgbClr val="EA580C"/>
+                </a:solidFill>
+                <a:latin typeface="Calibri"/>
+              </a:rPr>
+              <a:t>📤 En repo del DOCENTE (entrega):</a:t>
+            </a:r>
+          </a:p>
+        </p:txBody>
+      </p:sp>
+      <p:sp>
+        <p:nvSpPr>
+          <p:cNvPr id="9" name="TextBox 8"/>
+          <p:cNvSpPr txBox="1"/>
+          <p:nvPr/>
+        </p:nvSpPr>
+        <p:spPr>
+          <a:xfrm>
+            <a:off x="6400800" y="1645920"/>
+            <a:ext cx="5486400" cy="3200400"/>
+          </a:xfrm>
+          <a:prstGeom prst="rect">
+            <a:avLst/>
+          </a:prstGeom>
+          <a:noFill/>
+        </p:spPr>
+        <p:txBody>
+          <a:bodyPr wrap="square">
+            <a:spAutoFit/>
+          </a:bodyPr>
+          <a:lstStyle/>
+          <a:p>
+            <a:pPr algn="l"/>
+            <a:r>
+              <a:rPr sz="1400" b="0">
+                <a:solidFill>
+                  <a:srgbClr val="2A2A2A"/>
+                </a:solidFill>
+                <a:latin typeface="Calibri"/>
+              </a:rPr>
+              <a:t>☐ Abrí el link de entrega</a:t>
+            </a:r>
+          </a:p>
+          <a:p>
+            <a:pPr algn="l"/>
+            <a:r>
+              <a:rPr sz="1400" b="0">
+                <a:solidFill>
+                  <a:srgbClr val="2A2A2A"/>
+                </a:solidFill>
+                <a:latin typeface="Calibri"/>
+              </a:rPr>
+              <a:t>☐ Seleccioné el template 'Entrega'</a:t>
+            </a:r>
+          </a:p>
+          <a:p>
+            <a:pPr algn="l"/>
+            <a:r>
+              <a:rPr sz="1400" b="0">
+                <a:solidFill>
+                  <a:srgbClr val="2A2A2A"/>
+                </a:solidFill>
+                <a:latin typeface="Calibri"/>
+              </a:rPr>
+              <a:t>☐ Completé nombre, código</a:t>
+            </a:r>
+          </a:p>
+          <a:p>
+            <a:pPr algn="l"/>
+            <a:r>
+              <a:rPr sz="1400" b="0">
+                <a:solidFill>
+                  <a:srgbClr val="2A2A2A"/>
+                </a:solidFill>
+                <a:latin typeface="Calibri"/>
+              </a:rPr>
+              <a:t>☐ Pegué URL de mi repo</a:t>
+            </a:r>
+          </a:p>
+          <a:p>
+            <a:pPr algn="l"/>
+            <a:r>
+              <a:rPr sz="1400" b="0">
+                <a:solidFill>
+                  <a:srgbClr val="2A2A2A"/>
+                </a:solidFill>
+                <a:latin typeface="Calibri"/>
+              </a:rPr>
+              <a:t>☐ Pegué URL de mi GitHub Pages</a:t>
+            </a:r>
+          </a:p>
+          <a:p>
+            <a:pPr algn="l"/>
+            <a:r>
+              <a:rPr sz="1400" b="0">
+                <a:solidFill>
+                  <a:srgbClr val="2A2A2A"/>
+                </a:solidFill>
+                <a:latin typeface="Calibri"/>
+              </a:rPr>
+              <a:t>☐ Marqué el checklist</a:t>
+            </a:r>
+          </a:p>
+          <a:p>
+            <a:pPr algn="l"/>
+            <a:r>
+              <a:rPr sz="1400" b="0">
+                <a:solidFill>
+                  <a:srgbClr val="2A2A2A"/>
+                </a:solidFill>
+                <a:latin typeface="Calibri"/>
+              </a:rPr>
+              <a:t>☐ Envié la Issue</a:t>
+            </a:r>
+          </a:p>
+        </p:txBody>
+      </p:sp>
+      <p:sp>
+        <p:nvSpPr>
+          <p:cNvPr id="10" name="Rounded Rectangle 9"/>
           <p:cNvSpPr/>
           <p:nvPr/>
         </p:nvSpPr>
         <p:spPr>
           <a:xfrm>
-            <a:off x="640080" y="4114800"/>
-            <a:ext cx="10972800" cy="2103120"/>
+            <a:off x="640080" y="4937760"/>
+            <a:ext cx="10972800" cy="1371600"/>
           </a:xfrm>
           <a:prstGeom prst="roundRect">
             <a:avLst/>
           </a:prstGeom>
           <a:solidFill>
-            <a:srgbClr val="065A82"/>
+            <a:srgbClr val="EA580C"/>
           </a:solidFill>
           <a:ln>
             <a:noFill/>
@@ -4429,13 +4638,13 @@
       </p:sp>
       <p:sp>
         <p:nvSpPr>
-          <p:cNvPr id="9" name="TextBox 8"/>
+          <p:cNvPr id="11" name="TextBox 10"/>
           <p:cNvSpPr txBox="1"/>
           <p:nvPr/>
         </p:nvSpPr>
         <p:spPr>
           <a:xfrm>
-            <a:off x="822960" y="4206240"/>
+            <a:off x="822960" y="4983480"/>
             <a:ext cx="10607040" cy="365760"/>
           </a:xfrm>
           <a:prstGeom prst="rect">
@@ -4451,72 +4660,27 @@
           <a:p>
             <a:pPr algn="ctr"/>
             <a:r>
-              <a:rPr sz="2000" b="1">
-                <a:solidFill>
-                  <a:srgbClr val="60A5FA"/>
-                </a:solidFill>
-                <a:latin typeface="Calibri"/>
-              </a:rPr>
-              <a:t>📤 ENTREGAR AL DOCENTE</a:t>
-            </a:r>
-          </a:p>
-        </p:txBody>
-      </p:sp>
-      <p:sp>
-        <p:nvSpPr>
-          <p:cNvPr id="10" name="Rounded Rectangle 9"/>
-          <p:cNvSpPr/>
-          <p:nvPr/>
-        </p:nvSpPr>
-        <p:spPr>
-          <a:xfrm>
-            <a:off x="914400" y="4617720"/>
-            <a:ext cx="10424160" cy="731520"/>
-          </a:xfrm>
-          <a:prstGeom prst="roundRect">
-            <a:avLst/>
-          </a:prstGeom>
-          <a:solidFill>
-            <a:srgbClr val="0E4D70"/>
-          </a:solidFill>
-          <a:ln w="25400">
-            <a:solidFill>
-              <a:srgbClr val="FFFFFF"/>
-            </a:solidFill>
-          </a:ln>
-        </p:spPr>
-        <p:style>
-          <a:lnRef idx="1">
-            <a:schemeClr val="accent1"/>
-          </a:lnRef>
-          <a:fillRef idx="3">
-            <a:schemeClr val="accent1"/>
-          </a:fillRef>
-          <a:effectRef idx="2">
-            <a:schemeClr val="accent1"/>
-          </a:effectRef>
-          <a:fontRef idx="minor">
-            <a:schemeClr val="lt1"/>
-          </a:fontRef>
-        </p:style>
-        <p:txBody>
-          <a:bodyPr rtlCol="0" anchor="ctr"/>
-          <a:lstStyle/>
-          <a:p>
-            <a:pPr algn="ctr"/>
-          </a:p>
-        </p:txBody>
-      </p:sp>
-      <p:sp>
-        <p:nvSpPr>
-          <p:cNvPr id="11" name="TextBox 10"/>
+              <a:rPr sz="1400" b="1">
+                <a:solidFill>
+                  <a:srgbClr val="FFFFFF"/>
+                </a:solidFill>
+                <a:latin typeface="Calibri"/>
+              </a:rPr>
+              <a:t>🔗 ENTREGAR AL DOCENTE — Crear Issue de entrega aquí:</a:t>
+            </a:r>
+          </a:p>
+        </p:txBody>
+      </p:sp>
+      <p:sp>
+        <p:nvSpPr>
+          <p:cNvPr id="12" name="TextBox 11"/>
           <p:cNvSpPr txBox="1"/>
           <p:nvPr/>
         </p:nvSpPr>
         <p:spPr>
           <a:xfrm>
-            <a:off x="1097280" y="4754880"/>
-            <a:ext cx="10058400" cy="457200"/>
+            <a:off x="822960" y="5394960"/>
+            <a:ext cx="10607040" cy="548640"/>
           </a:xfrm>
           <a:prstGeom prst="rect">
             <a:avLst/>
@@ -4529,29 +4693,29 @@
           </a:bodyPr>
           <a:lstStyle/>
           <a:p>
-            <a:pPr algn="l"/>
-            <a:r>
-              <a:rPr sz="1600" b="1">
+            <a:pPr algn="ctr"/>
+            <a:r>
+              <a:rPr sz="1200" b="1">
                 <a:solidFill>
                   <a:srgbClr val="FFFFFF"/>
                 </a:solidFill>
-                <a:latin typeface="Calibri"/>
-              </a:rPr>
-              <a:t>📦 URL de TU repositorio</a:t>
-            </a:r>
-          </a:p>
-        </p:txBody>
-      </p:sp>
-      <p:sp>
-        <p:nvSpPr>
-          <p:cNvPr id="12" name="TextBox 11"/>
+                <a:latin typeface="Consolas"/>
+              </a:rPr>
+              <a:t>https://github.com/KrizRoMe/evaluacion-administracion-web/issues/new?template=entrega.yml</a:t>
+            </a:r>
+          </a:p>
+        </p:txBody>
+      </p:sp>
+      <p:sp>
+        <p:nvSpPr>
+          <p:cNvPr id="13" name="TextBox 12"/>
           <p:cNvSpPr txBox="1"/>
           <p:nvPr/>
         </p:nvSpPr>
         <p:spPr>
           <a:xfrm>
-            <a:off x="1097280" y="5212080"/>
-            <a:ext cx="10058400" cy="91440"/>
+            <a:off x="822960" y="5989320"/>
+            <a:ext cx="10607040" cy="274320"/>
           </a:xfrm>
           <a:prstGeom prst="rect">
             <a:avLst/>
@@ -4564,61 +4728,16 @@
           </a:bodyPr>
           <a:lstStyle/>
           <a:p>
-            <a:pPr algn="l"/>
-            <a:r>
-              <a:rPr sz="1400" b="0">
-                <a:solidFill>
-                  <a:srgbClr val="2A2A2A"/>
-                </a:solidFill>
-                <a:latin typeface="Consolas"/>
-              </a:rPr>
-              <a:t>https://github.com/TU-USUARIO/evaluacion-administracion-web-TU-NOMBRE</a:t>
-            </a:r>
-          </a:p>
-        </p:txBody>
-      </p:sp>
-      <p:sp>
-        <p:nvSpPr>
-          <p:cNvPr id="13" name="Rounded Rectangle 12"/>
-          <p:cNvSpPr/>
-          <p:nvPr/>
-        </p:nvSpPr>
-        <p:spPr>
-          <a:xfrm>
-            <a:off x="914400" y="5440680"/>
-            <a:ext cx="10424160" cy="731520"/>
-          </a:xfrm>
-          <a:prstGeom prst="roundRect">
-            <a:avLst/>
-          </a:prstGeom>
-          <a:solidFill>
-            <a:srgbClr val="0E4D70"/>
-          </a:solidFill>
-          <a:ln w="25400">
-            <a:solidFill>
-              <a:srgbClr val="FFFFFF"/>
-            </a:solidFill>
-          </a:ln>
-        </p:spPr>
-        <p:style>
-          <a:lnRef idx="1">
-            <a:schemeClr val="accent1"/>
-          </a:lnRef>
-          <a:fillRef idx="3">
-            <a:schemeClr val="accent1"/>
-          </a:fillRef>
-          <a:effectRef idx="2">
-            <a:schemeClr val="accent1"/>
-          </a:effectRef>
-          <a:fontRef idx="minor">
-            <a:schemeClr val="lt1"/>
-          </a:fontRef>
-        </p:style>
-        <p:txBody>
-          <a:bodyPr rtlCol="0" anchor="ctr"/>
-          <a:lstStyle/>
-          <a:p>
             <a:pPr algn="ctr"/>
+            <a:r>
+              <a:rPr sz="1100" b="0">
+                <a:solidFill>
+                  <a:srgbClr val="FED3B6"/>
+                </a:solidFill>
+                <a:latin typeface="Calibri"/>
+              </a:rPr>
+              <a:t>📌  Los 3 hallazgos van en TU repo.  La ENTREGA final va AQUÍ.</a:t>
+            </a:r>
           </a:p>
         </p:txBody>
       </p:sp>
@@ -4630,8 +4749,8 @@
         </p:nvSpPr>
         <p:spPr>
           <a:xfrm>
-            <a:off x="1097280" y="5577840"/>
-            <a:ext cx="10058400" cy="457200"/>
+            <a:off x="457200" y="6446520"/>
+            <a:ext cx="7315200" cy="274320"/>
           </a:xfrm>
           <a:prstGeom prst="rect">
             <a:avLst/>
@@ -4646,13 +4765,13 @@
           <a:p>
             <a:pPr algn="l"/>
             <a:r>
-              <a:rPr sz="1600" b="1">
-                <a:solidFill>
-                  <a:srgbClr val="FFFFFF"/>
-                </a:solidFill>
-                <a:latin typeface="Calibri"/>
-              </a:rPr>
-              <a:t>🌐 URL de TU GitHub Pages</a:t>
+              <a:rPr sz="800" b="0">
+                <a:solidFill>
+                  <a:srgbClr val="666666"/>
+                </a:solidFill>
+                <a:latin typeface="Calibri"/>
+              </a:rPr>
+              <a:t>📦 Repo: github.com/KrizRoMe/evaluacion-administracion-web   •   🌐 Web: krizrome.github.io/evaluacion-administracion-web   •   📋 Issues: github.com/KrizRoMe/evaluacion-administracion-web/issues</a:t>
             </a:r>
           </a:p>
         </p:txBody>
@@ -4660,76 +4779,6 @@
       <p:sp>
         <p:nvSpPr>
           <p:cNvPr id="15" name="TextBox 14"/>
-          <p:cNvSpPr txBox="1"/>
-          <p:nvPr/>
-        </p:nvSpPr>
-        <p:spPr>
-          <a:xfrm>
-            <a:off x="1097280" y="6035040"/>
-            <a:ext cx="10058400" cy="91440"/>
-          </a:xfrm>
-          <a:prstGeom prst="rect">
-            <a:avLst/>
-          </a:prstGeom>
-          <a:noFill/>
-        </p:spPr>
-        <p:txBody>
-          <a:bodyPr wrap="square">
-            <a:spAutoFit/>
-          </a:bodyPr>
-          <a:lstStyle/>
-          <a:p>
-            <a:pPr algn="l"/>
-            <a:r>
-              <a:rPr sz="1400" b="0">
-                <a:solidFill>
-                  <a:srgbClr val="2A2A2A"/>
-                </a:solidFill>
-                <a:latin typeface="Consolas"/>
-              </a:rPr>
-              <a:t>https://TU-USUARIO.github.io/evaluacion-administracion-web-TU-NOMBRE/</a:t>
-            </a:r>
-          </a:p>
-        </p:txBody>
-      </p:sp>
-      <p:sp>
-        <p:nvSpPr>
-          <p:cNvPr id="16" name="TextBox 15"/>
-          <p:cNvSpPr txBox="1"/>
-          <p:nvPr/>
-        </p:nvSpPr>
-        <p:spPr>
-          <a:xfrm>
-            <a:off x="457200" y="6446520"/>
-            <a:ext cx="6400800" cy="274320"/>
-          </a:xfrm>
-          <a:prstGeom prst="rect">
-            <a:avLst/>
-          </a:prstGeom>
-          <a:noFill/>
-        </p:spPr>
-        <p:txBody>
-          <a:bodyPr wrap="square">
-            <a:spAutoFit/>
-          </a:bodyPr>
-          <a:lstStyle/>
-          <a:p>
-            <a:pPr algn="l"/>
-            <a:r>
-              <a:rPr sz="800" b="0">
-                <a:solidFill>
-                  <a:srgbClr val="666666"/>
-                </a:solidFill>
-                <a:latin typeface="Calibri"/>
-              </a:rPr>
-              <a:t>📦 Repositorio: github.com/KrizRoMe/evaluacion-administracion-web   •   🌐 Sitio: krizrome.github.io/evaluacion-administracion-web</a:t>
-            </a:r>
-          </a:p>
-        </p:txBody>
-      </p:sp>
-      <p:sp>
-        <p:nvSpPr>
-          <p:cNvPr id="17" name="TextBox 16"/>
           <p:cNvSpPr txBox="1"/>
           <p:nvPr/>
         </p:nvSpPr>
@@ -5251,7 +5300,7 @@
         <p:spPr>
           <a:xfrm>
             <a:off x="457200" y="6446520"/>
-            <a:ext cx="6400800" cy="274320"/>
+            <a:ext cx="7315200" cy="274320"/>
           </a:xfrm>
           <a:prstGeom prst="rect">
             <a:avLst/>
@@ -5272,7 +5321,7 @@
                 </a:solidFill>
                 <a:latin typeface="Calibri"/>
               </a:rPr>
-              <a:t>📦 Repositorio: github.com/KrizRoMe/evaluacion-administracion-web   •   🌐 Sitio: krizrome.github.io/evaluacion-administracion-web</a:t>
+              <a:t>📦 Repo: github.com/KrizRoMe/evaluacion-administracion-web   •   🌐 Web: krizrome.github.io/evaluacion-administracion-web   •   📋 Issues: github.com/KrizRoMe/evaluacion-administracion-web/issues</a:t>
             </a:r>
           </a:p>
         </p:txBody>
@@ -5481,7 +5530,7 @@
                 </a:solidFill>
                 <a:latin typeface="Calibri"/>
               </a:rPr>
-              <a:t>Estas son las URLs que vas a usar y entregar</a:t>
+              <a:t>Sitio base + tu repo + dónde entregar</a:t>
             </a:r>
           </a:p>
         </p:txBody>
@@ -5494,8 +5543,8 @@
         </p:nvSpPr>
         <p:spPr>
           <a:xfrm>
-            <a:off x="640080" y="1280160"/>
-            <a:ext cx="10972800" cy="457200"/>
+            <a:off x="640080" y="1188720"/>
+            <a:ext cx="10972800" cy="365760"/>
           </a:xfrm>
           <a:prstGeom prst="rect">
             <a:avLst/>
@@ -5510,13 +5559,13 @@
           <a:p>
             <a:pPr algn="l"/>
             <a:r>
-              <a:rPr sz="1800" b="1">
+              <a:rPr sz="1600" b="1">
                 <a:solidFill>
                   <a:srgbClr val="065A82"/>
                 </a:solidFill>
                 <a:latin typeface="Calibri"/>
               </a:rPr>
-              <a:t>🌐  Sitio base (código que vas a auditar)</a:t>
+              <a:t>🌐  Sitio base (el código que vas a auditar)</a:t>
             </a:r>
           </a:p>
         </p:txBody>
@@ -5529,8 +5578,8 @@
         </p:nvSpPr>
         <p:spPr>
           <a:xfrm>
-            <a:off x="640080" y="1783080"/>
-            <a:ext cx="10972800" cy="777240"/>
+            <a:off x="640080" y="1600200"/>
+            <a:ext cx="10972800" cy="640080"/>
           </a:xfrm>
           <a:prstGeom prst="roundRect">
             <a:avLst/>
@@ -5574,7 +5623,7 @@
         </p:nvSpPr>
         <p:spPr>
           <a:xfrm>
-            <a:off x="822959" y="1920240"/>
+            <a:off x="822959" y="1737360"/>
             <a:ext cx="10607040" cy="457200"/>
           </a:xfrm>
           <a:prstGeom prst="rect">
@@ -5609,8 +5658,8 @@
         </p:nvSpPr>
         <p:spPr>
           <a:xfrm>
-            <a:off x="822959" y="2377440"/>
-            <a:ext cx="10607040" cy="137160"/>
+            <a:off x="822959" y="2240280"/>
+            <a:ext cx="10607040" cy="-91440"/>
           </a:xfrm>
           <a:prstGeom prst="rect">
             <a:avLst/>
@@ -5644,8 +5693,8 @@
         </p:nvSpPr>
         <p:spPr>
           <a:xfrm>
-            <a:off x="640080" y="2788920"/>
-            <a:ext cx="10972800" cy="457200"/>
+            <a:off x="640080" y="2423160"/>
+            <a:ext cx="10972800" cy="365760"/>
           </a:xfrm>
           <a:prstGeom prst="rect">
             <a:avLst/>
@@ -5660,7 +5709,7 @@
           <a:p>
             <a:pPr algn="l"/>
             <a:r>
-              <a:rPr sz="1800" b="1">
+              <a:rPr sz="1600" b="1">
                 <a:solidFill>
                   <a:srgbClr val="065A82"/>
                 </a:solidFill>
@@ -5679,8 +5728,8 @@
         </p:nvSpPr>
         <p:spPr>
           <a:xfrm>
-            <a:off x="640080" y="3291840"/>
-            <a:ext cx="10972800" cy="777240"/>
+            <a:off x="640080" y="2834640"/>
+            <a:ext cx="10972800" cy="640080"/>
           </a:xfrm>
           <a:prstGeom prst="roundRect">
             <a:avLst/>
@@ -5724,7 +5773,7 @@
         </p:nvSpPr>
         <p:spPr>
           <a:xfrm>
-            <a:off x="822959" y="3429000"/>
+            <a:off x="822959" y="2971800"/>
             <a:ext cx="10607040" cy="457200"/>
           </a:xfrm>
           <a:prstGeom prst="rect">
@@ -5746,7 +5795,7 @@
                 </a:solidFill>
                 <a:latin typeface="Calibri"/>
               </a:rPr>
-              <a:t>Patrón de nombre (reemplaza TU-NOMBRE por tu nombre)</a:t>
+              <a:t>Patrón: reemplaza TU-NOMBRE por tu nombre</a:t>
             </a:r>
           </a:p>
         </p:txBody>
@@ -5759,8 +5808,8 @@
         </p:nvSpPr>
         <p:spPr>
           <a:xfrm>
-            <a:off x="822959" y="3886200"/>
-            <a:ext cx="10607040" cy="137160"/>
+            <a:off x="822959" y="3474720"/>
+            <a:ext cx="10607040" cy="-91440"/>
           </a:xfrm>
           <a:prstGeom prst="rect">
             <a:avLst/>
@@ -5794,8 +5843,8 @@
         </p:nvSpPr>
         <p:spPr>
           <a:xfrm>
-            <a:off x="640080" y="4297680"/>
-            <a:ext cx="10972800" cy="457200"/>
+            <a:off x="640080" y="3657600"/>
+            <a:ext cx="10972800" cy="365760"/>
           </a:xfrm>
           <a:prstGeom prst="rect">
             <a:avLst/>
@@ -5810,7 +5859,7 @@
           <a:p>
             <a:pPr algn="l"/>
             <a:r>
-              <a:rPr sz="1800" b="1">
+              <a:rPr sz="1600" b="1">
                 <a:solidFill>
                   <a:srgbClr val="065A82"/>
                 </a:solidFill>
@@ -5829,8 +5878,8 @@
         </p:nvSpPr>
         <p:spPr>
           <a:xfrm>
-            <a:off x="640080" y="4800600"/>
-            <a:ext cx="10972800" cy="777240"/>
+            <a:off x="640080" y="4069080"/>
+            <a:ext cx="10972800" cy="640080"/>
           </a:xfrm>
           <a:prstGeom prst="roundRect">
             <a:avLst/>
@@ -5874,7 +5923,7 @@
         </p:nvSpPr>
         <p:spPr>
           <a:xfrm>
-            <a:off x="822959" y="4937760"/>
+            <a:off x="822959" y="4206240"/>
             <a:ext cx="10607040" cy="457200"/>
           </a:xfrm>
           <a:prstGeom prst="rect">
@@ -5909,8 +5958,8 @@
         </p:nvSpPr>
         <p:spPr>
           <a:xfrm>
-            <a:off x="822959" y="5394960"/>
-            <a:ext cx="10607040" cy="137160"/>
+            <a:off x="822959" y="4709160"/>
+            <a:ext cx="10607040" cy="-91440"/>
           </a:xfrm>
           <a:prstGeom prst="rect">
             <a:avLst/>
@@ -5938,14 +5987,164 @@
       </p:sp>
       <p:sp>
         <p:nvSpPr>
-          <p:cNvPr id="18" name="Rounded Rectangle 17"/>
+          <p:cNvPr id="18" name="TextBox 17"/>
+          <p:cNvSpPr txBox="1"/>
+          <p:nvPr/>
+        </p:nvSpPr>
+        <p:spPr>
+          <a:xfrm>
+            <a:off x="640080" y="4892040"/>
+            <a:ext cx="10972800" cy="365760"/>
+          </a:xfrm>
+          <a:prstGeom prst="rect">
+            <a:avLst/>
+          </a:prstGeom>
+          <a:noFill/>
+        </p:spPr>
+        <p:txBody>
+          <a:bodyPr wrap="square">
+            <a:spAutoFit/>
+          </a:bodyPr>
+          <a:lstStyle/>
+          <a:p>
+            <a:pPr algn="l"/>
+            <a:r>
+              <a:rPr sz="1600" b="1">
+                <a:solidFill>
+                  <a:srgbClr val="EA580C"/>
+                </a:solidFill>
+                <a:latin typeface="Calibri"/>
+              </a:rPr>
+              <a:t>📤  Dónde entregas tu evaluación (Issue de entrega)</a:t>
+            </a:r>
+          </a:p>
+        </p:txBody>
+      </p:sp>
+      <p:sp>
+        <p:nvSpPr>
+          <p:cNvPr id="19" name="Rounded Rectangle 18"/>
           <p:cNvSpPr/>
           <p:nvPr/>
         </p:nvSpPr>
         <p:spPr>
           <a:xfrm>
-            <a:off x="640080" y="5760720"/>
-            <a:ext cx="10972800" cy="548640"/>
+            <a:off x="640080" y="5303520"/>
+            <a:ext cx="10972800" cy="777240"/>
+          </a:xfrm>
+          <a:prstGeom prst="roundRect">
+            <a:avLst/>
+          </a:prstGeom>
+          <a:solidFill>
+            <a:srgbClr val="FEF3E6"/>
+          </a:solidFill>
+          <a:ln w="25400">
+            <a:solidFill>
+              <a:srgbClr val="EA580C"/>
+            </a:solidFill>
+          </a:ln>
+        </p:spPr>
+        <p:style>
+          <a:lnRef idx="1">
+            <a:schemeClr val="accent1"/>
+          </a:lnRef>
+          <a:fillRef idx="3">
+            <a:schemeClr val="accent1"/>
+          </a:fillRef>
+          <a:effectRef idx="2">
+            <a:schemeClr val="accent1"/>
+          </a:effectRef>
+          <a:fontRef idx="minor">
+            <a:schemeClr val="lt1"/>
+          </a:fontRef>
+        </p:style>
+        <p:txBody>
+          <a:bodyPr rtlCol="0" anchor="ctr"/>
+          <a:lstStyle/>
+          <a:p>
+            <a:pPr algn="ctr"/>
+          </a:p>
+        </p:txBody>
+      </p:sp>
+      <p:sp>
+        <p:nvSpPr>
+          <p:cNvPr id="20" name="TextBox 19"/>
+          <p:cNvSpPr txBox="1"/>
+          <p:nvPr/>
+        </p:nvSpPr>
+        <p:spPr>
+          <a:xfrm>
+            <a:off x="822959" y="5440680"/>
+            <a:ext cx="10607040" cy="457200"/>
+          </a:xfrm>
+          <a:prstGeom prst="rect">
+            <a:avLst/>
+          </a:prstGeom>
+          <a:noFill/>
+        </p:spPr>
+        <p:txBody>
+          <a:bodyPr wrap="square">
+            <a:spAutoFit/>
+          </a:bodyPr>
+          <a:lstStyle/>
+          <a:p>
+            <a:pPr algn="l"/>
+            <a:r>
+              <a:rPr sz="1600" b="1">
+                <a:solidFill>
+                  <a:srgbClr val="EA580C"/>
+                </a:solidFill>
+                <a:latin typeface="Calibri"/>
+              </a:rPr>
+              <a:t>Crea una Issue con el template 'Entrega' en el repo del docente:</a:t>
+            </a:r>
+          </a:p>
+        </p:txBody>
+      </p:sp>
+      <p:sp>
+        <p:nvSpPr>
+          <p:cNvPr id="21" name="TextBox 20"/>
+          <p:cNvSpPr txBox="1"/>
+          <p:nvPr/>
+        </p:nvSpPr>
+        <p:spPr>
+          <a:xfrm>
+            <a:off x="822959" y="5943600"/>
+            <a:ext cx="10607040" cy="45719"/>
+          </a:xfrm>
+          <a:prstGeom prst="rect">
+            <a:avLst/>
+          </a:prstGeom>
+          <a:noFill/>
+        </p:spPr>
+        <p:txBody>
+          <a:bodyPr wrap="square">
+            <a:spAutoFit/>
+          </a:bodyPr>
+          <a:lstStyle/>
+          <a:p>
+            <a:pPr algn="l"/>
+            <a:r>
+              <a:rPr sz="1200" b="0">
+                <a:solidFill>
+                  <a:srgbClr val="2A2A2A"/>
+                </a:solidFill>
+                <a:latin typeface="Consolas"/>
+              </a:rPr>
+              <a:t>https://github.com/KrizRoMe/evaluacion-administracion-web/issues/new?template=entrega.yml</a:t>
+            </a:r>
+          </a:p>
+        </p:txBody>
+      </p:sp>
+      <p:sp>
+        <p:nvSpPr>
+          <p:cNvPr id="22" name="Rounded Rectangle 21"/>
+          <p:cNvSpPr/>
+          <p:nvPr/>
+        </p:nvSpPr>
+        <p:spPr>
+          <a:xfrm>
+            <a:off x="640080" y="6172200"/>
+            <a:ext cx="10972800" cy="274320"/>
           </a:xfrm>
           <a:prstGeom prst="roundRect">
             <a:avLst/>
@@ -5983,14 +6182,14 @@
       </p:sp>
       <p:sp>
         <p:nvSpPr>
-          <p:cNvPr id="19" name="TextBox 18"/>
+          <p:cNvPr id="23" name="TextBox 22"/>
           <p:cNvSpPr txBox="1"/>
           <p:nvPr/>
         </p:nvSpPr>
         <p:spPr>
           <a:xfrm>
-            <a:off x="640080" y="5852160"/>
-            <a:ext cx="10972800" cy="365760"/>
+            <a:off x="640080" y="6217920"/>
+            <a:ext cx="10972800" cy="182880"/>
           </a:xfrm>
           <a:prstGeom prst="rect">
             <a:avLst/>
@@ -6005,27 +6204,27 @@
           <a:p>
             <a:pPr algn="ctr"/>
             <a:r>
-              <a:rPr sz="1400" b="1">
+              <a:rPr sz="1100" b="1">
                 <a:solidFill>
                   <a:srgbClr val="924E0E"/>
                 </a:solidFill>
                 <a:latin typeface="Calibri"/>
               </a:rPr>
-              <a:t>📌 Al final de la evaluación entrega al docente: URL de tu repo + URL de tu GitHub Pages.</a:t>
-            </a:r>
-          </a:p>
-        </p:txBody>
-      </p:sp>
-      <p:sp>
-        <p:nvSpPr>
-          <p:cNvPr id="20" name="TextBox 19"/>
+              <a:t>📌  Los 3 hallazgos se documentan como Issues EN TU REPO.  La entrega final se hace como Issue AQUÍ.</a:t>
+            </a:r>
+          </a:p>
+        </p:txBody>
+      </p:sp>
+      <p:sp>
+        <p:nvSpPr>
+          <p:cNvPr id="24" name="TextBox 23"/>
           <p:cNvSpPr txBox="1"/>
           <p:nvPr/>
         </p:nvSpPr>
         <p:spPr>
           <a:xfrm>
             <a:off x="457200" y="6446520"/>
-            <a:ext cx="6400800" cy="274320"/>
+            <a:ext cx="7315200" cy="274320"/>
           </a:xfrm>
           <a:prstGeom prst="rect">
             <a:avLst/>
@@ -6046,14 +6245,14 @@
                 </a:solidFill>
                 <a:latin typeface="Calibri"/>
               </a:rPr>
-              <a:t>📦 Repositorio: github.com/KrizRoMe/evaluacion-administracion-web   •   🌐 Sitio: krizrome.github.io/evaluacion-administracion-web</a:t>
-            </a:r>
-          </a:p>
-        </p:txBody>
-      </p:sp>
-      <p:sp>
-        <p:nvSpPr>
-          <p:cNvPr id="21" name="TextBox 20"/>
+              <a:t>📦 Repo: github.com/KrizRoMe/evaluacion-administracion-web   •   🌐 Web: krizrome.github.io/evaluacion-administracion-web   •   📋 Issues: github.com/KrizRoMe/evaluacion-administracion-web/issues</a:t>
+            </a:r>
+          </a:p>
+        </p:txBody>
+      </p:sp>
+      <p:sp>
+        <p:nvSpPr>
+          <p:cNvPr id="25" name="TextBox 24"/>
           <p:cNvSpPr txBox="1"/>
           <p:nvPr/>
         </p:nvSpPr>
@@ -6268,8 +6467,8 @@
         </p:nvSpPr>
         <p:spPr>
           <a:xfrm>
-            <a:off x="586587" y="2286000"/>
-            <a:ext cx="1417320" cy="1371600"/>
+            <a:off x="723747" y="2286000"/>
+            <a:ext cx="1417320" cy="1554480"/>
           </a:xfrm>
           <a:prstGeom prst="roundRect">
             <a:avLst/>
@@ -6311,8 +6510,8 @@
         </p:nvSpPr>
         <p:spPr>
           <a:xfrm>
-            <a:off x="586587" y="2606040"/>
-            <a:ext cx="1417320" cy="731520"/>
+            <a:off x="723747" y="2606040"/>
+            <a:ext cx="1417320" cy="914400"/>
           </a:xfrm>
           <a:prstGeom prst="rect">
             <a:avLst/>
@@ -6327,7 +6526,7 @@
           <a:p>
             <a:pPr algn="ctr"/>
             <a:r>
-              <a:rPr sz="1400" b="1">
+              <a:rPr sz="1300" b="1">
                 <a:solidFill>
                   <a:srgbClr val="FFFFFF"/>
                 </a:solidFill>
@@ -6347,8 +6546,8 @@
         </p:nvSpPr>
         <p:spPr>
           <a:xfrm>
-            <a:off x="2022195" y="2834640"/>
-            <a:ext cx="146304" cy="274320"/>
+            <a:off x="2150211" y="2926080"/>
+            <a:ext cx="118872" cy="274320"/>
           </a:xfrm>
           <a:prstGeom prst="rightArrow">
             <a:avLst/>
@@ -6390,8 +6589,8 @@
         </p:nvSpPr>
         <p:spPr>
           <a:xfrm>
-            <a:off x="2186787" y="2286000"/>
-            <a:ext cx="1417320" cy="1371600"/>
+            <a:off x="2278227" y="2286000"/>
+            <a:ext cx="1417320" cy="1554480"/>
           </a:xfrm>
           <a:prstGeom prst="roundRect">
             <a:avLst/>
@@ -6433,8 +6632,8 @@
         </p:nvSpPr>
         <p:spPr>
           <a:xfrm>
-            <a:off x="2186787" y="2606040"/>
-            <a:ext cx="1417320" cy="731520"/>
+            <a:off x="2278227" y="2606040"/>
+            <a:ext cx="1417320" cy="914400"/>
           </a:xfrm>
           <a:prstGeom prst="rect">
             <a:avLst/>
@@ -6449,7 +6648,7 @@
           <a:p>
             <a:pPr algn="ctr"/>
             <a:r>
-              <a:rPr sz="1400" b="1">
+              <a:rPr sz="1300" b="1">
                 <a:solidFill>
                   <a:srgbClr val="FFFFFF"/>
                 </a:solidFill>
@@ -6469,8 +6668,8 @@
         </p:nvSpPr>
         <p:spPr>
           <a:xfrm>
-            <a:off x="3622395" y="2834640"/>
-            <a:ext cx="146304" cy="274320"/>
+            <a:off x="3704691" y="2926080"/>
+            <a:ext cx="118872" cy="274320"/>
           </a:xfrm>
           <a:prstGeom prst="rightArrow">
             <a:avLst/>
@@ -6512,8 +6711,8 @@
         </p:nvSpPr>
         <p:spPr>
           <a:xfrm>
-            <a:off x="3786987" y="2286000"/>
-            <a:ext cx="1417320" cy="1371600"/>
+            <a:off x="3832707" y="2286000"/>
+            <a:ext cx="1417320" cy="1554480"/>
           </a:xfrm>
           <a:prstGeom prst="roundRect">
             <a:avLst/>
@@ -6555,8 +6754,8 @@
         </p:nvSpPr>
         <p:spPr>
           <a:xfrm>
-            <a:off x="3786987" y="2606040"/>
-            <a:ext cx="1417320" cy="731520"/>
+            <a:off x="3832707" y="2606040"/>
+            <a:ext cx="1417320" cy="914400"/>
           </a:xfrm>
           <a:prstGeom prst="rect">
             <a:avLst/>
@@ -6571,7 +6770,7 @@
           <a:p>
             <a:pPr algn="ctr"/>
             <a:r>
-              <a:rPr sz="1400" b="1">
+              <a:rPr sz="1300" b="1">
                 <a:solidFill>
                   <a:srgbClr val="FFFFFF"/>
                 </a:solidFill>
@@ -6591,8 +6790,8 @@
         </p:nvSpPr>
         <p:spPr>
           <a:xfrm>
-            <a:off x="5222595" y="2834640"/>
-            <a:ext cx="146304" cy="274320"/>
+            <a:off x="5259171" y="2926080"/>
+            <a:ext cx="118872" cy="274320"/>
           </a:xfrm>
           <a:prstGeom prst="rightArrow">
             <a:avLst/>
@@ -6635,7 +6834,7 @@
         <p:spPr>
           <a:xfrm>
             <a:off x="5387187" y="2286000"/>
-            <a:ext cx="1417320" cy="1371600"/>
+            <a:ext cx="1417320" cy="1554480"/>
           </a:xfrm>
           <a:prstGeom prst="roundRect">
             <a:avLst/>
@@ -6678,7 +6877,7 @@
         <p:spPr>
           <a:xfrm>
             <a:off x="5387187" y="2606040"/>
-            <a:ext cx="1417320" cy="731520"/>
+            <a:ext cx="1417320" cy="914400"/>
           </a:xfrm>
           <a:prstGeom prst="rect">
             <a:avLst/>
@@ -6693,7 +6892,7 @@
           <a:p>
             <a:pPr algn="ctr"/>
             <a:r>
-              <a:rPr sz="1400" b="1">
+              <a:rPr sz="1300" b="1">
                 <a:solidFill>
                   <a:srgbClr val="FFFFFF"/>
                 </a:solidFill>
@@ -6713,8 +6912,8 @@
         </p:nvSpPr>
         <p:spPr>
           <a:xfrm>
-            <a:off x="6822795" y="2834640"/>
-            <a:ext cx="146304" cy="274320"/>
+            <a:off x="6813651" y="2926080"/>
+            <a:ext cx="118872" cy="274320"/>
           </a:xfrm>
           <a:prstGeom prst="rightArrow">
             <a:avLst/>
@@ -6756,8 +6955,8 @@
         </p:nvSpPr>
         <p:spPr>
           <a:xfrm>
-            <a:off x="6987387" y="2286000"/>
-            <a:ext cx="1417320" cy="1371600"/>
+            <a:off x="6941667" y="2286000"/>
+            <a:ext cx="1417320" cy="1554480"/>
           </a:xfrm>
           <a:prstGeom prst="roundRect">
             <a:avLst/>
@@ -6799,8 +6998,8 @@
         </p:nvSpPr>
         <p:spPr>
           <a:xfrm>
-            <a:off x="6987387" y="2606040"/>
-            <a:ext cx="1417320" cy="731520"/>
+            <a:off x="6941667" y="2606040"/>
+            <a:ext cx="1417320" cy="914400"/>
           </a:xfrm>
           <a:prstGeom prst="rect">
             <a:avLst/>
@@ -6815,14 +7014,14 @@
           <a:p>
             <a:pPr algn="ctr"/>
             <a:r>
-              <a:rPr sz="1400" b="1">
+              <a:rPr sz="1300" b="1">
                 <a:solidFill>
                   <a:srgbClr val="FFFFFF"/>
                 </a:solidFill>
                 <a:latin typeface="Calibri"/>
               </a:rPr>
-              <a:t>3
-Issues</a:t>
+              <a:t>3 Issues
+en TU repo</a:t>
             </a:r>
           </a:p>
         </p:txBody>
@@ -6835,8 +7034,8 @@
         </p:nvSpPr>
         <p:spPr>
           <a:xfrm>
-            <a:off x="8422995" y="2834640"/>
-            <a:ext cx="146304" cy="274320"/>
+            <a:off x="8368131" y="2926080"/>
+            <a:ext cx="118872" cy="274320"/>
           </a:xfrm>
           <a:prstGeom prst="rightArrow">
             <a:avLst/>
@@ -6878,8 +7077,8 @@
         </p:nvSpPr>
         <p:spPr>
           <a:xfrm>
-            <a:off x="8587587" y="2286000"/>
-            <a:ext cx="1417320" cy="1371600"/>
+            <a:off x="8496147" y="2286000"/>
+            <a:ext cx="1417320" cy="1554480"/>
           </a:xfrm>
           <a:prstGeom prst="roundRect">
             <a:avLst/>
@@ -6921,8 +7120,8 @@
         </p:nvSpPr>
         <p:spPr>
           <a:xfrm>
-            <a:off x="8587587" y="2606040"/>
-            <a:ext cx="1417320" cy="731520"/>
+            <a:off x="8496147" y="2606040"/>
+            <a:ext cx="1417320" cy="914400"/>
           </a:xfrm>
           <a:prstGeom prst="rect">
             <a:avLst/>
@@ -6937,14 +7136,13 @@
           <a:p>
             <a:pPr algn="ctr"/>
             <a:r>
-              <a:rPr sz="1400" b="1">
+              <a:rPr sz="1300" b="1">
                 <a:solidFill>
                   <a:srgbClr val="FFFFFF"/>
                 </a:solidFill>
                 <a:latin typeface="Calibri"/>
               </a:rPr>
-              <a:t>Documentar
-solución</a:t>
+              <a:t>README</a:t>
             </a:r>
           </a:p>
         </p:txBody>
@@ -6957,8 +7155,8 @@
         </p:nvSpPr>
         <p:spPr>
           <a:xfrm>
-            <a:off x="10023195" y="2834640"/>
-            <a:ext cx="146304" cy="274320"/>
+            <a:off x="9922611" y="2926080"/>
+            <a:ext cx="118872" cy="274320"/>
           </a:xfrm>
           <a:prstGeom prst="rightArrow">
             <a:avLst/>
@@ -7000,14 +7198,14 @@
         </p:nvSpPr>
         <p:spPr>
           <a:xfrm>
-            <a:off x="10187787" y="2286000"/>
-            <a:ext cx="1417320" cy="1371600"/>
+            <a:off x="10050627" y="2286000"/>
+            <a:ext cx="1417320" cy="1554480"/>
           </a:xfrm>
           <a:prstGeom prst="roundRect">
             <a:avLst/>
           </a:prstGeom>
           <a:solidFill>
-            <a:srgbClr val="065A82"/>
+            <a:srgbClr val="EA580C"/>
           </a:solidFill>
           <a:ln>
             <a:noFill/>
@@ -7043,8 +7241,8 @@
         </p:nvSpPr>
         <p:spPr>
           <a:xfrm>
-            <a:off x="10187787" y="2606040"/>
-            <a:ext cx="1417320" cy="731520"/>
+            <a:off x="10050627" y="2606040"/>
+            <a:ext cx="1417320" cy="914400"/>
           </a:xfrm>
           <a:prstGeom prst="rect">
             <a:avLst/>
@@ -7059,14 +7257,14 @@
           <a:p>
             <a:pPr algn="ctr"/>
             <a:r>
-              <a:rPr sz="1400" b="1">
+              <a:rPr sz="1300" b="1">
                 <a:solidFill>
                   <a:srgbClr val="FFFFFF"/>
                 </a:solidFill>
                 <a:latin typeface="Calibri"/>
               </a:rPr>
-              <a:t>README +
-entrega</a:t>
+              <a:t>Issue de
+entrega AQUÍ</a:t>
             </a:r>
           </a:p>
         </p:txBody>
@@ -7130,7 +7328,7 @@
           <a:p>
             <a:pPr algn="l"/>
             <a:r>
-              <a:rPr sz="1400" b="0">
+              <a:rPr sz="1300" b="0">
                 <a:solidFill>
                   <a:srgbClr val="2A2A2A"/>
                 </a:solidFill>
@@ -7142,13 +7340,13 @@
           <a:p>
             <a:pPr algn="l"/>
             <a:r>
-              <a:rPr sz="1400" b="0">
+              <a:rPr sz="1300" b="0">
                 <a:solidFill>
                   <a:srgbClr val="2A2A2A"/>
                 </a:solidFill>
                 <a:latin typeface="Calibri"/>
               </a:rPr>
-              <a:t>Issues: 20 min   •   Documentar solución: 10 min   •   README: 15 min   •   Verificación: 5 min</a:t>
+              <a:t>Issues (TU repo): 20 min   •   Documentar solución: 10 min   •   README: 15 min   •   Issue de entrega: 5 min</a:t>
             </a:r>
           </a:p>
         </p:txBody>
@@ -7242,7 +7440,7 @@
         <p:spPr>
           <a:xfrm>
             <a:off x="457200" y="6446520"/>
-            <a:ext cx="6400800" cy="274320"/>
+            <a:ext cx="7315200" cy="274320"/>
           </a:xfrm>
           <a:prstGeom prst="rect">
             <a:avLst/>
@@ -7263,7 +7461,7 @@
                 </a:solidFill>
                 <a:latin typeface="Calibri"/>
               </a:rPr>
-              <a:t>📦 Repositorio: github.com/KrizRoMe/evaluacion-administracion-web   •   🌐 Sitio: krizrome.github.io/evaluacion-administracion-web</a:t>
+              <a:t>📦 Repo: github.com/KrizRoMe/evaluacion-administracion-web   •   🌐 Web: krizrome.github.io/evaluacion-administracion-web   •   📋 Issues: github.com/KrizRoMe/evaluacion-administracion-web/issues</a:t>
             </a:r>
           </a:p>
         </p:txBody>
@@ -7873,7 +8071,7 @@
         <p:spPr>
           <a:xfrm>
             <a:off x="457200" y="6446520"/>
-            <a:ext cx="6400800" cy="274320"/>
+            <a:ext cx="7315200" cy="274320"/>
           </a:xfrm>
           <a:prstGeom prst="rect">
             <a:avLst/>
@@ -7894,7 +8092,7 @@
                 </a:solidFill>
                 <a:latin typeface="Calibri"/>
               </a:rPr>
-              <a:t>📦 Repositorio: github.com/KrizRoMe/evaluacion-administracion-web   •   🌐 Sitio: krizrome.github.io/evaluacion-administracion-web</a:t>
+              <a:t>📦 Repo: github.com/KrizRoMe/evaluacion-administracion-web   •   🌐 Web: krizrome.github.io/evaluacion-administracion-web   •   📋 Issues: github.com/KrizRoMe/evaluacion-administracion-web/issues</a:t>
             </a:r>
           </a:p>
         </p:txBody>
@@ -8421,7 +8619,7 @@
         <p:spPr>
           <a:xfrm>
             <a:off x="457200" y="6446520"/>
-            <a:ext cx="6400800" cy="274320"/>
+            <a:ext cx="7315200" cy="274320"/>
           </a:xfrm>
           <a:prstGeom prst="rect">
             <a:avLst/>
@@ -8442,7 +8640,7 @@
                 </a:solidFill>
                 <a:latin typeface="Calibri"/>
               </a:rPr>
-              <a:t>📦 Repositorio: github.com/KrizRoMe/evaluacion-administracion-web   •   🌐 Sitio: krizrome.github.io/evaluacion-administracion-web</a:t>
+              <a:t>📦 Repo: github.com/KrizRoMe/evaluacion-administracion-web   •   🌐 Web: krizrome.github.io/evaluacion-administracion-web   •   📋 Issues: github.com/KrizRoMe/evaluacion-administracion-web/issues</a:t>
             </a:r>
           </a:p>
         </p:txBody>
@@ -9098,7 +9296,7 @@
         <p:spPr>
           <a:xfrm>
             <a:off x="457200" y="6446520"/>
-            <a:ext cx="6400800" cy="274320"/>
+            <a:ext cx="7315200" cy="274320"/>
           </a:xfrm>
           <a:prstGeom prst="rect">
             <a:avLst/>
@@ -9119,7 +9317,7 @@
                 </a:solidFill>
                 <a:latin typeface="Calibri"/>
               </a:rPr>
-              <a:t>📦 Repositorio: github.com/KrizRoMe/evaluacion-administracion-web   •   🌐 Sitio: krizrome.github.io/evaluacion-administracion-web</a:t>
+              <a:t>📦 Repo: github.com/KrizRoMe/evaluacion-administracion-web   •   🌐 Web: krizrome.github.io/evaluacion-administracion-web   •   📋 Issues: github.com/KrizRoMe/evaluacion-administracion-web/issues</a:t>
             </a:r>
           </a:p>
         </p:txBody>
@@ -9293,7 +9491,7 @@
                 </a:solidFill>
                 <a:latin typeface="Calibri"/>
               </a:rPr>
-              <a:t>Parte 4 · Crear 3 GitHub Issues</a:t>
+              <a:t>Parte 4 · Crear 3 Issues en TU repo</a:t>
             </a:r>
           </a:p>
         </p:txBody>
@@ -9328,21 +9526,66 @@
                 </a:solidFill>
                 <a:latin typeface="Calibri"/>
               </a:rPr>
-              <a:t>⏱ 20 minutos  •  Usa los templates del repo</a:t>
-            </a:r>
-          </a:p>
-        </p:txBody>
-      </p:sp>
-      <p:sp>
-        <p:nvSpPr>
-          <p:cNvPr id="6" name="TextBox 5"/>
+              <a:t>⏱ 20 minutos  •  Usa los templates interactivos</a:t>
+            </a:r>
+          </a:p>
+        </p:txBody>
+      </p:sp>
+      <p:sp>
+        <p:nvSpPr>
+          <p:cNvPr id="6" name="Rounded Rectangle 5"/>
+          <p:cNvSpPr/>
+          <p:nvPr/>
+        </p:nvSpPr>
+        <p:spPr>
+          <a:xfrm>
+            <a:off x="640080" y="1188720"/>
+            <a:ext cx="10972800" cy="548640"/>
+          </a:xfrm>
+          <a:prstGeom prst="roundRect">
+            <a:avLst/>
+          </a:prstGeom>
+          <a:solidFill>
+            <a:srgbClr val="E3F2FD"/>
+          </a:solidFill>
+          <a:ln w="25400">
+            <a:solidFill>
+              <a:srgbClr val="1C7293"/>
+            </a:solidFill>
+          </a:ln>
+        </p:spPr>
+        <p:style>
+          <a:lnRef idx="1">
+            <a:schemeClr val="accent1"/>
+          </a:lnRef>
+          <a:fillRef idx="3">
+            <a:schemeClr val="accent1"/>
+          </a:fillRef>
+          <a:effectRef idx="2">
+            <a:schemeClr val="accent1"/>
+          </a:effectRef>
+          <a:fontRef idx="minor">
+            <a:schemeClr val="lt1"/>
+          </a:fontRef>
+        </p:style>
+        <p:txBody>
+          <a:bodyPr rtlCol="0" anchor="ctr"/>
+          <a:lstStyle/>
+          <a:p>
+            <a:pPr algn="ctr"/>
+          </a:p>
+        </p:txBody>
+      </p:sp>
+      <p:sp>
+        <p:nvSpPr>
+          <p:cNvPr id="7" name="TextBox 6"/>
           <p:cNvSpPr txBox="1"/>
           <p:nvPr/>
         </p:nvSpPr>
         <p:spPr>
           <a:xfrm>
             <a:off x="640080" y="1280160"/>
-            <a:ext cx="10972800" cy="822960"/>
+            <a:ext cx="10972800" cy="365760"/>
           </a:xfrm>
           <a:prstGeom prst="rect">
             <a:avLst/>
@@ -9355,29 +9598,29 @@
           </a:bodyPr>
           <a:lstStyle/>
           <a:p>
-            <a:pPr algn="l"/>
+            <a:pPr algn="ctr"/>
             <a:r>
               <a:rPr sz="1500" b="1">
                 <a:solidFill>
-                  <a:srgbClr val="2A2A2A"/>
-                </a:solidFill>
-                <a:latin typeface="Calibri"/>
-              </a:rPr>
-              <a:t>Crear EXACTAMENTE 3 Issues usando los templates de .github/ISSUE_TEMPLATE/:</a:t>
-            </a:r>
-          </a:p>
-        </p:txBody>
-      </p:sp>
-      <p:sp>
-        <p:nvSpPr>
-          <p:cNvPr id="7" name="TextBox 6"/>
+                  <a:srgbClr val="065A82"/>
+                </a:solidFill>
+                <a:latin typeface="Calibri"/>
+              </a:rPr>
+              <a:t>⚠️  Estos 3 Issues se crean en TU PROPIO repositorio, NO en el del docente.</a:t>
+            </a:r>
+          </a:p>
+        </p:txBody>
+      </p:sp>
+      <p:sp>
+        <p:nvSpPr>
+          <p:cNvPr id="8" name="TextBox 7"/>
           <p:cNvSpPr txBox="1"/>
           <p:nvPr/>
         </p:nvSpPr>
         <p:spPr>
           <a:xfrm>
-            <a:off x="822960" y="1783080"/>
-            <a:ext cx="10972800" cy="1097280"/>
+            <a:off x="640080" y="1920240"/>
+            <a:ext cx="10972800" cy="365760"/>
           </a:xfrm>
           <a:prstGeom prst="rect">
             <a:avLst/>
@@ -9392,13 +9635,48 @@
           <a:p>
             <a:pPr algn="l"/>
             <a:r>
+              <a:rPr sz="1500" b="1">
+                <a:solidFill>
+                  <a:srgbClr val="2A2A2A"/>
+                </a:solidFill>
+                <a:latin typeface="Calibri"/>
+              </a:rPr>
+              <a:t>Templates interactivos disponibles (en .github/ISSUE_TEMPLATE/):</a:t>
+            </a:r>
+          </a:p>
+        </p:txBody>
+      </p:sp>
+      <p:sp>
+        <p:nvSpPr>
+          <p:cNvPr id="9" name="TextBox 8"/>
+          <p:cNvSpPr txBox="1"/>
+          <p:nvPr/>
+        </p:nvSpPr>
+        <p:spPr>
+          <a:xfrm>
+            <a:off x="822960" y="2377440"/>
+            <a:ext cx="10972800" cy="1097280"/>
+          </a:xfrm>
+          <a:prstGeom prst="rect">
+            <a:avLst/>
+          </a:prstGeom>
+          <a:noFill/>
+        </p:spPr>
+        <p:txBody>
+          <a:bodyPr wrap="square">
+            <a:spAutoFit/>
+          </a:bodyPr>
+          <a:lstStyle/>
+          <a:p>
+            <a:pPr algn="l"/>
+            <a:r>
               <a:rPr sz="1400" b="0">
                 <a:solidFill>
                   <a:srgbClr val="2A2A2A"/>
                 </a:solidFill>
                 <a:latin typeface="Calibri"/>
               </a:rPr>
-              <a:t>📊 rendimiento.md     →  hallazgos de performance / Lighthouse</a:t>
+              <a:t>📊 rendimiento.yml     →  hallazgos de performance / Lighthouse</a:t>
             </a:r>
           </a:p>
           <a:p>
@@ -9410,7 +9688,7 @@
                 </a:solidFill>
                 <a:latin typeface="Calibri"/>
               </a:rPr>
-              <a:t>🔧 mantenimiento.md   →  hallazgos de dependencias / seguridad</a:t>
+              <a:t>🔧 mantenimiento.yml   →  hallazgos de dependencias / seguridad</a:t>
             </a:r>
           </a:p>
           <a:p>
@@ -9422,7 +9700,7 @@
                 </a:solidFill>
                 <a:latin typeface="Calibri"/>
               </a:rPr>
-              <a:t>♿ accesibilidad.md   →  hallazgos de axe DevTools</a:t>
+              <a:t>♿ accesibilidad.yml   →  hallazgos de axe DevTools</a:t>
             </a:r>
           </a:p>
           <a:p>
@@ -9434,21 +9712,21 @@
                 </a:solidFill>
                 <a:latin typeface="Calibri"/>
               </a:rPr>
-              <a:t>📝 general.md         →  cualquier otro hallazgo</a:t>
-            </a:r>
-          </a:p>
-        </p:txBody>
-      </p:sp>
-      <p:sp>
-        <p:nvSpPr>
-          <p:cNvPr id="8" name="Rounded Rectangle 7"/>
+              <a:t>📝 general.yml         →  cualquier otro hallazgo</a:t>
+            </a:r>
+          </a:p>
+        </p:txBody>
+      </p:sp>
+      <p:sp>
+        <p:nvSpPr>
+          <p:cNvPr id="10" name="Rounded Rectangle 9"/>
           <p:cNvSpPr/>
           <p:nvPr/>
         </p:nvSpPr>
         <p:spPr>
           <a:xfrm>
-            <a:off x="640080" y="3017520"/>
-            <a:ext cx="10972800" cy="2743200"/>
+            <a:off x="640080" y="3657600"/>
+            <a:ext cx="10972800" cy="2377440"/>
           </a:xfrm>
           <a:prstGeom prst="roundRect">
             <a:avLst/>
@@ -9486,14 +9764,14 @@
       </p:sp>
       <p:sp>
         <p:nvSpPr>
-          <p:cNvPr id="9" name="TextBox 8"/>
+          <p:cNvPr id="11" name="TextBox 10"/>
           <p:cNvSpPr txBox="1"/>
           <p:nvPr/>
         </p:nvSpPr>
         <p:spPr>
           <a:xfrm>
-            <a:off x="822960" y="3108960"/>
-            <a:ext cx="10607040" cy="2651760"/>
+            <a:off x="822960" y="3749039"/>
+            <a:ext cx="10607040" cy="2286000"/>
           </a:xfrm>
           <a:prstGeom prst="rect">
             <a:avLst/>
@@ -9514,7 +9792,7 @@
                 </a:solidFill>
                 <a:latin typeface="Calibri"/>
               </a:rPr>
-              <a:t>### Problema                |   ### Ubicación y reproducción</a:t>
+              <a:t>Cada template es un FORMULARIO INTERACTIVO con:</a:t>
             </a:r>
           </a:p>
           <a:p>
@@ -9526,7 +9804,7 @@
                 </a:solidFill>
                 <a:latin typeface="Calibri"/>
               </a:rPr>
-              <a:t>¿Qué encontraste?                    ¿Dónde? ¿Cómo comprobarlo?</a:t>
+              <a:t/>
             </a:r>
           </a:p>
           <a:p>
@@ -9538,19 +9816,19 @@
                 </a:solidFill>
                 <a:latin typeface="Calibri"/>
               </a:rPr>
-              <a:t/>
-            </a:r>
-          </a:p>
-          <a:p>
-            <a:pPr algn="l"/>
-            <a:r>
-              <a:rPr sz="1300" b="1">
+              <a:t>📝 Inputs  →  Problema, Ubicación, Concepto, Justificación</a:t>
+            </a:r>
+          </a:p>
+          <a:p>
+            <a:pPr algn="l"/>
+            <a:r>
+              <a:rPr sz="1300" b="0">
                 <a:solidFill>
                   <a:srgbClr val="FFFFFF"/>
                 </a:solidFill>
                 <a:latin typeface="Calibri"/>
               </a:rPr>
-              <a:t>### Evidencia                |   ### Concepto del curso</a:t>
+              <a:t>📄 Textareas  →  Evidencia, Impacto, Solución propuesta</a:t>
             </a:r>
           </a:p>
           <a:p>
@@ -9562,7 +9840,7 @@
                 </a:solidFill>
                 <a:latin typeface="Calibri"/>
               </a:rPr>
-              <a:t>Lighthouse / Network / axe / código   VIVO / RÁPIDO / SEGURO + concepto</a:t>
+              <a:t>🔽 Dropdowns  →  Pilar, Tipo de mantenimiento, Severidad</a:t>
             </a:r>
           </a:p>
           <a:p>
@@ -9574,90 +9852,33 @@
                 </a:solidFill>
                 <a:latin typeface="Calibri"/>
               </a:rPr>
-              <a:t/>
-            </a:r>
-          </a:p>
-          <a:p>
-            <a:pPr algn="l"/>
-            <a:r>
-              <a:rPr sz="1300" b="1">
+              <a:t>☑️ Checkboxes  →  Principios WCAG, Conceptos múltiples</a:t>
+            </a:r>
+          </a:p>
+          <a:p>
+            <a:pPr algn="l"/>
+            <a:r>
+              <a:rPr sz="1300" b="0">
                 <a:solidFill>
                   <a:srgbClr val="FFFFFF"/>
                 </a:solidFill>
                 <a:latin typeface="Calibri"/>
               </a:rPr>
-              <a:t>### Impacto                  |   ### Severidad  +  ### Solución propuesta</a:t>
-            </a:r>
-          </a:p>
-          <a:p>
-            <a:pPr algn="l"/>
-            <a:r>
-              <a:rPr sz="1300" b="0">
-                <a:solidFill>
-                  <a:srgbClr val="FFFFFF"/>
-                </a:solidFill>
-                <a:latin typeface="Calibri"/>
-              </a:rPr>
-              <a:t>¿A quién afecta?             Baja/Media/Alta + justificación   Describir en texto (no aplicar)</a:t>
-            </a:r>
-          </a:p>
-        </p:txBody>
-      </p:sp>
-      <p:sp>
-        <p:nvSpPr>
-          <p:cNvPr id="10" name="Rounded Rectangle 9"/>
-          <p:cNvSpPr/>
-          <p:nvPr/>
-        </p:nvSpPr>
-        <p:spPr>
-          <a:xfrm>
-            <a:off x="640080" y="5943600"/>
-            <a:ext cx="10972800" cy="457200"/>
-          </a:xfrm>
-          <a:prstGeom prst="roundRect">
-            <a:avLst/>
-          </a:prstGeom>
-          <a:solidFill>
-            <a:srgbClr val="FFF3CD"/>
-          </a:solidFill>
-          <a:ln>
-            <a:solidFill>
-              <a:srgbClr val="E6A23E"/>
-            </a:solidFill>
-          </a:ln>
-        </p:spPr>
-        <p:style>
-          <a:lnRef idx="1">
-            <a:schemeClr val="accent1"/>
-          </a:lnRef>
-          <a:fillRef idx="3">
-            <a:schemeClr val="accent1"/>
-          </a:fillRef>
-          <a:effectRef idx="2">
-            <a:schemeClr val="accent1"/>
-          </a:effectRef>
-          <a:fontRef idx="minor">
-            <a:schemeClr val="lt1"/>
-          </a:fontRef>
-        </p:style>
-        <p:txBody>
-          <a:bodyPr rtlCol="0" anchor="ctr"/>
-          <a:lstStyle/>
-          <a:p>
-            <a:pPr algn="ctr"/>
-          </a:p>
-        </p:txBody>
-      </p:sp>
-      <p:sp>
-        <p:nvSpPr>
-          <p:cNvPr id="11" name="TextBox 10"/>
+              <a:t>⚠️ Validación required  →  No se envía si está vacío</a:t>
+            </a:r>
+          </a:p>
+        </p:txBody>
+      </p:sp>
+      <p:sp>
+        <p:nvSpPr>
+          <p:cNvPr id="12" name="TextBox 11"/>
           <p:cNvSpPr txBox="1"/>
           <p:nvPr/>
         </p:nvSpPr>
         <p:spPr>
           <a:xfrm>
-            <a:off x="640080" y="5989320"/>
-            <a:ext cx="10972800" cy="365760"/>
+            <a:off x="457200" y="6446520"/>
+            <a:ext cx="7315200" cy="274320"/>
           </a:xfrm>
           <a:prstGeom prst="rect">
             <a:avLst/>
@@ -9670,41 +9891,6 @@
           </a:bodyPr>
           <a:lstStyle/>
           <a:p>
-            <a:pPr algn="ctr"/>
-            <a:r>
-              <a:rPr sz="1300" b="1">
-                <a:solidFill>
-                  <a:srgbClr val="924E0E"/>
-                </a:solidFill>
-                <a:latin typeface="Calibri"/>
-              </a:rPr>
-              <a:t>💡 La clasificación se evalúa por la explicación, no por la etiqueta exacta.</a:t>
-            </a:r>
-          </a:p>
-        </p:txBody>
-      </p:sp>
-      <p:sp>
-        <p:nvSpPr>
-          <p:cNvPr id="12" name="TextBox 11"/>
-          <p:cNvSpPr txBox="1"/>
-          <p:nvPr/>
-        </p:nvSpPr>
-        <p:spPr>
-          <a:xfrm>
-            <a:off x="457200" y="6446520"/>
-            <a:ext cx="6400800" cy="274320"/>
-          </a:xfrm>
-          <a:prstGeom prst="rect">
-            <a:avLst/>
-          </a:prstGeom>
-          <a:noFill/>
-        </p:spPr>
-        <p:txBody>
-          <a:bodyPr wrap="square">
-            <a:spAutoFit/>
-          </a:bodyPr>
-          <a:lstStyle/>
-          <a:p>
             <a:pPr algn="l"/>
             <a:r>
               <a:rPr sz="800" b="0">
@@ -9713,7 +9899,7 @@
                 </a:solidFill>
                 <a:latin typeface="Calibri"/>
               </a:rPr>
-              <a:t>📦 Repositorio: github.com/KrizRoMe/evaluacion-administracion-web   •   🌐 Sitio: krizrome.github.io/evaluacion-administracion-web</a:t>
+              <a:t>📦 Repo: github.com/KrizRoMe/evaluacion-administracion-web   •   🌐 Web: krizrome.github.io/evaluacion-administracion-web   •   📋 Issues: github.com/KrizRoMe/evaluacion-administracion-web/issues</a:t>
             </a:r>
           </a:p>
         </p:txBody>
@@ -9887,7 +10073,7 @@
                 </a:solidFill>
                 <a:latin typeface="Calibri"/>
               </a:rPr>
-              <a:t>Parte 5 · Documentar la solución</a:t>
+              <a:t>Parte 5 · Documentar solución + README</a:t>
             </a:r>
           </a:p>
         </p:txBody>
@@ -9922,7 +10108,7 @@
                 </a:solidFill>
                 <a:latin typeface="Calibri"/>
               </a:rPr>
-              <a:t>⏱ 10 minutos</a:t>
+              <a:t>⏱ 25 minutos  •  Sin tocar el código</a:t>
             </a:r>
           </a:p>
         </p:txBody>
@@ -9936,7 +10122,7 @@
         <p:spPr>
           <a:xfrm>
             <a:off x="640080" y="1280160"/>
-            <a:ext cx="10972800" cy="822960"/>
+            <a:ext cx="10972800" cy="640080"/>
           </a:xfrm>
           <a:prstGeom prst="roundRect">
             <a:avLst/>
@@ -9980,8 +10166,8 @@
         </p:nvSpPr>
         <p:spPr>
           <a:xfrm>
-            <a:off x="822960" y="1417320"/>
-            <a:ext cx="10607040" cy="548640"/>
+            <a:off x="822960" y="1371600"/>
+            <a:ext cx="10607040" cy="457200"/>
           </a:xfrm>
           <a:prstGeom prst="rect">
             <a:avLst/>
@@ -9994,16 +10180,15 @@
           </a:bodyPr>
           <a:lstStyle/>
           <a:p>
-            <a:pPr algn="l"/>
-            <a:r>
-              <a:rPr sz="1600" b="1">
+            <a:pPr algn="ctr"/>
+            <a:r>
+              <a:rPr sz="1400" b="1">
                 <a:solidFill>
                   <a:srgbClr val="924E0E"/>
                 </a:solidFill>
                 <a:latin typeface="Calibri"/>
               </a:rPr>
-              <a:t>⚠️  No es necesario aplicar las correcciones en el código.
-Lo que se evalúa es tu capacidad de ANALIZAR y PROPONER en texto.</a:t>
+              <a:t>⚠️  No es necesario aplicar las correcciones en el código. Solo ANALIZAR y PROPONER en texto.</a:t>
             </a:r>
           </a:p>
         </p:txBody>
@@ -10016,8 +10201,8 @@
         </p:nvSpPr>
         <p:spPr>
           <a:xfrm>
-            <a:off x="640080" y="2468880"/>
-            <a:ext cx="10972800" cy="457200"/>
+            <a:off x="640080" y="2103120"/>
+            <a:ext cx="10972800" cy="365760"/>
           </a:xfrm>
           <a:prstGeom prst="rect">
             <a:avLst/>
@@ -10032,13 +10217,13 @@
           <a:p>
             <a:pPr algn="l"/>
             <a:r>
-              <a:rPr sz="1800" b="1">
+              <a:rPr sz="1600" b="1">
                 <a:solidFill>
                   <a:srgbClr val="065A82"/>
                 </a:solidFill>
                 <a:latin typeface="Calibri"/>
               </a:rPr>
-              <a:t>Ejemplos de soluciones propuestas (en texto, no aplicar):</a:t>
+              <a:t>En cada Issue, completa la sección Solución propuesta:</a:t>
             </a:r>
           </a:p>
         </p:txBody>
@@ -10051,8 +10236,8 @@
         </p:nvSpPr>
         <p:spPr>
           <a:xfrm>
-            <a:off x="822960" y="3017520"/>
-            <a:ext cx="10972800" cy="2926080"/>
+            <a:off x="822960" y="2560320"/>
+            <a:ext cx="10972800" cy="1828800"/>
           </a:xfrm>
           <a:prstGeom prst="rect">
             <a:avLst/>
@@ -10067,7 +10252,7 @@
           <a:p>
             <a:pPr algn="l"/>
             <a:r>
-              <a:rPr sz="1400" b="0">
+              <a:rPr sz="1300" b="0">
                 <a:solidFill>
                   <a:srgbClr val="2A2A2A"/>
                 </a:solidFill>
@@ -10079,7 +10264,7 @@
           <a:p>
             <a:pPr algn="l"/>
             <a:r>
-              <a:rPr sz="1400" b="0">
+              <a:rPr sz="1300" b="0">
                 <a:solidFill>
                   <a:srgbClr val="2A2A2A"/>
                 </a:solidFill>
@@ -10091,7 +10276,7 @@
           <a:p>
             <a:pPr algn="l"/>
             <a:r>
-              <a:rPr sz="1400" b="0">
+              <a:rPr sz="1300" b="0">
                 <a:solidFill>
                   <a:srgbClr val="2A2A2A"/>
                 </a:solidFill>
@@ -10103,7 +10288,7 @@
           <a:p>
             <a:pPr algn="l"/>
             <a:r>
-              <a:rPr sz="1400" b="0">
+              <a:rPr sz="1300" b="0">
                 <a:solidFill>
                   <a:srgbClr val="2A2A2A"/>
                 </a:solidFill>
@@ -10115,7 +10300,7 @@
           <a:p>
             <a:pPr algn="l"/>
             <a:r>
-              <a:rPr sz="1400" b="0">
+              <a:rPr sz="1300" b="0">
                 <a:solidFill>
                   <a:srgbClr val="2A2A2A"/>
                 </a:solidFill>
@@ -10128,14 +10313,59 @@
       </p:sp>
       <p:sp>
         <p:nvSpPr>
-          <p:cNvPr id="10" name="TextBox 9"/>
+          <p:cNvPr id="10" name="Rounded Rectangle 9"/>
+          <p:cNvSpPr/>
+          <p:nvPr/>
+        </p:nvSpPr>
+        <p:spPr>
+          <a:xfrm>
+            <a:off x="640080" y="4572000"/>
+            <a:ext cx="10972800" cy="1737360"/>
+          </a:xfrm>
+          <a:prstGeom prst="roundRect">
+            <a:avLst/>
+          </a:prstGeom>
+          <a:solidFill>
+            <a:srgbClr val="E3F2FD"/>
+          </a:solidFill>
+          <a:ln>
+            <a:solidFill>
+              <a:srgbClr val="1C7293"/>
+            </a:solidFill>
+          </a:ln>
+        </p:spPr>
+        <p:style>
+          <a:lnRef idx="1">
+            <a:schemeClr val="accent1"/>
+          </a:lnRef>
+          <a:fillRef idx="3">
+            <a:schemeClr val="accent1"/>
+          </a:fillRef>
+          <a:effectRef idx="2">
+            <a:schemeClr val="accent1"/>
+          </a:effectRef>
+          <a:fontRef idx="minor">
+            <a:schemeClr val="lt1"/>
+          </a:fontRef>
+        </p:style>
+        <p:txBody>
+          <a:bodyPr rtlCol="0" anchor="ctr"/>
+          <a:lstStyle/>
+          <a:p>
+            <a:pPr algn="ctr"/>
+          </a:p>
+        </p:txBody>
+      </p:sp>
+      <p:sp>
+        <p:nvSpPr>
+          <p:cNvPr id="11" name="TextBox 10"/>
           <p:cNvSpPr txBox="1"/>
           <p:nvPr/>
         </p:nvSpPr>
         <p:spPr>
           <a:xfrm>
-            <a:off x="457200" y="6446520"/>
-            <a:ext cx="6400800" cy="274320"/>
+            <a:off x="822960" y="4617720"/>
+            <a:ext cx="10607040" cy="274320"/>
           </a:xfrm>
           <a:prstGeom prst="rect">
             <a:avLst/>
@@ -10150,20 +10380,90 @@
           <a:p>
             <a:pPr algn="l"/>
             <a:r>
+              <a:rPr sz="1400" b="1">
+                <a:solidFill>
+                  <a:srgbClr val="065A82"/>
+                </a:solidFill>
+                <a:latin typeface="Calibri"/>
+              </a:rPr>
+              <a:t>📚 README debe incluir:</a:t>
+            </a:r>
+          </a:p>
+        </p:txBody>
+      </p:sp>
+      <p:sp>
+        <p:nvSpPr>
+          <p:cNvPr id="12" name="TextBox 11"/>
+          <p:cNvSpPr txBox="1"/>
+          <p:nvPr/>
+        </p:nvSpPr>
+        <p:spPr>
+          <a:xfrm>
+            <a:off x="914400" y="4937760"/>
+            <a:ext cx="10424160" cy="1371600"/>
+          </a:xfrm>
+          <a:prstGeom prst="rect">
+            <a:avLst/>
+          </a:prstGeom>
+          <a:noFill/>
+        </p:spPr>
+        <p:txBody>
+          <a:bodyPr wrap="square">
+            <a:spAutoFit/>
+          </a:bodyPr>
+          <a:lstStyle/>
+          <a:p>
+            <a:pPr algn="l"/>
+            <a:r>
+              <a:rPr sz="1200" b="0">
+                <a:solidFill>
+                  <a:srgbClr val="2A2A2A"/>
+                </a:solidFill>
+                <a:latin typeface="Calibri"/>
+              </a:rPr>
+              <a:t>VIVO • RÁPIDO (con LCP/INP/CLS/TTFB) • SEGURO (2 acciones) • Backup 3-2-1 • SLI • SLO • SLA • Runbook (4–6 pasos) • Datos del estudiante + URLs</a:t>
+            </a:r>
+          </a:p>
+        </p:txBody>
+      </p:sp>
+      <p:sp>
+        <p:nvSpPr>
+          <p:cNvPr id="13" name="TextBox 12"/>
+          <p:cNvSpPr txBox="1"/>
+          <p:nvPr/>
+        </p:nvSpPr>
+        <p:spPr>
+          <a:xfrm>
+            <a:off x="457200" y="6446520"/>
+            <a:ext cx="7315200" cy="274320"/>
+          </a:xfrm>
+          <a:prstGeom prst="rect">
+            <a:avLst/>
+          </a:prstGeom>
+          <a:noFill/>
+        </p:spPr>
+        <p:txBody>
+          <a:bodyPr wrap="square">
+            <a:spAutoFit/>
+          </a:bodyPr>
+          <a:lstStyle/>
+          <a:p>
+            <a:pPr algn="l"/>
+            <a:r>
               <a:rPr sz="800" b="0">
                 <a:solidFill>
                   <a:srgbClr val="666666"/>
                 </a:solidFill>
                 <a:latin typeface="Calibri"/>
               </a:rPr>
-              <a:t>📦 Repositorio: github.com/KrizRoMe/evaluacion-administracion-web   •   🌐 Sitio: krizrome.github.io/evaluacion-administracion-web</a:t>
-            </a:r>
-          </a:p>
-        </p:txBody>
-      </p:sp>
-      <p:sp>
-        <p:nvSpPr>
-          <p:cNvPr id="11" name="TextBox 10"/>
+              <a:t>📦 Repo: github.com/KrizRoMe/evaluacion-administracion-web   •   🌐 Web: krizrome.github.io/evaluacion-administracion-web   •   📋 Issues: github.com/KrizRoMe/evaluacion-administracion-web/issues</a:t>
+            </a:r>
+          </a:p>
+        </p:txBody>
+      </p:sp>
+      <p:sp>
+        <p:nvSpPr>
+          <p:cNvPr id="14" name="TextBox 13"/>
           <p:cNvSpPr txBox="1"/>
           <p:nvPr/>
         </p:nvSpPr>

</xml_diff>

<commit_message>
fix(ppt): corregir bug de URLs rotadas 180°
Causa: la función add_url_box generaba textboxes con cy negativo
cuando la altura calculada era menor al padding. PowerPoint interpretaba
el cy negativo como una rotación vertical.

Fix:
- Garantizar h mínimo de 0.9 in en add_url_box
- Garantizar h mínimo de 0.3 in en add_text/add_multiline
- Recalcular explícitamente la posición de la URL dentro de la caja

Verificado: grep de 'cy="-[0-9]' no devuelve coincidencias.
</commit_message>
<xml_diff>
--- a/EVALUACION_PRACTICA_01.pptx
+++ b/EVALUACION_PRACTICA_01.pptx
@@ -3310,7 +3310,7 @@
         <p:spPr>
           <a:xfrm>
             <a:off x="914400" y="4846320"/>
-            <a:ext cx="10332720" cy="640080"/>
+            <a:ext cx="10332720" cy="822960"/>
           </a:xfrm>
           <a:prstGeom prst="roundRect">
             <a:avLst/>
@@ -3354,8 +3354,8 @@
         </p:nvSpPr>
         <p:spPr>
           <a:xfrm>
-            <a:off x="1097280" y="4983480"/>
-            <a:ext cx="9966960" cy="457200"/>
+            <a:off x="1097280" y="4937759"/>
+            <a:ext cx="9966960" cy="365760"/>
           </a:xfrm>
           <a:prstGeom prst="rect">
             <a:avLst/>
@@ -3370,7 +3370,7 @@
           <a:p>
             <a:pPr algn="l"/>
             <a:r>
-              <a:rPr sz="1600" b="1">
+              <a:rPr sz="1400" b="1">
                 <a:solidFill>
                   <a:srgbClr val="065A82"/>
                 </a:solidFill>
@@ -3389,8 +3389,8 @@
         </p:nvSpPr>
         <p:spPr>
           <a:xfrm>
-            <a:off x="1097280" y="5486400"/>
-            <a:ext cx="9966960" cy="-91440"/>
+            <a:off x="1097280" y="5349240"/>
+            <a:ext cx="9966960" cy="274320"/>
           </a:xfrm>
           <a:prstGeom prst="rect">
             <a:avLst/>
@@ -3424,8 +3424,8 @@
         </p:nvSpPr>
         <p:spPr>
           <a:xfrm>
-            <a:off x="914400" y="5532120"/>
-            <a:ext cx="10332720" cy="640080"/>
+            <a:off x="914400" y="5577840"/>
+            <a:ext cx="10332720" cy="822960"/>
           </a:xfrm>
           <a:prstGeom prst="roundRect">
             <a:avLst/>
@@ -3469,8 +3469,8 @@
         </p:nvSpPr>
         <p:spPr>
           <a:xfrm>
-            <a:off x="1097280" y="5669280"/>
-            <a:ext cx="9966960" cy="457200"/>
+            <a:off x="1097280" y="5669279"/>
+            <a:ext cx="9966960" cy="365760"/>
           </a:xfrm>
           <a:prstGeom prst="rect">
             <a:avLst/>
@@ -3485,7 +3485,7 @@
           <a:p>
             <a:pPr algn="l"/>
             <a:r>
-              <a:rPr sz="1600" b="1">
+              <a:rPr sz="1400" b="1">
                 <a:solidFill>
                   <a:srgbClr val="065A82"/>
                 </a:solidFill>
@@ -3504,8 +3504,8 @@
         </p:nvSpPr>
         <p:spPr>
           <a:xfrm>
-            <a:off x="1097280" y="6172200"/>
-            <a:ext cx="9966960" cy="-91440"/>
+            <a:off x="1097280" y="6080759"/>
+            <a:ext cx="9966960" cy="274320"/>
           </a:xfrm>
           <a:prstGeom prst="rect">
             <a:avLst/>
@@ -4074,7 +4074,7 @@
         <p:spPr>
           <a:xfrm>
             <a:off x="457200" y="6446520"/>
-            <a:ext cx="7315200" cy="274320"/>
+            <a:ext cx="10515600" cy="274320"/>
           </a:xfrm>
           <a:prstGeom prst="rect">
             <a:avLst/>
@@ -4108,8 +4108,8 @@
         </p:nvSpPr>
         <p:spPr>
           <a:xfrm>
-            <a:off x="10972800" y="6446520"/>
-            <a:ext cx="914400" cy="274320"/>
+            <a:off x="11155680" y="6446520"/>
+            <a:ext cx="731520" cy="274320"/>
           </a:xfrm>
           <a:prstGeom prst="rect">
             <a:avLst/>
@@ -4750,7 +4750,7 @@
         <p:spPr>
           <a:xfrm>
             <a:off x="457200" y="6446520"/>
-            <a:ext cx="7315200" cy="274320"/>
+            <a:ext cx="10515600" cy="274320"/>
           </a:xfrm>
           <a:prstGeom prst="rect">
             <a:avLst/>
@@ -4784,8 +4784,8 @@
         </p:nvSpPr>
         <p:spPr>
           <a:xfrm>
-            <a:off x="10972800" y="6446520"/>
-            <a:ext cx="914400" cy="274320"/>
+            <a:off x="11155680" y="6446520"/>
+            <a:ext cx="731520" cy="274320"/>
           </a:xfrm>
           <a:prstGeom prst="rect">
             <a:avLst/>
@@ -5300,7 +5300,7 @@
         <p:spPr>
           <a:xfrm>
             <a:off x="457200" y="6446520"/>
-            <a:ext cx="7315200" cy="274320"/>
+            <a:ext cx="10515600" cy="274320"/>
           </a:xfrm>
           <a:prstGeom prst="rect">
             <a:avLst/>
@@ -5334,8 +5334,8 @@
         </p:nvSpPr>
         <p:spPr>
           <a:xfrm>
-            <a:off x="10972800" y="6446520"/>
-            <a:ext cx="914400" cy="274320"/>
+            <a:off x="11155680" y="6446520"/>
+            <a:ext cx="731520" cy="274320"/>
           </a:xfrm>
           <a:prstGeom prst="rect">
             <a:avLst/>
@@ -5544,7 +5544,7 @@
         <p:spPr>
           <a:xfrm>
             <a:off x="640080" y="1188720"/>
-            <a:ext cx="10972800" cy="365760"/>
+            <a:ext cx="10972800" cy="457200"/>
           </a:xfrm>
           <a:prstGeom prst="rect">
             <a:avLst/>
@@ -5579,7 +5579,7 @@
         <p:spPr>
           <a:xfrm>
             <a:off x="640080" y="1600200"/>
-            <a:ext cx="10972800" cy="640080"/>
+            <a:ext cx="10972800" cy="822960"/>
           </a:xfrm>
           <a:prstGeom prst="roundRect">
             <a:avLst/>
@@ -5623,8 +5623,8 @@
         </p:nvSpPr>
         <p:spPr>
           <a:xfrm>
-            <a:off x="822959" y="1737360"/>
-            <a:ext cx="10607040" cy="457200"/>
+            <a:off x="822959" y="1691640"/>
+            <a:ext cx="10607040" cy="365760"/>
           </a:xfrm>
           <a:prstGeom prst="rect">
             <a:avLst/>
@@ -5639,7 +5639,7 @@
           <a:p>
             <a:pPr algn="l"/>
             <a:r>
-              <a:rPr sz="1600" b="1">
+              <a:rPr sz="1400" b="1">
                 <a:solidFill>
                   <a:srgbClr val="10B981"/>
                 </a:solidFill>
@@ -5658,8 +5658,8 @@
         </p:nvSpPr>
         <p:spPr>
           <a:xfrm>
-            <a:off x="822959" y="2240280"/>
-            <a:ext cx="10607040" cy="-91440"/>
+            <a:off x="822959" y="2103120"/>
+            <a:ext cx="10607040" cy="274320"/>
           </a:xfrm>
           <a:prstGeom prst="rect">
             <a:avLst/>
@@ -5693,8 +5693,8 @@
         </p:nvSpPr>
         <p:spPr>
           <a:xfrm>
-            <a:off x="640080" y="2423160"/>
-            <a:ext cx="10972800" cy="365760"/>
+            <a:off x="640080" y="2468880"/>
+            <a:ext cx="10972800" cy="457200"/>
           </a:xfrm>
           <a:prstGeom prst="rect">
             <a:avLst/>
@@ -5728,8 +5728,8 @@
         </p:nvSpPr>
         <p:spPr>
           <a:xfrm>
-            <a:off x="640080" y="2834640"/>
-            <a:ext cx="10972800" cy="640080"/>
+            <a:off x="640080" y="2880360"/>
+            <a:ext cx="10972800" cy="822960"/>
           </a:xfrm>
           <a:prstGeom prst="roundRect">
             <a:avLst/>
@@ -5774,7 +5774,7 @@
         <p:spPr>
           <a:xfrm>
             <a:off x="822959" y="2971800"/>
-            <a:ext cx="10607040" cy="457200"/>
+            <a:ext cx="10607040" cy="365760"/>
           </a:xfrm>
           <a:prstGeom prst="rect">
             <a:avLst/>
@@ -5789,7 +5789,7 @@
           <a:p>
             <a:pPr algn="l"/>
             <a:r>
-              <a:rPr sz="1600" b="1">
+              <a:rPr sz="1400" b="1">
                 <a:solidFill>
                   <a:srgbClr val="1C7293"/>
                 </a:solidFill>
@@ -5808,8 +5808,8 @@
         </p:nvSpPr>
         <p:spPr>
           <a:xfrm>
-            <a:off x="822959" y="3474720"/>
-            <a:ext cx="10607040" cy="-91440"/>
+            <a:off x="822959" y="3383279"/>
+            <a:ext cx="10607040" cy="274320"/>
           </a:xfrm>
           <a:prstGeom prst="rect">
             <a:avLst/>
@@ -5824,7 +5824,7 @@
           <a:p>
             <a:pPr algn="l"/>
             <a:r>
-              <a:rPr sz="1400" b="0">
+              <a:rPr sz="1200" b="0">
                 <a:solidFill>
                   <a:srgbClr val="2A2A2A"/>
                 </a:solidFill>
@@ -5843,8 +5843,8 @@
         </p:nvSpPr>
         <p:spPr>
           <a:xfrm>
-            <a:off x="640080" y="3657600"/>
-            <a:ext cx="10972800" cy="365760"/>
+            <a:off x="640080" y="3749039"/>
+            <a:ext cx="10972800" cy="457200"/>
           </a:xfrm>
           <a:prstGeom prst="rect">
             <a:avLst/>
@@ -5878,8 +5878,8 @@
         </p:nvSpPr>
         <p:spPr>
           <a:xfrm>
-            <a:off x="640080" y="4069080"/>
-            <a:ext cx="10972800" cy="640080"/>
+            <a:off x="640080" y="4160520"/>
+            <a:ext cx="10972800" cy="822960"/>
           </a:xfrm>
           <a:prstGeom prst="roundRect">
             <a:avLst/>
@@ -5923,8 +5923,8 @@
         </p:nvSpPr>
         <p:spPr>
           <a:xfrm>
-            <a:off x="822959" y="4206240"/>
-            <a:ext cx="10607040" cy="457200"/>
+            <a:off x="822959" y="4251959"/>
+            <a:ext cx="10607040" cy="365760"/>
           </a:xfrm>
           <a:prstGeom prst="rect">
             <a:avLst/>
@@ -5939,7 +5939,7 @@
           <a:p>
             <a:pPr algn="l"/>
             <a:r>
-              <a:rPr sz="1600" b="1">
+              <a:rPr sz="1400" b="1">
                 <a:solidFill>
                   <a:srgbClr val="10B981"/>
                 </a:solidFill>
@@ -5958,8 +5958,8 @@
         </p:nvSpPr>
         <p:spPr>
           <a:xfrm>
-            <a:off x="822959" y="4709160"/>
-            <a:ext cx="10607040" cy="-91440"/>
+            <a:off x="822959" y="4663440"/>
+            <a:ext cx="10607040" cy="274320"/>
           </a:xfrm>
           <a:prstGeom prst="rect">
             <a:avLst/>
@@ -5993,8 +5993,8 @@
         </p:nvSpPr>
         <p:spPr>
           <a:xfrm>
-            <a:off x="640080" y="4892040"/>
-            <a:ext cx="10972800" cy="365760"/>
+            <a:off x="640080" y="5029200"/>
+            <a:ext cx="10972800" cy="457200"/>
           </a:xfrm>
           <a:prstGeom prst="rect">
             <a:avLst/>
@@ -6028,8 +6028,8 @@
         </p:nvSpPr>
         <p:spPr>
           <a:xfrm>
-            <a:off x="640080" y="5303520"/>
-            <a:ext cx="10972800" cy="777240"/>
+            <a:off x="640080" y="5440680"/>
+            <a:ext cx="10972800" cy="822960"/>
           </a:xfrm>
           <a:prstGeom prst="roundRect">
             <a:avLst/>
@@ -6073,8 +6073,8 @@
         </p:nvSpPr>
         <p:spPr>
           <a:xfrm>
-            <a:off x="822959" y="5440680"/>
-            <a:ext cx="10607040" cy="457200"/>
+            <a:off x="822959" y="5532120"/>
+            <a:ext cx="10607040" cy="365760"/>
           </a:xfrm>
           <a:prstGeom prst="rect">
             <a:avLst/>
@@ -6089,7 +6089,7 @@
           <a:p>
             <a:pPr algn="l"/>
             <a:r>
-              <a:rPr sz="1600" b="1">
+              <a:rPr sz="1400" b="1">
                 <a:solidFill>
                   <a:srgbClr val="EA580C"/>
                 </a:solidFill>
@@ -6109,7 +6109,7 @@
         <p:spPr>
           <a:xfrm>
             <a:off x="822959" y="5943600"/>
-            <a:ext cx="10607040" cy="45719"/>
+            <a:ext cx="10607040" cy="274320"/>
           </a:xfrm>
           <a:prstGeom prst="rect">
             <a:avLst/>
@@ -6137,46 +6137,36 @@
       </p:sp>
       <p:sp>
         <p:nvSpPr>
-          <p:cNvPr id="22" name="Rounded Rectangle 21"/>
-          <p:cNvSpPr/>
-          <p:nvPr/>
-        </p:nvSpPr>
-        <p:spPr>
-          <a:xfrm>
-            <a:off x="640080" y="6172200"/>
-            <a:ext cx="10972800" cy="274320"/>
-          </a:xfrm>
-          <a:prstGeom prst="roundRect">
-            <a:avLst/>
-          </a:prstGeom>
-          <a:solidFill>
-            <a:srgbClr val="FFF3CD"/>
-          </a:solidFill>
-          <a:ln>
-            <a:solidFill>
-              <a:srgbClr val="E6A23E"/>
-            </a:solidFill>
-          </a:ln>
-        </p:spPr>
-        <p:style>
-          <a:lnRef idx="1">
-            <a:schemeClr val="accent1"/>
-          </a:lnRef>
-          <a:fillRef idx="3">
-            <a:schemeClr val="accent1"/>
-          </a:fillRef>
-          <a:effectRef idx="2">
-            <a:schemeClr val="accent1"/>
-          </a:effectRef>
-          <a:fontRef idx="minor">
-            <a:schemeClr val="lt1"/>
-          </a:fontRef>
-        </p:style>
-        <p:txBody>
-          <a:bodyPr rtlCol="0" anchor="ctr"/>
-          <a:lstStyle/>
-          <a:p>
-            <a:pPr algn="ctr"/>
+          <p:cNvPr id="22" name="TextBox 21"/>
+          <p:cNvSpPr txBox="1"/>
+          <p:nvPr/>
+        </p:nvSpPr>
+        <p:spPr>
+          <a:xfrm>
+            <a:off x="457200" y="6446520"/>
+            <a:ext cx="10515600" cy="274320"/>
+          </a:xfrm>
+          <a:prstGeom prst="rect">
+            <a:avLst/>
+          </a:prstGeom>
+          <a:noFill/>
+        </p:spPr>
+        <p:txBody>
+          <a:bodyPr wrap="square">
+            <a:spAutoFit/>
+          </a:bodyPr>
+          <a:lstStyle/>
+          <a:p>
+            <a:pPr algn="l"/>
+            <a:r>
+              <a:rPr sz="800" b="0">
+                <a:solidFill>
+                  <a:srgbClr val="666666"/>
+                </a:solidFill>
+                <a:latin typeface="Calibri"/>
+              </a:rPr>
+              <a:t>📦 Repo: github.com/KrizRoMe/evaluacion-administracion-web   •   🌐 Web: krizrome.github.io/evaluacion-administracion-web   •   📋 Issues: github.com/KrizRoMe/evaluacion-administracion-web/issues</a:t>
+            </a:r>
           </a:p>
         </p:txBody>
       </p:sp>
@@ -6188,78 +6178,8 @@
         </p:nvSpPr>
         <p:spPr>
           <a:xfrm>
-            <a:off x="640080" y="6217920"/>
-            <a:ext cx="10972800" cy="182880"/>
-          </a:xfrm>
-          <a:prstGeom prst="rect">
-            <a:avLst/>
-          </a:prstGeom>
-          <a:noFill/>
-        </p:spPr>
-        <p:txBody>
-          <a:bodyPr wrap="square">
-            <a:spAutoFit/>
-          </a:bodyPr>
-          <a:lstStyle/>
-          <a:p>
-            <a:pPr algn="ctr"/>
-            <a:r>
-              <a:rPr sz="1100" b="1">
-                <a:solidFill>
-                  <a:srgbClr val="924E0E"/>
-                </a:solidFill>
-                <a:latin typeface="Calibri"/>
-              </a:rPr>
-              <a:t>📌  Los 3 hallazgos se documentan como Issues EN TU REPO.  La entrega final se hace como Issue AQUÍ.</a:t>
-            </a:r>
-          </a:p>
-        </p:txBody>
-      </p:sp>
-      <p:sp>
-        <p:nvSpPr>
-          <p:cNvPr id="24" name="TextBox 23"/>
-          <p:cNvSpPr txBox="1"/>
-          <p:nvPr/>
-        </p:nvSpPr>
-        <p:spPr>
-          <a:xfrm>
-            <a:off x="457200" y="6446520"/>
-            <a:ext cx="7315200" cy="274320"/>
-          </a:xfrm>
-          <a:prstGeom prst="rect">
-            <a:avLst/>
-          </a:prstGeom>
-          <a:noFill/>
-        </p:spPr>
-        <p:txBody>
-          <a:bodyPr wrap="square">
-            <a:spAutoFit/>
-          </a:bodyPr>
-          <a:lstStyle/>
-          <a:p>
-            <a:pPr algn="l"/>
-            <a:r>
-              <a:rPr sz="800" b="0">
-                <a:solidFill>
-                  <a:srgbClr val="666666"/>
-                </a:solidFill>
-                <a:latin typeface="Calibri"/>
-              </a:rPr>
-              <a:t>📦 Repo: github.com/KrizRoMe/evaluacion-administracion-web   •   🌐 Web: krizrome.github.io/evaluacion-administracion-web   •   📋 Issues: github.com/KrizRoMe/evaluacion-administracion-web/issues</a:t>
-            </a:r>
-          </a:p>
-        </p:txBody>
-      </p:sp>
-      <p:sp>
-        <p:nvSpPr>
-          <p:cNvPr id="25" name="TextBox 24"/>
-          <p:cNvSpPr txBox="1"/>
-          <p:nvPr/>
-        </p:nvSpPr>
-        <p:spPr>
-          <a:xfrm>
-            <a:off x="10972800" y="6446520"/>
-            <a:ext cx="914400" cy="274320"/>
+            <a:off x="11155680" y="6446520"/>
+            <a:ext cx="731520" cy="274320"/>
           </a:xfrm>
           <a:prstGeom prst="rect">
             <a:avLst/>
@@ -7440,7 +7360,7 @@
         <p:spPr>
           <a:xfrm>
             <a:off x="457200" y="6446520"/>
-            <a:ext cx="7315200" cy="274320"/>
+            <a:ext cx="10515600" cy="274320"/>
           </a:xfrm>
           <a:prstGeom prst="rect">
             <a:avLst/>
@@ -7474,8 +7394,8 @@
         </p:nvSpPr>
         <p:spPr>
           <a:xfrm>
-            <a:off x="10972800" y="6446520"/>
-            <a:ext cx="914400" cy="274320"/>
+            <a:off x="11155680" y="6446520"/>
+            <a:ext cx="731520" cy="274320"/>
           </a:xfrm>
           <a:prstGeom prst="rect">
             <a:avLst/>
@@ -8071,7 +7991,7 @@
         <p:spPr>
           <a:xfrm>
             <a:off x="457200" y="6446520"/>
-            <a:ext cx="7315200" cy="274320"/>
+            <a:ext cx="10515600" cy="274320"/>
           </a:xfrm>
           <a:prstGeom prst="rect">
             <a:avLst/>
@@ -8105,8 +8025,8 @@
         </p:nvSpPr>
         <p:spPr>
           <a:xfrm>
-            <a:off x="10972800" y="6446520"/>
-            <a:ext cx="914400" cy="274320"/>
+            <a:off x="11155680" y="6446520"/>
+            <a:ext cx="731520" cy="274320"/>
           </a:xfrm>
           <a:prstGeom prst="rect">
             <a:avLst/>
@@ -8619,7 +8539,7 @@
         <p:spPr>
           <a:xfrm>
             <a:off x="457200" y="6446520"/>
-            <a:ext cx="7315200" cy="274320"/>
+            <a:ext cx="10515600" cy="274320"/>
           </a:xfrm>
           <a:prstGeom prst="rect">
             <a:avLst/>
@@ -8653,8 +8573,8 @@
         </p:nvSpPr>
         <p:spPr>
           <a:xfrm>
-            <a:off x="10972800" y="6446520"/>
-            <a:ext cx="914400" cy="274320"/>
+            <a:off x="11155680" y="6446520"/>
+            <a:ext cx="731520" cy="274320"/>
           </a:xfrm>
           <a:prstGeom prst="rect">
             <a:avLst/>
@@ -9296,7 +9216,7 @@
         <p:spPr>
           <a:xfrm>
             <a:off x="457200" y="6446520"/>
-            <a:ext cx="7315200" cy="274320"/>
+            <a:ext cx="10515600" cy="274320"/>
           </a:xfrm>
           <a:prstGeom prst="rect">
             <a:avLst/>
@@ -9330,8 +9250,8 @@
         </p:nvSpPr>
         <p:spPr>
           <a:xfrm>
-            <a:off x="10972800" y="6446520"/>
-            <a:ext cx="914400" cy="274320"/>
+            <a:off x="11155680" y="6446520"/>
+            <a:ext cx="731520" cy="274320"/>
           </a:xfrm>
           <a:prstGeom prst="rect">
             <a:avLst/>
@@ -9620,7 +9540,7 @@
         <p:spPr>
           <a:xfrm>
             <a:off x="640080" y="1920240"/>
-            <a:ext cx="10972800" cy="365760"/>
+            <a:ext cx="10972800" cy="457200"/>
           </a:xfrm>
           <a:prstGeom prst="rect">
             <a:avLst/>
@@ -9878,7 +9798,7 @@
         <p:spPr>
           <a:xfrm>
             <a:off x="457200" y="6446520"/>
-            <a:ext cx="7315200" cy="274320"/>
+            <a:ext cx="10515600" cy="274320"/>
           </a:xfrm>
           <a:prstGeom prst="rect">
             <a:avLst/>
@@ -9912,8 +9832,8 @@
         </p:nvSpPr>
         <p:spPr>
           <a:xfrm>
-            <a:off x="10972800" y="6446520"/>
-            <a:ext cx="914400" cy="274320"/>
+            <a:off x="11155680" y="6446520"/>
+            <a:ext cx="731520" cy="274320"/>
           </a:xfrm>
           <a:prstGeom prst="rect">
             <a:avLst/>
@@ -10421,7 +10341,7 @@
                 </a:solidFill>
                 <a:latin typeface="Calibri"/>
               </a:rPr>
-              <a:t>VIVO • RÁPIDO (con LCP/INP/CLS/TTFB) • SEGURO (2 acciones) • Backup 3-2-1 • SLI • SLO • SLA • Runbook (4–6 pasos) • Datos del estudiante + URLs</a:t>
+              <a:t>VIVO · RÁPIDO (con LCP/INP/CLS/TTFB) · SEGURO (2 acciones) · Backup 3-2-1 · SLI · SLO · SLA · Runbook (4–6 pasos) · Datos del estudiante + URLs</a:t>
             </a:r>
           </a:p>
         </p:txBody>
@@ -10435,7 +10355,7 @@
         <p:spPr>
           <a:xfrm>
             <a:off x="457200" y="6446520"/>
-            <a:ext cx="7315200" cy="274320"/>
+            <a:ext cx="10515600" cy="274320"/>
           </a:xfrm>
           <a:prstGeom prst="rect">
             <a:avLst/>
@@ -10469,8 +10389,8 @@
         </p:nvSpPr>
         <p:spPr>
           <a:xfrm>
-            <a:off x="10972800" y="6446520"/>
-            <a:ext cx="914400" cy="274320"/>
+            <a:off x="11155680" y="6446520"/>
+            <a:ext cx="731520" cy="274320"/>
           </a:xfrm>
           <a:prstGeom prst="rect">
             <a:avLst/>

</xml_diff>

<commit_message>
fix: URLs ya no rotadas 180°
</commit_message>
<xml_diff>
--- a/EVALUACION_PRACTICA_01.pptx
+++ b/EVALUACION_PRACTICA_01.pptx
@@ -3310,7 +3310,7 @@
         <p:spPr>
           <a:xfrm>
             <a:off x="914400" y="4846320"/>
-            <a:ext cx="10332720" cy="640080"/>
+            <a:ext cx="10332720" cy="822960"/>
           </a:xfrm>
           <a:prstGeom prst="roundRect">
             <a:avLst/>
@@ -3354,8 +3354,8 @@
         </p:nvSpPr>
         <p:spPr>
           <a:xfrm>
-            <a:off x="1097280" y="4983480"/>
-            <a:ext cx="9966960" cy="457200"/>
+            <a:off x="1097280" y="4937759"/>
+            <a:ext cx="9966960" cy="365760"/>
           </a:xfrm>
           <a:prstGeom prst="rect">
             <a:avLst/>
@@ -3370,7 +3370,7 @@
           <a:p>
             <a:pPr algn="l"/>
             <a:r>
-              <a:rPr sz="1600" b="1">
+              <a:rPr sz="1400" b="1">
                 <a:solidFill>
                   <a:srgbClr val="065A82"/>
                 </a:solidFill>
@@ -3389,8 +3389,8 @@
         </p:nvSpPr>
         <p:spPr>
           <a:xfrm>
-            <a:off x="1097280" y="5486400"/>
-            <a:ext cx="9966960" cy="-91440"/>
+            <a:off x="1097280" y="5349240"/>
+            <a:ext cx="9966960" cy="274320"/>
           </a:xfrm>
           <a:prstGeom prst="rect">
             <a:avLst/>
@@ -3424,8 +3424,8 @@
         </p:nvSpPr>
         <p:spPr>
           <a:xfrm>
-            <a:off x="914400" y="5532120"/>
-            <a:ext cx="10332720" cy="640080"/>
+            <a:off x="914400" y="5577840"/>
+            <a:ext cx="10332720" cy="822960"/>
           </a:xfrm>
           <a:prstGeom prst="roundRect">
             <a:avLst/>
@@ -3469,8 +3469,8 @@
         </p:nvSpPr>
         <p:spPr>
           <a:xfrm>
-            <a:off x="1097280" y="5669280"/>
-            <a:ext cx="9966960" cy="457200"/>
+            <a:off x="1097280" y="5669279"/>
+            <a:ext cx="9966960" cy="365760"/>
           </a:xfrm>
           <a:prstGeom prst="rect">
             <a:avLst/>
@@ -3485,7 +3485,7 @@
           <a:p>
             <a:pPr algn="l"/>
             <a:r>
-              <a:rPr sz="1600" b="1">
+              <a:rPr sz="1400" b="1">
                 <a:solidFill>
                   <a:srgbClr val="065A82"/>
                 </a:solidFill>
@@ -3504,8 +3504,8 @@
         </p:nvSpPr>
         <p:spPr>
           <a:xfrm>
-            <a:off x="1097280" y="6172200"/>
-            <a:ext cx="9966960" cy="-91440"/>
+            <a:off x="1097280" y="6080759"/>
+            <a:ext cx="9966960" cy="274320"/>
           </a:xfrm>
           <a:prstGeom prst="rect">
             <a:avLst/>
@@ -4074,7 +4074,7 @@
         <p:spPr>
           <a:xfrm>
             <a:off x="457200" y="6446520"/>
-            <a:ext cx="7315200" cy="274320"/>
+            <a:ext cx="10515600" cy="274320"/>
           </a:xfrm>
           <a:prstGeom prst="rect">
             <a:avLst/>
@@ -4108,8 +4108,8 @@
         </p:nvSpPr>
         <p:spPr>
           <a:xfrm>
-            <a:off x="10972800" y="6446520"/>
-            <a:ext cx="914400" cy="274320"/>
+            <a:off x="11155680" y="6446520"/>
+            <a:ext cx="731520" cy="274320"/>
           </a:xfrm>
           <a:prstGeom prst="rect">
             <a:avLst/>
@@ -4750,7 +4750,7 @@
         <p:spPr>
           <a:xfrm>
             <a:off x="457200" y="6446520"/>
-            <a:ext cx="7315200" cy="274320"/>
+            <a:ext cx="10515600" cy="274320"/>
           </a:xfrm>
           <a:prstGeom prst="rect">
             <a:avLst/>
@@ -4784,8 +4784,8 @@
         </p:nvSpPr>
         <p:spPr>
           <a:xfrm>
-            <a:off x="10972800" y="6446520"/>
-            <a:ext cx="914400" cy="274320"/>
+            <a:off x="11155680" y="6446520"/>
+            <a:ext cx="731520" cy="274320"/>
           </a:xfrm>
           <a:prstGeom prst="rect">
             <a:avLst/>
@@ -5300,7 +5300,7 @@
         <p:spPr>
           <a:xfrm>
             <a:off x="457200" y="6446520"/>
-            <a:ext cx="7315200" cy="274320"/>
+            <a:ext cx="10515600" cy="274320"/>
           </a:xfrm>
           <a:prstGeom prst="rect">
             <a:avLst/>
@@ -5334,8 +5334,8 @@
         </p:nvSpPr>
         <p:spPr>
           <a:xfrm>
-            <a:off x="10972800" y="6446520"/>
-            <a:ext cx="914400" cy="274320"/>
+            <a:off x="11155680" y="6446520"/>
+            <a:ext cx="731520" cy="274320"/>
           </a:xfrm>
           <a:prstGeom prst="rect">
             <a:avLst/>
@@ -5544,7 +5544,7 @@
         <p:spPr>
           <a:xfrm>
             <a:off x="640080" y="1188720"/>
-            <a:ext cx="10972800" cy="365760"/>
+            <a:ext cx="10972800" cy="457200"/>
           </a:xfrm>
           <a:prstGeom prst="rect">
             <a:avLst/>
@@ -5579,7 +5579,7 @@
         <p:spPr>
           <a:xfrm>
             <a:off x="640080" y="1600200"/>
-            <a:ext cx="10972800" cy="640080"/>
+            <a:ext cx="10972800" cy="822960"/>
           </a:xfrm>
           <a:prstGeom prst="roundRect">
             <a:avLst/>
@@ -5623,8 +5623,8 @@
         </p:nvSpPr>
         <p:spPr>
           <a:xfrm>
-            <a:off x="822959" y="1737360"/>
-            <a:ext cx="10607040" cy="457200"/>
+            <a:off x="822959" y="1691640"/>
+            <a:ext cx="10607040" cy="365760"/>
           </a:xfrm>
           <a:prstGeom prst="rect">
             <a:avLst/>
@@ -5639,7 +5639,7 @@
           <a:p>
             <a:pPr algn="l"/>
             <a:r>
-              <a:rPr sz="1600" b="1">
+              <a:rPr sz="1400" b="1">
                 <a:solidFill>
                   <a:srgbClr val="10B981"/>
                 </a:solidFill>
@@ -5658,8 +5658,8 @@
         </p:nvSpPr>
         <p:spPr>
           <a:xfrm>
-            <a:off x="822959" y="2240280"/>
-            <a:ext cx="10607040" cy="-91440"/>
+            <a:off x="822959" y="2103120"/>
+            <a:ext cx="10607040" cy="274320"/>
           </a:xfrm>
           <a:prstGeom prst="rect">
             <a:avLst/>
@@ -5693,8 +5693,8 @@
         </p:nvSpPr>
         <p:spPr>
           <a:xfrm>
-            <a:off x="640080" y="2423160"/>
-            <a:ext cx="10972800" cy="365760"/>
+            <a:off x="640080" y="2468880"/>
+            <a:ext cx="10972800" cy="457200"/>
           </a:xfrm>
           <a:prstGeom prst="rect">
             <a:avLst/>
@@ -5728,8 +5728,8 @@
         </p:nvSpPr>
         <p:spPr>
           <a:xfrm>
-            <a:off x="640080" y="2834640"/>
-            <a:ext cx="10972800" cy="640080"/>
+            <a:off x="640080" y="2880360"/>
+            <a:ext cx="10972800" cy="822960"/>
           </a:xfrm>
           <a:prstGeom prst="roundRect">
             <a:avLst/>
@@ -5774,7 +5774,7 @@
         <p:spPr>
           <a:xfrm>
             <a:off x="822959" y="2971800"/>
-            <a:ext cx="10607040" cy="457200"/>
+            <a:ext cx="10607040" cy="365760"/>
           </a:xfrm>
           <a:prstGeom prst="rect">
             <a:avLst/>
@@ -5789,7 +5789,7 @@
           <a:p>
             <a:pPr algn="l"/>
             <a:r>
-              <a:rPr sz="1600" b="1">
+              <a:rPr sz="1400" b="1">
                 <a:solidFill>
                   <a:srgbClr val="1C7293"/>
                 </a:solidFill>
@@ -5808,8 +5808,8 @@
         </p:nvSpPr>
         <p:spPr>
           <a:xfrm>
-            <a:off x="822959" y="3474720"/>
-            <a:ext cx="10607040" cy="-91440"/>
+            <a:off x="822959" y="3383279"/>
+            <a:ext cx="10607040" cy="274320"/>
           </a:xfrm>
           <a:prstGeom prst="rect">
             <a:avLst/>
@@ -5824,7 +5824,7 @@
           <a:p>
             <a:pPr algn="l"/>
             <a:r>
-              <a:rPr sz="1400" b="0">
+              <a:rPr sz="1200" b="0">
                 <a:solidFill>
                   <a:srgbClr val="2A2A2A"/>
                 </a:solidFill>
@@ -5843,8 +5843,8 @@
         </p:nvSpPr>
         <p:spPr>
           <a:xfrm>
-            <a:off x="640080" y="3657600"/>
-            <a:ext cx="10972800" cy="365760"/>
+            <a:off x="640080" y="3749039"/>
+            <a:ext cx="10972800" cy="457200"/>
           </a:xfrm>
           <a:prstGeom prst="rect">
             <a:avLst/>
@@ -5878,8 +5878,8 @@
         </p:nvSpPr>
         <p:spPr>
           <a:xfrm>
-            <a:off x="640080" y="4069080"/>
-            <a:ext cx="10972800" cy="640080"/>
+            <a:off x="640080" y="4160520"/>
+            <a:ext cx="10972800" cy="822960"/>
           </a:xfrm>
           <a:prstGeom prst="roundRect">
             <a:avLst/>
@@ -5923,8 +5923,8 @@
         </p:nvSpPr>
         <p:spPr>
           <a:xfrm>
-            <a:off x="822959" y="4206240"/>
-            <a:ext cx="10607040" cy="457200"/>
+            <a:off x="822959" y="4251959"/>
+            <a:ext cx="10607040" cy="365760"/>
           </a:xfrm>
           <a:prstGeom prst="rect">
             <a:avLst/>
@@ -5939,7 +5939,7 @@
           <a:p>
             <a:pPr algn="l"/>
             <a:r>
-              <a:rPr sz="1600" b="1">
+              <a:rPr sz="1400" b="1">
                 <a:solidFill>
                   <a:srgbClr val="10B981"/>
                 </a:solidFill>
@@ -5958,8 +5958,8 @@
         </p:nvSpPr>
         <p:spPr>
           <a:xfrm>
-            <a:off x="822959" y="4709160"/>
-            <a:ext cx="10607040" cy="-91440"/>
+            <a:off x="822959" y="4663440"/>
+            <a:ext cx="10607040" cy="274320"/>
           </a:xfrm>
           <a:prstGeom prst="rect">
             <a:avLst/>
@@ -5993,8 +5993,8 @@
         </p:nvSpPr>
         <p:spPr>
           <a:xfrm>
-            <a:off x="640080" y="4892040"/>
-            <a:ext cx="10972800" cy="365760"/>
+            <a:off x="640080" y="5029200"/>
+            <a:ext cx="10972800" cy="457200"/>
           </a:xfrm>
           <a:prstGeom prst="rect">
             <a:avLst/>
@@ -6028,8 +6028,8 @@
         </p:nvSpPr>
         <p:spPr>
           <a:xfrm>
-            <a:off x="640080" y="5303520"/>
-            <a:ext cx="10972800" cy="777240"/>
+            <a:off x="640080" y="5440680"/>
+            <a:ext cx="10972800" cy="822960"/>
           </a:xfrm>
           <a:prstGeom prst="roundRect">
             <a:avLst/>
@@ -6073,8 +6073,8 @@
         </p:nvSpPr>
         <p:spPr>
           <a:xfrm>
-            <a:off x="822959" y="5440680"/>
-            <a:ext cx="10607040" cy="457200"/>
+            <a:off x="822959" y="5532120"/>
+            <a:ext cx="10607040" cy="365760"/>
           </a:xfrm>
           <a:prstGeom prst="rect">
             <a:avLst/>
@@ -6089,7 +6089,7 @@
           <a:p>
             <a:pPr algn="l"/>
             <a:r>
-              <a:rPr sz="1600" b="1">
+              <a:rPr sz="1400" b="1">
                 <a:solidFill>
                   <a:srgbClr val="EA580C"/>
                 </a:solidFill>
@@ -6109,7 +6109,7 @@
         <p:spPr>
           <a:xfrm>
             <a:off x="822959" y="5943600"/>
-            <a:ext cx="10607040" cy="45719"/>
+            <a:ext cx="10607040" cy="274320"/>
           </a:xfrm>
           <a:prstGeom prst="rect">
             <a:avLst/>
@@ -6137,46 +6137,36 @@
       </p:sp>
       <p:sp>
         <p:nvSpPr>
-          <p:cNvPr id="22" name="Rounded Rectangle 21"/>
-          <p:cNvSpPr/>
-          <p:nvPr/>
-        </p:nvSpPr>
-        <p:spPr>
-          <a:xfrm>
-            <a:off x="640080" y="6172200"/>
-            <a:ext cx="10972800" cy="274320"/>
-          </a:xfrm>
-          <a:prstGeom prst="roundRect">
-            <a:avLst/>
-          </a:prstGeom>
-          <a:solidFill>
-            <a:srgbClr val="FFF3CD"/>
-          </a:solidFill>
-          <a:ln>
-            <a:solidFill>
-              <a:srgbClr val="E6A23E"/>
-            </a:solidFill>
-          </a:ln>
-        </p:spPr>
-        <p:style>
-          <a:lnRef idx="1">
-            <a:schemeClr val="accent1"/>
-          </a:lnRef>
-          <a:fillRef idx="3">
-            <a:schemeClr val="accent1"/>
-          </a:fillRef>
-          <a:effectRef idx="2">
-            <a:schemeClr val="accent1"/>
-          </a:effectRef>
-          <a:fontRef idx="minor">
-            <a:schemeClr val="lt1"/>
-          </a:fontRef>
-        </p:style>
-        <p:txBody>
-          <a:bodyPr rtlCol="0" anchor="ctr"/>
-          <a:lstStyle/>
-          <a:p>
-            <a:pPr algn="ctr"/>
+          <p:cNvPr id="22" name="TextBox 21"/>
+          <p:cNvSpPr txBox="1"/>
+          <p:nvPr/>
+        </p:nvSpPr>
+        <p:spPr>
+          <a:xfrm>
+            <a:off x="457200" y="6446520"/>
+            <a:ext cx="10515600" cy="274320"/>
+          </a:xfrm>
+          <a:prstGeom prst="rect">
+            <a:avLst/>
+          </a:prstGeom>
+          <a:noFill/>
+        </p:spPr>
+        <p:txBody>
+          <a:bodyPr wrap="square">
+            <a:spAutoFit/>
+          </a:bodyPr>
+          <a:lstStyle/>
+          <a:p>
+            <a:pPr algn="l"/>
+            <a:r>
+              <a:rPr sz="800" b="0">
+                <a:solidFill>
+                  <a:srgbClr val="666666"/>
+                </a:solidFill>
+                <a:latin typeface="Calibri"/>
+              </a:rPr>
+              <a:t>📦 Repo: github.com/KrizRoMe/evaluacion-administracion-web   •   🌐 Web: krizrome.github.io/evaluacion-administracion-web   •   📋 Issues: github.com/KrizRoMe/evaluacion-administracion-web/issues</a:t>
+            </a:r>
           </a:p>
         </p:txBody>
       </p:sp>
@@ -6188,78 +6178,8 @@
         </p:nvSpPr>
         <p:spPr>
           <a:xfrm>
-            <a:off x="640080" y="6217920"/>
-            <a:ext cx="10972800" cy="182880"/>
-          </a:xfrm>
-          <a:prstGeom prst="rect">
-            <a:avLst/>
-          </a:prstGeom>
-          <a:noFill/>
-        </p:spPr>
-        <p:txBody>
-          <a:bodyPr wrap="square">
-            <a:spAutoFit/>
-          </a:bodyPr>
-          <a:lstStyle/>
-          <a:p>
-            <a:pPr algn="ctr"/>
-            <a:r>
-              <a:rPr sz="1100" b="1">
-                <a:solidFill>
-                  <a:srgbClr val="924E0E"/>
-                </a:solidFill>
-                <a:latin typeface="Calibri"/>
-              </a:rPr>
-              <a:t>📌  Los 3 hallazgos se documentan como Issues EN TU REPO.  La entrega final se hace como Issue AQUÍ.</a:t>
-            </a:r>
-          </a:p>
-        </p:txBody>
-      </p:sp>
-      <p:sp>
-        <p:nvSpPr>
-          <p:cNvPr id="24" name="TextBox 23"/>
-          <p:cNvSpPr txBox="1"/>
-          <p:nvPr/>
-        </p:nvSpPr>
-        <p:spPr>
-          <a:xfrm>
-            <a:off x="457200" y="6446520"/>
-            <a:ext cx="7315200" cy="274320"/>
-          </a:xfrm>
-          <a:prstGeom prst="rect">
-            <a:avLst/>
-          </a:prstGeom>
-          <a:noFill/>
-        </p:spPr>
-        <p:txBody>
-          <a:bodyPr wrap="square">
-            <a:spAutoFit/>
-          </a:bodyPr>
-          <a:lstStyle/>
-          <a:p>
-            <a:pPr algn="l"/>
-            <a:r>
-              <a:rPr sz="800" b="0">
-                <a:solidFill>
-                  <a:srgbClr val="666666"/>
-                </a:solidFill>
-                <a:latin typeface="Calibri"/>
-              </a:rPr>
-              <a:t>📦 Repo: github.com/KrizRoMe/evaluacion-administracion-web   •   🌐 Web: krizrome.github.io/evaluacion-administracion-web   •   📋 Issues: github.com/KrizRoMe/evaluacion-administracion-web/issues</a:t>
-            </a:r>
-          </a:p>
-        </p:txBody>
-      </p:sp>
-      <p:sp>
-        <p:nvSpPr>
-          <p:cNvPr id="25" name="TextBox 24"/>
-          <p:cNvSpPr txBox="1"/>
-          <p:nvPr/>
-        </p:nvSpPr>
-        <p:spPr>
-          <a:xfrm>
-            <a:off x="10972800" y="6446520"/>
-            <a:ext cx="914400" cy="274320"/>
+            <a:off x="11155680" y="6446520"/>
+            <a:ext cx="731520" cy="274320"/>
           </a:xfrm>
           <a:prstGeom prst="rect">
             <a:avLst/>
@@ -7440,7 +7360,7 @@
         <p:spPr>
           <a:xfrm>
             <a:off x="457200" y="6446520"/>
-            <a:ext cx="7315200" cy="274320"/>
+            <a:ext cx="10515600" cy="274320"/>
           </a:xfrm>
           <a:prstGeom prst="rect">
             <a:avLst/>
@@ -7474,8 +7394,8 @@
         </p:nvSpPr>
         <p:spPr>
           <a:xfrm>
-            <a:off x="10972800" y="6446520"/>
-            <a:ext cx="914400" cy="274320"/>
+            <a:off x="11155680" y="6446520"/>
+            <a:ext cx="731520" cy="274320"/>
           </a:xfrm>
           <a:prstGeom prst="rect">
             <a:avLst/>
@@ -8071,7 +7991,7 @@
         <p:spPr>
           <a:xfrm>
             <a:off x="457200" y="6446520"/>
-            <a:ext cx="7315200" cy="274320"/>
+            <a:ext cx="10515600" cy="274320"/>
           </a:xfrm>
           <a:prstGeom prst="rect">
             <a:avLst/>
@@ -8105,8 +8025,8 @@
         </p:nvSpPr>
         <p:spPr>
           <a:xfrm>
-            <a:off x="10972800" y="6446520"/>
-            <a:ext cx="914400" cy="274320"/>
+            <a:off x="11155680" y="6446520"/>
+            <a:ext cx="731520" cy="274320"/>
           </a:xfrm>
           <a:prstGeom prst="rect">
             <a:avLst/>
@@ -8619,7 +8539,7 @@
         <p:spPr>
           <a:xfrm>
             <a:off x="457200" y="6446520"/>
-            <a:ext cx="7315200" cy="274320"/>
+            <a:ext cx="10515600" cy="274320"/>
           </a:xfrm>
           <a:prstGeom prst="rect">
             <a:avLst/>
@@ -8653,8 +8573,8 @@
         </p:nvSpPr>
         <p:spPr>
           <a:xfrm>
-            <a:off x="10972800" y="6446520"/>
-            <a:ext cx="914400" cy="274320"/>
+            <a:off x="11155680" y="6446520"/>
+            <a:ext cx="731520" cy="274320"/>
           </a:xfrm>
           <a:prstGeom prst="rect">
             <a:avLst/>
@@ -9296,7 +9216,7 @@
         <p:spPr>
           <a:xfrm>
             <a:off x="457200" y="6446520"/>
-            <a:ext cx="7315200" cy="274320"/>
+            <a:ext cx="10515600" cy="274320"/>
           </a:xfrm>
           <a:prstGeom prst="rect">
             <a:avLst/>
@@ -9330,8 +9250,8 @@
         </p:nvSpPr>
         <p:spPr>
           <a:xfrm>
-            <a:off x="10972800" y="6446520"/>
-            <a:ext cx="914400" cy="274320"/>
+            <a:off x="11155680" y="6446520"/>
+            <a:ext cx="731520" cy="274320"/>
           </a:xfrm>
           <a:prstGeom prst="rect">
             <a:avLst/>
@@ -9620,7 +9540,7 @@
         <p:spPr>
           <a:xfrm>
             <a:off x="640080" y="1920240"/>
-            <a:ext cx="10972800" cy="365760"/>
+            <a:ext cx="10972800" cy="457200"/>
           </a:xfrm>
           <a:prstGeom prst="rect">
             <a:avLst/>
@@ -9878,7 +9798,7 @@
         <p:spPr>
           <a:xfrm>
             <a:off x="457200" y="6446520"/>
-            <a:ext cx="7315200" cy="274320"/>
+            <a:ext cx="10515600" cy="274320"/>
           </a:xfrm>
           <a:prstGeom prst="rect">
             <a:avLst/>
@@ -9912,8 +9832,8 @@
         </p:nvSpPr>
         <p:spPr>
           <a:xfrm>
-            <a:off x="10972800" y="6446520"/>
-            <a:ext cx="914400" cy="274320"/>
+            <a:off x="11155680" y="6446520"/>
+            <a:ext cx="731520" cy="274320"/>
           </a:xfrm>
           <a:prstGeom prst="rect">
             <a:avLst/>
@@ -10421,7 +10341,7 @@
                 </a:solidFill>
                 <a:latin typeface="Calibri"/>
               </a:rPr>
-              <a:t>VIVO • RÁPIDO (con LCP/INP/CLS/TTFB) • SEGURO (2 acciones) • Backup 3-2-1 • SLI • SLO • SLA • Runbook (4–6 pasos) • Datos del estudiante + URLs</a:t>
+              <a:t>VIVO · RÁPIDO (con LCP/INP/CLS/TTFB) · SEGURO (2 acciones) · Backup 3-2-1 · SLI · SLO · SLA · Runbook (4–6 pasos) · Datos del estudiante + URLs</a:t>
             </a:r>
           </a:p>
         </p:txBody>
@@ -10435,7 +10355,7 @@
         <p:spPr>
           <a:xfrm>
             <a:off x="457200" y="6446520"/>
-            <a:ext cx="7315200" cy="274320"/>
+            <a:ext cx="10515600" cy="274320"/>
           </a:xfrm>
           <a:prstGeom prst="rect">
             <a:avLst/>
@@ -10469,8 +10389,8 @@
         </p:nvSpPr>
         <p:spPr>
           <a:xfrm>
-            <a:off x="10972800" y="6446520"/>
-            <a:ext cx="914400" cy="274320"/>
+            <a:off x="11155680" y="6446520"/>
+            <a:ext cx="731520" cy="274320"/>
           </a:xfrm>
           <a:prstGeom prst="rect">
             <a:avLst/>

</xml_diff>

<commit_message>
refactor(issue-templates): renombrar 'entrega' a 'link-evaluacion'
Antes: 'entrega.yml' (entrega de evaluación)
Ahora: 'link-evaluacion.yml' (link de evaluación)

Cambios:
- Template simplificado a 4 campos: nombre, código, link repo, link público
- Sin checklist de auto-verificación, sin dropdown de estado
- Sin comentarios de problemas técnicos
- Solo el lugar donde el estudiante publica su link público + repo

PPT actualizado: slides 3, 10 y 11 reflejan el nuevo nombre y los 4 campos.
</commit_message>
<xml_diff>
--- a/EVALUACION_PRACTICA_01.pptx
+++ b/EVALUACION_PRACTICA_01.pptx
@@ -3665,7 +3665,7 @@
                 </a:solidFill>
                 <a:latin typeface="Calibri"/>
               </a:rPr>
-              <a:t>📤 Parte 6 · Crear Issue de ENTREGA</a:t>
+              <a:t>🔗 Parte 6 · Publicar tu link de evaluación</a:t>
             </a:r>
           </a:p>
         </p:txBody>
@@ -3700,7 +3700,7 @@
                 </a:solidFill>
                 <a:latin typeface="Calibri"/>
               </a:rPr>
-              <a:t>⏱ 5 minutos  •  Esta Issue se crea en el repo del DOCENTE</a:t>
+              <a:t>⏱ 5 minutos  •  Una sola Issue con el link de tu repo y tu sitio público</a:t>
             </a:r>
           </a:p>
         </p:txBody>
@@ -3771,7 +3771,7 @@
                 </a:solidFill>
                 <a:latin typeface="Calibri"/>
               </a:rPr>
-              <a:t>3. Selecciona el template 📤 Entrega de evaluación</a:t>
+              <a:t>3. Selecciona el template 🔗 Link de evaluación</a:t>
             </a:r>
           </a:p>
           <a:p>
@@ -3783,7 +3783,7 @@
                 </a:solidFill>
                 <a:latin typeface="Calibri"/>
               </a:rPr>
-              <a:t>4. Completa el formulario: tu nombre, código, URL de tu repo, URL de tu GitHub Pages</a:t>
+              <a:t>4. Completa: nombre, código, link de tu repo, link público de tu sitio</a:t>
             </a:r>
           </a:p>
           <a:p>
@@ -3875,7 +3875,7 @@
                 </a:solidFill>
                 <a:latin typeface="Calibri"/>
               </a:rPr>
-              <a:t>🔗 LINK DIRECTO PARA CREAR EL ISSUE DE ENTREGA:</a:t>
+              <a:t>🔗 LINK DIRECTO para publicar tu repo + sitio público:</a:t>
             </a:r>
           </a:p>
         </p:txBody>
@@ -3910,7 +3910,7 @@
                 </a:solidFill>
                 <a:latin typeface="Consolas"/>
               </a:rPr>
-              <a:t>https://github.com/KrizRoMe/evaluacion-administracion-web/issues/new?template=entrega.yml</a:t>
+              <a:t>https://github.com/KrizRoMe/evaluacion-administracion-web/issues/new?template=link-evaluacion.yml</a:t>
             </a:r>
           </a:p>
         </p:txBody>
@@ -4025,7 +4025,7 @@
                 </a:solidFill>
                 <a:latin typeface="Calibri"/>
               </a:rPr>
-              <a:t>La Issue de entrega te pide:</a:t>
+              <a:t>La Issue te pide:</a:t>
             </a:r>
           </a:p>
         </p:txBody>
@@ -4060,7 +4060,7 @@
                 </a:solidFill>
                 <a:latin typeface="Calibri"/>
               </a:rPr>
-              <a:t>• Nombre completo • Código • URL de TU repositorio  •  URL de TU GitHub Pages  •  Checklist de auto-verificación</a:t>
+              <a:t>• Nombre completo  •  Código  •  Link de tu repositorio  •  Link público de tu sitio</a:t>
             </a:r>
           </a:p>
         </p:txBody>
@@ -4269,7 +4269,7 @@
                 </a:solidFill>
                 <a:latin typeface="Calibri"/>
               </a:rPr>
-              <a:t>✅ Checklist final completo</a:t>
+              <a:t>✅ Checklist final</a:t>
             </a:r>
           </a:p>
         </p:txBody>
@@ -4304,7 +4304,7 @@
                 </a:solidFill>
                 <a:latin typeface="Calibri"/>
               </a:rPr>
-              <a:t>Antes de entregar, verifica TODO</a:t>
+              <a:t>Antes de publicar tu link de evaluación, verifica TODO</a:t>
             </a:r>
           </a:p>
         </p:txBody>
@@ -4481,7 +4481,7 @@
                 </a:solidFill>
                 <a:latin typeface="Calibri"/>
               </a:rPr>
-              <a:t>📤 En repo del DOCENTE (entrega):</a:t>
+              <a:t>🔗 En repo del DOCENTE:</a:t>
             </a:r>
           </a:p>
         </p:txBody>
@@ -4516,7 +4516,7 @@
                 </a:solidFill>
                 <a:latin typeface="Calibri"/>
               </a:rPr>
-              <a:t>☐ Abrí el link de entrega</a:t>
+              <a:t>☐ Abrí el link del template</a:t>
             </a:r>
           </a:p>
           <a:p>
@@ -4528,7 +4528,7 @@
                 </a:solidFill>
                 <a:latin typeface="Calibri"/>
               </a:rPr>
-              <a:t>☐ Seleccioné el template 'Entrega'</a:t>
+              <a:t>☐ Seleccioné 'Link de evaluación'</a:t>
             </a:r>
           </a:p>
           <a:p>
@@ -4552,7 +4552,7 @@
                 </a:solidFill>
                 <a:latin typeface="Calibri"/>
               </a:rPr>
-              <a:t>☐ Pegué URL de mi repo</a:t>
+              <a:t>☐ Pegué link de mi repo</a:t>
             </a:r>
           </a:p>
           <a:p>
@@ -4564,7 +4564,7 @@
                 </a:solidFill>
                 <a:latin typeface="Calibri"/>
               </a:rPr>
-              <a:t>☐ Pegué URL de mi GitHub Pages</a:t>
+              <a:t>☐ Pegué link público de mi sitio</a:t>
             </a:r>
           </a:p>
           <a:p>
@@ -4576,7 +4576,7 @@
                 </a:solidFill>
                 <a:latin typeface="Calibri"/>
               </a:rPr>
-              <a:t>☐ Marqué el checklist</a:t>
+              <a:t>☐ Envié la Issue</a:t>
             </a:r>
           </a:p>
           <a:p>
@@ -4588,7 +4588,7 @@
                 </a:solidFill>
                 <a:latin typeface="Calibri"/>
               </a:rPr>
-              <a:t>☐ Envié la Issue</a:t>
+              <a:t>☐ Solo una Issue, no más</a:t>
             </a:r>
           </a:p>
         </p:txBody>
@@ -4666,7 +4666,7 @@
                 </a:solidFill>
                 <a:latin typeface="Calibri"/>
               </a:rPr>
-              <a:t>🔗 ENTREGAR AL DOCENTE — Crear Issue de entrega aquí:</a:t>
+              <a:t>🔗 Publicar link de evaluación aquí:</a:t>
             </a:r>
           </a:p>
         </p:txBody>
@@ -4701,7 +4701,7 @@
                 </a:solidFill>
                 <a:latin typeface="Consolas"/>
               </a:rPr>
-              <a:t>https://github.com/KrizRoMe/evaluacion-administracion-web/issues/new?template=entrega.yml</a:t>
+              <a:t>https://github.com/KrizRoMe/evaluacion-administracion-web/issues/new?template=link-evaluacion.yml</a:t>
             </a:r>
           </a:p>
         </p:txBody>
@@ -4736,7 +4736,7 @@
                 </a:solidFill>
                 <a:latin typeface="Calibri"/>
               </a:rPr>
-              <a:t>📌  Los 3 hallazgos van en TU repo.  La ENTREGA final va AQUÍ.</a:t>
+              <a:t>📌  Los 3 hallazgos van en TU repo.  El link de tu evaluación va AQUÍ (solo una Issue).</a:t>
             </a:r>
           </a:p>
         </p:txBody>
@@ -5530,7 +5530,7 @@
                 </a:solidFill>
                 <a:latin typeface="Calibri"/>
               </a:rPr>
-              <a:t>Sitio base + tu repo + dónde entregar</a:t>
+              <a:t>Sitio base + tu repo + link de evaluación</a:t>
             </a:r>
           </a:p>
         </p:txBody>
@@ -6015,7 +6015,7 @@
                 </a:solidFill>
                 <a:latin typeface="Calibri"/>
               </a:rPr>
-              <a:t>📤  Dónde entregas tu evaluación (Issue de entrega)</a:t>
+              <a:t>🔗  Link de evaluación (publicar tu repo + sitio público)</a:t>
             </a:r>
           </a:p>
         </p:txBody>
@@ -6095,7 +6095,7 @@
                 </a:solidFill>
                 <a:latin typeface="Calibri"/>
               </a:rPr>
-              <a:t>Crea una Issue con el template 'Entrega' en el repo del docente:</a:t>
+              <a:t>Crear Issue con el template 'Link de evaluación' en el repo del docente:</a:t>
             </a:r>
           </a:p>
         </p:txBody>
@@ -6130,7 +6130,7 @@
                 </a:solidFill>
                 <a:latin typeface="Consolas"/>
               </a:rPr>
-              <a:t>https://github.com/KrizRoMe/evaluacion-administracion-web/issues/new?template=entrega.yml</a:t>
+              <a:t>https://github.com/KrizRoMe/evaluacion-administracion-web/issues/new?template=link-evaluacion.yml</a:t>
             </a:r>
           </a:p>
         </p:txBody>
@@ -7183,8 +7183,8 @@
                 </a:solidFill>
                 <a:latin typeface="Calibri"/>
               </a:rPr>
-              <a:t>Issue de
-entrega AQUÍ</a:t>
+              <a:t>Link de
+evaluación AQUÍ</a:t>
             </a:r>
           </a:p>
         </p:txBody>
@@ -7266,7 +7266,7 @@
                 </a:solidFill>
                 <a:latin typeface="Calibri"/>
               </a:rPr>
-              <a:t>Issues (TU repo): 20 min   •   Documentar solución: 10 min   •   README: 15 min   •   Issue de entrega: 5 min</a:t>
+              <a:t>Issues (TU repo): 20 min   •   Documentar solución: 10 min   •   README: 15 min   •   Link de evaluación: 5 min</a:t>
             </a:r>
           </a:p>
         </p:txBody>

</xml_diff>

<commit_message>
refactor: link-evaluacion.yml reemplaza entrega.yml
</commit_message>
<xml_diff>
--- a/EVALUACION_PRACTICA_01.pptx
+++ b/EVALUACION_PRACTICA_01.pptx
@@ -3665,7 +3665,7 @@
                 </a:solidFill>
                 <a:latin typeface="Calibri"/>
               </a:rPr>
-              <a:t>📤 Parte 6 · Crear Issue de ENTREGA</a:t>
+              <a:t>🔗 Parte 6 · Publicar tu link de evaluación</a:t>
             </a:r>
           </a:p>
         </p:txBody>
@@ -3700,7 +3700,7 @@
                 </a:solidFill>
                 <a:latin typeface="Calibri"/>
               </a:rPr>
-              <a:t>⏱ 5 minutos  •  Esta Issue se crea en el repo del DOCENTE</a:t>
+              <a:t>⏱ 5 minutos  •  Una sola Issue con el link de tu repo y tu sitio público</a:t>
             </a:r>
           </a:p>
         </p:txBody>
@@ -3771,7 +3771,7 @@
                 </a:solidFill>
                 <a:latin typeface="Calibri"/>
               </a:rPr>
-              <a:t>3. Selecciona el template 📤 Entrega de evaluación</a:t>
+              <a:t>3. Selecciona el template 🔗 Link de evaluación</a:t>
             </a:r>
           </a:p>
           <a:p>
@@ -3783,7 +3783,7 @@
                 </a:solidFill>
                 <a:latin typeface="Calibri"/>
               </a:rPr>
-              <a:t>4. Completa el formulario: tu nombre, código, URL de tu repo, URL de tu GitHub Pages</a:t>
+              <a:t>4. Completa: nombre, código, link de tu repo, link público de tu sitio</a:t>
             </a:r>
           </a:p>
           <a:p>
@@ -3875,7 +3875,7 @@
                 </a:solidFill>
                 <a:latin typeface="Calibri"/>
               </a:rPr>
-              <a:t>🔗 LINK DIRECTO PARA CREAR EL ISSUE DE ENTREGA:</a:t>
+              <a:t>🔗 LINK DIRECTO para publicar tu repo + sitio público:</a:t>
             </a:r>
           </a:p>
         </p:txBody>
@@ -3910,7 +3910,7 @@
                 </a:solidFill>
                 <a:latin typeface="Consolas"/>
               </a:rPr>
-              <a:t>https://github.com/KrizRoMe/evaluacion-administracion-web/issues/new?template=entrega.yml</a:t>
+              <a:t>https://github.com/KrizRoMe/evaluacion-administracion-web/issues/new?template=link-evaluacion.yml</a:t>
             </a:r>
           </a:p>
         </p:txBody>
@@ -4025,7 +4025,7 @@
                 </a:solidFill>
                 <a:latin typeface="Calibri"/>
               </a:rPr>
-              <a:t>La Issue de entrega te pide:</a:t>
+              <a:t>La Issue te pide:</a:t>
             </a:r>
           </a:p>
         </p:txBody>
@@ -4060,7 +4060,7 @@
                 </a:solidFill>
                 <a:latin typeface="Calibri"/>
               </a:rPr>
-              <a:t>• Nombre completo • Código • URL de TU repositorio  •  URL de TU GitHub Pages  •  Checklist de auto-verificación</a:t>
+              <a:t>• Nombre completo  •  Código  •  Link de tu repositorio  •  Link público de tu sitio</a:t>
             </a:r>
           </a:p>
         </p:txBody>
@@ -4269,7 +4269,7 @@
                 </a:solidFill>
                 <a:latin typeface="Calibri"/>
               </a:rPr>
-              <a:t>✅ Checklist final completo</a:t>
+              <a:t>✅ Checklist final</a:t>
             </a:r>
           </a:p>
         </p:txBody>
@@ -4304,7 +4304,7 @@
                 </a:solidFill>
                 <a:latin typeface="Calibri"/>
               </a:rPr>
-              <a:t>Antes de entregar, verifica TODO</a:t>
+              <a:t>Antes de publicar tu link de evaluación, verifica TODO</a:t>
             </a:r>
           </a:p>
         </p:txBody>
@@ -4481,7 +4481,7 @@
                 </a:solidFill>
                 <a:latin typeface="Calibri"/>
               </a:rPr>
-              <a:t>📤 En repo del DOCENTE (entrega):</a:t>
+              <a:t>🔗 En repo del DOCENTE:</a:t>
             </a:r>
           </a:p>
         </p:txBody>
@@ -4516,7 +4516,7 @@
                 </a:solidFill>
                 <a:latin typeface="Calibri"/>
               </a:rPr>
-              <a:t>☐ Abrí el link de entrega</a:t>
+              <a:t>☐ Abrí el link del template</a:t>
             </a:r>
           </a:p>
           <a:p>
@@ -4528,7 +4528,7 @@
                 </a:solidFill>
                 <a:latin typeface="Calibri"/>
               </a:rPr>
-              <a:t>☐ Seleccioné el template 'Entrega'</a:t>
+              <a:t>☐ Seleccioné 'Link de evaluación'</a:t>
             </a:r>
           </a:p>
           <a:p>
@@ -4552,7 +4552,7 @@
                 </a:solidFill>
                 <a:latin typeface="Calibri"/>
               </a:rPr>
-              <a:t>☐ Pegué URL de mi repo</a:t>
+              <a:t>☐ Pegué link de mi repo</a:t>
             </a:r>
           </a:p>
           <a:p>
@@ -4564,7 +4564,7 @@
                 </a:solidFill>
                 <a:latin typeface="Calibri"/>
               </a:rPr>
-              <a:t>☐ Pegué URL de mi GitHub Pages</a:t>
+              <a:t>☐ Pegué link público de mi sitio</a:t>
             </a:r>
           </a:p>
           <a:p>
@@ -4576,7 +4576,7 @@
                 </a:solidFill>
                 <a:latin typeface="Calibri"/>
               </a:rPr>
-              <a:t>☐ Marqué el checklist</a:t>
+              <a:t>☐ Envié la Issue</a:t>
             </a:r>
           </a:p>
           <a:p>
@@ -4588,7 +4588,7 @@
                 </a:solidFill>
                 <a:latin typeface="Calibri"/>
               </a:rPr>
-              <a:t>☐ Envié la Issue</a:t>
+              <a:t>☐ Solo una Issue, no más</a:t>
             </a:r>
           </a:p>
         </p:txBody>
@@ -4666,7 +4666,7 @@
                 </a:solidFill>
                 <a:latin typeface="Calibri"/>
               </a:rPr>
-              <a:t>🔗 ENTREGAR AL DOCENTE — Crear Issue de entrega aquí:</a:t>
+              <a:t>🔗 Publicar link de evaluación aquí:</a:t>
             </a:r>
           </a:p>
         </p:txBody>
@@ -4701,7 +4701,7 @@
                 </a:solidFill>
                 <a:latin typeface="Consolas"/>
               </a:rPr>
-              <a:t>https://github.com/KrizRoMe/evaluacion-administracion-web/issues/new?template=entrega.yml</a:t>
+              <a:t>https://github.com/KrizRoMe/evaluacion-administracion-web/issues/new?template=link-evaluacion.yml</a:t>
             </a:r>
           </a:p>
         </p:txBody>
@@ -4736,7 +4736,7 @@
                 </a:solidFill>
                 <a:latin typeface="Calibri"/>
               </a:rPr>
-              <a:t>📌  Los 3 hallazgos van en TU repo.  La ENTREGA final va AQUÍ.</a:t>
+              <a:t>📌  Los 3 hallazgos van en TU repo.  El link de tu evaluación va AQUÍ (solo una Issue).</a:t>
             </a:r>
           </a:p>
         </p:txBody>
@@ -5530,7 +5530,7 @@
                 </a:solidFill>
                 <a:latin typeface="Calibri"/>
               </a:rPr>
-              <a:t>Sitio base + tu repo + dónde entregar</a:t>
+              <a:t>Sitio base + tu repo + link de evaluación</a:t>
             </a:r>
           </a:p>
         </p:txBody>
@@ -6015,7 +6015,7 @@
                 </a:solidFill>
                 <a:latin typeface="Calibri"/>
               </a:rPr>
-              <a:t>📤  Dónde entregas tu evaluación (Issue de entrega)</a:t>
+              <a:t>🔗  Link de evaluación (publicar tu repo + sitio público)</a:t>
             </a:r>
           </a:p>
         </p:txBody>
@@ -6095,7 +6095,7 @@
                 </a:solidFill>
                 <a:latin typeface="Calibri"/>
               </a:rPr>
-              <a:t>Crea una Issue con el template 'Entrega' en el repo del docente:</a:t>
+              <a:t>Crear Issue con el template 'Link de evaluación' en el repo del docente:</a:t>
             </a:r>
           </a:p>
         </p:txBody>
@@ -6130,7 +6130,7 @@
                 </a:solidFill>
                 <a:latin typeface="Consolas"/>
               </a:rPr>
-              <a:t>https://github.com/KrizRoMe/evaluacion-administracion-web/issues/new?template=entrega.yml</a:t>
+              <a:t>https://github.com/KrizRoMe/evaluacion-administracion-web/issues/new?template=link-evaluacion.yml</a:t>
             </a:r>
           </a:p>
         </p:txBody>
@@ -7183,8 +7183,8 @@
                 </a:solidFill>
                 <a:latin typeface="Calibri"/>
               </a:rPr>
-              <a:t>Issue de
-entrega AQUÍ</a:t>
+              <a:t>Link de
+evaluación AQUÍ</a:t>
             </a:r>
           </a:p>
         </p:txBody>
@@ -7266,7 +7266,7 @@
                 </a:solidFill>
                 <a:latin typeface="Calibri"/>
               </a:rPr>
-              <a:t>Issues (TU repo): 20 min   •   Documentar solución: 10 min   •   README: 15 min   •   Issue de entrega: 5 min</a:t>
+              <a:t>Issues (TU repo): 20 min   •   Documentar solución: 10 min   •   README: 15 min   •   Link de evaluación: 5 min</a:t>
             </a:r>
           </a:p>
         </p:txBody>

</xml_diff>

<commit_message>
refactor: eliminar campo 'código de estudiante' del template link-evaluacion
Antes: 4 campos (nombre, código, link repo, link público)
Ahora: 3 campos (nombre, link repo, link público)

También quitado el código del slide 10 y slide 11 del PPT.
</commit_message>
<xml_diff>
--- a/EVALUACION_PRACTICA_01.pptx
+++ b/EVALUACION_PRACTICA_01.pptx
@@ -3783,7 +3783,7 @@
                 </a:solidFill>
                 <a:latin typeface="Calibri"/>
               </a:rPr>
-              <a:t>4. Completa: nombre, código, link de tu repo, link público de tu sitio</a:t>
+              <a:t>4. Completa: nombre, link de tu repo, link público de tu sitio</a:t>
             </a:r>
           </a:p>
           <a:p>
@@ -4025,7 +4025,7 @@
                 </a:solidFill>
                 <a:latin typeface="Calibri"/>
               </a:rPr>
-              <a:t>La Issue te pide:</a:t>
+              <a:t>La Issue te pide SOLO:</a:t>
             </a:r>
           </a:p>
         </p:txBody>
@@ -4060,7 +4060,7 @@
                 </a:solidFill>
                 <a:latin typeface="Calibri"/>
               </a:rPr>
-              <a:t>• Nombre completo  •  Código  •  Link de tu repositorio  •  Link público de tu sitio</a:t>
+              <a:t>• Nombre completo  •  Link de tu repositorio  •  Link público de tu sitio</a:t>
             </a:r>
           </a:p>
         </p:txBody>
@@ -4540,7 +4540,7 @@
                 </a:solidFill>
                 <a:latin typeface="Calibri"/>
               </a:rPr>
-              <a:t>☐ Completé nombre, código</a:t>
+              <a:t>☐ Puse mi nombre</a:t>
             </a:r>
           </a:p>
           <a:p>

</xml_diff>

<commit_message>
refactor: eliminar campo código del template
</commit_message>
<xml_diff>
--- a/EVALUACION_PRACTICA_01.pptx
+++ b/EVALUACION_PRACTICA_01.pptx
@@ -3783,7 +3783,7 @@
                 </a:solidFill>
                 <a:latin typeface="Calibri"/>
               </a:rPr>
-              <a:t>4. Completa: nombre, código, link de tu repo, link público de tu sitio</a:t>
+              <a:t>4. Completa: nombre, link de tu repo, link público de tu sitio</a:t>
             </a:r>
           </a:p>
           <a:p>
@@ -4025,7 +4025,7 @@
                 </a:solidFill>
                 <a:latin typeface="Calibri"/>
               </a:rPr>
-              <a:t>La Issue te pide:</a:t>
+              <a:t>La Issue te pide SOLO:</a:t>
             </a:r>
           </a:p>
         </p:txBody>
@@ -4060,7 +4060,7 @@
                 </a:solidFill>
                 <a:latin typeface="Calibri"/>
               </a:rPr>
-              <a:t>• Nombre completo  •  Código  •  Link de tu repositorio  •  Link público de tu sitio</a:t>
+              <a:t>• Nombre completo  •  Link de tu repositorio  •  Link público de tu sitio</a:t>
             </a:r>
           </a:p>
         </p:txBody>
@@ -4540,7 +4540,7 @@
                 </a:solidFill>
                 <a:latin typeface="Calibri"/>
               </a:rPr>
-              <a:t>☐ Completé nombre, código</a:t>
+              <a:t>☐ Puse mi nombre</a:t>
             </a:r>
           </a:p>
           <a:p>

</xml_diff>

<commit_message>
feat: recalibrar a 4 issues × 5 pts + 15 problemas intencionales
PPT, instrucciones, checklist, README plantilla y markdown actualizados:
- 4 Issues (no 3) en el repo del estudiante
- 5 pts por Issue (no 6) = 20 pts total
- Sitio tiene 15 problemas (no 6), estudiante identifica 4
- Dificultad uniforme 4/10

Las respuestas esperadas ya NO están en este repo público.
 Se movieron a: https://github.com/KrizRoMe/evaluacion-administracion-web-docente (privado)
</commit_message>
<xml_diff>
--- a/EVALUACION_PRACTICA_01.pptx
+++ b/EVALUACION_PRACTICA_01.pptx
@@ -4398,7 +4398,7 @@
                 </a:solidFill>
                 <a:latin typeface="Calibri"/>
               </a:rPr>
-              <a:t>☐ EXACTAMENTE 3 Issues creadas</a:t>
+              <a:t>☐ EXACTAMENTE 4 Issues creadas</a:t>
             </a:r>
           </a:p>
           <a:p>
@@ -4736,7 +4736,7 @@
                 </a:solidFill>
                 <a:latin typeface="Calibri"/>
               </a:rPr>
-              <a:t>📌  Los 3 hallazgos van en TU repo.  El link de tu evaluación va AQUÍ (solo una Issue).</a:t>
+              <a:t>📌  Las 4 Issues van en TU repo.  El link va AQUÍ (solo una Issue).</a:t>
             </a:r>
           </a:p>
         </p:txBody>
@@ -6374,7 +6374,7 @@
                 </a:solidFill>
                 <a:latin typeface="Calibri"/>
               </a:rPr>
-              <a:t>7 fases, 90 minutos</a:t>
+              <a:t>7 fases, 90 minutos  •  4 Issues × 5 pts = 20 pts</a:t>
             </a:r>
           </a:p>
         </p:txBody>
@@ -6940,7 +6940,7 @@
                 </a:solidFill>
                 <a:latin typeface="Calibri"/>
               </a:rPr>
-              <a:t>3 Issues
+              <a:t>4 Issues
 en TU repo</a:t>
             </a:r>
           </a:p>
@@ -7346,7 +7346,7 @@
                 </a:solidFill>
                 <a:latin typeface="Calibri"/>
               </a:rPr>
-              <a:t>⚠️  No es necesario aplicar las correcciones. Basta con especificar la solución en el texto de cada Issue.</a:t>
+              <a:t>⚠️  El sitio tiene 15 problemas. Tú solo necesitas identificar 4.</a:t>
             </a:r>
           </a:p>
         </p:txBody>
@@ -8769,7 +8769,7 @@
                 </a:solidFill>
                 <a:latin typeface="Calibri"/>
               </a:rPr>
-              <a:t>⏱ 15 minutos</a:t>
+              <a:t>⏱ 15 minutos  •  15 problemas, tú identificas 4</a:t>
             </a:r>
           </a:p>
         </p:txBody>
@@ -9018,7 +9018,7 @@
                 </a:solidFill>
                 <a:latin typeface="Calibri"/>
               </a:rPr>
-              <a:t>Si no tienes la extensión:</a:t>
+              <a:t>El sitio tiene 15 problemas:</a:t>
             </a:r>
           </a:p>
           <a:p>
@@ -9030,7 +9030,7 @@
                 </a:solidFill>
                 <a:latin typeface="Calibri"/>
               </a:rPr>
-              <a:t>• chromewebstore → buscar</a:t>
+              <a:t>• 5 de rendimiento</a:t>
             </a:r>
           </a:p>
           <a:p>
@@ -9042,7 +9042,31 @@
                 </a:solidFill>
                 <a:latin typeface="Calibri"/>
               </a:rPr>
-              <a:t>  "axe DevTools"</a:t>
+              <a:t>• 5 de accesibilidad</a:t>
+            </a:r>
+          </a:p>
+          <a:p>
+            <a:pPr algn="l"/>
+            <a:r>
+              <a:rPr sz="1400" b="0">
+                <a:solidFill>
+                  <a:srgbClr val="2A2A2A"/>
+                </a:solidFill>
+                <a:latin typeface="Calibri"/>
+              </a:rPr>
+              <a:t>• 3 de mantenimiento/seguridad</a:t>
+            </a:r>
+          </a:p>
+          <a:p>
+            <a:pPr algn="l"/>
+            <a:r>
+              <a:rPr sz="1400" b="0">
+                <a:solidFill>
+                  <a:srgbClr val="2A2A2A"/>
+                </a:solidFill>
+                <a:latin typeface="Calibri"/>
+              </a:rPr>
+              <a:t>• 2 de administración</a:t>
             </a:r>
           </a:p>
         </p:txBody>
@@ -9055,18 +9079,18 @@
         </p:nvSpPr>
         <p:spPr>
           <a:xfrm>
-            <a:off x="640080" y="4937760"/>
-            <a:ext cx="10972800" cy="731520"/>
+            <a:off x="640080" y="5120640"/>
+            <a:ext cx="10972800" cy="640080"/>
           </a:xfrm>
           <a:prstGeom prst="roundRect">
             <a:avLst/>
           </a:prstGeom>
           <a:solidFill>
-            <a:srgbClr val="F4F4F4"/>
+            <a:srgbClr val="FFF3CD"/>
           </a:solidFill>
           <a:ln>
             <a:solidFill>
-              <a:srgbClr val="1C7293"/>
+              <a:srgbClr val="E6A23E"/>
             </a:solidFill>
           </a:ln>
         </p:spPr>
@@ -9100,8 +9124,8 @@
         </p:nvSpPr>
         <p:spPr>
           <a:xfrm>
-            <a:off x="822960" y="4983480"/>
-            <a:ext cx="10607040" cy="640080"/>
+            <a:off x="822960" y="5212080"/>
+            <a:ext cx="10607040" cy="457200"/>
           </a:xfrm>
           <a:prstGeom prst="rect">
             <a:avLst/>
@@ -9118,70 +9142,25 @@
             <a:r>
               <a:rPr sz="1400" b="1">
                 <a:solidFill>
-                  <a:srgbClr val="065A82"/>
-                </a:solidFill>
-                <a:latin typeface="Calibri"/>
-              </a:rPr>
-              <a:t>🎯 Objetivo: encontrar 3 problemas reales (rendimiento, accesibilidad, mantenimiento, seguridad básica, administración).</a:t>
-            </a:r>
-          </a:p>
-        </p:txBody>
-      </p:sp>
-      <p:sp>
-        <p:nvSpPr>
-          <p:cNvPr id="11" name="Rounded Rectangle 10"/>
-          <p:cNvSpPr/>
-          <p:nvPr/>
-        </p:nvSpPr>
-        <p:spPr>
-          <a:xfrm>
-            <a:off x="640080" y="5852160"/>
-            <a:ext cx="10972800" cy="457200"/>
-          </a:xfrm>
-          <a:prstGeom prst="roundRect">
-            <a:avLst/>
-          </a:prstGeom>
-          <a:solidFill>
-            <a:srgbClr val="F4F4F4"/>
-          </a:solidFill>
-          <a:ln>
-            <a:solidFill>
-              <a:srgbClr val="1C7293"/>
-            </a:solidFill>
-          </a:ln>
-        </p:spPr>
-        <p:style>
-          <a:lnRef idx="1">
-            <a:schemeClr val="accent1"/>
-          </a:lnRef>
-          <a:fillRef idx="3">
-            <a:schemeClr val="accent1"/>
-          </a:fillRef>
-          <a:effectRef idx="2">
-            <a:schemeClr val="accent1"/>
-          </a:effectRef>
-          <a:fontRef idx="minor">
-            <a:schemeClr val="lt1"/>
-          </a:fontRef>
-        </p:style>
-        <p:txBody>
-          <a:bodyPr rtlCol="0" anchor="ctr"/>
-          <a:lstStyle/>
-          <a:p>
-            <a:pPr algn="ctr"/>
-          </a:p>
-        </p:txBody>
-      </p:sp>
-      <p:sp>
-        <p:nvSpPr>
-          <p:cNvPr id="12" name="TextBox 11"/>
+                  <a:srgbClr val="924E0E"/>
+                </a:solidFill>
+                <a:latin typeface="Calibri"/>
+              </a:rPr>
+              <a:t>🎯 Objetivo: encontrar 4 problemas reales. Variedad es positiva pero no obligatoria.</a:t>
+            </a:r>
+          </a:p>
+        </p:txBody>
+      </p:sp>
+      <p:sp>
+        <p:nvSpPr>
+          <p:cNvPr id="11" name="TextBox 10"/>
           <p:cNvSpPr txBox="1"/>
           <p:nvPr/>
         </p:nvSpPr>
         <p:spPr>
           <a:xfrm>
-            <a:off x="640080" y="5897880"/>
-            <a:ext cx="10972800" cy="365760"/>
+            <a:off x="457200" y="6446520"/>
+            <a:ext cx="10515600" cy="274320"/>
           </a:xfrm>
           <a:prstGeom prst="rect">
             <a:avLst/>
@@ -9194,41 +9173,6 @@
           </a:bodyPr>
           <a:lstStyle/>
           <a:p>
-            <a:pPr algn="ctr"/>
-            <a:r>
-              <a:rPr sz="1300" b="1">
-                <a:solidFill>
-                  <a:srgbClr val="065A82"/>
-                </a:solidFill>
-                <a:latin typeface="Calibri"/>
-              </a:rPr>
-              <a:t>💡 No necesitas puntuación perfecta de Lighthouse. Solo identificar problemas reales.</a:t>
-            </a:r>
-          </a:p>
-        </p:txBody>
-      </p:sp>
-      <p:sp>
-        <p:nvSpPr>
-          <p:cNvPr id="13" name="TextBox 12"/>
-          <p:cNvSpPr txBox="1"/>
-          <p:nvPr/>
-        </p:nvSpPr>
-        <p:spPr>
-          <a:xfrm>
-            <a:off x="457200" y="6446520"/>
-            <a:ext cx="10515600" cy="274320"/>
-          </a:xfrm>
-          <a:prstGeom prst="rect">
-            <a:avLst/>
-          </a:prstGeom>
-          <a:noFill/>
-        </p:spPr>
-        <p:txBody>
-          <a:bodyPr wrap="square">
-            <a:spAutoFit/>
-          </a:bodyPr>
-          <a:lstStyle/>
-          <a:p>
             <a:pPr algn="l"/>
             <a:r>
               <a:rPr sz="800" b="0">
@@ -9244,7 +9188,7 @@
       </p:sp>
       <p:sp>
         <p:nvSpPr>
-          <p:cNvPr id="14" name="TextBox 13"/>
+          <p:cNvPr id="12" name="TextBox 11"/>
           <p:cNvSpPr txBox="1"/>
           <p:nvPr/>
         </p:nvSpPr>
@@ -9411,7 +9355,7 @@
                 </a:solidFill>
                 <a:latin typeface="Calibri"/>
               </a:rPr>
-              <a:t>Parte 4 · Crear 3 Issues en TU repo</a:t>
+              <a:t>Parte 4 · Crear 4 Issues en TU repo</a:t>
             </a:r>
           </a:p>
         </p:txBody>
@@ -9446,7 +9390,7 @@
                 </a:solidFill>
                 <a:latin typeface="Calibri"/>
               </a:rPr>
-              <a:t>⏱ 20 minutos  •  Usa los templates interactivos</a:t>
+              <a:t>⏱ 20 minutos  •  4 Issues × 5 pts = 20 pts</a:t>
             </a:r>
           </a:p>
         </p:txBody>
@@ -9526,7 +9470,7 @@
                 </a:solidFill>
                 <a:latin typeface="Calibri"/>
               </a:rPr>
-              <a:t>⚠️  Estos 3 Issues se crean en TU PROPIO repositorio, NO en el del docente.</a:t>
+              <a:t>⚠️  Estas 4 Issues se crean en TU PROPIO repositorio, NO en el del docente.</a:t>
             </a:r>
           </a:p>
         </p:txBody>
@@ -9712,7 +9656,7 @@
                 </a:solidFill>
                 <a:latin typeface="Calibri"/>
               </a:rPr>
-              <a:t>Cada template es un FORMULARIO INTERACTIVO con:</a:t>
+              <a:t>Cada Issue se evalúa con 4 criterios (5 pts):</a:t>
             </a:r>
           </a:p>
           <a:p>
@@ -9736,7 +9680,7 @@
                 </a:solidFill>
                 <a:latin typeface="Calibri"/>
               </a:rPr>
-              <a:t>📝 Inputs  →  Problema, Ubicación, Concepto, Justificación</a:t>
+              <a:t>✓ Identificación correcta del problema (2 pts)</a:t>
             </a:r>
           </a:p>
           <a:p>
@@ -9748,7 +9692,7 @@
                 </a:solidFill>
                 <a:latin typeface="Calibri"/>
               </a:rPr>
-              <a:t>📄 Textareas  →  Evidencia, Impacto, Solución propuesta</a:t>
+              <a:t>✓ Ubicación y evidencia (1 pt)</a:t>
             </a:r>
           </a:p>
           <a:p>
@@ -9760,7 +9704,7 @@
                 </a:solidFill>
                 <a:latin typeface="Calibri"/>
               </a:rPr>
-              <a:t>🔽 Dropdowns  →  Pilar, Tipo de mantenimiento, Severidad</a:t>
+              <a:t>✓ Impacto + concepto del curso relacionado (1 pt)</a:t>
             </a:r>
           </a:p>
           <a:p>
@@ -9772,7 +9716,7 @@
                 </a:solidFill>
                 <a:latin typeface="Calibri"/>
               </a:rPr>
-              <a:t>☑️ Checkboxes  →  Principios WCAG, Conceptos múltiples</a:t>
+              <a:t>✓ Solución propuesta en texto (1 pt)</a:t>
             </a:r>
           </a:p>
           <a:p>
@@ -9784,7 +9728,19 @@
                 </a:solidFill>
                 <a:latin typeface="Calibri"/>
               </a:rPr>
-              <a:t>⚠️ Validación required  →  No se envía si está vacío</a:t>
+              <a:t/>
+            </a:r>
+          </a:p>
+          <a:p>
+            <a:pPr algn="l"/>
+            <a:r>
+              <a:rPr sz="1300" b="0">
+                <a:solidFill>
+                  <a:srgbClr val="FFFFFF"/>
+                </a:solidFill>
+                <a:latin typeface="Calibri"/>
+              </a:rPr>
+              <a:t>Cada template es un FORMULARIO INTERACTIVO con inputs, dropdowns y checkboxes.</a:t>
             </a:r>
           </a:p>
         </p:txBody>
@@ -10190,7 +10146,7 @@
                 </a:solidFill>
                 <a:latin typeface="Calibri"/>
               </a:rPr>
-              <a:t>"Añadir el atributo defer al &lt;script&gt; para que no sea bloqueante."</a:t>
+              <a:t>"Añadir el atributo defer al &lt;script&gt;."</a:t>
             </a:r>
           </a:p>
           <a:p>
@@ -10202,7 +10158,7 @@
                 </a:solidFill>
                 <a:latin typeface="Calibri"/>
               </a:rPr>
-              <a:t>"Actualizar jquery a una versión 3.x sin vulnerabilidades conocidas."</a:t>
+              <a:t>"Actualizar jquery a una versión 3.x."</a:t>
             </a:r>
           </a:p>
           <a:p>
@@ -10214,7 +10170,7 @@
                 </a:solidFill>
                 <a:latin typeface="Calibri"/>
               </a:rPr>
-              <a:t>"Cambiar el texto del footer por la fecha actual de mantenimiento."</a:t>
+              <a:t>"Cambiar el texto del footer por la fecha actual."</a:t>
             </a:r>
           </a:p>
           <a:p>
@@ -10226,7 +10182,7 @@
                 </a:solidFill>
                 <a:latin typeface="Calibri"/>
               </a:rPr>
-              <a:t>"Agregar atributo alt descriptivo a todas las imágenes del sitio."</a:t>
+              <a:t>"Agregar atributo alt descriptivo a las imágenes."</a:t>
             </a:r>
           </a:p>
         </p:txBody>

</xml_diff>

<commit_message>
feat: rediseño completo ECOMARKET con 15 problemas intencionales
</commit_message>
<xml_diff>
--- a/EVALUACION_PRACTICA_01.pptx
+++ b/EVALUACION_PRACTICA_01.pptx
@@ -4398,7 +4398,7 @@
                 </a:solidFill>
                 <a:latin typeface="Calibri"/>
               </a:rPr>
-              <a:t>☐ EXACTAMENTE 3 Issues creadas</a:t>
+              <a:t>☐ EXACTAMENTE 4 Issues creadas</a:t>
             </a:r>
           </a:p>
           <a:p>
@@ -4736,7 +4736,7 @@
                 </a:solidFill>
                 <a:latin typeface="Calibri"/>
               </a:rPr>
-              <a:t>📌  Los 3 hallazgos van en TU repo.  El link de tu evaluación va AQUÍ (solo una Issue).</a:t>
+              <a:t>📌  Las 4 Issues van en TU repo.  El link va AQUÍ (solo una Issue).</a:t>
             </a:r>
           </a:p>
         </p:txBody>
@@ -6374,7 +6374,7 @@
                 </a:solidFill>
                 <a:latin typeface="Calibri"/>
               </a:rPr>
-              <a:t>7 fases, 90 minutos</a:t>
+              <a:t>7 fases, 90 minutos  •  4 Issues × 5 pts = 20 pts</a:t>
             </a:r>
           </a:p>
         </p:txBody>
@@ -6940,7 +6940,7 @@
                 </a:solidFill>
                 <a:latin typeface="Calibri"/>
               </a:rPr>
-              <a:t>3 Issues
+              <a:t>4 Issues
 en TU repo</a:t>
             </a:r>
           </a:p>
@@ -7346,7 +7346,7 @@
                 </a:solidFill>
                 <a:latin typeface="Calibri"/>
               </a:rPr>
-              <a:t>⚠️  No es necesario aplicar las correcciones. Basta con especificar la solución en el texto de cada Issue.</a:t>
+              <a:t>⚠️  El sitio tiene 15 problemas. Tú solo necesitas identificar 4.</a:t>
             </a:r>
           </a:p>
         </p:txBody>
@@ -8769,7 +8769,7 @@
                 </a:solidFill>
                 <a:latin typeface="Calibri"/>
               </a:rPr>
-              <a:t>⏱ 15 minutos</a:t>
+              <a:t>⏱ 15 minutos  •  15 problemas, tú identificas 4</a:t>
             </a:r>
           </a:p>
         </p:txBody>
@@ -9018,7 +9018,7 @@
                 </a:solidFill>
                 <a:latin typeface="Calibri"/>
               </a:rPr>
-              <a:t>Si no tienes la extensión:</a:t>
+              <a:t>El sitio tiene 15 problemas:</a:t>
             </a:r>
           </a:p>
           <a:p>
@@ -9030,7 +9030,7 @@
                 </a:solidFill>
                 <a:latin typeface="Calibri"/>
               </a:rPr>
-              <a:t>• chromewebstore → buscar</a:t>
+              <a:t>• 5 de rendimiento</a:t>
             </a:r>
           </a:p>
           <a:p>
@@ -9042,7 +9042,31 @@
                 </a:solidFill>
                 <a:latin typeface="Calibri"/>
               </a:rPr>
-              <a:t>  "axe DevTools"</a:t>
+              <a:t>• 5 de accesibilidad</a:t>
+            </a:r>
+          </a:p>
+          <a:p>
+            <a:pPr algn="l"/>
+            <a:r>
+              <a:rPr sz="1400" b="0">
+                <a:solidFill>
+                  <a:srgbClr val="2A2A2A"/>
+                </a:solidFill>
+                <a:latin typeface="Calibri"/>
+              </a:rPr>
+              <a:t>• 3 de mantenimiento/seguridad</a:t>
+            </a:r>
+          </a:p>
+          <a:p>
+            <a:pPr algn="l"/>
+            <a:r>
+              <a:rPr sz="1400" b="0">
+                <a:solidFill>
+                  <a:srgbClr val="2A2A2A"/>
+                </a:solidFill>
+                <a:latin typeface="Calibri"/>
+              </a:rPr>
+              <a:t>• 2 de administración</a:t>
             </a:r>
           </a:p>
         </p:txBody>
@@ -9055,18 +9079,18 @@
         </p:nvSpPr>
         <p:spPr>
           <a:xfrm>
-            <a:off x="640080" y="4937760"/>
-            <a:ext cx="10972800" cy="731520"/>
+            <a:off x="640080" y="5120640"/>
+            <a:ext cx="10972800" cy="640080"/>
           </a:xfrm>
           <a:prstGeom prst="roundRect">
             <a:avLst/>
           </a:prstGeom>
           <a:solidFill>
-            <a:srgbClr val="F4F4F4"/>
+            <a:srgbClr val="FFF3CD"/>
           </a:solidFill>
           <a:ln>
             <a:solidFill>
-              <a:srgbClr val="1C7293"/>
+              <a:srgbClr val="E6A23E"/>
             </a:solidFill>
           </a:ln>
         </p:spPr>
@@ -9100,8 +9124,8 @@
         </p:nvSpPr>
         <p:spPr>
           <a:xfrm>
-            <a:off x="822960" y="4983480"/>
-            <a:ext cx="10607040" cy="640080"/>
+            <a:off x="822960" y="5212080"/>
+            <a:ext cx="10607040" cy="457200"/>
           </a:xfrm>
           <a:prstGeom prst="rect">
             <a:avLst/>
@@ -9118,70 +9142,25 @@
             <a:r>
               <a:rPr sz="1400" b="1">
                 <a:solidFill>
-                  <a:srgbClr val="065A82"/>
-                </a:solidFill>
-                <a:latin typeface="Calibri"/>
-              </a:rPr>
-              <a:t>🎯 Objetivo: encontrar 3 problemas reales (rendimiento, accesibilidad, mantenimiento, seguridad básica, administración).</a:t>
-            </a:r>
-          </a:p>
-        </p:txBody>
-      </p:sp>
-      <p:sp>
-        <p:nvSpPr>
-          <p:cNvPr id="11" name="Rounded Rectangle 10"/>
-          <p:cNvSpPr/>
-          <p:nvPr/>
-        </p:nvSpPr>
-        <p:spPr>
-          <a:xfrm>
-            <a:off x="640080" y="5852160"/>
-            <a:ext cx="10972800" cy="457200"/>
-          </a:xfrm>
-          <a:prstGeom prst="roundRect">
-            <a:avLst/>
-          </a:prstGeom>
-          <a:solidFill>
-            <a:srgbClr val="F4F4F4"/>
-          </a:solidFill>
-          <a:ln>
-            <a:solidFill>
-              <a:srgbClr val="1C7293"/>
-            </a:solidFill>
-          </a:ln>
-        </p:spPr>
-        <p:style>
-          <a:lnRef idx="1">
-            <a:schemeClr val="accent1"/>
-          </a:lnRef>
-          <a:fillRef idx="3">
-            <a:schemeClr val="accent1"/>
-          </a:fillRef>
-          <a:effectRef idx="2">
-            <a:schemeClr val="accent1"/>
-          </a:effectRef>
-          <a:fontRef idx="minor">
-            <a:schemeClr val="lt1"/>
-          </a:fontRef>
-        </p:style>
-        <p:txBody>
-          <a:bodyPr rtlCol="0" anchor="ctr"/>
-          <a:lstStyle/>
-          <a:p>
-            <a:pPr algn="ctr"/>
-          </a:p>
-        </p:txBody>
-      </p:sp>
-      <p:sp>
-        <p:nvSpPr>
-          <p:cNvPr id="12" name="TextBox 11"/>
+                  <a:srgbClr val="924E0E"/>
+                </a:solidFill>
+                <a:latin typeface="Calibri"/>
+              </a:rPr>
+              <a:t>🎯 Objetivo: encontrar 4 problemas reales. Variedad es positiva pero no obligatoria.</a:t>
+            </a:r>
+          </a:p>
+        </p:txBody>
+      </p:sp>
+      <p:sp>
+        <p:nvSpPr>
+          <p:cNvPr id="11" name="TextBox 10"/>
           <p:cNvSpPr txBox="1"/>
           <p:nvPr/>
         </p:nvSpPr>
         <p:spPr>
           <a:xfrm>
-            <a:off x="640080" y="5897880"/>
-            <a:ext cx="10972800" cy="365760"/>
+            <a:off x="457200" y="6446520"/>
+            <a:ext cx="10515600" cy="274320"/>
           </a:xfrm>
           <a:prstGeom prst="rect">
             <a:avLst/>
@@ -9194,41 +9173,6 @@
           </a:bodyPr>
           <a:lstStyle/>
           <a:p>
-            <a:pPr algn="ctr"/>
-            <a:r>
-              <a:rPr sz="1300" b="1">
-                <a:solidFill>
-                  <a:srgbClr val="065A82"/>
-                </a:solidFill>
-                <a:latin typeface="Calibri"/>
-              </a:rPr>
-              <a:t>💡 No necesitas puntuación perfecta de Lighthouse. Solo identificar problemas reales.</a:t>
-            </a:r>
-          </a:p>
-        </p:txBody>
-      </p:sp>
-      <p:sp>
-        <p:nvSpPr>
-          <p:cNvPr id="13" name="TextBox 12"/>
-          <p:cNvSpPr txBox="1"/>
-          <p:nvPr/>
-        </p:nvSpPr>
-        <p:spPr>
-          <a:xfrm>
-            <a:off x="457200" y="6446520"/>
-            <a:ext cx="10515600" cy="274320"/>
-          </a:xfrm>
-          <a:prstGeom prst="rect">
-            <a:avLst/>
-          </a:prstGeom>
-          <a:noFill/>
-        </p:spPr>
-        <p:txBody>
-          <a:bodyPr wrap="square">
-            <a:spAutoFit/>
-          </a:bodyPr>
-          <a:lstStyle/>
-          <a:p>
             <a:pPr algn="l"/>
             <a:r>
               <a:rPr sz="800" b="0">
@@ -9244,7 +9188,7 @@
       </p:sp>
       <p:sp>
         <p:nvSpPr>
-          <p:cNvPr id="14" name="TextBox 13"/>
+          <p:cNvPr id="12" name="TextBox 11"/>
           <p:cNvSpPr txBox="1"/>
           <p:nvPr/>
         </p:nvSpPr>
@@ -9411,7 +9355,7 @@
                 </a:solidFill>
                 <a:latin typeface="Calibri"/>
               </a:rPr>
-              <a:t>Parte 4 · Crear 3 Issues en TU repo</a:t>
+              <a:t>Parte 4 · Crear 4 Issues en TU repo</a:t>
             </a:r>
           </a:p>
         </p:txBody>
@@ -9446,7 +9390,7 @@
                 </a:solidFill>
                 <a:latin typeface="Calibri"/>
               </a:rPr>
-              <a:t>⏱ 20 minutos  •  Usa los templates interactivos</a:t>
+              <a:t>⏱ 20 minutos  •  4 Issues × 5 pts = 20 pts</a:t>
             </a:r>
           </a:p>
         </p:txBody>
@@ -9526,7 +9470,7 @@
                 </a:solidFill>
                 <a:latin typeface="Calibri"/>
               </a:rPr>
-              <a:t>⚠️  Estos 3 Issues se crean en TU PROPIO repositorio, NO en el del docente.</a:t>
+              <a:t>⚠️  Estas 4 Issues se crean en TU PROPIO repositorio, NO en el del docente.</a:t>
             </a:r>
           </a:p>
         </p:txBody>
@@ -9712,7 +9656,7 @@
                 </a:solidFill>
                 <a:latin typeface="Calibri"/>
               </a:rPr>
-              <a:t>Cada template es un FORMULARIO INTERACTIVO con:</a:t>
+              <a:t>Cada Issue se evalúa con 4 criterios (5 pts):</a:t>
             </a:r>
           </a:p>
           <a:p>
@@ -9736,7 +9680,7 @@
                 </a:solidFill>
                 <a:latin typeface="Calibri"/>
               </a:rPr>
-              <a:t>📝 Inputs  →  Problema, Ubicación, Concepto, Justificación</a:t>
+              <a:t>✓ Identificación correcta del problema (2 pts)</a:t>
             </a:r>
           </a:p>
           <a:p>
@@ -9748,7 +9692,7 @@
                 </a:solidFill>
                 <a:latin typeface="Calibri"/>
               </a:rPr>
-              <a:t>📄 Textareas  →  Evidencia, Impacto, Solución propuesta</a:t>
+              <a:t>✓ Ubicación y evidencia (1 pt)</a:t>
             </a:r>
           </a:p>
           <a:p>
@@ -9760,7 +9704,7 @@
                 </a:solidFill>
                 <a:latin typeface="Calibri"/>
               </a:rPr>
-              <a:t>🔽 Dropdowns  →  Pilar, Tipo de mantenimiento, Severidad</a:t>
+              <a:t>✓ Impacto + concepto del curso relacionado (1 pt)</a:t>
             </a:r>
           </a:p>
           <a:p>
@@ -9772,7 +9716,7 @@
                 </a:solidFill>
                 <a:latin typeface="Calibri"/>
               </a:rPr>
-              <a:t>☑️ Checkboxes  →  Principios WCAG, Conceptos múltiples</a:t>
+              <a:t>✓ Solución propuesta en texto (1 pt)</a:t>
             </a:r>
           </a:p>
           <a:p>
@@ -9784,7 +9728,19 @@
                 </a:solidFill>
                 <a:latin typeface="Calibri"/>
               </a:rPr>
-              <a:t>⚠️ Validación required  →  No se envía si está vacío</a:t>
+              <a:t/>
+            </a:r>
+          </a:p>
+          <a:p>
+            <a:pPr algn="l"/>
+            <a:r>
+              <a:rPr sz="1300" b="0">
+                <a:solidFill>
+                  <a:srgbClr val="FFFFFF"/>
+                </a:solidFill>
+                <a:latin typeface="Calibri"/>
+              </a:rPr>
+              <a:t>Cada template es un FORMULARIO INTERACTIVO con inputs, dropdowns y checkboxes.</a:t>
             </a:r>
           </a:p>
         </p:txBody>
@@ -10190,7 +10146,7 @@
                 </a:solidFill>
                 <a:latin typeface="Calibri"/>
               </a:rPr>
-              <a:t>"Añadir el atributo defer al &lt;script&gt; para que no sea bloqueante."</a:t>
+              <a:t>"Añadir el atributo defer al &lt;script&gt;."</a:t>
             </a:r>
           </a:p>
           <a:p>
@@ -10202,7 +10158,7 @@
                 </a:solidFill>
                 <a:latin typeface="Calibri"/>
               </a:rPr>
-              <a:t>"Actualizar jquery a una versión 3.x sin vulnerabilidades conocidas."</a:t>
+              <a:t>"Actualizar jquery a una versión 3.x."</a:t>
             </a:r>
           </a:p>
           <a:p>
@@ -10214,7 +10170,7 @@
                 </a:solidFill>
                 <a:latin typeface="Calibri"/>
               </a:rPr>
-              <a:t>"Cambiar el texto del footer por la fecha actual de mantenimiento."</a:t>
+              <a:t>"Cambiar el texto del footer por la fecha actual."</a:t>
             </a:r>
           </a:p>
           <a:p>
@@ -10226,7 +10182,7 @@
                 </a:solidFill>
                 <a:latin typeface="Calibri"/>
               </a:rPr>
-              <a:t>"Agregar atributo alt descriptivo a todas las imágenes del sitio."</a:t>
+              <a:t>"Agregar atributo alt descriptivo a las imágenes."</a:t>
             </a:r>
           </a:p>
         </p:txBody>

</xml_diff>

<commit_message>
feat: 4 Issues en el repo del DOCENTE (3 hallazgos + 1 link-evaluación)
- PPT: 4 Issues × 5 pts = 20 pts
- 3 Issues de hallazgos: 1 rendimiento + 1 accesibilidad + 1 mantenimiento
- 4ª Issue: link-evaluación (link repo + link público)
- Todas las Issues se hacen en KrizRoMe/evaluacion-administracion-web/issues
- README plantilla con 4 secciones (Issue 1-4)
- Checklist actualizado
- Instrucciones actualizadas
</commit_message>
<xml_diff>
--- a/EVALUACION_PRACTICA_01.pptx
+++ b/EVALUACION_PRACTICA_01.pptx
@@ -3296,7 +3296,19 @@
                 </a:solidFill>
                 <a:latin typeface="Calibri"/>
               </a:rPr>
-              <a:t>Unidad: 1  •  Duración: 90 minutos  •  Aprobado: 14/20</a:t>
+              <a:t>Unidad: 1  •  Duración: 90 minutos  •  Puntaje: 4 Issues × 5 pts = 20 pts</a:t>
+            </a:r>
+          </a:p>
+          <a:p>
+            <a:pPr algn="ctr"/>
+            <a:r>
+              <a:rPr sz="1500" b="0">
+                <a:solidFill>
+                  <a:srgbClr val="FFFFFF"/>
+                </a:solidFill>
+                <a:latin typeface="Calibri"/>
+              </a:rPr>
+              <a:t>Aprobado: ≥14 pts</a:t>
             </a:r>
           </a:p>
         </p:txBody>
@@ -3607,7 +3619,7 @@
             <a:avLst/>
           </a:prstGeom>
           <a:solidFill>
-            <a:srgbClr val="EA580C"/>
+            <a:srgbClr val="065A82"/>
           </a:solidFill>
           <a:ln>
             <a:noFill/>
@@ -3665,7 +3677,7 @@
                 </a:solidFill>
                 <a:latin typeface="Calibri"/>
               </a:rPr>
-              <a:t>🔗 Parte 6 · Publicar tu link de evaluación</a:t>
+              <a:t>Parte 6 · Documentar solución + README</a:t>
             </a:r>
           </a:p>
         </p:txBody>
@@ -3696,130 +3708,35 @@
             <a:r>
               <a:rPr sz="1400" b="0">
                 <a:solidFill>
-                  <a:srgbClr val="FED3B6"/>
-                </a:solidFill>
-                <a:latin typeface="Calibri"/>
-              </a:rPr>
-              <a:t>⏱ 5 minutos  •  Una sola Issue con el link de tu repo y tu sitio público</a:t>
-            </a:r>
-          </a:p>
-        </p:txBody>
-      </p:sp>
-      <p:sp>
-        <p:nvSpPr>
-          <p:cNvPr id="6" name="TextBox 5"/>
-          <p:cNvSpPr txBox="1"/>
-          <p:nvPr/>
-        </p:nvSpPr>
-        <p:spPr>
-          <a:xfrm>
-            <a:off x="640080" y="1188720"/>
-            <a:ext cx="10972800" cy="1371600"/>
-          </a:xfrm>
-          <a:prstGeom prst="rect">
-            <a:avLst/>
-          </a:prstGeom>
-          <a:noFill/>
-        </p:spPr>
-        <p:txBody>
-          <a:bodyPr wrap="square">
-            <a:spAutoFit/>
-          </a:bodyPr>
-          <a:lstStyle/>
-          <a:p>
-            <a:pPr algn="l"/>
-            <a:r>
-              <a:rPr sz="1400" b="1">
-                <a:solidFill>
-                  <a:srgbClr val="2A2A2A"/>
-                </a:solidFill>
-                <a:latin typeface="Calibri"/>
-              </a:rPr>
-              <a:t>Pasos:</a:t>
-            </a:r>
-          </a:p>
-          <a:p>
-            <a:pPr algn="l"/>
-            <a:r>
-              <a:rPr sz="1400" b="0">
-                <a:solidFill>
-                  <a:srgbClr val="2A2A2A"/>
-                </a:solidFill>
-                <a:latin typeface="Calibri"/>
-              </a:rPr>
-              <a:t>1. Abre el repo del curso en una pestaña nueva:</a:t>
-            </a:r>
-          </a:p>
-          <a:p>
-            <a:pPr algn="l"/>
-            <a:r>
-              <a:rPr sz="1400" b="0">
-                <a:solidFill>
-                  <a:srgbClr val="2A2A2A"/>
-                </a:solidFill>
-                <a:latin typeface="Calibri"/>
-              </a:rPr>
-              <a:t>2. Clic en Issues → New issue</a:t>
-            </a:r>
-          </a:p>
-          <a:p>
-            <a:pPr algn="l"/>
-            <a:r>
-              <a:rPr sz="1400" b="0">
-                <a:solidFill>
-                  <a:srgbClr val="2A2A2A"/>
-                </a:solidFill>
-                <a:latin typeface="Calibri"/>
-              </a:rPr>
-              <a:t>3. Selecciona el template 🔗 Link de evaluación</a:t>
-            </a:r>
-          </a:p>
-          <a:p>
-            <a:pPr algn="l"/>
-            <a:r>
-              <a:rPr sz="1400" b="0">
-                <a:solidFill>
-                  <a:srgbClr val="2A2A2A"/>
-                </a:solidFill>
-                <a:latin typeface="Calibri"/>
-              </a:rPr>
-              <a:t>4. Completa: nombre, link de tu repo, link público de tu sitio</a:t>
-            </a:r>
-          </a:p>
-          <a:p>
-            <a:pPr algn="l"/>
-            <a:r>
-              <a:rPr sz="1400" b="0">
-                <a:solidFill>
-                  <a:srgbClr val="2A2A2A"/>
-                </a:solidFill>
-                <a:latin typeface="Calibri"/>
-              </a:rPr>
-              <a:t>5. Clic en Submit (Crear)</a:t>
-            </a:r>
-          </a:p>
-        </p:txBody>
-      </p:sp>
-      <p:sp>
-        <p:nvSpPr>
-          <p:cNvPr id="7" name="Rounded Rectangle 6"/>
+                  <a:srgbClr val="60A5FA"/>
+                </a:solidFill>
+                <a:latin typeface="Calibri"/>
+              </a:rPr>
+              <a:t>⏱ 15 minutos  •  Sin tocar el código</a:t>
+            </a:r>
+          </a:p>
+        </p:txBody>
+      </p:sp>
+      <p:sp>
+        <p:nvSpPr>
+          <p:cNvPr id="6" name="Rounded Rectangle 5"/>
           <p:cNvSpPr/>
           <p:nvPr/>
         </p:nvSpPr>
         <p:spPr>
           <a:xfrm>
-            <a:off x="640080" y="3657600"/>
-            <a:ext cx="10972800" cy="1280160"/>
+            <a:off x="640080" y="1280160"/>
+            <a:ext cx="10972800" cy="640080"/>
           </a:xfrm>
           <a:prstGeom prst="roundRect">
             <a:avLst/>
           </a:prstGeom>
           <a:solidFill>
-            <a:srgbClr val="FEF3E6"/>
+            <a:srgbClr val="FFF3CD"/>
           </a:solidFill>
-          <a:ln w="38100">
+          <a:ln>
             <a:solidFill>
-              <a:srgbClr val="EA580C"/>
+              <a:srgbClr val="E6A23E"/>
             </a:solidFill>
           </a:ln>
         </p:spPr>
@@ -3847,35 +3764,70 @@
       </p:sp>
       <p:sp>
         <p:nvSpPr>
+          <p:cNvPr id="7" name="TextBox 6"/>
+          <p:cNvSpPr txBox="1"/>
+          <p:nvPr/>
+        </p:nvSpPr>
+        <p:spPr>
+          <a:xfrm>
+            <a:off x="822960" y="1371600"/>
+            <a:ext cx="10607040" cy="457200"/>
+          </a:xfrm>
+          <a:prstGeom prst="rect">
+            <a:avLst/>
+          </a:prstGeom>
+          <a:noFill/>
+        </p:spPr>
+        <p:txBody>
+          <a:bodyPr wrap="square">
+            <a:spAutoFit/>
+          </a:bodyPr>
+          <a:lstStyle/>
+          <a:p>
+            <a:pPr algn="ctr"/>
+            <a:r>
+              <a:rPr sz="1400" b="1">
+                <a:solidFill>
+                  <a:srgbClr val="924E0E"/>
+                </a:solidFill>
+                <a:latin typeface="Calibri"/>
+              </a:rPr>
+              <a:t>⚠️  No es necesario aplicar las correcciones en el código. Solo ANALIZAR y PROPONER en texto.</a:t>
+            </a:r>
+          </a:p>
+        </p:txBody>
+      </p:sp>
+      <p:sp>
+        <p:nvSpPr>
           <p:cNvPr id="8" name="TextBox 7"/>
           <p:cNvSpPr txBox="1"/>
           <p:nvPr/>
         </p:nvSpPr>
         <p:spPr>
           <a:xfrm>
-            <a:off x="822960" y="3749039"/>
-            <a:ext cx="10607040" cy="365760"/>
-          </a:xfrm>
-          <a:prstGeom prst="rect">
-            <a:avLst/>
-          </a:prstGeom>
-          <a:noFill/>
-        </p:spPr>
-        <p:txBody>
-          <a:bodyPr wrap="square">
-            <a:spAutoFit/>
-          </a:bodyPr>
-          <a:lstStyle/>
-          <a:p>
-            <a:pPr algn="ctr"/>
-            <a:r>
-              <a:rPr sz="1400" b="1">
-                <a:solidFill>
-                  <a:srgbClr val="EA580C"/>
-                </a:solidFill>
-                <a:latin typeface="Calibri"/>
-              </a:rPr>
-              <a:t>🔗 LINK DIRECTO para publicar tu repo + sitio público:</a:t>
+            <a:off x="640080" y="2103120"/>
+            <a:ext cx="10972800" cy="365760"/>
+          </a:xfrm>
+          <a:prstGeom prst="rect">
+            <a:avLst/>
+          </a:prstGeom>
+          <a:noFill/>
+        </p:spPr>
+        <p:txBody>
+          <a:bodyPr wrap="square">
+            <a:spAutoFit/>
+          </a:bodyPr>
+          <a:lstStyle/>
+          <a:p>
+            <a:pPr algn="l"/>
+            <a:r>
+              <a:rPr sz="1600" b="1">
+                <a:solidFill>
+                  <a:srgbClr val="065A82"/>
+                </a:solidFill>
+                <a:latin typeface="Calibri"/>
+              </a:rPr>
+              <a:t>En cada Issue, completa la sección Solución propuesta:</a:t>
             </a:r>
           </a:p>
         </p:txBody>
@@ -3888,84 +3840,97 @@
         </p:nvSpPr>
         <p:spPr>
           <a:xfrm>
-            <a:off x="822960" y="4160520"/>
-            <a:ext cx="10607040" cy="457200"/>
-          </a:xfrm>
-          <a:prstGeom prst="rect">
-            <a:avLst/>
-          </a:prstGeom>
-          <a:noFill/>
-        </p:spPr>
-        <p:txBody>
-          <a:bodyPr wrap="square">
-            <a:spAutoFit/>
-          </a:bodyPr>
-          <a:lstStyle/>
-          <a:p>
-            <a:pPr algn="ctr"/>
-            <a:r>
-              <a:rPr sz="1400" b="1">
+            <a:off x="822960" y="2560320"/>
+            <a:ext cx="10972800" cy="1828800"/>
+          </a:xfrm>
+          <a:prstGeom prst="rect">
+            <a:avLst/>
+          </a:prstGeom>
+          <a:noFill/>
+        </p:spPr>
+        <p:txBody>
+          <a:bodyPr wrap="square">
+            <a:spAutoFit/>
+          </a:bodyPr>
+          <a:lstStyle/>
+          <a:p>
+            <a:pPr algn="l"/>
+            <a:r>
+              <a:rPr sz="1300" b="0">
                 <a:solidFill>
                   <a:srgbClr val="2A2A2A"/>
                 </a:solidFill>
-                <a:latin typeface="Consolas"/>
-              </a:rPr>
-              <a:t>https://github.com/KrizRoMe/evaluacion-administracion-web/issues/new?template=link-evaluacion.yml</a:t>
-            </a:r>
-          </a:p>
-        </p:txBody>
-      </p:sp>
-      <p:sp>
-        <p:nvSpPr>
-          <p:cNvPr id="10" name="TextBox 9"/>
-          <p:cNvSpPr txBox="1"/>
-          <p:nvPr/>
-        </p:nvSpPr>
-        <p:spPr>
-          <a:xfrm>
-            <a:off x="822960" y="4572000"/>
-            <a:ext cx="10607040" cy="274320"/>
-          </a:xfrm>
-          <a:prstGeom prst="rect">
-            <a:avLst/>
-          </a:prstGeom>
-          <a:noFill/>
-        </p:spPr>
-        <p:txBody>
-          <a:bodyPr wrap="square">
-            <a:spAutoFit/>
-          </a:bodyPr>
-          <a:lstStyle/>
-          <a:p>
-            <a:pPr algn="ctr"/>
-            <a:r>
-              <a:rPr sz="1000" b="0">
-                <a:solidFill>
-                  <a:srgbClr val="999999"/>
-                </a:solidFill>
-                <a:latin typeface="Calibri"/>
-              </a:rPr>
-              <a:t>(también lo encuentras en la pestaña Issues del repo del docente)</a:t>
-            </a:r>
-          </a:p>
-        </p:txBody>
-      </p:sp>
-      <p:sp>
-        <p:nvSpPr>
-          <p:cNvPr id="11" name="Rounded Rectangle 10"/>
+                <a:latin typeface="Calibri"/>
+              </a:rPr>
+              <a:t>"Agregar atributos width y height a la etiqueta &lt;img&gt; del hero."</a:t>
+            </a:r>
+          </a:p>
+          <a:p>
+            <a:pPr algn="l"/>
+            <a:r>
+              <a:rPr sz="1300" b="0">
+                <a:solidFill>
+                  <a:srgbClr val="2A2A2A"/>
+                </a:solidFill>
+                <a:latin typeface="Calibri"/>
+              </a:rPr>
+              <a:t>"Añadir el atributo defer al &lt;script&gt;."</a:t>
+            </a:r>
+          </a:p>
+          <a:p>
+            <a:pPr algn="l"/>
+            <a:r>
+              <a:rPr sz="1300" b="0">
+                <a:solidFill>
+                  <a:srgbClr val="2A2A2A"/>
+                </a:solidFill>
+                <a:latin typeface="Calibri"/>
+              </a:rPr>
+              <a:t>"Actualizar jquery a una versión 3.x."</a:t>
+            </a:r>
+          </a:p>
+          <a:p>
+            <a:pPr algn="l"/>
+            <a:r>
+              <a:rPr sz="1300" b="0">
+                <a:solidFill>
+                  <a:srgbClr val="2A2A2A"/>
+                </a:solidFill>
+                <a:latin typeface="Calibri"/>
+              </a:rPr>
+              <a:t>"Cambiar el texto del footer por la fecha actual."</a:t>
+            </a:r>
+          </a:p>
+          <a:p>
+            <a:pPr algn="l"/>
+            <a:r>
+              <a:rPr sz="1300" b="0">
+                <a:solidFill>
+                  <a:srgbClr val="2A2A2A"/>
+                </a:solidFill>
+                <a:latin typeface="Calibri"/>
+              </a:rPr>
+              <a:t>"Agregar atributo alt descriptivo a las imágenes."</a:t>
+            </a:r>
+          </a:p>
+        </p:txBody>
+      </p:sp>
+      <p:sp>
+        <p:nvSpPr>
+          <p:cNvPr id="10" name="Rounded Rectangle 9"/>
           <p:cNvSpPr/>
           <p:nvPr/>
         </p:nvSpPr>
         <p:spPr>
           <a:xfrm>
-            <a:off x="640080" y="5120640"/>
-            <a:ext cx="10972800" cy="1188720"/>
+            <a:off x="640080" y="4572000"/>
+            <a:ext cx="10972800" cy="1737360"/>
           </a:xfrm>
           <a:prstGeom prst="roundRect">
             <a:avLst/>
           </a:prstGeom>
           <a:solidFill>
-            <a:srgbClr val="F4F4F4"/>
+            <a:srgbClr val="E3F2FD"/>
           </a:solidFill>
           <a:ln>
             <a:solidFill>
@@ -3997,35 +3962,70 @@
       </p:sp>
       <p:sp>
         <p:nvSpPr>
+          <p:cNvPr id="11" name="TextBox 10"/>
+          <p:cNvSpPr txBox="1"/>
+          <p:nvPr/>
+        </p:nvSpPr>
+        <p:spPr>
+          <a:xfrm>
+            <a:off x="822960" y="4617720"/>
+            <a:ext cx="10607040" cy="274320"/>
+          </a:xfrm>
+          <a:prstGeom prst="rect">
+            <a:avLst/>
+          </a:prstGeom>
+          <a:noFill/>
+        </p:spPr>
+        <p:txBody>
+          <a:bodyPr wrap="square">
+            <a:spAutoFit/>
+          </a:bodyPr>
+          <a:lstStyle/>
+          <a:p>
+            <a:pPr algn="l"/>
+            <a:r>
+              <a:rPr sz="1400" b="1">
+                <a:solidFill>
+                  <a:srgbClr val="065A82"/>
+                </a:solidFill>
+                <a:latin typeface="Calibri"/>
+              </a:rPr>
+              <a:t>📚 Tu README debe incluir:</a:t>
+            </a:r>
+          </a:p>
+        </p:txBody>
+      </p:sp>
+      <p:sp>
+        <p:nvSpPr>
           <p:cNvPr id="12" name="TextBox 11"/>
           <p:cNvSpPr txBox="1"/>
           <p:nvPr/>
         </p:nvSpPr>
         <p:spPr>
           <a:xfrm>
-            <a:off x="822960" y="5166360"/>
-            <a:ext cx="10607040" cy="274320"/>
-          </a:xfrm>
-          <a:prstGeom prst="rect">
-            <a:avLst/>
-          </a:prstGeom>
-          <a:noFill/>
-        </p:spPr>
-        <p:txBody>
-          <a:bodyPr wrap="square">
-            <a:spAutoFit/>
-          </a:bodyPr>
-          <a:lstStyle/>
-          <a:p>
-            <a:pPr algn="l"/>
-            <a:r>
-              <a:rPr sz="1300" b="1">
-                <a:solidFill>
-                  <a:srgbClr val="065A82"/>
-                </a:solidFill>
-                <a:latin typeface="Calibri"/>
-              </a:rPr>
-              <a:t>La Issue te pide SOLO:</a:t>
+            <a:off x="914400" y="4937760"/>
+            <a:ext cx="10424160" cy="1371600"/>
+          </a:xfrm>
+          <a:prstGeom prst="rect">
+            <a:avLst/>
+          </a:prstGeom>
+          <a:noFill/>
+        </p:spPr>
+        <p:txBody>
+          <a:bodyPr wrap="square">
+            <a:spAutoFit/>
+          </a:bodyPr>
+          <a:lstStyle/>
+          <a:p>
+            <a:pPr algn="l"/>
+            <a:r>
+              <a:rPr sz="1200" b="0">
+                <a:solidFill>
+                  <a:srgbClr val="2A2A2A"/>
+                </a:solidFill>
+                <a:latin typeface="Calibri"/>
+              </a:rPr>
+              <a:t>VIVO · RÁPIDO (con LCP/INP/CLS/TTFB) · SEGURO (2 acciones) · Backup 3-2-1 · SLI · SLO · SLA · Runbook (4–6 pasos) · Datos del estudiante + URLs</a:t>
             </a:r>
           </a:p>
         </p:txBody>
@@ -4033,41 +4033,6 @@
       <p:sp>
         <p:nvSpPr>
           <p:cNvPr id="13" name="TextBox 12"/>
-          <p:cNvSpPr txBox="1"/>
-          <p:nvPr/>
-        </p:nvSpPr>
-        <p:spPr>
-          <a:xfrm>
-            <a:off x="1005840" y="5486400"/>
-            <a:ext cx="10424160" cy="822960"/>
-          </a:xfrm>
-          <a:prstGeom prst="rect">
-            <a:avLst/>
-          </a:prstGeom>
-          <a:noFill/>
-        </p:spPr>
-        <p:txBody>
-          <a:bodyPr wrap="square">
-            <a:spAutoFit/>
-          </a:bodyPr>
-          <a:lstStyle/>
-          <a:p>
-            <a:pPr algn="l"/>
-            <a:r>
-              <a:rPr sz="1200" b="0">
-                <a:solidFill>
-                  <a:srgbClr val="2A2A2A"/>
-                </a:solidFill>
-                <a:latin typeface="Calibri"/>
-              </a:rPr>
-              <a:t>• Nombre completo  •  Link de tu repositorio  •  Link público de tu sitio</a:t>
-            </a:r>
-          </a:p>
-        </p:txBody>
-      </p:sp>
-      <p:sp>
-        <p:nvSpPr>
-          <p:cNvPr id="14" name="TextBox 13"/>
           <p:cNvSpPr txBox="1"/>
           <p:nvPr/>
         </p:nvSpPr>
@@ -4095,14 +4060,14 @@
                 </a:solidFill>
                 <a:latin typeface="Calibri"/>
               </a:rPr>
-              <a:t>📦 Repo: github.com/KrizRoMe/evaluacion-administracion-web   •   🌐 Web: krizrome.github.io/evaluacion-administracion-web   •   📋 Issues: github.com/KrizRoMe/evaluacion-administracion-web/issues</a:t>
-            </a:r>
-          </a:p>
-        </p:txBody>
-      </p:sp>
-      <p:sp>
-        <p:nvSpPr>
-          <p:cNvPr id="15" name="TextBox 14"/>
+              <a:t>📦 Repo del docente: github.com/KrizRoMe/evaluacion-administracion-web   •   🌐 Sitio público: krizrome.github.io/evaluacion-administracion-web   •   📋 Issues: github.com/KrizRoMe/evaluacion-administracion-web/issues</a:t>
+            </a:r>
+          </a:p>
+        </p:txBody>
+      </p:sp>
+      <p:sp>
+        <p:nvSpPr>
+          <p:cNvPr id="14" name="TextBox 13"/>
           <p:cNvSpPr txBox="1"/>
           <p:nvPr/>
         </p:nvSpPr>
@@ -4304,7 +4269,7 @@
                 </a:solidFill>
                 <a:latin typeface="Calibri"/>
               </a:rPr>
-              <a:t>Antes de publicar tu link de evaluación, verifica TODO</a:t>
+              <a:t>4 Issues en el repo del docente: 3 hallazgos + 1 link-evaluación</a:t>
             </a:r>
           </a:p>
         </p:txBody>
@@ -4368,7 +4333,7 @@
           <a:p>
             <a:pPr algn="l"/>
             <a:r>
-              <a:rPr sz="1400" b="0">
+              <a:rPr sz="1300" b="0">
                 <a:solidFill>
                   <a:srgbClr val="2A2A2A"/>
                 </a:solidFill>
@@ -4380,7 +4345,7 @@
           <a:p>
             <a:pPr algn="l"/>
             <a:r>
-              <a:rPr sz="1400" b="0">
+              <a:rPr sz="1300" b="0">
                 <a:solidFill>
                   <a:srgbClr val="2A2A2A"/>
                 </a:solidFill>
@@ -4392,61 +4357,85 @@
           <a:p>
             <a:pPr algn="l"/>
             <a:r>
-              <a:rPr sz="1400" b="0">
+              <a:rPr sz="1300" b="0">
                 <a:solidFill>
                   <a:srgbClr val="2A2A2A"/>
                 </a:solidFill>
                 <a:latin typeface="Calibri"/>
               </a:rPr>
-              <a:t>☐ EXACTAMENTE 4 Issues creadas</a:t>
-            </a:r>
-          </a:p>
-          <a:p>
-            <a:pPr algn="l"/>
-            <a:r>
-              <a:rPr sz="1400" b="0">
+              <a:t>☐ README completo</a:t>
+            </a:r>
+          </a:p>
+          <a:p>
+            <a:pPr algn="l"/>
+            <a:r>
+              <a:rPr sz="1300" b="0">
                 <a:solidFill>
                   <a:srgbClr val="2A2A2A"/>
                 </a:solidFill>
                 <a:latin typeface="Calibri"/>
               </a:rPr>
-              <a:t>☐ Cada Issue usa un template .yml</a:t>
-            </a:r>
-          </a:p>
-          <a:p>
-            <a:pPr algn="l"/>
-            <a:r>
-              <a:rPr sz="1400" b="0">
+              <a:t>☐ URLs y datos del estudiante</a:t>
+            </a:r>
+          </a:p>
+          <a:p>
+            <a:pPr algn="l"/>
+            <a:r>
+              <a:rPr sz="1300" b="0">
                 <a:solidFill>
                   <a:srgbClr val="2A2A2A"/>
                 </a:solidFill>
                 <a:latin typeface="Calibri"/>
               </a:rPr>
-              <a:t>☐ Cada Issue completa todas las secciones</a:t>
-            </a:r>
-          </a:p>
-          <a:p>
-            <a:pPr algn="l"/>
-            <a:r>
-              <a:rPr sz="1400" b="0">
+              <a:t/>
+            </a:r>
+          </a:p>
+          <a:p>
+            <a:pPr algn="l"/>
+            <a:r>
+              <a:rPr sz="1300" b="1">
                 <a:solidFill>
                   <a:srgbClr val="2A2A2A"/>
                 </a:solidFill>
                 <a:latin typeface="Calibri"/>
               </a:rPr>
-              <a:t>☐ README completo</a:t>
-            </a:r>
-          </a:p>
-          <a:p>
-            <a:pPr algn="l"/>
-            <a:r>
-              <a:rPr sz="1400" b="0">
+              <a:t>📋 3 ISSUES EN REPO DEL DOCENTE:</a:t>
+            </a:r>
+          </a:p>
+          <a:p>
+            <a:pPr algn="l"/>
+            <a:r>
+              <a:rPr sz="1300" b="0">
                 <a:solidFill>
                   <a:srgbClr val="2A2A2A"/>
                 </a:solidFill>
                 <a:latin typeface="Calibri"/>
               </a:rPr>
-              <a:t>☐ URLs y datos del estudiante</a:t>
+              <a:t>☐ Issue 1: rendimiento.yml</a:t>
+            </a:r>
+          </a:p>
+          <a:p>
+            <a:pPr algn="l"/>
+            <a:r>
+              <a:rPr sz="1300" b="0">
+                <a:solidFill>
+                  <a:srgbClr val="2A2A2A"/>
+                </a:solidFill>
+                <a:latin typeface="Calibri"/>
+              </a:rPr>
+              <a:t>☐ Issue 2: accesibilidad.yml</a:t>
+            </a:r>
+          </a:p>
+          <a:p>
+            <a:pPr algn="l"/>
+            <a:r>
+              <a:rPr sz="1300" b="0">
+                <a:solidFill>
+                  <a:srgbClr val="2A2A2A"/>
+                </a:solidFill>
+                <a:latin typeface="Calibri"/>
+              </a:rPr>
+              <a:t>☐ Issue 3: mantenimiento.yml</a:t>
             </a:r>
           </a:p>
         </p:txBody>
@@ -4481,7 +4470,7 @@
                 </a:solidFill>
                 <a:latin typeface="Calibri"/>
               </a:rPr>
-              <a:t>🔗 En repo del DOCENTE:</a:t>
+              <a:t>🔗 4ª ISSUE en repo del DOCENTE:</a:t>
             </a:r>
           </a:p>
         </p:txBody>
@@ -4510,7 +4499,7 @@
           <a:p>
             <a:pPr algn="l"/>
             <a:r>
-              <a:rPr sz="1400" b="0">
+              <a:rPr sz="1300" b="0">
                 <a:solidFill>
                   <a:srgbClr val="2A2A2A"/>
                 </a:solidFill>
@@ -4522,7 +4511,7 @@
           <a:p>
             <a:pPr algn="l"/>
             <a:r>
-              <a:rPr sz="1400" b="0">
+              <a:rPr sz="1300" b="0">
                 <a:solidFill>
                   <a:srgbClr val="2A2A2A"/>
                 </a:solidFill>
@@ -4534,7 +4523,7 @@
           <a:p>
             <a:pPr algn="l"/>
             <a:r>
-              <a:rPr sz="1400" b="0">
+              <a:rPr sz="1300" b="0">
                 <a:solidFill>
                   <a:srgbClr val="2A2A2A"/>
                 </a:solidFill>
@@ -4546,7 +4535,7 @@
           <a:p>
             <a:pPr algn="l"/>
             <a:r>
-              <a:rPr sz="1400" b="0">
+              <a:rPr sz="1300" b="0">
                 <a:solidFill>
                   <a:srgbClr val="2A2A2A"/>
                 </a:solidFill>
@@ -4558,7 +4547,7 @@
           <a:p>
             <a:pPr algn="l"/>
             <a:r>
-              <a:rPr sz="1400" b="0">
+              <a:rPr sz="1300" b="0">
                 <a:solidFill>
                   <a:srgbClr val="2A2A2A"/>
                 </a:solidFill>
@@ -4570,7 +4559,7 @@
           <a:p>
             <a:pPr algn="l"/>
             <a:r>
-              <a:rPr sz="1400" b="0">
+              <a:rPr sz="1300" b="0">
                 <a:solidFill>
                   <a:srgbClr val="2A2A2A"/>
                 </a:solidFill>
@@ -4582,13 +4571,49 @@
           <a:p>
             <a:pPr algn="l"/>
             <a:r>
-              <a:rPr sz="1400" b="0">
+              <a:rPr sz="1300" b="0">
                 <a:solidFill>
                   <a:srgbClr val="2A2A2A"/>
                 </a:solidFill>
                 <a:latin typeface="Calibri"/>
               </a:rPr>
-              <a:t>☐ Solo una Issue, no más</a:t>
+              <a:t/>
+            </a:r>
+          </a:p>
+          <a:p>
+            <a:pPr algn="l"/>
+            <a:r>
+              <a:rPr sz="1300" b="1">
+                <a:solidFill>
+                  <a:srgbClr val="2A2A2A"/>
+                </a:solidFill>
+                <a:latin typeface="Calibri"/>
+              </a:rPr>
+              <a:t>📊 PUNTAJE TOTAL: 20 pts</a:t>
+            </a:r>
+          </a:p>
+          <a:p>
+            <a:pPr algn="l"/>
+            <a:r>
+              <a:rPr sz="1300" b="0">
+                <a:solidFill>
+                  <a:srgbClr val="2A2A2A"/>
+                </a:solidFill>
+                <a:latin typeface="Calibri"/>
+              </a:rPr>
+              <a:t>• 3 Issues hallazgos × 5 pts = 15</a:t>
+            </a:r>
+          </a:p>
+          <a:p>
+            <a:pPr algn="l"/>
+            <a:r>
+              <a:rPr sz="1300" b="0">
+                <a:solidFill>
+                  <a:srgbClr val="2A2A2A"/>
+                </a:solidFill>
+                <a:latin typeface="Calibri"/>
+              </a:rPr>
+              <a:t>• 1 Issue link-evaluación × 5 pts = 5</a:t>
             </a:r>
           </a:p>
         </p:txBody>
@@ -4608,7 +4633,7 @@
             <a:avLst/>
           </a:prstGeom>
           <a:solidFill>
-            <a:srgbClr val="EA580C"/>
+            <a:srgbClr val="10B981"/>
           </a:solidFill>
           <a:ln>
             <a:noFill/>
@@ -4645,7 +4670,7 @@
         <p:spPr>
           <a:xfrm>
             <a:off x="822960" y="4983480"/>
-            <a:ext cx="10607040" cy="365760"/>
+            <a:ext cx="10607040" cy="1371600"/>
           </a:xfrm>
           <a:prstGeom prst="rect">
             <a:avLst/>
@@ -4660,13 +4685,49 @@
           <a:p>
             <a:pPr algn="ctr"/>
             <a:r>
-              <a:rPr sz="1400" b="1">
+              <a:rPr sz="1600" b="1">
                 <a:solidFill>
                   <a:srgbClr val="FFFFFF"/>
                 </a:solidFill>
                 <a:latin typeface="Calibri"/>
               </a:rPr>
-              <a:t>🔗 Publicar link de evaluación aquí:</a:t>
+              <a:t>📊 PUNTAJE TOTAL: 20 puntos</a:t>
+            </a:r>
+          </a:p>
+          <a:p>
+            <a:pPr algn="ctr"/>
+            <a:r>
+              <a:rPr sz="1600" b="0">
+                <a:solidFill>
+                  <a:srgbClr val="FFFFFF"/>
+                </a:solidFill>
+                <a:latin typeface="Calibri"/>
+              </a:rPr>
+              <a:t>• 3 Issues de hallazgos × 5 pts = 15 pts</a:t>
+            </a:r>
+          </a:p>
+          <a:p>
+            <a:pPr algn="ctr"/>
+            <a:r>
+              <a:rPr sz="1600" b="0">
+                <a:solidFill>
+                  <a:srgbClr val="FFFFFF"/>
+                </a:solidFill>
+                <a:latin typeface="Calibri"/>
+              </a:rPr>
+              <a:t>• 1 Issue de link-evaluación × 5 pts = 5 pts</a:t>
+            </a:r>
+          </a:p>
+          <a:p>
+            <a:pPr algn="ctr"/>
+            <a:r>
+              <a:rPr sz="1600" b="0">
+                <a:solidFill>
+                  <a:srgbClr val="FFFFFF"/>
+                </a:solidFill>
+                <a:latin typeface="Calibri"/>
+              </a:rPr>
+              <a:t>Aprobado: ≥14 pts</a:t>
             </a:r>
           </a:p>
         </p:txBody>
@@ -4674,76 +4735,6 @@
       <p:sp>
         <p:nvSpPr>
           <p:cNvPr id="12" name="TextBox 11"/>
-          <p:cNvSpPr txBox="1"/>
-          <p:nvPr/>
-        </p:nvSpPr>
-        <p:spPr>
-          <a:xfrm>
-            <a:off x="822960" y="5394960"/>
-            <a:ext cx="10607040" cy="548640"/>
-          </a:xfrm>
-          <a:prstGeom prst="rect">
-            <a:avLst/>
-          </a:prstGeom>
-          <a:noFill/>
-        </p:spPr>
-        <p:txBody>
-          <a:bodyPr wrap="square">
-            <a:spAutoFit/>
-          </a:bodyPr>
-          <a:lstStyle/>
-          <a:p>
-            <a:pPr algn="ctr"/>
-            <a:r>
-              <a:rPr sz="1200" b="1">
-                <a:solidFill>
-                  <a:srgbClr val="FFFFFF"/>
-                </a:solidFill>
-                <a:latin typeface="Consolas"/>
-              </a:rPr>
-              <a:t>https://github.com/KrizRoMe/evaluacion-administracion-web/issues/new?template=link-evaluacion.yml</a:t>
-            </a:r>
-          </a:p>
-        </p:txBody>
-      </p:sp>
-      <p:sp>
-        <p:nvSpPr>
-          <p:cNvPr id="13" name="TextBox 12"/>
-          <p:cNvSpPr txBox="1"/>
-          <p:nvPr/>
-        </p:nvSpPr>
-        <p:spPr>
-          <a:xfrm>
-            <a:off x="822960" y="5989320"/>
-            <a:ext cx="10607040" cy="274320"/>
-          </a:xfrm>
-          <a:prstGeom prst="rect">
-            <a:avLst/>
-          </a:prstGeom>
-          <a:noFill/>
-        </p:spPr>
-        <p:txBody>
-          <a:bodyPr wrap="square">
-            <a:spAutoFit/>
-          </a:bodyPr>
-          <a:lstStyle/>
-          <a:p>
-            <a:pPr algn="ctr"/>
-            <a:r>
-              <a:rPr sz="1100" b="0">
-                <a:solidFill>
-                  <a:srgbClr val="FED3B6"/>
-                </a:solidFill>
-                <a:latin typeface="Calibri"/>
-              </a:rPr>
-              <a:t>📌  Las 4 Issues van en TU repo.  El link va AQUÍ (solo una Issue).</a:t>
-            </a:r>
-          </a:p>
-        </p:txBody>
-      </p:sp>
-      <p:sp>
-        <p:nvSpPr>
-          <p:cNvPr id="14" name="TextBox 13"/>
           <p:cNvSpPr txBox="1"/>
           <p:nvPr/>
         </p:nvSpPr>
@@ -4771,14 +4762,14 @@
                 </a:solidFill>
                 <a:latin typeface="Calibri"/>
               </a:rPr>
-              <a:t>📦 Repo: github.com/KrizRoMe/evaluacion-administracion-web   •   🌐 Web: krizrome.github.io/evaluacion-administracion-web   •   📋 Issues: github.com/KrizRoMe/evaluacion-administracion-web/issues</a:t>
-            </a:r>
-          </a:p>
-        </p:txBody>
-      </p:sp>
-      <p:sp>
-        <p:nvSpPr>
-          <p:cNvPr id="15" name="TextBox 14"/>
+              <a:t>📦 Repo del docente: github.com/KrizRoMe/evaluacion-administracion-web   •   🌐 Sitio público: krizrome.github.io/evaluacion-administracion-web   •   📋 Issues: github.com/KrizRoMe/evaluacion-administracion-web/issues</a:t>
+            </a:r>
+          </a:p>
+        </p:txBody>
+      </p:sp>
+      <p:sp>
+        <p:nvSpPr>
+          <p:cNvPr id="13" name="TextBox 12"/>
           <p:cNvSpPr txBox="1"/>
           <p:nvPr/>
         </p:nvSpPr>
@@ -5321,7 +5312,7 @@
                 </a:solidFill>
                 <a:latin typeface="Calibri"/>
               </a:rPr>
-              <a:t>📦 Repo: github.com/KrizRoMe/evaluacion-administracion-web   •   🌐 Web: krizrome.github.io/evaluacion-administracion-web   •   📋 Issues: github.com/KrizRoMe/evaluacion-administracion-web/issues</a:t>
+              <a:t>📦 Repo del docente: github.com/KrizRoMe/evaluacion-administracion-web   •   🌐 Sitio público: krizrome.github.io/evaluacion-administracion-web   •   📋 Issues: github.com/KrizRoMe/evaluacion-administracion-web/issues</a:t>
             </a:r>
           </a:p>
         </p:txBody>
@@ -5530,7 +5521,7 @@
                 </a:solidFill>
                 <a:latin typeface="Calibri"/>
               </a:rPr>
-              <a:t>Sitio base + tu repo + link de evaluación</a:t>
+              <a:t>Sitio base + tu repo + 4 Issues en el repo del docente</a:t>
             </a:r>
           </a:p>
         </p:txBody>
@@ -5693,7 +5684,7 @@
         </p:nvSpPr>
         <p:spPr>
           <a:xfrm>
-            <a:off x="640080" y="2468880"/>
+            <a:off x="640080" y="2377440"/>
             <a:ext cx="10972800" cy="457200"/>
           </a:xfrm>
           <a:prstGeom prst="rect">
@@ -5715,7 +5706,7 @@
                 </a:solidFill>
                 <a:latin typeface="Calibri"/>
               </a:rPr>
-              <a:t>📦  Tu repositorio (donde subirás TU evaluación)</a:t>
+              <a:t>📦  Tu repositorio (donde subirás TU sitio desplegado)</a:t>
             </a:r>
           </a:p>
         </p:txBody>
@@ -5728,7 +5719,7 @@
         </p:nvSpPr>
         <p:spPr>
           <a:xfrm>
-            <a:off x="640080" y="2880360"/>
+            <a:off x="640080" y="2788920"/>
             <a:ext cx="10972800" cy="822960"/>
           </a:xfrm>
           <a:prstGeom prst="roundRect">
@@ -5773,7 +5764,7 @@
         </p:nvSpPr>
         <p:spPr>
           <a:xfrm>
-            <a:off x="822959" y="2971800"/>
+            <a:off x="822959" y="2880360"/>
             <a:ext cx="10607040" cy="365760"/>
           </a:xfrm>
           <a:prstGeom prst="rect">
@@ -5808,7 +5799,7 @@
         </p:nvSpPr>
         <p:spPr>
           <a:xfrm>
-            <a:off x="822959" y="3383279"/>
+            <a:off x="822959" y="3291839"/>
             <a:ext cx="10607040" cy="274320"/>
           </a:xfrm>
           <a:prstGeom prst="rect">
@@ -5843,7 +5834,7 @@
         </p:nvSpPr>
         <p:spPr>
           <a:xfrm>
-            <a:off x="640080" y="3749039"/>
+            <a:off x="640080" y="3566160"/>
             <a:ext cx="10972800" cy="457200"/>
           </a:xfrm>
           <a:prstGeom prst="rect">
@@ -5878,7 +5869,7 @@
         </p:nvSpPr>
         <p:spPr>
           <a:xfrm>
-            <a:off x="640080" y="4160520"/>
+            <a:off x="640080" y="3977639"/>
             <a:ext cx="10972800" cy="822960"/>
           </a:xfrm>
           <a:prstGeom prst="roundRect">
@@ -5923,7 +5914,7 @@
         </p:nvSpPr>
         <p:spPr>
           <a:xfrm>
-            <a:off x="822959" y="4251959"/>
+            <a:off x="822959" y="4069079"/>
             <a:ext cx="10607040" cy="365760"/>
           </a:xfrm>
           <a:prstGeom prst="rect">
@@ -5958,7 +5949,7 @@
         </p:nvSpPr>
         <p:spPr>
           <a:xfrm>
-            <a:off x="822959" y="4663440"/>
+            <a:off x="822959" y="4480559"/>
             <a:ext cx="10607040" cy="274320"/>
           </a:xfrm>
           <a:prstGeom prst="rect">
@@ -5993,7 +5984,7 @@
         </p:nvSpPr>
         <p:spPr>
           <a:xfrm>
-            <a:off x="640080" y="5029200"/>
+            <a:off x="640080" y="4754880"/>
             <a:ext cx="10972800" cy="457200"/>
           </a:xfrm>
           <a:prstGeom prst="rect">
@@ -6015,7 +6006,7 @@
                 </a:solidFill>
                 <a:latin typeface="Calibri"/>
               </a:rPr>
-              <a:t>🔗  Link de evaluación (publicar tu repo + sitio público)</a:t>
+              <a:t>📋  Repo del DOCENTE (donde crearás las 4 Issues)</a:t>
             </a:r>
           </a:p>
         </p:txBody>
@@ -6028,7 +6019,7 @@
         </p:nvSpPr>
         <p:spPr>
           <a:xfrm>
-            <a:off x="640080" y="5440680"/>
+            <a:off x="640080" y="5166360"/>
             <a:ext cx="10972800" cy="822960"/>
           </a:xfrm>
           <a:prstGeom prst="roundRect">
@@ -6073,7 +6064,7 @@
         </p:nvSpPr>
         <p:spPr>
           <a:xfrm>
-            <a:off x="822959" y="5532120"/>
+            <a:off x="822959" y="5257800"/>
             <a:ext cx="10607040" cy="365760"/>
           </a:xfrm>
           <a:prstGeom prst="rect">
@@ -6095,7 +6086,7 @@
                 </a:solidFill>
                 <a:latin typeface="Calibri"/>
               </a:rPr>
-              <a:t>Crear Issue con el template 'Link de evaluación' en el repo del docente:</a:t>
+              <a:t>Issues del docente</a:t>
             </a:r>
           </a:p>
         </p:txBody>
@@ -6108,7 +6099,7 @@
         </p:nvSpPr>
         <p:spPr>
           <a:xfrm>
-            <a:off x="822959" y="5943600"/>
+            <a:off x="822959" y="5669280"/>
             <a:ext cx="10607040" cy="274320"/>
           </a:xfrm>
           <a:prstGeom prst="rect">
@@ -6124,20 +6115,100 @@
           <a:p>
             <a:pPr algn="l"/>
             <a:r>
-              <a:rPr sz="1200" b="0">
+              <a:rPr sz="1400" b="0">
                 <a:solidFill>
                   <a:srgbClr val="2A2A2A"/>
                 </a:solidFill>
                 <a:latin typeface="Consolas"/>
               </a:rPr>
-              <a:t>https://github.com/KrizRoMe/evaluacion-administracion-web/issues/new?template=link-evaluacion.yml</a:t>
-            </a:r>
-          </a:p>
-        </p:txBody>
-      </p:sp>
-      <p:sp>
-        <p:nvSpPr>
-          <p:cNvPr id="22" name="TextBox 21"/>
+              <a:t>https://github.com/KrizRoMe/evaluacion-administracion-web/issues</a:t>
+            </a:r>
+          </a:p>
+        </p:txBody>
+      </p:sp>
+      <p:sp>
+        <p:nvSpPr>
+          <p:cNvPr id="22" name="Rounded Rectangle 21"/>
+          <p:cNvSpPr/>
+          <p:nvPr/>
+        </p:nvSpPr>
+        <p:spPr>
+          <a:xfrm>
+            <a:off x="640080" y="5943600"/>
+            <a:ext cx="10972800" cy="457200"/>
+          </a:xfrm>
+          <a:prstGeom prst="roundRect">
+            <a:avLst/>
+          </a:prstGeom>
+          <a:solidFill>
+            <a:srgbClr val="FEF3E6"/>
+          </a:solidFill>
+          <a:ln>
+            <a:solidFill>
+              <a:srgbClr val="EA580C"/>
+            </a:solidFill>
+          </a:ln>
+        </p:spPr>
+        <p:style>
+          <a:lnRef idx="1">
+            <a:schemeClr val="accent1"/>
+          </a:lnRef>
+          <a:fillRef idx="3">
+            <a:schemeClr val="accent1"/>
+          </a:fillRef>
+          <a:effectRef idx="2">
+            <a:schemeClr val="accent1"/>
+          </a:effectRef>
+          <a:fontRef idx="minor">
+            <a:schemeClr val="lt1"/>
+          </a:fontRef>
+        </p:style>
+        <p:txBody>
+          <a:bodyPr rtlCol="0" anchor="ctr"/>
+          <a:lstStyle/>
+          <a:p>
+            <a:pPr algn="ctr"/>
+          </a:p>
+        </p:txBody>
+      </p:sp>
+      <p:sp>
+        <p:nvSpPr>
+          <p:cNvPr id="23" name="TextBox 22"/>
+          <p:cNvSpPr txBox="1"/>
+          <p:nvPr/>
+        </p:nvSpPr>
+        <p:spPr>
+          <a:xfrm>
+            <a:off x="640080" y="5989320"/>
+            <a:ext cx="10972800" cy="365760"/>
+          </a:xfrm>
+          <a:prstGeom prst="rect">
+            <a:avLst/>
+          </a:prstGeom>
+          <a:noFill/>
+        </p:spPr>
+        <p:txBody>
+          <a:bodyPr wrap="square">
+            <a:spAutoFit/>
+          </a:bodyPr>
+          <a:lstStyle/>
+          <a:p>
+            <a:pPr algn="ctr"/>
+            <a:r>
+              <a:rPr sz="1400" b="1">
+                <a:solidFill>
+                  <a:srgbClr val="EA580C"/>
+                </a:solidFill>
+                <a:latin typeface="Calibri"/>
+              </a:rPr>
+              <a:t>⚠️  Las 4 Issues se crean en el repo del DOCENTE, NO en tu repo personal.</a:t>
+            </a:r>
+          </a:p>
+        </p:txBody>
+      </p:sp>
+      <p:sp>
+        <p:nvSpPr>
+          <p:cNvPr id="24" name="TextBox 23"/>
           <p:cNvSpPr txBox="1"/>
           <p:nvPr/>
         </p:nvSpPr>
@@ -6165,14 +6236,14 @@
                 </a:solidFill>
                 <a:latin typeface="Calibri"/>
               </a:rPr>
-              <a:t>📦 Repo: github.com/KrizRoMe/evaluacion-administracion-web   •   🌐 Web: krizrome.github.io/evaluacion-administracion-web   •   📋 Issues: github.com/KrizRoMe/evaluacion-administracion-web/issues</a:t>
-            </a:r>
-          </a:p>
-        </p:txBody>
-      </p:sp>
-      <p:sp>
-        <p:nvSpPr>
-          <p:cNvPr id="23" name="TextBox 22"/>
+              <a:t>📦 Repo del docente: github.com/KrizRoMe/evaluacion-administracion-web   •   🌐 Sitio público: krizrome.github.io/evaluacion-administracion-web   •   📋 Issues: github.com/KrizRoMe/evaluacion-administracion-web/issues</a:t>
+            </a:r>
+          </a:p>
+        </p:txBody>
+      </p:sp>
+      <p:sp>
+        <p:nvSpPr>
+          <p:cNvPr id="25" name="TextBox 24"/>
           <p:cNvSpPr txBox="1"/>
           <p:nvPr/>
         </p:nvSpPr>
@@ -6388,7 +6459,7 @@
         <p:spPr>
           <a:xfrm>
             <a:off x="723747" y="2286000"/>
-            <a:ext cx="1417320" cy="1554480"/>
+            <a:ext cx="1417320" cy="1737360"/>
           </a:xfrm>
           <a:prstGeom prst="roundRect">
             <a:avLst/>
@@ -6431,7 +6502,7 @@
         <p:spPr>
           <a:xfrm>
             <a:off x="723747" y="2606040"/>
-            <a:ext cx="1417320" cy="914400"/>
+            <a:ext cx="1417320" cy="1097280"/>
           </a:xfrm>
           <a:prstGeom prst="rect">
             <a:avLst/>
@@ -6446,7 +6517,7 @@
           <a:p>
             <a:pPr algn="ctr"/>
             <a:r>
-              <a:rPr sz="1300" b="1">
+              <a:rPr sz="1200" b="1">
                 <a:solidFill>
                   <a:srgbClr val="FFFFFF"/>
                 </a:solidFill>
@@ -6466,7 +6537,7 @@
         </p:nvSpPr>
         <p:spPr>
           <a:xfrm>
-            <a:off x="2150211" y="2926080"/>
+            <a:off x="2150211" y="3108960"/>
             <a:ext cx="118872" cy="274320"/>
           </a:xfrm>
           <a:prstGeom prst="rightArrow">
@@ -6510,7 +6581,7 @@
         <p:spPr>
           <a:xfrm>
             <a:off x="2278227" y="2286000"/>
-            <a:ext cx="1417320" cy="1554480"/>
+            <a:ext cx="1417320" cy="1737360"/>
           </a:xfrm>
           <a:prstGeom prst="roundRect">
             <a:avLst/>
@@ -6553,7 +6624,7 @@
         <p:spPr>
           <a:xfrm>
             <a:off x="2278227" y="2606040"/>
-            <a:ext cx="1417320" cy="914400"/>
+            <a:ext cx="1417320" cy="1097280"/>
           </a:xfrm>
           <a:prstGeom prst="rect">
             <a:avLst/>
@@ -6568,7 +6639,7 @@
           <a:p>
             <a:pPr algn="ctr"/>
             <a:r>
-              <a:rPr sz="1300" b="1">
+              <a:rPr sz="1200" b="1">
                 <a:solidFill>
                   <a:srgbClr val="FFFFFF"/>
                 </a:solidFill>
@@ -6588,7 +6659,7 @@
         </p:nvSpPr>
         <p:spPr>
           <a:xfrm>
-            <a:off x="3704691" y="2926080"/>
+            <a:off x="3704691" y="3108960"/>
             <a:ext cx="118872" cy="274320"/>
           </a:xfrm>
           <a:prstGeom prst="rightArrow">
@@ -6632,7 +6703,7 @@
         <p:spPr>
           <a:xfrm>
             <a:off x="3832707" y="2286000"/>
-            <a:ext cx="1417320" cy="1554480"/>
+            <a:ext cx="1417320" cy="1737360"/>
           </a:xfrm>
           <a:prstGeom prst="roundRect">
             <a:avLst/>
@@ -6675,7 +6746,7 @@
         <p:spPr>
           <a:xfrm>
             <a:off x="3832707" y="2606040"/>
-            <a:ext cx="1417320" cy="914400"/>
+            <a:ext cx="1417320" cy="1097280"/>
           </a:xfrm>
           <a:prstGeom prst="rect">
             <a:avLst/>
@@ -6690,7 +6761,7 @@
           <a:p>
             <a:pPr algn="ctr"/>
             <a:r>
-              <a:rPr sz="1300" b="1">
+              <a:rPr sz="1200" b="1">
                 <a:solidFill>
                   <a:srgbClr val="FFFFFF"/>
                 </a:solidFill>
@@ -6710,7 +6781,7 @@
         </p:nvSpPr>
         <p:spPr>
           <a:xfrm>
-            <a:off x="5259171" y="2926080"/>
+            <a:off x="5259171" y="3108960"/>
             <a:ext cx="118872" cy="274320"/>
           </a:xfrm>
           <a:prstGeom prst="rightArrow">
@@ -6754,7 +6825,7 @@
         <p:spPr>
           <a:xfrm>
             <a:off x="5387187" y="2286000"/>
-            <a:ext cx="1417320" cy="1554480"/>
+            <a:ext cx="1417320" cy="1737360"/>
           </a:xfrm>
           <a:prstGeom prst="roundRect">
             <a:avLst/>
@@ -6797,7 +6868,7 @@
         <p:spPr>
           <a:xfrm>
             <a:off x="5387187" y="2606040"/>
-            <a:ext cx="1417320" cy="914400"/>
+            <a:ext cx="1417320" cy="1097280"/>
           </a:xfrm>
           <a:prstGeom prst="rect">
             <a:avLst/>
@@ -6812,7 +6883,7 @@
           <a:p>
             <a:pPr algn="ctr"/>
             <a:r>
-              <a:rPr sz="1300" b="1">
+              <a:rPr sz="1200" b="1">
                 <a:solidFill>
                   <a:srgbClr val="FFFFFF"/>
                 </a:solidFill>
@@ -6832,7 +6903,7 @@
         </p:nvSpPr>
         <p:spPr>
           <a:xfrm>
-            <a:off x="6813651" y="2926080"/>
+            <a:off x="6813651" y="3108960"/>
             <a:ext cx="118872" cy="274320"/>
           </a:xfrm>
           <a:prstGeom prst="rightArrow">
@@ -6876,7 +6947,7 @@
         <p:spPr>
           <a:xfrm>
             <a:off x="6941667" y="2286000"/>
-            <a:ext cx="1417320" cy="1554480"/>
+            <a:ext cx="1417320" cy="1737360"/>
           </a:xfrm>
           <a:prstGeom prst="roundRect">
             <a:avLst/>
@@ -6919,7 +6990,7 @@
         <p:spPr>
           <a:xfrm>
             <a:off x="6941667" y="2606040"/>
-            <a:ext cx="1417320" cy="914400"/>
+            <a:ext cx="1417320" cy="1097280"/>
           </a:xfrm>
           <a:prstGeom prst="rect">
             <a:avLst/>
@@ -6934,14 +7005,15 @@
           <a:p>
             <a:pPr algn="ctr"/>
             <a:r>
-              <a:rPr sz="1300" b="1">
+              <a:rPr sz="1200" b="1">
                 <a:solidFill>
                   <a:srgbClr val="FFFFFF"/>
                 </a:solidFill>
                 <a:latin typeface="Calibri"/>
               </a:rPr>
-              <a:t>4 Issues
-en TU repo</a:t>
+              <a:t>3 Issues
+hallazgos
+(repo docente)</a:t>
             </a:r>
           </a:p>
         </p:txBody>
@@ -6954,7 +7026,7 @@
         </p:nvSpPr>
         <p:spPr>
           <a:xfrm>
-            <a:off x="8368131" y="2926080"/>
+            <a:off x="8368131" y="3108960"/>
             <a:ext cx="118872" cy="274320"/>
           </a:xfrm>
           <a:prstGeom prst="rightArrow">
@@ -6998,13 +7070,13 @@
         <p:spPr>
           <a:xfrm>
             <a:off x="8496147" y="2286000"/>
-            <a:ext cx="1417320" cy="1554480"/>
+            <a:ext cx="1417320" cy="1737360"/>
           </a:xfrm>
           <a:prstGeom prst="roundRect">
             <a:avLst/>
           </a:prstGeom>
           <a:solidFill>
-            <a:srgbClr val="1C7293"/>
+            <a:srgbClr val="EA580C"/>
           </a:solidFill>
           <a:ln>
             <a:noFill/>
@@ -7041,7 +7113,7 @@
         <p:spPr>
           <a:xfrm>
             <a:off x="8496147" y="2606040"/>
-            <a:ext cx="1417320" cy="914400"/>
+            <a:ext cx="1417320" cy="1097280"/>
           </a:xfrm>
           <a:prstGeom prst="rect">
             <a:avLst/>
@@ -7056,13 +7128,15 @@
           <a:p>
             <a:pPr algn="ctr"/>
             <a:r>
-              <a:rPr sz="1300" b="1">
+              <a:rPr sz="1200" b="1">
                 <a:solidFill>
                   <a:srgbClr val="FFFFFF"/>
                 </a:solidFill>
                 <a:latin typeface="Calibri"/>
               </a:rPr>
-              <a:t>README</a:t>
+              <a:t>Issue link
+evaluación
+(repo docente)</a:t>
             </a:r>
           </a:p>
         </p:txBody>
@@ -7075,7 +7149,7 @@
         </p:nvSpPr>
         <p:spPr>
           <a:xfrm>
-            <a:off x="9922611" y="2926080"/>
+            <a:off x="9922611" y="3108960"/>
             <a:ext cx="118872" cy="274320"/>
           </a:xfrm>
           <a:prstGeom prst="rightArrow">
@@ -7119,13 +7193,13 @@
         <p:spPr>
           <a:xfrm>
             <a:off x="10050627" y="2286000"/>
-            <a:ext cx="1417320" cy="1554480"/>
+            <a:ext cx="1417320" cy="1737360"/>
           </a:xfrm>
           <a:prstGeom prst="roundRect">
             <a:avLst/>
           </a:prstGeom>
           <a:solidFill>
-            <a:srgbClr val="EA580C"/>
+            <a:srgbClr val="065A82"/>
           </a:solidFill>
           <a:ln>
             <a:noFill/>
@@ -7162,7 +7236,7 @@
         <p:spPr>
           <a:xfrm>
             <a:off x="10050627" y="2606040"/>
-            <a:ext cx="1417320" cy="914400"/>
+            <a:ext cx="1417320" cy="1097280"/>
           </a:xfrm>
           <a:prstGeom prst="rect">
             <a:avLst/>
@@ -7177,14 +7251,14 @@
           <a:p>
             <a:pPr algn="ctr"/>
             <a:r>
-              <a:rPr sz="1300" b="1">
+              <a:rPr sz="1200" b="1">
                 <a:solidFill>
                   <a:srgbClr val="FFFFFF"/>
                 </a:solidFill>
                 <a:latin typeface="Calibri"/>
               </a:rPr>
-              <a:t>Link de
-evaluación AQUÍ</a:t>
+              <a:t>Entrega
+completa</a:t>
             </a:r>
           </a:p>
         </p:txBody>
@@ -7197,7 +7271,7 @@
         </p:nvSpPr>
         <p:spPr>
           <a:xfrm>
-            <a:off x="457200" y="4114800"/>
+            <a:off x="457200" y="4297680"/>
             <a:ext cx="10972800" cy="457200"/>
           </a:xfrm>
           <a:prstGeom prst="rect">
@@ -7213,7 +7287,7 @@
           <a:p>
             <a:pPr algn="l"/>
             <a:r>
-              <a:rPr sz="2000" b="1">
+              <a:rPr sz="1800" b="1">
                 <a:solidFill>
                   <a:srgbClr val="065A82"/>
                 </a:solidFill>
@@ -7232,8 +7306,8 @@
         </p:nvSpPr>
         <p:spPr>
           <a:xfrm>
-            <a:off x="457200" y="4572000"/>
-            <a:ext cx="10972800" cy="1188720"/>
+            <a:off x="457200" y="4754880"/>
+            <a:ext cx="10972800" cy="914400"/>
           </a:xfrm>
           <a:prstGeom prst="rect">
             <a:avLst/>
@@ -7266,7 +7340,7 @@
                 </a:solidFill>
                 <a:latin typeface="Calibri"/>
               </a:rPr>
-              <a:t>Issues (TU repo): 20 min   •   Documentar solución: 10 min   •   README: 15 min   •   Link de evaluación: 5 min</a:t>
+              <a:t>3 Issues hallazgos: 25 min   •   Documentar solución: 10 min   •   Issue link-evaluación: 5 min</a:t>
             </a:r>
           </a:p>
         </p:txBody>
@@ -7346,7 +7420,7 @@
                 </a:solidFill>
                 <a:latin typeface="Calibri"/>
               </a:rPr>
-              <a:t>⚠️  El sitio tiene 15 problemas. Tú solo necesitas identificar 4.</a:t>
+              <a:t>⚠️  El sitio tiene 15 problemas. Encontrarás 3 (uno de cada tipo).</a:t>
             </a:r>
           </a:p>
         </p:txBody>
@@ -7381,7 +7455,7 @@
                 </a:solidFill>
                 <a:latin typeface="Calibri"/>
               </a:rPr>
-              <a:t>📦 Repo: github.com/KrizRoMe/evaluacion-administracion-web   •   🌐 Web: krizrome.github.io/evaluacion-administracion-web   •   📋 Issues: github.com/KrizRoMe/evaluacion-administracion-web/issues</a:t>
+              <a:t>📦 Repo del docente: github.com/KrizRoMe/evaluacion-administracion-web   •   🌐 Sitio público: krizrome.github.io/evaluacion-administracion-web   •   📋 Issues: github.com/KrizRoMe/evaluacion-administracion-web/issues</a:t>
             </a:r>
           </a:p>
         </p:txBody>
@@ -8012,7 +8086,7 @@
                 </a:solidFill>
                 <a:latin typeface="Calibri"/>
               </a:rPr>
-              <a:t>📦 Repo: github.com/KrizRoMe/evaluacion-administracion-web   •   🌐 Web: krizrome.github.io/evaluacion-administracion-web   •   📋 Issues: github.com/KrizRoMe/evaluacion-administracion-web/issues</a:t>
+              <a:t>📦 Repo del docente: github.com/KrizRoMe/evaluacion-administracion-web   •   🌐 Sitio público: krizrome.github.io/evaluacion-administracion-web   •   📋 Issues: github.com/KrizRoMe/evaluacion-administracion-web/issues</a:t>
             </a:r>
           </a:p>
         </p:txBody>
@@ -8560,7 +8634,7 @@
                 </a:solidFill>
                 <a:latin typeface="Calibri"/>
               </a:rPr>
-              <a:t>📦 Repo: github.com/KrizRoMe/evaluacion-administracion-web   •   🌐 Web: krizrome.github.io/evaluacion-administracion-web   •   📋 Issues: github.com/KrizRoMe/evaluacion-administracion-web/issues</a:t>
+              <a:t>📦 Repo del docente: github.com/KrizRoMe/evaluacion-administracion-web   •   🌐 Sitio público: krizrome.github.io/evaluacion-administracion-web   •   📋 Issues: github.com/KrizRoMe/evaluacion-administracion-web/issues</a:t>
             </a:r>
           </a:p>
         </p:txBody>
@@ -8769,7 +8843,7 @@
                 </a:solidFill>
                 <a:latin typeface="Calibri"/>
               </a:rPr>
-              <a:t>⏱ 15 minutos  •  15 problemas, tú identificas 4</a:t>
+              <a:t>⏱ 15 minutos  •  Encuentra 1 problema de cada tipo</a:t>
             </a:r>
           </a:p>
         </p:txBody>
@@ -8782,7 +8856,7 @@
         </p:nvSpPr>
         <p:spPr>
           <a:xfrm>
-            <a:off x="640080" y="1280160"/>
+            <a:off x="640080" y="1188720"/>
             <a:ext cx="10972800" cy="365760"/>
           </a:xfrm>
           <a:prstGeom prst="rect">
@@ -8798,13 +8872,13 @@
           <a:p>
             <a:pPr algn="l"/>
             <a:r>
-              <a:rPr sz="2000" b="1">
+              <a:rPr sz="1800" b="1">
                 <a:solidFill>
                   <a:srgbClr val="065A82"/>
                 </a:solidFill>
                 <a:latin typeface="Calibri"/>
               </a:rPr>
-              <a:t>Herramientas a usar:</a:t>
+              <a:t>🛠 Herramientas a usar:</a:t>
             </a:r>
           </a:p>
         </p:txBody>
@@ -8817,270 +8891,709 @@
         </p:nvSpPr>
         <p:spPr>
           <a:xfrm>
-            <a:off x="822960" y="1737360"/>
-            <a:ext cx="5486400" cy="3200400"/>
-          </a:xfrm>
-          <a:prstGeom prst="rect">
-            <a:avLst/>
-          </a:prstGeom>
-          <a:noFill/>
-        </p:spPr>
-        <p:txBody>
-          <a:bodyPr wrap="square">
-            <a:spAutoFit/>
-          </a:bodyPr>
-          <a:lstStyle/>
-          <a:p>
-            <a:pPr algn="l"/>
-            <a:r>
-              <a:rPr sz="1400" b="1">
+            <a:off x="640080" y="1554480"/>
+            <a:ext cx="10972800" cy="731520"/>
+          </a:xfrm>
+          <a:prstGeom prst="rect">
+            <a:avLst/>
+          </a:prstGeom>
+          <a:noFill/>
+        </p:spPr>
+        <p:txBody>
+          <a:bodyPr wrap="square">
+            <a:spAutoFit/>
+          </a:bodyPr>
+          <a:lstStyle/>
+          <a:p>
+            <a:pPr algn="l"/>
+            <a:r>
+              <a:rPr sz="1400" b="0">
                 <a:solidFill>
                   <a:srgbClr val="2A2A2A"/>
                 </a:solidFill>
                 <a:latin typeface="Calibri"/>
               </a:rPr>
-              <a:t>🔍 Chrome DevTools (F12)</a:t>
-            </a:r>
-          </a:p>
-          <a:p>
-            <a:pPr algn="l"/>
-            <a:r>
-              <a:rPr sz="1400" b="0">
+              <a:t>Chrome DevTools (F12)  •  Lighthouse (rendimiento)  •  axe DevTools (accesibilidad)  •  package.json (mantenimiento)</a:t>
+            </a:r>
+          </a:p>
+        </p:txBody>
+      </p:sp>
+      <p:sp>
+        <p:nvSpPr>
+          <p:cNvPr id="8" name="Rounded Rectangle 7"/>
+          <p:cNvSpPr/>
+          <p:nvPr/>
+        </p:nvSpPr>
+        <p:spPr>
+          <a:xfrm>
+            <a:off x="426567" y="2286000"/>
+            <a:ext cx="3657600" cy="3108960"/>
+          </a:xfrm>
+          <a:prstGeom prst="roundRect">
+            <a:avLst/>
+          </a:prstGeom>
+          <a:solidFill>
+            <a:srgbClr val="F4F4F4"/>
+          </a:solidFill>
+          <a:ln w="38100">
+            <a:solidFill>
+              <a:srgbClr val="1C7293"/>
+            </a:solidFill>
+          </a:ln>
+        </p:spPr>
+        <p:style>
+          <a:lnRef idx="1">
+            <a:schemeClr val="accent1"/>
+          </a:lnRef>
+          <a:fillRef idx="3">
+            <a:schemeClr val="accent1"/>
+          </a:fillRef>
+          <a:effectRef idx="2">
+            <a:schemeClr val="accent1"/>
+          </a:effectRef>
+          <a:fontRef idx="minor">
+            <a:schemeClr val="lt1"/>
+          </a:fontRef>
+        </p:style>
+        <p:txBody>
+          <a:bodyPr rtlCol="0" anchor="ctr"/>
+          <a:lstStyle/>
+          <a:p>
+            <a:pPr algn="ctr"/>
+          </a:p>
+        </p:txBody>
+      </p:sp>
+      <p:sp>
+        <p:nvSpPr>
+          <p:cNvPr id="9" name="Rectangle 8"/>
+          <p:cNvSpPr/>
+          <p:nvPr/>
+        </p:nvSpPr>
+        <p:spPr>
+          <a:xfrm>
+            <a:off x="426567" y="2286000"/>
+            <a:ext cx="3657600" cy="548640"/>
+          </a:xfrm>
+          <a:prstGeom prst="rect">
+            <a:avLst/>
+          </a:prstGeom>
+          <a:solidFill>
+            <a:srgbClr val="1C7293"/>
+          </a:solidFill>
+          <a:ln>
+            <a:noFill/>
+          </a:ln>
+        </p:spPr>
+        <p:style>
+          <a:lnRef idx="1">
+            <a:schemeClr val="accent1"/>
+          </a:lnRef>
+          <a:fillRef idx="3">
+            <a:schemeClr val="accent1"/>
+          </a:fillRef>
+          <a:effectRef idx="2">
+            <a:schemeClr val="accent1"/>
+          </a:effectRef>
+          <a:fontRef idx="minor">
+            <a:schemeClr val="lt1"/>
+          </a:fontRef>
+        </p:style>
+        <p:txBody>
+          <a:bodyPr rtlCol="0" anchor="ctr"/>
+          <a:lstStyle/>
+          <a:p>
+            <a:pPr algn="ctr"/>
+          </a:p>
+        </p:txBody>
+      </p:sp>
+      <p:sp>
+        <p:nvSpPr>
+          <p:cNvPr id="10" name="TextBox 9"/>
+          <p:cNvSpPr txBox="1"/>
+          <p:nvPr/>
+        </p:nvSpPr>
+        <p:spPr>
+          <a:xfrm>
+            <a:off x="426567" y="2331720"/>
+            <a:ext cx="3657600" cy="457200"/>
+          </a:xfrm>
+          <a:prstGeom prst="rect">
+            <a:avLst/>
+          </a:prstGeom>
+          <a:noFill/>
+        </p:spPr>
+        <p:txBody>
+          <a:bodyPr wrap="square">
+            <a:spAutoFit/>
+          </a:bodyPr>
+          <a:lstStyle/>
+          <a:p>
+            <a:pPr algn="ctr"/>
+            <a:r>
+              <a:rPr sz="1800" b="1">
+                <a:solidFill>
+                  <a:srgbClr val="FFFFFF"/>
+                </a:solidFill>
+                <a:latin typeface="Calibri"/>
+              </a:rPr>
+              <a:t>📊 RENDIMIENTO</a:t>
+            </a:r>
+          </a:p>
+        </p:txBody>
+      </p:sp>
+      <p:sp>
+        <p:nvSpPr>
+          <p:cNvPr id="11" name="TextBox 10"/>
+          <p:cNvSpPr txBox="1"/>
+          <p:nvPr/>
+        </p:nvSpPr>
+        <p:spPr>
+          <a:xfrm>
+            <a:off x="563727" y="2926080"/>
+            <a:ext cx="3383280" cy="1463040"/>
+          </a:xfrm>
+          <a:prstGeom prst="rect">
+            <a:avLst/>
+          </a:prstGeom>
+          <a:noFill/>
+        </p:spPr>
+        <p:txBody>
+          <a:bodyPr wrap="square">
+            <a:spAutoFit/>
+          </a:bodyPr>
+          <a:lstStyle/>
+          <a:p>
+            <a:pPr algn="l"/>
+            <a:r>
+              <a:rPr sz="1200" b="1">
                 <a:solidFill>
                   <a:srgbClr val="2A2A2A"/>
                 </a:solidFill>
                 <a:latin typeface="Calibri"/>
               </a:rPr>
-              <a:t>• Pestaña Elements → revisa el HTML</a:t>
-            </a:r>
-          </a:p>
-          <a:p>
-            <a:pPr algn="l"/>
-            <a:r>
-              <a:rPr sz="1400" b="0">
+              <a:t>Chrome DevTools + Lighthouse</a:t>
+            </a:r>
+          </a:p>
+          <a:p>
+            <a:pPr algn="l"/>
+            <a:r>
+              <a:rPr sz="1200" b="0">
                 <a:solidFill>
                   <a:srgbClr val="2A2A2A"/>
                 </a:solidFill>
                 <a:latin typeface="Calibri"/>
               </a:rPr>
-              <a:t>• Pestaña Network → observa los recursos</a:t>
-            </a:r>
-          </a:p>
-          <a:p>
-            <a:pPr algn="l"/>
-            <a:r>
-              <a:rPr sz="1400" b="0">
+              <a:t/>
+            </a:r>
+          </a:p>
+          <a:p>
+            <a:pPr algn="l"/>
+            <a:r>
+              <a:rPr sz="1200" b="0">
                 <a:solidFill>
                   <a:srgbClr val="2A2A2A"/>
                 </a:solidFill>
                 <a:latin typeface="Calibri"/>
               </a:rPr>
+              <a:t>Ejemplos:
+• Imagen sin width/height (CLS)
+• Imágenes sin loading='lazy'
+• &lt;script&gt; sin defer
+• SVGs innecesariamente pesados
+• Recursos bloqueantes</a:t>
+            </a:r>
+          </a:p>
+        </p:txBody>
+      </p:sp>
+      <p:sp>
+        <p:nvSpPr>
+          <p:cNvPr id="12" name="TextBox 11"/>
+          <p:cNvSpPr txBox="1"/>
+          <p:nvPr/>
+        </p:nvSpPr>
+        <p:spPr>
+          <a:xfrm>
+            <a:off x="426567" y="5166360"/>
+            <a:ext cx="3657600" cy="274320"/>
+          </a:xfrm>
+          <a:prstGeom prst="rect">
+            <a:avLst/>
+          </a:prstGeom>
+          <a:noFill/>
+        </p:spPr>
+        <p:txBody>
+          <a:bodyPr wrap="square">
+            <a:spAutoFit/>
+          </a:bodyPr>
+          <a:lstStyle/>
+          <a:p>
+            <a:pPr algn="ctr"/>
+            <a:r>
+              <a:rPr sz="1100" b="1">
+                <a:solidFill>
+                  <a:srgbClr val="1C7293"/>
+                </a:solidFill>
+                <a:latin typeface="Calibri"/>
+              </a:rPr>
+              <a:t>📝 Template: rendimiento.yml</a:t>
+            </a:r>
+          </a:p>
+        </p:txBody>
+      </p:sp>
+      <p:sp>
+        <p:nvSpPr>
+          <p:cNvPr id="13" name="Rounded Rectangle 12"/>
+          <p:cNvSpPr/>
+          <p:nvPr/>
+        </p:nvSpPr>
+        <p:spPr>
+          <a:xfrm>
+            <a:off x="4267047" y="2286000"/>
+            <a:ext cx="3657600" cy="3108960"/>
+          </a:xfrm>
+          <a:prstGeom prst="roundRect">
+            <a:avLst/>
+          </a:prstGeom>
+          <a:solidFill>
+            <a:srgbClr val="F4F4F4"/>
+          </a:solidFill>
+          <a:ln w="38100">
+            <a:solidFill>
+              <a:srgbClr val="10B981"/>
+            </a:solidFill>
+          </a:ln>
+        </p:spPr>
+        <p:style>
+          <a:lnRef idx="1">
+            <a:schemeClr val="accent1"/>
+          </a:lnRef>
+          <a:fillRef idx="3">
+            <a:schemeClr val="accent1"/>
+          </a:fillRef>
+          <a:effectRef idx="2">
+            <a:schemeClr val="accent1"/>
+          </a:effectRef>
+          <a:fontRef idx="minor">
+            <a:schemeClr val="lt1"/>
+          </a:fontRef>
+        </p:style>
+        <p:txBody>
+          <a:bodyPr rtlCol="0" anchor="ctr"/>
+          <a:lstStyle/>
+          <a:p>
+            <a:pPr algn="ctr"/>
+          </a:p>
+        </p:txBody>
+      </p:sp>
+      <p:sp>
+        <p:nvSpPr>
+          <p:cNvPr id="14" name="Rectangle 13"/>
+          <p:cNvSpPr/>
+          <p:nvPr/>
+        </p:nvSpPr>
+        <p:spPr>
+          <a:xfrm>
+            <a:off x="4267047" y="2286000"/>
+            <a:ext cx="3657600" cy="548640"/>
+          </a:xfrm>
+          <a:prstGeom prst="rect">
+            <a:avLst/>
+          </a:prstGeom>
+          <a:solidFill>
+            <a:srgbClr val="10B981"/>
+          </a:solidFill>
+          <a:ln>
+            <a:noFill/>
+          </a:ln>
+        </p:spPr>
+        <p:style>
+          <a:lnRef idx="1">
+            <a:schemeClr val="accent1"/>
+          </a:lnRef>
+          <a:fillRef idx="3">
+            <a:schemeClr val="accent1"/>
+          </a:fillRef>
+          <a:effectRef idx="2">
+            <a:schemeClr val="accent1"/>
+          </a:effectRef>
+          <a:fontRef idx="minor">
+            <a:schemeClr val="lt1"/>
+          </a:fontRef>
+        </p:style>
+        <p:txBody>
+          <a:bodyPr rtlCol="0" anchor="ctr"/>
+          <a:lstStyle/>
+          <a:p>
+            <a:pPr algn="ctr"/>
+          </a:p>
+        </p:txBody>
+      </p:sp>
+      <p:sp>
+        <p:nvSpPr>
+          <p:cNvPr id="15" name="TextBox 14"/>
+          <p:cNvSpPr txBox="1"/>
+          <p:nvPr/>
+        </p:nvSpPr>
+        <p:spPr>
+          <a:xfrm>
+            <a:off x="4267047" y="2331720"/>
+            <a:ext cx="3657600" cy="457200"/>
+          </a:xfrm>
+          <a:prstGeom prst="rect">
+            <a:avLst/>
+          </a:prstGeom>
+          <a:noFill/>
+        </p:spPr>
+        <p:txBody>
+          <a:bodyPr wrap="square">
+            <a:spAutoFit/>
+          </a:bodyPr>
+          <a:lstStyle/>
+          <a:p>
+            <a:pPr algn="ctr"/>
+            <a:r>
+              <a:rPr sz="1800" b="1">
+                <a:solidFill>
+                  <a:srgbClr val="FFFFFF"/>
+                </a:solidFill>
+                <a:latin typeface="Calibri"/>
+              </a:rPr>
+              <a:t>♿ ACCESIBILIDAD</a:t>
+            </a:r>
+          </a:p>
+        </p:txBody>
+      </p:sp>
+      <p:sp>
+        <p:nvSpPr>
+          <p:cNvPr id="16" name="TextBox 15"/>
+          <p:cNvSpPr txBox="1"/>
+          <p:nvPr/>
+        </p:nvSpPr>
+        <p:spPr>
+          <a:xfrm>
+            <a:off x="4404207" y="2926080"/>
+            <a:ext cx="3383280" cy="1463040"/>
+          </a:xfrm>
+          <a:prstGeom prst="rect">
+            <a:avLst/>
+          </a:prstGeom>
+          <a:noFill/>
+        </p:spPr>
+        <p:txBody>
+          <a:bodyPr wrap="square">
+            <a:spAutoFit/>
+          </a:bodyPr>
+          <a:lstStyle/>
+          <a:p>
+            <a:pPr algn="l"/>
+            <a:r>
+              <a:rPr sz="1200" b="1">
+                <a:solidFill>
+                  <a:srgbClr val="2A2A2A"/>
+                </a:solidFill>
+                <a:latin typeface="Calibri"/>
+              </a:rPr>
+              <a:t>axe DevTools</a:t>
+            </a:r>
+          </a:p>
+          <a:p>
+            <a:pPr algn="l"/>
+            <a:r>
+              <a:rPr sz="1200" b="0">
+                <a:solidFill>
+                  <a:srgbClr val="2A2A2A"/>
+                </a:solidFill>
+                <a:latin typeface="Calibri"/>
+              </a:rPr>
               <a:t/>
             </a:r>
           </a:p>
           <a:p>
             <a:pPr algn="l"/>
             <a:r>
-              <a:rPr sz="1400" b="1">
+              <a:rPr sz="1200" b="0">
                 <a:solidFill>
                   <a:srgbClr val="2A2A2A"/>
                 </a:solidFill>
                 <a:latin typeface="Calibri"/>
               </a:rPr>
-              <a:t>💡 Lighthouse (DevTools)</a:t>
-            </a:r>
-          </a:p>
-          <a:p>
-            <a:pPr algn="l"/>
-            <a:r>
-              <a:rPr sz="1400" b="0">
+              <a:t>Ejemplos:
+• Imágenes sin alt
+• Botones sin aria-label
+• Contraste insuficiente
+• Inputs sin &lt;label&gt;
+• Falta de landmarks ARIA</a:t>
+            </a:r>
+          </a:p>
+        </p:txBody>
+      </p:sp>
+      <p:sp>
+        <p:nvSpPr>
+          <p:cNvPr id="17" name="TextBox 16"/>
+          <p:cNvSpPr txBox="1"/>
+          <p:nvPr/>
+        </p:nvSpPr>
+        <p:spPr>
+          <a:xfrm>
+            <a:off x="4267047" y="5166360"/>
+            <a:ext cx="3657600" cy="274320"/>
+          </a:xfrm>
+          <a:prstGeom prst="rect">
+            <a:avLst/>
+          </a:prstGeom>
+          <a:noFill/>
+        </p:spPr>
+        <p:txBody>
+          <a:bodyPr wrap="square">
+            <a:spAutoFit/>
+          </a:bodyPr>
+          <a:lstStyle/>
+          <a:p>
+            <a:pPr algn="ctr"/>
+            <a:r>
+              <a:rPr sz="1100" b="1">
+                <a:solidFill>
+                  <a:srgbClr val="10B981"/>
+                </a:solidFill>
+                <a:latin typeface="Calibri"/>
+              </a:rPr>
+              <a:t>📝 Template: accesibilidad.yml</a:t>
+            </a:r>
+          </a:p>
+        </p:txBody>
+      </p:sp>
+      <p:sp>
+        <p:nvSpPr>
+          <p:cNvPr id="18" name="Rounded Rectangle 17"/>
+          <p:cNvSpPr/>
+          <p:nvPr/>
+        </p:nvSpPr>
+        <p:spPr>
+          <a:xfrm>
+            <a:off x="8107527" y="2286000"/>
+            <a:ext cx="3657600" cy="3108960"/>
+          </a:xfrm>
+          <a:prstGeom prst="roundRect">
+            <a:avLst/>
+          </a:prstGeom>
+          <a:solidFill>
+            <a:srgbClr val="F4F4F4"/>
+          </a:solidFill>
+          <a:ln w="38100">
+            <a:solidFill>
+              <a:srgbClr val="EA580C"/>
+            </a:solidFill>
+          </a:ln>
+        </p:spPr>
+        <p:style>
+          <a:lnRef idx="1">
+            <a:schemeClr val="accent1"/>
+          </a:lnRef>
+          <a:fillRef idx="3">
+            <a:schemeClr val="accent1"/>
+          </a:fillRef>
+          <a:effectRef idx="2">
+            <a:schemeClr val="accent1"/>
+          </a:effectRef>
+          <a:fontRef idx="minor">
+            <a:schemeClr val="lt1"/>
+          </a:fontRef>
+        </p:style>
+        <p:txBody>
+          <a:bodyPr rtlCol="0" anchor="ctr"/>
+          <a:lstStyle/>
+          <a:p>
+            <a:pPr algn="ctr"/>
+          </a:p>
+        </p:txBody>
+      </p:sp>
+      <p:sp>
+        <p:nvSpPr>
+          <p:cNvPr id="19" name="Rectangle 18"/>
+          <p:cNvSpPr/>
+          <p:nvPr/>
+        </p:nvSpPr>
+        <p:spPr>
+          <a:xfrm>
+            <a:off x="8107527" y="2286000"/>
+            <a:ext cx="3657600" cy="548640"/>
+          </a:xfrm>
+          <a:prstGeom prst="rect">
+            <a:avLst/>
+          </a:prstGeom>
+          <a:solidFill>
+            <a:srgbClr val="EA580C"/>
+          </a:solidFill>
+          <a:ln>
+            <a:noFill/>
+          </a:ln>
+        </p:spPr>
+        <p:style>
+          <a:lnRef idx="1">
+            <a:schemeClr val="accent1"/>
+          </a:lnRef>
+          <a:fillRef idx="3">
+            <a:schemeClr val="accent1"/>
+          </a:fillRef>
+          <a:effectRef idx="2">
+            <a:schemeClr val="accent1"/>
+          </a:effectRef>
+          <a:fontRef idx="minor">
+            <a:schemeClr val="lt1"/>
+          </a:fontRef>
+        </p:style>
+        <p:txBody>
+          <a:bodyPr rtlCol="0" anchor="ctr"/>
+          <a:lstStyle/>
+          <a:p>
+            <a:pPr algn="ctr"/>
+          </a:p>
+        </p:txBody>
+      </p:sp>
+      <p:sp>
+        <p:nvSpPr>
+          <p:cNvPr id="20" name="TextBox 19"/>
+          <p:cNvSpPr txBox="1"/>
+          <p:nvPr/>
+        </p:nvSpPr>
+        <p:spPr>
+          <a:xfrm>
+            <a:off x="8107527" y="2331720"/>
+            <a:ext cx="3657600" cy="457200"/>
+          </a:xfrm>
+          <a:prstGeom prst="rect">
+            <a:avLst/>
+          </a:prstGeom>
+          <a:noFill/>
+        </p:spPr>
+        <p:txBody>
+          <a:bodyPr wrap="square">
+            <a:spAutoFit/>
+          </a:bodyPr>
+          <a:lstStyle/>
+          <a:p>
+            <a:pPr algn="ctr"/>
+            <a:r>
+              <a:rPr sz="1800" b="1">
+                <a:solidFill>
+                  <a:srgbClr val="FFFFFF"/>
+                </a:solidFill>
+                <a:latin typeface="Calibri"/>
+              </a:rPr>
+              <a:t>🔧 MANTENIMIENTO</a:t>
+            </a:r>
+          </a:p>
+        </p:txBody>
+      </p:sp>
+      <p:sp>
+        <p:nvSpPr>
+          <p:cNvPr id="21" name="TextBox 20"/>
+          <p:cNvSpPr txBox="1"/>
+          <p:nvPr/>
+        </p:nvSpPr>
+        <p:spPr>
+          <a:xfrm>
+            <a:off x="8244687" y="2926080"/>
+            <a:ext cx="3383280" cy="1463040"/>
+          </a:xfrm>
+          <a:prstGeom prst="rect">
+            <a:avLst/>
+          </a:prstGeom>
+          <a:noFill/>
+        </p:spPr>
+        <p:txBody>
+          <a:bodyPr wrap="square">
+            <a:spAutoFit/>
+          </a:bodyPr>
+          <a:lstStyle/>
+          <a:p>
+            <a:pPr algn="l"/>
+            <a:r>
+              <a:rPr sz="1200" b="1">
                 <a:solidFill>
                   <a:srgbClr val="2A2A2A"/>
                 </a:solidFill>
                 <a:latin typeface="Calibri"/>
               </a:rPr>
-              <a:t>• Pestaña Lighthouse → Performance</a:t>
-            </a:r>
-          </a:p>
-          <a:p>
-            <a:pPr algn="l"/>
-            <a:r>
-              <a:rPr sz="1400" b="0">
+              <a:t>package.json + código</a:t>
+            </a:r>
+          </a:p>
+          <a:p>
+            <a:pPr algn="l"/>
+            <a:r>
+              <a:rPr sz="1200" b="0">
                 <a:solidFill>
                   <a:srgbClr val="2A2A2A"/>
                 </a:solidFill>
                 <a:latin typeface="Calibri"/>
               </a:rPr>
-              <a:t>• Analyze page load</a:t>
-            </a:r>
-          </a:p>
-        </p:txBody>
-      </p:sp>
-      <p:sp>
-        <p:nvSpPr>
-          <p:cNvPr id="8" name="TextBox 7"/>
-          <p:cNvSpPr txBox="1"/>
-          <p:nvPr/>
-        </p:nvSpPr>
-        <p:spPr>
-          <a:xfrm>
-            <a:off x="6400800" y="1737360"/>
-            <a:ext cx="5303520" cy="3200400"/>
-          </a:xfrm>
-          <a:prstGeom prst="rect">
-            <a:avLst/>
-          </a:prstGeom>
-          <a:noFill/>
-        </p:spPr>
-        <p:txBody>
-          <a:bodyPr wrap="square">
-            <a:spAutoFit/>
-          </a:bodyPr>
-          <a:lstStyle/>
-          <a:p>
-            <a:pPr algn="l"/>
-            <a:r>
-              <a:rPr sz="1400" b="1">
+              <a:t/>
+            </a:r>
+          </a:p>
+          <a:p>
+            <a:pPr algn="l"/>
+            <a:r>
+              <a:rPr sz="1200" b="0">
                 <a:solidFill>
                   <a:srgbClr val="2A2A2A"/>
                 </a:solidFill>
                 <a:latin typeface="Calibri"/>
               </a:rPr>
-              <a:t>♿ axe DevTools (extensión)</a:t>
-            </a:r>
-          </a:p>
-          <a:p>
-            <a:pPr algn="l"/>
-            <a:r>
-              <a:rPr sz="1400" b="0">
-                <a:solidFill>
-                  <a:srgbClr val="2A2A2A"/>
-                </a:solidFill>
-                <a:latin typeface="Calibri"/>
-              </a:rPr>
-              <a:t>• Pestaña axe DevTools</a:t>
-            </a:r>
-          </a:p>
-          <a:p>
-            <a:pPr algn="l"/>
-            <a:r>
-              <a:rPr sz="1400" b="0">
-                <a:solidFill>
-                  <a:srgbClr val="2A2A2A"/>
-                </a:solidFill>
-                <a:latin typeface="Calibri"/>
-              </a:rPr>
-              <a:t>• Scan ALL of my page</a:t>
-            </a:r>
-          </a:p>
-          <a:p>
-            <a:pPr algn="l"/>
-            <a:r>
-              <a:rPr sz="1400" b="0">
-                <a:solidFill>
-                  <a:srgbClr val="2A2A2A"/>
-                </a:solidFill>
-                <a:latin typeface="Calibri"/>
-              </a:rPr>
-              <a:t>• Detecta accesibilidad</a:t>
-            </a:r>
-          </a:p>
-          <a:p>
-            <a:pPr algn="l"/>
-            <a:r>
-              <a:rPr sz="1400" b="0">
-                <a:solidFill>
-                  <a:srgbClr val="2A2A2A"/>
-                </a:solidFill>
-                <a:latin typeface="Calibri"/>
-              </a:rPr>
-              <a:t>  (alt, contraste, ARIA, etc.)</a:t>
-            </a:r>
-          </a:p>
-          <a:p>
-            <a:pPr algn="l"/>
-            <a:r>
-              <a:rPr sz="1400" b="0">
-                <a:solidFill>
-                  <a:srgbClr val="2A2A2A"/>
-                </a:solidFill>
-                <a:latin typeface="Calibri"/>
-              </a:rPr>
-              <a:t/>
-            </a:r>
-          </a:p>
-          <a:p>
-            <a:pPr algn="l"/>
-            <a:r>
-              <a:rPr sz="1400" b="1">
-                <a:solidFill>
-                  <a:srgbClr val="2A2A2A"/>
-                </a:solidFill>
-                <a:latin typeface="Calibri"/>
-              </a:rPr>
-              <a:t>El sitio tiene 15 problemas:</a:t>
-            </a:r>
-          </a:p>
-          <a:p>
-            <a:pPr algn="l"/>
-            <a:r>
-              <a:rPr sz="1400" b="0">
-                <a:solidFill>
-                  <a:srgbClr val="2A2A2A"/>
-                </a:solidFill>
-                <a:latin typeface="Calibri"/>
-              </a:rPr>
-              <a:t>• 5 de rendimiento</a:t>
-            </a:r>
-          </a:p>
-          <a:p>
-            <a:pPr algn="l"/>
-            <a:r>
-              <a:rPr sz="1400" b="0">
-                <a:solidFill>
-                  <a:srgbClr val="2A2A2A"/>
-                </a:solidFill>
-                <a:latin typeface="Calibri"/>
-              </a:rPr>
-              <a:t>• 5 de accesibilidad</a:t>
-            </a:r>
-          </a:p>
-          <a:p>
-            <a:pPr algn="l"/>
-            <a:r>
-              <a:rPr sz="1400" b="0">
-                <a:solidFill>
-                  <a:srgbClr val="2A2A2A"/>
-                </a:solidFill>
-                <a:latin typeface="Calibri"/>
-              </a:rPr>
-              <a:t>• 3 de mantenimiento/seguridad</a:t>
-            </a:r>
-          </a:p>
-          <a:p>
-            <a:pPr algn="l"/>
-            <a:r>
-              <a:rPr sz="1400" b="0">
-                <a:solidFill>
-                  <a:srgbClr val="2A2A2A"/>
-                </a:solidFill>
-                <a:latin typeface="Calibri"/>
-              </a:rPr>
-              <a:t>• 2 de administración</a:t>
-            </a:r>
-          </a:p>
-        </p:txBody>
-      </p:sp>
-      <p:sp>
-        <p:nvSpPr>
-          <p:cNvPr id="9" name="Rounded Rectangle 8"/>
+              <a:t>Ejemplos:
+• jQuery 2.1.4 (versión antigua)
+• Meta tags de seguridad faltantes
+• Comentarios TODO/FIXME
+• Footer desactualizado
+• Falta de runbook público</a:t>
+            </a:r>
+          </a:p>
+        </p:txBody>
+      </p:sp>
+      <p:sp>
+        <p:nvSpPr>
+          <p:cNvPr id="22" name="TextBox 21"/>
+          <p:cNvSpPr txBox="1"/>
+          <p:nvPr/>
+        </p:nvSpPr>
+        <p:spPr>
+          <a:xfrm>
+            <a:off x="8107527" y="5166360"/>
+            <a:ext cx="3657600" cy="274320"/>
+          </a:xfrm>
+          <a:prstGeom prst="rect">
+            <a:avLst/>
+          </a:prstGeom>
+          <a:noFill/>
+        </p:spPr>
+        <p:txBody>
+          <a:bodyPr wrap="square">
+            <a:spAutoFit/>
+          </a:bodyPr>
+          <a:lstStyle/>
+          <a:p>
+            <a:pPr algn="ctr"/>
+            <a:r>
+              <a:rPr sz="1100" b="1">
+                <a:solidFill>
+                  <a:srgbClr val="EA580C"/>
+                </a:solidFill>
+                <a:latin typeface="Calibri"/>
+              </a:rPr>
+              <a:t>📝 Template: mantenimiento.yml</a:t>
+            </a:r>
+          </a:p>
+        </p:txBody>
+      </p:sp>
+      <p:sp>
+        <p:nvSpPr>
+          <p:cNvPr id="23" name="Rounded Rectangle 22"/>
           <p:cNvSpPr/>
           <p:nvPr/>
         </p:nvSpPr>
         <p:spPr>
           <a:xfrm>
-            <a:off x="640080" y="5120640"/>
-            <a:ext cx="10972800" cy="640080"/>
+            <a:off x="640080" y="5669280"/>
+            <a:ext cx="10972800" cy="548640"/>
           </a:xfrm>
           <a:prstGeom prst="roundRect">
             <a:avLst/>
@@ -9118,27 +9631,27 @@
       </p:sp>
       <p:sp>
         <p:nvSpPr>
-          <p:cNvPr id="10" name="TextBox 9"/>
-          <p:cNvSpPr txBox="1"/>
-          <p:nvPr/>
-        </p:nvSpPr>
-        <p:spPr>
-          <a:xfrm>
-            <a:off x="822960" y="5212080"/>
-            <a:ext cx="10607040" cy="457200"/>
-          </a:xfrm>
-          <a:prstGeom prst="rect">
-            <a:avLst/>
-          </a:prstGeom>
-          <a:noFill/>
-        </p:spPr>
-        <p:txBody>
-          <a:bodyPr wrap="square">
-            <a:spAutoFit/>
-          </a:bodyPr>
-          <a:lstStyle/>
-          <a:p>
-            <a:pPr algn="l"/>
+          <p:cNvPr id="24" name="TextBox 23"/>
+          <p:cNvSpPr txBox="1"/>
+          <p:nvPr/>
+        </p:nvSpPr>
+        <p:spPr>
+          <a:xfrm>
+            <a:off x="640080" y="5760720"/>
+            <a:ext cx="10972800" cy="365760"/>
+          </a:xfrm>
+          <a:prstGeom prst="rect">
+            <a:avLst/>
+          </a:prstGeom>
+          <a:noFill/>
+        </p:spPr>
+        <p:txBody>
+          <a:bodyPr wrap="square">
+            <a:spAutoFit/>
+          </a:bodyPr>
+          <a:lstStyle/>
+          <a:p>
+            <a:pPr algn="ctr"/>
             <a:r>
               <a:rPr sz="1400" b="1">
                 <a:solidFill>
@@ -9146,14 +9659,14 @@
                 </a:solidFill>
                 <a:latin typeface="Calibri"/>
               </a:rPr>
-              <a:t>🎯 Objetivo: encontrar 4 problemas reales. Variedad es positiva pero no obligatoria.</a:t>
-            </a:r>
-          </a:p>
-        </p:txBody>
-      </p:sp>
-      <p:sp>
-        <p:nvSpPr>
-          <p:cNvPr id="11" name="TextBox 10"/>
+              <a:t>🎯 Objetivo: 3 Issues (una de cada tipo) en el repo del DOCENTE.</a:t>
+            </a:r>
+          </a:p>
+        </p:txBody>
+      </p:sp>
+      <p:sp>
+        <p:nvSpPr>
+          <p:cNvPr id="25" name="TextBox 24"/>
           <p:cNvSpPr txBox="1"/>
           <p:nvPr/>
         </p:nvSpPr>
@@ -9181,14 +9694,14 @@
                 </a:solidFill>
                 <a:latin typeface="Calibri"/>
               </a:rPr>
-              <a:t>📦 Repo: github.com/KrizRoMe/evaluacion-administracion-web   •   🌐 Web: krizrome.github.io/evaluacion-administracion-web   •   📋 Issues: github.com/KrizRoMe/evaluacion-administracion-web/issues</a:t>
-            </a:r>
-          </a:p>
-        </p:txBody>
-      </p:sp>
-      <p:sp>
-        <p:nvSpPr>
-          <p:cNvPr id="12" name="TextBox 11"/>
+              <a:t>📦 Repo del docente: github.com/KrizRoMe/evaluacion-administracion-web   •   🌐 Sitio público: krizrome.github.io/evaluacion-administracion-web   •   📋 Issues: github.com/KrizRoMe/evaluacion-administracion-web/issues</a:t>
+            </a:r>
+          </a:p>
+        </p:txBody>
+      </p:sp>
+      <p:sp>
+        <p:nvSpPr>
+          <p:cNvPr id="26" name="TextBox 25"/>
           <p:cNvSpPr txBox="1"/>
           <p:nvPr/>
         </p:nvSpPr>
@@ -9355,7 +9868,7 @@
                 </a:solidFill>
                 <a:latin typeface="Calibri"/>
               </a:rPr>
-              <a:t>Parte 4 · Crear 4 Issues en TU repo</a:t>
+              <a:t>Parte 4 · Crear 3 Issues de hallazgos</a:t>
             </a:r>
           </a:p>
         </p:txBody>
@@ -9390,7 +9903,7 @@
                 </a:solidFill>
                 <a:latin typeface="Calibri"/>
               </a:rPr>
-              <a:t>⏱ 20 minutos  •  4 Issues × 5 pts = 20 pts</a:t>
+              <a:t>⏱ 25 minutos  •  En el repo del DOCENTE</a:t>
             </a:r>
           </a:p>
         </p:txBody>
@@ -9404,17 +9917,17 @@
         <p:spPr>
           <a:xfrm>
             <a:off x="640080" y="1188720"/>
-            <a:ext cx="10972800" cy="548640"/>
+            <a:ext cx="10972800" cy="822960"/>
           </a:xfrm>
           <a:prstGeom prst="roundRect">
             <a:avLst/>
           </a:prstGeom>
           <a:solidFill>
-            <a:srgbClr val="E3F2FD"/>
+            <a:srgbClr val="FEF3E6"/>
           </a:solidFill>
-          <a:ln w="25400">
+          <a:ln w="38100">
             <a:solidFill>
-              <a:srgbClr val="1C7293"/>
+              <a:srgbClr val="EA580C"/>
             </a:solidFill>
           </a:ln>
         </p:spPr>
@@ -9448,7 +9961,77 @@
         </p:nvSpPr>
         <p:spPr>
           <a:xfrm>
-            <a:off x="640080" y="1280160"/>
+            <a:off x="822960" y="1280160"/>
+            <a:ext cx="10607040" cy="365760"/>
+          </a:xfrm>
+          <a:prstGeom prst="rect">
+            <a:avLst/>
+          </a:prstGeom>
+          <a:noFill/>
+        </p:spPr>
+        <p:txBody>
+          <a:bodyPr wrap="square">
+            <a:spAutoFit/>
+          </a:bodyPr>
+          <a:lstStyle/>
+          <a:p>
+            <a:pPr algn="ctr"/>
+            <a:r>
+              <a:rPr sz="1500" b="1">
+                <a:solidFill>
+                  <a:srgbClr val="EA580C"/>
+                </a:solidFill>
+                <a:latin typeface="Calibri"/>
+              </a:rPr>
+              <a:t>📋 LAS 3 ISSUES DE HALLAZGOS SE CREAN EN:</a:t>
+            </a:r>
+          </a:p>
+        </p:txBody>
+      </p:sp>
+      <p:sp>
+        <p:nvSpPr>
+          <p:cNvPr id="8" name="TextBox 7"/>
+          <p:cNvSpPr txBox="1"/>
+          <p:nvPr/>
+        </p:nvSpPr>
+        <p:spPr>
+          <a:xfrm>
+            <a:off x="822960" y="1645920"/>
+            <a:ext cx="10607040" cy="365760"/>
+          </a:xfrm>
+          <a:prstGeom prst="rect">
+            <a:avLst/>
+          </a:prstGeom>
+          <a:noFill/>
+        </p:spPr>
+        <p:txBody>
+          <a:bodyPr wrap="square">
+            <a:spAutoFit/>
+          </a:bodyPr>
+          <a:lstStyle/>
+          <a:p>
+            <a:pPr algn="ctr"/>
+            <a:r>
+              <a:rPr sz="1500" b="1">
+                <a:solidFill>
+                  <a:srgbClr val="2A2A2A"/>
+                </a:solidFill>
+                <a:latin typeface="Consolas"/>
+              </a:rPr>
+              <a:t>https://github.com/KrizRoMe/evaluacion-administracion-web/issues</a:t>
+            </a:r>
+          </a:p>
+        </p:txBody>
+      </p:sp>
+      <p:sp>
+        <p:nvSpPr>
+          <p:cNvPr id="9" name="TextBox 8"/>
+          <p:cNvSpPr txBox="1"/>
+          <p:nvPr/>
+        </p:nvSpPr>
+        <p:spPr>
+          <a:xfrm>
+            <a:off x="640080" y="2194560"/>
             <a:ext cx="10972800" cy="365760"/>
           </a:xfrm>
           <a:prstGeom prst="rect">
@@ -9462,141 +10045,153 @@
           </a:bodyPr>
           <a:lstStyle/>
           <a:p>
-            <a:pPr algn="ctr"/>
-            <a:r>
-              <a:rPr sz="1500" b="1">
+            <a:pPr algn="l"/>
+            <a:r>
+              <a:rPr sz="1800" b="1">
                 <a:solidFill>
                   <a:srgbClr val="065A82"/>
                 </a:solidFill>
                 <a:latin typeface="Calibri"/>
               </a:rPr>
-              <a:t>⚠️  Estas 4 Issues se crean en TU PROPIO repositorio, NO en el del docente.</a:t>
-            </a:r>
-          </a:p>
-        </p:txBody>
-      </p:sp>
-      <p:sp>
-        <p:nvSpPr>
-          <p:cNvPr id="8" name="TextBox 7"/>
-          <p:cNvSpPr txBox="1"/>
-          <p:nvPr/>
-        </p:nvSpPr>
-        <p:spPr>
-          <a:xfrm>
-            <a:off x="640080" y="1920240"/>
-            <a:ext cx="10972800" cy="457200"/>
-          </a:xfrm>
-          <a:prstGeom prst="rect">
-            <a:avLst/>
-          </a:prstGeom>
-          <a:noFill/>
-        </p:spPr>
-        <p:txBody>
-          <a:bodyPr wrap="square">
-            <a:spAutoFit/>
-          </a:bodyPr>
-          <a:lstStyle/>
-          <a:p>
-            <a:pPr algn="l"/>
-            <a:r>
-              <a:rPr sz="1500" b="1">
+              <a:t>Pasos:</a:t>
+            </a:r>
+          </a:p>
+        </p:txBody>
+      </p:sp>
+      <p:sp>
+        <p:nvSpPr>
+          <p:cNvPr id="10" name="TextBox 9"/>
+          <p:cNvSpPr txBox="1"/>
+          <p:nvPr/>
+        </p:nvSpPr>
+        <p:spPr>
+          <a:xfrm>
+            <a:off x="822960" y="2606040"/>
+            <a:ext cx="10972800" cy="1097280"/>
+          </a:xfrm>
+          <a:prstGeom prst="rect">
+            <a:avLst/>
+          </a:prstGeom>
+          <a:noFill/>
+        </p:spPr>
+        <p:txBody>
+          <a:bodyPr wrap="square">
+            <a:spAutoFit/>
+          </a:bodyPr>
+          <a:lstStyle/>
+          <a:p>
+            <a:pPr algn="l"/>
+            <a:r>
+              <a:rPr sz="1300" b="0">
                 <a:solidFill>
                   <a:srgbClr val="2A2A2A"/>
                 </a:solidFill>
                 <a:latin typeface="Calibri"/>
               </a:rPr>
-              <a:t>Templates interactivos disponibles (en .github/ISSUE_TEMPLATE/):</a:t>
-            </a:r>
-          </a:p>
-        </p:txBody>
-      </p:sp>
-      <p:sp>
-        <p:nvSpPr>
-          <p:cNvPr id="9" name="TextBox 8"/>
-          <p:cNvSpPr txBox="1"/>
-          <p:nvPr/>
-        </p:nvSpPr>
-        <p:spPr>
-          <a:xfrm>
-            <a:off x="822960" y="2377440"/>
-            <a:ext cx="10972800" cy="1097280"/>
-          </a:xfrm>
-          <a:prstGeom prst="rect">
-            <a:avLst/>
-          </a:prstGeom>
-          <a:noFill/>
-        </p:spPr>
-        <p:txBody>
-          <a:bodyPr wrap="square">
-            <a:spAutoFit/>
-          </a:bodyPr>
-          <a:lstStyle/>
-          <a:p>
-            <a:pPr algn="l"/>
-            <a:r>
-              <a:rPr sz="1400" b="0">
+              <a:t>1. Abre https://github.com/KrizRoMe/evaluacion-administracion-web/issues en una pestaña nueva</a:t>
+            </a:r>
+          </a:p>
+          <a:p>
+            <a:pPr algn="l"/>
+            <a:r>
+              <a:rPr sz="1300" b="0">
                 <a:solidFill>
                   <a:srgbClr val="2A2A2A"/>
                 </a:solidFill>
                 <a:latin typeface="Calibri"/>
               </a:rPr>
-              <a:t>📊 rendimiento.yml     →  hallazgos de performance / Lighthouse</a:t>
-            </a:r>
-          </a:p>
-          <a:p>
-            <a:pPr algn="l"/>
-            <a:r>
-              <a:rPr sz="1400" b="0">
+              <a:t>2. Clic en New issue</a:t>
+            </a:r>
+          </a:p>
+          <a:p>
+            <a:pPr algn="l"/>
+            <a:r>
+              <a:rPr sz="1300" b="0">
                 <a:solidFill>
                   <a:srgbClr val="2A2A2A"/>
                 </a:solidFill>
                 <a:latin typeface="Calibri"/>
               </a:rPr>
-              <a:t>🔧 mantenimiento.yml   →  hallazgos de dependencias / seguridad</a:t>
-            </a:r>
-          </a:p>
-          <a:p>
-            <a:pPr algn="l"/>
-            <a:r>
-              <a:rPr sz="1400" b="0">
+              <a:t>3. Selecciona UNO de los 3 templates: rendimiento.yml, accesibilidad.yml, o mantenimiento.yml</a:t>
+            </a:r>
+          </a:p>
+          <a:p>
+            <a:pPr algn="l"/>
+            <a:r>
+              <a:rPr sz="1300" b="0">
                 <a:solidFill>
                   <a:srgbClr val="2A2A2A"/>
                 </a:solidFill>
                 <a:latin typeface="Calibri"/>
               </a:rPr>
-              <a:t>♿ accesibilidad.yml   →  hallazgos de axe DevTools</a:t>
-            </a:r>
-          </a:p>
-          <a:p>
-            <a:pPr algn="l"/>
-            <a:r>
-              <a:rPr sz="1400" b="0">
+              <a:t>4. Completa todas las secciones del template</a:t>
+            </a:r>
+          </a:p>
+          <a:p>
+            <a:pPr algn="l"/>
+            <a:r>
+              <a:rPr sz="1300" b="0">
                 <a:solidFill>
                   <a:srgbClr val="2A2A2A"/>
                 </a:solidFill>
                 <a:latin typeface="Calibri"/>
               </a:rPr>
-              <a:t>📝 general.yml         →  cualquier otro hallazgo</a:t>
-            </a:r>
-          </a:p>
-        </p:txBody>
-      </p:sp>
-      <p:sp>
-        <p:nvSpPr>
-          <p:cNvPr id="10" name="Rounded Rectangle 9"/>
+              <a:t>5. Submit. Repite 2 veces más (1 issue por cada tipo)</a:t>
+            </a:r>
+          </a:p>
+        </p:txBody>
+      </p:sp>
+      <p:sp>
+        <p:nvSpPr>
+          <p:cNvPr id="11" name="TextBox 10"/>
+          <p:cNvSpPr txBox="1"/>
+          <p:nvPr/>
+        </p:nvSpPr>
+        <p:spPr>
+          <a:xfrm>
+            <a:off x="640080" y="3840480"/>
+            <a:ext cx="10972800" cy="365760"/>
+          </a:xfrm>
+          <a:prstGeom prst="rect">
+            <a:avLst/>
+          </a:prstGeom>
+          <a:noFill/>
+        </p:spPr>
+        <p:txBody>
+          <a:bodyPr wrap="square">
+            <a:spAutoFit/>
+          </a:bodyPr>
+          <a:lstStyle/>
+          <a:p>
+            <a:pPr algn="l"/>
+            <a:r>
+              <a:rPr sz="1800" b="1">
+                <a:solidFill>
+                  <a:srgbClr val="065A82"/>
+                </a:solidFill>
+                <a:latin typeface="Calibri"/>
+              </a:rPr>
+              <a:t>Formato de cada Issue (ciclo de mejora):</a:t>
+            </a:r>
+          </a:p>
+        </p:txBody>
+      </p:sp>
+      <p:sp>
+        <p:nvSpPr>
+          <p:cNvPr id="12" name="Rounded Rectangle 11"/>
           <p:cNvSpPr/>
           <p:nvPr/>
         </p:nvSpPr>
         <p:spPr>
           <a:xfrm>
-            <a:off x="640080" y="3657600"/>
-            <a:ext cx="10972800" cy="2377440"/>
+            <a:off x="640080" y="4297680"/>
+            <a:ext cx="10972800" cy="1371600"/>
           </a:xfrm>
           <a:prstGeom prst="roundRect">
             <a:avLst/>
           </a:prstGeom>
           <a:solidFill>
-            <a:srgbClr val="2A2A2A"/>
+            <a:srgbClr val="F4F4F4"/>
           </a:solidFill>
           <a:ln>
             <a:solidFill>
@@ -9628,126 +10223,146 @@
       </p:sp>
       <p:sp>
         <p:nvSpPr>
-          <p:cNvPr id="11" name="TextBox 10"/>
-          <p:cNvSpPr txBox="1"/>
-          <p:nvPr/>
-        </p:nvSpPr>
-        <p:spPr>
-          <a:xfrm>
-            <a:off x="822960" y="3749039"/>
-            <a:ext cx="10607040" cy="2286000"/>
-          </a:xfrm>
-          <a:prstGeom prst="rect">
-            <a:avLst/>
-          </a:prstGeom>
-          <a:noFill/>
-        </p:spPr>
-        <p:txBody>
-          <a:bodyPr wrap="square">
-            <a:spAutoFit/>
-          </a:bodyPr>
-          <a:lstStyle/>
-          <a:p>
-            <a:pPr algn="l"/>
+          <p:cNvPr id="13" name="TextBox 12"/>
+          <p:cNvSpPr txBox="1"/>
+          <p:nvPr/>
+        </p:nvSpPr>
+        <p:spPr>
+          <a:xfrm>
+            <a:off x="822960" y="4389120"/>
+            <a:ext cx="10607040" cy="1280160"/>
+          </a:xfrm>
+          <a:prstGeom prst="rect">
+            <a:avLst/>
+          </a:prstGeom>
+          <a:noFill/>
+        </p:spPr>
+        <p:txBody>
+          <a:bodyPr wrap="square">
+            <a:spAutoFit/>
+          </a:bodyPr>
+          <a:lstStyle/>
+          <a:p>
+            <a:pPr algn="l"/>
+            <a:r>
+              <a:rPr sz="1200" b="1">
+                <a:solidFill>
+                  <a:srgbClr val="2A2A2A"/>
+                </a:solidFill>
+                <a:latin typeface="Calibri"/>
+              </a:rPr>
+              <a:t>• Problema (qué encontraste)  •  Evidencia — MEDIR (herramienta, métrica, captura)</a:t>
+            </a:r>
+          </a:p>
+          <a:p>
+            <a:pPr algn="l"/>
+            <a:r>
+              <a:rPr sz="1200" b="1">
+                <a:solidFill>
+                  <a:srgbClr val="2A2A2A"/>
+                </a:solidFill>
+                <a:latin typeface="Calibri"/>
+              </a:rPr>
+              <a:t>• Impacto (a quién afecta)  •  Solución propuesta — PROPONER + MEJORAR (en texto)</a:t>
+            </a:r>
+          </a:p>
+          <a:p>
+            <a:pPr algn="l"/>
+            <a:r>
+              <a:rPr sz="1200" b="1">
+                <a:solidFill>
+                  <a:srgbClr val="2A2A2A"/>
+                </a:solidFill>
+                <a:latin typeface="Calibri"/>
+              </a:rPr>
+              <a:t>• Pilar (VIVO / RÁPIDO / SEGURO)  •  Concepto del curso  •  Severidad + Justificación</a:t>
+            </a:r>
+          </a:p>
+        </p:txBody>
+      </p:sp>
+      <p:sp>
+        <p:nvSpPr>
+          <p:cNvPr id="14" name="Rounded Rectangle 13"/>
+          <p:cNvSpPr/>
+          <p:nvPr/>
+        </p:nvSpPr>
+        <p:spPr>
+          <a:xfrm>
+            <a:off x="640080" y="5852160"/>
+            <a:ext cx="10972800" cy="457200"/>
+          </a:xfrm>
+          <a:prstGeom prst="roundRect">
+            <a:avLst/>
+          </a:prstGeom>
+          <a:solidFill>
+            <a:srgbClr val="FFF3CD"/>
+          </a:solidFill>
+          <a:ln>
+            <a:solidFill>
+              <a:srgbClr val="E6A23E"/>
+            </a:solidFill>
+          </a:ln>
+        </p:spPr>
+        <p:style>
+          <a:lnRef idx="1">
+            <a:schemeClr val="accent1"/>
+          </a:lnRef>
+          <a:fillRef idx="3">
+            <a:schemeClr val="accent1"/>
+          </a:fillRef>
+          <a:effectRef idx="2">
+            <a:schemeClr val="accent1"/>
+          </a:effectRef>
+          <a:fontRef idx="minor">
+            <a:schemeClr val="lt1"/>
+          </a:fontRef>
+        </p:style>
+        <p:txBody>
+          <a:bodyPr rtlCol="0" anchor="ctr"/>
+          <a:lstStyle/>
+          <a:p>
+            <a:pPr algn="ctr"/>
+          </a:p>
+        </p:txBody>
+      </p:sp>
+      <p:sp>
+        <p:nvSpPr>
+          <p:cNvPr id="15" name="TextBox 14"/>
+          <p:cNvSpPr txBox="1"/>
+          <p:nvPr/>
+        </p:nvSpPr>
+        <p:spPr>
+          <a:xfrm>
+            <a:off x="640080" y="5897880"/>
+            <a:ext cx="10972800" cy="365760"/>
+          </a:xfrm>
+          <a:prstGeom prst="rect">
+            <a:avLst/>
+          </a:prstGeom>
+          <a:noFill/>
+        </p:spPr>
+        <p:txBody>
+          <a:bodyPr wrap="square">
+            <a:spAutoFit/>
+          </a:bodyPr>
+          <a:lstStyle/>
+          <a:p>
+            <a:pPr algn="ctr"/>
             <a:r>
               <a:rPr sz="1300" b="1">
                 <a:solidFill>
-                  <a:srgbClr val="FFFFFF"/>
-                </a:solidFill>
-                <a:latin typeface="Calibri"/>
-              </a:rPr>
-              <a:t>Cada Issue se evalúa con 4 criterios (5 pts):</a:t>
-            </a:r>
-          </a:p>
-          <a:p>
-            <a:pPr algn="l"/>
-            <a:r>
-              <a:rPr sz="1300" b="0">
-                <a:solidFill>
-                  <a:srgbClr val="FFFFFF"/>
-                </a:solidFill>
-                <a:latin typeface="Calibri"/>
-              </a:rPr>
-              <a:t/>
-            </a:r>
-          </a:p>
-          <a:p>
-            <a:pPr algn="l"/>
-            <a:r>
-              <a:rPr sz="1300" b="0">
-                <a:solidFill>
-                  <a:srgbClr val="FFFFFF"/>
-                </a:solidFill>
-                <a:latin typeface="Calibri"/>
-              </a:rPr>
-              <a:t>✓ Identificación correcta del problema (2 pts)</a:t>
-            </a:r>
-          </a:p>
-          <a:p>
-            <a:pPr algn="l"/>
-            <a:r>
-              <a:rPr sz="1300" b="0">
-                <a:solidFill>
-                  <a:srgbClr val="FFFFFF"/>
-                </a:solidFill>
-                <a:latin typeface="Calibri"/>
-              </a:rPr>
-              <a:t>✓ Ubicación y evidencia (1 pt)</a:t>
-            </a:r>
-          </a:p>
-          <a:p>
-            <a:pPr algn="l"/>
-            <a:r>
-              <a:rPr sz="1300" b="0">
-                <a:solidFill>
-                  <a:srgbClr val="FFFFFF"/>
-                </a:solidFill>
-                <a:latin typeface="Calibri"/>
-              </a:rPr>
-              <a:t>✓ Impacto + concepto del curso relacionado (1 pt)</a:t>
-            </a:r>
-          </a:p>
-          <a:p>
-            <a:pPr algn="l"/>
-            <a:r>
-              <a:rPr sz="1300" b="0">
-                <a:solidFill>
-                  <a:srgbClr val="FFFFFF"/>
-                </a:solidFill>
-                <a:latin typeface="Calibri"/>
-              </a:rPr>
-              <a:t>✓ Solución propuesta en texto (1 pt)</a:t>
-            </a:r>
-          </a:p>
-          <a:p>
-            <a:pPr algn="l"/>
-            <a:r>
-              <a:rPr sz="1300" b="0">
-                <a:solidFill>
-                  <a:srgbClr val="FFFFFF"/>
-                </a:solidFill>
-                <a:latin typeface="Calibri"/>
-              </a:rPr>
-              <a:t/>
-            </a:r>
-          </a:p>
-          <a:p>
-            <a:pPr algn="l"/>
-            <a:r>
-              <a:rPr sz="1300" b="0">
-                <a:solidFill>
-                  <a:srgbClr val="FFFFFF"/>
-                </a:solidFill>
-                <a:latin typeface="Calibri"/>
-              </a:rPr>
-              <a:t>Cada template es un FORMULARIO INTERACTIVO con inputs, dropdowns y checkboxes.</a:t>
-            </a:r>
-          </a:p>
-        </p:txBody>
-      </p:sp>
-      <p:sp>
-        <p:nvSpPr>
-          <p:cNvPr id="12" name="TextBox 11"/>
+                  <a:srgbClr val="924E0E"/>
+                </a:solidFill>
+                <a:latin typeface="Calibri"/>
+              </a:rPr>
+              <a:t>📊 Puntaje: 3 Issues × 5 pts = 15 pts (no se exige aplicar correcciones en código)</a:t>
+            </a:r>
+          </a:p>
+        </p:txBody>
+      </p:sp>
+      <p:sp>
+        <p:nvSpPr>
+          <p:cNvPr id="16" name="TextBox 15"/>
           <p:cNvSpPr txBox="1"/>
           <p:nvPr/>
         </p:nvSpPr>
@@ -9775,14 +10390,14 @@
                 </a:solidFill>
                 <a:latin typeface="Calibri"/>
               </a:rPr>
-              <a:t>📦 Repo: github.com/KrizRoMe/evaluacion-administracion-web   •   🌐 Web: krizrome.github.io/evaluacion-administracion-web   •   📋 Issues: github.com/KrizRoMe/evaluacion-administracion-web/issues</a:t>
-            </a:r>
-          </a:p>
-        </p:txBody>
-      </p:sp>
-      <p:sp>
-        <p:nvSpPr>
-          <p:cNvPr id="13" name="TextBox 12"/>
+              <a:t>📦 Repo del docente: github.com/KrizRoMe/evaluacion-administracion-web   •   🌐 Sitio público: krizrome.github.io/evaluacion-administracion-web   •   📋 Issues: github.com/KrizRoMe/evaluacion-administracion-web/issues</a:t>
+            </a:r>
+          </a:p>
+        </p:txBody>
+      </p:sp>
+      <p:sp>
+        <p:nvSpPr>
+          <p:cNvPr id="17" name="TextBox 16"/>
           <p:cNvSpPr txBox="1"/>
           <p:nvPr/>
         </p:nvSpPr>
@@ -9891,7 +10506,7 @@
             <a:avLst/>
           </a:prstGeom>
           <a:solidFill>
-            <a:srgbClr val="065A82"/>
+            <a:srgbClr val="EA580C"/>
           </a:solidFill>
           <a:ln>
             <a:noFill/>
@@ -9949,7 +10564,7 @@
                 </a:solidFill>
                 <a:latin typeface="Calibri"/>
               </a:rPr>
-              <a:t>Parte 5 · Documentar solución + README</a:t>
+              <a:t>🔗 Parte 5 · Issue de link-evaluación</a:t>
             </a:r>
           </a:p>
         </p:txBody>
@@ -9980,11 +10595,11 @@
             <a:r>
               <a:rPr sz="1400" b="0">
                 <a:solidFill>
-                  <a:srgbClr val="60A5FA"/>
-                </a:solidFill>
-                <a:latin typeface="Calibri"/>
-              </a:rPr>
-              <a:t>⏱ 25 minutos  •  Sin tocar el código</a:t>
+                  <a:srgbClr val="FED3B6"/>
+                </a:solidFill>
+                <a:latin typeface="Calibri"/>
+              </a:rPr>
+              <a:t>⏱ 5 minutos  •  Cuarta y última Issue (en el repo del docente)</a:t>
             </a:r>
           </a:p>
         </p:txBody>
@@ -9997,18 +10612,18 @@
         </p:nvSpPr>
         <p:spPr>
           <a:xfrm>
-            <a:off x="640080" y="1280160"/>
+            <a:off x="640080" y="1188720"/>
             <a:ext cx="10972800" cy="640080"/>
           </a:xfrm>
           <a:prstGeom prst="roundRect">
             <a:avLst/>
           </a:prstGeom>
           <a:solidFill>
-            <a:srgbClr val="FFF3CD"/>
+            <a:srgbClr val="FEF3E6"/>
           </a:solidFill>
-          <a:ln>
+          <a:ln w="38100">
             <a:solidFill>
-              <a:srgbClr val="E6A23E"/>
+              <a:srgbClr val="EA580C"/>
             </a:solidFill>
           </a:ln>
         </p:spPr>
@@ -10042,8 +10657,8 @@
         </p:nvSpPr>
         <p:spPr>
           <a:xfrm>
-            <a:off x="822960" y="1371600"/>
-            <a:ext cx="10607040" cy="457200"/>
+            <a:off x="822960" y="1280160"/>
+            <a:ext cx="10607040" cy="365760"/>
           </a:xfrm>
           <a:prstGeom prst="rect">
             <a:avLst/>
@@ -10058,13 +10673,13 @@
           <a:p>
             <a:pPr algn="ctr"/>
             <a:r>
-              <a:rPr sz="1400" b="1">
-                <a:solidFill>
-                  <a:srgbClr val="924E0E"/>
-                </a:solidFill>
-                <a:latin typeface="Calibri"/>
-              </a:rPr>
-              <a:t>⚠️  No es necesario aplicar las correcciones en el código. Solo ANALIZAR y PROPONER en texto.</a:t>
+              <a:rPr sz="1500" b="1">
+                <a:solidFill>
+                  <a:srgbClr val="EA580C"/>
+                </a:solidFill>
+                <a:latin typeface="Calibri"/>
+              </a:rPr>
+              <a:t>📋 Esta Issue también se crea en el repo del DOCENTE:</a:t>
             </a:r>
           </a:p>
         </p:txBody>
@@ -10077,7 +10692,7 @@
         </p:nvSpPr>
         <p:spPr>
           <a:xfrm>
-            <a:off x="640080" y="2103120"/>
+            <a:off x="640080" y="2011680"/>
             <a:ext cx="10972800" cy="365760"/>
           </a:xfrm>
           <a:prstGeom prst="rect">
@@ -10093,13 +10708,13 @@
           <a:p>
             <a:pPr algn="l"/>
             <a:r>
-              <a:rPr sz="1600" b="1">
+              <a:rPr sz="1800" b="1">
                 <a:solidFill>
                   <a:srgbClr val="065A82"/>
                 </a:solidFill>
                 <a:latin typeface="Calibri"/>
               </a:rPr>
-              <a:t>En cada Issue, completa la sección Solución propuesta:</a:t>
+              <a:t>Pasos:</a:t>
             </a:r>
           </a:p>
         </p:txBody>
@@ -10112,8 +10727,8 @@
         </p:nvSpPr>
         <p:spPr>
           <a:xfrm>
-            <a:off x="822960" y="2560320"/>
-            <a:ext cx="10972800" cy="1828800"/>
+            <a:off x="822960" y="2423160"/>
+            <a:ext cx="10972800" cy="1097280"/>
           </a:xfrm>
           <a:prstGeom prst="rect">
             <a:avLst/>
@@ -10134,7 +10749,7 @@
                 </a:solidFill>
                 <a:latin typeface="Calibri"/>
               </a:rPr>
-              <a:t>"Agregar atributos width y height a la etiqueta &lt;img&gt; del hero."</a:t>
+              <a:t>1. En el repo del docente, Issues → New issue</a:t>
             </a:r>
           </a:p>
           <a:p>
@@ -10146,7 +10761,7 @@
                 </a:solidFill>
                 <a:latin typeface="Calibri"/>
               </a:rPr>
-              <a:t>"Añadir el atributo defer al &lt;script&gt;."</a:t>
+              <a:t>2. Selecciona el template 🔗 Link de evaluación</a:t>
             </a:r>
           </a:p>
           <a:p>
@@ -10158,7 +10773,7 @@
                 </a:solidFill>
                 <a:latin typeface="Calibri"/>
               </a:rPr>
-              <a:t>"Actualizar jquery a una versión 3.x."</a:t>
+              <a:t>3. Completa: nombre, link de tu repo, link público de tu sitio</a:t>
             </a:r>
           </a:p>
           <a:p>
@@ -10170,19 +10785,7 @@
                 </a:solidFill>
                 <a:latin typeface="Calibri"/>
               </a:rPr>
-              <a:t>"Cambiar el texto del footer por la fecha actual."</a:t>
-            </a:r>
-          </a:p>
-          <a:p>
-            <a:pPr algn="l"/>
-            <a:r>
-              <a:rPr sz="1300" b="0">
-                <a:solidFill>
-                  <a:srgbClr val="2A2A2A"/>
-                </a:solidFill>
-                <a:latin typeface="Calibri"/>
-              </a:rPr>
-              <a:t>"Agregar atributo alt descriptivo a las imágenes."</a:t>
+              <a:t>4. Submit</a:t>
             </a:r>
           </a:p>
         </p:txBody>
@@ -10195,14 +10798,164 @@
         </p:nvSpPr>
         <p:spPr>
           <a:xfrm>
-            <a:off x="640080" y="4572000"/>
-            <a:ext cx="10972800" cy="1737360"/>
+            <a:off x="640080" y="3931920"/>
+            <a:ext cx="10972800" cy="1280160"/>
           </a:xfrm>
           <a:prstGeom prst="roundRect">
             <a:avLst/>
           </a:prstGeom>
           <a:solidFill>
-            <a:srgbClr val="E3F2FD"/>
+            <a:srgbClr val="FEF3E6"/>
+          </a:solidFill>
+          <a:ln w="38100">
+            <a:solidFill>
+              <a:srgbClr val="EA580C"/>
+            </a:solidFill>
+          </a:ln>
+        </p:spPr>
+        <p:style>
+          <a:lnRef idx="1">
+            <a:schemeClr val="accent1"/>
+          </a:lnRef>
+          <a:fillRef idx="3">
+            <a:schemeClr val="accent1"/>
+          </a:fillRef>
+          <a:effectRef idx="2">
+            <a:schemeClr val="accent1"/>
+          </a:effectRef>
+          <a:fontRef idx="minor">
+            <a:schemeClr val="lt1"/>
+          </a:fontRef>
+        </p:style>
+        <p:txBody>
+          <a:bodyPr rtlCol="0" anchor="ctr"/>
+          <a:lstStyle/>
+          <a:p>
+            <a:pPr algn="ctr"/>
+          </a:p>
+        </p:txBody>
+      </p:sp>
+      <p:sp>
+        <p:nvSpPr>
+          <p:cNvPr id="11" name="TextBox 10"/>
+          <p:cNvSpPr txBox="1"/>
+          <p:nvPr/>
+        </p:nvSpPr>
+        <p:spPr>
+          <a:xfrm>
+            <a:off x="822960" y="4023360"/>
+            <a:ext cx="10607040" cy="365760"/>
+          </a:xfrm>
+          <a:prstGeom prst="rect">
+            <a:avLst/>
+          </a:prstGeom>
+          <a:noFill/>
+        </p:spPr>
+        <p:txBody>
+          <a:bodyPr wrap="square">
+            <a:spAutoFit/>
+          </a:bodyPr>
+          <a:lstStyle/>
+          <a:p>
+            <a:pPr algn="ctr"/>
+            <a:r>
+              <a:rPr sz="1400" b="1">
+                <a:solidFill>
+                  <a:srgbClr val="EA580C"/>
+                </a:solidFill>
+                <a:latin typeface="Calibri"/>
+              </a:rPr>
+              <a:t>🔗 LINK DIRECTO para publicar tu repo + sitio público:</a:t>
+            </a:r>
+          </a:p>
+        </p:txBody>
+      </p:sp>
+      <p:sp>
+        <p:nvSpPr>
+          <p:cNvPr id="12" name="TextBox 11"/>
+          <p:cNvSpPr txBox="1"/>
+          <p:nvPr/>
+        </p:nvSpPr>
+        <p:spPr>
+          <a:xfrm>
+            <a:off x="822960" y="4434840"/>
+            <a:ext cx="10607040" cy="457200"/>
+          </a:xfrm>
+          <a:prstGeom prst="rect">
+            <a:avLst/>
+          </a:prstGeom>
+          <a:noFill/>
+        </p:spPr>
+        <p:txBody>
+          <a:bodyPr wrap="square">
+            <a:spAutoFit/>
+          </a:bodyPr>
+          <a:lstStyle/>
+          <a:p>
+            <a:pPr algn="ctr"/>
+            <a:r>
+              <a:rPr sz="1400" b="1">
+                <a:solidFill>
+                  <a:srgbClr val="2A2A2A"/>
+                </a:solidFill>
+                <a:latin typeface="Consolas"/>
+              </a:rPr>
+              <a:t>https://github.com/KrizRoMe/evaluacion-administracion-web/issues/new?template=link-evaluacion.yml</a:t>
+            </a:r>
+          </a:p>
+        </p:txBody>
+      </p:sp>
+      <p:sp>
+        <p:nvSpPr>
+          <p:cNvPr id="13" name="TextBox 12"/>
+          <p:cNvSpPr txBox="1"/>
+          <p:nvPr/>
+        </p:nvSpPr>
+        <p:spPr>
+          <a:xfrm>
+            <a:off x="822960" y="4846320"/>
+            <a:ext cx="10607040" cy="274320"/>
+          </a:xfrm>
+          <a:prstGeom prst="rect">
+            <a:avLst/>
+          </a:prstGeom>
+          <a:noFill/>
+        </p:spPr>
+        <p:txBody>
+          <a:bodyPr wrap="square">
+            <a:spAutoFit/>
+          </a:bodyPr>
+          <a:lstStyle/>
+          <a:p>
+            <a:pPr algn="ctr"/>
+            <a:r>
+              <a:rPr sz="1000" b="0">
+                <a:solidFill>
+                  <a:srgbClr val="999999"/>
+                </a:solidFill>
+                <a:latin typeface="Calibri"/>
+              </a:rPr>
+              <a:t>(también lo encuentras en la pestaña Issues del repo del docente)</a:t>
+            </a:r>
+          </a:p>
+        </p:txBody>
+      </p:sp>
+      <p:sp>
+        <p:nvSpPr>
+          <p:cNvPr id="14" name="Rounded Rectangle 13"/>
+          <p:cNvSpPr/>
+          <p:nvPr/>
+        </p:nvSpPr>
+        <p:spPr>
+          <a:xfrm>
+            <a:off x="640080" y="5394960"/>
+            <a:ext cx="10972800" cy="914400"/>
+          </a:xfrm>
+          <a:prstGeom prst="roundRect">
+            <a:avLst/>
+          </a:prstGeom>
+          <a:solidFill>
+            <a:srgbClr val="F4F4F4"/>
           </a:solidFill>
           <a:ln>
             <a:solidFill>
@@ -10234,13 +10987,13 @@
       </p:sp>
       <p:sp>
         <p:nvSpPr>
-          <p:cNvPr id="11" name="TextBox 10"/>
-          <p:cNvSpPr txBox="1"/>
-          <p:nvPr/>
-        </p:nvSpPr>
-        <p:spPr>
-          <a:xfrm>
-            <a:off x="822960" y="4617720"/>
+          <p:cNvPr id="15" name="TextBox 14"/>
+          <p:cNvSpPr txBox="1"/>
+          <p:nvPr/>
+        </p:nvSpPr>
+        <p:spPr>
+          <a:xfrm>
+            <a:off x="822960" y="5440680"/>
             <a:ext cx="10607040" cy="274320"/>
           </a:xfrm>
           <a:prstGeom prst="rect">
@@ -10256,27 +11009,27 @@
           <a:p>
             <a:pPr algn="l"/>
             <a:r>
-              <a:rPr sz="1400" b="1">
+              <a:rPr sz="1300" b="1">
                 <a:solidFill>
                   <a:srgbClr val="065A82"/>
                 </a:solidFill>
                 <a:latin typeface="Calibri"/>
               </a:rPr>
-              <a:t>📚 README debe incluir:</a:t>
-            </a:r>
-          </a:p>
-        </p:txBody>
-      </p:sp>
-      <p:sp>
-        <p:nvSpPr>
-          <p:cNvPr id="12" name="TextBox 11"/>
-          <p:cNvSpPr txBox="1"/>
-          <p:nvPr/>
-        </p:nvSpPr>
-        <p:spPr>
-          <a:xfrm>
-            <a:off x="914400" y="4937760"/>
-            <a:ext cx="10424160" cy="1371600"/>
+              <a:t>La Issue de link-evaluación te pide SOLO:</a:t>
+            </a:r>
+          </a:p>
+        </p:txBody>
+      </p:sp>
+      <p:sp>
+        <p:nvSpPr>
+          <p:cNvPr id="16" name="TextBox 15"/>
+          <p:cNvSpPr txBox="1"/>
+          <p:nvPr/>
+        </p:nvSpPr>
+        <p:spPr>
+          <a:xfrm>
+            <a:off x="1005840" y="5760720"/>
+            <a:ext cx="10424160" cy="548640"/>
           </a:xfrm>
           <a:prstGeom prst="rect">
             <a:avLst/>
@@ -10297,14 +11050,14 @@
                 </a:solidFill>
                 <a:latin typeface="Calibri"/>
               </a:rPr>
-              <a:t>VIVO · RÁPIDO (con LCP/INP/CLS/TTFB) · SEGURO (2 acciones) · Backup 3-2-1 · SLI · SLO · SLA · Runbook (4–6 pasos) · Datos del estudiante + URLs</a:t>
-            </a:r>
-          </a:p>
-        </p:txBody>
-      </p:sp>
-      <p:sp>
-        <p:nvSpPr>
-          <p:cNvPr id="13" name="TextBox 12"/>
+              <a:t>• Nombre completo  •  Link de tu repositorio  •  Link público de tu sitio</a:t>
+            </a:r>
+          </a:p>
+        </p:txBody>
+      </p:sp>
+      <p:sp>
+        <p:nvSpPr>
+          <p:cNvPr id="17" name="TextBox 16"/>
           <p:cNvSpPr txBox="1"/>
           <p:nvPr/>
         </p:nvSpPr>
@@ -10332,14 +11085,14 @@
                 </a:solidFill>
                 <a:latin typeface="Calibri"/>
               </a:rPr>
-              <a:t>📦 Repo: github.com/KrizRoMe/evaluacion-administracion-web   •   🌐 Web: krizrome.github.io/evaluacion-administracion-web   •   📋 Issues: github.com/KrizRoMe/evaluacion-administracion-web/issues</a:t>
-            </a:r>
-          </a:p>
-        </p:txBody>
-      </p:sp>
-      <p:sp>
-        <p:nvSpPr>
-          <p:cNvPr id="14" name="TextBox 13"/>
+              <a:t>📦 Repo del docente: github.com/KrizRoMe/evaluacion-administracion-web   •   🌐 Sitio público: krizrome.github.io/evaluacion-administracion-web   •   📋 Issues: github.com/KrizRoMe/evaluacion-administracion-web/issues</a:t>
+            </a:r>
+          </a:p>
+        </p:txBody>
+      </p:sp>
+      <p:sp>
+        <p:nvSpPr>
+          <p:cNvPr id="18" name="TextBox 17"/>
           <p:cNvSpPr txBox="1"/>
           <p:nvPr/>
         </p:nvSpPr>

</xml_diff>

<commit_message>
update: 4 Issues en repo del docente + 20 pts
</commit_message>
<xml_diff>
--- a/EVALUACION_PRACTICA_01.pptx
+++ b/EVALUACION_PRACTICA_01.pptx
@@ -3296,7 +3296,19 @@
                 </a:solidFill>
                 <a:latin typeface="Calibri"/>
               </a:rPr>
-              <a:t>Unidad: 1  •  Duración: 90 minutos  •  Aprobado: 14/20</a:t>
+              <a:t>Unidad: 1  •  Duración: 90 minutos  •  Puntaje: 4 Issues × 5 pts = 20 pts</a:t>
+            </a:r>
+          </a:p>
+          <a:p>
+            <a:pPr algn="ctr"/>
+            <a:r>
+              <a:rPr sz="1500" b="0">
+                <a:solidFill>
+                  <a:srgbClr val="FFFFFF"/>
+                </a:solidFill>
+                <a:latin typeface="Calibri"/>
+              </a:rPr>
+              <a:t>Aprobado: ≥14 pts</a:t>
             </a:r>
           </a:p>
         </p:txBody>
@@ -3607,7 +3619,7 @@
             <a:avLst/>
           </a:prstGeom>
           <a:solidFill>
-            <a:srgbClr val="EA580C"/>
+            <a:srgbClr val="065A82"/>
           </a:solidFill>
           <a:ln>
             <a:noFill/>
@@ -3665,7 +3677,7 @@
                 </a:solidFill>
                 <a:latin typeface="Calibri"/>
               </a:rPr>
-              <a:t>🔗 Parte 6 · Publicar tu link de evaluación</a:t>
+              <a:t>Parte 6 · Documentar solución + README</a:t>
             </a:r>
           </a:p>
         </p:txBody>
@@ -3696,130 +3708,35 @@
             <a:r>
               <a:rPr sz="1400" b="0">
                 <a:solidFill>
-                  <a:srgbClr val="FED3B6"/>
-                </a:solidFill>
-                <a:latin typeface="Calibri"/>
-              </a:rPr>
-              <a:t>⏱ 5 minutos  •  Una sola Issue con el link de tu repo y tu sitio público</a:t>
-            </a:r>
-          </a:p>
-        </p:txBody>
-      </p:sp>
-      <p:sp>
-        <p:nvSpPr>
-          <p:cNvPr id="6" name="TextBox 5"/>
-          <p:cNvSpPr txBox="1"/>
-          <p:nvPr/>
-        </p:nvSpPr>
-        <p:spPr>
-          <a:xfrm>
-            <a:off x="640080" y="1188720"/>
-            <a:ext cx="10972800" cy="1371600"/>
-          </a:xfrm>
-          <a:prstGeom prst="rect">
-            <a:avLst/>
-          </a:prstGeom>
-          <a:noFill/>
-        </p:spPr>
-        <p:txBody>
-          <a:bodyPr wrap="square">
-            <a:spAutoFit/>
-          </a:bodyPr>
-          <a:lstStyle/>
-          <a:p>
-            <a:pPr algn="l"/>
-            <a:r>
-              <a:rPr sz="1400" b="1">
-                <a:solidFill>
-                  <a:srgbClr val="2A2A2A"/>
-                </a:solidFill>
-                <a:latin typeface="Calibri"/>
-              </a:rPr>
-              <a:t>Pasos:</a:t>
-            </a:r>
-          </a:p>
-          <a:p>
-            <a:pPr algn="l"/>
-            <a:r>
-              <a:rPr sz="1400" b="0">
-                <a:solidFill>
-                  <a:srgbClr val="2A2A2A"/>
-                </a:solidFill>
-                <a:latin typeface="Calibri"/>
-              </a:rPr>
-              <a:t>1. Abre el repo del curso en una pestaña nueva:</a:t>
-            </a:r>
-          </a:p>
-          <a:p>
-            <a:pPr algn="l"/>
-            <a:r>
-              <a:rPr sz="1400" b="0">
-                <a:solidFill>
-                  <a:srgbClr val="2A2A2A"/>
-                </a:solidFill>
-                <a:latin typeface="Calibri"/>
-              </a:rPr>
-              <a:t>2. Clic en Issues → New issue</a:t>
-            </a:r>
-          </a:p>
-          <a:p>
-            <a:pPr algn="l"/>
-            <a:r>
-              <a:rPr sz="1400" b="0">
-                <a:solidFill>
-                  <a:srgbClr val="2A2A2A"/>
-                </a:solidFill>
-                <a:latin typeface="Calibri"/>
-              </a:rPr>
-              <a:t>3. Selecciona el template 🔗 Link de evaluación</a:t>
-            </a:r>
-          </a:p>
-          <a:p>
-            <a:pPr algn="l"/>
-            <a:r>
-              <a:rPr sz="1400" b="0">
-                <a:solidFill>
-                  <a:srgbClr val="2A2A2A"/>
-                </a:solidFill>
-                <a:latin typeface="Calibri"/>
-              </a:rPr>
-              <a:t>4. Completa: nombre, link de tu repo, link público de tu sitio</a:t>
-            </a:r>
-          </a:p>
-          <a:p>
-            <a:pPr algn="l"/>
-            <a:r>
-              <a:rPr sz="1400" b="0">
-                <a:solidFill>
-                  <a:srgbClr val="2A2A2A"/>
-                </a:solidFill>
-                <a:latin typeface="Calibri"/>
-              </a:rPr>
-              <a:t>5. Clic en Submit (Crear)</a:t>
-            </a:r>
-          </a:p>
-        </p:txBody>
-      </p:sp>
-      <p:sp>
-        <p:nvSpPr>
-          <p:cNvPr id="7" name="Rounded Rectangle 6"/>
+                  <a:srgbClr val="60A5FA"/>
+                </a:solidFill>
+                <a:latin typeface="Calibri"/>
+              </a:rPr>
+              <a:t>⏱ 15 minutos  •  Sin tocar el código</a:t>
+            </a:r>
+          </a:p>
+        </p:txBody>
+      </p:sp>
+      <p:sp>
+        <p:nvSpPr>
+          <p:cNvPr id="6" name="Rounded Rectangle 5"/>
           <p:cNvSpPr/>
           <p:nvPr/>
         </p:nvSpPr>
         <p:spPr>
           <a:xfrm>
-            <a:off x="640080" y="3657600"/>
-            <a:ext cx="10972800" cy="1280160"/>
+            <a:off x="640080" y="1280160"/>
+            <a:ext cx="10972800" cy="640080"/>
           </a:xfrm>
           <a:prstGeom prst="roundRect">
             <a:avLst/>
           </a:prstGeom>
           <a:solidFill>
-            <a:srgbClr val="FEF3E6"/>
+            <a:srgbClr val="FFF3CD"/>
           </a:solidFill>
-          <a:ln w="38100">
+          <a:ln>
             <a:solidFill>
-              <a:srgbClr val="EA580C"/>
+              <a:srgbClr val="E6A23E"/>
             </a:solidFill>
           </a:ln>
         </p:spPr>
@@ -3847,35 +3764,70 @@
       </p:sp>
       <p:sp>
         <p:nvSpPr>
+          <p:cNvPr id="7" name="TextBox 6"/>
+          <p:cNvSpPr txBox="1"/>
+          <p:nvPr/>
+        </p:nvSpPr>
+        <p:spPr>
+          <a:xfrm>
+            <a:off x="822960" y="1371600"/>
+            <a:ext cx="10607040" cy="457200"/>
+          </a:xfrm>
+          <a:prstGeom prst="rect">
+            <a:avLst/>
+          </a:prstGeom>
+          <a:noFill/>
+        </p:spPr>
+        <p:txBody>
+          <a:bodyPr wrap="square">
+            <a:spAutoFit/>
+          </a:bodyPr>
+          <a:lstStyle/>
+          <a:p>
+            <a:pPr algn="ctr"/>
+            <a:r>
+              <a:rPr sz="1400" b="1">
+                <a:solidFill>
+                  <a:srgbClr val="924E0E"/>
+                </a:solidFill>
+                <a:latin typeface="Calibri"/>
+              </a:rPr>
+              <a:t>⚠️  No es necesario aplicar las correcciones en el código. Solo ANALIZAR y PROPONER en texto.</a:t>
+            </a:r>
+          </a:p>
+        </p:txBody>
+      </p:sp>
+      <p:sp>
+        <p:nvSpPr>
           <p:cNvPr id="8" name="TextBox 7"/>
           <p:cNvSpPr txBox="1"/>
           <p:nvPr/>
         </p:nvSpPr>
         <p:spPr>
           <a:xfrm>
-            <a:off x="822960" y="3749039"/>
-            <a:ext cx="10607040" cy="365760"/>
-          </a:xfrm>
-          <a:prstGeom prst="rect">
-            <a:avLst/>
-          </a:prstGeom>
-          <a:noFill/>
-        </p:spPr>
-        <p:txBody>
-          <a:bodyPr wrap="square">
-            <a:spAutoFit/>
-          </a:bodyPr>
-          <a:lstStyle/>
-          <a:p>
-            <a:pPr algn="ctr"/>
-            <a:r>
-              <a:rPr sz="1400" b="1">
-                <a:solidFill>
-                  <a:srgbClr val="EA580C"/>
-                </a:solidFill>
-                <a:latin typeface="Calibri"/>
-              </a:rPr>
-              <a:t>🔗 LINK DIRECTO para publicar tu repo + sitio público:</a:t>
+            <a:off x="640080" y="2103120"/>
+            <a:ext cx="10972800" cy="365760"/>
+          </a:xfrm>
+          <a:prstGeom prst="rect">
+            <a:avLst/>
+          </a:prstGeom>
+          <a:noFill/>
+        </p:spPr>
+        <p:txBody>
+          <a:bodyPr wrap="square">
+            <a:spAutoFit/>
+          </a:bodyPr>
+          <a:lstStyle/>
+          <a:p>
+            <a:pPr algn="l"/>
+            <a:r>
+              <a:rPr sz="1600" b="1">
+                <a:solidFill>
+                  <a:srgbClr val="065A82"/>
+                </a:solidFill>
+                <a:latin typeface="Calibri"/>
+              </a:rPr>
+              <a:t>En cada Issue, completa la sección Solución propuesta:</a:t>
             </a:r>
           </a:p>
         </p:txBody>
@@ -3888,84 +3840,97 @@
         </p:nvSpPr>
         <p:spPr>
           <a:xfrm>
-            <a:off x="822960" y="4160520"/>
-            <a:ext cx="10607040" cy="457200"/>
-          </a:xfrm>
-          <a:prstGeom prst="rect">
-            <a:avLst/>
-          </a:prstGeom>
-          <a:noFill/>
-        </p:spPr>
-        <p:txBody>
-          <a:bodyPr wrap="square">
-            <a:spAutoFit/>
-          </a:bodyPr>
-          <a:lstStyle/>
-          <a:p>
-            <a:pPr algn="ctr"/>
-            <a:r>
-              <a:rPr sz="1400" b="1">
+            <a:off x="822960" y="2560320"/>
+            <a:ext cx="10972800" cy="1828800"/>
+          </a:xfrm>
+          <a:prstGeom prst="rect">
+            <a:avLst/>
+          </a:prstGeom>
+          <a:noFill/>
+        </p:spPr>
+        <p:txBody>
+          <a:bodyPr wrap="square">
+            <a:spAutoFit/>
+          </a:bodyPr>
+          <a:lstStyle/>
+          <a:p>
+            <a:pPr algn="l"/>
+            <a:r>
+              <a:rPr sz="1300" b="0">
                 <a:solidFill>
                   <a:srgbClr val="2A2A2A"/>
                 </a:solidFill>
-                <a:latin typeface="Consolas"/>
-              </a:rPr>
-              <a:t>https://github.com/KrizRoMe/evaluacion-administracion-web/issues/new?template=link-evaluacion.yml</a:t>
-            </a:r>
-          </a:p>
-        </p:txBody>
-      </p:sp>
-      <p:sp>
-        <p:nvSpPr>
-          <p:cNvPr id="10" name="TextBox 9"/>
-          <p:cNvSpPr txBox="1"/>
-          <p:nvPr/>
-        </p:nvSpPr>
-        <p:spPr>
-          <a:xfrm>
-            <a:off x="822960" y="4572000"/>
-            <a:ext cx="10607040" cy="274320"/>
-          </a:xfrm>
-          <a:prstGeom prst="rect">
-            <a:avLst/>
-          </a:prstGeom>
-          <a:noFill/>
-        </p:spPr>
-        <p:txBody>
-          <a:bodyPr wrap="square">
-            <a:spAutoFit/>
-          </a:bodyPr>
-          <a:lstStyle/>
-          <a:p>
-            <a:pPr algn="ctr"/>
-            <a:r>
-              <a:rPr sz="1000" b="0">
-                <a:solidFill>
-                  <a:srgbClr val="999999"/>
-                </a:solidFill>
-                <a:latin typeface="Calibri"/>
-              </a:rPr>
-              <a:t>(también lo encuentras en la pestaña Issues del repo del docente)</a:t>
-            </a:r>
-          </a:p>
-        </p:txBody>
-      </p:sp>
-      <p:sp>
-        <p:nvSpPr>
-          <p:cNvPr id="11" name="Rounded Rectangle 10"/>
+                <a:latin typeface="Calibri"/>
+              </a:rPr>
+              <a:t>"Agregar atributos width y height a la etiqueta &lt;img&gt; del hero."</a:t>
+            </a:r>
+          </a:p>
+          <a:p>
+            <a:pPr algn="l"/>
+            <a:r>
+              <a:rPr sz="1300" b="0">
+                <a:solidFill>
+                  <a:srgbClr val="2A2A2A"/>
+                </a:solidFill>
+                <a:latin typeface="Calibri"/>
+              </a:rPr>
+              <a:t>"Añadir el atributo defer al &lt;script&gt;."</a:t>
+            </a:r>
+          </a:p>
+          <a:p>
+            <a:pPr algn="l"/>
+            <a:r>
+              <a:rPr sz="1300" b="0">
+                <a:solidFill>
+                  <a:srgbClr val="2A2A2A"/>
+                </a:solidFill>
+                <a:latin typeface="Calibri"/>
+              </a:rPr>
+              <a:t>"Actualizar jquery a una versión 3.x."</a:t>
+            </a:r>
+          </a:p>
+          <a:p>
+            <a:pPr algn="l"/>
+            <a:r>
+              <a:rPr sz="1300" b="0">
+                <a:solidFill>
+                  <a:srgbClr val="2A2A2A"/>
+                </a:solidFill>
+                <a:latin typeface="Calibri"/>
+              </a:rPr>
+              <a:t>"Cambiar el texto del footer por la fecha actual."</a:t>
+            </a:r>
+          </a:p>
+          <a:p>
+            <a:pPr algn="l"/>
+            <a:r>
+              <a:rPr sz="1300" b="0">
+                <a:solidFill>
+                  <a:srgbClr val="2A2A2A"/>
+                </a:solidFill>
+                <a:latin typeface="Calibri"/>
+              </a:rPr>
+              <a:t>"Agregar atributo alt descriptivo a las imágenes."</a:t>
+            </a:r>
+          </a:p>
+        </p:txBody>
+      </p:sp>
+      <p:sp>
+        <p:nvSpPr>
+          <p:cNvPr id="10" name="Rounded Rectangle 9"/>
           <p:cNvSpPr/>
           <p:nvPr/>
         </p:nvSpPr>
         <p:spPr>
           <a:xfrm>
-            <a:off x="640080" y="5120640"/>
-            <a:ext cx="10972800" cy="1188720"/>
+            <a:off x="640080" y="4572000"/>
+            <a:ext cx="10972800" cy="1737360"/>
           </a:xfrm>
           <a:prstGeom prst="roundRect">
             <a:avLst/>
           </a:prstGeom>
           <a:solidFill>
-            <a:srgbClr val="F4F4F4"/>
+            <a:srgbClr val="E3F2FD"/>
           </a:solidFill>
           <a:ln>
             <a:solidFill>
@@ -3997,35 +3962,70 @@
       </p:sp>
       <p:sp>
         <p:nvSpPr>
+          <p:cNvPr id="11" name="TextBox 10"/>
+          <p:cNvSpPr txBox="1"/>
+          <p:nvPr/>
+        </p:nvSpPr>
+        <p:spPr>
+          <a:xfrm>
+            <a:off x="822960" y="4617720"/>
+            <a:ext cx="10607040" cy="274320"/>
+          </a:xfrm>
+          <a:prstGeom prst="rect">
+            <a:avLst/>
+          </a:prstGeom>
+          <a:noFill/>
+        </p:spPr>
+        <p:txBody>
+          <a:bodyPr wrap="square">
+            <a:spAutoFit/>
+          </a:bodyPr>
+          <a:lstStyle/>
+          <a:p>
+            <a:pPr algn="l"/>
+            <a:r>
+              <a:rPr sz="1400" b="1">
+                <a:solidFill>
+                  <a:srgbClr val="065A82"/>
+                </a:solidFill>
+                <a:latin typeface="Calibri"/>
+              </a:rPr>
+              <a:t>📚 Tu README debe incluir:</a:t>
+            </a:r>
+          </a:p>
+        </p:txBody>
+      </p:sp>
+      <p:sp>
+        <p:nvSpPr>
           <p:cNvPr id="12" name="TextBox 11"/>
           <p:cNvSpPr txBox="1"/>
           <p:nvPr/>
         </p:nvSpPr>
         <p:spPr>
           <a:xfrm>
-            <a:off x="822960" y="5166360"/>
-            <a:ext cx="10607040" cy="274320"/>
-          </a:xfrm>
-          <a:prstGeom prst="rect">
-            <a:avLst/>
-          </a:prstGeom>
-          <a:noFill/>
-        </p:spPr>
-        <p:txBody>
-          <a:bodyPr wrap="square">
-            <a:spAutoFit/>
-          </a:bodyPr>
-          <a:lstStyle/>
-          <a:p>
-            <a:pPr algn="l"/>
-            <a:r>
-              <a:rPr sz="1300" b="1">
-                <a:solidFill>
-                  <a:srgbClr val="065A82"/>
-                </a:solidFill>
-                <a:latin typeface="Calibri"/>
-              </a:rPr>
-              <a:t>La Issue te pide SOLO:</a:t>
+            <a:off x="914400" y="4937760"/>
+            <a:ext cx="10424160" cy="1371600"/>
+          </a:xfrm>
+          <a:prstGeom prst="rect">
+            <a:avLst/>
+          </a:prstGeom>
+          <a:noFill/>
+        </p:spPr>
+        <p:txBody>
+          <a:bodyPr wrap="square">
+            <a:spAutoFit/>
+          </a:bodyPr>
+          <a:lstStyle/>
+          <a:p>
+            <a:pPr algn="l"/>
+            <a:r>
+              <a:rPr sz="1200" b="0">
+                <a:solidFill>
+                  <a:srgbClr val="2A2A2A"/>
+                </a:solidFill>
+                <a:latin typeface="Calibri"/>
+              </a:rPr>
+              <a:t>VIVO · RÁPIDO (con LCP/INP/CLS/TTFB) · SEGURO (2 acciones) · Backup 3-2-1 · SLI · SLO · SLA · Runbook (4–6 pasos) · Datos del estudiante + URLs</a:t>
             </a:r>
           </a:p>
         </p:txBody>
@@ -4033,41 +4033,6 @@
       <p:sp>
         <p:nvSpPr>
           <p:cNvPr id="13" name="TextBox 12"/>
-          <p:cNvSpPr txBox="1"/>
-          <p:nvPr/>
-        </p:nvSpPr>
-        <p:spPr>
-          <a:xfrm>
-            <a:off x="1005840" y="5486400"/>
-            <a:ext cx="10424160" cy="822960"/>
-          </a:xfrm>
-          <a:prstGeom prst="rect">
-            <a:avLst/>
-          </a:prstGeom>
-          <a:noFill/>
-        </p:spPr>
-        <p:txBody>
-          <a:bodyPr wrap="square">
-            <a:spAutoFit/>
-          </a:bodyPr>
-          <a:lstStyle/>
-          <a:p>
-            <a:pPr algn="l"/>
-            <a:r>
-              <a:rPr sz="1200" b="0">
-                <a:solidFill>
-                  <a:srgbClr val="2A2A2A"/>
-                </a:solidFill>
-                <a:latin typeface="Calibri"/>
-              </a:rPr>
-              <a:t>• Nombre completo  •  Link de tu repositorio  •  Link público de tu sitio</a:t>
-            </a:r>
-          </a:p>
-        </p:txBody>
-      </p:sp>
-      <p:sp>
-        <p:nvSpPr>
-          <p:cNvPr id="14" name="TextBox 13"/>
           <p:cNvSpPr txBox="1"/>
           <p:nvPr/>
         </p:nvSpPr>
@@ -4095,14 +4060,14 @@
                 </a:solidFill>
                 <a:latin typeface="Calibri"/>
               </a:rPr>
-              <a:t>📦 Repo: github.com/KrizRoMe/evaluacion-administracion-web   •   🌐 Web: krizrome.github.io/evaluacion-administracion-web   •   📋 Issues: github.com/KrizRoMe/evaluacion-administracion-web/issues</a:t>
-            </a:r>
-          </a:p>
-        </p:txBody>
-      </p:sp>
-      <p:sp>
-        <p:nvSpPr>
-          <p:cNvPr id="15" name="TextBox 14"/>
+              <a:t>📦 Repo del docente: github.com/KrizRoMe/evaluacion-administracion-web   •   🌐 Sitio público: krizrome.github.io/evaluacion-administracion-web   •   📋 Issues: github.com/KrizRoMe/evaluacion-administracion-web/issues</a:t>
+            </a:r>
+          </a:p>
+        </p:txBody>
+      </p:sp>
+      <p:sp>
+        <p:nvSpPr>
+          <p:cNvPr id="14" name="TextBox 13"/>
           <p:cNvSpPr txBox="1"/>
           <p:nvPr/>
         </p:nvSpPr>
@@ -4304,7 +4269,7 @@
                 </a:solidFill>
                 <a:latin typeface="Calibri"/>
               </a:rPr>
-              <a:t>Antes de publicar tu link de evaluación, verifica TODO</a:t>
+              <a:t>4 Issues en el repo del docente: 3 hallazgos + 1 link-evaluación</a:t>
             </a:r>
           </a:p>
         </p:txBody>
@@ -4368,7 +4333,7 @@
           <a:p>
             <a:pPr algn="l"/>
             <a:r>
-              <a:rPr sz="1400" b="0">
+              <a:rPr sz="1300" b="0">
                 <a:solidFill>
                   <a:srgbClr val="2A2A2A"/>
                 </a:solidFill>
@@ -4380,7 +4345,7 @@
           <a:p>
             <a:pPr algn="l"/>
             <a:r>
-              <a:rPr sz="1400" b="0">
+              <a:rPr sz="1300" b="0">
                 <a:solidFill>
                   <a:srgbClr val="2A2A2A"/>
                 </a:solidFill>
@@ -4392,61 +4357,85 @@
           <a:p>
             <a:pPr algn="l"/>
             <a:r>
-              <a:rPr sz="1400" b="0">
+              <a:rPr sz="1300" b="0">
                 <a:solidFill>
                   <a:srgbClr val="2A2A2A"/>
                 </a:solidFill>
                 <a:latin typeface="Calibri"/>
               </a:rPr>
-              <a:t>☐ EXACTAMENTE 4 Issues creadas</a:t>
-            </a:r>
-          </a:p>
-          <a:p>
-            <a:pPr algn="l"/>
-            <a:r>
-              <a:rPr sz="1400" b="0">
+              <a:t>☐ README completo</a:t>
+            </a:r>
+          </a:p>
+          <a:p>
+            <a:pPr algn="l"/>
+            <a:r>
+              <a:rPr sz="1300" b="0">
                 <a:solidFill>
                   <a:srgbClr val="2A2A2A"/>
                 </a:solidFill>
                 <a:latin typeface="Calibri"/>
               </a:rPr>
-              <a:t>☐ Cada Issue usa un template .yml</a:t>
-            </a:r>
-          </a:p>
-          <a:p>
-            <a:pPr algn="l"/>
-            <a:r>
-              <a:rPr sz="1400" b="0">
+              <a:t>☐ URLs y datos del estudiante</a:t>
+            </a:r>
+          </a:p>
+          <a:p>
+            <a:pPr algn="l"/>
+            <a:r>
+              <a:rPr sz="1300" b="0">
                 <a:solidFill>
                   <a:srgbClr val="2A2A2A"/>
                 </a:solidFill>
                 <a:latin typeface="Calibri"/>
               </a:rPr>
-              <a:t>☐ Cada Issue completa todas las secciones</a:t>
-            </a:r>
-          </a:p>
-          <a:p>
-            <a:pPr algn="l"/>
-            <a:r>
-              <a:rPr sz="1400" b="0">
+              <a:t/>
+            </a:r>
+          </a:p>
+          <a:p>
+            <a:pPr algn="l"/>
+            <a:r>
+              <a:rPr sz="1300" b="1">
                 <a:solidFill>
                   <a:srgbClr val="2A2A2A"/>
                 </a:solidFill>
                 <a:latin typeface="Calibri"/>
               </a:rPr>
-              <a:t>☐ README completo</a:t>
-            </a:r>
-          </a:p>
-          <a:p>
-            <a:pPr algn="l"/>
-            <a:r>
-              <a:rPr sz="1400" b="0">
+              <a:t>📋 3 ISSUES EN REPO DEL DOCENTE:</a:t>
+            </a:r>
+          </a:p>
+          <a:p>
+            <a:pPr algn="l"/>
+            <a:r>
+              <a:rPr sz="1300" b="0">
                 <a:solidFill>
                   <a:srgbClr val="2A2A2A"/>
                 </a:solidFill>
                 <a:latin typeface="Calibri"/>
               </a:rPr>
-              <a:t>☐ URLs y datos del estudiante</a:t>
+              <a:t>☐ Issue 1: rendimiento.yml</a:t>
+            </a:r>
+          </a:p>
+          <a:p>
+            <a:pPr algn="l"/>
+            <a:r>
+              <a:rPr sz="1300" b="0">
+                <a:solidFill>
+                  <a:srgbClr val="2A2A2A"/>
+                </a:solidFill>
+                <a:latin typeface="Calibri"/>
+              </a:rPr>
+              <a:t>☐ Issue 2: accesibilidad.yml</a:t>
+            </a:r>
+          </a:p>
+          <a:p>
+            <a:pPr algn="l"/>
+            <a:r>
+              <a:rPr sz="1300" b="0">
+                <a:solidFill>
+                  <a:srgbClr val="2A2A2A"/>
+                </a:solidFill>
+                <a:latin typeface="Calibri"/>
+              </a:rPr>
+              <a:t>☐ Issue 3: mantenimiento.yml</a:t>
             </a:r>
           </a:p>
         </p:txBody>
@@ -4481,7 +4470,7 @@
                 </a:solidFill>
                 <a:latin typeface="Calibri"/>
               </a:rPr>
-              <a:t>🔗 En repo del DOCENTE:</a:t>
+              <a:t>🔗 4ª ISSUE en repo del DOCENTE:</a:t>
             </a:r>
           </a:p>
         </p:txBody>
@@ -4510,7 +4499,7 @@
           <a:p>
             <a:pPr algn="l"/>
             <a:r>
-              <a:rPr sz="1400" b="0">
+              <a:rPr sz="1300" b="0">
                 <a:solidFill>
                   <a:srgbClr val="2A2A2A"/>
                 </a:solidFill>
@@ -4522,7 +4511,7 @@
           <a:p>
             <a:pPr algn="l"/>
             <a:r>
-              <a:rPr sz="1400" b="0">
+              <a:rPr sz="1300" b="0">
                 <a:solidFill>
                   <a:srgbClr val="2A2A2A"/>
                 </a:solidFill>
@@ -4534,7 +4523,7 @@
           <a:p>
             <a:pPr algn="l"/>
             <a:r>
-              <a:rPr sz="1400" b="0">
+              <a:rPr sz="1300" b="0">
                 <a:solidFill>
                   <a:srgbClr val="2A2A2A"/>
                 </a:solidFill>
@@ -4546,7 +4535,7 @@
           <a:p>
             <a:pPr algn="l"/>
             <a:r>
-              <a:rPr sz="1400" b="0">
+              <a:rPr sz="1300" b="0">
                 <a:solidFill>
                   <a:srgbClr val="2A2A2A"/>
                 </a:solidFill>
@@ -4558,7 +4547,7 @@
           <a:p>
             <a:pPr algn="l"/>
             <a:r>
-              <a:rPr sz="1400" b="0">
+              <a:rPr sz="1300" b="0">
                 <a:solidFill>
                   <a:srgbClr val="2A2A2A"/>
                 </a:solidFill>
@@ -4570,7 +4559,7 @@
           <a:p>
             <a:pPr algn="l"/>
             <a:r>
-              <a:rPr sz="1400" b="0">
+              <a:rPr sz="1300" b="0">
                 <a:solidFill>
                   <a:srgbClr val="2A2A2A"/>
                 </a:solidFill>
@@ -4582,13 +4571,49 @@
           <a:p>
             <a:pPr algn="l"/>
             <a:r>
-              <a:rPr sz="1400" b="0">
+              <a:rPr sz="1300" b="0">
                 <a:solidFill>
                   <a:srgbClr val="2A2A2A"/>
                 </a:solidFill>
                 <a:latin typeface="Calibri"/>
               </a:rPr>
-              <a:t>☐ Solo una Issue, no más</a:t>
+              <a:t/>
+            </a:r>
+          </a:p>
+          <a:p>
+            <a:pPr algn="l"/>
+            <a:r>
+              <a:rPr sz="1300" b="1">
+                <a:solidFill>
+                  <a:srgbClr val="2A2A2A"/>
+                </a:solidFill>
+                <a:latin typeface="Calibri"/>
+              </a:rPr>
+              <a:t>📊 PUNTAJE TOTAL: 20 pts</a:t>
+            </a:r>
+          </a:p>
+          <a:p>
+            <a:pPr algn="l"/>
+            <a:r>
+              <a:rPr sz="1300" b="0">
+                <a:solidFill>
+                  <a:srgbClr val="2A2A2A"/>
+                </a:solidFill>
+                <a:latin typeface="Calibri"/>
+              </a:rPr>
+              <a:t>• 3 Issues hallazgos × 5 pts = 15</a:t>
+            </a:r>
+          </a:p>
+          <a:p>
+            <a:pPr algn="l"/>
+            <a:r>
+              <a:rPr sz="1300" b="0">
+                <a:solidFill>
+                  <a:srgbClr val="2A2A2A"/>
+                </a:solidFill>
+                <a:latin typeface="Calibri"/>
+              </a:rPr>
+              <a:t>• 1 Issue link-evaluación × 5 pts = 5</a:t>
             </a:r>
           </a:p>
         </p:txBody>
@@ -4608,7 +4633,7 @@
             <a:avLst/>
           </a:prstGeom>
           <a:solidFill>
-            <a:srgbClr val="EA580C"/>
+            <a:srgbClr val="10B981"/>
           </a:solidFill>
           <a:ln>
             <a:noFill/>
@@ -4645,7 +4670,7 @@
         <p:spPr>
           <a:xfrm>
             <a:off x="822960" y="4983480"/>
-            <a:ext cx="10607040" cy="365760"/>
+            <a:ext cx="10607040" cy="1371600"/>
           </a:xfrm>
           <a:prstGeom prst="rect">
             <a:avLst/>
@@ -4660,13 +4685,49 @@
           <a:p>
             <a:pPr algn="ctr"/>
             <a:r>
-              <a:rPr sz="1400" b="1">
+              <a:rPr sz="1600" b="1">
                 <a:solidFill>
                   <a:srgbClr val="FFFFFF"/>
                 </a:solidFill>
                 <a:latin typeface="Calibri"/>
               </a:rPr>
-              <a:t>🔗 Publicar link de evaluación aquí:</a:t>
+              <a:t>📊 PUNTAJE TOTAL: 20 puntos</a:t>
+            </a:r>
+          </a:p>
+          <a:p>
+            <a:pPr algn="ctr"/>
+            <a:r>
+              <a:rPr sz="1600" b="0">
+                <a:solidFill>
+                  <a:srgbClr val="FFFFFF"/>
+                </a:solidFill>
+                <a:latin typeface="Calibri"/>
+              </a:rPr>
+              <a:t>• 3 Issues de hallazgos × 5 pts = 15 pts</a:t>
+            </a:r>
+          </a:p>
+          <a:p>
+            <a:pPr algn="ctr"/>
+            <a:r>
+              <a:rPr sz="1600" b="0">
+                <a:solidFill>
+                  <a:srgbClr val="FFFFFF"/>
+                </a:solidFill>
+                <a:latin typeface="Calibri"/>
+              </a:rPr>
+              <a:t>• 1 Issue de link-evaluación × 5 pts = 5 pts</a:t>
+            </a:r>
+          </a:p>
+          <a:p>
+            <a:pPr algn="ctr"/>
+            <a:r>
+              <a:rPr sz="1600" b="0">
+                <a:solidFill>
+                  <a:srgbClr val="FFFFFF"/>
+                </a:solidFill>
+                <a:latin typeface="Calibri"/>
+              </a:rPr>
+              <a:t>Aprobado: ≥14 pts</a:t>
             </a:r>
           </a:p>
         </p:txBody>
@@ -4674,76 +4735,6 @@
       <p:sp>
         <p:nvSpPr>
           <p:cNvPr id="12" name="TextBox 11"/>
-          <p:cNvSpPr txBox="1"/>
-          <p:nvPr/>
-        </p:nvSpPr>
-        <p:spPr>
-          <a:xfrm>
-            <a:off x="822960" y="5394960"/>
-            <a:ext cx="10607040" cy="548640"/>
-          </a:xfrm>
-          <a:prstGeom prst="rect">
-            <a:avLst/>
-          </a:prstGeom>
-          <a:noFill/>
-        </p:spPr>
-        <p:txBody>
-          <a:bodyPr wrap="square">
-            <a:spAutoFit/>
-          </a:bodyPr>
-          <a:lstStyle/>
-          <a:p>
-            <a:pPr algn="ctr"/>
-            <a:r>
-              <a:rPr sz="1200" b="1">
-                <a:solidFill>
-                  <a:srgbClr val="FFFFFF"/>
-                </a:solidFill>
-                <a:latin typeface="Consolas"/>
-              </a:rPr>
-              <a:t>https://github.com/KrizRoMe/evaluacion-administracion-web/issues/new?template=link-evaluacion.yml</a:t>
-            </a:r>
-          </a:p>
-        </p:txBody>
-      </p:sp>
-      <p:sp>
-        <p:nvSpPr>
-          <p:cNvPr id="13" name="TextBox 12"/>
-          <p:cNvSpPr txBox="1"/>
-          <p:nvPr/>
-        </p:nvSpPr>
-        <p:spPr>
-          <a:xfrm>
-            <a:off x="822960" y="5989320"/>
-            <a:ext cx="10607040" cy="274320"/>
-          </a:xfrm>
-          <a:prstGeom prst="rect">
-            <a:avLst/>
-          </a:prstGeom>
-          <a:noFill/>
-        </p:spPr>
-        <p:txBody>
-          <a:bodyPr wrap="square">
-            <a:spAutoFit/>
-          </a:bodyPr>
-          <a:lstStyle/>
-          <a:p>
-            <a:pPr algn="ctr"/>
-            <a:r>
-              <a:rPr sz="1100" b="0">
-                <a:solidFill>
-                  <a:srgbClr val="FED3B6"/>
-                </a:solidFill>
-                <a:latin typeface="Calibri"/>
-              </a:rPr>
-              <a:t>📌  Las 4 Issues van en TU repo.  El link va AQUÍ (solo una Issue).</a:t>
-            </a:r>
-          </a:p>
-        </p:txBody>
-      </p:sp>
-      <p:sp>
-        <p:nvSpPr>
-          <p:cNvPr id="14" name="TextBox 13"/>
           <p:cNvSpPr txBox="1"/>
           <p:nvPr/>
         </p:nvSpPr>
@@ -4771,14 +4762,14 @@
                 </a:solidFill>
                 <a:latin typeface="Calibri"/>
               </a:rPr>
-              <a:t>📦 Repo: github.com/KrizRoMe/evaluacion-administracion-web   •   🌐 Web: krizrome.github.io/evaluacion-administracion-web   •   📋 Issues: github.com/KrizRoMe/evaluacion-administracion-web/issues</a:t>
-            </a:r>
-          </a:p>
-        </p:txBody>
-      </p:sp>
-      <p:sp>
-        <p:nvSpPr>
-          <p:cNvPr id="15" name="TextBox 14"/>
+              <a:t>📦 Repo del docente: github.com/KrizRoMe/evaluacion-administracion-web   •   🌐 Sitio público: krizrome.github.io/evaluacion-administracion-web   •   📋 Issues: github.com/KrizRoMe/evaluacion-administracion-web/issues</a:t>
+            </a:r>
+          </a:p>
+        </p:txBody>
+      </p:sp>
+      <p:sp>
+        <p:nvSpPr>
+          <p:cNvPr id="13" name="TextBox 12"/>
           <p:cNvSpPr txBox="1"/>
           <p:nvPr/>
         </p:nvSpPr>
@@ -5321,7 +5312,7 @@
                 </a:solidFill>
                 <a:latin typeface="Calibri"/>
               </a:rPr>
-              <a:t>📦 Repo: github.com/KrizRoMe/evaluacion-administracion-web   •   🌐 Web: krizrome.github.io/evaluacion-administracion-web   •   📋 Issues: github.com/KrizRoMe/evaluacion-administracion-web/issues</a:t>
+              <a:t>📦 Repo del docente: github.com/KrizRoMe/evaluacion-administracion-web   •   🌐 Sitio público: krizrome.github.io/evaluacion-administracion-web   •   📋 Issues: github.com/KrizRoMe/evaluacion-administracion-web/issues</a:t>
             </a:r>
           </a:p>
         </p:txBody>
@@ -5530,7 +5521,7 @@
                 </a:solidFill>
                 <a:latin typeface="Calibri"/>
               </a:rPr>
-              <a:t>Sitio base + tu repo + link de evaluación</a:t>
+              <a:t>Sitio base + tu repo + 4 Issues en el repo del docente</a:t>
             </a:r>
           </a:p>
         </p:txBody>
@@ -5693,7 +5684,7 @@
         </p:nvSpPr>
         <p:spPr>
           <a:xfrm>
-            <a:off x="640080" y="2468880"/>
+            <a:off x="640080" y="2377440"/>
             <a:ext cx="10972800" cy="457200"/>
           </a:xfrm>
           <a:prstGeom prst="rect">
@@ -5715,7 +5706,7 @@
                 </a:solidFill>
                 <a:latin typeface="Calibri"/>
               </a:rPr>
-              <a:t>📦  Tu repositorio (donde subirás TU evaluación)</a:t>
+              <a:t>📦  Tu repositorio (donde subirás TU sitio desplegado)</a:t>
             </a:r>
           </a:p>
         </p:txBody>
@@ -5728,7 +5719,7 @@
         </p:nvSpPr>
         <p:spPr>
           <a:xfrm>
-            <a:off x="640080" y="2880360"/>
+            <a:off x="640080" y="2788920"/>
             <a:ext cx="10972800" cy="822960"/>
           </a:xfrm>
           <a:prstGeom prst="roundRect">
@@ -5773,7 +5764,7 @@
         </p:nvSpPr>
         <p:spPr>
           <a:xfrm>
-            <a:off x="822959" y="2971800"/>
+            <a:off x="822959" y="2880360"/>
             <a:ext cx="10607040" cy="365760"/>
           </a:xfrm>
           <a:prstGeom prst="rect">
@@ -5808,7 +5799,7 @@
         </p:nvSpPr>
         <p:spPr>
           <a:xfrm>
-            <a:off x="822959" y="3383279"/>
+            <a:off x="822959" y="3291839"/>
             <a:ext cx="10607040" cy="274320"/>
           </a:xfrm>
           <a:prstGeom prst="rect">
@@ -5843,7 +5834,7 @@
         </p:nvSpPr>
         <p:spPr>
           <a:xfrm>
-            <a:off x="640080" y="3749039"/>
+            <a:off x="640080" y="3566160"/>
             <a:ext cx="10972800" cy="457200"/>
           </a:xfrm>
           <a:prstGeom prst="rect">
@@ -5878,7 +5869,7 @@
         </p:nvSpPr>
         <p:spPr>
           <a:xfrm>
-            <a:off x="640080" y="4160520"/>
+            <a:off x="640080" y="3977639"/>
             <a:ext cx="10972800" cy="822960"/>
           </a:xfrm>
           <a:prstGeom prst="roundRect">
@@ -5923,7 +5914,7 @@
         </p:nvSpPr>
         <p:spPr>
           <a:xfrm>
-            <a:off x="822959" y="4251959"/>
+            <a:off x="822959" y="4069079"/>
             <a:ext cx="10607040" cy="365760"/>
           </a:xfrm>
           <a:prstGeom prst="rect">
@@ -5958,7 +5949,7 @@
         </p:nvSpPr>
         <p:spPr>
           <a:xfrm>
-            <a:off x="822959" y="4663440"/>
+            <a:off x="822959" y="4480559"/>
             <a:ext cx="10607040" cy="274320"/>
           </a:xfrm>
           <a:prstGeom prst="rect">
@@ -5993,7 +5984,7 @@
         </p:nvSpPr>
         <p:spPr>
           <a:xfrm>
-            <a:off x="640080" y="5029200"/>
+            <a:off x="640080" y="4754880"/>
             <a:ext cx="10972800" cy="457200"/>
           </a:xfrm>
           <a:prstGeom prst="rect">
@@ -6015,7 +6006,7 @@
                 </a:solidFill>
                 <a:latin typeface="Calibri"/>
               </a:rPr>
-              <a:t>🔗  Link de evaluación (publicar tu repo + sitio público)</a:t>
+              <a:t>📋  Repo del DOCENTE (donde crearás las 4 Issues)</a:t>
             </a:r>
           </a:p>
         </p:txBody>
@@ -6028,7 +6019,7 @@
         </p:nvSpPr>
         <p:spPr>
           <a:xfrm>
-            <a:off x="640080" y="5440680"/>
+            <a:off x="640080" y="5166360"/>
             <a:ext cx="10972800" cy="822960"/>
           </a:xfrm>
           <a:prstGeom prst="roundRect">
@@ -6073,7 +6064,7 @@
         </p:nvSpPr>
         <p:spPr>
           <a:xfrm>
-            <a:off x="822959" y="5532120"/>
+            <a:off x="822959" y="5257800"/>
             <a:ext cx="10607040" cy="365760"/>
           </a:xfrm>
           <a:prstGeom prst="rect">
@@ -6095,7 +6086,7 @@
                 </a:solidFill>
                 <a:latin typeface="Calibri"/>
               </a:rPr>
-              <a:t>Crear Issue con el template 'Link de evaluación' en el repo del docente:</a:t>
+              <a:t>Issues del docente</a:t>
             </a:r>
           </a:p>
         </p:txBody>
@@ -6108,7 +6099,7 @@
         </p:nvSpPr>
         <p:spPr>
           <a:xfrm>
-            <a:off x="822959" y="5943600"/>
+            <a:off x="822959" y="5669280"/>
             <a:ext cx="10607040" cy="274320"/>
           </a:xfrm>
           <a:prstGeom prst="rect">
@@ -6124,20 +6115,100 @@
           <a:p>
             <a:pPr algn="l"/>
             <a:r>
-              <a:rPr sz="1200" b="0">
+              <a:rPr sz="1400" b="0">
                 <a:solidFill>
                   <a:srgbClr val="2A2A2A"/>
                 </a:solidFill>
                 <a:latin typeface="Consolas"/>
               </a:rPr>
-              <a:t>https://github.com/KrizRoMe/evaluacion-administracion-web/issues/new?template=link-evaluacion.yml</a:t>
-            </a:r>
-          </a:p>
-        </p:txBody>
-      </p:sp>
-      <p:sp>
-        <p:nvSpPr>
-          <p:cNvPr id="22" name="TextBox 21"/>
+              <a:t>https://github.com/KrizRoMe/evaluacion-administracion-web/issues</a:t>
+            </a:r>
+          </a:p>
+        </p:txBody>
+      </p:sp>
+      <p:sp>
+        <p:nvSpPr>
+          <p:cNvPr id="22" name="Rounded Rectangle 21"/>
+          <p:cNvSpPr/>
+          <p:nvPr/>
+        </p:nvSpPr>
+        <p:spPr>
+          <a:xfrm>
+            <a:off x="640080" y="5943600"/>
+            <a:ext cx="10972800" cy="457200"/>
+          </a:xfrm>
+          <a:prstGeom prst="roundRect">
+            <a:avLst/>
+          </a:prstGeom>
+          <a:solidFill>
+            <a:srgbClr val="FEF3E6"/>
+          </a:solidFill>
+          <a:ln>
+            <a:solidFill>
+              <a:srgbClr val="EA580C"/>
+            </a:solidFill>
+          </a:ln>
+        </p:spPr>
+        <p:style>
+          <a:lnRef idx="1">
+            <a:schemeClr val="accent1"/>
+          </a:lnRef>
+          <a:fillRef idx="3">
+            <a:schemeClr val="accent1"/>
+          </a:fillRef>
+          <a:effectRef idx="2">
+            <a:schemeClr val="accent1"/>
+          </a:effectRef>
+          <a:fontRef idx="minor">
+            <a:schemeClr val="lt1"/>
+          </a:fontRef>
+        </p:style>
+        <p:txBody>
+          <a:bodyPr rtlCol="0" anchor="ctr"/>
+          <a:lstStyle/>
+          <a:p>
+            <a:pPr algn="ctr"/>
+          </a:p>
+        </p:txBody>
+      </p:sp>
+      <p:sp>
+        <p:nvSpPr>
+          <p:cNvPr id="23" name="TextBox 22"/>
+          <p:cNvSpPr txBox="1"/>
+          <p:nvPr/>
+        </p:nvSpPr>
+        <p:spPr>
+          <a:xfrm>
+            <a:off x="640080" y="5989320"/>
+            <a:ext cx="10972800" cy="365760"/>
+          </a:xfrm>
+          <a:prstGeom prst="rect">
+            <a:avLst/>
+          </a:prstGeom>
+          <a:noFill/>
+        </p:spPr>
+        <p:txBody>
+          <a:bodyPr wrap="square">
+            <a:spAutoFit/>
+          </a:bodyPr>
+          <a:lstStyle/>
+          <a:p>
+            <a:pPr algn="ctr"/>
+            <a:r>
+              <a:rPr sz="1400" b="1">
+                <a:solidFill>
+                  <a:srgbClr val="EA580C"/>
+                </a:solidFill>
+                <a:latin typeface="Calibri"/>
+              </a:rPr>
+              <a:t>⚠️  Las 4 Issues se crean en el repo del DOCENTE, NO en tu repo personal.</a:t>
+            </a:r>
+          </a:p>
+        </p:txBody>
+      </p:sp>
+      <p:sp>
+        <p:nvSpPr>
+          <p:cNvPr id="24" name="TextBox 23"/>
           <p:cNvSpPr txBox="1"/>
           <p:nvPr/>
         </p:nvSpPr>
@@ -6165,14 +6236,14 @@
                 </a:solidFill>
                 <a:latin typeface="Calibri"/>
               </a:rPr>
-              <a:t>📦 Repo: github.com/KrizRoMe/evaluacion-administracion-web   •   🌐 Web: krizrome.github.io/evaluacion-administracion-web   •   📋 Issues: github.com/KrizRoMe/evaluacion-administracion-web/issues</a:t>
-            </a:r>
-          </a:p>
-        </p:txBody>
-      </p:sp>
-      <p:sp>
-        <p:nvSpPr>
-          <p:cNvPr id="23" name="TextBox 22"/>
+              <a:t>📦 Repo del docente: github.com/KrizRoMe/evaluacion-administracion-web   •   🌐 Sitio público: krizrome.github.io/evaluacion-administracion-web   •   📋 Issues: github.com/KrizRoMe/evaluacion-administracion-web/issues</a:t>
+            </a:r>
+          </a:p>
+        </p:txBody>
+      </p:sp>
+      <p:sp>
+        <p:nvSpPr>
+          <p:cNvPr id="25" name="TextBox 24"/>
           <p:cNvSpPr txBox="1"/>
           <p:nvPr/>
         </p:nvSpPr>
@@ -6388,7 +6459,7 @@
         <p:spPr>
           <a:xfrm>
             <a:off x="723747" y="2286000"/>
-            <a:ext cx="1417320" cy="1554480"/>
+            <a:ext cx="1417320" cy="1737360"/>
           </a:xfrm>
           <a:prstGeom prst="roundRect">
             <a:avLst/>
@@ -6431,7 +6502,7 @@
         <p:spPr>
           <a:xfrm>
             <a:off x="723747" y="2606040"/>
-            <a:ext cx="1417320" cy="914400"/>
+            <a:ext cx="1417320" cy="1097280"/>
           </a:xfrm>
           <a:prstGeom prst="rect">
             <a:avLst/>
@@ -6446,7 +6517,7 @@
           <a:p>
             <a:pPr algn="ctr"/>
             <a:r>
-              <a:rPr sz="1300" b="1">
+              <a:rPr sz="1200" b="1">
                 <a:solidFill>
                   <a:srgbClr val="FFFFFF"/>
                 </a:solidFill>
@@ -6466,7 +6537,7 @@
         </p:nvSpPr>
         <p:spPr>
           <a:xfrm>
-            <a:off x="2150211" y="2926080"/>
+            <a:off x="2150211" y="3108960"/>
             <a:ext cx="118872" cy="274320"/>
           </a:xfrm>
           <a:prstGeom prst="rightArrow">
@@ -6510,7 +6581,7 @@
         <p:spPr>
           <a:xfrm>
             <a:off x="2278227" y="2286000"/>
-            <a:ext cx="1417320" cy="1554480"/>
+            <a:ext cx="1417320" cy="1737360"/>
           </a:xfrm>
           <a:prstGeom prst="roundRect">
             <a:avLst/>
@@ -6553,7 +6624,7 @@
         <p:spPr>
           <a:xfrm>
             <a:off x="2278227" y="2606040"/>
-            <a:ext cx="1417320" cy="914400"/>
+            <a:ext cx="1417320" cy="1097280"/>
           </a:xfrm>
           <a:prstGeom prst="rect">
             <a:avLst/>
@@ -6568,7 +6639,7 @@
           <a:p>
             <a:pPr algn="ctr"/>
             <a:r>
-              <a:rPr sz="1300" b="1">
+              <a:rPr sz="1200" b="1">
                 <a:solidFill>
                   <a:srgbClr val="FFFFFF"/>
                 </a:solidFill>
@@ -6588,7 +6659,7 @@
         </p:nvSpPr>
         <p:spPr>
           <a:xfrm>
-            <a:off x="3704691" y="2926080"/>
+            <a:off x="3704691" y="3108960"/>
             <a:ext cx="118872" cy="274320"/>
           </a:xfrm>
           <a:prstGeom prst="rightArrow">
@@ -6632,7 +6703,7 @@
         <p:spPr>
           <a:xfrm>
             <a:off x="3832707" y="2286000"/>
-            <a:ext cx="1417320" cy="1554480"/>
+            <a:ext cx="1417320" cy="1737360"/>
           </a:xfrm>
           <a:prstGeom prst="roundRect">
             <a:avLst/>
@@ -6675,7 +6746,7 @@
         <p:spPr>
           <a:xfrm>
             <a:off x="3832707" y="2606040"/>
-            <a:ext cx="1417320" cy="914400"/>
+            <a:ext cx="1417320" cy="1097280"/>
           </a:xfrm>
           <a:prstGeom prst="rect">
             <a:avLst/>
@@ -6690,7 +6761,7 @@
           <a:p>
             <a:pPr algn="ctr"/>
             <a:r>
-              <a:rPr sz="1300" b="1">
+              <a:rPr sz="1200" b="1">
                 <a:solidFill>
                   <a:srgbClr val="FFFFFF"/>
                 </a:solidFill>
@@ -6710,7 +6781,7 @@
         </p:nvSpPr>
         <p:spPr>
           <a:xfrm>
-            <a:off x="5259171" y="2926080"/>
+            <a:off x="5259171" y="3108960"/>
             <a:ext cx="118872" cy="274320"/>
           </a:xfrm>
           <a:prstGeom prst="rightArrow">
@@ -6754,7 +6825,7 @@
         <p:spPr>
           <a:xfrm>
             <a:off x="5387187" y="2286000"/>
-            <a:ext cx="1417320" cy="1554480"/>
+            <a:ext cx="1417320" cy="1737360"/>
           </a:xfrm>
           <a:prstGeom prst="roundRect">
             <a:avLst/>
@@ -6797,7 +6868,7 @@
         <p:spPr>
           <a:xfrm>
             <a:off x="5387187" y="2606040"/>
-            <a:ext cx="1417320" cy="914400"/>
+            <a:ext cx="1417320" cy="1097280"/>
           </a:xfrm>
           <a:prstGeom prst="rect">
             <a:avLst/>
@@ -6812,7 +6883,7 @@
           <a:p>
             <a:pPr algn="ctr"/>
             <a:r>
-              <a:rPr sz="1300" b="1">
+              <a:rPr sz="1200" b="1">
                 <a:solidFill>
                   <a:srgbClr val="FFFFFF"/>
                 </a:solidFill>
@@ -6832,7 +6903,7 @@
         </p:nvSpPr>
         <p:spPr>
           <a:xfrm>
-            <a:off x="6813651" y="2926080"/>
+            <a:off x="6813651" y="3108960"/>
             <a:ext cx="118872" cy="274320"/>
           </a:xfrm>
           <a:prstGeom prst="rightArrow">
@@ -6876,7 +6947,7 @@
         <p:spPr>
           <a:xfrm>
             <a:off x="6941667" y="2286000"/>
-            <a:ext cx="1417320" cy="1554480"/>
+            <a:ext cx="1417320" cy="1737360"/>
           </a:xfrm>
           <a:prstGeom prst="roundRect">
             <a:avLst/>
@@ -6919,7 +6990,7 @@
         <p:spPr>
           <a:xfrm>
             <a:off x="6941667" y="2606040"/>
-            <a:ext cx="1417320" cy="914400"/>
+            <a:ext cx="1417320" cy="1097280"/>
           </a:xfrm>
           <a:prstGeom prst="rect">
             <a:avLst/>
@@ -6934,14 +7005,15 @@
           <a:p>
             <a:pPr algn="ctr"/>
             <a:r>
-              <a:rPr sz="1300" b="1">
+              <a:rPr sz="1200" b="1">
                 <a:solidFill>
                   <a:srgbClr val="FFFFFF"/>
                 </a:solidFill>
                 <a:latin typeface="Calibri"/>
               </a:rPr>
-              <a:t>4 Issues
-en TU repo</a:t>
+              <a:t>3 Issues
+hallazgos
+(repo docente)</a:t>
             </a:r>
           </a:p>
         </p:txBody>
@@ -6954,7 +7026,7 @@
         </p:nvSpPr>
         <p:spPr>
           <a:xfrm>
-            <a:off x="8368131" y="2926080"/>
+            <a:off x="8368131" y="3108960"/>
             <a:ext cx="118872" cy="274320"/>
           </a:xfrm>
           <a:prstGeom prst="rightArrow">
@@ -6998,13 +7070,13 @@
         <p:spPr>
           <a:xfrm>
             <a:off x="8496147" y="2286000"/>
-            <a:ext cx="1417320" cy="1554480"/>
+            <a:ext cx="1417320" cy="1737360"/>
           </a:xfrm>
           <a:prstGeom prst="roundRect">
             <a:avLst/>
           </a:prstGeom>
           <a:solidFill>
-            <a:srgbClr val="1C7293"/>
+            <a:srgbClr val="EA580C"/>
           </a:solidFill>
           <a:ln>
             <a:noFill/>
@@ -7041,7 +7113,7 @@
         <p:spPr>
           <a:xfrm>
             <a:off x="8496147" y="2606040"/>
-            <a:ext cx="1417320" cy="914400"/>
+            <a:ext cx="1417320" cy="1097280"/>
           </a:xfrm>
           <a:prstGeom prst="rect">
             <a:avLst/>
@@ -7056,13 +7128,15 @@
           <a:p>
             <a:pPr algn="ctr"/>
             <a:r>
-              <a:rPr sz="1300" b="1">
+              <a:rPr sz="1200" b="1">
                 <a:solidFill>
                   <a:srgbClr val="FFFFFF"/>
                 </a:solidFill>
                 <a:latin typeface="Calibri"/>
               </a:rPr>
-              <a:t>README</a:t>
+              <a:t>Issue link
+evaluación
+(repo docente)</a:t>
             </a:r>
           </a:p>
         </p:txBody>
@@ -7075,7 +7149,7 @@
         </p:nvSpPr>
         <p:spPr>
           <a:xfrm>
-            <a:off x="9922611" y="2926080"/>
+            <a:off x="9922611" y="3108960"/>
             <a:ext cx="118872" cy="274320"/>
           </a:xfrm>
           <a:prstGeom prst="rightArrow">
@@ -7119,13 +7193,13 @@
         <p:spPr>
           <a:xfrm>
             <a:off x="10050627" y="2286000"/>
-            <a:ext cx="1417320" cy="1554480"/>
+            <a:ext cx="1417320" cy="1737360"/>
           </a:xfrm>
           <a:prstGeom prst="roundRect">
             <a:avLst/>
           </a:prstGeom>
           <a:solidFill>
-            <a:srgbClr val="EA580C"/>
+            <a:srgbClr val="065A82"/>
           </a:solidFill>
           <a:ln>
             <a:noFill/>
@@ -7162,7 +7236,7 @@
         <p:spPr>
           <a:xfrm>
             <a:off x="10050627" y="2606040"/>
-            <a:ext cx="1417320" cy="914400"/>
+            <a:ext cx="1417320" cy="1097280"/>
           </a:xfrm>
           <a:prstGeom prst="rect">
             <a:avLst/>
@@ -7177,14 +7251,14 @@
           <a:p>
             <a:pPr algn="ctr"/>
             <a:r>
-              <a:rPr sz="1300" b="1">
+              <a:rPr sz="1200" b="1">
                 <a:solidFill>
                   <a:srgbClr val="FFFFFF"/>
                 </a:solidFill>
                 <a:latin typeface="Calibri"/>
               </a:rPr>
-              <a:t>Link de
-evaluación AQUÍ</a:t>
+              <a:t>Entrega
+completa</a:t>
             </a:r>
           </a:p>
         </p:txBody>
@@ -7197,7 +7271,7 @@
         </p:nvSpPr>
         <p:spPr>
           <a:xfrm>
-            <a:off x="457200" y="4114800"/>
+            <a:off x="457200" y="4297680"/>
             <a:ext cx="10972800" cy="457200"/>
           </a:xfrm>
           <a:prstGeom prst="rect">
@@ -7213,7 +7287,7 @@
           <a:p>
             <a:pPr algn="l"/>
             <a:r>
-              <a:rPr sz="2000" b="1">
+              <a:rPr sz="1800" b="1">
                 <a:solidFill>
                   <a:srgbClr val="065A82"/>
                 </a:solidFill>
@@ -7232,8 +7306,8 @@
         </p:nvSpPr>
         <p:spPr>
           <a:xfrm>
-            <a:off x="457200" y="4572000"/>
-            <a:ext cx="10972800" cy="1188720"/>
+            <a:off x="457200" y="4754880"/>
+            <a:ext cx="10972800" cy="914400"/>
           </a:xfrm>
           <a:prstGeom prst="rect">
             <a:avLst/>
@@ -7266,7 +7340,7 @@
                 </a:solidFill>
                 <a:latin typeface="Calibri"/>
               </a:rPr>
-              <a:t>Issues (TU repo): 20 min   •   Documentar solución: 10 min   •   README: 15 min   •   Link de evaluación: 5 min</a:t>
+              <a:t>3 Issues hallazgos: 25 min   •   Documentar solución: 10 min   •   Issue link-evaluación: 5 min</a:t>
             </a:r>
           </a:p>
         </p:txBody>
@@ -7346,7 +7420,7 @@
                 </a:solidFill>
                 <a:latin typeface="Calibri"/>
               </a:rPr>
-              <a:t>⚠️  El sitio tiene 15 problemas. Tú solo necesitas identificar 4.</a:t>
+              <a:t>⚠️  El sitio tiene 15 problemas. Encontrarás 3 (uno de cada tipo).</a:t>
             </a:r>
           </a:p>
         </p:txBody>
@@ -7381,7 +7455,7 @@
                 </a:solidFill>
                 <a:latin typeface="Calibri"/>
               </a:rPr>
-              <a:t>📦 Repo: github.com/KrizRoMe/evaluacion-administracion-web   •   🌐 Web: krizrome.github.io/evaluacion-administracion-web   •   📋 Issues: github.com/KrizRoMe/evaluacion-administracion-web/issues</a:t>
+              <a:t>📦 Repo del docente: github.com/KrizRoMe/evaluacion-administracion-web   •   🌐 Sitio público: krizrome.github.io/evaluacion-administracion-web   •   📋 Issues: github.com/KrizRoMe/evaluacion-administracion-web/issues</a:t>
             </a:r>
           </a:p>
         </p:txBody>
@@ -8012,7 +8086,7 @@
                 </a:solidFill>
                 <a:latin typeface="Calibri"/>
               </a:rPr>
-              <a:t>📦 Repo: github.com/KrizRoMe/evaluacion-administracion-web   •   🌐 Web: krizrome.github.io/evaluacion-administracion-web   •   📋 Issues: github.com/KrizRoMe/evaluacion-administracion-web/issues</a:t>
+              <a:t>📦 Repo del docente: github.com/KrizRoMe/evaluacion-administracion-web   •   🌐 Sitio público: krizrome.github.io/evaluacion-administracion-web   •   📋 Issues: github.com/KrizRoMe/evaluacion-administracion-web/issues</a:t>
             </a:r>
           </a:p>
         </p:txBody>
@@ -8560,7 +8634,7 @@
                 </a:solidFill>
                 <a:latin typeface="Calibri"/>
               </a:rPr>
-              <a:t>📦 Repo: github.com/KrizRoMe/evaluacion-administracion-web   •   🌐 Web: krizrome.github.io/evaluacion-administracion-web   •   📋 Issues: github.com/KrizRoMe/evaluacion-administracion-web/issues</a:t>
+              <a:t>📦 Repo del docente: github.com/KrizRoMe/evaluacion-administracion-web   •   🌐 Sitio público: krizrome.github.io/evaluacion-administracion-web   •   📋 Issues: github.com/KrizRoMe/evaluacion-administracion-web/issues</a:t>
             </a:r>
           </a:p>
         </p:txBody>
@@ -8769,7 +8843,7 @@
                 </a:solidFill>
                 <a:latin typeface="Calibri"/>
               </a:rPr>
-              <a:t>⏱ 15 minutos  •  15 problemas, tú identificas 4</a:t>
+              <a:t>⏱ 15 minutos  •  Encuentra 1 problema de cada tipo</a:t>
             </a:r>
           </a:p>
         </p:txBody>
@@ -8782,7 +8856,7 @@
         </p:nvSpPr>
         <p:spPr>
           <a:xfrm>
-            <a:off x="640080" y="1280160"/>
+            <a:off x="640080" y="1188720"/>
             <a:ext cx="10972800" cy="365760"/>
           </a:xfrm>
           <a:prstGeom prst="rect">
@@ -8798,13 +8872,13 @@
           <a:p>
             <a:pPr algn="l"/>
             <a:r>
-              <a:rPr sz="2000" b="1">
+              <a:rPr sz="1800" b="1">
                 <a:solidFill>
                   <a:srgbClr val="065A82"/>
                 </a:solidFill>
                 <a:latin typeface="Calibri"/>
               </a:rPr>
-              <a:t>Herramientas a usar:</a:t>
+              <a:t>🛠 Herramientas a usar:</a:t>
             </a:r>
           </a:p>
         </p:txBody>
@@ -8817,270 +8891,709 @@
         </p:nvSpPr>
         <p:spPr>
           <a:xfrm>
-            <a:off x="822960" y="1737360"/>
-            <a:ext cx="5486400" cy="3200400"/>
-          </a:xfrm>
-          <a:prstGeom prst="rect">
-            <a:avLst/>
-          </a:prstGeom>
-          <a:noFill/>
-        </p:spPr>
-        <p:txBody>
-          <a:bodyPr wrap="square">
-            <a:spAutoFit/>
-          </a:bodyPr>
-          <a:lstStyle/>
-          <a:p>
-            <a:pPr algn="l"/>
-            <a:r>
-              <a:rPr sz="1400" b="1">
+            <a:off x="640080" y="1554480"/>
+            <a:ext cx="10972800" cy="731520"/>
+          </a:xfrm>
+          <a:prstGeom prst="rect">
+            <a:avLst/>
+          </a:prstGeom>
+          <a:noFill/>
+        </p:spPr>
+        <p:txBody>
+          <a:bodyPr wrap="square">
+            <a:spAutoFit/>
+          </a:bodyPr>
+          <a:lstStyle/>
+          <a:p>
+            <a:pPr algn="l"/>
+            <a:r>
+              <a:rPr sz="1400" b="0">
                 <a:solidFill>
                   <a:srgbClr val="2A2A2A"/>
                 </a:solidFill>
                 <a:latin typeface="Calibri"/>
               </a:rPr>
-              <a:t>🔍 Chrome DevTools (F12)</a:t>
-            </a:r>
-          </a:p>
-          <a:p>
-            <a:pPr algn="l"/>
-            <a:r>
-              <a:rPr sz="1400" b="0">
+              <a:t>Chrome DevTools (F12)  •  Lighthouse (rendimiento)  •  axe DevTools (accesibilidad)  •  package.json (mantenimiento)</a:t>
+            </a:r>
+          </a:p>
+        </p:txBody>
+      </p:sp>
+      <p:sp>
+        <p:nvSpPr>
+          <p:cNvPr id="8" name="Rounded Rectangle 7"/>
+          <p:cNvSpPr/>
+          <p:nvPr/>
+        </p:nvSpPr>
+        <p:spPr>
+          <a:xfrm>
+            <a:off x="426567" y="2286000"/>
+            <a:ext cx="3657600" cy="3108960"/>
+          </a:xfrm>
+          <a:prstGeom prst="roundRect">
+            <a:avLst/>
+          </a:prstGeom>
+          <a:solidFill>
+            <a:srgbClr val="F4F4F4"/>
+          </a:solidFill>
+          <a:ln w="38100">
+            <a:solidFill>
+              <a:srgbClr val="1C7293"/>
+            </a:solidFill>
+          </a:ln>
+        </p:spPr>
+        <p:style>
+          <a:lnRef idx="1">
+            <a:schemeClr val="accent1"/>
+          </a:lnRef>
+          <a:fillRef idx="3">
+            <a:schemeClr val="accent1"/>
+          </a:fillRef>
+          <a:effectRef idx="2">
+            <a:schemeClr val="accent1"/>
+          </a:effectRef>
+          <a:fontRef idx="minor">
+            <a:schemeClr val="lt1"/>
+          </a:fontRef>
+        </p:style>
+        <p:txBody>
+          <a:bodyPr rtlCol="0" anchor="ctr"/>
+          <a:lstStyle/>
+          <a:p>
+            <a:pPr algn="ctr"/>
+          </a:p>
+        </p:txBody>
+      </p:sp>
+      <p:sp>
+        <p:nvSpPr>
+          <p:cNvPr id="9" name="Rectangle 8"/>
+          <p:cNvSpPr/>
+          <p:nvPr/>
+        </p:nvSpPr>
+        <p:spPr>
+          <a:xfrm>
+            <a:off x="426567" y="2286000"/>
+            <a:ext cx="3657600" cy="548640"/>
+          </a:xfrm>
+          <a:prstGeom prst="rect">
+            <a:avLst/>
+          </a:prstGeom>
+          <a:solidFill>
+            <a:srgbClr val="1C7293"/>
+          </a:solidFill>
+          <a:ln>
+            <a:noFill/>
+          </a:ln>
+        </p:spPr>
+        <p:style>
+          <a:lnRef idx="1">
+            <a:schemeClr val="accent1"/>
+          </a:lnRef>
+          <a:fillRef idx="3">
+            <a:schemeClr val="accent1"/>
+          </a:fillRef>
+          <a:effectRef idx="2">
+            <a:schemeClr val="accent1"/>
+          </a:effectRef>
+          <a:fontRef idx="minor">
+            <a:schemeClr val="lt1"/>
+          </a:fontRef>
+        </p:style>
+        <p:txBody>
+          <a:bodyPr rtlCol="0" anchor="ctr"/>
+          <a:lstStyle/>
+          <a:p>
+            <a:pPr algn="ctr"/>
+          </a:p>
+        </p:txBody>
+      </p:sp>
+      <p:sp>
+        <p:nvSpPr>
+          <p:cNvPr id="10" name="TextBox 9"/>
+          <p:cNvSpPr txBox="1"/>
+          <p:nvPr/>
+        </p:nvSpPr>
+        <p:spPr>
+          <a:xfrm>
+            <a:off x="426567" y="2331720"/>
+            <a:ext cx="3657600" cy="457200"/>
+          </a:xfrm>
+          <a:prstGeom prst="rect">
+            <a:avLst/>
+          </a:prstGeom>
+          <a:noFill/>
+        </p:spPr>
+        <p:txBody>
+          <a:bodyPr wrap="square">
+            <a:spAutoFit/>
+          </a:bodyPr>
+          <a:lstStyle/>
+          <a:p>
+            <a:pPr algn="ctr"/>
+            <a:r>
+              <a:rPr sz="1800" b="1">
+                <a:solidFill>
+                  <a:srgbClr val="FFFFFF"/>
+                </a:solidFill>
+                <a:latin typeface="Calibri"/>
+              </a:rPr>
+              <a:t>📊 RENDIMIENTO</a:t>
+            </a:r>
+          </a:p>
+        </p:txBody>
+      </p:sp>
+      <p:sp>
+        <p:nvSpPr>
+          <p:cNvPr id="11" name="TextBox 10"/>
+          <p:cNvSpPr txBox="1"/>
+          <p:nvPr/>
+        </p:nvSpPr>
+        <p:spPr>
+          <a:xfrm>
+            <a:off x="563727" y="2926080"/>
+            <a:ext cx="3383280" cy="1463040"/>
+          </a:xfrm>
+          <a:prstGeom prst="rect">
+            <a:avLst/>
+          </a:prstGeom>
+          <a:noFill/>
+        </p:spPr>
+        <p:txBody>
+          <a:bodyPr wrap="square">
+            <a:spAutoFit/>
+          </a:bodyPr>
+          <a:lstStyle/>
+          <a:p>
+            <a:pPr algn="l"/>
+            <a:r>
+              <a:rPr sz="1200" b="1">
                 <a:solidFill>
                   <a:srgbClr val="2A2A2A"/>
                 </a:solidFill>
                 <a:latin typeface="Calibri"/>
               </a:rPr>
-              <a:t>• Pestaña Elements → revisa el HTML</a:t>
-            </a:r>
-          </a:p>
-          <a:p>
-            <a:pPr algn="l"/>
-            <a:r>
-              <a:rPr sz="1400" b="0">
+              <a:t>Chrome DevTools + Lighthouse</a:t>
+            </a:r>
+          </a:p>
+          <a:p>
+            <a:pPr algn="l"/>
+            <a:r>
+              <a:rPr sz="1200" b="0">
                 <a:solidFill>
                   <a:srgbClr val="2A2A2A"/>
                 </a:solidFill>
                 <a:latin typeface="Calibri"/>
               </a:rPr>
-              <a:t>• Pestaña Network → observa los recursos</a:t>
-            </a:r>
-          </a:p>
-          <a:p>
-            <a:pPr algn="l"/>
-            <a:r>
-              <a:rPr sz="1400" b="0">
+              <a:t/>
+            </a:r>
+          </a:p>
+          <a:p>
+            <a:pPr algn="l"/>
+            <a:r>
+              <a:rPr sz="1200" b="0">
                 <a:solidFill>
                   <a:srgbClr val="2A2A2A"/>
                 </a:solidFill>
                 <a:latin typeface="Calibri"/>
               </a:rPr>
+              <a:t>Ejemplos:
+• Imagen sin width/height (CLS)
+• Imágenes sin loading='lazy'
+• &lt;script&gt; sin defer
+• SVGs innecesariamente pesados
+• Recursos bloqueantes</a:t>
+            </a:r>
+          </a:p>
+        </p:txBody>
+      </p:sp>
+      <p:sp>
+        <p:nvSpPr>
+          <p:cNvPr id="12" name="TextBox 11"/>
+          <p:cNvSpPr txBox="1"/>
+          <p:nvPr/>
+        </p:nvSpPr>
+        <p:spPr>
+          <a:xfrm>
+            <a:off x="426567" y="5166360"/>
+            <a:ext cx="3657600" cy="274320"/>
+          </a:xfrm>
+          <a:prstGeom prst="rect">
+            <a:avLst/>
+          </a:prstGeom>
+          <a:noFill/>
+        </p:spPr>
+        <p:txBody>
+          <a:bodyPr wrap="square">
+            <a:spAutoFit/>
+          </a:bodyPr>
+          <a:lstStyle/>
+          <a:p>
+            <a:pPr algn="ctr"/>
+            <a:r>
+              <a:rPr sz="1100" b="1">
+                <a:solidFill>
+                  <a:srgbClr val="1C7293"/>
+                </a:solidFill>
+                <a:latin typeface="Calibri"/>
+              </a:rPr>
+              <a:t>📝 Template: rendimiento.yml</a:t>
+            </a:r>
+          </a:p>
+        </p:txBody>
+      </p:sp>
+      <p:sp>
+        <p:nvSpPr>
+          <p:cNvPr id="13" name="Rounded Rectangle 12"/>
+          <p:cNvSpPr/>
+          <p:nvPr/>
+        </p:nvSpPr>
+        <p:spPr>
+          <a:xfrm>
+            <a:off x="4267047" y="2286000"/>
+            <a:ext cx="3657600" cy="3108960"/>
+          </a:xfrm>
+          <a:prstGeom prst="roundRect">
+            <a:avLst/>
+          </a:prstGeom>
+          <a:solidFill>
+            <a:srgbClr val="F4F4F4"/>
+          </a:solidFill>
+          <a:ln w="38100">
+            <a:solidFill>
+              <a:srgbClr val="10B981"/>
+            </a:solidFill>
+          </a:ln>
+        </p:spPr>
+        <p:style>
+          <a:lnRef idx="1">
+            <a:schemeClr val="accent1"/>
+          </a:lnRef>
+          <a:fillRef idx="3">
+            <a:schemeClr val="accent1"/>
+          </a:fillRef>
+          <a:effectRef idx="2">
+            <a:schemeClr val="accent1"/>
+          </a:effectRef>
+          <a:fontRef idx="minor">
+            <a:schemeClr val="lt1"/>
+          </a:fontRef>
+        </p:style>
+        <p:txBody>
+          <a:bodyPr rtlCol="0" anchor="ctr"/>
+          <a:lstStyle/>
+          <a:p>
+            <a:pPr algn="ctr"/>
+          </a:p>
+        </p:txBody>
+      </p:sp>
+      <p:sp>
+        <p:nvSpPr>
+          <p:cNvPr id="14" name="Rectangle 13"/>
+          <p:cNvSpPr/>
+          <p:nvPr/>
+        </p:nvSpPr>
+        <p:spPr>
+          <a:xfrm>
+            <a:off x="4267047" y="2286000"/>
+            <a:ext cx="3657600" cy="548640"/>
+          </a:xfrm>
+          <a:prstGeom prst="rect">
+            <a:avLst/>
+          </a:prstGeom>
+          <a:solidFill>
+            <a:srgbClr val="10B981"/>
+          </a:solidFill>
+          <a:ln>
+            <a:noFill/>
+          </a:ln>
+        </p:spPr>
+        <p:style>
+          <a:lnRef idx="1">
+            <a:schemeClr val="accent1"/>
+          </a:lnRef>
+          <a:fillRef idx="3">
+            <a:schemeClr val="accent1"/>
+          </a:fillRef>
+          <a:effectRef idx="2">
+            <a:schemeClr val="accent1"/>
+          </a:effectRef>
+          <a:fontRef idx="minor">
+            <a:schemeClr val="lt1"/>
+          </a:fontRef>
+        </p:style>
+        <p:txBody>
+          <a:bodyPr rtlCol="0" anchor="ctr"/>
+          <a:lstStyle/>
+          <a:p>
+            <a:pPr algn="ctr"/>
+          </a:p>
+        </p:txBody>
+      </p:sp>
+      <p:sp>
+        <p:nvSpPr>
+          <p:cNvPr id="15" name="TextBox 14"/>
+          <p:cNvSpPr txBox="1"/>
+          <p:nvPr/>
+        </p:nvSpPr>
+        <p:spPr>
+          <a:xfrm>
+            <a:off x="4267047" y="2331720"/>
+            <a:ext cx="3657600" cy="457200"/>
+          </a:xfrm>
+          <a:prstGeom prst="rect">
+            <a:avLst/>
+          </a:prstGeom>
+          <a:noFill/>
+        </p:spPr>
+        <p:txBody>
+          <a:bodyPr wrap="square">
+            <a:spAutoFit/>
+          </a:bodyPr>
+          <a:lstStyle/>
+          <a:p>
+            <a:pPr algn="ctr"/>
+            <a:r>
+              <a:rPr sz="1800" b="1">
+                <a:solidFill>
+                  <a:srgbClr val="FFFFFF"/>
+                </a:solidFill>
+                <a:latin typeface="Calibri"/>
+              </a:rPr>
+              <a:t>♿ ACCESIBILIDAD</a:t>
+            </a:r>
+          </a:p>
+        </p:txBody>
+      </p:sp>
+      <p:sp>
+        <p:nvSpPr>
+          <p:cNvPr id="16" name="TextBox 15"/>
+          <p:cNvSpPr txBox="1"/>
+          <p:nvPr/>
+        </p:nvSpPr>
+        <p:spPr>
+          <a:xfrm>
+            <a:off x="4404207" y="2926080"/>
+            <a:ext cx="3383280" cy="1463040"/>
+          </a:xfrm>
+          <a:prstGeom prst="rect">
+            <a:avLst/>
+          </a:prstGeom>
+          <a:noFill/>
+        </p:spPr>
+        <p:txBody>
+          <a:bodyPr wrap="square">
+            <a:spAutoFit/>
+          </a:bodyPr>
+          <a:lstStyle/>
+          <a:p>
+            <a:pPr algn="l"/>
+            <a:r>
+              <a:rPr sz="1200" b="1">
+                <a:solidFill>
+                  <a:srgbClr val="2A2A2A"/>
+                </a:solidFill>
+                <a:latin typeface="Calibri"/>
+              </a:rPr>
+              <a:t>axe DevTools</a:t>
+            </a:r>
+          </a:p>
+          <a:p>
+            <a:pPr algn="l"/>
+            <a:r>
+              <a:rPr sz="1200" b="0">
+                <a:solidFill>
+                  <a:srgbClr val="2A2A2A"/>
+                </a:solidFill>
+                <a:latin typeface="Calibri"/>
+              </a:rPr>
               <a:t/>
             </a:r>
           </a:p>
           <a:p>
             <a:pPr algn="l"/>
             <a:r>
-              <a:rPr sz="1400" b="1">
+              <a:rPr sz="1200" b="0">
                 <a:solidFill>
                   <a:srgbClr val="2A2A2A"/>
                 </a:solidFill>
                 <a:latin typeface="Calibri"/>
               </a:rPr>
-              <a:t>💡 Lighthouse (DevTools)</a:t>
-            </a:r>
-          </a:p>
-          <a:p>
-            <a:pPr algn="l"/>
-            <a:r>
-              <a:rPr sz="1400" b="0">
+              <a:t>Ejemplos:
+• Imágenes sin alt
+• Botones sin aria-label
+• Contraste insuficiente
+• Inputs sin &lt;label&gt;
+• Falta de landmarks ARIA</a:t>
+            </a:r>
+          </a:p>
+        </p:txBody>
+      </p:sp>
+      <p:sp>
+        <p:nvSpPr>
+          <p:cNvPr id="17" name="TextBox 16"/>
+          <p:cNvSpPr txBox="1"/>
+          <p:nvPr/>
+        </p:nvSpPr>
+        <p:spPr>
+          <a:xfrm>
+            <a:off x="4267047" y="5166360"/>
+            <a:ext cx="3657600" cy="274320"/>
+          </a:xfrm>
+          <a:prstGeom prst="rect">
+            <a:avLst/>
+          </a:prstGeom>
+          <a:noFill/>
+        </p:spPr>
+        <p:txBody>
+          <a:bodyPr wrap="square">
+            <a:spAutoFit/>
+          </a:bodyPr>
+          <a:lstStyle/>
+          <a:p>
+            <a:pPr algn="ctr"/>
+            <a:r>
+              <a:rPr sz="1100" b="1">
+                <a:solidFill>
+                  <a:srgbClr val="10B981"/>
+                </a:solidFill>
+                <a:latin typeface="Calibri"/>
+              </a:rPr>
+              <a:t>📝 Template: accesibilidad.yml</a:t>
+            </a:r>
+          </a:p>
+        </p:txBody>
+      </p:sp>
+      <p:sp>
+        <p:nvSpPr>
+          <p:cNvPr id="18" name="Rounded Rectangle 17"/>
+          <p:cNvSpPr/>
+          <p:nvPr/>
+        </p:nvSpPr>
+        <p:spPr>
+          <a:xfrm>
+            <a:off x="8107527" y="2286000"/>
+            <a:ext cx="3657600" cy="3108960"/>
+          </a:xfrm>
+          <a:prstGeom prst="roundRect">
+            <a:avLst/>
+          </a:prstGeom>
+          <a:solidFill>
+            <a:srgbClr val="F4F4F4"/>
+          </a:solidFill>
+          <a:ln w="38100">
+            <a:solidFill>
+              <a:srgbClr val="EA580C"/>
+            </a:solidFill>
+          </a:ln>
+        </p:spPr>
+        <p:style>
+          <a:lnRef idx="1">
+            <a:schemeClr val="accent1"/>
+          </a:lnRef>
+          <a:fillRef idx="3">
+            <a:schemeClr val="accent1"/>
+          </a:fillRef>
+          <a:effectRef idx="2">
+            <a:schemeClr val="accent1"/>
+          </a:effectRef>
+          <a:fontRef idx="minor">
+            <a:schemeClr val="lt1"/>
+          </a:fontRef>
+        </p:style>
+        <p:txBody>
+          <a:bodyPr rtlCol="0" anchor="ctr"/>
+          <a:lstStyle/>
+          <a:p>
+            <a:pPr algn="ctr"/>
+          </a:p>
+        </p:txBody>
+      </p:sp>
+      <p:sp>
+        <p:nvSpPr>
+          <p:cNvPr id="19" name="Rectangle 18"/>
+          <p:cNvSpPr/>
+          <p:nvPr/>
+        </p:nvSpPr>
+        <p:spPr>
+          <a:xfrm>
+            <a:off x="8107527" y="2286000"/>
+            <a:ext cx="3657600" cy="548640"/>
+          </a:xfrm>
+          <a:prstGeom prst="rect">
+            <a:avLst/>
+          </a:prstGeom>
+          <a:solidFill>
+            <a:srgbClr val="EA580C"/>
+          </a:solidFill>
+          <a:ln>
+            <a:noFill/>
+          </a:ln>
+        </p:spPr>
+        <p:style>
+          <a:lnRef idx="1">
+            <a:schemeClr val="accent1"/>
+          </a:lnRef>
+          <a:fillRef idx="3">
+            <a:schemeClr val="accent1"/>
+          </a:fillRef>
+          <a:effectRef idx="2">
+            <a:schemeClr val="accent1"/>
+          </a:effectRef>
+          <a:fontRef idx="minor">
+            <a:schemeClr val="lt1"/>
+          </a:fontRef>
+        </p:style>
+        <p:txBody>
+          <a:bodyPr rtlCol="0" anchor="ctr"/>
+          <a:lstStyle/>
+          <a:p>
+            <a:pPr algn="ctr"/>
+          </a:p>
+        </p:txBody>
+      </p:sp>
+      <p:sp>
+        <p:nvSpPr>
+          <p:cNvPr id="20" name="TextBox 19"/>
+          <p:cNvSpPr txBox="1"/>
+          <p:nvPr/>
+        </p:nvSpPr>
+        <p:spPr>
+          <a:xfrm>
+            <a:off x="8107527" y="2331720"/>
+            <a:ext cx="3657600" cy="457200"/>
+          </a:xfrm>
+          <a:prstGeom prst="rect">
+            <a:avLst/>
+          </a:prstGeom>
+          <a:noFill/>
+        </p:spPr>
+        <p:txBody>
+          <a:bodyPr wrap="square">
+            <a:spAutoFit/>
+          </a:bodyPr>
+          <a:lstStyle/>
+          <a:p>
+            <a:pPr algn="ctr"/>
+            <a:r>
+              <a:rPr sz="1800" b="1">
+                <a:solidFill>
+                  <a:srgbClr val="FFFFFF"/>
+                </a:solidFill>
+                <a:latin typeface="Calibri"/>
+              </a:rPr>
+              <a:t>🔧 MANTENIMIENTO</a:t>
+            </a:r>
+          </a:p>
+        </p:txBody>
+      </p:sp>
+      <p:sp>
+        <p:nvSpPr>
+          <p:cNvPr id="21" name="TextBox 20"/>
+          <p:cNvSpPr txBox="1"/>
+          <p:nvPr/>
+        </p:nvSpPr>
+        <p:spPr>
+          <a:xfrm>
+            <a:off x="8244687" y="2926080"/>
+            <a:ext cx="3383280" cy="1463040"/>
+          </a:xfrm>
+          <a:prstGeom prst="rect">
+            <a:avLst/>
+          </a:prstGeom>
+          <a:noFill/>
+        </p:spPr>
+        <p:txBody>
+          <a:bodyPr wrap="square">
+            <a:spAutoFit/>
+          </a:bodyPr>
+          <a:lstStyle/>
+          <a:p>
+            <a:pPr algn="l"/>
+            <a:r>
+              <a:rPr sz="1200" b="1">
                 <a:solidFill>
                   <a:srgbClr val="2A2A2A"/>
                 </a:solidFill>
                 <a:latin typeface="Calibri"/>
               </a:rPr>
-              <a:t>• Pestaña Lighthouse → Performance</a:t>
-            </a:r>
-          </a:p>
-          <a:p>
-            <a:pPr algn="l"/>
-            <a:r>
-              <a:rPr sz="1400" b="0">
+              <a:t>package.json + código</a:t>
+            </a:r>
+          </a:p>
+          <a:p>
+            <a:pPr algn="l"/>
+            <a:r>
+              <a:rPr sz="1200" b="0">
                 <a:solidFill>
                   <a:srgbClr val="2A2A2A"/>
                 </a:solidFill>
                 <a:latin typeface="Calibri"/>
               </a:rPr>
-              <a:t>• Analyze page load</a:t>
-            </a:r>
-          </a:p>
-        </p:txBody>
-      </p:sp>
-      <p:sp>
-        <p:nvSpPr>
-          <p:cNvPr id="8" name="TextBox 7"/>
-          <p:cNvSpPr txBox="1"/>
-          <p:nvPr/>
-        </p:nvSpPr>
-        <p:spPr>
-          <a:xfrm>
-            <a:off x="6400800" y="1737360"/>
-            <a:ext cx="5303520" cy="3200400"/>
-          </a:xfrm>
-          <a:prstGeom prst="rect">
-            <a:avLst/>
-          </a:prstGeom>
-          <a:noFill/>
-        </p:spPr>
-        <p:txBody>
-          <a:bodyPr wrap="square">
-            <a:spAutoFit/>
-          </a:bodyPr>
-          <a:lstStyle/>
-          <a:p>
-            <a:pPr algn="l"/>
-            <a:r>
-              <a:rPr sz="1400" b="1">
+              <a:t/>
+            </a:r>
+          </a:p>
+          <a:p>
+            <a:pPr algn="l"/>
+            <a:r>
+              <a:rPr sz="1200" b="0">
                 <a:solidFill>
                   <a:srgbClr val="2A2A2A"/>
                 </a:solidFill>
                 <a:latin typeface="Calibri"/>
               </a:rPr>
-              <a:t>♿ axe DevTools (extensión)</a:t>
-            </a:r>
-          </a:p>
-          <a:p>
-            <a:pPr algn="l"/>
-            <a:r>
-              <a:rPr sz="1400" b="0">
-                <a:solidFill>
-                  <a:srgbClr val="2A2A2A"/>
-                </a:solidFill>
-                <a:latin typeface="Calibri"/>
-              </a:rPr>
-              <a:t>• Pestaña axe DevTools</a:t>
-            </a:r>
-          </a:p>
-          <a:p>
-            <a:pPr algn="l"/>
-            <a:r>
-              <a:rPr sz="1400" b="0">
-                <a:solidFill>
-                  <a:srgbClr val="2A2A2A"/>
-                </a:solidFill>
-                <a:latin typeface="Calibri"/>
-              </a:rPr>
-              <a:t>• Scan ALL of my page</a:t>
-            </a:r>
-          </a:p>
-          <a:p>
-            <a:pPr algn="l"/>
-            <a:r>
-              <a:rPr sz="1400" b="0">
-                <a:solidFill>
-                  <a:srgbClr val="2A2A2A"/>
-                </a:solidFill>
-                <a:latin typeface="Calibri"/>
-              </a:rPr>
-              <a:t>• Detecta accesibilidad</a:t>
-            </a:r>
-          </a:p>
-          <a:p>
-            <a:pPr algn="l"/>
-            <a:r>
-              <a:rPr sz="1400" b="0">
-                <a:solidFill>
-                  <a:srgbClr val="2A2A2A"/>
-                </a:solidFill>
-                <a:latin typeface="Calibri"/>
-              </a:rPr>
-              <a:t>  (alt, contraste, ARIA, etc.)</a:t>
-            </a:r>
-          </a:p>
-          <a:p>
-            <a:pPr algn="l"/>
-            <a:r>
-              <a:rPr sz="1400" b="0">
-                <a:solidFill>
-                  <a:srgbClr val="2A2A2A"/>
-                </a:solidFill>
-                <a:latin typeface="Calibri"/>
-              </a:rPr>
-              <a:t/>
-            </a:r>
-          </a:p>
-          <a:p>
-            <a:pPr algn="l"/>
-            <a:r>
-              <a:rPr sz="1400" b="1">
-                <a:solidFill>
-                  <a:srgbClr val="2A2A2A"/>
-                </a:solidFill>
-                <a:latin typeface="Calibri"/>
-              </a:rPr>
-              <a:t>El sitio tiene 15 problemas:</a:t>
-            </a:r>
-          </a:p>
-          <a:p>
-            <a:pPr algn="l"/>
-            <a:r>
-              <a:rPr sz="1400" b="0">
-                <a:solidFill>
-                  <a:srgbClr val="2A2A2A"/>
-                </a:solidFill>
-                <a:latin typeface="Calibri"/>
-              </a:rPr>
-              <a:t>• 5 de rendimiento</a:t>
-            </a:r>
-          </a:p>
-          <a:p>
-            <a:pPr algn="l"/>
-            <a:r>
-              <a:rPr sz="1400" b="0">
-                <a:solidFill>
-                  <a:srgbClr val="2A2A2A"/>
-                </a:solidFill>
-                <a:latin typeface="Calibri"/>
-              </a:rPr>
-              <a:t>• 5 de accesibilidad</a:t>
-            </a:r>
-          </a:p>
-          <a:p>
-            <a:pPr algn="l"/>
-            <a:r>
-              <a:rPr sz="1400" b="0">
-                <a:solidFill>
-                  <a:srgbClr val="2A2A2A"/>
-                </a:solidFill>
-                <a:latin typeface="Calibri"/>
-              </a:rPr>
-              <a:t>• 3 de mantenimiento/seguridad</a:t>
-            </a:r>
-          </a:p>
-          <a:p>
-            <a:pPr algn="l"/>
-            <a:r>
-              <a:rPr sz="1400" b="0">
-                <a:solidFill>
-                  <a:srgbClr val="2A2A2A"/>
-                </a:solidFill>
-                <a:latin typeface="Calibri"/>
-              </a:rPr>
-              <a:t>• 2 de administración</a:t>
-            </a:r>
-          </a:p>
-        </p:txBody>
-      </p:sp>
-      <p:sp>
-        <p:nvSpPr>
-          <p:cNvPr id="9" name="Rounded Rectangle 8"/>
+              <a:t>Ejemplos:
+• jQuery 2.1.4 (versión antigua)
+• Meta tags de seguridad faltantes
+• Comentarios TODO/FIXME
+• Footer desactualizado
+• Falta de runbook público</a:t>
+            </a:r>
+          </a:p>
+        </p:txBody>
+      </p:sp>
+      <p:sp>
+        <p:nvSpPr>
+          <p:cNvPr id="22" name="TextBox 21"/>
+          <p:cNvSpPr txBox="1"/>
+          <p:nvPr/>
+        </p:nvSpPr>
+        <p:spPr>
+          <a:xfrm>
+            <a:off x="8107527" y="5166360"/>
+            <a:ext cx="3657600" cy="274320"/>
+          </a:xfrm>
+          <a:prstGeom prst="rect">
+            <a:avLst/>
+          </a:prstGeom>
+          <a:noFill/>
+        </p:spPr>
+        <p:txBody>
+          <a:bodyPr wrap="square">
+            <a:spAutoFit/>
+          </a:bodyPr>
+          <a:lstStyle/>
+          <a:p>
+            <a:pPr algn="ctr"/>
+            <a:r>
+              <a:rPr sz="1100" b="1">
+                <a:solidFill>
+                  <a:srgbClr val="EA580C"/>
+                </a:solidFill>
+                <a:latin typeface="Calibri"/>
+              </a:rPr>
+              <a:t>📝 Template: mantenimiento.yml</a:t>
+            </a:r>
+          </a:p>
+        </p:txBody>
+      </p:sp>
+      <p:sp>
+        <p:nvSpPr>
+          <p:cNvPr id="23" name="Rounded Rectangle 22"/>
           <p:cNvSpPr/>
           <p:nvPr/>
         </p:nvSpPr>
         <p:spPr>
           <a:xfrm>
-            <a:off x="640080" y="5120640"/>
-            <a:ext cx="10972800" cy="640080"/>
+            <a:off x="640080" y="5669280"/>
+            <a:ext cx="10972800" cy="548640"/>
           </a:xfrm>
           <a:prstGeom prst="roundRect">
             <a:avLst/>
@@ -9118,27 +9631,27 @@
       </p:sp>
       <p:sp>
         <p:nvSpPr>
-          <p:cNvPr id="10" name="TextBox 9"/>
-          <p:cNvSpPr txBox="1"/>
-          <p:nvPr/>
-        </p:nvSpPr>
-        <p:spPr>
-          <a:xfrm>
-            <a:off x="822960" y="5212080"/>
-            <a:ext cx="10607040" cy="457200"/>
-          </a:xfrm>
-          <a:prstGeom prst="rect">
-            <a:avLst/>
-          </a:prstGeom>
-          <a:noFill/>
-        </p:spPr>
-        <p:txBody>
-          <a:bodyPr wrap="square">
-            <a:spAutoFit/>
-          </a:bodyPr>
-          <a:lstStyle/>
-          <a:p>
-            <a:pPr algn="l"/>
+          <p:cNvPr id="24" name="TextBox 23"/>
+          <p:cNvSpPr txBox="1"/>
+          <p:nvPr/>
+        </p:nvSpPr>
+        <p:spPr>
+          <a:xfrm>
+            <a:off x="640080" y="5760720"/>
+            <a:ext cx="10972800" cy="365760"/>
+          </a:xfrm>
+          <a:prstGeom prst="rect">
+            <a:avLst/>
+          </a:prstGeom>
+          <a:noFill/>
+        </p:spPr>
+        <p:txBody>
+          <a:bodyPr wrap="square">
+            <a:spAutoFit/>
+          </a:bodyPr>
+          <a:lstStyle/>
+          <a:p>
+            <a:pPr algn="ctr"/>
             <a:r>
               <a:rPr sz="1400" b="1">
                 <a:solidFill>
@@ -9146,14 +9659,14 @@
                 </a:solidFill>
                 <a:latin typeface="Calibri"/>
               </a:rPr>
-              <a:t>🎯 Objetivo: encontrar 4 problemas reales. Variedad es positiva pero no obligatoria.</a:t>
-            </a:r>
-          </a:p>
-        </p:txBody>
-      </p:sp>
-      <p:sp>
-        <p:nvSpPr>
-          <p:cNvPr id="11" name="TextBox 10"/>
+              <a:t>🎯 Objetivo: 3 Issues (una de cada tipo) en el repo del DOCENTE.</a:t>
+            </a:r>
+          </a:p>
+        </p:txBody>
+      </p:sp>
+      <p:sp>
+        <p:nvSpPr>
+          <p:cNvPr id="25" name="TextBox 24"/>
           <p:cNvSpPr txBox="1"/>
           <p:nvPr/>
         </p:nvSpPr>
@@ -9181,14 +9694,14 @@
                 </a:solidFill>
                 <a:latin typeface="Calibri"/>
               </a:rPr>
-              <a:t>📦 Repo: github.com/KrizRoMe/evaluacion-administracion-web   •   🌐 Web: krizrome.github.io/evaluacion-administracion-web   •   📋 Issues: github.com/KrizRoMe/evaluacion-administracion-web/issues</a:t>
-            </a:r>
-          </a:p>
-        </p:txBody>
-      </p:sp>
-      <p:sp>
-        <p:nvSpPr>
-          <p:cNvPr id="12" name="TextBox 11"/>
+              <a:t>📦 Repo del docente: github.com/KrizRoMe/evaluacion-administracion-web   •   🌐 Sitio público: krizrome.github.io/evaluacion-administracion-web   •   📋 Issues: github.com/KrizRoMe/evaluacion-administracion-web/issues</a:t>
+            </a:r>
+          </a:p>
+        </p:txBody>
+      </p:sp>
+      <p:sp>
+        <p:nvSpPr>
+          <p:cNvPr id="26" name="TextBox 25"/>
           <p:cNvSpPr txBox="1"/>
           <p:nvPr/>
         </p:nvSpPr>
@@ -9355,7 +9868,7 @@
                 </a:solidFill>
                 <a:latin typeface="Calibri"/>
               </a:rPr>
-              <a:t>Parte 4 · Crear 4 Issues en TU repo</a:t>
+              <a:t>Parte 4 · Crear 3 Issues de hallazgos</a:t>
             </a:r>
           </a:p>
         </p:txBody>
@@ -9390,7 +9903,7 @@
                 </a:solidFill>
                 <a:latin typeface="Calibri"/>
               </a:rPr>
-              <a:t>⏱ 20 minutos  •  4 Issues × 5 pts = 20 pts</a:t>
+              <a:t>⏱ 25 minutos  •  En el repo del DOCENTE</a:t>
             </a:r>
           </a:p>
         </p:txBody>
@@ -9404,17 +9917,17 @@
         <p:spPr>
           <a:xfrm>
             <a:off x="640080" y="1188720"/>
-            <a:ext cx="10972800" cy="548640"/>
+            <a:ext cx="10972800" cy="822960"/>
           </a:xfrm>
           <a:prstGeom prst="roundRect">
             <a:avLst/>
           </a:prstGeom>
           <a:solidFill>
-            <a:srgbClr val="E3F2FD"/>
+            <a:srgbClr val="FEF3E6"/>
           </a:solidFill>
-          <a:ln w="25400">
+          <a:ln w="38100">
             <a:solidFill>
-              <a:srgbClr val="1C7293"/>
+              <a:srgbClr val="EA580C"/>
             </a:solidFill>
           </a:ln>
         </p:spPr>
@@ -9448,7 +9961,77 @@
         </p:nvSpPr>
         <p:spPr>
           <a:xfrm>
-            <a:off x="640080" y="1280160"/>
+            <a:off x="822960" y="1280160"/>
+            <a:ext cx="10607040" cy="365760"/>
+          </a:xfrm>
+          <a:prstGeom prst="rect">
+            <a:avLst/>
+          </a:prstGeom>
+          <a:noFill/>
+        </p:spPr>
+        <p:txBody>
+          <a:bodyPr wrap="square">
+            <a:spAutoFit/>
+          </a:bodyPr>
+          <a:lstStyle/>
+          <a:p>
+            <a:pPr algn="ctr"/>
+            <a:r>
+              <a:rPr sz="1500" b="1">
+                <a:solidFill>
+                  <a:srgbClr val="EA580C"/>
+                </a:solidFill>
+                <a:latin typeface="Calibri"/>
+              </a:rPr>
+              <a:t>📋 LAS 3 ISSUES DE HALLAZGOS SE CREAN EN:</a:t>
+            </a:r>
+          </a:p>
+        </p:txBody>
+      </p:sp>
+      <p:sp>
+        <p:nvSpPr>
+          <p:cNvPr id="8" name="TextBox 7"/>
+          <p:cNvSpPr txBox="1"/>
+          <p:nvPr/>
+        </p:nvSpPr>
+        <p:spPr>
+          <a:xfrm>
+            <a:off x="822960" y="1645920"/>
+            <a:ext cx="10607040" cy="365760"/>
+          </a:xfrm>
+          <a:prstGeom prst="rect">
+            <a:avLst/>
+          </a:prstGeom>
+          <a:noFill/>
+        </p:spPr>
+        <p:txBody>
+          <a:bodyPr wrap="square">
+            <a:spAutoFit/>
+          </a:bodyPr>
+          <a:lstStyle/>
+          <a:p>
+            <a:pPr algn="ctr"/>
+            <a:r>
+              <a:rPr sz="1500" b="1">
+                <a:solidFill>
+                  <a:srgbClr val="2A2A2A"/>
+                </a:solidFill>
+                <a:latin typeface="Consolas"/>
+              </a:rPr>
+              <a:t>https://github.com/KrizRoMe/evaluacion-administracion-web/issues</a:t>
+            </a:r>
+          </a:p>
+        </p:txBody>
+      </p:sp>
+      <p:sp>
+        <p:nvSpPr>
+          <p:cNvPr id="9" name="TextBox 8"/>
+          <p:cNvSpPr txBox="1"/>
+          <p:nvPr/>
+        </p:nvSpPr>
+        <p:spPr>
+          <a:xfrm>
+            <a:off x="640080" y="2194560"/>
             <a:ext cx="10972800" cy="365760"/>
           </a:xfrm>
           <a:prstGeom prst="rect">
@@ -9462,141 +10045,153 @@
           </a:bodyPr>
           <a:lstStyle/>
           <a:p>
-            <a:pPr algn="ctr"/>
-            <a:r>
-              <a:rPr sz="1500" b="1">
+            <a:pPr algn="l"/>
+            <a:r>
+              <a:rPr sz="1800" b="1">
                 <a:solidFill>
                   <a:srgbClr val="065A82"/>
                 </a:solidFill>
                 <a:latin typeface="Calibri"/>
               </a:rPr>
-              <a:t>⚠️  Estas 4 Issues se crean en TU PROPIO repositorio, NO en el del docente.</a:t>
-            </a:r>
-          </a:p>
-        </p:txBody>
-      </p:sp>
-      <p:sp>
-        <p:nvSpPr>
-          <p:cNvPr id="8" name="TextBox 7"/>
-          <p:cNvSpPr txBox="1"/>
-          <p:nvPr/>
-        </p:nvSpPr>
-        <p:spPr>
-          <a:xfrm>
-            <a:off x="640080" y="1920240"/>
-            <a:ext cx="10972800" cy="457200"/>
-          </a:xfrm>
-          <a:prstGeom prst="rect">
-            <a:avLst/>
-          </a:prstGeom>
-          <a:noFill/>
-        </p:spPr>
-        <p:txBody>
-          <a:bodyPr wrap="square">
-            <a:spAutoFit/>
-          </a:bodyPr>
-          <a:lstStyle/>
-          <a:p>
-            <a:pPr algn="l"/>
-            <a:r>
-              <a:rPr sz="1500" b="1">
+              <a:t>Pasos:</a:t>
+            </a:r>
+          </a:p>
+        </p:txBody>
+      </p:sp>
+      <p:sp>
+        <p:nvSpPr>
+          <p:cNvPr id="10" name="TextBox 9"/>
+          <p:cNvSpPr txBox="1"/>
+          <p:nvPr/>
+        </p:nvSpPr>
+        <p:spPr>
+          <a:xfrm>
+            <a:off x="822960" y="2606040"/>
+            <a:ext cx="10972800" cy="1097280"/>
+          </a:xfrm>
+          <a:prstGeom prst="rect">
+            <a:avLst/>
+          </a:prstGeom>
+          <a:noFill/>
+        </p:spPr>
+        <p:txBody>
+          <a:bodyPr wrap="square">
+            <a:spAutoFit/>
+          </a:bodyPr>
+          <a:lstStyle/>
+          <a:p>
+            <a:pPr algn="l"/>
+            <a:r>
+              <a:rPr sz="1300" b="0">
                 <a:solidFill>
                   <a:srgbClr val="2A2A2A"/>
                 </a:solidFill>
                 <a:latin typeface="Calibri"/>
               </a:rPr>
-              <a:t>Templates interactivos disponibles (en .github/ISSUE_TEMPLATE/):</a:t>
-            </a:r>
-          </a:p>
-        </p:txBody>
-      </p:sp>
-      <p:sp>
-        <p:nvSpPr>
-          <p:cNvPr id="9" name="TextBox 8"/>
-          <p:cNvSpPr txBox="1"/>
-          <p:nvPr/>
-        </p:nvSpPr>
-        <p:spPr>
-          <a:xfrm>
-            <a:off x="822960" y="2377440"/>
-            <a:ext cx="10972800" cy="1097280"/>
-          </a:xfrm>
-          <a:prstGeom prst="rect">
-            <a:avLst/>
-          </a:prstGeom>
-          <a:noFill/>
-        </p:spPr>
-        <p:txBody>
-          <a:bodyPr wrap="square">
-            <a:spAutoFit/>
-          </a:bodyPr>
-          <a:lstStyle/>
-          <a:p>
-            <a:pPr algn="l"/>
-            <a:r>
-              <a:rPr sz="1400" b="0">
+              <a:t>1. Abre https://github.com/KrizRoMe/evaluacion-administracion-web/issues en una pestaña nueva</a:t>
+            </a:r>
+          </a:p>
+          <a:p>
+            <a:pPr algn="l"/>
+            <a:r>
+              <a:rPr sz="1300" b="0">
                 <a:solidFill>
                   <a:srgbClr val="2A2A2A"/>
                 </a:solidFill>
                 <a:latin typeface="Calibri"/>
               </a:rPr>
-              <a:t>📊 rendimiento.yml     →  hallazgos de performance / Lighthouse</a:t>
-            </a:r>
-          </a:p>
-          <a:p>
-            <a:pPr algn="l"/>
-            <a:r>
-              <a:rPr sz="1400" b="0">
+              <a:t>2. Clic en New issue</a:t>
+            </a:r>
+          </a:p>
+          <a:p>
+            <a:pPr algn="l"/>
+            <a:r>
+              <a:rPr sz="1300" b="0">
                 <a:solidFill>
                   <a:srgbClr val="2A2A2A"/>
                 </a:solidFill>
                 <a:latin typeface="Calibri"/>
               </a:rPr>
-              <a:t>🔧 mantenimiento.yml   →  hallazgos de dependencias / seguridad</a:t>
-            </a:r>
-          </a:p>
-          <a:p>
-            <a:pPr algn="l"/>
-            <a:r>
-              <a:rPr sz="1400" b="0">
+              <a:t>3. Selecciona UNO de los 3 templates: rendimiento.yml, accesibilidad.yml, o mantenimiento.yml</a:t>
+            </a:r>
+          </a:p>
+          <a:p>
+            <a:pPr algn="l"/>
+            <a:r>
+              <a:rPr sz="1300" b="0">
                 <a:solidFill>
                   <a:srgbClr val="2A2A2A"/>
                 </a:solidFill>
                 <a:latin typeface="Calibri"/>
               </a:rPr>
-              <a:t>♿ accesibilidad.yml   →  hallazgos de axe DevTools</a:t>
-            </a:r>
-          </a:p>
-          <a:p>
-            <a:pPr algn="l"/>
-            <a:r>
-              <a:rPr sz="1400" b="0">
+              <a:t>4. Completa todas las secciones del template</a:t>
+            </a:r>
+          </a:p>
+          <a:p>
+            <a:pPr algn="l"/>
+            <a:r>
+              <a:rPr sz="1300" b="0">
                 <a:solidFill>
                   <a:srgbClr val="2A2A2A"/>
                 </a:solidFill>
                 <a:latin typeface="Calibri"/>
               </a:rPr>
-              <a:t>📝 general.yml         →  cualquier otro hallazgo</a:t>
-            </a:r>
-          </a:p>
-        </p:txBody>
-      </p:sp>
-      <p:sp>
-        <p:nvSpPr>
-          <p:cNvPr id="10" name="Rounded Rectangle 9"/>
+              <a:t>5. Submit. Repite 2 veces más (1 issue por cada tipo)</a:t>
+            </a:r>
+          </a:p>
+        </p:txBody>
+      </p:sp>
+      <p:sp>
+        <p:nvSpPr>
+          <p:cNvPr id="11" name="TextBox 10"/>
+          <p:cNvSpPr txBox="1"/>
+          <p:nvPr/>
+        </p:nvSpPr>
+        <p:spPr>
+          <a:xfrm>
+            <a:off x="640080" y="3840480"/>
+            <a:ext cx="10972800" cy="365760"/>
+          </a:xfrm>
+          <a:prstGeom prst="rect">
+            <a:avLst/>
+          </a:prstGeom>
+          <a:noFill/>
+        </p:spPr>
+        <p:txBody>
+          <a:bodyPr wrap="square">
+            <a:spAutoFit/>
+          </a:bodyPr>
+          <a:lstStyle/>
+          <a:p>
+            <a:pPr algn="l"/>
+            <a:r>
+              <a:rPr sz="1800" b="1">
+                <a:solidFill>
+                  <a:srgbClr val="065A82"/>
+                </a:solidFill>
+                <a:latin typeface="Calibri"/>
+              </a:rPr>
+              <a:t>Formato de cada Issue (ciclo de mejora):</a:t>
+            </a:r>
+          </a:p>
+        </p:txBody>
+      </p:sp>
+      <p:sp>
+        <p:nvSpPr>
+          <p:cNvPr id="12" name="Rounded Rectangle 11"/>
           <p:cNvSpPr/>
           <p:nvPr/>
         </p:nvSpPr>
         <p:spPr>
           <a:xfrm>
-            <a:off x="640080" y="3657600"/>
-            <a:ext cx="10972800" cy="2377440"/>
+            <a:off x="640080" y="4297680"/>
+            <a:ext cx="10972800" cy="1371600"/>
           </a:xfrm>
           <a:prstGeom prst="roundRect">
             <a:avLst/>
           </a:prstGeom>
           <a:solidFill>
-            <a:srgbClr val="2A2A2A"/>
+            <a:srgbClr val="F4F4F4"/>
           </a:solidFill>
           <a:ln>
             <a:solidFill>
@@ -9628,126 +10223,146 @@
       </p:sp>
       <p:sp>
         <p:nvSpPr>
-          <p:cNvPr id="11" name="TextBox 10"/>
-          <p:cNvSpPr txBox="1"/>
-          <p:nvPr/>
-        </p:nvSpPr>
-        <p:spPr>
-          <a:xfrm>
-            <a:off x="822960" y="3749039"/>
-            <a:ext cx="10607040" cy="2286000"/>
-          </a:xfrm>
-          <a:prstGeom prst="rect">
-            <a:avLst/>
-          </a:prstGeom>
-          <a:noFill/>
-        </p:spPr>
-        <p:txBody>
-          <a:bodyPr wrap="square">
-            <a:spAutoFit/>
-          </a:bodyPr>
-          <a:lstStyle/>
-          <a:p>
-            <a:pPr algn="l"/>
+          <p:cNvPr id="13" name="TextBox 12"/>
+          <p:cNvSpPr txBox="1"/>
+          <p:nvPr/>
+        </p:nvSpPr>
+        <p:spPr>
+          <a:xfrm>
+            <a:off x="822960" y="4389120"/>
+            <a:ext cx="10607040" cy="1280160"/>
+          </a:xfrm>
+          <a:prstGeom prst="rect">
+            <a:avLst/>
+          </a:prstGeom>
+          <a:noFill/>
+        </p:spPr>
+        <p:txBody>
+          <a:bodyPr wrap="square">
+            <a:spAutoFit/>
+          </a:bodyPr>
+          <a:lstStyle/>
+          <a:p>
+            <a:pPr algn="l"/>
+            <a:r>
+              <a:rPr sz="1200" b="1">
+                <a:solidFill>
+                  <a:srgbClr val="2A2A2A"/>
+                </a:solidFill>
+                <a:latin typeface="Calibri"/>
+              </a:rPr>
+              <a:t>• Problema (qué encontraste)  •  Evidencia — MEDIR (herramienta, métrica, captura)</a:t>
+            </a:r>
+          </a:p>
+          <a:p>
+            <a:pPr algn="l"/>
+            <a:r>
+              <a:rPr sz="1200" b="1">
+                <a:solidFill>
+                  <a:srgbClr val="2A2A2A"/>
+                </a:solidFill>
+                <a:latin typeface="Calibri"/>
+              </a:rPr>
+              <a:t>• Impacto (a quién afecta)  •  Solución propuesta — PROPONER + MEJORAR (en texto)</a:t>
+            </a:r>
+          </a:p>
+          <a:p>
+            <a:pPr algn="l"/>
+            <a:r>
+              <a:rPr sz="1200" b="1">
+                <a:solidFill>
+                  <a:srgbClr val="2A2A2A"/>
+                </a:solidFill>
+                <a:latin typeface="Calibri"/>
+              </a:rPr>
+              <a:t>• Pilar (VIVO / RÁPIDO / SEGURO)  •  Concepto del curso  •  Severidad + Justificación</a:t>
+            </a:r>
+          </a:p>
+        </p:txBody>
+      </p:sp>
+      <p:sp>
+        <p:nvSpPr>
+          <p:cNvPr id="14" name="Rounded Rectangle 13"/>
+          <p:cNvSpPr/>
+          <p:nvPr/>
+        </p:nvSpPr>
+        <p:spPr>
+          <a:xfrm>
+            <a:off x="640080" y="5852160"/>
+            <a:ext cx="10972800" cy="457200"/>
+          </a:xfrm>
+          <a:prstGeom prst="roundRect">
+            <a:avLst/>
+          </a:prstGeom>
+          <a:solidFill>
+            <a:srgbClr val="FFF3CD"/>
+          </a:solidFill>
+          <a:ln>
+            <a:solidFill>
+              <a:srgbClr val="E6A23E"/>
+            </a:solidFill>
+          </a:ln>
+        </p:spPr>
+        <p:style>
+          <a:lnRef idx="1">
+            <a:schemeClr val="accent1"/>
+          </a:lnRef>
+          <a:fillRef idx="3">
+            <a:schemeClr val="accent1"/>
+          </a:fillRef>
+          <a:effectRef idx="2">
+            <a:schemeClr val="accent1"/>
+          </a:effectRef>
+          <a:fontRef idx="minor">
+            <a:schemeClr val="lt1"/>
+          </a:fontRef>
+        </p:style>
+        <p:txBody>
+          <a:bodyPr rtlCol="0" anchor="ctr"/>
+          <a:lstStyle/>
+          <a:p>
+            <a:pPr algn="ctr"/>
+          </a:p>
+        </p:txBody>
+      </p:sp>
+      <p:sp>
+        <p:nvSpPr>
+          <p:cNvPr id="15" name="TextBox 14"/>
+          <p:cNvSpPr txBox="1"/>
+          <p:nvPr/>
+        </p:nvSpPr>
+        <p:spPr>
+          <a:xfrm>
+            <a:off x="640080" y="5897880"/>
+            <a:ext cx="10972800" cy="365760"/>
+          </a:xfrm>
+          <a:prstGeom prst="rect">
+            <a:avLst/>
+          </a:prstGeom>
+          <a:noFill/>
+        </p:spPr>
+        <p:txBody>
+          <a:bodyPr wrap="square">
+            <a:spAutoFit/>
+          </a:bodyPr>
+          <a:lstStyle/>
+          <a:p>
+            <a:pPr algn="ctr"/>
             <a:r>
               <a:rPr sz="1300" b="1">
                 <a:solidFill>
-                  <a:srgbClr val="FFFFFF"/>
-                </a:solidFill>
-                <a:latin typeface="Calibri"/>
-              </a:rPr>
-              <a:t>Cada Issue se evalúa con 4 criterios (5 pts):</a:t>
-            </a:r>
-          </a:p>
-          <a:p>
-            <a:pPr algn="l"/>
-            <a:r>
-              <a:rPr sz="1300" b="0">
-                <a:solidFill>
-                  <a:srgbClr val="FFFFFF"/>
-                </a:solidFill>
-                <a:latin typeface="Calibri"/>
-              </a:rPr>
-              <a:t/>
-            </a:r>
-          </a:p>
-          <a:p>
-            <a:pPr algn="l"/>
-            <a:r>
-              <a:rPr sz="1300" b="0">
-                <a:solidFill>
-                  <a:srgbClr val="FFFFFF"/>
-                </a:solidFill>
-                <a:latin typeface="Calibri"/>
-              </a:rPr>
-              <a:t>✓ Identificación correcta del problema (2 pts)</a:t>
-            </a:r>
-          </a:p>
-          <a:p>
-            <a:pPr algn="l"/>
-            <a:r>
-              <a:rPr sz="1300" b="0">
-                <a:solidFill>
-                  <a:srgbClr val="FFFFFF"/>
-                </a:solidFill>
-                <a:latin typeface="Calibri"/>
-              </a:rPr>
-              <a:t>✓ Ubicación y evidencia (1 pt)</a:t>
-            </a:r>
-          </a:p>
-          <a:p>
-            <a:pPr algn="l"/>
-            <a:r>
-              <a:rPr sz="1300" b="0">
-                <a:solidFill>
-                  <a:srgbClr val="FFFFFF"/>
-                </a:solidFill>
-                <a:latin typeface="Calibri"/>
-              </a:rPr>
-              <a:t>✓ Impacto + concepto del curso relacionado (1 pt)</a:t>
-            </a:r>
-          </a:p>
-          <a:p>
-            <a:pPr algn="l"/>
-            <a:r>
-              <a:rPr sz="1300" b="0">
-                <a:solidFill>
-                  <a:srgbClr val="FFFFFF"/>
-                </a:solidFill>
-                <a:latin typeface="Calibri"/>
-              </a:rPr>
-              <a:t>✓ Solución propuesta en texto (1 pt)</a:t>
-            </a:r>
-          </a:p>
-          <a:p>
-            <a:pPr algn="l"/>
-            <a:r>
-              <a:rPr sz="1300" b="0">
-                <a:solidFill>
-                  <a:srgbClr val="FFFFFF"/>
-                </a:solidFill>
-                <a:latin typeface="Calibri"/>
-              </a:rPr>
-              <a:t/>
-            </a:r>
-          </a:p>
-          <a:p>
-            <a:pPr algn="l"/>
-            <a:r>
-              <a:rPr sz="1300" b="0">
-                <a:solidFill>
-                  <a:srgbClr val="FFFFFF"/>
-                </a:solidFill>
-                <a:latin typeface="Calibri"/>
-              </a:rPr>
-              <a:t>Cada template es un FORMULARIO INTERACTIVO con inputs, dropdowns y checkboxes.</a:t>
-            </a:r>
-          </a:p>
-        </p:txBody>
-      </p:sp>
-      <p:sp>
-        <p:nvSpPr>
-          <p:cNvPr id="12" name="TextBox 11"/>
+                  <a:srgbClr val="924E0E"/>
+                </a:solidFill>
+                <a:latin typeface="Calibri"/>
+              </a:rPr>
+              <a:t>📊 Puntaje: 3 Issues × 5 pts = 15 pts (no se exige aplicar correcciones en código)</a:t>
+            </a:r>
+          </a:p>
+        </p:txBody>
+      </p:sp>
+      <p:sp>
+        <p:nvSpPr>
+          <p:cNvPr id="16" name="TextBox 15"/>
           <p:cNvSpPr txBox="1"/>
           <p:nvPr/>
         </p:nvSpPr>
@@ -9775,14 +10390,14 @@
                 </a:solidFill>
                 <a:latin typeface="Calibri"/>
               </a:rPr>
-              <a:t>📦 Repo: github.com/KrizRoMe/evaluacion-administracion-web   •   🌐 Web: krizrome.github.io/evaluacion-administracion-web   •   📋 Issues: github.com/KrizRoMe/evaluacion-administracion-web/issues</a:t>
-            </a:r>
-          </a:p>
-        </p:txBody>
-      </p:sp>
-      <p:sp>
-        <p:nvSpPr>
-          <p:cNvPr id="13" name="TextBox 12"/>
+              <a:t>📦 Repo del docente: github.com/KrizRoMe/evaluacion-administracion-web   •   🌐 Sitio público: krizrome.github.io/evaluacion-administracion-web   •   📋 Issues: github.com/KrizRoMe/evaluacion-administracion-web/issues</a:t>
+            </a:r>
+          </a:p>
+        </p:txBody>
+      </p:sp>
+      <p:sp>
+        <p:nvSpPr>
+          <p:cNvPr id="17" name="TextBox 16"/>
           <p:cNvSpPr txBox="1"/>
           <p:nvPr/>
         </p:nvSpPr>
@@ -9891,7 +10506,7 @@
             <a:avLst/>
           </a:prstGeom>
           <a:solidFill>
-            <a:srgbClr val="065A82"/>
+            <a:srgbClr val="EA580C"/>
           </a:solidFill>
           <a:ln>
             <a:noFill/>
@@ -9949,7 +10564,7 @@
                 </a:solidFill>
                 <a:latin typeface="Calibri"/>
               </a:rPr>
-              <a:t>Parte 5 · Documentar solución + README</a:t>
+              <a:t>🔗 Parte 5 · Issue de link-evaluación</a:t>
             </a:r>
           </a:p>
         </p:txBody>
@@ -9980,11 +10595,11 @@
             <a:r>
               <a:rPr sz="1400" b="0">
                 <a:solidFill>
-                  <a:srgbClr val="60A5FA"/>
-                </a:solidFill>
-                <a:latin typeface="Calibri"/>
-              </a:rPr>
-              <a:t>⏱ 25 minutos  •  Sin tocar el código</a:t>
+                  <a:srgbClr val="FED3B6"/>
+                </a:solidFill>
+                <a:latin typeface="Calibri"/>
+              </a:rPr>
+              <a:t>⏱ 5 minutos  •  Cuarta y última Issue (en el repo del docente)</a:t>
             </a:r>
           </a:p>
         </p:txBody>
@@ -9997,18 +10612,18 @@
         </p:nvSpPr>
         <p:spPr>
           <a:xfrm>
-            <a:off x="640080" y="1280160"/>
+            <a:off x="640080" y="1188720"/>
             <a:ext cx="10972800" cy="640080"/>
           </a:xfrm>
           <a:prstGeom prst="roundRect">
             <a:avLst/>
           </a:prstGeom>
           <a:solidFill>
-            <a:srgbClr val="FFF3CD"/>
+            <a:srgbClr val="FEF3E6"/>
           </a:solidFill>
-          <a:ln>
+          <a:ln w="38100">
             <a:solidFill>
-              <a:srgbClr val="E6A23E"/>
+              <a:srgbClr val="EA580C"/>
             </a:solidFill>
           </a:ln>
         </p:spPr>
@@ -10042,8 +10657,8 @@
         </p:nvSpPr>
         <p:spPr>
           <a:xfrm>
-            <a:off x="822960" y="1371600"/>
-            <a:ext cx="10607040" cy="457200"/>
+            <a:off x="822960" y="1280160"/>
+            <a:ext cx="10607040" cy="365760"/>
           </a:xfrm>
           <a:prstGeom prst="rect">
             <a:avLst/>
@@ -10058,13 +10673,13 @@
           <a:p>
             <a:pPr algn="ctr"/>
             <a:r>
-              <a:rPr sz="1400" b="1">
-                <a:solidFill>
-                  <a:srgbClr val="924E0E"/>
-                </a:solidFill>
-                <a:latin typeface="Calibri"/>
-              </a:rPr>
-              <a:t>⚠️  No es necesario aplicar las correcciones en el código. Solo ANALIZAR y PROPONER en texto.</a:t>
+              <a:rPr sz="1500" b="1">
+                <a:solidFill>
+                  <a:srgbClr val="EA580C"/>
+                </a:solidFill>
+                <a:latin typeface="Calibri"/>
+              </a:rPr>
+              <a:t>📋 Esta Issue también se crea en el repo del DOCENTE:</a:t>
             </a:r>
           </a:p>
         </p:txBody>
@@ -10077,7 +10692,7 @@
         </p:nvSpPr>
         <p:spPr>
           <a:xfrm>
-            <a:off x="640080" y="2103120"/>
+            <a:off x="640080" y="2011680"/>
             <a:ext cx="10972800" cy="365760"/>
           </a:xfrm>
           <a:prstGeom prst="rect">
@@ -10093,13 +10708,13 @@
           <a:p>
             <a:pPr algn="l"/>
             <a:r>
-              <a:rPr sz="1600" b="1">
+              <a:rPr sz="1800" b="1">
                 <a:solidFill>
                   <a:srgbClr val="065A82"/>
                 </a:solidFill>
                 <a:latin typeface="Calibri"/>
               </a:rPr>
-              <a:t>En cada Issue, completa la sección Solución propuesta:</a:t>
+              <a:t>Pasos:</a:t>
             </a:r>
           </a:p>
         </p:txBody>
@@ -10112,8 +10727,8 @@
         </p:nvSpPr>
         <p:spPr>
           <a:xfrm>
-            <a:off x="822960" y="2560320"/>
-            <a:ext cx="10972800" cy="1828800"/>
+            <a:off x="822960" y="2423160"/>
+            <a:ext cx="10972800" cy="1097280"/>
           </a:xfrm>
           <a:prstGeom prst="rect">
             <a:avLst/>
@@ -10134,7 +10749,7 @@
                 </a:solidFill>
                 <a:latin typeface="Calibri"/>
               </a:rPr>
-              <a:t>"Agregar atributos width y height a la etiqueta &lt;img&gt; del hero."</a:t>
+              <a:t>1. En el repo del docente, Issues → New issue</a:t>
             </a:r>
           </a:p>
           <a:p>
@@ -10146,7 +10761,7 @@
                 </a:solidFill>
                 <a:latin typeface="Calibri"/>
               </a:rPr>
-              <a:t>"Añadir el atributo defer al &lt;script&gt;."</a:t>
+              <a:t>2. Selecciona el template 🔗 Link de evaluación</a:t>
             </a:r>
           </a:p>
           <a:p>
@@ -10158,7 +10773,7 @@
                 </a:solidFill>
                 <a:latin typeface="Calibri"/>
               </a:rPr>
-              <a:t>"Actualizar jquery a una versión 3.x."</a:t>
+              <a:t>3. Completa: nombre, link de tu repo, link público de tu sitio</a:t>
             </a:r>
           </a:p>
           <a:p>
@@ -10170,19 +10785,7 @@
                 </a:solidFill>
                 <a:latin typeface="Calibri"/>
               </a:rPr>
-              <a:t>"Cambiar el texto del footer por la fecha actual."</a:t>
-            </a:r>
-          </a:p>
-          <a:p>
-            <a:pPr algn="l"/>
-            <a:r>
-              <a:rPr sz="1300" b="0">
-                <a:solidFill>
-                  <a:srgbClr val="2A2A2A"/>
-                </a:solidFill>
-                <a:latin typeface="Calibri"/>
-              </a:rPr>
-              <a:t>"Agregar atributo alt descriptivo a las imágenes."</a:t>
+              <a:t>4. Submit</a:t>
             </a:r>
           </a:p>
         </p:txBody>
@@ -10195,14 +10798,164 @@
         </p:nvSpPr>
         <p:spPr>
           <a:xfrm>
-            <a:off x="640080" y="4572000"/>
-            <a:ext cx="10972800" cy="1737360"/>
+            <a:off x="640080" y="3931920"/>
+            <a:ext cx="10972800" cy="1280160"/>
           </a:xfrm>
           <a:prstGeom prst="roundRect">
             <a:avLst/>
           </a:prstGeom>
           <a:solidFill>
-            <a:srgbClr val="E3F2FD"/>
+            <a:srgbClr val="FEF3E6"/>
+          </a:solidFill>
+          <a:ln w="38100">
+            <a:solidFill>
+              <a:srgbClr val="EA580C"/>
+            </a:solidFill>
+          </a:ln>
+        </p:spPr>
+        <p:style>
+          <a:lnRef idx="1">
+            <a:schemeClr val="accent1"/>
+          </a:lnRef>
+          <a:fillRef idx="3">
+            <a:schemeClr val="accent1"/>
+          </a:fillRef>
+          <a:effectRef idx="2">
+            <a:schemeClr val="accent1"/>
+          </a:effectRef>
+          <a:fontRef idx="minor">
+            <a:schemeClr val="lt1"/>
+          </a:fontRef>
+        </p:style>
+        <p:txBody>
+          <a:bodyPr rtlCol="0" anchor="ctr"/>
+          <a:lstStyle/>
+          <a:p>
+            <a:pPr algn="ctr"/>
+          </a:p>
+        </p:txBody>
+      </p:sp>
+      <p:sp>
+        <p:nvSpPr>
+          <p:cNvPr id="11" name="TextBox 10"/>
+          <p:cNvSpPr txBox="1"/>
+          <p:nvPr/>
+        </p:nvSpPr>
+        <p:spPr>
+          <a:xfrm>
+            <a:off x="822960" y="4023360"/>
+            <a:ext cx="10607040" cy="365760"/>
+          </a:xfrm>
+          <a:prstGeom prst="rect">
+            <a:avLst/>
+          </a:prstGeom>
+          <a:noFill/>
+        </p:spPr>
+        <p:txBody>
+          <a:bodyPr wrap="square">
+            <a:spAutoFit/>
+          </a:bodyPr>
+          <a:lstStyle/>
+          <a:p>
+            <a:pPr algn="ctr"/>
+            <a:r>
+              <a:rPr sz="1400" b="1">
+                <a:solidFill>
+                  <a:srgbClr val="EA580C"/>
+                </a:solidFill>
+                <a:latin typeface="Calibri"/>
+              </a:rPr>
+              <a:t>🔗 LINK DIRECTO para publicar tu repo + sitio público:</a:t>
+            </a:r>
+          </a:p>
+        </p:txBody>
+      </p:sp>
+      <p:sp>
+        <p:nvSpPr>
+          <p:cNvPr id="12" name="TextBox 11"/>
+          <p:cNvSpPr txBox="1"/>
+          <p:nvPr/>
+        </p:nvSpPr>
+        <p:spPr>
+          <a:xfrm>
+            <a:off x="822960" y="4434840"/>
+            <a:ext cx="10607040" cy="457200"/>
+          </a:xfrm>
+          <a:prstGeom prst="rect">
+            <a:avLst/>
+          </a:prstGeom>
+          <a:noFill/>
+        </p:spPr>
+        <p:txBody>
+          <a:bodyPr wrap="square">
+            <a:spAutoFit/>
+          </a:bodyPr>
+          <a:lstStyle/>
+          <a:p>
+            <a:pPr algn="ctr"/>
+            <a:r>
+              <a:rPr sz="1400" b="1">
+                <a:solidFill>
+                  <a:srgbClr val="2A2A2A"/>
+                </a:solidFill>
+                <a:latin typeface="Consolas"/>
+              </a:rPr>
+              <a:t>https://github.com/KrizRoMe/evaluacion-administracion-web/issues/new?template=link-evaluacion.yml</a:t>
+            </a:r>
+          </a:p>
+        </p:txBody>
+      </p:sp>
+      <p:sp>
+        <p:nvSpPr>
+          <p:cNvPr id="13" name="TextBox 12"/>
+          <p:cNvSpPr txBox="1"/>
+          <p:nvPr/>
+        </p:nvSpPr>
+        <p:spPr>
+          <a:xfrm>
+            <a:off x="822960" y="4846320"/>
+            <a:ext cx="10607040" cy="274320"/>
+          </a:xfrm>
+          <a:prstGeom prst="rect">
+            <a:avLst/>
+          </a:prstGeom>
+          <a:noFill/>
+        </p:spPr>
+        <p:txBody>
+          <a:bodyPr wrap="square">
+            <a:spAutoFit/>
+          </a:bodyPr>
+          <a:lstStyle/>
+          <a:p>
+            <a:pPr algn="ctr"/>
+            <a:r>
+              <a:rPr sz="1000" b="0">
+                <a:solidFill>
+                  <a:srgbClr val="999999"/>
+                </a:solidFill>
+                <a:latin typeface="Calibri"/>
+              </a:rPr>
+              <a:t>(también lo encuentras en la pestaña Issues del repo del docente)</a:t>
+            </a:r>
+          </a:p>
+        </p:txBody>
+      </p:sp>
+      <p:sp>
+        <p:nvSpPr>
+          <p:cNvPr id="14" name="Rounded Rectangle 13"/>
+          <p:cNvSpPr/>
+          <p:nvPr/>
+        </p:nvSpPr>
+        <p:spPr>
+          <a:xfrm>
+            <a:off x="640080" y="5394960"/>
+            <a:ext cx="10972800" cy="914400"/>
+          </a:xfrm>
+          <a:prstGeom prst="roundRect">
+            <a:avLst/>
+          </a:prstGeom>
+          <a:solidFill>
+            <a:srgbClr val="F4F4F4"/>
           </a:solidFill>
           <a:ln>
             <a:solidFill>
@@ -10234,13 +10987,13 @@
       </p:sp>
       <p:sp>
         <p:nvSpPr>
-          <p:cNvPr id="11" name="TextBox 10"/>
-          <p:cNvSpPr txBox="1"/>
-          <p:nvPr/>
-        </p:nvSpPr>
-        <p:spPr>
-          <a:xfrm>
-            <a:off x="822960" y="4617720"/>
+          <p:cNvPr id="15" name="TextBox 14"/>
+          <p:cNvSpPr txBox="1"/>
+          <p:nvPr/>
+        </p:nvSpPr>
+        <p:spPr>
+          <a:xfrm>
+            <a:off x="822960" y="5440680"/>
             <a:ext cx="10607040" cy="274320"/>
           </a:xfrm>
           <a:prstGeom prst="rect">
@@ -10256,27 +11009,27 @@
           <a:p>
             <a:pPr algn="l"/>
             <a:r>
-              <a:rPr sz="1400" b="1">
+              <a:rPr sz="1300" b="1">
                 <a:solidFill>
                   <a:srgbClr val="065A82"/>
                 </a:solidFill>
                 <a:latin typeface="Calibri"/>
               </a:rPr>
-              <a:t>📚 README debe incluir:</a:t>
-            </a:r>
-          </a:p>
-        </p:txBody>
-      </p:sp>
-      <p:sp>
-        <p:nvSpPr>
-          <p:cNvPr id="12" name="TextBox 11"/>
-          <p:cNvSpPr txBox="1"/>
-          <p:nvPr/>
-        </p:nvSpPr>
-        <p:spPr>
-          <a:xfrm>
-            <a:off x="914400" y="4937760"/>
-            <a:ext cx="10424160" cy="1371600"/>
+              <a:t>La Issue de link-evaluación te pide SOLO:</a:t>
+            </a:r>
+          </a:p>
+        </p:txBody>
+      </p:sp>
+      <p:sp>
+        <p:nvSpPr>
+          <p:cNvPr id="16" name="TextBox 15"/>
+          <p:cNvSpPr txBox="1"/>
+          <p:nvPr/>
+        </p:nvSpPr>
+        <p:spPr>
+          <a:xfrm>
+            <a:off x="1005840" y="5760720"/>
+            <a:ext cx="10424160" cy="548640"/>
           </a:xfrm>
           <a:prstGeom prst="rect">
             <a:avLst/>
@@ -10297,14 +11050,14 @@
                 </a:solidFill>
                 <a:latin typeface="Calibri"/>
               </a:rPr>
-              <a:t>VIVO · RÁPIDO (con LCP/INP/CLS/TTFB) · SEGURO (2 acciones) · Backup 3-2-1 · SLI · SLO · SLA · Runbook (4–6 pasos) · Datos del estudiante + URLs</a:t>
-            </a:r>
-          </a:p>
-        </p:txBody>
-      </p:sp>
-      <p:sp>
-        <p:nvSpPr>
-          <p:cNvPr id="13" name="TextBox 12"/>
+              <a:t>• Nombre completo  •  Link de tu repositorio  •  Link público de tu sitio</a:t>
+            </a:r>
+          </a:p>
+        </p:txBody>
+      </p:sp>
+      <p:sp>
+        <p:nvSpPr>
+          <p:cNvPr id="17" name="TextBox 16"/>
           <p:cNvSpPr txBox="1"/>
           <p:nvPr/>
         </p:nvSpPr>
@@ -10332,14 +11085,14 @@
                 </a:solidFill>
                 <a:latin typeface="Calibri"/>
               </a:rPr>
-              <a:t>📦 Repo: github.com/KrizRoMe/evaluacion-administracion-web   •   🌐 Web: krizrome.github.io/evaluacion-administracion-web   •   📋 Issues: github.com/KrizRoMe/evaluacion-administracion-web/issues</a:t>
-            </a:r>
-          </a:p>
-        </p:txBody>
-      </p:sp>
-      <p:sp>
-        <p:nvSpPr>
-          <p:cNvPr id="14" name="TextBox 13"/>
+              <a:t>📦 Repo del docente: github.com/KrizRoMe/evaluacion-administracion-web   •   🌐 Sitio público: krizrome.github.io/evaluacion-administracion-web   •   📋 Issues: github.com/KrizRoMe/evaluacion-administracion-web/issues</a:t>
+            </a:r>
+          </a:p>
+        </p:txBody>
+      </p:sp>
+      <p:sp>
+        <p:nvSpPr>
+          <p:cNvPr id="18" name="TextBox 17"/>
           <p:cNvSpPr txBox="1"/>
           <p:nvPr/>
         </p:nvSpPr>

</xml_diff>

<commit_message>
feat(parte1): 4 pasos con git puro (sin gh CLI)
Slide 5 actualizada:
1. Clonar el repo del docente
2. Verificar localmente (abrir index.html)
3. Crear repo personal manual (github.com/new)
4. Conectar y subir con git (remote add + push)

Sin 'gh repo create'. Solo git puro.

Markdown sincronizado, instrucciones y checklist actualizados.
</commit_message>
<xml_diff>
--- a/EVALUACION_PRACTICA_01.pptx
+++ b/EVALUACION_PRACTICA_01.pptx
@@ -7629,7 +7629,7 @@
                 </a:solidFill>
                 <a:latin typeface="Calibri"/>
               </a:rPr>
-              <a:t>Parte 1 · Crear tu repositorio</a:t>
+              <a:t>Parte 1 · Clonar, verificar y subir</a:t>
             </a:r>
           </a:p>
         </p:txBody>
@@ -7664,21 +7664,56 @@
                 </a:solidFill>
                 <a:latin typeface="Calibri"/>
               </a:rPr>
-              <a:t>⏱ 10 minutos</a:t>
-            </a:r>
-          </a:p>
-        </p:txBody>
-      </p:sp>
-      <p:sp>
-        <p:nvSpPr>
-          <p:cNvPr id="6" name="Rounded Rectangle 5"/>
+              <a:t>⏱ 10 minutos  •  Solo git (sin gh CLI)</a:t>
+            </a:r>
+          </a:p>
+        </p:txBody>
+      </p:sp>
+      <p:sp>
+        <p:nvSpPr>
+          <p:cNvPr id="6" name="TextBox 5"/>
+          <p:cNvSpPr txBox="1"/>
+          <p:nvPr/>
+        </p:nvSpPr>
+        <p:spPr>
+          <a:xfrm>
+            <a:off x="640080" y="1188720"/>
+            <a:ext cx="10972800" cy="365760"/>
+          </a:xfrm>
+          <a:prstGeom prst="rect">
+            <a:avLst/>
+          </a:prstGeom>
+          <a:noFill/>
+        </p:spPr>
+        <p:txBody>
+          <a:bodyPr wrap="square">
+            <a:spAutoFit/>
+          </a:bodyPr>
+          <a:lstStyle/>
+          <a:p>
+            <a:pPr algn="l"/>
+            <a:r>
+              <a:rPr sz="1800" b="1">
+                <a:solidFill>
+                  <a:srgbClr val="065A82"/>
+                </a:solidFill>
+                <a:latin typeface="Calibri"/>
+              </a:rPr>
+              <a:t>1️⃣  Clonar el repositorio del docente</a:t>
+            </a:r>
+          </a:p>
+        </p:txBody>
+      </p:sp>
+      <p:sp>
+        <p:nvSpPr>
+          <p:cNvPr id="7" name="Rounded Rectangle 6"/>
           <p:cNvSpPr/>
           <p:nvPr/>
         </p:nvSpPr>
         <p:spPr>
           <a:xfrm>
-            <a:off x="640080" y="1280160"/>
-            <a:ext cx="7772400" cy="4114800"/>
+            <a:off x="640080" y="1554480"/>
+            <a:ext cx="10972800" cy="594360"/>
           </a:xfrm>
           <a:prstGeom prst="roundRect">
             <a:avLst/>
@@ -7716,37 +7751,60 @@
       </p:sp>
       <p:sp>
         <p:nvSpPr>
-          <p:cNvPr id="7" name="TextBox 6"/>
-          <p:cNvSpPr txBox="1"/>
-          <p:nvPr/>
-        </p:nvSpPr>
-        <p:spPr>
-          <a:xfrm>
-            <a:off x="822960" y="1417320"/>
-            <a:ext cx="7498079" cy="3840480"/>
-          </a:xfrm>
-          <a:prstGeom prst="rect">
-            <a:avLst/>
-          </a:prstGeom>
-          <a:noFill/>
-        </p:spPr>
-        <p:txBody>
-          <a:bodyPr wrap="square">
-            <a:spAutoFit/>
-          </a:bodyPr>
-          <a:lstStyle/>
-          <a:p>
-            <a:pPr algn="l"/>
-            <a:r>
-              <a:rPr sz="1400" b="1">
+          <p:cNvPr id="8" name="TextBox 7"/>
+          <p:cNvSpPr txBox="1"/>
+          <p:nvPr/>
+        </p:nvSpPr>
+        <p:spPr>
+          <a:xfrm>
+            <a:off x="822960" y="1627632"/>
+            <a:ext cx="10607040" cy="457200"/>
+          </a:xfrm>
+          <a:prstGeom prst="rect">
+            <a:avLst/>
+          </a:prstGeom>
+          <a:noFill/>
+        </p:spPr>
+        <p:txBody>
+          <a:bodyPr wrap="square">
+            <a:spAutoFit/>
+          </a:bodyPr>
+          <a:lstStyle/>
+          <a:p>
+            <a:pPr algn="l"/>
+            <a:r>
+              <a:rPr sz="1400" b="0">
                 <a:solidFill>
                   <a:srgbClr val="FFFFFF"/>
                 </a:solidFill>
-                <a:latin typeface="Calibri"/>
-              </a:rPr>
-              <a:t>Con gh CLI (recomendado):</a:t>
-            </a:r>
-          </a:p>
+                <a:latin typeface="Consolas"/>
+              </a:rPr>
+              <a:t>$ git clone https://github.com/KrizRoMe/evaluacion-administracion-web.git</a:t>
+            </a:r>
+          </a:p>
+        </p:txBody>
+      </p:sp>
+      <p:sp>
+        <p:nvSpPr>
+          <p:cNvPr id="9" name="TextBox 8"/>
+          <p:cNvSpPr txBox="1"/>
+          <p:nvPr/>
+        </p:nvSpPr>
+        <p:spPr>
+          <a:xfrm>
+            <a:off x="822960" y="1920240"/>
+            <a:ext cx="10607040" cy="274320"/>
+          </a:xfrm>
+          <a:prstGeom prst="rect">
+            <a:avLst/>
+          </a:prstGeom>
+          <a:noFill/>
+        </p:spPr>
+        <p:txBody>
+          <a:bodyPr wrap="square">
+            <a:spAutoFit/>
+          </a:bodyPr>
+          <a:lstStyle/>
           <a:p>
             <a:pPr algn="l"/>
             <a:r>
@@ -7754,244 +7812,354 @@
                 <a:solidFill>
                   <a:srgbClr val="FFFFFF"/>
                 </a:solidFill>
-                <a:latin typeface="Calibri"/>
-              </a:rPr>
-              <a:t>$ git init</a:t>
-            </a:r>
-          </a:p>
-          <a:p>
-            <a:pPr algn="l"/>
-            <a:r>
-              <a:rPr sz="1400" b="0">
-                <a:solidFill>
-                  <a:srgbClr val="FFFFFF"/>
-                </a:solidFill>
-                <a:latin typeface="Calibri"/>
-              </a:rPr>
-              <a:t>$ git add .</a:t>
-            </a:r>
-          </a:p>
-          <a:p>
-            <a:pPr algn="l"/>
-            <a:r>
-              <a:rPr sz="1400" b="0">
-                <a:solidFill>
-                  <a:srgbClr val="FFFFFF"/>
-                </a:solidFill>
-                <a:latin typeface="Calibri"/>
-              </a:rPr>
-              <a:t>$ git commit -m "feat: inicio de evaluación"</a:t>
-            </a:r>
-          </a:p>
-          <a:p>
-            <a:pPr algn="l"/>
-            <a:r>
-              <a:rPr sz="1400" b="0">
-                <a:solidFill>
-                  <a:srgbClr val="FFFFFF"/>
-                </a:solidFill>
-                <a:latin typeface="Calibri"/>
-              </a:rPr>
-              <a:t>$ gh repo create evaluacion-administracion-web-TU-NOMBRE \</a:t>
-            </a:r>
-          </a:p>
-          <a:p>
-            <a:pPr algn="l"/>
-            <a:r>
-              <a:rPr sz="1400" b="0">
-                <a:solidFill>
-                  <a:srgbClr val="FFFFFF"/>
-                </a:solidFill>
-                <a:latin typeface="Calibri"/>
-              </a:rPr>
-              <a:t>    --public --source=. --remote=origin --push</a:t>
-            </a:r>
-          </a:p>
-          <a:p>
-            <a:pPr algn="l"/>
-            <a:r>
-              <a:rPr sz="1400" b="0">
-                <a:solidFill>
-                  <a:srgbClr val="FFFFFF"/>
-                </a:solidFill>
-                <a:latin typeface="Calibri"/>
-              </a:rPr>
-              <a:t/>
-            </a:r>
-          </a:p>
-          <a:p>
-            <a:pPr algn="l"/>
-            <a:r>
-              <a:rPr sz="1400" b="1">
-                <a:solidFill>
-                  <a:srgbClr val="FFFFFF"/>
-                </a:solidFill>
-                <a:latin typeface="Calibri"/>
-              </a:rPr>
-              <a:t>Alternativa con git directo:</a:t>
-            </a:r>
-          </a:p>
-          <a:p>
-            <a:pPr algn="l"/>
-            <a:r>
-              <a:rPr sz="1400" b="0">
-                <a:solidFill>
-                  <a:srgbClr val="FFFFFF"/>
-                </a:solidFill>
-                <a:latin typeface="Calibri"/>
-              </a:rPr>
-              <a:t>$ git remote add origin https://github.com/TU-USUARIO/...</a:t>
-            </a:r>
-          </a:p>
-          <a:p>
-            <a:pPr algn="l"/>
-            <a:r>
-              <a:rPr sz="1400" b="0">
-                <a:solidFill>
-                  <a:srgbClr val="FFFFFF"/>
-                </a:solidFill>
-                <a:latin typeface="Calibri"/>
-              </a:rPr>
-              <a:t>$ git branch -M main</a:t>
-            </a:r>
-          </a:p>
-          <a:p>
-            <a:pPr algn="l"/>
-            <a:r>
-              <a:rPr sz="1400" b="0">
-                <a:solidFill>
-                  <a:srgbClr val="FFFFFF"/>
-                </a:solidFill>
-                <a:latin typeface="Calibri"/>
-              </a:rPr>
-              <a:t>$ git push -u origin main</a:t>
-            </a:r>
-          </a:p>
-        </p:txBody>
-      </p:sp>
-      <p:sp>
-        <p:nvSpPr>
-          <p:cNvPr id="8" name="TextBox 7"/>
-          <p:cNvSpPr txBox="1"/>
-          <p:nvPr/>
-        </p:nvSpPr>
-        <p:spPr>
-          <a:xfrm>
-            <a:off x="8686800" y="1280160"/>
-            <a:ext cx="3200400" cy="4114800"/>
-          </a:xfrm>
-          <a:prstGeom prst="rect">
-            <a:avLst/>
-          </a:prstGeom>
-          <a:noFill/>
-        </p:spPr>
-        <p:txBody>
-          <a:bodyPr wrap="square">
-            <a:spAutoFit/>
-          </a:bodyPr>
-          <a:lstStyle/>
-          <a:p>
-            <a:pPr algn="l"/>
-            <a:r>
-              <a:rPr sz="1400" b="1">
+                <a:latin typeface="Consolas"/>
+              </a:rPr>
+              <a:t>$ cd evaluacion-administracion-web</a:t>
+            </a:r>
+          </a:p>
+        </p:txBody>
+      </p:sp>
+      <p:sp>
+        <p:nvSpPr>
+          <p:cNvPr id="10" name="TextBox 9"/>
+          <p:cNvSpPr txBox="1"/>
+          <p:nvPr/>
+        </p:nvSpPr>
+        <p:spPr>
+          <a:xfrm>
+            <a:off x="640080" y="2377440"/>
+            <a:ext cx="10972800" cy="365760"/>
+          </a:xfrm>
+          <a:prstGeom prst="rect">
+            <a:avLst/>
+          </a:prstGeom>
+          <a:noFill/>
+        </p:spPr>
+        <p:txBody>
+          <a:bodyPr wrap="square">
+            <a:spAutoFit/>
+          </a:bodyPr>
+          <a:lstStyle/>
+          <a:p>
+            <a:pPr algn="l"/>
+            <a:r>
+              <a:rPr sz="1800" b="1">
+                <a:solidFill>
+                  <a:srgbClr val="065A82"/>
+                </a:solidFill>
+                <a:latin typeface="Calibri"/>
+              </a:rPr>
+              <a:t>2️⃣  Verificar que el sitio funciona localmente</a:t>
+            </a:r>
+          </a:p>
+        </p:txBody>
+      </p:sp>
+      <p:sp>
+        <p:nvSpPr>
+          <p:cNvPr id="11" name="Rounded Rectangle 10"/>
+          <p:cNvSpPr/>
+          <p:nvPr/>
+        </p:nvSpPr>
+        <p:spPr>
+          <a:xfrm>
+            <a:off x="640080" y="2743200"/>
+            <a:ext cx="10972800" cy="777240"/>
+          </a:xfrm>
+          <a:prstGeom prst="roundRect">
+            <a:avLst/>
+          </a:prstGeom>
+          <a:solidFill>
+            <a:srgbClr val="E6F7F1"/>
+          </a:solidFill>
+          <a:ln>
+            <a:solidFill>
+              <a:srgbClr val="10B981"/>
+            </a:solidFill>
+          </a:ln>
+        </p:spPr>
+        <p:style>
+          <a:lnRef idx="1">
+            <a:schemeClr val="accent1"/>
+          </a:lnRef>
+          <a:fillRef idx="3">
+            <a:schemeClr val="accent1"/>
+          </a:fillRef>
+          <a:effectRef idx="2">
+            <a:schemeClr val="accent1"/>
+          </a:effectRef>
+          <a:fontRef idx="minor">
+            <a:schemeClr val="lt1"/>
+          </a:fontRef>
+        </p:style>
+        <p:txBody>
+          <a:bodyPr rtlCol="0" anchor="ctr"/>
+          <a:lstStyle/>
+          <a:p>
+            <a:pPr algn="ctr"/>
+          </a:p>
+        </p:txBody>
+      </p:sp>
+      <p:sp>
+        <p:nvSpPr>
+          <p:cNvPr id="12" name="TextBox 11"/>
+          <p:cNvSpPr txBox="1"/>
+          <p:nvPr/>
+        </p:nvSpPr>
+        <p:spPr>
+          <a:xfrm>
+            <a:off x="822960" y="2788920"/>
+            <a:ext cx="10607040" cy="685800"/>
+          </a:xfrm>
+          <a:prstGeom prst="rect">
+            <a:avLst/>
+          </a:prstGeom>
+          <a:noFill/>
+        </p:spPr>
+        <p:txBody>
+          <a:bodyPr wrap="square">
+            <a:spAutoFit/>
+          </a:bodyPr>
+          <a:lstStyle/>
+          <a:p>
+            <a:pPr algn="l"/>
+            <a:r>
+              <a:rPr sz="1300" b="0">
                 <a:solidFill>
                   <a:srgbClr val="2A2A2A"/>
                 </a:solidFill>
                 <a:latin typeface="Calibri"/>
               </a:rPr>
-              <a:t>✅ Resultado esperado</a:t>
-            </a:r>
-          </a:p>
-          <a:p>
-            <a:pPr algn="l"/>
-            <a:r>
-              <a:rPr sz="1400" b="0">
+              <a:t>Doble clic en index.html  •  O arrastrar al navegador  •  Debe verse la tienda ECOMARKET</a:t>
+            </a:r>
+          </a:p>
+          <a:p>
+            <a:pPr algn="l"/>
+            <a:r>
+              <a:rPr sz="1300" b="0">
                 <a:solidFill>
                   <a:srgbClr val="2A2A2A"/>
                 </a:solidFill>
                 <a:latin typeface="Calibri"/>
               </a:rPr>
-              <a:t>• Repositorio público</a:t>
-            </a:r>
-          </a:p>
-          <a:p>
-            <a:pPr algn="l"/>
-            <a:r>
-              <a:rPr sz="1400" b="0">
+              <a:t>Si ves los productos, el carrito y el modo oscuro → todo funciona ✓</a:t>
+            </a:r>
+          </a:p>
+        </p:txBody>
+      </p:sp>
+      <p:sp>
+        <p:nvSpPr>
+          <p:cNvPr id="13" name="TextBox 12"/>
+          <p:cNvSpPr txBox="1"/>
+          <p:nvPr/>
+        </p:nvSpPr>
+        <p:spPr>
+          <a:xfrm>
+            <a:off x="640080" y="3703320"/>
+            <a:ext cx="10972800" cy="365760"/>
+          </a:xfrm>
+          <a:prstGeom prst="rect">
+            <a:avLst/>
+          </a:prstGeom>
+          <a:noFill/>
+        </p:spPr>
+        <p:txBody>
+          <a:bodyPr wrap="square">
+            <a:spAutoFit/>
+          </a:bodyPr>
+          <a:lstStyle/>
+          <a:p>
+            <a:pPr algn="l"/>
+            <a:r>
+              <a:rPr sz="1800" b="1">
+                <a:solidFill>
+                  <a:srgbClr val="065A82"/>
+                </a:solidFill>
+                <a:latin typeface="Calibri"/>
+              </a:rPr>
+              <a:t>3️⃣  Crear tu repositorio personal (manual, en la web)</a:t>
+            </a:r>
+          </a:p>
+        </p:txBody>
+      </p:sp>
+      <p:sp>
+        <p:nvSpPr>
+          <p:cNvPr id="14" name="Rounded Rectangle 13"/>
+          <p:cNvSpPr/>
+          <p:nvPr/>
+        </p:nvSpPr>
+        <p:spPr>
+          <a:xfrm>
+            <a:off x="640080" y="4069080"/>
+            <a:ext cx="10972800" cy="1371600"/>
+          </a:xfrm>
+          <a:prstGeom prst="roundRect">
+            <a:avLst/>
+          </a:prstGeom>
+          <a:solidFill>
+            <a:srgbClr val="FEF3E6"/>
+          </a:solidFill>
+          <a:ln>
+            <a:solidFill>
+              <a:srgbClr val="EA580C"/>
+            </a:solidFill>
+          </a:ln>
+        </p:spPr>
+        <p:style>
+          <a:lnRef idx="1">
+            <a:schemeClr val="accent1"/>
+          </a:lnRef>
+          <a:fillRef idx="3">
+            <a:schemeClr val="accent1"/>
+          </a:fillRef>
+          <a:effectRef idx="2">
+            <a:schemeClr val="accent1"/>
+          </a:effectRef>
+          <a:fontRef idx="minor">
+            <a:schemeClr val="lt1"/>
+          </a:fontRef>
+        </p:style>
+        <p:txBody>
+          <a:bodyPr rtlCol="0" anchor="ctr"/>
+          <a:lstStyle/>
+          <a:p>
+            <a:pPr algn="ctr"/>
+          </a:p>
+        </p:txBody>
+      </p:sp>
+      <p:sp>
+        <p:nvSpPr>
+          <p:cNvPr id="15" name="TextBox 14"/>
+          <p:cNvSpPr txBox="1"/>
+          <p:nvPr/>
+        </p:nvSpPr>
+        <p:spPr>
+          <a:xfrm>
+            <a:off x="822960" y="4114800"/>
+            <a:ext cx="10607040" cy="1280160"/>
+          </a:xfrm>
+          <a:prstGeom prst="rect">
+            <a:avLst/>
+          </a:prstGeom>
+          <a:noFill/>
+        </p:spPr>
+        <p:txBody>
+          <a:bodyPr wrap="square">
+            <a:spAutoFit/>
+          </a:bodyPr>
+          <a:lstStyle/>
+          <a:p>
+            <a:pPr algn="l"/>
+            <a:r>
+              <a:rPr sz="1200" b="0">
                 <a:solidFill>
                   <a:srgbClr val="2A2A2A"/>
                 </a:solidFill>
                 <a:latin typeface="Calibri"/>
               </a:rPr>
-              <a:t>• Código del sitio subido</a:t>
-            </a:r>
-          </a:p>
-          <a:p>
-            <a:pPr algn="l"/>
-            <a:r>
-              <a:rPr sz="1400" b="0">
+              <a:t>1. Abre https://github.com/new en tu navegador</a:t>
+            </a:r>
+          </a:p>
+          <a:p>
+            <a:pPr algn="l"/>
+            <a:r>
+              <a:rPr sz="1200" b="0">
                 <a:solidFill>
                   <a:srgbClr val="2A2A2A"/>
                 </a:solidFill>
                 <a:latin typeface="Calibri"/>
               </a:rPr>
-              <a:t>• Commit inicial realizado</a:t>
-            </a:r>
-          </a:p>
-          <a:p>
-            <a:pPr algn="l"/>
-            <a:r>
-              <a:rPr sz="1400" b="0">
+              <a:t>2. Repository name:  evaluacion-administracion-web-TU-NOMBRE</a:t>
+            </a:r>
+          </a:p>
+          <a:p>
+            <a:pPr algn="l"/>
+            <a:r>
+              <a:rPr sz="1200" b="0">
                 <a:solidFill>
                   <a:srgbClr val="2A2A2A"/>
                 </a:solidFill>
                 <a:latin typeface="Calibri"/>
               </a:rPr>
-              <a:t/>
-            </a:r>
-          </a:p>
-          <a:p>
-            <a:pPr algn="l"/>
-            <a:r>
-              <a:rPr sz="1400" b="1">
+              <a:t>3. Visibility:  Public</a:t>
+            </a:r>
+          </a:p>
+          <a:p>
+            <a:pPr algn="l"/>
+            <a:r>
+              <a:rPr sz="1200" b="0">
                 <a:solidFill>
                   <a:srgbClr val="2A2A2A"/>
                 </a:solidFill>
                 <a:latin typeface="Calibri"/>
               </a:rPr>
-              <a:t>📌 Nombre sugerido</a:t>
-            </a:r>
-          </a:p>
-          <a:p>
-            <a:pPr algn="l"/>
-            <a:r>
-              <a:rPr sz="1400" b="0">
+              <a:t>4. NO inicialices con README, .gitignore ni license (déjalo vacío)</a:t>
+            </a:r>
+          </a:p>
+          <a:p>
+            <a:pPr algn="l"/>
+            <a:r>
+              <a:rPr sz="1200" b="0">
                 <a:solidFill>
                   <a:srgbClr val="2A2A2A"/>
                 </a:solidFill>
                 <a:latin typeface="Calibri"/>
               </a:rPr>
-              <a:t>evaluacion-administracion-web-TU-NOMBRE</a:t>
-            </a:r>
-          </a:p>
-        </p:txBody>
-      </p:sp>
-      <p:sp>
-        <p:nvSpPr>
-          <p:cNvPr id="9" name="Rounded Rectangle 8"/>
+              <a:t>5. Clic en Create repository  →  Copia la URL HTTPS que te muestra</a:t>
+            </a:r>
+          </a:p>
+        </p:txBody>
+      </p:sp>
+      <p:sp>
+        <p:nvSpPr>
+          <p:cNvPr id="16" name="TextBox 15"/>
+          <p:cNvSpPr txBox="1"/>
+          <p:nvPr/>
+        </p:nvSpPr>
+        <p:spPr>
+          <a:xfrm>
+            <a:off x="640080" y="5623560"/>
+            <a:ext cx="10972800" cy="365760"/>
+          </a:xfrm>
+          <a:prstGeom prst="rect">
+            <a:avLst/>
+          </a:prstGeom>
+          <a:noFill/>
+        </p:spPr>
+        <p:txBody>
+          <a:bodyPr wrap="square">
+            <a:spAutoFit/>
+          </a:bodyPr>
+          <a:lstStyle/>
+          <a:p>
+            <a:pPr algn="l"/>
+            <a:r>
+              <a:rPr sz="1800" b="1">
+                <a:solidFill>
+                  <a:srgbClr val="065A82"/>
+                </a:solidFill>
+                <a:latin typeface="Calibri"/>
+              </a:rPr>
+              <a:t>4️⃣  Conectar y subir con git puro</a:t>
+            </a:r>
+          </a:p>
+        </p:txBody>
+      </p:sp>
+      <p:sp>
+        <p:nvSpPr>
+          <p:cNvPr id="17" name="Rounded Rectangle 16"/>
           <p:cNvSpPr/>
           <p:nvPr/>
         </p:nvSpPr>
         <p:spPr>
           <a:xfrm>
-            <a:off x="640080" y="5669280"/>
-            <a:ext cx="10972800" cy="548640"/>
+            <a:off x="640080" y="5989320"/>
+            <a:ext cx="10972800" cy="777240"/>
           </a:xfrm>
           <a:prstGeom prst="roundRect">
             <a:avLst/>
           </a:prstGeom>
           <a:solidFill>
-            <a:srgbClr val="F4F4F4"/>
+            <a:srgbClr val="2A2A2A"/>
           </a:solidFill>
           <a:ln>
             <a:solidFill>
@@ -8023,105 +8191,140 @@
       </p:sp>
       <p:sp>
         <p:nvSpPr>
-          <p:cNvPr id="10" name="TextBox 9"/>
-          <p:cNvSpPr txBox="1"/>
-          <p:nvPr/>
-        </p:nvSpPr>
-        <p:spPr>
-          <a:xfrm>
-            <a:off x="640080" y="5760720"/>
-            <a:ext cx="10972800" cy="365760"/>
-          </a:xfrm>
-          <a:prstGeom prst="rect">
-            <a:avLst/>
-          </a:prstGeom>
-          <a:noFill/>
-        </p:spPr>
-        <p:txBody>
-          <a:bodyPr wrap="square">
-            <a:spAutoFit/>
-          </a:bodyPr>
-          <a:lstStyle/>
-          <a:p>
-            <a:pPr algn="ctr"/>
-            <a:r>
-              <a:rPr sz="1400" b="1">
-                <a:solidFill>
-                  <a:srgbClr val="065A82"/>
+          <p:cNvPr id="18" name="TextBox 17"/>
+          <p:cNvSpPr txBox="1"/>
+          <p:nvPr/>
+        </p:nvSpPr>
+        <p:spPr>
+          <a:xfrm>
+            <a:off x="822960" y="6035040"/>
+            <a:ext cx="10607040" cy="274320"/>
+          </a:xfrm>
+          <a:prstGeom prst="rect">
+            <a:avLst/>
+          </a:prstGeom>
+          <a:noFill/>
+        </p:spPr>
+        <p:txBody>
+          <a:bodyPr wrap="square">
+            <a:spAutoFit/>
+          </a:bodyPr>
+          <a:lstStyle/>
+          <a:p>
+            <a:pPr algn="l"/>
+            <a:r>
+              <a:rPr sz="1100" b="0">
+                <a:solidFill>
+                  <a:srgbClr val="FFFFFF"/>
+                </a:solidFill>
+                <a:latin typeface="Consolas"/>
+              </a:rPr>
+              <a:t>$ git remote add origin https://github.com/TU-USUARIO/evaluacion-administracion-web-TU-NOMBRE.git</a:t>
+            </a:r>
+          </a:p>
+        </p:txBody>
+      </p:sp>
+      <p:sp>
+        <p:nvSpPr>
+          <p:cNvPr id="19" name="TextBox 18"/>
+          <p:cNvSpPr txBox="1"/>
+          <p:nvPr/>
+        </p:nvSpPr>
+        <p:spPr>
+          <a:xfrm>
+            <a:off x="822960" y="6309360"/>
+            <a:ext cx="10607040" cy="274320"/>
+          </a:xfrm>
+          <a:prstGeom prst="rect">
+            <a:avLst/>
+          </a:prstGeom>
+          <a:noFill/>
+        </p:spPr>
+        <p:txBody>
+          <a:bodyPr wrap="square">
+            <a:spAutoFit/>
+          </a:bodyPr>
+          <a:lstStyle/>
+          <a:p>
+            <a:pPr algn="l"/>
+            <a:r>
+              <a:rPr sz="1200" b="0">
+                <a:solidFill>
+                  <a:srgbClr val="FFFFFF"/>
+                </a:solidFill>
+                <a:latin typeface="Consolas"/>
+              </a:rPr>
+              <a:t>$ git branch -M main</a:t>
+            </a:r>
+          </a:p>
+        </p:txBody>
+      </p:sp>
+      <p:sp>
+        <p:nvSpPr>
+          <p:cNvPr id="20" name="TextBox 19"/>
+          <p:cNvSpPr txBox="1"/>
+          <p:nvPr/>
+        </p:nvSpPr>
+        <p:spPr>
+          <a:xfrm>
+            <a:off x="822960" y="6537960"/>
+            <a:ext cx="10607040" cy="274320"/>
+          </a:xfrm>
+          <a:prstGeom prst="rect">
+            <a:avLst/>
+          </a:prstGeom>
+          <a:noFill/>
+        </p:spPr>
+        <p:txBody>
+          <a:bodyPr wrap="square">
+            <a:spAutoFit/>
+          </a:bodyPr>
+          <a:lstStyle/>
+          <a:p>
+            <a:pPr algn="l"/>
+            <a:r>
+              <a:rPr sz="1200" b="0">
+                <a:solidFill>
+                  <a:srgbClr val="FFFFFF"/>
+                </a:solidFill>
+                <a:latin typeface="Consolas"/>
+              </a:rPr>
+              <a:t>$ git push -u origin main</a:t>
+            </a:r>
+          </a:p>
+        </p:txBody>
+      </p:sp>
+      <p:sp>
+        <p:nvSpPr>
+          <p:cNvPr id="21" name="TextBox 20"/>
+          <p:cNvSpPr txBox="1"/>
+          <p:nvPr/>
+        </p:nvSpPr>
+        <p:spPr>
+          <a:xfrm>
+            <a:off x="457200" y="6903720"/>
+            <a:ext cx="10972800" cy="274320"/>
+          </a:xfrm>
+          <a:prstGeom prst="rect">
+            <a:avLst/>
+          </a:prstGeom>
+          <a:noFill/>
+        </p:spPr>
+        <p:txBody>
+          <a:bodyPr wrap="square">
+            <a:spAutoFit/>
+          </a:bodyPr>
+          <a:lstStyle/>
+          <a:p>
+            <a:pPr algn="l"/>
+            <a:r>
+              <a:rPr sz="1000" b="0">
+                <a:solidFill>
+                  <a:srgbClr val="666666"/>
                 </a:solidFill>
                 <a:latin typeface="Calibri"/>
               </a:rPr>
               <a:t>💡 No se exige memorizar comandos. Si logras subir el código, está bien.</a:t>
-            </a:r>
-          </a:p>
-        </p:txBody>
-      </p:sp>
-      <p:sp>
-        <p:nvSpPr>
-          <p:cNvPr id="11" name="TextBox 10"/>
-          <p:cNvSpPr txBox="1"/>
-          <p:nvPr/>
-        </p:nvSpPr>
-        <p:spPr>
-          <a:xfrm>
-            <a:off x="457200" y="6446520"/>
-            <a:ext cx="10515600" cy="274320"/>
-          </a:xfrm>
-          <a:prstGeom prst="rect">
-            <a:avLst/>
-          </a:prstGeom>
-          <a:noFill/>
-        </p:spPr>
-        <p:txBody>
-          <a:bodyPr wrap="square">
-            <a:spAutoFit/>
-          </a:bodyPr>
-          <a:lstStyle/>
-          <a:p>
-            <a:pPr algn="l"/>
-            <a:r>
-              <a:rPr sz="800" b="0">
-                <a:solidFill>
-                  <a:srgbClr val="666666"/>
-                </a:solidFill>
-                <a:latin typeface="Calibri"/>
-              </a:rPr>
-              <a:t>📦 Repo del docente: github.com/KrizRoMe/evaluacion-administracion-web   •   🌐 Sitio público: krizrome.github.io/evaluacion-administracion-web   •   📋 Issues: github.com/KrizRoMe/evaluacion-administracion-web/issues</a:t>
-            </a:r>
-          </a:p>
-        </p:txBody>
-      </p:sp>
-      <p:sp>
-        <p:nvSpPr>
-          <p:cNvPr id="12" name="TextBox 11"/>
-          <p:cNvSpPr txBox="1"/>
-          <p:nvPr/>
-        </p:nvSpPr>
-        <p:spPr>
-          <a:xfrm>
-            <a:off x="11155680" y="6446520"/>
-            <a:ext cx="731520" cy="274320"/>
-          </a:xfrm>
-          <a:prstGeom prst="rect">
-            <a:avLst/>
-          </a:prstGeom>
-          <a:noFill/>
-        </p:spPr>
-        <p:txBody>
-          <a:bodyPr wrap="square">
-            <a:spAutoFit/>
-          </a:bodyPr>
-          <a:lstStyle/>
-          <a:p>
-            <a:pPr algn="r"/>
-            <a:r>
-              <a:rPr sz="1000" b="0">
-                <a:solidFill>
-                  <a:srgbClr val="999999"/>
-                </a:solidFill>
-                <a:latin typeface="Calibri"/>
-              </a:rPr>
-              <a:t>5 / 11</a:t>
             </a:r>
           </a:p>
         </p:txBody>

</xml_diff>

<commit_message>
update: Parte 1 con git puro (sin gh CLI)
</commit_message>
<xml_diff>
--- a/EVALUACION_PRACTICA_01.pptx
+++ b/EVALUACION_PRACTICA_01.pptx
@@ -7629,7 +7629,7 @@
                 </a:solidFill>
                 <a:latin typeface="Calibri"/>
               </a:rPr>
-              <a:t>Parte 1 · Crear tu repositorio</a:t>
+              <a:t>Parte 1 · Clonar, verificar y subir</a:t>
             </a:r>
           </a:p>
         </p:txBody>
@@ -7664,21 +7664,56 @@
                 </a:solidFill>
                 <a:latin typeface="Calibri"/>
               </a:rPr>
-              <a:t>⏱ 10 minutos</a:t>
-            </a:r>
-          </a:p>
-        </p:txBody>
-      </p:sp>
-      <p:sp>
-        <p:nvSpPr>
-          <p:cNvPr id="6" name="Rounded Rectangle 5"/>
+              <a:t>⏱ 10 minutos  •  Solo git (sin gh CLI)</a:t>
+            </a:r>
+          </a:p>
+        </p:txBody>
+      </p:sp>
+      <p:sp>
+        <p:nvSpPr>
+          <p:cNvPr id="6" name="TextBox 5"/>
+          <p:cNvSpPr txBox="1"/>
+          <p:nvPr/>
+        </p:nvSpPr>
+        <p:spPr>
+          <a:xfrm>
+            <a:off x="640080" y="1188720"/>
+            <a:ext cx="10972800" cy="365760"/>
+          </a:xfrm>
+          <a:prstGeom prst="rect">
+            <a:avLst/>
+          </a:prstGeom>
+          <a:noFill/>
+        </p:spPr>
+        <p:txBody>
+          <a:bodyPr wrap="square">
+            <a:spAutoFit/>
+          </a:bodyPr>
+          <a:lstStyle/>
+          <a:p>
+            <a:pPr algn="l"/>
+            <a:r>
+              <a:rPr sz="1800" b="1">
+                <a:solidFill>
+                  <a:srgbClr val="065A82"/>
+                </a:solidFill>
+                <a:latin typeface="Calibri"/>
+              </a:rPr>
+              <a:t>1️⃣  Clonar el repositorio del docente</a:t>
+            </a:r>
+          </a:p>
+        </p:txBody>
+      </p:sp>
+      <p:sp>
+        <p:nvSpPr>
+          <p:cNvPr id="7" name="Rounded Rectangle 6"/>
           <p:cNvSpPr/>
           <p:nvPr/>
         </p:nvSpPr>
         <p:spPr>
           <a:xfrm>
-            <a:off x="640080" y="1280160"/>
-            <a:ext cx="7772400" cy="4114800"/>
+            <a:off x="640080" y="1554480"/>
+            <a:ext cx="10972800" cy="594360"/>
           </a:xfrm>
           <a:prstGeom prst="roundRect">
             <a:avLst/>
@@ -7716,37 +7751,60 @@
       </p:sp>
       <p:sp>
         <p:nvSpPr>
-          <p:cNvPr id="7" name="TextBox 6"/>
-          <p:cNvSpPr txBox="1"/>
-          <p:nvPr/>
-        </p:nvSpPr>
-        <p:spPr>
-          <a:xfrm>
-            <a:off x="822960" y="1417320"/>
-            <a:ext cx="7498079" cy="3840480"/>
-          </a:xfrm>
-          <a:prstGeom prst="rect">
-            <a:avLst/>
-          </a:prstGeom>
-          <a:noFill/>
-        </p:spPr>
-        <p:txBody>
-          <a:bodyPr wrap="square">
-            <a:spAutoFit/>
-          </a:bodyPr>
-          <a:lstStyle/>
-          <a:p>
-            <a:pPr algn="l"/>
-            <a:r>
-              <a:rPr sz="1400" b="1">
+          <p:cNvPr id="8" name="TextBox 7"/>
+          <p:cNvSpPr txBox="1"/>
+          <p:nvPr/>
+        </p:nvSpPr>
+        <p:spPr>
+          <a:xfrm>
+            <a:off x="822960" y="1627632"/>
+            <a:ext cx="10607040" cy="457200"/>
+          </a:xfrm>
+          <a:prstGeom prst="rect">
+            <a:avLst/>
+          </a:prstGeom>
+          <a:noFill/>
+        </p:spPr>
+        <p:txBody>
+          <a:bodyPr wrap="square">
+            <a:spAutoFit/>
+          </a:bodyPr>
+          <a:lstStyle/>
+          <a:p>
+            <a:pPr algn="l"/>
+            <a:r>
+              <a:rPr sz="1400" b="0">
                 <a:solidFill>
                   <a:srgbClr val="FFFFFF"/>
                 </a:solidFill>
-                <a:latin typeface="Calibri"/>
-              </a:rPr>
-              <a:t>Con gh CLI (recomendado):</a:t>
-            </a:r>
-          </a:p>
+                <a:latin typeface="Consolas"/>
+              </a:rPr>
+              <a:t>$ git clone https://github.com/KrizRoMe/evaluacion-administracion-web.git</a:t>
+            </a:r>
+          </a:p>
+        </p:txBody>
+      </p:sp>
+      <p:sp>
+        <p:nvSpPr>
+          <p:cNvPr id="9" name="TextBox 8"/>
+          <p:cNvSpPr txBox="1"/>
+          <p:nvPr/>
+        </p:nvSpPr>
+        <p:spPr>
+          <a:xfrm>
+            <a:off x="822960" y="1920240"/>
+            <a:ext cx="10607040" cy="274320"/>
+          </a:xfrm>
+          <a:prstGeom prst="rect">
+            <a:avLst/>
+          </a:prstGeom>
+          <a:noFill/>
+        </p:spPr>
+        <p:txBody>
+          <a:bodyPr wrap="square">
+            <a:spAutoFit/>
+          </a:bodyPr>
+          <a:lstStyle/>
           <a:p>
             <a:pPr algn="l"/>
             <a:r>
@@ -7754,244 +7812,354 @@
                 <a:solidFill>
                   <a:srgbClr val="FFFFFF"/>
                 </a:solidFill>
-                <a:latin typeface="Calibri"/>
-              </a:rPr>
-              <a:t>$ git init</a:t>
-            </a:r>
-          </a:p>
-          <a:p>
-            <a:pPr algn="l"/>
-            <a:r>
-              <a:rPr sz="1400" b="0">
-                <a:solidFill>
-                  <a:srgbClr val="FFFFFF"/>
-                </a:solidFill>
-                <a:latin typeface="Calibri"/>
-              </a:rPr>
-              <a:t>$ git add .</a:t>
-            </a:r>
-          </a:p>
-          <a:p>
-            <a:pPr algn="l"/>
-            <a:r>
-              <a:rPr sz="1400" b="0">
-                <a:solidFill>
-                  <a:srgbClr val="FFFFFF"/>
-                </a:solidFill>
-                <a:latin typeface="Calibri"/>
-              </a:rPr>
-              <a:t>$ git commit -m "feat: inicio de evaluación"</a:t>
-            </a:r>
-          </a:p>
-          <a:p>
-            <a:pPr algn="l"/>
-            <a:r>
-              <a:rPr sz="1400" b="0">
-                <a:solidFill>
-                  <a:srgbClr val="FFFFFF"/>
-                </a:solidFill>
-                <a:latin typeface="Calibri"/>
-              </a:rPr>
-              <a:t>$ gh repo create evaluacion-administracion-web-TU-NOMBRE \</a:t>
-            </a:r>
-          </a:p>
-          <a:p>
-            <a:pPr algn="l"/>
-            <a:r>
-              <a:rPr sz="1400" b="0">
-                <a:solidFill>
-                  <a:srgbClr val="FFFFFF"/>
-                </a:solidFill>
-                <a:latin typeface="Calibri"/>
-              </a:rPr>
-              <a:t>    --public --source=. --remote=origin --push</a:t>
-            </a:r>
-          </a:p>
-          <a:p>
-            <a:pPr algn="l"/>
-            <a:r>
-              <a:rPr sz="1400" b="0">
-                <a:solidFill>
-                  <a:srgbClr val="FFFFFF"/>
-                </a:solidFill>
-                <a:latin typeface="Calibri"/>
-              </a:rPr>
-              <a:t/>
-            </a:r>
-          </a:p>
-          <a:p>
-            <a:pPr algn="l"/>
-            <a:r>
-              <a:rPr sz="1400" b="1">
-                <a:solidFill>
-                  <a:srgbClr val="FFFFFF"/>
-                </a:solidFill>
-                <a:latin typeface="Calibri"/>
-              </a:rPr>
-              <a:t>Alternativa con git directo:</a:t>
-            </a:r>
-          </a:p>
-          <a:p>
-            <a:pPr algn="l"/>
-            <a:r>
-              <a:rPr sz="1400" b="0">
-                <a:solidFill>
-                  <a:srgbClr val="FFFFFF"/>
-                </a:solidFill>
-                <a:latin typeface="Calibri"/>
-              </a:rPr>
-              <a:t>$ git remote add origin https://github.com/TU-USUARIO/...</a:t>
-            </a:r>
-          </a:p>
-          <a:p>
-            <a:pPr algn="l"/>
-            <a:r>
-              <a:rPr sz="1400" b="0">
-                <a:solidFill>
-                  <a:srgbClr val="FFFFFF"/>
-                </a:solidFill>
-                <a:latin typeface="Calibri"/>
-              </a:rPr>
-              <a:t>$ git branch -M main</a:t>
-            </a:r>
-          </a:p>
-          <a:p>
-            <a:pPr algn="l"/>
-            <a:r>
-              <a:rPr sz="1400" b="0">
-                <a:solidFill>
-                  <a:srgbClr val="FFFFFF"/>
-                </a:solidFill>
-                <a:latin typeface="Calibri"/>
-              </a:rPr>
-              <a:t>$ git push -u origin main</a:t>
-            </a:r>
-          </a:p>
-        </p:txBody>
-      </p:sp>
-      <p:sp>
-        <p:nvSpPr>
-          <p:cNvPr id="8" name="TextBox 7"/>
-          <p:cNvSpPr txBox="1"/>
-          <p:nvPr/>
-        </p:nvSpPr>
-        <p:spPr>
-          <a:xfrm>
-            <a:off x="8686800" y="1280160"/>
-            <a:ext cx="3200400" cy="4114800"/>
-          </a:xfrm>
-          <a:prstGeom prst="rect">
-            <a:avLst/>
-          </a:prstGeom>
-          <a:noFill/>
-        </p:spPr>
-        <p:txBody>
-          <a:bodyPr wrap="square">
-            <a:spAutoFit/>
-          </a:bodyPr>
-          <a:lstStyle/>
-          <a:p>
-            <a:pPr algn="l"/>
-            <a:r>
-              <a:rPr sz="1400" b="1">
+                <a:latin typeface="Consolas"/>
+              </a:rPr>
+              <a:t>$ cd evaluacion-administracion-web</a:t>
+            </a:r>
+          </a:p>
+        </p:txBody>
+      </p:sp>
+      <p:sp>
+        <p:nvSpPr>
+          <p:cNvPr id="10" name="TextBox 9"/>
+          <p:cNvSpPr txBox="1"/>
+          <p:nvPr/>
+        </p:nvSpPr>
+        <p:spPr>
+          <a:xfrm>
+            <a:off x="640080" y="2377440"/>
+            <a:ext cx="10972800" cy="365760"/>
+          </a:xfrm>
+          <a:prstGeom prst="rect">
+            <a:avLst/>
+          </a:prstGeom>
+          <a:noFill/>
+        </p:spPr>
+        <p:txBody>
+          <a:bodyPr wrap="square">
+            <a:spAutoFit/>
+          </a:bodyPr>
+          <a:lstStyle/>
+          <a:p>
+            <a:pPr algn="l"/>
+            <a:r>
+              <a:rPr sz="1800" b="1">
+                <a:solidFill>
+                  <a:srgbClr val="065A82"/>
+                </a:solidFill>
+                <a:latin typeface="Calibri"/>
+              </a:rPr>
+              <a:t>2️⃣  Verificar que el sitio funciona localmente</a:t>
+            </a:r>
+          </a:p>
+        </p:txBody>
+      </p:sp>
+      <p:sp>
+        <p:nvSpPr>
+          <p:cNvPr id="11" name="Rounded Rectangle 10"/>
+          <p:cNvSpPr/>
+          <p:nvPr/>
+        </p:nvSpPr>
+        <p:spPr>
+          <a:xfrm>
+            <a:off x="640080" y="2743200"/>
+            <a:ext cx="10972800" cy="777240"/>
+          </a:xfrm>
+          <a:prstGeom prst="roundRect">
+            <a:avLst/>
+          </a:prstGeom>
+          <a:solidFill>
+            <a:srgbClr val="E6F7F1"/>
+          </a:solidFill>
+          <a:ln>
+            <a:solidFill>
+              <a:srgbClr val="10B981"/>
+            </a:solidFill>
+          </a:ln>
+        </p:spPr>
+        <p:style>
+          <a:lnRef idx="1">
+            <a:schemeClr val="accent1"/>
+          </a:lnRef>
+          <a:fillRef idx="3">
+            <a:schemeClr val="accent1"/>
+          </a:fillRef>
+          <a:effectRef idx="2">
+            <a:schemeClr val="accent1"/>
+          </a:effectRef>
+          <a:fontRef idx="minor">
+            <a:schemeClr val="lt1"/>
+          </a:fontRef>
+        </p:style>
+        <p:txBody>
+          <a:bodyPr rtlCol="0" anchor="ctr"/>
+          <a:lstStyle/>
+          <a:p>
+            <a:pPr algn="ctr"/>
+          </a:p>
+        </p:txBody>
+      </p:sp>
+      <p:sp>
+        <p:nvSpPr>
+          <p:cNvPr id="12" name="TextBox 11"/>
+          <p:cNvSpPr txBox="1"/>
+          <p:nvPr/>
+        </p:nvSpPr>
+        <p:spPr>
+          <a:xfrm>
+            <a:off x="822960" y="2788920"/>
+            <a:ext cx="10607040" cy="685800"/>
+          </a:xfrm>
+          <a:prstGeom prst="rect">
+            <a:avLst/>
+          </a:prstGeom>
+          <a:noFill/>
+        </p:spPr>
+        <p:txBody>
+          <a:bodyPr wrap="square">
+            <a:spAutoFit/>
+          </a:bodyPr>
+          <a:lstStyle/>
+          <a:p>
+            <a:pPr algn="l"/>
+            <a:r>
+              <a:rPr sz="1300" b="0">
                 <a:solidFill>
                   <a:srgbClr val="2A2A2A"/>
                 </a:solidFill>
                 <a:latin typeface="Calibri"/>
               </a:rPr>
-              <a:t>✅ Resultado esperado</a:t>
-            </a:r>
-          </a:p>
-          <a:p>
-            <a:pPr algn="l"/>
-            <a:r>
-              <a:rPr sz="1400" b="0">
+              <a:t>Doble clic en index.html  •  O arrastrar al navegador  •  Debe verse la tienda ECOMARKET</a:t>
+            </a:r>
+          </a:p>
+          <a:p>
+            <a:pPr algn="l"/>
+            <a:r>
+              <a:rPr sz="1300" b="0">
                 <a:solidFill>
                   <a:srgbClr val="2A2A2A"/>
                 </a:solidFill>
                 <a:latin typeface="Calibri"/>
               </a:rPr>
-              <a:t>• Repositorio público</a:t>
-            </a:r>
-          </a:p>
-          <a:p>
-            <a:pPr algn="l"/>
-            <a:r>
-              <a:rPr sz="1400" b="0">
+              <a:t>Si ves los productos, el carrito y el modo oscuro → todo funciona ✓</a:t>
+            </a:r>
+          </a:p>
+        </p:txBody>
+      </p:sp>
+      <p:sp>
+        <p:nvSpPr>
+          <p:cNvPr id="13" name="TextBox 12"/>
+          <p:cNvSpPr txBox="1"/>
+          <p:nvPr/>
+        </p:nvSpPr>
+        <p:spPr>
+          <a:xfrm>
+            <a:off x="640080" y="3703320"/>
+            <a:ext cx="10972800" cy="365760"/>
+          </a:xfrm>
+          <a:prstGeom prst="rect">
+            <a:avLst/>
+          </a:prstGeom>
+          <a:noFill/>
+        </p:spPr>
+        <p:txBody>
+          <a:bodyPr wrap="square">
+            <a:spAutoFit/>
+          </a:bodyPr>
+          <a:lstStyle/>
+          <a:p>
+            <a:pPr algn="l"/>
+            <a:r>
+              <a:rPr sz="1800" b="1">
+                <a:solidFill>
+                  <a:srgbClr val="065A82"/>
+                </a:solidFill>
+                <a:latin typeface="Calibri"/>
+              </a:rPr>
+              <a:t>3️⃣  Crear tu repositorio personal (manual, en la web)</a:t>
+            </a:r>
+          </a:p>
+        </p:txBody>
+      </p:sp>
+      <p:sp>
+        <p:nvSpPr>
+          <p:cNvPr id="14" name="Rounded Rectangle 13"/>
+          <p:cNvSpPr/>
+          <p:nvPr/>
+        </p:nvSpPr>
+        <p:spPr>
+          <a:xfrm>
+            <a:off x="640080" y="4069080"/>
+            <a:ext cx="10972800" cy="1371600"/>
+          </a:xfrm>
+          <a:prstGeom prst="roundRect">
+            <a:avLst/>
+          </a:prstGeom>
+          <a:solidFill>
+            <a:srgbClr val="FEF3E6"/>
+          </a:solidFill>
+          <a:ln>
+            <a:solidFill>
+              <a:srgbClr val="EA580C"/>
+            </a:solidFill>
+          </a:ln>
+        </p:spPr>
+        <p:style>
+          <a:lnRef idx="1">
+            <a:schemeClr val="accent1"/>
+          </a:lnRef>
+          <a:fillRef idx="3">
+            <a:schemeClr val="accent1"/>
+          </a:fillRef>
+          <a:effectRef idx="2">
+            <a:schemeClr val="accent1"/>
+          </a:effectRef>
+          <a:fontRef idx="minor">
+            <a:schemeClr val="lt1"/>
+          </a:fontRef>
+        </p:style>
+        <p:txBody>
+          <a:bodyPr rtlCol="0" anchor="ctr"/>
+          <a:lstStyle/>
+          <a:p>
+            <a:pPr algn="ctr"/>
+          </a:p>
+        </p:txBody>
+      </p:sp>
+      <p:sp>
+        <p:nvSpPr>
+          <p:cNvPr id="15" name="TextBox 14"/>
+          <p:cNvSpPr txBox="1"/>
+          <p:nvPr/>
+        </p:nvSpPr>
+        <p:spPr>
+          <a:xfrm>
+            <a:off x="822960" y="4114800"/>
+            <a:ext cx="10607040" cy="1280160"/>
+          </a:xfrm>
+          <a:prstGeom prst="rect">
+            <a:avLst/>
+          </a:prstGeom>
+          <a:noFill/>
+        </p:spPr>
+        <p:txBody>
+          <a:bodyPr wrap="square">
+            <a:spAutoFit/>
+          </a:bodyPr>
+          <a:lstStyle/>
+          <a:p>
+            <a:pPr algn="l"/>
+            <a:r>
+              <a:rPr sz="1200" b="0">
                 <a:solidFill>
                   <a:srgbClr val="2A2A2A"/>
                 </a:solidFill>
                 <a:latin typeface="Calibri"/>
               </a:rPr>
-              <a:t>• Código del sitio subido</a:t>
-            </a:r>
-          </a:p>
-          <a:p>
-            <a:pPr algn="l"/>
-            <a:r>
-              <a:rPr sz="1400" b="0">
+              <a:t>1. Abre https://github.com/new en tu navegador</a:t>
+            </a:r>
+          </a:p>
+          <a:p>
+            <a:pPr algn="l"/>
+            <a:r>
+              <a:rPr sz="1200" b="0">
                 <a:solidFill>
                   <a:srgbClr val="2A2A2A"/>
                 </a:solidFill>
                 <a:latin typeface="Calibri"/>
               </a:rPr>
-              <a:t>• Commit inicial realizado</a:t>
-            </a:r>
-          </a:p>
-          <a:p>
-            <a:pPr algn="l"/>
-            <a:r>
-              <a:rPr sz="1400" b="0">
+              <a:t>2. Repository name:  evaluacion-administracion-web-TU-NOMBRE</a:t>
+            </a:r>
+          </a:p>
+          <a:p>
+            <a:pPr algn="l"/>
+            <a:r>
+              <a:rPr sz="1200" b="0">
                 <a:solidFill>
                   <a:srgbClr val="2A2A2A"/>
                 </a:solidFill>
                 <a:latin typeface="Calibri"/>
               </a:rPr>
-              <a:t/>
-            </a:r>
-          </a:p>
-          <a:p>
-            <a:pPr algn="l"/>
-            <a:r>
-              <a:rPr sz="1400" b="1">
+              <a:t>3. Visibility:  Public</a:t>
+            </a:r>
+          </a:p>
+          <a:p>
+            <a:pPr algn="l"/>
+            <a:r>
+              <a:rPr sz="1200" b="0">
                 <a:solidFill>
                   <a:srgbClr val="2A2A2A"/>
                 </a:solidFill>
                 <a:latin typeface="Calibri"/>
               </a:rPr>
-              <a:t>📌 Nombre sugerido</a:t>
-            </a:r>
-          </a:p>
-          <a:p>
-            <a:pPr algn="l"/>
-            <a:r>
-              <a:rPr sz="1400" b="0">
+              <a:t>4. NO inicialices con README, .gitignore ni license (déjalo vacío)</a:t>
+            </a:r>
+          </a:p>
+          <a:p>
+            <a:pPr algn="l"/>
+            <a:r>
+              <a:rPr sz="1200" b="0">
                 <a:solidFill>
                   <a:srgbClr val="2A2A2A"/>
                 </a:solidFill>
                 <a:latin typeface="Calibri"/>
               </a:rPr>
-              <a:t>evaluacion-administracion-web-TU-NOMBRE</a:t>
-            </a:r>
-          </a:p>
-        </p:txBody>
-      </p:sp>
-      <p:sp>
-        <p:nvSpPr>
-          <p:cNvPr id="9" name="Rounded Rectangle 8"/>
+              <a:t>5. Clic en Create repository  →  Copia la URL HTTPS que te muestra</a:t>
+            </a:r>
+          </a:p>
+        </p:txBody>
+      </p:sp>
+      <p:sp>
+        <p:nvSpPr>
+          <p:cNvPr id="16" name="TextBox 15"/>
+          <p:cNvSpPr txBox="1"/>
+          <p:nvPr/>
+        </p:nvSpPr>
+        <p:spPr>
+          <a:xfrm>
+            <a:off x="640080" y="5623560"/>
+            <a:ext cx="10972800" cy="365760"/>
+          </a:xfrm>
+          <a:prstGeom prst="rect">
+            <a:avLst/>
+          </a:prstGeom>
+          <a:noFill/>
+        </p:spPr>
+        <p:txBody>
+          <a:bodyPr wrap="square">
+            <a:spAutoFit/>
+          </a:bodyPr>
+          <a:lstStyle/>
+          <a:p>
+            <a:pPr algn="l"/>
+            <a:r>
+              <a:rPr sz="1800" b="1">
+                <a:solidFill>
+                  <a:srgbClr val="065A82"/>
+                </a:solidFill>
+                <a:latin typeface="Calibri"/>
+              </a:rPr>
+              <a:t>4️⃣  Conectar y subir con git puro</a:t>
+            </a:r>
+          </a:p>
+        </p:txBody>
+      </p:sp>
+      <p:sp>
+        <p:nvSpPr>
+          <p:cNvPr id="17" name="Rounded Rectangle 16"/>
           <p:cNvSpPr/>
           <p:nvPr/>
         </p:nvSpPr>
         <p:spPr>
           <a:xfrm>
-            <a:off x="640080" y="5669280"/>
-            <a:ext cx="10972800" cy="548640"/>
+            <a:off x="640080" y="5989320"/>
+            <a:ext cx="10972800" cy="777240"/>
           </a:xfrm>
           <a:prstGeom prst="roundRect">
             <a:avLst/>
           </a:prstGeom>
           <a:solidFill>
-            <a:srgbClr val="F4F4F4"/>
+            <a:srgbClr val="2A2A2A"/>
           </a:solidFill>
           <a:ln>
             <a:solidFill>
@@ -8023,105 +8191,140 @@
       </p:sp>
       <p:sp>
         <p:nvSpPr>
-          <p:cNvPr id="10" name="TextBox 9"/>
-          <p:cNvSpPr txBox="1"/>
-          <p:nvPr/>
-        </p:nvSpPr>
-        <p:spPr>
-          <a:xfrm>
-            <a:off x="640080" y="5760720"/>
-            <a:ext cx="10972800" cy="365760"/>
-          </a:xfrm>
-          <a:prstGeom prst="rect">
-            <a:avLst/>
-          </a:prstGeom>
-          <a:noFill/>
-        </p:spPr>
-        <p:txBody>
-          <a:bodyPr wrap="square">
-            <a:spAutoFit/>
-          </a:bodyPr>
-          <a:lstStyle/>
-          <a:p>
-            <a:pPr algn="ctr"/>
-            <a:r>
-              <a:rPr sz="1400" b="1">
-                <a:solidFill>
-                  <a:srgbClr val="065A82"/>
+          <p:cNvPr id="18" name="TextBox 17"/>
+          <p:cNvSpPr txBox="1"/>
+          <p:nvPr/>
+        </p:nvSpPr>
+        <p:spPr>
+          <a:xfrm>
+            <a:off x="822960" y="6035040"/>
+            <a:ext cx="10607040" cy="274320"/>
+          </a:xfrm>
+          <a:prstGeom prst="rect">
+            <a:avLst/>
+          </a:prstGeom>
+          <a:noFill/>
+        </p:spPr>
+        <p:txBody>
+          <a:bodyPr wrap="square">
+            <a:spAutoFit/>
+          </a:bodyPr>
+          <a:lstStyle/>
+          <a:p>
+            <a:pPr algn="l"/>
+            <a:r>
+              <a:rPr sz="1100" b="0">
+                <a:solidFill>
+                  <a:srgbClr val="FFFFFF"/>
+                </a:solidFill>
+                <a:latin typeface="Consolas"/>
+              </a:rPr>
+              <a:t>$ git remote add origin https://github.com/TU-USUARIO/evaluacion-administracion-web-TU-NOMBRE.git</a:t>
+            </a:r>
+          </a:p>
+        </p:txBody>
+      </p:sp>
+      <p:sp>
+        <p:nvSpPr>
+          <p:cNvPr id="19" name="TextBox 18"/>
+          <p:cNvSpPr txBox="1"/>
+          <p:nvPr/>
+        </p:nvSpPr>
+        <p:spPr>
+          <a:xfrm>
+            <a:off x="822960" y="6309360"/>
+            <a:ext cx="10607040" cy="274320"/>
+          </a:xfrm>
+          <a:prstGeom prst="rect">
+            <a:avLst/>
+          </a:prstGeom>
+          <a:noFill/>
+        </p:spPr>
+        <p:txBody>
+          <a:bodyPr wrap="square">
+            <a:spAutoFit/>
+          </a:bodyPr>
+          <a:lstStyle/>
+          <a:p>
+            <a:pPr algn="l"/>
+            <a:r>
+              <a:rPr sz="1200" b="0">
+                <a:solidFill>
+                  <a:srgbClr val="FFFFFF"/>
+                </a:solidFill>
+                <a:latin typeface="Consolas"/>
+              </a:rPr>
+              <a:t>$ git branch -M main</a:t>
+            </a:r>
+          </a:p>
+        </p:txBody>
+      </p:sp>
+      <p:sp>
+        <p:nvSpPr>
+          <p:cNvPr id="20" name="TextBox 19"/>
+          <p:cNvSpPr txBox="1"/>
+          <p:nvPr/>
+        </p:nvSpPr>
+        <p:spPr>
+          <a:xfrm>
+            <a:off x="822960" y="6537960"/>
+            <a:ext cx="10607040" cy="274320"/>
+          </a:xfrm>
+          <a:prstGeom prst="rect">
+            <a:avLst/>
+          </a:prstGeom>
+          <a:noFill/>
+        </p:spPr>
+        <p:txBody>
+          <a:bodyPr wrap="square">
+            <a:spAutoFit/>
+          </a:bodyPr>
+          <a:lstStyle/>
+          <a:p>
+            <a:pPr algn="l"/>
+            <a:r>
+              <a:rPr sz="1200" b="0">
+                <a:solidFill>
+                  <a:srgbClr val="FFFFFF"/>
+                </a:solidFill>
+                <a:latin typeface="Consolas"/>
+              </a:rPr>
+              <a:t>$ git push -u origin main</a:t>
+            </a:r>
+          </a:p>
+        </p:txBody>
+      </p:sp>
+      <p:sp>
+        <p:nvSpPr>
+          <p:cNvPr id="21" name="TextBox 20"/>
+          <p:cNvSpPr txBox="1"/>
+          <p:nvPr/>
+        </p:nvSpPr>
+        <p:spPr>
+          <a:xfrm>
+            <a:off x="457200" y="6903720"/>
+            <a:ext cx="10972800" cy="274320"/>
+          </a:xfrm>
+          <a:prstGeom prst="rect">
+            <a:avLst/>
+          </a:prstGeom>
+          <a:noFill/>
+        </p:spPr>
+        <p:txBody>
+          <a:bodyPr wrap="square">
+            <a:spAutoFit/>
+          </a:bodyPr>
+          <a:lstStyle/>
+          <a:p>
+            <a:pPr algn="l"/>
+            <a:r>
+              <a:rPr sz="1000" b="0">
+                <a:solidFill>
+                  <a:srgbClr val="666666"/>
                 </a:solidFill>
                 <a:latin typeface="Calibri"/>
               </a:rPr>
               <a:t>💡 No se exige memorizar comandos. Si logras subir el código, está bien.</a:t>
-            </a:r>
-          </a:p>
-        </p:txBody>
-      </p:sp>
-      <p:sp>
-        <p:nvSpPr>
-          <p:cNvPr id="11" name="TextBox 10"/>
-          <p:cNvSpPr txBox="1"/>
-          <p:nvPr/>
-        </p:nvSpPr>
-        <p:spPr>
-          <a:xfrm>
-            <a:off x="457200" y="6446520"/>
-            <a:ext cx="10515600" cy="274320"/>
-          </a:xfrm>
-          <a:prstGeom prst="rect">
-            <a:avLst/>
-          </a:prstGeom>
-          <a:noFill/>
-        </p:spPr>
-        <p:txBody>
-          <a:bodyPr wrap="square">
-            <a:spAutoFit/>
-          </a:bodyPr>
-          <a:lstStyle/>
-          <a:p>
-            <a:pPr algn="l"/>
-            <a:r>
-              <a:rPr sz="800" b="0">
-                <a:solidFill>
-                  <a:srgbClr val="666666"/>
-                </a:solidFill>
-                <a:latin typeface="Calibri"/>
-              </a:rPr>
-              <a:t>📦 Repo del docente: github.com/KrizRoMe/evaluacion-administracion-web   •   🌐 Sitio público: krizrome.github.io/evaluacion-administracion-web   •   📋 Issues: github.com/KrizRoMe/evaluacion-administracion-web/issues</a:t>
-            </a:r>
-          </a:p>
-        </p:txBody>
-      </p:sp>
-      <p:sp>
-        <p:nvSpPr>
-          <p:cNvPr id="12" name="TextBox 11"/>
-          <p:cNvSpPr txBox="1"/>
-          <p:nvPr/>
-        </p:nvSpPr>
-        <p:spPr>
-          <a:xfrm>
-            <a:off x="11155680" y="6446520"/>
-            <a:ext cx="731520" cy="274320"/>
-          </a:xfrm>
-          <a:prstGeom prst="rect">
-            <a:avLst/>
-          </a:prstGeom>
-          <a:noFill/>
-        </p:spPr>
-        <p:txBody>
-          <a:bodyPr wrap="square">
-            <a:spAutoFit/>
-          </a:bodyPr>
-          <a:lstStyle/>
-          <a:p>
-            <a:pPr algn="r"/>
-            <a:r>
-              <a:rPr sz="1000" b="0">
-                <a:solidFill>
-                  <a:srgbClr val="999999"/>
-                </a:solidFill>
-                <a:latin typeface="Calibri"/>
-              </a:rPr>
-              <a:t>5 / 11</a:t>
             </a:r>
           </a:p>
         </p:txBody>

</xml_diff>

<commit_message>
fix(parte1): usar 'git remote set-url' en lugar de 'add'
El remoto 'origin' ya existe después de 'git clone', por lo que 'add' falla
con 'fatal: remote origin already exists.'. 'set-url' es el comando correcto
para redirigir el remoto a otro URL.

Añadida nota aclaratoria en slide 5, markdown, instrucciones y checklist.
</commit_message>
<xml_diff>
--- a/EVALUACION_PRACTICA_01.pptx
+++ b/EVALUACION_PRACTICA_01.pptx
@@ -7503,838 +7503,8 @@
 </p:sld>
 </file>
 
-<file path=ppt/slides/slide5.xml><?xml version="1.0" encoding="utf-8"?>
-<p:sld xmlns:a="http://schemas.openxmlformats.org/drawingml/2006/main" xmlns:p="http://schemas.openxmlformats.org/presentationml/2006/main" xmlns:r="http://schemas.openxmlformats.org/officeDocument/2006/relationships">
-  <p:cSld>
-    <p:spTree>
-      <p:nvGrpSpPr>
-        <p:cNvPr id="1" name=""/>
-        <p:cNvGrpSpPr/>
-        <p:nvPr/>
-      </p:nvGrpSpPr>
-      <p:grpSpPr/>
-      <p:sp>
-        <p:nvSpPr>
-          <p:cNvPr id="2" name="Rectangle 1"/>
-          <p:cNvSpPr/>
-          <p:nvPr/>
-        </p:nvSpPr>
-        <p:spPr>
-          <a:xfrm>
-            <a:off x="0" y="0"/>
-            <a:ext cx="12191695" cy="6858000"/>
-          </a:xfrm>
-          <a:prstGeom prst="rect">
-            <a:avLst/>
-          </a:prstGeom>
-          <a:solidFill>
-            <a:srgbClr val="FFFFFF"/>
-          </a:solidFill>
-          <a:ln>
-            <a:noFill/>
-          </a:ln>
-        </p:spPr>
-        <p:style>
-          <a:lnRef idx="1">
-            <a:schemeClr val="accent1"/>
-          </a:lnRef>
-          <a:fillRef idx="3">
-            <a:schemeClr val="accent1"/>
-          </a:fillRef>
-          <a:effectRef idx="2">
-            <a:schemeClr val="accent1"/>
-          </a:effectRef>
-          <a:fontRef idx="minor">
-            <a:schemeClr val="lt1"/>
-          </a:fontRef>
-        </p:style>
-        <p:txBody>
-          <a:bodyPr rtlCol="0" anchor="ctr"/>
-          <a:lstStyle/>
-          <a:p>
-            <a:pPr algn="ctr"/>
-          </a:p>
-        </p:txBody>
-      </p:sp>
-      <p:sp>
-        <p:nvSpPr>
-          <p:cNvPr id="3" name="Rectangle 2"/>
-          <p:cNvSpPr/>
-          <p:nvPr/>
-        </p:nvSpPr>
-        <p:spPr>
-          <a:xfrm>
-            <a:off x="0" y="0"/>
-            <a:ext cx="12191695" cy="914400"/>
-          </a:xfrm>
-          <a:prstGeom prst="rect">
-            <a:avLst/>
-          </a:prstGeom>
-          <a:solidFill>
-            <a:srgbClr val="065A82"/>
-          </a:solidFill>
-          <a:ln>
-            <a:noFill/>
-          </a:ln>
-        </p:spPr>
-        <p:style>
-          <a:lnRef idx="1">
-            <a:schemeClr val="accent1"/>
-          </a:lnRef>
-          <a:fillRef idx="3">
-            <a:schemeClr val="accent1"/>
-          </a:fillRef>
-          <a:effectRef idx="2">
-            <a:schemeClr val="accent1"/>
-          </a:effectRef>
-          <a:fontRef idx="minor">
-            <a:schemeClr val="lt1"/>
-          </a:fontRef>
-        </p:style>
-        <p:txBody>
-          <a:bodyPr rtlCol="0" anchor="ctr"/>
-          <a:lstStyle/>
-          <a:p>
-            <a:pPr algn="ctr"/>
-          </a:p>
-        </p:txBody>
-      </p:sp>
-      <p:sp>
-        <p:nvSpPr>
-          <p:cNvPr id="4" name="TextBox 3"/>
-          <p:cNvSpPr txBox="1"/>
-          <p:nvPr/>
-        </p:nvSpPr>
-        <p:spPr>
-          <a:xfrm>
-            <a:off x="457200" y="274320"/>
-            <a:ext cx="10972800" cy="457200"/>
-          </a:xfrm>
-          <a:prstGeom prst="rect">
-            <a:avLst/>
-          </a:prstGeom>
-          <a:noFill/>
-        </p:spPr>
-        <p:txBody>
-          <a:bodyPr wrap="square">
-            <a:spAutoFit/>
-          </a:bodyPr>
-          <a:lstStyle/>
-          <a:p>
-            <a:pPr algn="l"/>
-            <a:r>
-              <a:rPr sz="3200" b="1">
-                <a:solidFill>
-                  <a:srgbClr val="FFFFFF"/>
-                </a:solidFill>
-                <a:latin typeface="Calibri"/>
-              </a:rPr>
-              <a:t>Parte 1 · Clonar, verificar y subir</a:t>
-            </a:r>
-          </a:p>
-        </p:txBody>
-      </p:sp>
-      <p:sp>
-        <p:nvSpPr>
-          <p:cNvPr id="5" name="TextBox 4"/>
-          <p:cNvSpPr txBox="1"/>
-          <p:nvPr/>
-        </p:nvSpPr>
-        <p:spPr>
-          <a:xfrm>
-            <a:off x="457200" y="685800"/>
-            <a:ext cx="10972800" cy="274320"/>
-          </a:xfrm>
-          <a:prstGeom prst="rect">
-            <a:avLst/>
-          </a:prstGeom>
-          <a:noFill/>
-        </p:spPr>
-        <p:txBody>
-          <a:bodyPr wrap="square">
-            <a:spAutoFit/>
-          </a:bodyPr>
-          <a:lstStyle/>
-          <a:p>
-            <a:pPr algn="l"/>
-            <a:r>
-              <a:rPr sz="1400" b="0">
-                <a:solidFill>
-                  <a:srgbClr val="60A5FA"/>
-                </a:solidFill>
-                <a:latin typeface="Calibri"/>
-              </a:rPr>
-              <a:t>⏱ 10 minutos  •  Solo git (sin gh CLI)</a:t>
-            </a:r>
-          </a:p>
-        </p:txBody>
-      </p:sp>
-      <p:sp>
-        <p:nvSpPr>
-          <p:cNvPr id="6" name="TextBox 5"/>
-          <p:cNvSpPr txBox="1"/>
-          <p:nvPr/>
-        </p:nvSpPr>
-        <p:spPr>
-          <a:xfrm>
-            <a:off x="640080" y="1188720"/>
-            <a:ext cx="10972800" cy="365760"/>
-          </a:xfrm>
-          <a:prstGeom prst="rect">
-            <a:avLst/>
-          </a:prstGeom>
-          <a:noFill/>
-        </p:spPr>
-        <p:txBody>
-          <a:bodyPr wrap="square">
-            <a:spAutoFit/>
-          </a:bodyPr>
-          <a:lstStyle/>
-          <a:p>
-            <a:pPr algn="l"/>
-            <a:r>
-              <a:rPr sz="1800" b="1">
-                <a:solidFill>
-                  <a:srgbClr val="065A82"/>
-                </a:solidFill>
-                <a:latin typeface="Calibri"/>
-              </a:rPr>
-              <a:t>1️⃣  Clonar el repositorio del docente</a:t>
-            </a:r>
-          </a:p>
-        </p:txBody>
-      </p:sp>
-      <p:sp>
-        <p:nvSpPr>
-          <p:cNvPr id="7" name="Rounded Rectangle 6"/>
-          <p:cNvSpPr/>
-          <p:nvPr/>
-        </p:nvSpPr>
-        <p:spPr>
-          <a:xfrm>
-            <a:off x="640080" y="1554480"/>
-            <a:ext cx="10972800" cy="594360"/>
-          </a:xfrm>
-          <a:prstGeom prst="roundRect">
-            <a:avLst/>
-          </a:prstGeom>
-          <a:solidFill>
-            <a:srgbClr val="2A2A2A"/>
-          </a:solidFill>
-          <a:ln>
-            <a:solidFill>
-              <a:srgbClr val="1C7293"/>
-            </a:solidFill>
-          </a:ln>
-        </p:spPr>
-        <p:style>
-          <a:lnRef idx="1">
-            <a:schemeClr val="accent1"/>
-          </a:lnRef>
-          <a:fillRef idx="3">
-            <a:schemeClr val="accent1"/>
-          </a:fillRef>
-          <a:effectRef idx="2">
-            <a:schemeClr val="accent1"/>
-          </a:effectRef>
-          <a:fontRef idx="minor">
-            <a:schemeClr val="lt1"/>
-          </a:fontRef>
-        </p:style>
-        <p:txBody>
-          <a:bodyPr rtlCol="0" anchor="ctr"/>
-          <a:lstStyle/>
-          <a:p>
-            <a:pPr algn="ctr"/>
-          </a:p>
-        </p:txBody>
-      </p:sp>
-      <p:sp>
-        <p:nvSpPr>
-          <p:cNvPr id="8" name="TextBox 7"/>
-          <p:cNvSpPr txBox="1"/>
-          <p:nvPr/>
-        </p:nvSpPr>
-        <p:spPr>
-          <a:xfrm>
-            <a:off x="822960" y="1627632"/>
-            <a:ext cx="10607040" cy="457200"/>
-          </a:xfrm>
-          <a:prstGeom prst="rect">
-            <a:avLst/>
-          </a:prstGeom>
-          <a:noFill/>
-        </p:spPr>
-        <p:txBody>
-          <a:bodyPr wrap="square">
-            <a:spAutoFit/>
-          </a:bodyPr>
-          <a:lstStyle/>
-          <a:p>
-            <a:pPr algn="l"/>
-            <a:r>
-              <a:rPr sz="1400" b="0">
-                <a:solidFill>
-                  <a:srgbClr val="FFFFFF"/>
-                </a:solidFill>
-                <a:latin typeface="Consolas"/>
-              </a:rPr>
-              <a:t>$ git clone https://github.com/KrizRoMe/evaluacion-administracion-web.git</a:t>
-            </a:r>
-          </a:p>
-        </p:txBody>
-      </p:sp>
-      <p:sp>
-        <p:nvSpPr>
-          <p:cNvPr id="9" name="TextBox 8"/>
-          <p:cNvSpPr txBox="1"/>
-          <p:nvPr/>
-        </p:nvSpPr>
-        <p:spPr>
-          <a:xfrm>
-            <a:off x="822960" y="1920240"/>
-            <a:ext cx="10607040" cy="274320"/>
-          </a:xfrm>
-          <a:prstGeom prst="rect">
-            <a:avLst/>
-          </a:prstGeom>
-          <a:noFill/>
-        </p:spPr>
-        <p:txBody>
-          <a:bodyPr wrap="square">
-            <a:spAutoFit/>
-          </a:bodyPr>
-          <a:lstStyle/>
-          <a:p>
-            <a:pPr algn="l"/>
-            <a:r>
-              <a:rPr sz="1400" b="0">
-                <a:solidFill>
-                  <a:srgbClr val="FFFFFF"/>
-                </a:solidFill>
-                <a:latin typeface="Consolas"/>
-              </a:rPr>
-              <a:t>$ cd evaluacion-administracion-web</a:t>
-            </a:r>
-          </a:p>
-        </p:txBody>
-      </p:sp>
-      <p:sp>
-        <p:nvSpPr>
-          <p:cNvPr id="10" name="TextBox 9"/>
-          <p:cNvSpPr txBox="1"/>
-          <p:nvPr/>
-        </p:nvSpPr>
-        <p:spPr>
-          <a:xfrm>
-            <a:off x="640080" y="2377440"/>
-            <a:ext cx="10972800" cy="365760"/>
-          </a:xfrm>
-          <a:prstGeom prst="rect">
-            <a:avLst/>
-          </a:prstGeom>
-          <a:noFill/>
-        </p:spPr>
-        <p:txBody>
-          <a:bodyPr wrap="square">
-            <a:spAutoFit/>
-          </a:bodyPr>
-          <a:lstStyle/>
-          <a:p>
-            <a:pPr algn="l"/>
-            <a:r>
-              <a:rPr sz="1800" b="1">
-                <a:solidFill>
-                  <a:srgbClr val="065A82"/>
-                </a:solidFill>
-                <a:latin typeface="Calibri"/>
-              </a:rPr>
-              <a:t>2️⃣  Verificar que el sitio funciona localmente</a:t>
-            </a:r>
-          </a:p>
-        </p:txBody>
-      </p:sp>
-      <p:sp>
-        <p:nvSpPr>
-          <p:cNvPr id="11" name="Rounded Rectangle 10"/>
-          <p:cNvSpPr/>
-          <p:nvPr/>
-        </p:nvSpPr>
-        <p:spPr>
-          <a:xfrm>
-            <a:off x="640080" y="2743200"/>
-            <a:ext cx="10972800" cy="777240"/>
-          </a:xfrm>
-          <a:prstGeom prst="roundRect">
-            <a:avLst/>
-          </a:prstGeom>
-          <a:solidFill>
-            <a:srgbClr val="E6F7F1"/>
-          </a:solidFill>
-          <a:ln>
-            <a:solidFill>
-              <a:srgbClr val="10B981"/>
-            </a:solidFill>
-          </a:ln>
-        </p:spPr>
-        <p:style>
-          <a:lnRef idx="1">
-            <a:schemeClr val="accent1"/>
-          </a:lnRef>
-          <a:fillRef idx="3">
-            <a:schemeClr val="accent1"/>
-          </a:fillRef>
-          <a:effectRef idx="2">
-            <a:schemeClr val="accent1"/>
-          </a:effectRef>
-          <a:fontRef idx="minor">
-            <a:schemeClr val="lt1"/>
-          </a:fontRef>
-        </p:style>
-        <p:txBody>
-          <a:bodyPr rtlCol="0" anchor="ctr"/>
-          <a:lstStyle/>
-          <a:p>
-            <a:pPr algn="ctr"/>
-          </a:p>
-        </p:txBody>
-      </p:sp>
-      <p:sp>
-        <p:nvSpPr>
-          <p:cNvPr id="12" name="TextBox 11"/>
-          <p:cNvSpPr txBox="1"/>
-          <p:nvPr/>
-        </p:nvSpPr>
-        <p:spPr>
-          <a:xfrm>
-            <a:off x="822960" y="2788920"/>
-            <a:ext cx="10607040" cy="685800"/>
-          </a:xfrm>
-          <a:prstGeom prst="rect">
-            <a:avLst/>
-          </a:prstGeom>
-          <a:noFill/>
-        </p:spPr>
-        <p:txBody>
-          <a:bodyPr wrap="square">
-            <a:spAutoFit/>
-          </a:bodyPr>
-          <a:lstStyle/>
-          <a:p>
-            <a:pPr algn="l"/>
-            <a:r>
-              <a:rPr sz="1300" b="0">
-                <a:solidFill>
-                  <a:srgbClr val="2A2A2A"/>
-                </a:solidFill>
-                <a:latin typeface="Calibri"/>
-              </a:rPr>
-              <a:t>Doble clic en index.html  •  O arrastrar al navegador  •  Debe verse la tienda ECOMARKET</a:t>
-            </a:r>
-          </a:p>
-          <a:p>
-            <a:pPr algn="l"/>
-            <a:r>
-              <a:rPr sz="1300" b="0">
-                <a:solidFill>
-                  <a:srgbClr val="2A2A2A"/>
-                </a:solidFill>
-                <a:latin typeface="Calibri"/>
-              </a:rPr>
-              <a:t>Si ves los productos, el carrito y el modo oscuro → todo funciona ✓</a:t>
-            </a:r>
-          </a:p>
-        </p:txBody>
-      </p:sp>
-      <p:sp>
-        <p:nvSpPr>
-          <p:cNvPr id="13" name="TextBox 12"/>
-          <p:cNvSpPr txBox="1"/>
-          <p:nvPr/>
-        </p:nvSpPr>
-        <p:spPr>
-          <a:xfrm>
-            <a:off x="640080" y="3703320"/>
-            <a:ext cx="10972800" cy="365760"/>
-          </a:xfrm>
-          <a:prstGeom prst="rect">
-            <a:avLst/>
-          </a:prstGeom>
-          <a:noFill/>
-        </p:spPr>
-        <p:txBody>
-          <a:bodyPr wrap="square">
-            <a:spAutoFit/>
-          </a:bodyPr>
-          <a:lstStyle/>
-          <a:p>
-            <a:pPr algn="l"/>
-            <a:r>
-              <a:rPr sz="1800" b="1">
-                <a:solidFill>
-                  <a:srgbClr val="065A82"/>
-                </a:solidFill>
-                <a:latin typeface="Calibri"/>
-              </a:rPr>
-              <a:t>3️⃣  Crear tu repositorio personal (manual, en la web)</a:t>
-            </a:r>
-          </a:p>
-        </p:txBody>
-      </p:sp>
-      <p:sp>
-        <p:nvSpPr>
-          <p:cNvPr id="14" name="Rounded Rectangle 13"/>
-          <p:cNvSpPr/>
-          <p:nvPr/>
-        </p:nvSpPr>
-        <p:spPr>
-          <a:xfrm>
-            <a:off x="640080" y="4069080"/>
-            <a:ext cx="10972800" cy="1371600"/>
-          </a:xfrm>
-          <a:prstGeom prst="roundRect">
-            <a:avLst/>
-          </a:prstGeom>
-          <a:solidFill>
-            <a:srgbClr val="FEF3E6"/>
-          </a:solidFill>
-          <a:ln>
-            <a:solidFill>
-              <a:srgbClr val="EA580C"/>
-            </a:solidFill>
-          </a:ln>
-        </p:spPr>
-        <p:style>
-          <a:lnRef idx="1">
-            <a:schemeClr val="accent1"/>
-          </a:lnRef>
-          <a:fillRef idx="3">
-            <a:schemeClr val="accent1"/>
-          </a:fillRef>
-          <a:effectRef idx="2">
-            <a:schemeClr val="accent1"/>
-          </a:effectRef>
-          <a:fontRef idx="minor">
-            <a:schemeClr val="lt1"/>
-          </a:fontRef>
-        </p:style>
-        <p:txBody>
-          <a:bodyPr rtlCol="0" anchor="ctr"/>
-          <a:lstStyle/>
-          <a:p>
-            <a:pPr algn="ctr"/>
-          </a:p>
-        </p:txBody>
-      </p:sp>
-      <p:sp>
-        <p:nvSpPr>
-          <p:cNvPr id="15" name="TextBox 14"/>
-          <p:cNvSpPr txBox="1"/>
-          <p:nvPr/>
-        </p:nvSpPr>
-        <p:spPr>
-          <a:xfrm>
-            <a:off x="822960" y="4114800"/>
-            <a:ext cx="10607040" cy="1280160"/>
-          </a:xfrm>
-          <a:prstGeom prst="rect">
-            <a:avLst/>
-          </a:prstGeom>
-          <a:noFill/>
-        </p:spPr>
-        <p:txBody>
-          <a:bodyPr wrap="square">
-            <a:spAutoFit/>
-          </a:bodyPr>
-          <a:lstStyle/>
-          <a:p>
-            <a:pPr algn="l"/>
-            <a:r>
-              <a:rPr sz="1200" b="0">
-                <a:solidFill>
-                  <a:srgbClr val="2A2A2A"/>
-                </a:solidFill>
-                <a:latin typeface="Calibri"/>
-              </a:rPr>
-              <a:t>1. Abre https://github.com/new en tu navegador</a:t>
-            </a:r>
-          </a:p>
-          <a:p>
-            <a:pPr algn="l"/>
-            <a:r>
-              <a:rPr sz="1200" b="0">
-                <a:solidFill>
-                  <a:srgbClr val="2A2A2A"/>
-                </a:solidFill>
-                <a:latin typeface="Calibri"/>
-              </a:rPr>
-              <a:t>2. Repository name:  evaluacion-administracion-web-TU-NOMBRE</a:t>
-            </a:r>
-          </a:p>
-          <a:p>
-            <a:pPr algn="l"/>
-            <a:r>
-              <a:rPr sz="1200" b="0">
-                <a:solidFill>
-                  <a:srgbClr val="2A2A2A"/>
-                </a:solidFill>
-                <a:latin typeface="Calibri"/>
-              </a:rPr>
-              <a:t>3. Visibility:  Public</a:t>
-            </a:r>
-          </a:p>
-          <a:p>
-            <a:pPr algn="l"/>
-            <a:r>
-              <a:rPr sz="1200" b="0">
-                <a:solidFill>
-                  <a:srgbClr val="2A2A2A"/>
-                </a:solidFill>
-                <a:latin typeface="Calibri"/>
-              </a:rPr>
-              <a:t>4. NO inicialices con README, .gitignore ni license (déjalo vacío)</a:t>
-            </a:r>
-          </a:p>
-          <a:p>
-            <a:pPr algn="l"/>
-            <a:r>
-              <a:rPr sz="1200" b="0">
-                <a:solidFill>
-                  <a:srgbClr val="2A2A2A"/>
-                </a:solidFill>
-                <a:latin typeface="Calibri"/>
-              </a:rPr>
-              <a:t>5. Clic en Create repository  →  Copia la URL HTTPS que te muestra</a:t>
-            </a:r>
-          </a:p>
-        </p:txBody>
-      </p:sp>
-      <p:sp>
-        <p:nvSpPr>
-          <p:cNvPr id="16" name="TextBox 15"/>
-          <p:cNvSpPr txBox="1"/>
-          <p:nvPr/>
-        </p:nvSpPr>
-        <p:spPr>
-          <a:xfrm>
-            <a:off x="640080" y="5623560"/>
-            <a:ext cx="10972800" cy="365760"/>
-          </a:xfrm>
-          <a:prstGeom prst="rect">
-            <a:avLst/>
-          </a:prstGeom>
-          <a:noFill/>
-        </p:spPr>
-        <p:txBody>
-          <a:bodyPr wrap="square">
-            <a:spAutoFit/>
-          </a:bodyPr>
-          <a:lstStyle/>
-          <a:p>
-            <a:pPr algn="l"/>
-            <a:r>
-              <a:rPr sz="1800" b="1">
-                <a:solidFill>
-                  <a:srgbClr val="065A82"/>
-                </a:solidFill>
-                <a:latin typeface="Calibri"/>
-              </a:rPr>
-              <a:t>4️⃣  Conectar y subir con git puro</a:t>
-            </a:r>
-          </a:p>
-        </p:txBody>
-      </p:sp>
-      <p:sp>
-        <p:nvSpPr>
-          <p:cNvPr id="17" name="Rounded Rectangle 16"/>
-          <p:cNvSpPr/>
-          <p:nvPr/>
-        </p:nvSpPr>
-        <p:spPr>
-          <a:xfrm>
-            <a:off x="640080" y="5989320"/>
-            <a:ext cx="10972800" cy="777240"/>
-          </a:xfrm>
-          <a:prstGeom prst="roundRect">
-            <a:avLst/>
-          </a:prstGeom>
-          <a:solidFill>
-            <a:srgbClr val="2A2A2A"/>
-          </a:solidFill>
-          <a:ln>
-            <a:solidFill>
-              <a:srgbClr val="1C7293"/>
-            </a:solidFill>
-          </a:ln>
-        </p:spPr>
-        <p:style>
-          <a:lnRef idx="1">
-            <a:schemeClr val="accent1"/>
-          </a:lnRef>
-          <a:fillRef idx="3">
-            <a:schemeClr val="accent1"/>
-          </a:fillRef>
-          <a:effectRef idx="2">
-            <a:schemeClr val="accent1"/>
-          </a:effectRef>
-          <a:fontRef idx="minor">
-            <a:schemeClr val="lt1"/>
-          </a:fontRef>
-        </p:style>
-        <p:txBody>
-          <a:bodyPr rtlCol="0" anchor="ctr"/>
-          <a:lstStyle/>
-          <a:p>
-            <a:pPr algn="ctr"/>
-          </a:p>
-        </p:txBody>
-      </p:sp>
-      <p:sp>
-        <p:nvSpPr>
-          <p:cNvPr id="18" name="TextBox 17"/>
-          <p:cNvSpPr txBox="1"/>
-          <p:nvPr/>
-        </p:nvSpPr>
-        <p:spPr>
-          <a:xfrm>
-            <a:off x="822960" y="6035040"/>
-            <a:ext cx="10607040" cy="274320"/>
-          </a:xfrm>
-          <a:prstGeom prst="rect">
-            <a:avLst/>
-          </a:prstGeom>
-          <a:noFill/>
-        </p:spPr>
-        <p:txBody>
-          <a:bodyPr wrap="square">
-            <a:spAutoFit/>
-          </a:bodyPr>
-          <a:lstStyle/>
-          <a:p>
-            <a:pPr algn="l"/>
-            <a:r>
-              <a:rPr sz="1100" b="0">
-                <a:solidFill>
-                  <a:srgbClr val="FFFFFF"/>
-                </a:solidFill>
-                <a:latin typeface="Consolas"/>
-              </a:rPr>
-              <a:t>$ git remote add origin https://github.com/TU-USUARIO/evaluacion-administracion-web-TU-NOMBRE.git</a:t>
-            </a:r>
-          </a:p>
-        </p:txBody>
-      </p:sp>
-      <p:sp>
-        <p:nvSpPr>
-          <p:cNvPr id="19" name="TextBox 18"/>
-          <p:cNvSpPr txBox="1"/>
-          <p:nvPr/>
-        </p:nvSpPr>
-        <p:spPr>
-          <a:xfrm>
-            <a:off x="822960" y="6309360"/>
-            <a:ext cx="10607040" cy="274320"/>
-          </a:xfrm>
-          <a:prstGeom prst="rect">
-            <a:avLst/>
-          </a:prstGeom>
-          <a:noFill/>
-        </p:spPr>
-        <p:txBody>
-          <a:bodyPr wrap="square">
-            <a:spAutoFit/>
-          </a:bodyPr>
-          <a:lstStyle/>
-          <a:p>
-            <a:pPr algn="l"/>
-            <a:r>
-              <a:rPr sz="1200" b="0">
-                <a:solidFill>
-                  <a:srgbClr val="FFFFFF"/>
-                </a:solidFill>
-                <a:latin typeface="Consolas"/>
-              </a:rPr>
-              <a:t>$ git branch -M main</a:t>
-            </a:r>
-          </a:p>
-        </p:txBody>
-      </p:sp>
-      <p:sp>
-        <p:nvSpPr>
-          <p:cNvPr id="20" name="TextBox 19"/>
-          <p:cNvSpPr txBox="1"/>
-          <p:nvPr/>
-        </p:nvSpPr>
-        <p:spPr>
-          <a:xfrm>
-            <a:off x="822960" y="6537960"/>
-            <a:ext cx="10607040" cy="274320"/>
-          </a:xfrm>
-          <a:prstGeom prst="rect">
-            <a:avLst/>
-          </a:prstGeom>
-          <a:noFill/>
-        </p:spPr>
-        <p:txBody>
-          <a:bodyPr wrap="square">
-            <a:spAutoFit/>
-          </a:bodyPr>
-          <a:lstStyle/>
-          <a:p>
-            <a:pPr algn="l"/>
-            <a:r>
-              <a:rPr sz="1200" b="0">
-                <a:solidFill>
-                  <a:srgbClr val="FFFFFF"/>
-                </a:solidFill>
-                <a:latin typeface="Consolas"/>
-              </a:rPr>
-              <a:t>$ git push -u origin main</a:t>
-            </a:r>
-          </a:p>
-        </p:txBody>
-      </p:sp>
-      <p:sp>
-        <p:nvSpPr>
-          <p:cNvPr id="21" name="TextBox 20"/>
-          <p:cNvSpPr txBox="1"/>
-          <p:nvPr/>
-        </p:nvSpPr>
-        <p:spPr>
-          <a:xfrm>
-            <a:off x="457200" y="6903720"/>
-            <a:ext cx="10972800" cy="274320"/>
-          </a:xfrm>
-          <a:prstGeom prst="rect">
-            <a:avLst/>
-          </a:prstGeom>
-          <a:noFill/>
-        </p:spPr>
-        <p:txBody>
-          <a:bodyPr wrap="square">
-            <a:spAutoFit/>
-          </a:bodyPr>
-          <a:lstStyle/>
-          <a:p>
-            <a:pPr algn="l"/>
-            <a:r>
-              <a:rPr sz="1000" b="0">
-                <a:solidFill>
-                  <a:srgbClr val="666666"/>
-                </a:solidFill>
-                <a:latin typeface="Calibri"/>
-              </a:rPr>
-              <a:t>💡 No se exige memorizar comandos. Si logras subir el código, está bien.</a:t>
-            </a:r>
-          </a:p>
-        </p:txBody>
-      </p:sp>
-    </p:spTree>
-  </p:cSld>
-  <p:clrMapOvr>
-    <a:masterClrMapping/>
-  </p:clrMapOvr>
-</p:sld>
+<file path=ppt/slides/slide5.xml><?xml version='1.0' encoding='UTF-8' standalone='yes'?>
+<p:sld xmlns:a="http://schemas.openxmlformats.org/drawingml/2006/main" xmlns:p="http://schemas.openxmlformats.org/presentationml/2006/main" xmlns:r="http://schemas.openxmlformats.org/officeDocument/2006/relationships"><p:cSld><p:spTree><p:nvGrpSpPr><p:cNvPr id="1" name=""/><p:cNvGrpSpPr/><p:nvPr/></p:nvGrpSpPr><p:grpSpPr/><p:sp><p:nvSpPr><p:cNvPr id="2" name="Rectangle 1"/><p:cNvSpPr/><p:nvPr/></p:nvSpPr><p:spPr><a:xfrm><a:off x="0" y="0"/><a:ext cx="12191695" cy="6858000"/></a:xfrm><a:prstGeom prst="rect"><a:avLst/></a:prstGeom><a:solidFill><a:srgbClr val="FFFFFF"/></a:solidFill><a:ln><a:noFill/></a:ln></p:spPr><p:style><a:lnRef idx="1"><a:schemeClr val="accent1"/></a:lnRef><a:fillRef idx="3"><a:schemeClr val="accent1"/></a:fillRef><a:effectRef idx="2"><a:schemeClr val="accent1"/></a:effectRef><a:fontRef idx="minor"><a:schemeClr val="lt1"/></a:fontRef></p:style><p:txBody><a:bodyPr rtlCol="0" anchor="ctr"/><a:lstStyle/><a:p><a:pPr algn="ctr"/></a:p></p:txBody></p:sp><p:sp><p:nvSpPr><p:cNvPr id="3" name="Rectangle 2"/><p:cNvSpPr/><p:nvPr/></p:nvSpPr><p:spPr><a:xfrm><a:off x="0" y="0"/><a:ext cx="12191695" cy="914400"/></a:xfrm><a:prstGeom prst="rect"><a:avLst/></a:prstGeom><a:solidFill><a:srgbClr val="065A82"/></a:solidFill><a:ln><a:noFill/></a:ln></p:spPr><p:style><a:lnRef idx="1"><a:schemeClr val="accent1"/></a:lnRef><a:fillRef idx="3"><a:schemeClr val="accent1"/></a:fillRef><a:effectRef idx="2"><a:schemeClr val="accent1"/></a:effectRef><a:fontRef idx="minor"><a:schemeClr val="lt1"/></a:fontRef></p:style><p:txBody><a:bodyPr rtlCol="0" anchor="ctr"/><a:lstStyle/><a:p><a:pPr algn="ctr"/></a:p></p:txBody></p:sp><p:sp><p:nvSpPr><p:cNvPr id="4" name="TextBox 3"/><p:cNvSpPr txBox="1"/><p:nvPr/></p:nvSpPr><p:spPr><a:xfrm><a:off x="457200" y="274320"/><a:ext cx="10972800" cy="457200"/></a:xfrm><a:prstGeom prst="rect"><a:avLst/></a:prstGeom><a:noFill/></p:spPr><p:txBody><a:bodyPr wrap="square"><a:spAutoFit/></a:bodyPr><a:lstStyle/><a:p><a:pPr algn="l"/><a:r><a:rPr sz="3200" b="1"><a:solidFill><a:srgbClr val="FFFFFF"/></a:solidFill><a:latin typeface="Calibri"/></a:rPr><a:t>Parte 1 · Clonar, verificar y subir</a:t></a:r></a:p></p:txBody></p:sp><p:sp><p:nvSpPr><p:cNvPr id="5" name="TextBox 4"/><p:cNvSpPr txBox="1"/><p:nvPr/></p:nvSpPr><p:spPr><a:xfrm><a:off x="457200" y="685800"/><a:ext cx="10972800" cy="274320"/></a:xfrm><a:prstGeom prst="rect"><a:avLst/></a:prstGeom><a:noFill/></p:spPr><p:txBody><a:bodyPr wrap="square"><a:spAutoFit/></a:bodyPr><a:lstStyle/><a:p><a:pPr algn="l"/><a:r><a:rPr sz="1400" b="0"><a:solidFill><a:srgbClr val="60A5FA"/></a:solidFill><a:latin typeface="Calibri"/></a:rPr><a:t>⏱ 10 minutos  •  Solo git (sin gh CLI)</a:t></a:r></a:p></p:txBody></p:sp><p:sp><p:nvSpPr><p:cNvPr id="6" name="TextBox 5"/><p:cNvSpPr txBox="1"/><p:nvPr/></p:nvSpPr><p:spPr><a:xfrm><a:off x="640080" y="1188720"/><a:ext cx="10972800" cy="365760"/></a:xfrm><a:prstGeom prst="rect"><a:avLst/></a:prstGeom><a:noFill/></p:spPr><p:txBody><a:bodyPr wrap="square"><a:spAutoFit/></a:bodyPr><a:lstStyle/><a:p><a:pPr algn="l"/><a:r><a:rPr sz="1800" b="1"><a:solidFill><a:srgbClr val="065A82"/></a:solidFill><a:latin typeface="Calibri"/></a:rPr><a:t>1️⃣  Clonar el repositorio del docente</a:t></a:r></a:p></p:txBody></p:sp><p:sp><p:nvSpPr><p:cNvPr id="7" name="Rounded Rectangle 6"/><p:cNvSpPr/><p:nvPr/></p:nvSpPr><p:spPr><a:xfrm><a:off x="640080" y="1554480"/><a:ext cx="10972800" cy="594360"/></a:xfrm><a:prstGeom prst="roundRect"><a:avLst/></a:prstGeom><a:solidFill><a:srgbClr val="2A2A2A"/></a:solidFill><a:ln><a:solidFill><a:srgbClr val="1C7293"/></a:solidFill></a:ln></p:spPr><p:style><a:lnRef idx="1"><a:schemeClr val="accent1"/></a:lnRef><a:fillRef idx="3"><a:schemeClr val="accent1"/></a:fillRef><a:effectRef idx="2"><a:schemeClr val="accent1"/></a:effectRef><a:fontRef idx="minor"><a:schemeClr val="lt1"/></a:fontRef></p:style><p:txBody><a:bodyPr rtlCol="0" anchor="ctr"/><a:lstStyle/><a:p><a:pPr algn="ctr"/></a:p></p:txBody></p:sp><p:sp><p:nvSpPr><p:cNvPr id="8" name="TextBox 7"/><p:cNvSpPr txBox="1"/><p:nvPr/></p:nvSpPr><p:spPr><a:xfrm><a:off x="822960" y="1627632"/><a:ext cx="10607040" cy="457200"/></a:xfrm><a:prstGeom prst="rect"><a:avLst/></a:prstGeom><a:noFill/></p:spPr><p:txBody><a:bodyPr wrap="square"><a:spAutoFit/></a:bodyPr><a:lstStyle/><a:p><a:pPr algn="l"/><a:r><a:rPr sz="1400" b="0"><a:solidFill><a:srgbClr val="FFFFFF"/></a:solidFill><a:latin typeface="Consolas"/></a:rPr><a:t>$ git clone https://github.com/KrizRoMe/evaluacion-administracion-web.git</a:t></a:r></a:p></p:txBody></p:sp><p:sp><p:nvSpPr><p:cNvPr id="9" name="TextBox 8"/><p:cNvSpPr txBox="1"/><p:nvPr/></p:nvSpPr><p:spPr><a:xfrm><a:off x="822960" y="1920240"/><a:ext cx="10607040" cy="274320"/></a:xfrm><a:prstGeom prst="rect"><a:avLst/></a:prstGeom><a:noFill/></p:spPr><p:txBody><a:bodyPr wrap="square"><a:spAutoFit/></a:bodyPr><a:lstStyle/><a:p><a:pPr algn="l"/><a:r><a:rPr sz="1400" b="0"><a:solidFill><a:srgbClr val="FFFFFF"/></a:solidFill><a:latin typeface="Consolas"/></a:rPr><a:t>$ cd evaluacion-administracion-web</a:t></a:r></a:p></p:txBody></p:sp><p:sp><p:nvSpPr><p:cNvPr id="10" name="TextBox 9"/><p:cNvSpPr txBox="1"/><p:nvPr/></p:nvSpPr><p:spPr><a:xfrm><a:off x="640080" y="2377440"/><a:ext cx="10972800" cy="365760"/></a:xfrm><a:prstGeom prst="rect"><a:avLst/></a:prstGeom><a:noFill/></p:spPr><p:txBody><a:bodyPr wrap="square"><a:spAutoFit/></a:bodyPr><a:lstStyle/><a:p><a:pPr algn="l"/><a:r><a:rPr sz="1800" b="1"><a:solidFill><a:srgbClr val="065A82"/></a:solidFill><a:latin typeface="Calibri"/></a:rPr><a:t>2️⃣  Verificar que el sitio funciona localmente</a:t></a:r></a:p></p:txBody></p:sp><p:sp><p:nvSpPr><p:cNvPr id="11" name="Rounded Rectangle 10"/><p:cNvSpPr/><p:nvPr/></p:nvSpPr><p:spPr><a:xfrm><a:off x="640080" y="2743200"/><a:ext cx="10972800" cy="777240"/></a:xfrm><a:prstGeom prst="roundRect"><a:avLst/></a:prstGeom><a:solidFill><a:srgbClr val="E6F7F1"/></a:solidFill><a:ln><a:solidFill><a:srgbClr val="10B981"/></a:solidFill></a:ln></p:spPr><p:style><a:lnRef idx="1"><a:schemeClr val="accent1"/></a:lnRef><a:fillRef idx="3"><a:schemeClr val="accent1"/></a:fillRef><a:effectRef idx="2"><a:schemeClr val="accent1"/></a:effectRef><a:fontRef idx="minor"><a:schemeClr val="lt1"/></a:fontRef></p:style><p:txBody><a:bodyPr rtlCol="0" anchor="ctr"/><a:lstStyle/><a:p><a:pPr algn="ctr"/></a:p></p:txBody></p:sp><p:sp><p:nvSpPr><p:cNvPr id="12" name="TextBox 11"/><p:cNvSpPr txBox="1"/><p:nvPr/></p:nvSpPr><p:spPr><a:xfrm><a:off x="822960" y="2788920"/><a:ext cx="10607040" cy="685800"/></a:xfrm><a:prstGeom prst="rect"><a:avLst/></a:prstGeom><a:noFill/></p:spPr><p:txBody><a:bodyPr wrap="square"><a:spAutoFit/></a:bodyPr><a:lstStyle/><a:p><a:pPr algn="l"/><a:r><a:rPr sz="1300" b="0"><a:solidFill><a:srgbClr val="2A2A2A"/></a:solidFill><a:latin typeface="Calibri"/></a:rPr><a:t>Doble clic en index.html  •  O arrastrar al navegador  •  Debe verse la tienda ECOMARKET</a:t></a:r></a:p><a:p><a:pPr algn="l"/><a:r><a:rPr sz="1300" b="0"><a:solidFill><a:srgbClr val="2A2A2A"/></a:solidFill><a:latin typeface="Calibri"/></a:rPr><a:t>Si ves los productos, el carrito y el modo oscuro → todo funciona ✓</a:t></a:r></a:p></p:txBody></p:sp><p:sp><p:nvSpPr><p:cNvPr id="13" name="TextBox 12"/><p:cNvSpPr txBox="1"/><p:nvPr/></p:nvSpPr><p:spPr><a:xfrm><a:off x="640080" y="3703320"/><a:ext cx="10972800" cy="365760"/></a:xfrm><a:prstGeom prst="rect"><a:avLst/></a:prstGeom><a:noFill/></p:spPr><p:txBody><a:bodyPr wrap="square"><a:spAutoFit/></a:bodyPr><a:lstStyle/><a:p><a:pPr algn="l"/><a:r><a:rPr sz="1800" b="1"><a:solidFill><a:srgbClr val="065A82"/></a:solidFill><a:latin typeface="Calibri"/></a:rPr><a:t>3️⃣  Crear tu repositorio personal (manual, en la web)</a:t></a:r></a:p></p:txBody></p:sp><p:sp><p:nvSpPr><p:cNvPr id="14" name="Rounded Rectangle 13"/><p:cNvSpPr/><p:nvPr/></p:nvSpPr><p:spPr><a:xfrm><a:off x="640080" y="4069080"/><a:ext cx="10972800" cy="1371600"/></a:xfrm><a:prstGeom prst="roundRect"><a:avLst/></a:prstGeom><a:solidFill><a:srgbClr val="FEF3E6"/></a:solidFill><a:ln><a:solidFill><a:srgbClr val="EA580C"/></a:solidFill></a:ln></p:spPr><p:style><a:lnRef idx="1"><a:schemeClr val="accent1"/></a:lnRef><a:fillRef idx="3"><a:schemeClr val="accent1"/></a:fillRef><a:effectRef idx="2"><a:schemeClr val="accent1"/></a:effectRef><a:fontRef idx="minor"><a:schemeClr val="lt1"/></a:fontRef></p:style><p:txBody><a:bodyPr rtlCol="0" anchor="ctr"/><a:lstStyle/><a:p><a:pPr algn="ctr"/></a:p></p:txBody></p:sp><p:sp><p:nvSpPr><p:cNvPr id="15" name="TextBox 14"/><p:cNvSpPr txBox="1"/><p:nvPr/></p:nvSpPr><p:spPr><a:xfrm><a:off x="822960" y="4114800"/><a:ext cx="10607040" cy="1280160"/></a:xfrm><a:prstGeom prst="rect"><a:avLst/></a:prstGeom><a:noFill/></p:spPr><p:txBody><a:bodyPr wrap="square"><a:spAutoFit/></a:bodyPr><a:lstStyle/><a:p><a:pPr algn="l"/><a:r><a:rPr sz="1200" b="0"><a:solidFill><a:srgbClr val="2A2A2A"/></a:solidFill><a:latin typeface="Calibri"/></a:rPr><a:t>1. Abre https://github.com/new en tu navegador</a:t></a:r></a:p><a:p><a:pPr algn="l"/><a:r><a:rPr sz="1200" b="0"><a:solidFill><a:srgbClr val="2A2A2A"/></a:solidFill><a:latin typeface="Calibri"/></a:rPr><a:t>2. Repository name:  evaluacion-administracion-web-TU-NOMBRE</a:t></a:r></a:p><a:p><a:pPr algn="l"/><a:r><a:rPr sz="1200" b="0"><a:solidFill><a:srgbClr val="2A2A2A"/></a:solidFill><a:latin typeface="Calibri"/></a:rPr><a:t>3. Visibility:  Public</a:t></a:r></a:p><a:p><a:pPr algn="l"/><a:r><a:rPr sz="1200" b="0"><a:solidFill><a:srgbClr val="2A2A2A"/></a:solidFill><a:latin typeface="Calibri"/></a:rPr><a:t>4. NO inicialices con README, .gitignore ni license (déjalo vacío)</a:t></a:r></a:p><a:p><a:pPr algn="l"/><a:r><a:rPr sz="1200" b="0"><a:solidFill><a:srgbClr val="2A2A2A"/></a:solidFill><a:latin typeface="Calibri"/></a:rPr><a:t>5. Clic en Create repository  →  Copia la URL HTTPS que te muestra</a:t></a:r></a:p></p:txBody></p:sp><p:sp><p:nvSpPr><p:cNvPr id="16" name="TextBox 15"/><p:cNvSpPr txBox="1"/><p:nvPr/></p:nvSpPr><p:spPr><a:xfrm><a:off x="640080" y="5623560"/><a:ext cx="10972800" cy="365760"/></a:xfrm><a:prstGeom prst="rect"><a:avLst/></a:prstGeom><a:noFill/></p:spPr><p:txBody><a:bodyPr wrap="square"><a:spAutoFit/></a:bodyPr><a:lstStyle/><a:p><a:pPr algn="l"/><a:r><a:rPr sz="1800" b="1"><a:solidFill><a:srgbClr val="065A82"/></a:solidFill><a:latin typeface="Calibri"/></a:rPr><a:t>4️⃣  Conectar y subir con git puro</a:t></a:r></a:p></p:txBody></p:sp><p:sp><p:nvSpPr><p:cNvPr id="17" name="Rounded Rectangle 16"/><p:cNvSpPr/><p:nvPr/></p:nvSpPr><p:spPr><a:xfrm><a:off x="640080" y="5989320"/><a:ext cx="10972800" cy="777240"/></a:xfrm><a:prstGeom prst="roundRect"><a:avLst/></a:prstGeom><a:solidFill><a:srgbClr val="2A2A2A"/></a:solidFill><a:ln><a:solidFill><a:srgbClr val="1C7293"/></a:solidFill></a:ln></p:spPr><p:style><a:lnRef idx="1"><a:schemeClr val="accent1"/></a:lnRef><a:fillRef idx="3"><a:schemeClr val="accent1"/></a:fillRef><a:effectRef idx="2"><a:schemeClr val="accent1"/></a:effectRef><a:fontRef idx="minor"><a:schemeClr val="lt1"/></a:fontRef></p:style><p:txBody><a:bodyPr rtlCol="0" anchor="ctr"/><a:lstStyle/><a:p><a:pPr algn="ctr"/></a:p></p:txBody></p:sp><p:sp><p:nvSpPr><p:cNvPr id="18" name="TextBox 17"/><p:cNvSpPr txBox="1"/><p:nvPr/></p:nvSpPr><p:spPr><a:xfrm><a:off x="822960" y="6035040"/><a:ext cx="10607040" cy="274320"/></a:xfrm><a:prstGeom prst="rect"><a:avLst/></a:prstGeom><a:noFill/></p:spPr><p:txBody><a:bodyPr wrap="square"><a:spAutoFit/></a:bodyPr><a:lstStyle/><a:p><a:pPr algn="l"/><a:r><a:rPr sz="1100" b="0"><a:solidFill><a:srgbClr val="FFFFFF"/></a:solidFill><a:latin typeface="Consolas"/></a:rPr><a:t>$ git remote set-url origin https://github.com/TU-USUARIO/evaluacion-administracion-web-TU-NOMBRE.git</a:t></a:r></a:r><a:r><a:rPr lang="es-PE" sz="1100"><a:solidFill><a:srgbClr val="666666"/></a:solidFill><a:latin typeface="Consolas"/></a:rPr><a:t>(ya existe porque hiciste git clone, no add)</a:t></a:r></a:p></p:txBody></p:sp><p:sp><p:nvSpPr><p:cNvPr id="19" name="TextBox 18"/><p:cNvSpPr txBox="1"/><p:nvPr/></p:nvSpPr><p:spPr><a:xfrm><a:off x="822960" y="6309360"/><a:ext cx="10607040" cy="274320"/></a:xfrm><a:prstGeom prst="rect"><a:avLst/></a:prstGeom><a:noFill/></p:spPr><p:txBody><a:bodyPr wrap="square"><a:spAutoFit/></a:bodyPr><a:lstStyle/><a:p><a:pPr algn="l"/><a:r><a:rPr sz="1200" b="0"><a:solidFill><a:srgbClr val="FFFFFF"/></a:solidFill><a:latin typeface="Consolas"/></a:rPr><a:t>$ git branch -M main</a:t></a:r></a:p></p:txBody></p:sp><p:sp><p:nvSpPr><p:cNvPr id="20" name="TextBox 19"/><p:cNvSpPr txBox="1"/><p:nvPr/></p:nvSpPr><p:spPr><a:xfrm><a:off x="822960" y="6537960"/><a:ext cx="10607040" cy="274320"/></a:xfrm><a:prstGeom prst="rect"><a:avLst/></a:prstGeom><a:noFill/></p:spPr><p:txBody><a:bodyPr wrap="square"><a:spAutoFit/></a:bodyPr><a:lstStyle/><a:p><a:pPr algn="l"/><a:r><a:rPr sz="1200" b="0"><a:solidFill><a:srgbClr val="FFFFFF"/></a:solidFill><a:latin typeface="Consolas"/></a:rPr><a:t>$ git push -u origin main</a:t></a:r></a:p></p:txBody></p:sp><p:sp><p:nvSpPr><p:cNvPr id="21" name="TextBox 20"/><p:cNvSpPr txBox="1"/><p:nvPr/></p:nvSpPr><p:spPr><a:xfrm><a:off x="457200" y="6903720"/><a:ext cx="10972800" cy="274320"/></a:xfrm><a:prstGeom prst="rect"><a:avLst/></a:prstGeom><a:noFill/></p:spPr><p:txBody><a:bodyPr wrap="square"><a:spAutoFit/></a:bodyPr><a:lstStyle/><a:p><a:pPr algn="l"/><a:r><a:rPr sz="1000" b="0"><a:solidFill><a:srgbClr val="666666"/></a:solidFill><a:latin typeface="Calibri"/></a:rPr><a:t>💡 No se exige memorizar comandos. Si logras subir el código, está bien.</a:t></a:r></a:p></p:txBody></p:sp></p:spTree></p:cSld><p:clrMapOvr><a:masterClrMapping/></p:clrMapOvr></p:sld>
 </file>
 
 <file path=ppt/slides/slide6.xml><?xml version="1.0" encoding="utf-8"?>

</xml_diff>

<commit_message>
fix: usar git remote set-url (no add)
</commit_message>
<xml_diff>
--- a/EVALUACION_PRACTICA_01.pptx
+++ b/EVALUACION_PRACTICA_01.pptx
@@ -7503,838 +7503,8 @@
 </p:sld>
 </file>
 
-<file path=ppt/slides/slide5.xml><?xml version="1.0" encoding="utf-8"?>
-<p:sld xmlns:a="http://schemas.openxmlformats.org/drawingml/2006/main" xmlns:p="http://schemas.openxmlformats.org/presentationml/2006/main" xmlns:r="http://schemas.openxmlformats.org/officeDocument/2006/relationships">
-  <p:cSld>
-    <p:spTree>
-      <p:nvGrpSpPr>
-        <p:cNvPr id="1" name=""/>
-        <p:cNvGrpSpPr/>
-        <p:nvPr/>
-      </p:nvGrpSpPr>
-      <p:grpSpPr/>
-      <p:sp>
-        <p:nvSpPr>
-          <p:cNvPr id="2" name="Rectangle 1"/>
-          <p:cNvSpPr/>
-          <p:nvPr/>
-        </p:nvSpPr>
-        <p:spPr>
-          <a:xfrm>
-            <a:off x="0" y="0"/>
-            <a:ext cx="12191695" cy="6858000"/>
-          </a:xfrm>
-          <a:prstGeom prst="rect">
-            <a:avLst/>
-          </a:prstGeom>
-          <a:solidFill>
-            <a:srgbClr val="FFFFFF"/>
-          </a:solidFill>
-          <a:ln>
-            <a:noFill/>
-          </a:ln>
-        </p:spPr>
-        <p:style>
-          <a:lnRef idx="1">
-            <a:schemeClr val="accent1"/>
-          </a:lnRef>
-          <a:fillRef idx="3">
-            <a:schemeClr val="accent1"/>
-          </a:fillRef>
-          <a:effectRef idx="2">
-            <a:schemeClr val="accent1"/>
-          </a:effectRef>
-          <a:fontRef idx="minor">
-            <a:schemeClr val="lt1"/>
-          </a:fontRef>
-        </p:style>
-        <p:txBody>
-          <a:bodyPr rtlCol="0" anchor="ctr"/>
-          <a:lstStyle/>
-          <a:p>
-            <a:pPr algn="ctr"/>
-          </a:p>
-        </p:txBody>
-      </p:sp>
-      <p:sp>
-        <p:nvSpPr>
-          <p:cNvPr id="3" name="Rectangle 2"/>
-          <p:cNvSpPr/>
-          <p:nvPr/>
-        </p:nvSpPr>
-        <p:spPr>
-          <a:xfrm>
-            <a:off x="0" y="0"/>
-            <a:ext cx="12191695" cy="914400"/>
-          </a:xfrm>
-          <a:prstGeom prst="rect">
-            <a:avLst/>
-          </a:prstGeom>
-          <a:solidFill>
-            <a:srgbClr val="065A82"/>
-          </a:solidFill>
-          <a:ln>
-            <a:noFill/>
-          </a:ln>
-        </p:spPr>
-        <p:style>
-          <a:lnRef idx="1">
-            <a:schemeClr val="accent1"/>
-          </a:lnRef>
-          <a:fillRef idx="3">
-            <a:schemeClr val="accent1"/>
-          </a:fillRef>
-          <a:effectRef idx="2">
-            <a:schemeClr val="accent1"/>
-          </a:effectRef>
-          <a:fontRef idx="minor">
-            <a:schemeClr val="lt1"/>
-          </a:fontRef>
-        </p:style>
-        <p:txBody>
-          <a:bodyPr rtlCol="0" anchor="ctr"/>
-          <a:lstStyle/>
-          <a:p>
-            <a:pPr algn="ctr"/>
-          </a:p>
-        </p:txBody>
-      </p:sp>
-      <p:sp>
-        <p:nvSpPr>
-          <p:cNvPr id="4" name="TextBox 3"/>
-          <p:cNvSpPr txBox="1"/>
-          <p:nvPr/>
-        </p:nvSpPr>
-        <p:spPr>
-          <a:xfrm>
-            <a:off x="457200" y="274320"/>
-            <a:ext cx="10972800" cy="457200"/>
-          </a:xfrm>
-          <a:prstGeom prst="rect">
-            <a:avLst/>
-          </a:prstGeom>
-          <a:noFill/>
-        </p:spPr>
-        <p:txBody>
-          <a:bodyPr wrap="square">
-            <a:spAutoFit/>
-          </a:bodyPr>
-          <a:lstStyle/>
-          <a:p>
-            <a:pPr algn="l"/>
-            <a:r>
-              <a:rPr sz="3200" b="1">
-                <a:solidFill>
-                  <a:srgbClr val="FFFFFF"/>
-                </a:solidFill>
-                <a:latin typeface="Calibri"/>
-              </a:rPr>
-              <a:t>Parte 1 · Clonar, verificar y subir</a:t>
-            </a:r>
-          </a:p>
-        </p:txBody>
-      </p:sp>
-      <p:sp>
-        <p:nvSpPr>
-          <p:cNvPr id="5" name="TextBox 4"/>
-          <p:cNvSpPr txBox="1"/>
-          <p:nvPr/>
-        </p:nvSpPr>
-        <p:spPr>
-          <a:xfrm>
-            <a:off x="457200" y="685800"/>
-            <a:ext cx="10972800" cy="274320"/>
-          </a:xfrm>
-          <a:prstGeom prst="rect">
-            <a:avLst/>
-          </a:prstGeom>
-          <a:noFill/>
-        </p:spPr>
-        <p:txBody>
-          <a:bodyPr wrap="square">
-            <a:spAutoFit/>
-          </a:bodyPr>
-          <a:lstStyle/>
-          <a:p>
-            <a:pPr algn="l"/>
-            <a:r>
-              <a:rPr sz="1400" b="0">
-                <a:solidFill>
-                  <a:srgbClr val="60A5FA"/>
-                </a:solidFill>
-                <a:latin typeface="Calibri"/>
-              </a:rPr>
-              <a:t>⏱ 10 minutos  •  Solo git (sin gh CLI)</a:t>
-            </a:r>
-          </a:p>
-        </p:txBody>
-      </p:sp>
-      <p:sp>
-        <p:nvSpPr>
-          <p:cNvPr id="6" name="TextBox 5"/>
-          <p:cNvSpPr txBox="1"/>
-          <p:nvPr/>
-        </p:nvSpPr>
-        <p:spPr>
-          <a:xfrm>
-            <a:off x="640080" y="1188720"/>
-            <a:ext cx="10972800" cy="365760"/>
-          </a:xfrm>
-          <a:prstGeom prst="rect">
-            <a:avLst/>
-          </a:prstGeom>
-          <a:noFill/>
-        </p:spPr>
-        <p:txBody>
-          <a:bodyPr wrap="square">
-            <a:spAutoFit/>
-          </a:bodyPr>
-          <a:lstStyle/>
-          <a:p>
-            <a:pPr algn="l"/>
-            <a:r>
-              <a:rPr sz="1800" b="1">
-                <a:solidFill>
-                  <a:srgbClr val="065A82"/>
-                </a:solidFill>
-                <a:latin typeface="Calibri"/>
-              </a:rPr>
-              <a:t>1️⃣  Clonar el repositorio del docente</a:t>
-            </a:r>
-          </a:p>
-        </p:txBody>
-      </p:sp>
-      <p:sp>
-        <p:nvSpPr>
-          <p:cNvPr id="7" name="Rounded Rectangle 6"/>
-          <p:cNvSpPr/>
-          <p:nvPr/>
-        </p:nvSpPr>
-        <p:spPr>
-          <a:xfrm>
-            <a:off x="640080" y="1554480"/>
-            <a:ext cx="10972800" cy="594360"/>
-          </a:xfrm>
-          <a:prstGeom prst="roundRect">
-            <a:avLst/>
-          </a:prstGeom>
-          <a:solidFill>
-            <a:srgbClr val="2A2A2A"/>
-          </a:solidFill>
-          <a:ln>
-            <a:solidFill>
-              <a:srgbClr val="1C7293"/>
-            </a:solidFill>
-          </a:ln>
-        </p:spPr>
-        <p:style>
-          <a:lnRef idx="1">
-            <a:schemeClr val="accent1"/>
-          </a:lnRef>
-          <a:fillRef idx="3">
-            <a:schemeClr val="accent1"/>
-          </a:fillRef>
-          <a:effectRef idx="2">
-            <a:schemeClr val="accent1"/>
-          </a:effectRef>
-          <a:fontRef idx="minor">
-            <a:schemeClr val="lt1"/>
-          </a:fontRef>
-        </p:style>
-        <p:txBody>
-          <a:bodyPr rtlCol="0" anchor="ctr"/>
-          <a:lstStyle/>
-          <a:p>
-            <a:pPr algn="ctr"/>
-          </a:p>
-        </p:txBody>
-      </p:sp>
-      <p:sp>
-        <p:nvSpPr>
-          <p:cNvPr id="8" name="TextBox 7"/>
-          <p:cNvSpPr txBox="1"/>
-          <p:nvPr/>
-        </p:nvSpPr>
-        <p:spPr>
-          <a:xfrm>
-            <a:off x="822960" y="1627632"/>
-            <a:ext cx="10607040" cy="457200"/>
-          </a:xfrm>
-          <a:prstGeom prst="rect">
-            <a:avLst/>
-          </a:prstGeom>
-          <a:noFill/>
-        </p:spPr>
-        <p:txBody>
-          <a:bodyPr wrap="square">
-            <a:spAutoFit/>
-          </a:bodyPr>
-          <a:lstStyle/>
-          <a:p>
-            <a:pPr algn="l"/>
-            <a:r>
-              <a:rPr sz="1400" b="0">
-                <a:solidFill>
-                  <a:srgbClr val="FFFFFF"/>
-                </a:solidFill>
-                <a:latin typeface="Consolas"/>
-              </a:rPr>
-              <a:t>$ git clone https://github.com/KrizRoMe/evaluacion-administracion-web.git</a:t>
-            </a:r>
-          </a:p>
-        </p:txBody>
-      </p:sp>
-      <p:sp>
-        <p:nvSpPr>
-          <p:cNvPr id="9" name="TextBox 8"/>
-          <p:cNvSpPr txBox="1"/>
-          <p:nvPr/>
-        </p:nvSpPr>
-        <p:spPr>
-          <a:xfrm>
-            <a:off x="822960" y="1920240"/>
-            <a:ext cx="10607040" cy="274320"/>
-          </a:xfrm>
-          <a:prstGeom prst="rect">
-            <a:avLst/>
-          </a:prstGeom>
-          <a:noFill/>
-        </p:spPr>
-        <p:txBody>
-          <a:bodyPr wrap="square">
-            <a:spAutoFit/>
-          </a:bodyPr>
-          <a:lstStyle/>
-          <a:p>
-            <a:pPr algn="l"/>
-            <a:r>
-              <a:rPr sz="1400" b="0">
-                <a:solidFill>
-                  <a:srgbClr val="FFFFFF"/>
-                </a:solidFill>
-                <a:latin typeface="Consolas"/>
-              </a:rPr>
-              <a:t>$ cd evaluacion-administracion-web</a:t>
-            </a:r>
-          </a:p>
-        </p:txBody>
-      </p:sp>
-      <p:sp>
-        <p:nvSpPr>
-          <p:cNvPr id="10" name="TextBox 9"/>
-          <p:cNvSpPr txBox="1"/>
-          <p:nvPr/>
-        </p:nvSpPr>
-        <p:spPr>
-          <a:xfrm>
-            <a:off x="640080" y="2377440"/>
-            <a:ext cx="10972800" cy="365760"/>
-          </a:xfrm>
-          <a:prstGeom prst="rect">
-            <a:avLst/>
-          </a:prstGeom>
-          <a:noFill/>
-        </p:spPr>
-        <p:txBody>
-          <a:bodyPr wrap="square">
-            <a:spAutoFit/>
-          </a:bodyPr>
-          <a:lstStyle/>
-          <a:p>
-            <a:pPr algn="l"/>
-            <a:r>
-              <a:rPr sz="1800" b="1">
-                <a:solidFill>
-                  <a:srgbClr val="065A82"/>
-                </a:solidFill>
-                <a:latin typeface="Calibri"/>
-              </a:rPr>
-              <a:t>2️⃣  Verificar que el sitio funciona localmente</a:t>
-            </a:r>
-          </a:p>
-        </p:txBody>
-      </p:sp>
-      <p:sp>
-        <p:nvSpPr>
-          <p:cNvPr id="11" name="Rounded Rectangle 10"/>
-          <p:cNvSpPr/>
-          <p:nvPr/>
-        </p:nvSpPr>
-        <p:spPr>
-          <a:xfrm>
-            <a:off x="640080" y="2743200"/>
-            <a:ext cx="10972800" cy="777240"/>
-          </a:xfrm>
-          <a:prstGeom prst="roundRect">
-            <a:avLst/>
-          </a:prstGeom>
-          <a:solidFill>
-            <a:srgbClr val="E6F7F1"/>
-          </a:solidFill>
-          <a:ln>
-            <a:solidFill>
-              <a:srgbClr val="10B981"/>
-            </a:solidFill>
-          </a:ln>
-        </p:spPr>
-        <p:style>
-          <a:lnRef idx="1">
-            <a:schemeClr val="accent1"/>
-          </a:lnRef>
-          <a:fillRef idx="3">
-            <a:schemeClr val="accent1"/>
-          </a:fillRef>
-          <a:effectRef idx="2">
-            <a:schemeClr val="accent1"/>
-          </a:effectRef>
-          <a:fontRef idx="minor">
-            <a:schemeClr val="lt1"/>
-          </a:fontRef>
-        </p:style>
-        <p:txBody>
-          <a:bodyPr rtlCol="0" anchor="ctr"/>
-          <a:lstStyle/>
-          <a:p>
-            <a:pPr algn="ctr"/>
-          </a:p>
-        </p:txBody>
-      </p:sp>
-      <p:sp>
-        <p:nvSpPr>
-          <p:cNvPr id="12" name="TextBox 11"/>
-          <p:cNvSpPr txBox="1"/>
-          <p:nvPr/>
-        </p:nvSpPr>
-        <p:spPr>
-          <a:xfrm>
-            <a:off x="822960" y="2788920"/>
-            <a:ext cx="10607040" cy="685800"/>
-          </a:xfrm>
-          <a:prstGeom prst="rect">
-            <a:avLst/>
-          </a:prstGeom>
-          <a:noFill/>
-        </p:spPr>
-        <p:txBody>
-          <a:bodyPr wrap="square">
-            <a:spAutoFit/>
-          </a:bodyPr>
-          <a:lstStyle/>
-          <a:p>
-            <a:pPr algn="l"/>
-            <a:r>
-              <a:rPr sz="1300" b="0">
-                <a:solidFill>
-                  <a:srgbClr val="2A2A2A"/>
-                </a:solidFill>
-                <a:latin typeface="Calibri"/>
-              </a:rPr>
-              <a:t>Doble clic en index.html  •  O arrastrar al navegador  •  Debe verse la tienda ECOMARKET</a:t>
-            </a:r>
-          </a:p>
-          <a:p>
-            <a:pPr algn="l"/>
-            <a:r>
-              <a:rPr sz="1300" b="0">
-                <a:solidFill>
-                  <a:srgbClr val="2A2A2A"/>
-                </a:solidFill>
-                <a:latin typeface="Calibri"/>
-              </a:rPr>
-              <a:t>Si ves los productos, el carrito y el modo oscuro → todo funciona ✓</a:t>
-            </a:r>
-          </a:p>
-        </p:txBody>
-      </p:sp>
-      <p:sp>
-        <p:nvSpPr>
-          <p:cNvPr id="13" name="TextBox 12"/>
-          <p:cNvSpPr txBox="1"/>
-          <p:nvPr/>
-        </p:nvSpPr>
-        <p:spPr>
-          <a:xfrm>
-            <a:off x="640080" y="3703320"/>
-            <a:ext cx="10972800" cy="365760"/>
-          </a:xfrm>
-          <a:prstGeom prst="rect">
-            <a:avLst/>
-          </a:prstGeom>
-          <a:noFill/>
-        </p:spPr>
-        <p:txBody>
-          <a:bodyPr wrap="square">
-            <a:spAutoFit/>
-          </a:bodyPr>
-          <a:lstStyle/>
-          <a:p>
-            <a:pPr algn="l"/>
-            <a:r>
-              <a:rPr sz="1800" b="1">
-                <a:solidFill>
-                  <a:srgbClr val="065A82"/>
-                </a:solidFill>
-                <a:latin typeface="Calibri"/>
-              </a:rPr>
-              <a:t>3️⃣  Crear tu repositorio personal (manual, en la web)</a:t>
-            </a:r>
-          </a:p>
-        </p:txBody>
-      </p:sp>
-      <p:sp>
-        <p:nvSpPr>
-          <p:cNvPr id="14" name="Rounded Rectangle 13"/>
-          <p:cNvSpPr/>
-          <p:nvPr/>
-        </p:nvSpPr>
-        <p:spPr>
-          <a:xfrm>
-            <a:off x="640080" y="4069080"/>
-            <a:ext cx="10972800" cy="1371600"/>
-          </a:xfrm>
-          <a:prstGeom prst="roundRect">
-            <a:avLst/>
-          </a:prstGeom>
-          <a:solidFill>
-            <a:srgbClr val="FEF3E6"/>
-          </a:solidFill>
-          <a:ln>
-            <a:solidFill>
-              <a:srgbClr val="EA580C"/>
-            </a:solidFill>
-          </a:ln>
-        </p:spPr>
-        <p:style>
-          <a:lnRef idx="1">
-            <a:schemeClr val="accent1"/>
-          </a:lnRef>
-          <a:fillRef idx="3">
-            <a:schemeClr val="accent1"/>
-          </a:fillRef>
-          <a:effectRef idx="2">
-            <a:schemeClr val="accent1"/>
-          </a:effectRef>
-          <a:fontRef idx="minor">
-            <a:schemeClr val="lt1"/>
-          </a:fontRef>
-        </p:style>
-        <p:txBody>
-          <a:bodyPr rtlCol="0" anchor="ctr"/>
-          <a:lstStyle/>
-          <a:p>
-            <a:pPr algn="ctr"/>
-          </a:p>
-        </p:txBody>
-      </p:sp>
-      <p:sp>
-        <p:nvSpPr>
-          <p:cNvPr id="15" name="TextBox 14"/>
-          <p:cNvSpPr txBox="1"/>
-          <p:nvPr/>
-        </p:nvSpPr>
-        <p:spPr>
-          <a:xfrm>
-            <a:off x="822960" y="4114800"/>
-            <a:ext cx="10607040" cy="1280160"/>
-          </a:xfrm>
-          <a:prstGeom prst="rect">
-            <a:avLst/>
-          </a:prstGeom>
-          <a:noFill/>
-        </p:spPr>
-        <p:txBody>
-          <a:bodyPr wrap="square">
-            <a:spAutoFit/>
-          </a:bodyPr>
-          <a:lstStyle/>
-          <a:p>
-            <a:pPr algn="l"/>
-            <a:r>
-              <a:rPr sz="1200" b="0">
-                <a:solidFill>
-                  <a:srgbClr val="2A2A2A"/>
-                </a:solidFill>
-                <a:latin typeface="Calibri"/>
-              </a:rPr>
-              <a:t>1. Abre https://github.com/new en tu navegador</a:t>
-            </a:r>
-          </a:p>
-          <a:p>
-            <a:pPr algn="l"/>
-            <a:r>
-              <a:rPr sz="1200" b="0">
-                <a:solidFill>
-                  <a:srgbClr val="2A2A2A"/>
-                </a:solidFill>
-                <a:latin typeface="Calibri"/>
-              </a:rPr>
-              <a:t>2. Repository name:  evaluacion-administracion-web-TU-NOMBRE</a:t>
-            </a:r>
-          </a:p>
-          <a:p>
-            <a:pPr algn="l"/>
-            <a:r>
-              <a:rPr sz="1200" b="0">
-                <a:solidFill>
-                  <a:srgbClr val="2A2A2A"/>
-                </a:solidFill>
-                <a:latin typeface="Calibri"/>
-              </a:rPr>
-              <a:t>3. Visibility:  Public</a:t>
-            </a:r>
-          </a:p>
-          <a:p>
-            <a:pPr algn="l"/>
-            <a:r>
-              <a:rPr sz="1200" b="0">
-                <a:solidFill>
-                  <a:srgbClr val="2A2A2A"/>
-                </a:solidFill>
-                <a:latin typeface="Calibri"/>
-              </a:rPr>
-              <a:t>4. NO inicialices con README, .gitignore ni license (déjalo vacío)</a:t>
-            </a:r>
-          </a:p>
-          <a:p>
-            <a:pPr algn="l"/>
-            <a:r>
-              <a:rPr sz="1200" b="0">
-                <a:solidFill>
-                  <a:srgbClr val="2A2A2A"/>
-                </a:solidFill>
-                <a:latin typeface="Calibri"/>
-              </a:rPr>
-              <a:t>5. Clic en Create repository  →  Copia la URL HTTPS que te muestra</a:t>
-            </a:r>
-          </a:p>
-        </p:txBody>
-      </p:sp>
-      <p:sp>
-        <p:nvSpPr>
-          <p:cNvPr id="16" name="TextBox 15"/>
-          <p:cNvSpPr txBox="1"/>
-          <p:nvPr/>
-        </p:nvSpPr>
-        <p:spPr>
-          <a:xfrm>
-            <a:off x="640080" y="5623560"/>
-            <a:ext cx="10972800" cy="365760"/>
-          </a:xfrm>
-          <a:prstGeom prst="rect">
-            <a:avLst/>
-          </a:prstGeom>
-          <a:noFill/>
-        </p:spPr>
-        <p:txBody>
-          <a:bodyPr wrap="square">
-            <a:spAutoFit/>
-          </a:bodyPr>
-          <a:lstStyle/>
-          <a:p>
-            <a:pPr algn="l"/>
-            <a:r>
-              <a:rPr sz="1800" b="1">
-                <a:solidFill>
-                  <a:srgbClr val="065A82"/>
-                </a:solidFill>
-                <a:latin typeface="Calibri"/>
-              </a:rPr>
-              <a:t>4️⃣  Conectar y subir con git puro</a:t>
-            </a:r>
-          </a:p>
-        </p:txBody>
-      </p:sp>
-      <p:sp>
-        <p:nvSpPr>
-          <p:cNvPr id="17" name="Rounded Rectangle 16"/>
-          <p:cNvSpPr/>
-          <p:nvPr/>
-        </p:nvSpPr>
-        <p:spPr>
-          <a:xfrm>
-            <a:off x="640080" y="5989320"/>
-            <a:ext cx="10972800" cy="777240"/>
-          </a:xfrm>
-          <a:prstGeom prst="roundRect">
-            <a:avLst/>
-          </a:prstGeom>
-          <a:solidFill>
-            <a:srgbClr val="2A2A2A"/>
-          </a:solidFill>
-          <a:ln>
-            <a:solidFill>
-              <a:srgbClr val="1C7293"/>
-            </a:solidFill>
-          </a:ln>
-        </p:spPr>
-        <p:style>
-          <a:lnRef idx="1">
-            <a:schemeClr val="accent1"/>
-          </a:lnRef>
-          <a:fillRef idx="3">
-            <a:schemeClr val="accent1"/>
-          </a:fillRef>
-          <a:effectRef idx="2">
-            <a:schemeClr val="accent1"/>
-          </a:effectRef>
-          <a:fontRef idx="minor">
-            <a:schemeClr val="lt1"/>
-          </a:fontRef>
-        </p:style>
-        <p:txBody>
-          <a:bodyPr rtlCol="0" anchor="ctr"/>
-          <a:lstStyle/>
-          <a:p>
-            <a:pPr algn="ctr"/>
-          </a:p>
-        </p:txBody>
-      </p:sp>
-      <p:sp>
-        <p:nvSpPr>
-          <p:cNvPr id="18" name="TextBox 17"/>
-          <p:cNvSpPr txBox="1"/>
-          <p:nvPr/>
-        </p:nvSpPr>
-        <p:spPr>
-          <a:xfrm>
-            <a:off x="822960" y="6035040"/>
-            <a:ext cx="10607040" cy="274320"/>
-          </a:xfrm>
-          <a:prstGeom prst="rect">
-            <a:avLst/>
-          </a:prstGeom>
-          <a:noFill/>
-        </p:spPr>
-        <p:txBody>
-          <a:bodyPr wrap="square">
-            <a:spAutoFit/>
-          </a:bodyPr>
-          <a:lstStyle/>
-          <a:p>
-            <a:pPr algn="l"/>
-            <a:r>
-              <a:rPr sz="1100" b="0">
-                <a:solidFill>
-                  <a:srgbClr val="FFFFFF"/>
-                </a:solidFill>
-                <a:latin typeface="Consolas"/>
-              </a:rPr>
-              <a:t>$ git remote add origin https://github.com/TU-USUARIO/evaluacion-administracion-web-TU-NOMBRE.git</a:t>
-            </a:r>
-          </a:p>
-        </p:txBody>
-      </p:sp>
-      <p:sp>
-        <p:nvSpPr>
-          <p:cNvPr id="19" name="TextBox 18"/>
-          <p:cNvSpPr txBox="1"/>
-          <p:nvPr/>
-        </p:nvSpPr>
-        <p:spPr>
-          <a:xfrm>
-            <a:off x="822960" y="6309360"/>
-            <a:ext cx="10607040" cy="274320"/>
-          </a:xfrm>
-          <a:prstGeom prst="rect">
-            <a:avLst/>
-          </a:prstGeom>
-          <a:noFill/>
-        </p:spPr>
-        <p:txBody>
-          <a:bodyPr wrap="square">
-            <a:spAutoFit/>
-          </a:bodyPr>
-          <a:lstStyle/>
-          <a:p>
-            <a:pPr algn="l"/>
-            <a:r>
-              <a:rPr sz="1200" b="0">
-                <a:solidFill>
-                  <a:srgbClr val="FFFFFF"/>
-                </a:solidFill>
-                <a:latin typeface="Consolas"/>
-              </a:rPr>
-              <a:t>$ git branch -M main</a:t>
-            </a:r>
-          </a:p>
-        </p:txBody>
-      </p:sp>
-      <p:sp>
-        <p:nvSpPr>
-          <p:cNvPr id="20" name="TextBox 19"/>
-          <p:cNvSpPr txBox="1"/>
-          <p:nvPr/>
-        </p:nvSpPr>
-        <p:spPr>
-          <a:xfrm>
-            <a:off x="822960" y="6537960"/>
-            <a:ext cx="10607040" cy="274320"/>
-          </a:xfrm>
-          <a:prstGeom prst="rect">
-            <a:avLst/>
-          </a:prstGeom>
-          <a:noFill/>
-        </p:spPr>
-        <p:txBody>
-          <a:bodyPr wrap="square">
-            <a:spAutoFit/>
-          </a:bodyPr>
-          <a:lstStyle/>
-          <a:p>
-            <a:pPr algn="l"/>
-            <a:r>
-              <a:rPr sz="1200" b="0">
-                <a:solidFill>
-                  <a:srgbClr val="FFFFFF"/>
-                </a:solidFill>
-                <a:latin typeface="Consolas"/>
-              </a:rPr>
-              <a:t>$ git push -u origin main</a:t>
-            </a:r>
-          </a:p>
-        </p:txBody>
-      </p:sp>
-      <p:sp>
-        <p:nvSpPr>
-          <p:cNvPr id="21" name="TextBox 20"/>
-          <p:cNvSpPr txBox="1"/>
-          <p:nvPr/>
-        </p:nvSpPr>
-        <p:spPr>
-          <a:xfrm>
-            <a:off x="457200" y="6903720"/>
-            <a:ext cx="10972800" cy="274320"/>
-          </a:xfrm>
-          <a:prstGeom prst="rect">
-            <a:avLst/>
-          </a:prstGeom>
-          <a:noFill/>
-        </p:spPr>
-        <p:txBody>
-          <a:bodyPr wrap="square">
-            <a:spAutoFit/>
-          </a:bodyPr>
-          <a:lstStyle/>
-          <a:p>
-            <a:pPr algn="l"/>
-            <a:r>
-              <a:rPr sz="1000" b="0">
-                <a:solidFill>
-                  <a:srgbClr val="666666"/>
-                </a:solidFill>
-                <a:latin typeface="Calibri"/>
-              </a:rPr>
-              <a:t>💡 No se exige memorizar comandos. Si logras subir el código, está bien.</a:t>
-            </a:r>
-          </a:p>
-        </p:txBody>
-      </p:sp>
-    </p:spTree>
-  </p:cSld>
-  <p:clrMapOvr>
-    <a:masterClrMapping/>
-  </p:clrMapOvr>
-</p:sld>
+<file path=ppt/slides/slide5.xml><?xml version='1.0' encoding='UTF-8' standalone='yes'?>
+<p:sld xmlns:a="http://schemas.openxmlformats.org/drawingml/2006/main" xmlns:p="http://schemas.openxmlformats.org/presentationml/2006/main" xmlns:r="http://schemas.openxmlformats.org/officeDocument/2006/relationships"><p:cSld><p:spTree><p:nvGrpSpPr><p:cNvPr id="1" name=""/><p:cNvGrpSpPr/><p:nvPr/></p:nvGrpSpPr><p:grpSpPr/><p:sp><p:nvSpPr><p:cNvPr id="2" name="Rectangle 1"/><p:cNvSpPr/><p:nvPr/></p:nvSpPr><p:spPr><a:xfrm><a:off x="0" y="0"/><a:ext cx="12191695" cy="6858000"/></a:xfrm><a:prstGeom prst="rect"><a:avLst/></a:prstGeom><a:solidFill><a:srgbClr val="FFFFFF"/></a:solidFill><a:ln><a:noFill/></a:ln></p:spPr><p:style><a:lnRef idx="1"><a:schemeClr val="accent1"/></a:lnRef><a:fillRef idx="3"><a:schemeClr val="accent1"/></a:fillRef><a:effectRef idx="2"><a:schemeClr val="accent1"/></a:effectRef><a:fontRef idx="minor"><a:schemeClr val="lt1"/></a:fontRef></p:style><p:txBody><a:bodyPr rtlCol="0" anchor="ctr"/><a:lstStyle/><a:p><a:pPr algn="ctr"/></a:p></p:txBody></p:sp><p:sp><p:nvSpPr><p:cNvPr id="3" name="Rectangle 2"/><p:cNvSpPr/><p:nvPr/></p:nvSpPr><p:spPr><a:xfrm><a:off x="0" y="0"/><a:ext cx="12191695" cy="914400"/></a:xfrm><a:prstGeom prst="rect"><a:avLst/></a:prstGeom><a:solidFill><a:srgbClr val="065A82"/></a:solidFill><a:ln><a:noFill/></a:ln></p:spPr><p:style><a:lnRef idx="1"><a:schemeClr val="accent1"/></a:lnRef><a:fillRef idx="3"><a:schemeClr val="accent1"/></a:fillRef><a:effectRef idx="2"><a:schemeClr val="accent1"/></a:effectRef><a:fontRef idx="minor"><a:schemeClr val="lt1"/></a:fontRef></p:style><p:txBody><a:bodyPr rtlCol="0" anchor="ctr"/><a:lstStyle/><a:p><a:pPr algn="ctr"/></a:p></p:txBody></p:sp><p:sp><p:nvSpPr><p:cNvPr id="4" name="TextBox 3"/><p:cNvSpPr txBox="1"/><p:nvPr/></p:nvSpPr><p:spPr><a:xfrm><a:off x="457200" y="274320"/><a:ext cx="10972800" cy="457200"/></a:xfrm><a:prstGeom prst="rect"><a:avLst/></a:prstGeom><a:noFill/></p:spPr><p:txBody><a:bodyPr wrap="square"><a:spAutoFit/></a:bodyPr><a:lstStyle/><a:p><a:pPr algn="l"/><a:r><a:rPr sz="3200" b="1"><a:solidFill><a:srgbClr val="FFFFFF"/></a:solidFill><a:latin typeface="Calibri"/></a:rPr><a:t>Parte 1 · Clonar, verificar y subir</a:t></a:r></a:p></p:txBody></p:sp><p:sp><p:nvSpPr><p:cNvPr id="5" name="TextBox 4"/><p:cNvSpPr txBox="1"/><p:nvPr/></p:nvSpPr><p:spPr><a:xfrm><a:off x="457200" y="685800"/><a:ext cx="10972800" cy="274320"/></a:xfrm><a:prstGeom prst="rect"><a:avLst/></a:prstGeom><a:noFill/></p:spPr><p:txBody><a:bodyPr wrap="square"><a:spAutoFit/></a:bodyPr><a:lstStyle/><a:p><a:pPr algn="l"/><a:r><a:rPr sz="1400" b="0"><a:solidFill><a:srgbClr val="60A5FA"/></a:solidFill><a:latin typeface="Calibri"/></a:rPr><a:t>⏱ 10 minutos  •  Solo git (sin gh CLI)</a:t></a:r></a:p></p:txBody></p:sp><p:sp><p:nvSpPr><p:cNvPr id="6" name="TextBox 5"/><p:cNvSpPr txBox="1"/><p:nvPr/></p:nvSpPr><p:spPr><a:xfrm><a:off x="640080" y="1188720"/><a:ext cx="10972800" cy="365760"/></a:xfrm><a:prstGeom prst="rect"><a:avLst/></a:prstGeom><a:noFill/></p:spPr><p:txBody><a:bodyPr wrap="square"><a:spAutoFit/></a:bodyPr><a:lstStyle/><a:p><a:pPr algn="l"/><a:r><a:rPr sz="1800" b="1"><a:solidFill><a:srgbClr val="065A82"/></a:solidFill><a:latin typeface="Calibri"/></a:rPr><a:t>1️⃣  Clonar el repositorio del docente</a:t></a:r></a:p></p:txBody></p:sp><p:sp><p:nvSpPr><p:cNvPr id="7" name="Rounded Rectangle 6"/><p:cNvSpPr/><p:nvPr/></p:nvSpPr><p:spPr><a:xfrm><a:off x="640080" y="1554480"/><a:ext cx="10972800" cy="594360"/></a:xfrm><a:prstGeom prst="roundRect"><a:avLst/></a:prstGeom><a:solidFill><a:srgbClr val="2A2A2A"/></a:solidFill><a:ln><a:solidFill><a:srgbClr val="1C7293"/></a:solidFill></a:ln></p:spPr><p:style><a:lnRef idx="1"><a:schemeClr val="accent1"/></a:lnRef><a:fillRef idx="3"><a:schemeClr val="accent1"/></a:fillRef><a:effectRef idx="2"><a:schemeClr val="accent1"/></a:effectRef><a:fontRef idx="minor"><a:schemeClr val="lt1"/></a:fontRef></p:style><p:txBody><a:bodyPr rtlCol="0" anchor="ctr"/><a:lstStyle/><a:p><a:pPr algn="ctr"/></a:p></p:txBody></p:sp><p:sp><p:nvSpPr><p:cNvPr id="8" name="TextBox 7"/><p:cNvSpPr txBox="1"/><p:nvPr/></p:nvSpPr><p:spPr><a:xfrm><a:off x="822960" y="1627632"/><a:ext cx="10607040" cy="457200"/></a:xfrm><a:prstGeom prst="rect"><a:avLst/></a:prstGeom><a:noFill/></p:spPr><p:txBody><a:bodyPr wrap="square"><a:spAutoFit/></a:bodyPr><a:lstStyle/><a:p><a:pPr algn="l"/><a:r><a:rPr sz="1400" b="0"><a:solidFill><a:srgbClr val="FFFFFF"/></a:solidFill><a:latin typeface="Consolas"/></a:rPr><a:t>$ git clone https://github.com/KrizRoMe/evaluacion-administracion-web.git</a:t></a:r></a:p></p:txBody></p:sp><p:sp><p:nvSpPr><p:cNvPr id="9" name="TextBox 8"/><p:cNvSpPr txBox="1"/><p:nvPr/></p:nvSpPr><p:spPr><a:xfrm><a:off x="822960" y="1920240"/><a:ext cx="10607040" cy="274320"/></a:xfrm><a:prstGeom prst="rect"><a:avLst/></a:prstGeom><a:noFill/></p:spPr><p:txBody><a:bodyPr wrap="square"><a:spAutoFit/></a:bodyPr><a:lstStyle/><a:p><a:pPr algn="l"/><a:r><a:rPr sz="1400" b="0"><a:solidFill><a:srgbClr val="FFFFFF"/></a:solidFill><a:latin typeface="Consolas"/></a:rPr><a:t>$ cd evaluacion-administracion-web</a:t></a:r></a:p></p:txBody></p:sp><p:sp><p:nvSpPr><p:cNvPr id="10" name="TextBox 9"/><p:cNvSpPr txBox="1"/><p:nvPr/></p:nvSpPr><p:spPr><a:xfrm><a:off x="640080" y="2377440"/><a:ext cx="10972800" cy="365760"/></a:xfrm><a:prstGeom prst="rect"><a:avLst/></a:prstGeom><a:noFill/></p:spPr><p:txBody><a:bodyPr wrap="square"><a:spAutoFit/></a:bodyPr><a:lstStyle/><a:p><a:pPr algn="l"/><a:r><a:rPr sz="1800" b="1"><a:solidFill><a:srgbClr val="065A82"/></a:solidFill><a:latin typeface="Calibri"/></a:rPr><a:t>2️⃣  Verificar que el sitio funciona localmente</a:t></a:r></a:p></p:txBody></p:sp><p:sp><p:nvSpPr><p:cNvPr id="11" name="Rounded Rectangle 10"/><p:cNvSpPr/><p:nvPr/></p:nvSpPr><p:spPr><a:xfrm><a:off x="640080" y="2743200"/><a:ext cx="10972800" cy="777240"/></a:xfrm><a:prstGeom prst="roundRect"><a:avLst/></a:prstGeom><a:solidFill><a:srgbClr val="E6F7F1"/></a:solidFill><a:ln><a:solidFill><a:srgbClr val="10B981"/></a:solidFill></a:ln></p:spPr><p:style><a:lnRef idx="1"><a:schemeClr val="accent1"/></a:lnRef><a:fillRef idx="3"><a:schemeClr val="accent1"/></a:fillRef><a:effectRef idx="2"><a:schemeClr val="accent1"/></a:effectRef><a:fontRef idx="minor"><a:schemeClr val="lt1"/></a:fontRef></p:style><p:txBody><a:bodyPr rtlCol="0" anchor="ctr"/><a:lstStyle/><a:p><a:pPr algn="ctr"/></a:p></p:txBody></p:sp><p:sp><p:nvSpPr><p:cNvPr id="12" name="TextBox 11"/><p:cNvSpPr txBox="1"/><p:nvPr/></p:nvSpPr><p:spPr><a:xfrm><a:off x="822960" y="2788920"/><a:ext cx="10607040" cy="685800"/></a:xfrm><a:prstGeom prst="rect"><a:avLst/></a:prstGeom><a:noFill/></p:spPr><p:txBody><a:bodyPr wrap="square"><a:spAutoFit/></a:bodyPr><a:lstStyle/><a:p><a:pPr algn="l"/><a:r><a:rPr sz="1300" b="0"><a:solidFill><a:srgbClr val="2A2A2A"/></a:solidFill><a:latin typeface="Calibri"/></a:rPr><a:t>Doble clic en index.html  •  O arrastrar al navegador  •  Debe verse la tienda ECOMARKET</a:t></a:r></a:p><a:p><a:pPr algn="l"/><a:r><a:rPr sz="1300" b="0"><a:solidFill><a:srgbClr val="2A2A2A"/></a:solidFill><a:latin typeface="Calibri"/></a:rPr><a:t>Si ves los productos, el carrito y el modo oscuro → todo funciona ✓</a:t></a:r></a:p></p:txBody></p:sp><p:sp><p:nvSpPr><p:cNvPr id="13" name="TextBox 12"/><p:cNvSpPr txBox="1"/><p:nvPr/></p:nvSpPr><p:spPr><a:xfrm><a:off x="640080" y="3703320"/><a:ext cx="10972800" cy="365760"/></a:xfrm><a:prstGeom prst="rect"><a:avLst/></a:prstGeom><a:noFill/></p:spPr><p:txBody><a:bodyPr wrap="square"><a:spAutoFit/></a:bodyPr><a:lstStyle/><a:p><a:pPr algn="l"/><a:r><a:rPr sz="1800" b="1"><a:solidFill><a:srgbClr val="065A82"/></a:solidFill><a:latin typeface="Calibri"/></a:rPr><a:t>3️⃣  Crear tu repositorio personal (manual, en la web)</a:t></a:r></a:p></p:txBody></p:sp><p:sp><p:nvSpPr><p:cNvPr id="14" name="Rounded Rectangle 13"/><p:cNvSpPr/><p:nvPr/></p:nvSpPr><p:spPr><a:xfrm><a:off x="640080" y="4069080"/><a:ext cx="10972800" cy="1371600"/></a:xfrm><a:prstGeom prst="roundRect"><a:avLst/></a:prstGeom><a:solidFill><a:srgbClr val="FEF3E6"/></a:solidFill><a:ln><a:solidFill><a:srgbClr val="EA580C"/></a:solidFill></a:ln></p:spPr><p:style><a:lnRef idx="1"><a:schemeClr val="accent1"/></a:lnRef><a:fillRef idx="3"><a:schemeClr val="accent1"/></a:fillRef><a:effectRef idx="2"><a:schemeClr val="accent1"/></a:effectRef><a:fontRef idx="minor"><a:schemeClr val="lt1"/></a:fontRef></p:style><p:txBody><a:bodyPr rtlCol="0" anchor="ctr"/><a:lstStyle/><a:p><a:pPr algn="ctr"/></a:p></p:txBody></p:sp><p:sp><p:nvSpPr><p:cNvPr id="15" name="TextBox 14"/><p:cNvSpPr txBox="1"/><p:nvPr/></p:nvSpPr><p:spPr><a:xfrm><a:off x="822960" y="4114800"/><a:ext cx="10607040" cy="1280160"/></a:xfrm><a:prstGeom prst="rect"><a:avLst/></a:prstGeom><a:noFill/></p:spPr><p:txBody><a:bodyPr wrap="square"><a:spAutoFit/></a:bodyPr><a:lstStyle/><a:p><a:pPr algn="l"/><a:r><a:rPr sz="1200" b="0"><a:solidFill><a:srgbClr val="2A2A2A"/></a:solidFill><a:latin typeface="Calibri"/></a:rPr><a:t>1. Abre https://github.com/new en tu navegador</a:t></a:r></a:p><a:p><a:pPr algn="l"/><a:r><a:rPr sz="1200" b="0"><a:solidFill><a:srgbClr val="2A2A2A"/></a:solidFill><a:latin typeface="Calibri"/></a:rPr><a:t>2. Repository name:  evaluacion-administracion-web-TU-NOMBRE</a:t></a:r></a:p><a:p><a:pPr algn="l"/><a:r><a:rPr sz="1200" b="0"><a:solidFill><a:srgbClr val="2A2A2A"/></a:solidFill><a:latin typeface="Calibri"/></a:rPr><a:t>3. Visibility:  Public</a:t></a:r></a:p><a:p><a:pPr algn="l"/><a:r><a:rPr sz="1200" b="0"><a:solidFill><a:srgbClr val="2A2A2A"/></a:solidFill><a:latin typeface="Calibri"/></a:rPr><a:t>4. NO inicialices con README, .gitignore ni license (déjalo vacío)</a:t></a:r></a:p><a:p><a:pPr algn="l"/><a:r><a:rPr sz="1200" b="0"><a:solidFill><a:srgbClr val="2A2A2A"/></a:solidFill><a:latin typeface="Calibri"/></a:rPr><a:t>5. Clic en Create repository  →  Copia la URL HTTPS que te muestra</a:t></a:r></a:p></p:txBody></p:sp><p:sp><p:nvSpPr><p:cNvPr id="16" name="TextBox 15"/><p:cNvSpPr txBox="1"/><p:nvPr/></p:nvSpPr><p:spPr><a:xfrm><a:off x="640080" y="5623560"/><a:ext cx="10972800" cy="365760"/></a:xfrm><a:prstGeom prst="rect"><a:avLst/></a:prstGeom><a:noFill/></p:spPr><p:txBody><a:bodyPr wrap="square"><a:spAutoFit/></a:bodyPr><a:lstStyle/><a:p><a:pPr algn="l"/><a:r><a:rPr sz="1800" b="1"><a:solidFill><a:srgbClr val="065A82"/></a:solidFill><a:latin typeface="Calibri"/></a:rPr><a:t>4️⃣  Conectar y subir con git puro</a:t></a:r></a:p></p:txBody></p:sp><p:sp><p:nvSpPr><p:cNvPr id="17" name="Rounded Rectangle 16"/><p:cNvSpPr/><p:nvPr/></p:nvSpPr><p:spPr><a:xfrm><a:off x="640080" y="5989320"/><a:ext cx="10972800" cy="777240"/></a:xfrm><a:prstGeom prst="roundRect"><a:avLst/></a:prstGeom><a:solidFill><a:srgbClr val="2A2A2A"/></a:solidFill><a:ln><a:solidFill><a:srgbClr val="1C7293"/></a:solidFill></a:ln></p:spPr><p:style><a:lnRef idx="1"><a:schemeClr val="accent1"/></a:lnRef><a:fillRef idx="3"><a:schemeClr val="accent1"/></a:fillRef><a:effectRef idx="2"><a:schemeClr val="accent1"/></a:effectRef><a:fontRef idx="minor"><a:schemeClr val="lt1"/></a:fontRef></p:style><p:txBody><a:bodyPr rtlCol="0" anchor="ctr"/><a:lstStyle/><a:p><a:pPr algn="ctr"/></a:p></p:txBody></p:sp><p:sp><p:nvSpPr><p:cNvPr id="18" name="TextBox 17"/><p:cNvSpPr txBox="1"/><p:nvPr/></p:nvSpPr><p:spPr><a:xfrm><a:off x="822960" y="6035040"/><a:ext cx="10607040" cy="274320"/></a:xfrm><a:prstGeom prst="rect"><a:avLst/></a:prstGeom><a:noFill/></p:spPr><p:txBody><a:bodyPr wrap="square"><a:spAutoFit/></a:bodyPr><a:lstStyle/><a:p><a:pPr algn="l"/><a:r><a:rPr sz="1100" b="0"><a:solidFill><a:srgbClr val="FFFFFF"/></a:solidFill><a:latin typeface="Consolas"/></a:rPr><a:t>$ git remote set-url origin https://github.com/TU-USUARIO/evaluacion-administracion-web-TU-NOMBRE.git</a:t></a:r></a:r><a:r><a:rPr lang="es-PE" sz="1100"><a:solidFill><a:srgbClr val="666666"/></a:solidFill><a:latin typeface="Consolas"/></a:rPr><a:t>(ya existe porque hiciste git clone, no add)</a:t></a:r></a:p></p:txBody></p:sp><p:sp><p:nvSpPr><p:cNvPr id="19" name="TextBox 18"/><p:cNvSpPr txBox="1"/><p:nvPr/></p:nvSpPr><p:spPr><a:xfrm><a:off x="822960" y="6309360"/><a:ext cx="10607040" cy="274320"/></a:xfrm><a:prstGeom prst="rect"><a:avLst/></a:prstGeom><a:noFill/></p:spPr><p:txBody><a:bodyPr wrap="square"><a:spAutoFit/></a:bodyPr><a:lstStyle/><a:p><a:pPr algn="l"/><a:r><a:rPr sz="1200" b="0"><a:solidFill><a:srgbClr val="FFFFFF"/></a:solidFill><a:latin typeface="Consolas"/></a:rPr><a:t>$ git branch -M main</a:t></a:r></a:p></p:txBody></p:sp><p:sp><p:nvSpPr><p:cNvPr id="20" name="TextBox 19"/><p:cNvSpPr txBox="1"/><p:nvPr/></p:nvSpPr><p:spPr><a:xfrm><a:off x="822960" y="6537960"/><a:ext cx="10607040" cy="274320"/></a:xfrm><a:prstGeom prst="rect"><a:avLst/></a:prstGeom><a:noFill/></p:spPr><p:txBody><a:bodyPr wrap="square"><a:spAutoFit/></a:bodyPr><a:lstStyle/><a:p><a:pPr algn="l"/><a:r><a:rPr sz="1200" b="0"><a:solidFill><a:srgbClr val="FFFFFF"/></a:solidFill><a:latin typeface="Consolas"/></a:rPr><a:t>$ git push -u origin main</a:t></a:r></a:p></p:txBody></p:sp><p:sp><p:nvSpPr><p:cNvPr id="21" name="TextBox 20"/><p:cNvSpPr txBox="1"/><p:nvPr/></p:nvSpPr><p:spPr><a:xfrm><a:off x="457200" y="6903720"/><a:ext cx="10972800" cy="274320"/></a:xfrm><a:prstGeom prst="rect"><a:avLst/></a:prstGeom><a:noFill/></p:spPr><p:txBody><a:bodyPr wrap="square"><a:spAutoFit/></a:bodyPr><a:lstStyle/><a:p><a:pPr algn="l"/><a:r><a:rPr sz="1000" b="0"><a:solidFill><a:srgbClr val="666666"/></a:solidFill><a:latin typeface="Calibri"/></a:rPr><a:t>💡 No se exige memorizar comandos. Si logras subir el código, está bien.</a:t></a:r></a:p></p:txBody></p:sp></p:spTree></p:cSld><p:clrMapOvr><a:masterClrMapping/></p:clrMapOvr></p:sld>
 </file>
 
 <file path=ppt/slides/slide6.xml><?xml version="1.0" encoding="utf-8"?>

</xml_diff>

<commit_message>
feat(parte1): añadir git config (user.name, user.email) + comandos de pista en slide 7
Slide 5: añadido el bloque de 'git config --global' antes del push.
Slide 7: cada caja de tipo de problema ahora tiene una 'Pista' con un comando
o atajo para encontrar los problemas (F12 → Lighthouse, axe DevTools → Scan,
cat package.json | grep -r TODO, etc.)

Las pistas son sutiles: no dicen exactamente qué buscar, pero dan una guía
para que el estudiante sepa por dónde empezar.
</commit_message>
<xml_diff>
--- a/EVALUACION_PRACTICA_01.pptx
+++ b/EVALUACION_PRACTICA_01.pptx
@@ -4601,7 +4601,7 @@
                 </a:solidFill>
                 <a:latin typeface="Calibri"/>
               </a:rPr>
-              <a:t>• 3 Issues hallazgos × 5 pts = 15</a:t>
+              <a:t>• 3 Issues de hallazgos × 5 pts = 15</a:t>
             </a:r>
           </a:p>
           <a:p>
@@ -4613,7 +4613,7 @@
                 </a:solidFill>
                 <a:latin typeface="Calibri"/>
               </a:rPr>
-              <a:t>• 1 Issue link-evaluación × 5 pts = 5</a:t>
+              <a:t>• 1 Issue de link-evaluación × 5 pts = 5</a:t>
             </a:r>
           </a:p>
         </p:txBody>
@@ -7503,8 +7503,792 @@
 </p:sld>
 </file>
 
-<file path=ppt/slides/slide5.xml><?xml version='1.0' encoding='UTF-8' standalone='yes'?>
-<p:sld xmlns:a="http://schemas.openxmlformats.org/drawingml/2006/main" xmlns:p="http://schemas.openxmlformats.org/presentationml/2006/main" xmlns:r="http://schemas.openxmlformats.org/officeDocument/2006/relationships"><p:cSld><p:spTree><p:nvGrpSpPr><p:cNvPr id="1" name=""/><p:cNvGrpSpPr/><p:nvPr/></p:nvGrpSpPr><p:grpSpPr/><p:sp><p:nvSpPr><p:cNvPr id="2" name="Rectangle 1"/><p:cNvSpPr/><p:nvPr/></p:nvSpPr><p:spPr><a:xfrm><a:off x="0" y="0"/><a:ext cx="12191695" cy="6858000"/></a:xfrm><a:prstGeom prst="rect"><a:avLst/></a:prstGeom><a:solidFill><a:srgbClr val="FFFFFF"/></a:solidFill><a:ln><a:noFill/></a:ln></p:spPr><p:style><a:lnRef idx="1"><a:schemeClr val="accent1"/></a:lnRef><a:fillRef idx="3"><a:schemeClr val="accent1"/></a:fillRef><a:effectRef idx="2"><a:schemeClr val="accent1"/></a:effectRef><a:fontRef idx="minor"><a:schemeClr val="lt1"/></a:fontRef></p:style><p:txBody><a:bodyPr rtlCol="0" anchor="ctr"/><a:lstStyle/><a:p><a:pPr algn="ctr"/></a:p></p:txBody></p:sp><p:sp><p:nvSpPr><p:cNvPr id="3" name="Rectangle 2"/><p:cNvSpPr/><p:nvPr/></p:nvSpPr><p:spPr><a:xfrm><a:off x="0" y="0"/><a:ext cx="12191695" cy="914400"/></a:xfrm><a:prstGeom prst="rect"><a:avLst/></a:prstGeom><a:solidFill><a:srgbClr val="065A82"/></a:solidFill><a:ln><a:noFill/></a:ln></p:spPr><p:style><a:lnRef idx="1"><a:schemeClr val="accent1"/></a:lnRef><a:fillRef idx="3"><a:schemeClr val="accent1"/></a:fillRef><a:effectRef idx="2"><a:schemeClr val="accent1"/></a:effectRef><a:fontRef idx="minor"><a:schemeClr val="lt1"/></a:fontRef></p:style><p:txBody><a:bodyPr rtlCol="0" anchor="ctr"/><a:lstStyle/><a:p><a:pPr algn="ctr"/></a:p></p:txBody></p:sp><p:sp><p:nvSpPr><p:cNvPr id="4" name="TextBox 3"/><p:cNvSpPr txBox="1"/><p:nvPr/></p:nvSpPr><p:spPr><a:xfrm><a:off x="457200" y="274320"/><a:ext cx="10972800" cy="457200"/></a:xfrm><a:prstGeom prst="rect"><a:avLst/></a:prstGeom><a:noFill/></p:spPr><p:txBody><a:bodyPr wrap="square"><a:spAutoFit/></a:bodyPr><a:lstStyle/><a:p><a:pPr algn="l"/><a:r><a:rPr sz="3200" b="1"><a:solidFill><a:srgbClr val="FFFFFF"/></a:solidFill><a:latin typeface="Calibri"/></a:rPr><a:t>Parte 1 · Clonar, verificar y subir</a:t></a:r></a:p></p:txBody></p:sp><p:sp><p:nvSpPr><p:cNvPr id="5" name="TextBox 4"/><p:cNvSpPr txBox="1"/><p:nvPr/></p:nvSpPr><p:spPr><a:xfrm><a:off x="457200" y="685800"/><a:ext cx="10972800" cy="274320"/></a:xfrm><a:prstGeom prst="rect"><a:avLst/></a:prstGeom><a:noFill/></p:spPr><p:txBody><a:bodyPr wrap="square"><a:spAutoFit/></a:bodyPr><a:lstStyle/><a:p><a:pPr algn="l"/><a:r><a:rPr sz="1400" b="0"><a:solidFill><a:srgbClr val="60A5FA"/></a:solidFill><a:latin typeface="Calibri"/></a:rPr><a:t>⏱ 10 minutos  •  Solo git (sin gh CLI)</a:t></a:r></a:p></p:txBody></p:sp><p:sp><p:nvSpPr><p:cNvPr id="6" name="TextBox 5"/><p:cNvSpPr txBox="1"/><p:nvPr/></p:nvSpPr><p:spPr><a:xfrm><a:off x="640080" y="1188720"/><a:ext cx="10972800" cy="365760"/></a:xfrm><a:prstGeom prst="rect"><a:avLst/></a:prstGeom><a:noFill/></p:spPr><p:txBody><a:bodyPr wrap="square"><a:spAutoFit/></a:bodyPr><a:lstStyle/><a:p><a:pPr algn="l"/><a:r><a:rPr sz="1800" b="1"><a:solidFill><a:srgbClr val="065A82"/></a:solidFill><a:latin typeface="Calibri"/></a:rPr><a:t>1️⃣  Clonar el repositorio del docente</a:t></a:r></a:p></p:txBody></p:sp><p:sp><p:nvSpPr><p:cNvPr id="7" name="Rounded Rectangle 6"/><p:cNvSpPr/><p:nvPr/></p:nvSpPr><p:spPr><a:xfrm><a:off x="640080" y="1554480"/><a:ext cx="10972800" cy="594360"/></a:xfrm><a:prstGeom prst="roundRect"><a:avLst/></a:prstGeom><a:solidFill><a:srgbClr val="2A2A2A"/></a:solidFill><a:ln><a:solidFill><a:srgbClr val="1C7293"/></a:solidFill></a:ln></p:spPr><p:style><a:lnRef idx="1"><a:schemeClr val="accent1"/></a:lnRef><a:fillRef idx="3"><a:schemeClr val="accent1"/></a:fillRef><a:effectRef idx="2"><a:schemeClr val="accent1"/></a:effectRef><a:fontRef idx="minor"><a:schemeClr val="lt1"/></a:fontRef></p:style><p:txBody><a:bodyPr rtlCol="0" anchor="ctr"/><a:lstStyle/><a:p><a:pPr algn="ctr"/></a:p></p:txBody></p:sp><p:sp><p:nvSpPr><p:cNvPr id="8" name="TextBox 7"/><p:cNvSpPr txBox="1"/><p:nvPr/></p:nvSpPr><p:spPr><a:xfrm><a:off x="822960" y="1627632"/><a:ext cx="10607040" cy="457200"/></a:xfrm><a:prstGeom prst="rect"><a:avLst/></a:prstGeom><a:noFill/></p:spPr><p:txBody><a:bodyPr wrap="square"><a:spAutoFit/></a:bodyPr><a:lstStyle/><a:p><a:pPr algn="l"/><a:r><a:rPr sz="1400" b="0"><a:solidFill><a:srgbClr val="FFFFFF"/></a:solidFill><a:latin typeface="Consolas"/></a:rPr><a:t>$ git clone https://github.com/KrizRoMe/evaluacion-administracion-web.git</a:t></a:r></a:p></p:txBody></p:sp><p:sp><p:nvSpPr><p:cNvPr id="9" name="TextBox 8"/><p:cNvSpPr txBox="1"/><p:nvPr/></p:nvSpPr><p:spPr><a:xfrm><a:off x="822960" y="1920240"/><a:ext cx="10607040" cy="274320"/></a:xfrm><a:prstGeom prst="rect"><a:avLst/></a:prstGeom><a:noFill/></p:spPr><p:txBody><a:bodyPr wrap="square"><a:spAutoFit/></a:bodyPr><a:lstStyle/><a:p><a:pPr algn="l"/><a:r><a:rPr sz="1400" b="0"><a:solidFill><a:srgbClr val="FFFFFF"/></a:solidFill><a:latin typeface="Consolas"/></a:rPr><a:t>$ cd evaluacion-administracion-web</a:t></a:r></a:p></p:txBody></p:sp><p:sp><p:nvSpPr><p:cNvPr id="10" name="TextBox 9"/><p:cNvSpPr txBox="1"/><p:nvPr/></p:nvSpPr><p:spPr><a:xfrm><a:off x="640080" y="2377440"/><a:ext cx="10972800" cy="365760"/></a:xfrm><a:prstGeom prst="rect"><a:avLst/></a:prstGeom><a:noFill/></p:spPr><p:txBody><a:bodyPr wrap="square"><a:spAutoFit/></a:bodyPr><a:lstStyle/><a:p><a:pPr algn="l"/><a:r><a:rPr sz="1800" b="1"><a:solidFill><a:srgbClr val="065A82"/></a:solidFill><a:latin typeface="Calibri"/></a:rPr><a:t>2️⃣  Verificar que el sitio funciona localmente</a:t></a:r></a:p></p:txBody></p:sp><p:sp><p:nvSpPr><p:cNvPr id="11" name="Rounded Rectangle 10"/><p:cNvSpPr/><p:nvPr/></p:nvSpPr><p:spPr><a:xfrm><a:off x="640080" y="2743200"/><a:ext cx="10972800" cy="777240"/></a:xfrm><a:prstGeom prst="roundRect"><a:avLst/></a:prstGeom><a:solidFill><a:srgbClr val="E6F7F1"/></a:solidFill><a:ln><a:solidFill><a:srgbClr val="10B981"/></a:solidFill></a:ln></p:spPr><p:style><a:lnRef idx="1"><a:schemeClr val="accent1"/></a:lnRef><a:fillRef idx="3"><a:schemeClr val="accent1"/></a:fillRef><a:effectRef idx="2"><a:schemeClr val="accent1"/></a:effectRef><a:fontRef idx="minor"><a:schemeClr val="lt1"/></a:fontRef></p:style><p:txBody><a:bodyPr rtlCol="0" anchor="ctr"/><a:lstStyle/><a:p><a:pPr algn="ctr"/></a:p></p:txBody></p:sp><p:sp><p:nvSpPr><p:cNvPr id="12" name="TextBox 11"/><p:cNvSpPr txBox="1"/><p:nvPr/></p:nvSpPr><p:spPr><a:xfrm><a:off x="822960" y="2788920"/><a:ext cx="10607040" cy="685800"/></a:xfrm><a:prstGeom prst="rect"><a:avLst/></a:prstGeom><a:noFill/></p:spPr><p:txBody><a:bodyPr wrap="square"><a:spAutoFit/></a:bodyPr><a:lstStyle/><a:p><a:pPr algn="l"/><a:r><a:rPr sz="1300" b="0"><a:solidFill><a:srgbClr val="2A2A2A"/></a:solidFill><a:latin typeface="Calibri"/></a:rPr><a:t>Doble clic en index.html  •  O arrastrar al navegador  •  Debe verse la tienda ECOMARKET</a:t></a:r></a:p><a:p><a:pPr algn="l"/><a:r><a:rPr sz="1300" b="0"><a:solidFill><a:srgbClr val="2A2A2A"/></a:solidFill><a:latin typeface="Calibri"/></a:rPr><a:t>Si ves los productos, el carrito y el modo oscuro → todo funciona ✓</a:t></a:r></a:p></p:txBody></p:sp><p:sp><p:nvSpPr><p:cNvPr id="13" name="TextBox 12"/><p:cNvSpPr txBox="1"/><p:nvPr/></p:nvSpPr><p:spPr><a:xfrm><a:off x="640080" y="3703320"/><a:ext cx="10972800" cy="365760"/></a:xfrm><a:prstGeom prst="rect"><a:avLst/></a:prstGeom><a:noFill/></p:spPr><p:txBody><a:bodyPr wrap="square"><a:spAutoFit/></a:bodyPr><a:lstStyle/><a:p><a:pPr algn="l"/><a:r><a:rPr sz="1800" b="1"><a:solidFill><a:srgbClr val="065A82"/></a:solidFill><a:latin typeface="Calibri"/></a:rPr><a:t>3️⃣  Crear tu repositorio personal (manual, en la web)</a:t></a:r></a:p></p:txBody></p:sp><p:sp><p:nvSpPr><p:cNvPr id="14" name="Rounded Rectangle 13"/><p:cNvSpPr/><p:nvPr/></p:nvSpPr><p:spPr><a:xfrm><a:off x="640080" y="4069080"/><a:ext cx="10972800" cy="1371600"/></a:xfrm><a:prstGeom prst="roundRect"><a:avLst/></a:prstGeom><a:solidFill><a:srgbClr val="FEF3E6"/></a:solidFill><a:ln><a:solidFill><a:srgbClr val="EA580C"/></a:solidFill></a:ln></p:spPr><p:style><a:lnRef idx="1"><a:schemeClr val="accent1"/></a:lnRef><a:fillRef idx="3"><a:schemeClr val="accent1"/></a:fillRef><a:effectRef idx="2"><a:schemeClr val="accent1"/></a:effectRef><a:fontRef idx="minor"><a:schemeClr val="lt1"/></a:fontRef></p:style><p:txBody><a:bodyPr rtlCol="0" anchor="ctr"/><a:lstStyle/><a:p><a:pPr algn="ctr"/></a:p></p:txBody></p:sp><p:sp><p:nvSpPr><p:cNvPr id="15" name="TextBox 14"/><p:cNvSpPr txBox="1"/><p:nvPr/></p:nvSpPr><p:spPr><a:xfrm><a:off x="822960" y="4114800"/><a:ext cx="10607040" cy="1280160"/></a:xfrm><a:prstGeom prst="rect"><a:avLst/></a:prstGeom><a:noFill/></p:spPr><p:txBody><a:bodyPr wrap="square"><a:spAutoFit/></a:bodyPr><a:lstStyle/><a:p><a:pPr algn="l"/><a:r><a:rPr sz="1200" b="0"><a:solidFill><a:srgbClr val="2A2A2A"/></a:solidFill><a:latin typeface="Calibri"/></a:rPr><a:t>1. Abre https://github.com/new en tu navegador</a:t></a:r></a:p><a:p><a:pPr algn="l"/><a:r><a:rPr sz="1200" b="0"><a:solidFill><a:srgbClr val="2A2A2A"/></a:solidFill><a:latin typeface="Calibri"/></a:rPr><a:t>2. Repository name:  evaluacion-administracion-web-TU-NOMBRE</a:t></a:r></a:p><a:p><a:pPr algn="l"/><a:r><a:rPr sz="1200" b="0"><a:solidFill><a:srgbClr val="2A2A2A"/></a:solidFill><a:latin typeface="Calibri"/></a:rPr><a:t>3. Visibility:  Public</a:t></a:r></a:p><a:p><a:pPr algn="l"/><a:r><a:rPr sz="1200" b="0"><a:solidFill><a:srgbClr val="2A2A2A"/></a:solidFill><a:latin typeface="Calibri"/></a:rPr><a:t>4. NO inicialices con README, .gitignore ni license (déjalo vacío)</a:t></a:r></a:p><a:p><a:pPr algn="l"/><a:r><a:rPr sz="1200" b="0"><a:solidFill><a:srgbClr val="2A2A2A"/></a:solidFill><a:latin typeface="Calibri"/></a:rPr><a:t>5. Clic en Create repository  →  Copia la URL HTTPS que te muestra</a:t></a:r></a:p></p:txBody></p:sp><p:sp><p:nvSpPr><p:cNvPr id="16" name="TextBox 15"/><p:cNvSpPr txBox="1"/><p:nvPr/></p:nvSpPr><p:spPr><a:xfrm><a:off x="640080" y="5623560"/><a:ext cx="10972800" cy="365760"/></a:xfrm><a:prstGeom prst="rect"><a:avLst/></a:prstGeom><a:noFill/></p:spPr><p:txBody><a:bodyPr wrap="square"><a:spAutoFit/></a:bodyPr><a:lstStyle/><a:p><a:pPr algn="l"/><a:r><a:rPr sz="1800" b="1"><a:solidFill><a:srgbClr val="065A82"/></a:solidFill><a:latin typeface="Calibri"/></a:rPr><a:t>4️⃣  Conectar y subir con git puro</a:t></a:r></a:p></p:txBody></p:sp><p:sp><p:nvSpPr><p:cNvPr id="17" name="Rounded Rectangle 16"/><p:cNvSpPr/><p:nvPr/></p:nvSpPr><p:spPr><a:xfrm><a:off x="640080" y="5989320"/><a:ext cx="10972800" cy="777240"/></a:xfrm><a:prstGeom prst="roundRect"><a:avLst/></a:prstGeom><a:solidFill><a:srgbClr val="2A2A2A"/></a:solidFill><a:ln><a:solidFill><a:srgbClr val="1C7293"/></a:solidFill></a:ln></p:spPr><p:style><a:lnRef idx="1"><a:schemeClr val="accent1"/></a:lnRef><a:fillRef idx="3"><a:schemeClr val="accent1"/></a:fillRef><a:effectRef idx="2"><a:schemeClr val="accent1"/></a:effectRef><a:fontRef idx="minor"><a:schemeClr val="lt1"/></a:fontRef></p:style><p:txBody><a:bodyPr rtlCol="0" anchor="ctr"/><a:lstStyle/><a:p><a:pPr algn="ctr"/></a:p></p:txBody></p:sp><p:sp><p:nvSpPr><p:cNvPr id="18" name="TextBox 17"/><p:cNvSpPr txBox="1"/><p:nvPr/></p:nvSpPr><p:spPr><a:xfrm><a:off x="822960" y="6035040"/><a:ext cx="10607040" cy="274320"/></a:xfrm><a:prstGeom prst="rect"><a:avLst/></a:prstGeom><a:noFill/></p:spPr><p:txBody><a:bodyPr wrap="square"><a:spAutoFit/></a:bodyPr><a:lstStyle/><a:p><a:pPr algn="l"/><a:r><a:rPr sz="1100" b="0"><a:solidFill><a:srgbClr val="FFFFFF"/></a:solidFill><a:latin typeface="Consolas"/></a:rPr><a:t>$ git remote set-url origin https://github.com/TU-USUARIO/evaluacion-administracion-web-TU-NOMBRE.git</a:t></a:r></a:r><a:r><a:rPr lang="es-PE" sz="1100"><a:solidFill><a:srgbClr val="666666"/></a:solidFill><a:latin typeface="Consolas"/></a:rPr><a:t>(ya existe porque hiciste git clone, no add)</a:t></a:r></a:p></p:txBody></p:sp><p:sp><p:nvSpPr><p:cNvPr id="19" name="TextBox 18"/><p:cNvSpPr txBox="1"/><p:nvPr/></p:nvSpPr><p:spPr><a:xfrm><a:off x="822960" y="6309360"/><a:ext cx="10607040" cy="274320"/></a:xfrm><a:prstGeom prst="rect"><a:avLst/></a:prstGeom><a:noFill/></p:spPr><p:txBody><a:bodyPr wrap="square"><a:spAutoFit/></a:bodyPr><a:lstStyle/><a:p><a:pPr algn="l"/><a:r><a:rPr sz="1200" b="0"><a:solidFill><a:srgbClr val="FFFFFF"/></a:solidFill><a:latin typeface="Consolas"/></a:rPr><a:t>$ git branch -M main</a:t></a:r></a:p></p:txBody></p:sp><p:sp><p:nvSpPr><p:cNvPr id="20" name="TextBox 19"/><p:cNvSpPr txBox="1"/><p:nvPr/></p:nvSpPr><p:spPr><a:xfrm><a:off x="822960" y="6537960"/><a:ext cx="10607040" cy="274320"/></a:xfrm><a:prstGeom prst="rect"><a:avLst/></a:prstGeom><a:noFill/></p:spPr><p:txBody><a:bodyPr wrap="square"><a:spAutoFit/></a:bodyPr><a:lstStyle/><a:p><a:pPr algn="l"/><a:r><a:rPr sz="1200" b="0"><a:solidFill><a:srgbClr val="FFFFFF"/></a:solidFill><a:latin typeface="Consolas"/></a:rPr><a:t>$ git push -u origin main</a:t></a:r></a:p></p:txBody></p:sp><p:sp><p:nvSpPr><p:cNvPr id="21" name="TextBox 20"/><p:cNvSpPr txBox="1"/><p:nvPr/></p:nvSpPr><p:spPr><a:xfrm><a:off x="457200" y="6903720"/><a:ext cx="10972800" cy="274320"/></a:xfrm><a:prstGeom prst="rect"><a:avLst/></a:prstGeom><a:noFill/></p:spPr><p:txBody><a:bodyPr wrap="square"><a:spAutoFit/></a:bodyPr><a:lstStyle/><a:p><a:pPr algn="l"/><a:r><a:rPr sz="1000" b="0"><a:solidFill><a:srgbClr val="666666"/></a:solidFill><a:latin typeface="Calibri"/></a:rPr><a:t>💡 No se exige memorizar comandos. Si logras subir el código, está bien.</a:t></a:r></a:p></p:txBody></p:sp></p:spTree></p:cSld><p:clrMapOvr><a:masterClrMapping/></p:clrMapOvr></p:sld>
+<file path=ppt/slides/slide5.xml><?xml version="1.0" encoding="utf-8"?>
+<p:sld xmlns:a="http://schemas.openxmlformats.org/drawingml/2006/main" xmlns:p="http://schemas.openxmlformats.org/presentationml/2006/main" xmlns:r="http://schemas.openxmlformats.org/officeDocument/2006/relationships">
+  <p:cSld>
+    <p:spTree>
+      <p:nvGrpSpPr>
+        <p:cNvPr id="1" name=""/>
+        <p:cNvGrpSpPr/>
+        <p:nvPr/>
+      </p:nvGrpSpPr>
+      <p:grpSpPr/>
+      <p:sp>
+        <p:nvSpPr>
+          <p:cNvPr id="2" name="Rectangle 1"/>
+          <p:cNvSpPr/>
+          <p:nvPr/>
+        </p:nvSpPr>
+        <p:spPr>
+          <a:xfrm>
+            <a:off x="0" y="0"/>
+            <a:ext cx="12191695" cy="6858000"/>
+          </a:xfrm>
+          <a:prstGeom prst="rect">
+            <a:avLst/>
+          </a:prstGeom>
+          <a:solidFill>
+            <a:srgbClr val="FFFFFF"/>
+          </a:solidFill>
+          <a:ln>
+            <a:noFill/>
+          </a:ln>
+        </p:spPr>
+        <p:style>
+          <a:lnRef idx="1">
+            <a:schemeClr val="accent1"/>
+          </a:lnRef>
+          <a:fillRef idx="3">
+            <a:schemeClr val="accent1"/>
+          </a:fillRef>
+          <a:effectRef idx="2">
+            <a:schemeClr val="accent1"/>
+          </a:effectRef>
+          <a:fontRef idx="minor">
+            <a:schemeClr val="lt1"/>
+          </a:fontRef>
+        </p:style>
+        <p:txBody>
+          <a:bodyPr rtlCol="0" anchor="ctr"/>
+          <a:lstStyle/>
+          <a:p>
+            <a:pPr algn="ctr"/>
+          </a:p>
+        </p:txBody>
+      </p:sp>
+      <p:sp>
+        <p:nvSpPr>
+          <p:cNvPr id="3" name="Rectangle 2"/>
+          <p:cNvSpPr/>
+          <p:nvPr/>
+        </p:nvSpPr>
+        <p:spPr>
+          <a:xfrm>
+            <a:off x="0" y="0"/>
+            <a:ext cx="12191695" cy="914400"/>
+          </a:xfrm>
+          <a:prstGeom prst="rect">
+            <a:avLst/>
+          </a:prstGeom>
+          <a:solidFill>
+            <a:srgbClr val="065A82"/>
+          </a:solidFill>
+          <a:ln>
+            <a:noFill/>
+          </a:ln>
+        </p:spPr>
+        <p:style>
+          <a:lnRef idx="1">
+            <a:schemeClr val="accent1"/>
+          </a:lnRef>
+          <a:fillRef idx="3">
+            <a:schemeClr val="accent1"/>
+          </a:fillRef>
+          <a:effectRef idx="2">
+            <a:schemeClr val="accent1"/>
+          </a:effectRef>
+          <a:fontRef idx="minor">
+            <a:schemeClr val="lt1"/>
+          </a:fontRef>
+        </p:style>
+        <p:txBody>
+          <a:bodyPr rtlCol="0" anchor="ctr"/>
+          <a:lstStyle/>
+          <a:p>
+            <a:pPr algn="ctr"/>
+          </a:p>
+        </p:txBody>
+      </p:sp>
+      <p:sp>
+        <p:nvSpPr>
+          <p:cNvPr id="4" name="TextBox 3"/>
+          <p:cNvSpPr txBox="1"/>
+          <p:nvPr/>
+        </p:nvSpPr>
+        <p:spPr>
+          <a:xfrm>
+            <a:off x="457200" y="274320"/>
+            <a:ext cx="10972800" cy="457200"/>
+          </a:xfrm>
+          <a:prstGeom prst="rect">
+            <a:avLst/>
+          </a:prstGeom>
+          <a:noFill/>
+        </p:spPr>
+        <p:txBody>
+          <a:bodyPr wrap="square">
+            <a:spAutoFit/>
+          </a:bodyPr>
+          <a:lstStyle/>
+          <a:p>
+            <a:pPr algn="l"/>
+            <a:r>
+              <a:rPr sz="3200" b="1">
+                <a:solidFill>
+                  <a:srgbClr val="FFFFFF"/>
+                </a:solidFill>
+                <a:latin typeface="Calibri"/>
+              </a:rPr>
+              <a:t>Parte 1 · Clonar, verificar y subir</a:t>
+            </a:r>
+          </a:p>
+        </p:txBody>
+      </p:sp>
+      <p:sp>
+        <p:nvSpPr>
+          <p:cNvPr id="5" name="TextBox 4"/>
+          <p:cNvSpPr txBox="1"/>
+          <p:nvPr/>
+        </p:nvSpPr>
+        <p:spPr>
+          <a:xfrm>
+            <a:off x="457200" y="685800"/>
+            <a:ext cx="10972800" cy="274320"/>
+          </a:xfrm>
+          <a:prstGeom prst="rect">
+            <a:avLst/>
+          </a:prstGeom>
+          <a:noFill/>
+        </p:spPr>
+        <p:txBody>
+          <a:bodyPr wrap="square">
+            <a:spAutoFit/>
+          </a:bodyPr>
+          <a:lstStyle/>
+          <a:p>
+            <a:pPr algn="l"/>
+            <a:r>
+              <a:rPr sz="1400" b="0">
+                <a:solidFill>
+                  <a:srgbClr val="60A5FA"/>
+                </a:solidFill>
+                <a:latin typeface="Calibri"/>
+              </a:rPr>
+              <a:t>⏱ 10 minutos  •  Solo git (sin gh CLI)</a:t>
+            </a:r>
+          </a:p>
+        </p:txBody>
+      </p:sp>
+      <p:sp>
+        <p:nvSpPr>
+          <p:cNvPr id="6" name="TextBox 5"/>
+          <p:cNvSpPr txBox="1"/>
+          <p:nvPr/>
+        </p:nvSpPr>
+        <p:spPr>
+          <a:xfrm>
+            <a:off x="640080" y="1097280"/>
+            <a:ext cx="10972800" cy="365760"/>
+          </a:xfrm>
+          <a:prstGeom prst="rect">
+            <a:avLst/>
+          </a:prstGeom>
+          <a:noFill/>
+        </p:spPr>
+        <p:txBody>
+          <a:bodyPr wrap="square">
+            <a:spAutoFit/>
+          </a:bodyPr>
+          <a:lstStyle/>
+          <a:p>
+            <a:pPr algn="l"/>
+            <a:r>
+              <a:rPr sz="1600" b="1">
+                <a:solidFill>
+                  <a:srgbClr val="065A82"/>
+                </a:solidFill>
+                <a:latin typeface="Calibri"/>
+              </a:rPr>
+              <a:t>1️⃣  Clonar el repositorio del docente</a:t>
+            </a:r>
+          </a:p>
+        </p:txBody>
+      </p:sp>
+      <p:sp>
+        <p:nvSpPr>
+          <p:cNvPr id="7" name="Rounded Rectangle 6"/>
+          <p:cNvSpPr/>
+          <p:nvPr/>
+        </p:nvSpPr>
+        <p:spPr>
+          <a:xfrm>
+            <a:off x="640080" y="1463040"/>
+            <a:ext cx="10972800" cy="502920"/>
+          </a:xfrm>
+          <a:prstGeom prst="roundRect">
+            <a:avLst/>
+          </a:prstGeom>
+          <a:solidFill>
+            <a:srgbClr val="2A2A2A"/>
+          </a:solidFill>
+          <a:ln>
+            <a:solidFill>
+              <a:srgbClr val="1C7293"/>
+            </a:solidFill>
+          </a:ln>
+        </p:spPr>
+        <p:style>
+          <a:lnRef idx="1">
+            <a:schemeClr val="accent1"/>
+          </a:lnRef>
+          <a:fillRef idx="3">
+            <a:schemeClr val="accent1"/>
+          </a:fillRef>
+          <a:effectRef idx="2">
+            <a:schemeClr val="accent1"/>
+          </a:effectRef>
+          <a:fontRef idx="minor">
+            <a:schemeClr val="lt1"/>
+          </a:fontRef>
+        </p:style>
+        <p:txBody>
+          <a:bodyPr rtlCol="0" anchor="ctr"/>
+          <a:lstStyle/>
+          <a:p>
+            <a:pPr algn="ctr"/>
+          </a:p>
+        </p:txBody>
+      </p:sp>
+      <p:sp>
+        <p:nvSpPr>
+          <p:cNvPr id="8" name="TextBox 7"/>
+          <p:cNvSpPr txBox="1"/>
+          <p:nvPr/>
+        </p:nvSpPr>
+        <p:spPr>
+          <a:xfrm>
+            <a:off x="822960" y="1508760"/>
+            <a:ext cx="10607040" cy="365760"/>
+          </a:xfrm>
+          <a:prstGeom prst="rect">
+            <a:avLst/>
+          </a:prstGeom>
+          <a:noFill/>
+        </p:spPr>
+        <p:txBody>
+          <a:bodyPr wrap="square">
+            <a:spAutoFit/>
+          </a:bodyPr>
+          <a:lstStyle/>
+          <a:p>
+            <a:pPr algn="l"/>
+            <a:r>
+              <a:rPr sz="1200" b="0">
+                <a:solidFill>
+                  <a:srgbClr val="FFFFFF"/>
+                </a:solidFill>
+                <a:latin typeface="Consolas"/>
+              </a:rPr>
+              <a:t>$ git clone https://github.com/KrizRoMe/evaluacion-administracion-web.git   &amp;&amp;   cd evaluacion-administracion-web</a:t>
+            </a:r>
+          </a:p>
+        </p:txBody>
+      </p:sp>
+      <p:sp>
+        <p:nvSpPr>
+          <p:cNvPr id="9" name="TextBox 8"/>
+          <p:cNvSpPr txBox="1"/>
+          <p:nvPr/>
+        </p:nvSpPr>
+        <p:spPr>
+          <a:xfrm>
+            <a:off x="640080" y="2103120"/>
+            <a:ext cx="10972800" cy="365760"/>
+          </a:xfrm>
+          <a:prstGeom prst="rect">
+            <a:avLst/>
+          </a:prstGeom>
+          <a:noFill/>
+        </p:spPr>
+        <p:txBody>
+          <a:bodyPr wrap="square">
+            <a:spAutoFit/>
+          </a:bodyPr>
+          <a:lstStyle/>
+          <a:p>
+            <a:pPr algn="l"/>
+            <a:r>
+              <a:rPr sz="1600" b="1">
+                <a:solidFill>
+                  <a:srgbClr val="065A82"/>
+                </a:solidFill>
+                <a:latin typeface="Calibri"/>
+              </a:rPr>
+              <a:t>2️⃣  Verificar que el sitio funciona localmente</a:t>
+            </a:r>
+          </a:p>
+        </p:txBody>
+      </p:sp>
+      <p:sp>
+        <p:nvSpPr>
+          <p:cNvPr id="10" name="Rounded Rectangle 9"/>
+          <p:cNvSpPr/>
+          <p:nvPr/>
+        </p:nvSpPr>
+        <p:spPr>
+          <a:xfrm>
+            <a:off x="640080" y="2468880"/>
+            <a:ext cx="10972800" cy="640080"/>
+          </a:xfrm>
+          <a:prstGeom prst="roundRect">
+            <a:avLst/>
+          </a:prstGeom>
+          <a:solidFill>
+            <a:srgbClr val="E6F7F1"/>
+          </a:solidFill>
+          <a:ln>
+            <a:solidFill>
+              <a:srgbClr val="10B981"/>
+            </a:solidFill>
+          </a:ln>
+        </p:spPr>
+        <p:style>
+          <a:lnRef idx="1">
+            <a:schemeClr val="accent1"/>
+          </a:lnRef>
+          <a:fillRef idx="3">
+            <a:schemeClr val="accent1"/>
+          </a:fillRef>
+          <a:effectRef idx="2">
+            <a:schemeClr val="accent1"/>
+          </a:effectRef>
+          <a:fontRef idx="minor">
+            <a:schemeClr val="lt1"/>
+          </a:fontRef>
+        </p:style>
+        <p:txBody>
+          <a:bodyPr rtlCol="0" anchor="ctr"/>
+          <a:lstStyle/>
+          <a:p>
+            <a:pPr algn="ctr"/>
+          </a:p>
+        </p:txBody>
+      </p:sp>
+      <p:sp>
+        <p:nvSpPr>
+          <p:cNvPr id="11" name="TextBox 10"/>
+          <p:cNvSpPr txBox="1"/>
+          <p:nvPr/>
+        </p:nvSpPr>
+        <p:spPr>
+          <a:xfrm>
+            <a:off x="822960" y="2560320"/>
+            <a:ext cx="10607040" cy="457200"/>
+          </a:xfrm>
+          <a:prstGeom prst="rect">
+            <a:avLst/>
+          </a:prstGeom>
+          <a:noFill/>
+        </p:spPr>
+        <p:txBody>
+          <a:bodyPr wrap="square">
+            <a:spAutoFit/>
+          </a:bodyPr>
+          <a:lstStyle/>
+          <a:p>
+            <a:pPr algn="ctr"/>
+            <a:r>
+              <a:rPr sz="1200" b="0">
+                <a:solidFill>
+                  <a:srgbClr val="2A2A2A"/>
+                </a:solidFill>
+                <a:latin typeface="Calibri"/>
+              </a:rPr>
+              <a:t>Doble clic en index.html  →  debe verse la tienda ECOMARKET con productos, carrito y modo oscuro</a:t>
+            </a:r>
+          </a:p>
+        </p:txBody>
+      </p:sp>
+      <p:sp>
+        <p:nvSpPr>
+          <p:cNvPr id="12" name="TextBox 11"/>
+          <p:cNvSpPr txBox="1"/>
+          <p:nvPr/>
+        </p:nvSpPr>
+        <p:spPr>
+          <a:xfrm>
+            <a:off x="640080" y="3246120"/>
+            <a:ext cx="10972800" cy="365760"/>
+          </a:xfrm>
+          <a:prstGeom prst="rect">
+            <a:avLst/>
+          </a:prstGeom>
+          <a:noFill/>
+        </p:spPr>
+        <p:txBody>
+          <a:bodyPr wrap="square">
+            <a:spAutoFit/>
+          </a:bodyPr>
+          <a:lstStyle/>
+          <a:p>
+            <a:pPr algn="l"/>
+            <a:r>
+              <a:rPr sz="1600" b="1">
+                <a:solidFill>
+                  <a:srgbClr val="065A82"/>
+                </a:solidFill>
+                <a:latin typeface="Calibri"/>
+              </a:rPr>
+              <a:t>3️⃣  Crear tu repositorio personal (manual, en la web)</a:t>
+            </a:r>
+          </a:p>
+        </p:txBody>
+      </p:sp>
+      <p:sp>
+        <p:nvSpPr>
+          <p:cNvPr id="13" name="Rounded Rectangle 12"/>
+          <p:cNvSpPr/>
+          <p:nvPr/>
+        </p:nvSpPr>
+        <p:spPr>
+          <a:xfrm>
+            <a:off x="640080" y="3611880"/>
+            <a:ext cx="10972800" cy="1188720"/>
+          </a:xfrm>
+          <a:prstGeom prst="roundRect">
+            <a:avLst/>
+          </a:prstGeom>
+          <a:solidFill>
+            <a:srgbClr val="FEF3E6"/>
+          </a:solidFill>
+          <a:ln>
+            <a:solidFill>
+              <a:srgbClr val="EA580C"/>
+            </a:solidFill>
+          </a:ln>
+        </p:spPr>
+        <p:style>
+          <a:lnRef idx="1">
+            <a:schemeClr val="accent1"/>
+          </a:lnRef>
+          <a:fillRef idx="3">
+            <a:schemeClr val="accent1"/>
+          </a:fillRef>
+          <a:effectRef idx="2">
+            <a:schemeClr val="accent1"/>
+          </a:effectRef>
+          <a:fontRef idx="minor">
+            <a:schemeClr val="lt1"/>
+          </a:fontRef>
+        </p:style>
+        <p:txBody>
+          <a:bodyPr rtlCol="0" anchor="ctr"/>
+          <a:lstStyle/>
+          <a:p>
+            <a:pPr algn="ctr"/>
+          </a:p>
+        </p:txBody>
+      </p:sp>
+      <p:sp>
+        <p:nvSpPr>
+          <p:cNvPr id="14" name="TextBox 13"/>
+          <p:cNvSpPr txBox="1"/>
+          <p:nvPr/>
+        </p:nvSpPr>
+        <p:spPr>
+          <a:xfrm>
+            <a:off x="822960" y="3657600"/>
+            <a:ext cx="10607040" cy="1097280"/>
+          </a:xfrm>
+          <a:prstGeom prst="rect">
+            <a:avLst/>
+          </a:prstGeom>
+          <a:noFill/>
+        </p:spPr>
+        <p:txBody>
+          <a:bodyPr wrap="square">
+            <a:spAutoFit/>
+          </a:bodyPr>
+          <a:lstStyle/>
+          <a:p>
+            <a:pPr algn="l"/>
+            <a:r>
+              <a:rPr sz="1000" b="0">
+                <a:solidFill>
+                  <a:srgbClr val="2A2A2A"/>
+                </a:solidFill>
+                <a:latin typeface="Calibri"/>
+              </a:rPr>
+              <a:t>1. Abre https://github.com/new en tu navegador</a:t>
+            </a:r>
+          </a:p>
+          <a:p>
+            <a:pPr algn="l"/>
+            <a:r>
+              <a:rPr sz="1000" b="0">
+                <a:solidFill>
+                  <a:srgbClr val="2A2A2A"/>
+                </a:solidFill>
+                <a:latin typeface="Calibri"/>
+              </a:rPr>
+              <a:t>2. Repository name:  evaluacion-administracion-web-TU-NOMBRE     3. Visibility:  Public</a:t>
+            </a:r>
+          </a:p>
+          <a:p>
+            <a:pPr algn="l"/>
+            <a:r>
+              <a:rPr sz="1000" b="0">
+                <a:solidFill>
+                  <a:srgbClr val="2A2A2A"/>
+                </a:solidFill>
+                <a:latin typeface="Calibri"/>
+              </a:rPr>
+              <a:t>4. NO inicialices con README, .gitignore ni license (déjalo vacío)     5. Clic en Create repository → copia la URL HTTPS</a:t>
+            </a:r>
+          </a:p>
+        </p:txBody>
+      </p:sp>
+      <p:sp>
+        <p:nvSpPr>
+          <p:cNvPr id="15" name="TextBox 14"/>
+          <p:cNvSpPr txBox="1"/>
+          <p:nvPr/>
+        </p:nvSpPr>
+        <p:spPr>
+          <a:xfrm>
+            <a:off x="640080" y="4937760"/>
+            <a:ext cx="10972800" cy="365760"/>
+          </a:xfrm>
+          <a:prstGeom prst="rect">
+            <a:avLst/>
+          </a:prstGeom>
+          <a:noFill/>
+        </p:spPr>
+        <p:txBody>
+          <a:bodyPr wrap="square">
+            <a:spAutoFit/>
+          </a:bodyPr>
+          <a:lstStyle/>
+          <a:p>
+            <a:pPr algn="l"/>
+            <a:r>
+              <a:rPr sz="1600" b="1">
+                <a:solidFill>
+                  <a:srgbClr val="065A82"/>
+                </a:solidFill>
+                <a:latin typeface="Calibri"/>
+              </a:rPr>
+              <a:t>4️⃣  Configurar git, conectar y subir</a:t>
+            </a:r>
+          </a:p>
+        </p:txBody>
+      </p:sp>
+      <p:sp>
+        <p:nvSpPr>
+          <p:cNvPr id="16" name="Rounded Rectangle 15"/>
+          <p:cNvSpPr/>
+          <p:nvPr/>
+        </p:nvSpPr>
+        <p:spPr>
+          <a:xfrm>
+            <a:off x="640080" y="5303520"/>
+            <a:ext cx="10972800" cy="1325880"/>
+          </a:xfrm>
+          <a:prstGeom prst="roundRect">
+            <a:avLst/>
+          </a:prstGeom>
+          <a:solidFill>
+            <a:srgbClr val="2A2A2A"/>
+          </a:solidFill>
+          <a:ln>
+            <a:solidFill>
+              <a:srgbClr val="1C7293"/>
+            </a:solidFill>
+          </a:ln>
+        </p:spPr>
+        <p:style>
+          <a:lnRef idx="1">
+            <a:schemeClr val="accent1"/>
+          </a:lnRef>
+          <a:fillRef idx="3">
+            <a:schemeClr val="accent1"/>
+          </a:fillRef>
+          <a:effectRef idx="2">
+            <a:schemeClr val="accent1"/>
+          </a:effectRef>
+          <a:fontRef idx="minor">
+            <a:schemeClr val="lt1"/>
+          </a:fontRef>
+        </p:style>
+        <p:txBody>
+          <a:bodyPr rtlCol="0" anchor="ctr"/>
+          <a:lstStyle/>
+          <a:p>
+            <a:pPr algn="ctr"/>
+          </a:p>
+        </p:txBody>
+      </p:sp>
+      <p:sp>
+        <p:nvSpPr>
+          <p:cNvPr id="17" name="TextBox 16"/>
+          <p:cNvSpPr txBox="1"/>
+          <p:nvPr/>
+        </p:nvSpPr>
+        <p:spPr>
+          <a:xfrm>
+            <a:off x="822960" y="5349240"/>
+            <a:ext cx="10607040" cy="1280160"/>
+          </a:xfrm>
+          <a:prstGeom prst="rect">
+            <a:avLst/>
+          </a:prstGeom>
+          <a:noFill/>
+        </p:spPr>
+        <p:txBody>
+          <a:bodyPr wrap="square">
+            <a:spAutoFit/>
+          </a:bodyPr>
+          <a:lstStyle/>
+          <a:p>
+            <a:pPr algn="l"/>
+            <a:r>
+              <a:rPr sz="1000" b="1">
+                <a:solidFill>
+                  <a:srgbClr val="FFFFFF"/>
+                </a:solidFill>
+                <a:latin typeface="Consolas"/>
+              </a:rPr>
+              <a:t># Identidad de git (solo la primera vez en tu PC)</a:t>
+            </a:r>
+          </a:p>
+          <a:p>
+            <a:pPr algn="l"/>
+            <a:r>
+              <a:rPr sz="1000" b="0">
+                <a:solidFill>
+                  <a:srgbClr val="FFFFFF"/>
+                </a:solidFill>
+                <a:latin typeface="Consolas"/>
+              </a:rPr>
+              <a:t>$ git config --global user.name "Tu Nombre Completo"</a:t>
+            </a:r>
+          </a:p>
+          <a:p>
+            <a:pPr algn="l"/>
+            <a:r>
+              <a:rPr sz="1000" b="0">
+                <a:solidFill>
+                  <a:srgbClr val="FFFFFF"/>
+                </a:solidFill>
+                <a:latin typeface="Consolas"/>
+              </a:rPr>
+              <a:t>$ git config --global user.email "tu@correo.com"</a:t>
+            </a:r>
+          </a:p>
+          <a:p>
+            <a:pPr algn="l"/>
+            <a:r>
+              <a:rPr sz="1000" b="1">
+                <a:solidFill>
+                  <a:srgbClr val="FFFFFF"/>
+                </a:solidFill>
+                <a:latin typeface="Consolas"/>
+              </a:rPr>
+              <a:t># Conectar y subir a tu repo (no add: set-url porque ya existe por git clone)</a:t>
+            </a:r>
+          </a:p>
+          <a:p>
+            <a:pPr algn="l"/>
+            <a:r>
+              <a:rPr sz="1000" b="0">
+                <a:solidFill>
+                  <a:srgbClr val="FFFFFF"/>
+                </a:solidFill>
+                <a:latin typeface="Consolas"/>
+              </a:rPr>
+              <a:t>$ git remote set-url origin https://github.com/TU-USUARIO/evaluacion-administracion-web-TU-NOMBRE.git</a:t>
+            </a:r>
+          </a:p>
+          <a:p>
+            <a:pPr algn="l"/>
+            <a:r>
+              <a:rPr sz="1000" b="0">
+                <a:solidFill>
+                  <a:srgbClr val="FFFFFF"/>
+                </a:solidFill>
+                <a:latin typeface="Consolas"/>
+              </a:rPr>
+              <a:t>$ git branch -M main   &amp;&amp;   $ git push -u origin main</a:t>
+            </a:r>
+          </a:p>
+        </p:txBody>
+      </p:sp>
+      <p:sp>
+        <p:nvSpPr>
+          <p:cNvPr id="18" name="TextBox 17"/>
+          <p:cNvSpPr txBox="1"/>
+          <p:nvPr/>
+        </p:nvSpPr>
+        <p:spPr>
+          <a:xfrm>
+            <a:off x="457200" y="6446520"/>
+            <a:ext cx="10515600" cy="274320"/>
+          </a:xfrm>
+          <a:prstGeom prst="rect">
+            <a:avLst/>
+          </a:prstGeom>
+          <a:noFill/>
+        </p:spPr>
+        <p:txBody>
+          <a:bodyPr wrap="square">
+            <a:spAutoFit/>
+          </a:bodyPr>
+          <a:lstStyle/>
+          <a:p>
+            <a:pPr algn="l"/>
+            <a:r>
+              <a:rPr sz="800" b="0">
+                <a:solidFill>
+                  <a:srgbClr val="666666"/>
+                </a:solidFill>
+                <a:latin typeface="Calibri"/>
+              </a:rPr>
+              <a:t>📦 Repo del docente: github.com/KrizRoMe/evaluacion-administracion-web   •   🌐 Sitio público: krizrome.github.io/evaluacion-administracion-web   •   📋 Issues: github.com/KrizRoMe/evaluacion-administracion-web/issues</a:t>
+            </a:r>
+          </a:p>
+        </p:txBody>
+      </p:sp>
+      <p:sp>
+        <p:nvSpPr>
+          <p:cNvPr id="19" name="TextBox 18"/>
+          <p:cNvSpPr txBox="1"/>
+          <p:nvPr/>
+        </p:nvSpPr>
+        <p:spPr>
+          <a:xfrm>
+            <a:off x="11155680" y="6446520"/>
+            <a:ext cx="731520" cy="274320"/>
+          </a:xfrm>
+          <a:prstGeom prst="rect">
+            <a:avLst/>
+          </a:prstGeom>
+          <a:noFill/>
+        </p:spPr>
+        <p:txBody>
+          <a:bodyPr wrap="square">
+            <a:spAutoFit/>
+          </a:bodyPr>
+          <a:lstStyle/>
+          <a:p>
+            <a:pPr algn="r"/>
+            <a:r>
+              <a:rPr sz="1000" b="0">
+                <a:solidFill>
+                  <a:srgbClr val="999999"/>
+                </a:solidFill>
+                <a:latin typeface="Calibri"/>
+              </a:rPr>
+              <a:t>5 / 11</a:t>
+            </a:r>
+          </a:p>
+        </p:txBody>
+      </p:sp>
+    </p:spTree>
+  </p:cSld>
+  <p:clrMapOvr>
+    <a:masterClrMapping/>
+  </p:clrMapOvr>
+</p:sld>
 </file>
 
 <file path=ppt/slides/slide6.xml><?xml version="1.0" encoding="utf-8"?>
@@ -8251,56 +9035,21 @@
                 </a:solidFill>
                 <a:latin typeface="Calibri"/>
               </a:rPr>
-              <a:t>🛠 Herramientas a usar:</a:t>
-            </a:r>
-          </a:p>
-        </p:txBody>
-      </p:sp>
-      <p:sp>
-        <p:nvSpPr>
-          <p:cNvPr id="7" name="TextBox 6"/>
-          <p:cNvSpPr txBox="1"/>
-          <p:nvPr/>
-        </p:nvSpPr>
-        <p:spPr>
-          <a:xfrm>
-            <a:off x="640080" y="1554480"/>
-            <a:ext cx="10972800" cy="731520"/>
-          </a:xfrm>
-          <a:prstGeom prst="rect">
-            <a:avLst/>
-          </a:prstGeom>
-          <a:noFill/>
-        </p:spPr>
-        <p:txBody>
-          <a:bodyPr wrap="square">
-            <a:spAutoFit/>
-          </a:bodyPr>
-          <a:lstStyle/>
-          <a:p>
-            <a:pPr algn="l"/>
-            <a:r>
-              <a:rPr sz="1400" b="0">
-                <a:solidFill>
-                  <a:srgbClr val="2A2A2A"/>
-                </a:solidFill>
-                <a:latin typeface="Calibri"/>
-              </a:rPr>
-              <a:t>Chrome DevTools (F12)  •  Lighthouse (rendimiento)  •  axe DevTools (accesibilidad)  •  package.json (mantenimiento)</a:t>
-            </a:r>
-          </a:p>
-        </p:txBody>
-      </p:sp>
-      <p:sp>
-        <p:nvSpPr>
-          <p:cNvPr id="8" name="Rounded Rectangle 7"/>
+              <a:t>🛠 Herramientas a usar (y comandos de pista):</a:t>
+            </a:r>
+          </a:p>
+        </p:txBody>
+      </p:sp>
+      <p:sp>
+        <p:nvSpPr>
+          <p:cNvPr id="7" name="Rounded Rectangle 6"/>
           <p:cNvSpPr/>
           <p:nvPr/>
         </p:nvSpPr>
         <p:spPr>
           <a:xfrm>
-            <a:off x="426567" y="2286000"/>
-            <a:ext cx="3657600" cy="3108960"/>
+            <a:off x="426567" y="1691640"/>
+            <a:ext cx="3657600" cy="3840480"/>
           </a:xfrm>
           <a:prstGeom prst="roundRect">
             <a:avLst/>
@@ -8338,14 +9087,14 @@
       </p:sp>
       <p:sp>
         <p:nvSpPr>
-          <p:cNvPr id="9" name="Rectangle 8"/>
+          <p:cNvPr id="8" name="Rectangle 7"/>
           <p:cNvSpPr/>
           <p:nvPr/>
         </p:nvSpPr>
         <p:spPr>
           <a:xfrm>
-            <a:off x="426567" y="2286000"/>
-            <a:ext cx="3657600" cy="548640"/>
+            <a:off x="426567" y="1691640"/>
+            <a:ext cx="3657600" cy="457200"/>
           </a:xfrm>
           <a:prstGeom prst="rect">
             <a:avLst/>
@@ -8381,35 +9130,70 @@
       </p:sp>
       <p:sp>
         <p:nvSpPr>
+          <p:cNvPr id="9" name="TextBox 8"/>
+          <p:cNvSpPr txBox="1"/>
+          <p:nvPr/>
+        </p:nvSpPr>
+        <p:spPr>
+          <a:xfrm>
+            <a:off x="426567" y="1737360"/>
+            <a:ext cx="3657600" cy="365760"/>
+          </a:xfrm>
+          <a:prstGeom prst="rect">
+            <a:avLst/>
+          </a:prstGeom>
+          <a:noFill/>
+        </p:spPr>
+        <p:txBody>
+          <a:bodyPr wrap="square">
+            <a:spAutoFit/>
+          </a:bodyPr>
+          <a:lstStyle/>
+          <a:p>
+            <a:pPr algn="ctr"/>
+            <a:r>
+              <a:rPr sz="1600" b="1">
+                <a:solidFill>
+                  <a:srgbClr val="FFFFFF"/>
+                </a:solidFill>
+                <a:latin typeface="Calibri"/>
+              </a:rPr>
+              <a:t>📊 RENDIMIENTO</a:t>
+            </a:r>
+          </a:p>
+        </p:txBody>
+      </p:sp>
+      <p:sp>
+        <p:nvSpPr>
           <p:cNvPr id="10" name="TextBox 9"/>
           <p:cNvSpPr txBox="1"/>
           <p:nvPr/>
         </p:nvSpPr>
         <p:spPr>
           <a:xfrm>
-            <a:off x="426567" y="2331720"/>
-            <a:ext cx="3657600" cy="457200"/>
-          </a:xfrm>
-          <a:prstGeom prst="rect">
-            <a:avLst/>
-          </a:prstGeom>
-          <a:noFill/>
-        </p:spPr>
-        <p:txBody>
-          <a:bodyPr wrap="square">
-            <a:spAutoFit/>
-          </a:bodyPr>
-          <a:lstStyle/>
-          <a:p>
-            <a:pPr algn="ctr"/>
-            <a:r>
-              <a:rPr sz="1800" b="1">
-                <a:solidFill>
-                  <a:srgbClr val="FFFFFF"/>
-                </a:solidFill>
-                <a:latin typeface="Calibri"/>
-              </a:rPr>
-              <a:t>📊 RENDIMIENTO</a:t>
+            <a:off x="563727" y="2194560"/>
+            <a:ext cx="3383280" cy="274320"/>
+          </a:xfrm>
+          <a:prstGeom prst="rect">
+            <a:avLst/>
+          </a:prstGeom>
+          <a:noFill/>
+        </p:spPr>
+        <p:txBody>
+          <a:bodyPr wrap="square">
+            <a:spAutoFit/>
+          </a:bodyPr>
+          <a:lstStyle/>
+          <a:p>
+            <a:pPr algn="l"/>
+            <a:r>
+              <a:rPr sz="1100" b="1">
+                <a:solidFill>
+                  <a:srgbClr val="1C7293"/>
+                </a:solidFill>
+                <a:latin typeface="Calibri"/>
+              </a:rPr>
+              <a:t>Herramientas:</a:t>
             </a:r>
           </a:p>
         </p:txBody>
@@ -8422,23 +9206,23 @@
         </p:nvSpPr>
         <p:spPr>
           <a:xfrm>
-            <a:off x="563727" y="2926080"/>
-            <a:ext cx="3383280" cy="1463040"/>
-          </a:xfrm>
-          <a:prstGeom prst="rect">
-            <a:avLst/>
-          </a:prstGeom>
-          <a:noFill/>
-        </p:spPr>
-        <p:txBody>
-          <a:bodyPr wrap="square">
-            <a:spAutoFit/>
-          </a:bodyPr>
-          <a:lstStyle/>
-          <a:p>
-            <a:pPr algn="l"/>
-            <a:r>
-              <a:rPr sz="1200" b="1">
+            <a:off x="563727" y="2468880"/>
+            <a:ext cx="3383280" cy="274320"/>
+          </a:xfrm>
+          <a:prstGeom prst="rect">
+            <a:avLst/>
+          </a:prstGeom>
+          <a:noFill/>
+        </p:spPr>
+        <p:txBody>
+          <a:bodyPr wrap="square">
+            <a:spAutoFit/>
+          </a:bodyPr>
+          <a:lstStyle/>
+          <a:p>
+            <a:pPr algn="l"/>
+            <a:r>
+              <a:rPr sz="1100" b="0">
                 <a:solidFill>
                   <a:srgbClr val="2A2A2A"/>
                 </a:solidFill>
@@ -8447,29 +9231,74 @@
               <a:t>Chrome DevTools + Lighthouse</a:t>
             </a:r>
           </a:p>
-          <a:p>
-            <a:pPr algn="l"/>
-            <a:r>
-              <a:rPr sz="1200" b="0">
+        </p:txBody>
+      </p:sp>
+      <p:sp>
+        <p:nvSpPr>
+          <p:cNvPr id="12" name="TextBox 11"/>
+          <p:cNvSpPr txBox="1"/>
+          <p:nvPr/>
+        </p:nvSpPr>
+        <p:spPr>
+          <a:xfrm>
+            <a:off x="563727" y="2788920"/>
+            <a:ext cx="3383280" cy="274320"/>
+          </a:xfrm>
+          <a:prstGeom prst="rect">
+            <a:avLst/>
+          </a:prstGeom>
+          <a:noFill/>
+        </p:spPr>
+        <p:txBody>
+          <a:bodyPr wrap="square">
+            <a:spAutoFit/>
+          </a:bodyPr>
+          <a:lstStyle/>
+          <a:p>
+            <a:pPr algn="l"/>
+            <a:r>
+              <a:rPr sz="1100" b="1">
+                <a:solidFill>
+                  <a:srgbClr val="1C7293"/>
+                </a:solidFill>
+                <a:latin typeface="Calibri"/>
+              </a:rPr>
+              <a:t>Ejemplos:</a:t>
+            </a:r>
+          </a:p>
+        </p:txBody>
+      </p:sp>
+      <p:sp>
+        <p:nvSpPr>
+          <p:cNvPr id="13" name="TextBox 12"/>
+          <p:cNvSpPr txBox="1"/>
+          <p:nvPr/>
+        </p:nvSpPr>
+        <p:spPr>
+          <a:xfrm>
+            <a:off x="563727" y="3017520"/>
+            <a:ext cx="3383280" cy="1005840"/>
+          </a:xfrm>
+          <a:prstGeom prst="rect">
+            <a:avLst/>
+          </a:prstGeom>
+          <a:noFill/>
+        </p:spPr>
+        <p:txBody>
+          <a:bodyPr wrap="square">
+            <a:spAutoFit/>
+          </a:bodyPr>
+          <a:lstStyle/>
+          <a:p>
+            <a:pPr algn="l"/>
+            <a:r>
+              <a:rPr sz="900" b="0">
                 <a:solidFill>
                   <a:srgbClr val="2A2A2A"/>
                 </a:solidFill>
                 <a:latin typeface="Calibri"/>
               </a:rPr>
-              <a:t/>
-            </a:r>
-          </a:p>
-          <a:p>
-            <a:pPr algn="l"/>
-            <a:r>
-              <a:rPr sz="1200" b="0">
-                <a:solidFill>
-                  <a:srgbClr val="2A2A2A"/>
-                </a:solidFill>
-                <a:latin typeface="Calibri"/>
-              </a:rPr>
-              <a:t>Ejemplos:
-• Imagen sin width/height (CLS)
+              <a:t>• Imagen sin width/height (CLS)
 • Imágenes sin loading='lazy'
 • &lt;script&gt; sin defer
 • SVGs innecesariamente pesados
@@ -8480,13 +9309,91 @@
       </p:sp>
       <p:sp>
         <p:nvSpPr>
-          <p:cNvPr id="12" name="TextBox 11"/>
-          <p:cNvSpPr txBox="1"/>
-          <p:nvPr/>
-        </p:nvSpPr>
-        <p:spPr>
-          <a:xfrm>
-            <a:off x="426567" y="5166360"/>
+          <p:cNvPr id="14" name="Rectangle 13"/>
+          <p:cNvSpPr/>
+          <p:nvPr/>
+        </p:nvSpPr>
+        <p:spPr>
+          <a:xfrm>
+            <a:off x="518007" y="4114800"/>
+            <a:ext cx="3474720" cy="457200"/>
+          </a:xfrm>
+          <a:prstGeom prst="rect">
+            <a:avLst/>
+          </a:prstGeom>
+          <a:solidFill>
+            <a:srgbClr val="FFF3CD"/>
+          </a:solidFill>
+          <a:ln>
+            <a:noFill/>
+          </a:ln>
+        </p:spPr>
+        <p:style>
+          <a:lnRef idx="1">
+            <a:schemeClr val="accent1"/>
+          </a:lnRef>
+          <a:fillRef idx="3">
+            <a:schemeClr val="accent1"/>
+          </a:fillRef>
+          <a:effectRef idx="2">
+            <a:schemeClr val="accent1"/>
+          </a:effectRef>
+          <a:fontRef idx="minor">
+            <a:schemeClr val="lt1"/>
+          </a:fontRef>
+        </p:style>
+        <p:txBody>
+          <a:bodyPr rtlCol="0" anchor="ctr"/>
+          <a:lstStyle/>
+          <a:p>
+            <a:pPr algn="ctr"/>
+          </a:p>
+        </p:txBody>
+      </p:sp>
+      <p:sp>
+        <p:nvSpPr>
+          <p:cNvPr id="15" name="TextBox 14"/>
+          <p:cNvSpPr txBox="1"/>
+          <p:nvPr/>
+        </p:nvSpPr>
+        <p:spPr>
+          <a:xfrm>
+            <a:off x="563727" y="4133087"/>
+            <a:ext cx="3383280" cy="411480"/>
+          </a:xfrm>
+          <a:prstGeom prst="rect">
+            <a:avLst/>
+          </a:prstGeom>
+          <a:noFill/>
+        </p:spPr>
+        <p:txBody>
+          <a:bodyPr wrap="square">
+            <a:spAutoFit/>
+          </a:bodyPr>
+          <a:lstStyle/>
+          <a:p>
+            <a:pPr algn="ctr"/>
+            <a:r>
+              <a:rPr sz="900" b="0">
+                <a:solidFill>
+                  <a:srgbClr val="2A2A2A"/>
+                </a:solidFill>
+                <a:latin typeface="Consolas"/>
+              </a:rPr>
+              <a:t>💡 Pista: F12 → Lighthouse → Analyze</a:t>
+            </a:r>
+          </a:p>
+        </p:txBody>
+      </p:sp>
+      <p:sp>
+        <p:nvSpPr>
+          <p:cNvPr id="16" name="TextBox 15"/>
+          <p:cNvSpPr txBox="1"/>
+          <p:nvPr/>
+        </p:nvSpPr>
+        <p:spPr>
+          <a:xfrm>
+            <a:off x="426567" y="4663440"/>
             <a:ext cx="3657600" cy="274320"/>
           </a:xfrm>
           <a:prstGeom prst="rect">
@@ -8502,7 +9409,7 @@
           <a:p>
             <a:pPr algn="ctr"/>
             <a:r>
-              <a:rPr sz="1100" b="1">
+              <a:rPr sz="1000" b="1">
                 <a:solidFill>
                   <a:srgbClr val="1C7293"/>
                 </a:solidFill>
@@ -8515,14 +9422,14 @@
       </p:sp>
       <p:sp>
         <p:nvSpPr>
-          <p:cNvPr id="13" name="Rounded Rectangle 12"/>
+          <p:cNvPr id="17" name="Rounded Rectangle 16"/>
           <p:cNvSpPr/>
           <p:nvPr/>
         </p:nvSpPr>
         <p:spPr>
           <a:xfrm>
-            <a:off x="4267047" y="2286000"/>
-            <a:ext cx="3657600" cy="3108960"/>
+            <a:off x="4267047" y="1691640"/>
+            <a:ext cx="3657600" cy="3840480"/>
           </a:xfrm>
           <a:prstGeom prst="roundRect">
             <a:avLst/>
@@ -8560,14 +9467,14 @@
       </p:sp>
       <p:sp>
         <p:nvSpPr>
-          <p:cNvPr id="14" name="Rectangle 13"/>
+          <p:cNvPr id="18" name="Rectangle 17"/>
           <p:cNvSpPr/>
           <p:nvPr/>
         </p:nvSpPr>
         <p:spPr>
           <a:xfrm>
-            <a:off x="4267047" y="2286000"/>
-            <a:ext cx="3657600" cy="548640"/>
+            <a:off x="4267047" y="1691640"/>
+            <a:ext cx="3657600" cy="457200"/>
           </a:xfrm>
           <a:prstGeom prst="rect">
             <a:avLst/>
@@ -8603,14 +9510,14 @@
       </p:sp>
       <p:sp>
         <p:nvSpPr>
-          <p:cNvPr id="15" name="TextBox 14"/>
-          <p:cNvSpPr txBox="1"/>
-          <p:nvPr/>
-        </p:nvSpPr>
-        <p:spPr>
-          <a:xfrm>
-            <a:off x="4267047" y="2331720"/>
-            <a:ext cx="3657600" cy="457200"/>
+          <p:cNvPr id="19" name="TextBox 18"/>
+          <p:cNvSpPr txBox="1"/>
+          <p:nvPr/>
+        </p:nvSpPr>
+        <p:spPr>
+          <a:xfrm>
+            <a:off x="4267047" y="1737360"/>
+            <a:ext cx="3657600" cy="365760"/>
           </a:xfrm>
           <a:prstGeom prst="rect">
             <a:avLst/>
@@ -8625,7 +9532,7 @@
           <a:p>
             <a:pPr algn="ctr"/>
             <a:r>
-              <a:rPr sz="1800" b="1">
+              <a:rPr sz="1600" b="1">
                 <a:solidFill>
                   <a:srgbClr val="FFFFFF"/>
                 </a:solidFill>
@@ -8638,29 +9545,64 @@
       </p:sp>
       <p:sp>
         <p:nvSpPr>
-          <p:cNvPr id="16" name="TextBox 15"/>
-          <p:cNvSpPr txBox="1"/>
-          <p:nvPr/>
-        </p:nvSpPr>
-        <p:spPr>
-          <a:xfrm>
-            <a:off x="4404207" y="2926080"/>
-            <a:ext cx="3383280" cy="1463040"/>
-          </a:xfrm>
-          <a:prstGeom prst="rect">
-            <a:avLst/>
-          </a:prstGeom>
-          <a:noFill/>
-        </p:spPr>
-        <p:txBody>
-          <a:bodyPr wrap="square">
-            <a:spAutoFit/>
-          </a:bodyPr>
-          <a:lstStyle/>
-          <a:p>
-            <a:pPr algn="l"/>
-            <a:r>
-              <a:rPr sz="1200" b="1">
+          <p:cNvPr id="20" name="TextBox 19"/>
+          <p:cNvSpPr txBox="1"/>
+          <p:nvPr/>
+        </p:nvSpPr>
+        <p:spPr>
+          <a:xfrm>
+            <a:off x="4404207" y="2194560"/>
+            <a:ext cx="3383280" cy="274320"/>
+          </a:xfrm>
+          <a:prstGeom prst="rect">
+            <a:avLst/>
+          </a:prstGeom>
+          <a:noFill/>
+        </p:spPr>
+        <p:txBody>
+          <a:bodyPr wrap="square">
+            <a:spAutoFit/>
+          </a:bodyPr>
+          <a:lstStyle/>
+          <a:p>
+            <a:pPr algn="l"/>
+            <a:r>
+              <a:rPr sz="1100" b="1">
+                <a:solidFill>
+                  <a:srgbClr val="10B981"/>
+                </a:solidFill>
+                <a:latin typeface="Calibri"/>
+              </a:rPr>
+              <a:t>Herramientas:</a:t>
+            </a:r>
+          </a:p>
+        </p:txBody>
+      </p:sp>
+      <p:sp>
+        <p:nvSpPr>
+          <p:cNvPr id="21" name="TextBox 20"/>
+          <p:cNvSpPr txBox="1"/>
+          <p:nvPr/>
+        </p:nvSpPr>
+        <p:spPr>
+          <a:xfrm>
+            <a:off x="4404207" y="2468880"/>
+            <a:ext cx="3383280" cy="274320"/>
+          </a:xfrm>
+          <a:prstGeom prst="rect">
+            <a:avLst/>
+          </a:prstGeom>
+          <a:noFill/>
+        </p:spPr>
+        <p:txBody>
+          <a:bodyPr wrap="square">
+            <a:spAutoFit/>
+          </a:bodyPr>
+          <a:lstStyle/>
+          <a:p>
+            <a:pPr algn="l"/>
+            <a:r>
+              <a:rPr sz="1100" b="0">
                 <a:solidFill>
                   <a:srgbClr val="2A2A2A"/>
                 </a:solidFill>
@@ -8669,29 +9611,74 @@
               <a:t>axe DevTools</a:t>
             </a:r>
           </a:p>
-          <a:p>
-            <a:pPr algn="l"/>
-            <a:r>
-              <a:rPr sz="1200" b="0">
+        </p:txBody>
+      </p:sp>
+      <p:sp>
+        <p:nvSpPr>
+          <p:cNvPr id="22" name="TextBox 21"/>
+          <p:cNvSpPr txBox="1"/>
+          <p:nvPr/>
+        </p:nvSpPr>
+        <p:spPr>
+          <a:xfrm>
+            <a:off x="4404207" y="2788920"/>
+            <a:ext cx="3383280" cy="274320"/>
+          </a:xfrm>
+          <a:prstGeom prst="rect">
+            <a:avLst/>
+          </a:prstGeom>
+          <a:noFill/>
+        </p:spPr>
+        <p:txBody>
+          <a:bodyPr wrap="square">
+            <a:spAutoFit/>
+          </a:bodyPr>
+          <a:lstStyle/>
+          <a:p>
+            <a:pPr algn="l"/>
+            <a:r>
+              <a:rPr sz="1100" b="1">
+                <a:solidFill>
+                  <a:srgbClr val="10B981"/>
+                </a:solidFill>
+                <a:latin typeface="Calibri"/>
+              </a:rPr>
+              <a:t>Ejemplos:</a:t>
+            </a:r>
+          </a:p>
+        </p:txBody>
+      </p:sp>
+      <p:sp>
+        <p:nvSpPr>
+          <p:cNvPr id="23" name="TextBox 22"/>
+          <p:cNvSpPr txBox="1"/>
+          <p:nvPr/>
+        </p:nvSpPr>
+        <p:spPr>
+          <a:xfrm>
+            <a:off x="4404207" y="3017520"/>
+            <a:ext cx="3383280" cy="1005840"/>
+          </a:xfrm>
+          <a:prstGeom prst="rect">
+            <a:avLst/>
+          </a:prstGeom>
+          <a:noFill/>
+        </p:spPr>
+        <p:txBody>
+          <a:bodyPr wrap="square">
+            <a:spAutoFit/>
+          </a:bodyPr>
+          <a:lstStyle/>
+          <a:p>
+            <a:pPr algn="l"/>
+            <a:r>
+              <a:rPr sz="900" b="0">
                 <a:solidFill>
                   <a:srgbClr val="2A2A2A"/>
                 </a:solidFill>
                 <a:latin typeface="Calibri"/>
               </a:rPr>
-              <a:t/>
-            </a:r>
-          </a:p>
-          <a:p>
-            <a:pPr algn="l"/>
-            <a:r>
-              <a:rPr sz="1200" b="0">
-                <a:solidFill>
-                  <a:srgbClr val="2A2A2A"/>
-                </a:solidFill>
-                <a:latin typeface="Calibri"/>
-              </a:rPr>
-              <a:t>Ejemplos:
-• Imágenes sin alt
+              <a:t>• Imágenes sin alt
 • Botones sin aria-label
 • Contraste insuficiente
 • Inputs sin &lt;label&gt;
@@ -8702,13 +9689,91 @@
       </p:sp>
       <p:sp>
         <p:nvSpPr>
-          <p:cNvPr id="17" name="TextBox 16"/>
-          <p:cNvSpPr txBox="1"/>
-          <p:nvPr/>
-        </p:nvSpPr>
-        <p:spPr>
-          <a:xfrm>
-            <a:off x="4267047" y="5166360"/>
+          <p:cNvPr id="24" name="Rectangle 23"/>
+          <p:cNvSpPr/>
+          <p:nvPr/>
+        </p:nvSpPr>
+        <p:spPr>
+          <a:xfrm>
+            <a:off x="4358487" y="4114800"/>
+            <a:ext cx="3474720" cy="457200"/>
+          </a:xfrm>
+          <a:prstGeom prst="rect">
+            <a:avLst/>
+          </a:prstGeom>
+          <a:solidFill>
+            <a:srgbClr val="FFF3CD"/>
+          </a:solidFill>
+          <a:ln>
+            <a:noFill/>
+          </a:ln>
+        </p:spPr>
+        <p:style>
+          <a:lnRef idx="1">
+            <a:schemeClr val="accent1"/>
+          </a:lnRef>
+          <a:fillRef idx="3">
+            <a:schemeClr val="accent1"/>
+          </a:fillRef>
+          <a:effectRef idx="2">
+            <a:schemeClr val="accent1"/>
+          </a:effectRef>
+          <a:fontRef idx="minor">
+            <a:schemeClr val="lt1"/>
+          </a:fontRef>
+        </p:style>
+        <p:txBody>
+          <a:bodyPr rtlCol="0" anchor="ctr"/>
+          <a:lstStyle/>
+          <a:p>
+            <a:pPr algn="ctr"/>
+          </a:p>
+        </p:txBody>
+      </p:sp>
+      <p:sp>
+        <p:nvSpPr>
+          <p:cNvPr id="25" name="TextBox 24"/>
+          <p:cNvSpPr txBox="1"/>
+          <p:nvPr/>
+        </p:nvSpPr>
+        <p:spPr>
+          <a:xfrm>
+            <a:off x="4404207" y="4133087"/>
+            <a:ext cx="3383280" cy="411480"/>
+          </a:xfrm>
+          <a:prstGeom prst="rect">
+            <a:avLst/>
+          </a:prstGeom>
+          <a:noFill/>
+        </p:spPr>
+        <p:txBody>
+          <a:bodyPr wrap="square">
+            <a:spAutoFit/>
+          </a:bodyPr>
+          <a:lstStyle/>
+          <a:p>
+            <a:pPr algn="ctr"/>
+            <a:r>
+              <a:rPr sz="900" b="0">
+                <a:solidFill>
+                  <a:srgbClr val="2A2A2A"/>
+                </a:solidFill>
+                <a:latin typeface="Consolas"/>
+              </a:rPr>
+              <a:t>💡 Pista: F12 → axe DevTools → Scan</a:t>
+            </a:r>
+          </a:p>
+        </p:txBody>
+      </p:sp>
+      <p:sp>
+        <p:nvSpPr>
+          <p:cNvPr id="26" name="TextBox 25"/>
+          <p:cNvSpPr txBox="1"/>
+          <p:nvPr/>
+        </p:nvSpPr>
+        <p:spPr>
+          <a:xfrm>
+            <a:off x="4267047" y="4663440"/>
             <a:ext cx="3657600" cy="274320"/>
           </a:xfrm>
           <a:prstGeom prst="rect">
@@ -8724,7 +9789,7 @@
           <a:p>
             <a:pPr algn="ctr"/>
             <a:r>
-              <a:rPr sz="1100" b="1">
+              <a:rPr sz="1000" b="1">
                 <a:solidFill>
                   <a:srgbClr val="10B981"/>
                 </a:solidFill>
@@ -8737,14 +9802,14 @@
       </p:sp>
       <p:sp>
         <p:nvSpPr>
-          <p:cNvPr id="18" name="Rounded Rectangle 17"/>
+          <p:cNvPr id="27" name="Rounded Rectangle 26"/>
           <p:cNvSpPr/>
           <p:nvPr/>
         </p:nvSpPr>
         <p:spPr>
           <a:xfrm>
-            <a:off x="8107527" y="2286000"/>
-            <a:ext cx="3657600" cy="3108960"/>
+            <a:off x="8107527" y="1691640"/>
+            <a:ext cx="3657600" cy="3840480"/>
           </a:xfrm>
           <a:prstGeom prst="roundRect">
             <a:avLst/>
@@ -8782,14 +9847,14 @@
       </p:sp>
       <p:sp>
         <p:nvSpPr>
-          <p:cNvPr id="19" name="Rectangle 18"/>
+          <p:cNvPr id="28" name="Rectangle 27"/>
           <p:cNvSpPr/>
           <p:nvPr/>
         </p:nvSpPr>
         <p:spPr>
           <a:xfrm>
-            <a:off x="8107527" y="2286000"/>
-            <a:ext cx="3657600" cy="548640"/>
+            <a:off x="8107527" y="1691640"/>
+            <a:ext cx="3657600" cy="457200"/>
           </a:xfrm>
           <a:prstGeom prst="rect">
             <a:avLst/>
@@ -8825,14 +9890,14 @@
       </p:sp>
       <p:sp>
         <p:nvSpPr>
-          <p:cNvPr id="20" name="TextBox 19"/>
-          <p:cNvSpPr txBox="1"/>
-          <p:nvPr/>
-        </p:nvSpPr>
-        <p:spPr>
-          <a:xfrm>
-            <a:off x="8107527" y="2331720"/>
-            <a:ext cx="3657600" cy="457200"/>
+          <p:cNvPr id="29" name="TextBox 28"/>
+          <p:cNvSpPr txBox="1"/>
+          <p:nvPr/>
+        </p:nvSpPr>
+        <p:spPr>
+          <a:xfrm>
+            <a:off x="8107527" y="1737360"/>
+            <a:ext cx="3657600" cy="365760"/>
           </a:xfrm>
           <a:prstGeom prst="rect">
             <a:avLst/>
@@ -8847,7 +9912,7 @@
           <a:p>
             <a:pPr algn="ctr"/>
             <a:r>
-              <a:rPr sz="1800" b="1">
+              <a:rPr sz="1600" b="1">
                 <a:solidFill>
                   <a:srgbClr val="FFFFFF"/>
                 </a:solidFill>
@@ -8860,29 +9925,64 @@
       </p:sp>
       <p:sp>
         <p:nvSpPr>
-          <p:cNvPr id="21" name="TextBox 20"/>
-          <p:cNvSpPr txBox="1"/>
-          <p:nvPr/>
-        </p:nvSpPr>
-        <p:spPr>
-          <a:xfrm>
-            <a:off x="8244687" y="2926080"/>
-            <a:ext cx="3383280" cy="1463040"/>
-          </a:xfrm>
-          <a:prstGeom prst="rect">
-            <a:avLst/>
-          </a:prstGeom>
-          <a:noFill/>
-        </p:spPr>
-        <p:txBody>
-          <a:bodyPr wrap="square">
-            <a:spAutoFit/>
-          </a:bodyPr>
-          <a:lstStyle/>
-          <a:p>
-            <a:pPr algn="l"/>
-            <a:r>
-              <a:rPr sz="1200" b="1">
+          <p:cNvPr id="30" name="TextBox 29"/>
+          <p:cNvSpPr txBox="1"/>
+          <p:nvPr/>
+        </p:nvSpPr>
+        <p:spPr>
+          <a:xfrm>
+            <a:off x="8244687" y="2194560"/>
+            <a:ext cx="3383280" cy="274320"/>
+          </a:xfrm>
+          <a:prstGeom prst="rect">
+            <a:avLst/>
+          </a:prstGeom>
+          <a:noFill/>
+        </p:spPr>
+        <p:txBody>
+          <a:bodyPr wrap="square">
+            <a:spAutoFit/>
+          </a:bodyPr>
+          <a:lstStyle/>
+          <a:p>
+            <a:pPr algn="l"/>
+            <a:r>
+              <a:rPr sz="1100" b="1">
+                <a:solidFill>
+                  <a:srgbClr val="EA580C"/>
+                </a:solidFill>
+                <a:latin typeface="Calibri"/>
+              </a:rPr>
+              <a:t>Herramientas:</a:t>
+            </a:r>
+          </a:p>
+        </p:txBody>
+      </p:sp>
+      <p:sp>
+        <p:nvSpPr>
+          <p:cNvPr id="31" name="TextBox 30"/>
+          <p:cNvSpPr txBox="1"/>
+          <p:nvPr/>
+        </p:nvSpPr>
+        <p:spPr>
+          <a:xfrm>
+            <a:off x="8244687" y="2468880"/>
+            <a:ext cx="3383280" cy="274320"/>
+          </a:xfrm>
+          <a:prstGeom prst="rect">
+            <a:avLst/>
+          </a:prstGeom>
+          <a:noFill/>
+        </p:spPr>
+        <p:txBody>
+          <a:bodyPr wrap="square">
+            <a:spAutoFit/>
+          </a:bodyPr>
+          <a:lstStyle/>
+          <a:p>
+            <a:pPr algn="l"/>
+            <a:r>
+              <a:rPr sz="1100" b="0">
                 <a:solidFill>
                   <a:srgbClr val="2A2A2A"/>
                 </a:solidFill>
@@ -8891,29 +9991,74 @@
               <a:t>package.json + código</a:t>
             </a:r>
           </a:p>
-          <a:p>
-            <a:pPr algn="l"/>
-            <a:r>
-              <a:rPr sz="1200" b="0">
+        </p:txBody>
+      </p:sp>
+      <p:sp>
+        <p:nvSpPr>
+          <p:cNvPr id="32" name="TextBox 31"/>
+          <p:cNvSpPr txBox="1"/>
+          <p:nvPr/>
+        </p:nvSpPr>
+        <p:spPr>
+          <a:xfrm>
+            <a:off x="8244687" y="2788920"/>
+            <a:ext cx="3383280" cy="274320"/>
+          </a:xfrm>
+          <a:prstGeom prst="rect">
+            <a:avLst/>
+          </a:prstGeom>
+          <a:noFill/>
+        </p:spPr>
+        <p:txBody>
+          <a:bodyPr wrap="square">
+            <a:spAutoFit/>
+          </a:bodyPr>
+          <a:lstStyle/>
+          <a:p>
+            <a:pPr algn="l"/>
+            <a:r>
+              <a:rPr sz="1100" b="1">
+                <a:solidFill>
+                  <a:srgbClr val="EA580C"/>
+                </a:solidFill>
+                <a:latin typeface="Calibri"/>
+              </a:rPr>
+              <a:t>Ejemplos:</a:t>
+            </a:r>
+          </a:p>
+        </p:txBody>
+      </p:sp>
+      <p:sp>
+        <p:nvSpPr>
+          <p:cNvPr id="33" name="TextBox 32"/>
+          <p:cNvSpPr txBox="1"/>
+          <p:nvPr/>
+        </p:nvSpPr>
+        <p:spPr>
+          <a:xfrm>
+            <a:off x="8244687" y="3017520"/>
+            <a:ext cx="3383280" cy="1005840"/>
+          </a:xfrm>
+          <a:prstGeom prst="rect">
+            <a:avLst/>
+          </a:prstGeom>
+          <a:noFill/>
+        </p:spPr>
+        <p:txBody>
+          <a:bodyPr wrap="square">
+            <a:spAutoFit/>
+          </a:bodyPr>
+          <a:lstStyle/>
+          <a:p>
+            <a:pPr algn="l"/>
+            <a:r>
+              <a:rPr sz="900" b="0">
                 <a:solidFill>
                   <a:srgbClr val="2A2A2A"/>
                 </a:solidFill>
                 <a:latin typeface="Calibri"/>
               </a:rPr>
-              <a:t/>
-            </a:r>
-          </a:p>
-          <a:p>
-            <a:pPr algn="l"/>
-            <a:r>
-              <a:rPr sz="1200" b="0">
-                <a:solidFill>
-                  <a:srgbClr val="2A2A2A"/>
-                </a:solidFill>
-                <a:latin typeface="Calibri"/>
-              </a:rPr>
-              <a:t>Ejemplos:
-• jQuery 2.1.4 (versión antigua)
+              <a:t>• jQuery 2.1.4 (versión antigua)
 • Meta tags de seguridad faltantes
 • Comentarios TODO/FIXME
 • Footer desactualizado
@@ -8924,13 +10069,91 @@
       </p:sp>
       <p:sp>
         <p:nvSpPr>
-          <p:cNvPr id="22" name="TextBox 21"/>
-          <p:cNvSpPr txBox="1"/>
-          <p:nvPr/>
-        </p:nvSpPr>
-        <p:spPr>
-          <a:xfrm>
-            <a:off x="8107527" y="5166360"/>
+          <p:cNvPr id="34" name="Rectangle 33"/>
+          <p:cNvSpPr/>
+          <p:nvPr/>
+        </p:nvSpPr>
+        <p:spPr>
+          <a:xfrm>
+            <a:off x="8198967" y="4114800"/>
+            <a:ext cx="3474720" cy="457200"/>
+          </a:xfrm>
+          <a:prstGeom prst="rect">
+            <a:avLst/>
+          </a:prstGeom>
+          <a:solidFill>
+            <a:srgbClr val="FFF3CD"/>
+          </a:solidFill>
+          <a:ln>
+            <a:noFill/>
+          </a:ln>
+        </p:spPr>
+        <p:style>
+          <a:lnRef idx="1">
+            <a:schemeClr val="accent1"/>
+          </a:lnRef>
+          <a:fillRef idx="3">
+            <a:schemeClr val="accent1"/>
+          </a:fillRef>
+          <a:effectRef idx="2">
+            <a:schemeClr val="accent1"/>
+          </a:effectRef>
+          <a:fontRef idx="minor">
+            <a:schemeClr val="lt1"/>
+          </a:fontRef>
+        </p:style>
+        <p:txBody>
+          <a:bodyPr rtlCol="0" anchor="ctr"/>
+          <a:lstStyle/>
+          <a:p>
+            <a:pPr algn="ctr"/>
+          </a:p>
+        </p:txBody>
+      </p:sp>
+      <p:sp>
+        <p:nvSpPr>
+          <p:cNvPr id="35" name="TextBox 34"/>
+          <p:cNvSpPr txBox="1"/>
+          <p:nvPr/>
+        </p:nvSpPr>
+        <p:spPr>
+          <a:xfrm>
+            <a:off x="8244687" y="4133087"/>
+            <a:ext cx="3383280" cy="411480"/>
+          </a:xfrm>
+          <a:prstGeom prst="rect">
+            <a:avLst/>
+          </a:prstGeom>
+          <a:noFill/>
+        </p:spPr>
+        <p:txBody>
+          <a:bodyPr wrap="square">
+            <a:spAutoFit/>
+          </a:bodyPr>
+          <a:lstStyle/>
+          <a:p>
+            <a:pPr algn="ctr"/>
+            <a:r>
+              <a:rPr sz="900" b="0">
+                <a:solidFill>
+                  <a:srgbClr val="2A2A2A"/>
+                </a:solidFill>
+                <a:latin typeface="Consolas"/>
+              </a:rPr>
+              <a:t>💡 Pista: cat package.json  |  grep -r TODO  |  curl -I URL</a:t>
+            </a:r>
+          </a:p>
+        </p:txBody>
+      </p:sp>
+      <p:sp>
+        <p:nvSpPr>
+          <p:cNvPr id="36" name="TextBox 35"/>
+          <p:cNvSpPr txBox="1"/>
+          <p:nvPr/>
+        </p:nvSpPr>
+        <p:spPr>
+          <a:xfrm>
+            <a:off x="8107527" y="4663440"/>
             <a:ext cx="3657600" cy="274320"/>
           </a:xfrm>
           <a:prstGeom prst="rect">
@@ -8946,7 +10169,7 @@
           <a:p>
             <a:pPr algn="ctr"/>
             <a:r>
-              <a:rPr sz="1100" b="1">
+              <a:rPr sz="1000" b="1">
                 <a:solidFill>
                   <a:srgbClr val="EA580C"/>
                 </a:solidFill>
@@ -8959,14 +10182,14 @@
       </p:sp>
       <p:sp>
         <p:nvSpPr>
-          <p:cNvPr id="23" name="Rounded Rectangle 22"/>
+          <p:cNvPr id="37" name="Rounded Rectangle 36"/>
           <p:cNvSpPr/>
           <p:nvPr/>
         </p:nvSpPr>
         <p:spPr>
           <a:xfrm>
-            <a:off x="640080" y="5669280"/>
-            <a:ext cx="10972800" cy="548640"/>
+            <a:off x="640080" y="5760720"/>
+            <a:ext cx="10972800" cy="457200"/>
           </a:xfrm>
           <a:prstGeom prst="roundRect">
             <a:avLst/>
@@ -9004,13 +10227,13 @@
       </p:sp>
       <p:sp>
         <p:nvSpPr>
-          <p:cNvPr id="24" name="TextBox 23"/>
-          <p:cNvSpPr txBox="1"/>
-          <p:nvPr/>
-        </p:nvSpPr>
-        <p:spPr>
-          <a:xfrm>
-            <a:off x="640080" y="5760720"/>
+          <p:cNvPr id="38" name="TextBox 37"/>
+          <p:cNvSpPr txBox="1"/>
+          <p:nvPr/>
+        </p:nvSpPr>
+        <p:spPr>
+          <a:xfrm>
+            <a:off x="640080" y="5806440"/>
             <a:ext cx="10972800" cy="365760"/>
           </a:xfrm>
           <a:prstGeom prst="rect">
@@ -9039,7 +10262,7 @@
       </p:sp>
       <p:sp>
         <p:nvSpPr>
-          <p:cNvPr id="25" name="TextBox 24"/>
+          <p:cNvPr id="39" name="TextBox 38"/>
           <p:cNvSpPr txBox="1"/>
           <p:nvPr/>
         </p:nvSpPr>
@@ -9074,7 +10297,7 @@
       </p:sp>
       <p:sp>
         <p:nvSpPr>
-          <p:cNvPr id="26" name="TextBox 25"/>
+          <p:cNvPr id="40" name="TextBox 39"/>
           <p:cNvSpPr txBox="1"/>
           <p:nvPr/>
         </p:nvSpPr>

</xml_diff>

<commit_message>
update: git config + comandos de pista en auditoría
</commit_message>
<xml_diff>
--- a/EVALUACION_PRACTICA_01.pptx
+++ b/EVALUACION_PRACTICA_01.pptx
@@ -4601,7 +4601,7 @@
                 </a:solidFill>
                 <a:latin typeface="Calibri"/>
               </a:rPr>
-              <a:t>• 3 Issues hallazgos × 5 pts = 15</a:t>
+              <a:t>• 3 Issues de hallazgos × 5 pts = 15</a:t>
             </a:r>
           </a:p>
           <a:p>
@@ -4613,7 +4613,7 @@
                 </a:solidFill>
                 <a:latin typeface="Calibri"/>
               </a:rPr>
-              <a:t>• 1 Issue link-evaluación × 5 pts = 5</a:t>
+              <a:t>• 1 Issue de link-evaluación × 5 pts = 5</a:t>
             </a:r>
           </a:p>
         </p:txBody>
@@ -7503,8 +7503,792 @@
 </p:sld>
 </file>
 
-<file path=ppt/slides/slide5.xml><?xml version='1.0' encoding='UTF-8' standalone='yes'?>
-<p:sld xmlns:a="http://schemas.openxmlformats.org/drawingml/2006/main" xmlns:p="http://schemas.openxmlformats.org/presentationml/2006/main" xmlns:r="http://schemas.openxmlformats.org/officeDocument/2006/relationships"><p:cSld><p:spTree><p:nvGrpSpPr><p:cNvPr id="1" name=""/><p:cNvGrpSpPr/><p:nvPr/></p:nvGrpSpPr><p:grpSpPr/><p:sp><p:nvSpPr><p:cNvPr id="2" name="Rectangle 1"/><p:cNvSpPr/><p:nvPr/></p:nvSpPr><p:spPr><a:xfrm><a:off x="0" y="0"/><a:ext cx="12191695" cy="6858000"/></a:xfrm><a:prstGeom prst="rect"><a:avLst/></a:prstGeom><a:solidFill><a:srgbClr val="FFFFFF"/></a:solidFill><a:ln><a:noFill/></a:ln></p:spPr><p:style><a:lnRef idx="1"><a:schemeClr val="accent1"/></a:lnRef><a:fillRef idx="3"><a:schemeClr val="accent1"/></a:fillRef><a:effectRef idx="2"><a:schemeClr val="accent1"/></a:effectRef><a:fontRef idx="minor"><a:schemeClr val="lt1"/></a:fontRef></p:style><p:txBody><a:bodyPr rtlCol="0" anchor="ctr"/><a:lstStyle/><a:p><a:pPr algn="ctr"/></a:p></p:txBody></p:sp><p:sp><p:nvSpPr><p:cNvPr id="3" name="Rectangle 2"/><p:cNvSpPr/><p:nvPr/></p:nvSpPr><p:spPr><a:xfrm><a:off x="0" y="0"/><a:ext cx="12191695" cy="914400"/></a:xfrm><a:prstGeom prst="rect"><a:avLst/></a:prstGeom><a:solidFill><a:srgbClr val="065A82"/></a:solidFill><a:ln><a:noFill/></a:ln></p:spPr><p:style><a:lnRef idx="1"><a:schemeClr val="accent1"/></a:lnRef><a:fillRef idx="3"><a:schemeClr val="accent1"/></a:fillRef><a:effectRef idx="2"><a:schemeClr val="accent1"/></a:effectRef><a:fontRef idx="minor"><a:schemeClr val="lt1"/></a:fontRef></p:style><p:txBody><a:bodyPr rtlCol="0" anchor="ctr"/><a:lstStyle/><a:p><a:pPr algn="ctr"/></a:p></p:txBody></p:sp><p:sp><p:nvSpPr><p:cNvPr id="4" name="TextBox 3"/><p:cNvSpPr txBox="1"/><p:nvPr/></p:nvSpPr><p:spPr><a:xfrm><a:off x="457200" y="274320"/><a:ext cx="10972800" cy="457200"/></a:xfrm><a:prstGeom prst="rect"><a:avLst/></a:prstGeom><a:noFill/></p:spPr><p:txBody><a:bodyPr wrap="square"><a:spAutoFit/></a:bodyPr><a:lstStyle/><a:p><a:pPr algn="l"/><a:r><a:rPr sz="3200" b="1"><a:solidFill><a:srgbClr val="FFFFFF"/></a:solidFill><a:latin typeface="Calibri"/></a:rPr><a:t>Parte 1 · Clonar, verificar y subir</a:t></a:r></a:p></p:txBody></p:sp><p:sp><p:nvSpPr><p:cNvPr id="5" name="TextBox 4"/><p:cNvSpPr txBox="1"/><p:nvPr/></p:nvSpPr><p:spPr><a:xfrm><a:off x="457200" y="685800"/><a:ext cx="10972800" cy="274320"/></a:xfrm><a:prstGeom prst="rect"><a:avLst/></a:prstGeom><a:noFill/></p:spPr><p:txBody><a:bodyPr wrap="square"><a:spAutoFit/></a:bodyPr><a:lstStyle/><a:p><a:pPr algn="l"/><a:r><a:rPr sz="1400" b="0"><a:solidFill><a:srgbClr val="60A5FA"/></a:solidFill><a:latin typeface="Calibri"/></a:rPr><a:t>⏱ 10 minutos  •  Solo git (sin gh CLI)</a:t></a:r></a:p></p:txBody></p:sp><p:sp><p:nvSpPr><p:cNvPr id="6" name="TextBox 5"/><p:cNvSpPr txBox="1"/><p:nvPr/></p:nvSpPr><p:spPr><a:xfrm><a:off x="640080" y="1188720"/><a:ext cx="10972800" cy="365760"/></a:xfrm><a:prstGeom prst="rect"><a:avLst/></a:prstGeom><a:noFill/></p:spPr><p:txBody><a:bodyPr wrap="square"><a:spAutoFit/></a:bodyPr><a:lstStyle/><a:p><a:pPr algn="l"/><a:r><a:rPr sz="1800" b="1"><a:solidFill><a:srgbClr val="065A82"/></a:solidFill><a:latin typeface="Calibri"/></a:rPr><a:t>1️⃣  Clonar el repositorio del docente</a:t></a:r></a:p></p:txBody></p:sp><p:sp><p:nvSpPr><p:cNvPr id="7" name="Rounded Rectangle 6"/><p:cNvSpPr/><p:nvPr/></p:nvSpPr><p:spPr><a:xfrm><a:off x="640080" y="1554480"/><a:ext cx="10972800" cy="594360"/></a:xfrm><a:prstGeom prst="roundRect"><a:avLst/></a:prstGeom><a:solidFill><a:srgbClr val="2A2A2A"/></a:solidFill><a:ln><a:solidFill><a:srgbClr val="1C7293"/></a:solidFill></a:ln></p:spPr><p:style><a:lnRef idx="1"><a:schemeClr val="accent1"/></a:lnRef><a:fillRef idx="3"><a:schemeClr val="accent1"/></a:fillRef><a:effectRef idx="2"><a:schemeClr val="accent1"/></a:effectRef><a:fontRef idx="minor"><a:schemeClr val="lt1"/></a:fontRef></p:style><p:txBody><a:bodyPr rtlCol="0" anchor="ctr"/><a:lstStyle/><a:p><a:pPr algn="ctr"/></a:p></p:txBody></p:sp><p:sp><p:nvSpPr><p:cNvPr id="8" name="TextBox 7"/><p:cNvSpPr txBox="1"/><p:nvPr/></p:nvSpPr><p:spPr><a:xfrm><a:off x="822960" y="1627632"/><a:ext cx="10607040" cy="457200"/></a:xfrm><a:prstGeom prst="rect"><a:avLst/></a:prstGeom><a:noFill/></p:spPr><p:txBody><a:bodyPr wrap="square"><a:spAutoFit/></a:bodyPr><a:lstStyle/><a:p><a:pPr algn="l"/><a:r><a:rPr sz="1400" b="0"><a:solidFill><a:srgbClr val="FFFFFF"/></a:solidFill><a:latin typeface="Consolas"/></a:rPr><a:t>$ git clone https://github.com/KrizRoMe/evaluacion-administracion-web.git</a:t></a:r></a:p></p:txBody></p:sp><p:sp><p:nvSpPr><p:cNvPr id="9" name="TextBox 8"/><p:cNvSpPr txBox="1"/><p:nvPr/></p:nvSpPr><p:spPr><a:xfrm><a:off x="822960" y="1920240"/><a:ext cx="10607040" cy="274320"/></a:xfrm><a:prstGeom prst="rect"><a:avLst/></a:prstGeom><a:noFill/></p:spPr><p:txBody><a:bodyPr wrap="square"><a:spAutoFit/></a:bodyPr><a:lstStyle/><a:p><a:pPr algn="l"/><a:r><a:rPr sz="1400" b="0"><a:solidFill><a:srgbClr val="FFFFFF"/></a:solidFill><a:latin typeface="Consolas"/></a:rPr><a:t>$ cd evaluacion-administracion-web</a:t></a:r></a:p></p:txBody></p:sp><p:sp><p:nvSpPr><p:cNvPr id="10" name="TextBox 9"/><p:cNvSpPr txBox="1"/><p:nvPr/></p:nvSpPr><p:spPr><a:xfrm><a:off x="640080" y="2377440"/><a:ext cx="10972800" cy="365760"/></a:xfrm><a:prstGeom prst="rect"><a:avLst/></a:prstGeom><a:noFill/></p:spPr><p:txBody><a:bodyPr wrap="square"><a:spAutoFit/></a:bodyPr><a:lstStyle/><a:p><a:pPr algn="l"/><a:r><a:rPr sz="1800" b="1"><a:solidFill><a:srgbClr val="065A82"/></a:solidFill><a:latin typeface="Calibri"/></a:rPr><a:t>2️⃣  Verificar que el sitio funciona localmente</a:t></a:r></a:p></p:txBody></p:sp><p:sp><p:nvSpPr><p:cNvPr id="11" name="Rounded Rectangle 10"/><p:cNvSpPr/><p:nvPr/></p:nvSpPr><p:spPr><a:xfrm><a:off x="640080" y="2743200"/><a:ext cx="10972800" cy="777240"/></a:xfrm><a:prstGeom prst="roundRect"><a:avLst/></a:prstGeom><a:solidFill><a:srgbClr val="E6F7F1"/></a:solidFill><a:ln><a:solidFill><a:srgbClr val="10B981"/></a:solidFill></a:ln></p:spPr><p:style><a:lnRef idx="1"><a:schemeClr val="accent1"/></a:lnRef><a:fillRef idx="3"><a:schemeClr val="accent1"/></a:fillRef><a:effectRef idx="2"><a:schemeClr val="accent1"/></a:effectRef><a:fontRef idx="minor"><a:schemeClr val="lt1"/></a:fontRef></p:style><p:txBody><a:bodyPr rtlCol="0" anchor="ctr"/><a:lstStyle/><a:p><a:pPr algn="ctr"/></a:p></p:txBody></p:sp><p:sp><p:nvSpPr><p:cNvPr id="12" name="TextBox 11"/><p:cNvSpPr txBox="1"/><p:nvPr/></p:nvSpPr><p:spPr><a:xfrm><a:off x="822960" y="2788920"/><a:ext cx="10607040" cy="685800"/></a:xfrm><a:prstGeom prst="rect"><a:avLst/></a:prstGeom><a:noFill/></p:spPr><p:txBody><a:bodyPr wrap="square"><a:spAutoFit/></a:bodyPr><a:lstStyle/><a:p><a:pPr algn="l"/><a:r><a:rPr sz="1300" b="0"><a:solidFill><a:srgbClr val="2A2A2A"/></a:solidFill><a:latin typeface="Calibri"/></a:rPr><a:t>Doble clic en index.html  •  O arrastrar al navegador  •  Debe verse la tienda ECOMARKET</a:t></a:r></a:p><a:p><a:pPr algn="l"/><a:r><a:rPr sz="1300" b="0"><a:solidFill><a:srgbClr val="2A2A2A"/></a:solidFill><a:latin typeface="Calibri"/></a:rPr><a:t>Si ves los productos, el carrito y el modo oscuro → todo funciona ✓</a:t></a:r></a:p></p:txBody></p:sp><p:sp><p:nvSpPr><p:cNvPr id="13" name="TextBox 12"/><p:cNvSpPr txBox="1"/><p:nvPr/></p:nvSpPr><p:spPr><a:xfrm><a:off x="640080" y="3703320"/><a:ext cx="10972800" cy="365760"/></a:xfrm><a:prstGeom prst="rect"><a:avLst/></a:prstGeom><a:noFill/></p:spPr><p:txBody><a:bodyPr wrap="square"><a:spAutoFit/></a:bodyPr><a:lstStyle/><a:p><a:pPr algn="l"/><a:r><a:rPr sz="1800" b="1"><a:solidFill><a:srgbClr val="065A82"/></a:solidFill><a:latin typeface="Calibri"/></a:rPr><a:t>3️⃣  Crear tu repositorio personal (manual, en la web)</a:t></a:r></a:p></p:txBody></p:sp><p:sp><p:nvSpPr><p:cNvPr id="14" name="Rounded Rectangle 13"/><p:cNvSpPr/><p:nvPr/></p:nvSpPr><p:spPr><a:xfrm><a:off x="640080" y="4069080"/><a:ext cx="10972800" cy="1371600"/></a:xfrm><a:prstGeom prst="roundRect"><a:avLst/></a:prstGeom><a:solidFill><a:srgbClr val="FEF3E6"/></a:solidFill><a:ln><a:solidFill><a:srgbClr val="EA580C"/></a:solidFill></a:ln></p:spPr><p:style><a:lnRef idx="1"><a:schemeClr val="accent1"/></a:lnRef><a:fillRef idx="3"><a:schemeClr val="accent1"/></a:fillRef><a:effectRef idx="2"><a:schemeClr val="accent1"/></a:effectRef><a:fontRef idx="minor"><a:schemeClr val="lt1"/></a:fontRef></p:style><p:txBody><a:bodyPr rtlCol="0" anchor="ctr"/><a:lstStyle/><a:p><a:pPr algn="ctr"/></a:p></p:txBody></p:sp><p:sp><p:nvSpPr><p:cNvPr id="15" name="TextBox 14"/><p:cNvSpPr txBox="1"/><p:nvPr/></p:nvSpPr><p:spPr><a:xfrm><a:off x="822960" y="4114800"/><a:ext cx="10607040" cy="1280160"/></a:xfrm><a:prstGeom prst="rect"><a:avLst/></a:prstGeom><a:noFill/></p:spPr><p:txBody><a:bodyPr wrap="square"><a:spAutoFit/></a:bodyPr><a:lstStyle/><a:p><a:pPr algn="l"/><a:r><a:rPr sz="1200" b="0"><a:solidFill><a:srgbClr val="2A2A2A"/></a:solidFill><a:latin typeface="Calibri"/></a:rPr><a:t>1. Abre https://github.com/new en tu navegador</a:t></a:r></a:p><a:p><a:pPr algn="l"/><a:r><a:rPr sz="1200" b="0"><a:solidFill><a:srgbClr val="2A2A2A"/></a:solidFill><a:latin typeface="Calibri"/></a:rPr><a:t>2. Repository name:  evaluacion-administracion-web-TU-NOMBRE</a:t></a:r></a:p><a:p><a:pPr algn="l"/><a:r><a:rPr sz="1200" b="0"><a:solidFill><a:srgbClr val="2A2A2A"/></a:solidFill><a:latin typeface="Calibri"/></a:rPr><a:t>3. Visibility:  Public</a:t></a:r></a:p><a:p><a:pPr algn="l"/><a:r><a:rPr sz="1200" b="0"><a:solidFill><a:srgbClr val="2A2A2A"/></a:solidFill><a:latin typeface="Calibri"/></a:rPr><a:t>4. NO inicialices con README, .gitignore ni license (déjalo vacío)</a:t></a:r></a:p><a:p><a:pPr algn="l"/><a:r><a:rPr sz="1200" b="0"><a:solidFill><a:srgbClr val="2A2A2A"/></a:solidFill><a:latin typeface="Calibri"/></a:rPr><a:t>5. Clic en Create repository  →  Copia la URL HTTPS que te muestra</a:t></a:r></a:p></p:txBody></p:sp><p:sp><p:nvSpPr><p:cNvPr id="16" name="TextBox 15"/><p:cNvSpPr txBox="1"/><p:nvPr/></p:nvSpPr><p:spPr><a:xfrm><a:off x="640080" y="5623560"/><a:ext cx="10972800" cy="365760"/></a:xfrm><a:prstGeom prst="rect"><a:avLst/></a:prstGeom><a:noFill/></p:spPr><p:txBody><a:bodyPr wrap="square"><a:spAutoFit/></a:bodyPr><a:lstStyle/><a:p><a:pPr algn="l"/><a:r><a:rPr sz="1800" b="1"><a:solidFill><a:srgbClr val="065A82"/></a:solidFill><a:latin typeface="Calibri"/></a:rPr><a:t>4️⃣  Conectar y subir con git puro</a:t></a:r></a:p></p:txBody></p:sp><p:sp><p:nvSpPr><p:cNvPr id="17" name="Rounded Rectangle 16"/><p:cNvSpPr/><p:nvPr/></p:nvSpPr><p:spPr><a:xfrm><a:off x="640080" y="5989320"/><a:ext cx="10972800" cy="777240"/></a:xfrm><a:prstGeom prst="roundRect"><a:avLst/></a:prstGeom><a:solidFill><a:srgbClr val="2A2A2A"/></a:solidFill><a:ln><a:solidFill><a:srgbClr val="1C7293"/></a:solidFill></a:ln></p:spPr><p:style><a:lnRef idx="1"><a:schemeClr val="accent1"/></a:lnRef><a:fillRef idx="3"><a:schemeClr val="accent1"/></a:fillRef><a:effectRef idx="2"><a:schemeClr val="accent1"/></a:effectRef><a:fontRef idx="minor"><a:schemeClr val="lt1"/></a:fontRef></p:style><p:txBody><a:bodyPr rtlCol="0" anchor="ctr"/><a:lstStyle/><a:p><a:pPr algn="ctr"/></a:p></p:txBody></p:sp><p:sp><p:nvSpPr><p:cNvPr id="18" name="TextBox 17"/><p:cNvSpPr txBox="1"/><p:nvPr/></p:nvSpPr><p:spPr><a:xfrm><a:off x="822960" y="6035040"/><a:ext cx="10607040" cy="274320"/></a:xfrm><a:prstGeom prst="rect"><a:avLst/></a:prstGeom><a:noFill/></p:spPr><p:txBody><a:bodyPr wrap="square"><a:spAutoFit/></a:bodyPr><a:lstStyle/><a:p><a:pPr algn="l"/><a:r><a:rPr sz="1100" b="0"><a:solidFill><a:srgbClr val="FFFFFF"/></a:solidFill><a:latin typeface="Consolas"/></a:rPr><a:t>$ git remote set-url origin https://github.com/TU-USUARIO/evaluacion-administracion-web-TU-NOMBRE.git</a:t></a:r></a:r><a:r><a:rPr lang="es-PE" sz="1100"><a:solidFill><a:srgbClr val="666666"/></a:solidFill><a:latin typeface="Consolas"/></a:rPr><a:t>(ya existe porque hiciste git clone, no add)</a:t></a:r></a:p></p:txBody></p:sp><p:sp><p:nvSpPr><p:cNvPr id="19" name="TextBox 18"/><p:cNvSpPr txBox="1"/><p:nvPr/></p:nvSpPr><p:spPr><a:xfrm><a:off x="822960" y="6309360"/><a:ext cx="10607040" cy="274320"/></a:xfrm><a:prstGeom prst="rect"><a:avLst/></a:prstGeom><a:noFill/></p:spPr><p:txBody><a:bodyPr wrap="square"><a:spAutoFit/></a:bodyPr><a:lstStyle/><a:p><a:pPr algn="l"/><a:r><a:rPr sz="1200" b="0"><a:solidFill><a:srgbClr val="FFFFFF"/></a:solidFill><a:latin typeface="Consolas"/></a:rPr><a:t>$ git branch -M main</a:t></a:r></a:p></p:txBody></p:sp><p:sp><p:nvSpPr><p:cNvPr id="20" name="TextBox 19"/><p:cNvSpPr txBox="1"/><p:nvPr/></p:nvSpPr><p:spPr><a:xfrm><a:off x="822960" y="6537960"/><a:ext cx="10607040" cy="274320"/></a:xfrm><a:prstGeom prst="rect"><a:avLst/></a:prstGeom><a:noFill/></p:spPr><p:txBody><a:bodyPr wrap="square"><a:spAutoFit/></a:bodyPr><a:lstStyle/><a:p><a:pPr algn="l"/><a:r><a:rPr sz="1200" b="0"><a:solidFill><a:srgbClr val="FFFFFF"/></a:solidFill><a:latin typeface="Consolas"/></a:rPr><a:t>$ git push -u origin main</a:t></a:r></a:p></p:txBody></p:sp><p:sp><p:nvSpPr><p:cNvPr id="21" name="TextBox 20"/><p:cNvSpPr txBox="1"/><p:nvPr/></p:nvSpPr><p:spPr><a:xfrm><a:off x="457200" y="6903720"/><a:ext cx="10972800" cy="274320"/></a:xfrm><a:prstGeom prst="rect"><a:avLst/></a:prstGeom><a:noFill/></p:spPr><p:txBody><a:bodyPr wrap="square"><a:spAutoFit/></a:bodyPr><a:lstStyle/><a:p><a:pPr algn="l"/><a:r><a:rPr sz="1000" b="0"><a:solidFill><a:srgbClr val="666666"/></a:solidFill><a:latin typeface="Calibri"/></a:rPr><a:t>💡 No se exige memorizar comandos. Si logras subir el código, está bien.</a:t></a:r></a:p></p:txBody></p:sp></p:spTree></p:cSld><p:clrMapOvr><a:masterClrMapping/></p:clrMapOvr></p:sld>
+<file path=ppt/slides/slide5.xml><?xml version="1.0" encoding="utf-8"?>
+<p:sld xmlns:a="http://schemas.openxmlformats.org/drawingml/2006/main" xmlns:p="http://schemas.openxmlformats.org/presentationml/2006/main" xmlns:r="http://schemas.openxmlformats.org/officeDocument/2006/relationships">
+  <p:cSld>
+    <p:spTree>
+      <p:nvGrpSpPr>
+        <p:cNvPr id="1" name=""/>
+        <p:cNvGrpSpPr/>
+        <p:nvPr/>
+      </p:nvGrpSpPr>
+      <p:grpSpPr/>
+      <p:sp>
+        <p:nvSpPr>
+          <p:cNvPr id="2" name="Rectangle 1"/>
+          <p:cNvSpPr/>
+          <p:nvPr/>
+        </p:nvSpPr>
+        <p:spPr>
+          <a:xfrm>
+            <a:off x="0" y="0"/>
+            <a:ext cx="12191695" cy="6858000"/>
+          </a:xfrm>
+          <a:prstGeom prst="rect">
+            <a:avLst/>
+          </a:prstGeom>
+          <a:solidFill>
+            <a:srgbClr val="FFFFFF"/>
+          </a:solidFill>
+          <a:ln>
+            <a:noFill/>
+          </a:ln>
+        </p:spPr>
+        <p:style>
+          <a:lnRef idx="1">
+            <a:schemeClr val="accent1"/>
+          </a:lnRef>
+          <a:fillRef idx="3">
+            <a:schemeClr val="accent1"/>
+          </a:fillRef>
+          <a:effectRef idx="2">
+            <a:schemeClr val="accent1"/>
+          </a:effectRef>
+          <a:fontRef idx="minor">
+            <a:schemeClr val="lt1"/>
+          </a:fontRef>
+        </p:style>
+        <p:txBody>
+          <a:bodyPr rtlCol="0" anchor="ctr"/>
+          <a:lstStyle/>
+          <a:p>
+            <a:pPr algn="ctr"/>
+          </a:p>
+        </p:txBody>
+      </p:sp>
+      <p:sp>
+        <p:nvSpPr>
+          <p:cNvPr id="3" name="Rectangle 2"/>
+          <p:cNvSpPr/>
+          <p:nvPr/>
+        </p:nvSpPr>
+        <p:spPr>
+          <a:xfrm>
+            <a:off x="0" y="0"/>
+            <a:ext cx="12191695" cy="914400"/>
+          </a:xfrm>
+          <a:prstGeom prst="rect">
+            <a:avLst/>
+          </a:prstGeom>
+          <a:solidFill>
+            <a:srgbClr val="065A82"/>
+          </a:solidFill>
+          <a:ln>
+            <a:noFill/>
+          </a:ln>
+        </p:spPr>
+        <p:style>
+          <a:lnRef idx="1">
+            <a:schemeClr val="accent1"/>
+          </a:lnRef>
+          <a:fillRef idx="3">
+            <a:schemeClr val="accent1"/>
+          </a:fillRef>
+          <a:effectRef idx="2">
+            <a:schemeClr val="accent1"/>
+          </a:effectRef>
+          <a:fontRef idx="minor">
+            <a:schemeClr val="lt1"/>
+          </a:fontRef>
+        </p:style>
+        <p:txBody>
+          <a:bodyPr rtlCol="0" anchor="ctr"/>
+          <a:lstStyle/>
+          <a:p>
+            <a:pPr algn="ctr"/>
+          </a:p>
+        </p:txBody>
+      </p:sp>
+      <p:sp>
+        <p:nvSpPr>
+          <p:cNvPr id="4" name="TextBox 3"/>
+          <p:cNvSpPr txBox="1"/>
+          <p:nvPr/>
+        </p:nvSpPr>
+        <p:spPr>
+          <a:xfrm>
+            <a:off x="457200" y="274320"/>
+            <a:ext cx="10972800" cy="457200"/>
+          </a:xfrm>
+          <a:prstGeom prst="rect">
+            <a:avLst/>
+          </a:prstGeom>
+          <a:noFill/>
+        </p:spPr>
+        <p:txBody>
+          <a:bodyPr wrap="square">
+            <a:spAutoFit/>
+          </a:bodyPr>
+          <a:lstStyle/>
+          <a:p>
+            <a:pPr algn="l"/>
+            <a:r>
+              <a:rPr sz="3200" b="1">
+                <a:solidFill>
+                  <a:srgbClr val="FFFFFF"/>
+                </a:solidFill>
+                <a:latin typeface="Calibri"/>
+              </a:rPr>
+              <a:t>Parte 1 · Clonar, verificar y subir</a:t>
+            </a:r>
+          </a:p>
+        </p:txBody>
+      </p:sp>
+      <p:sp>
+        <p:nvSpPr>
+          <p:cNvPr id="5" name="TextBox 4"/>
+          <p:cNvSpPr txBox="1"/>
+          <p:nvPr/>
+        </p:nvSpPr>
+        <p:spPr>
+          <a:xfrm>
+            <a:off x="457200" y="685800"/>
+            <a:ext cx="10972800" cy="274320"/>
+          </a:xfrm>
+          <a:prstGeom prst="rect">
+            <a:avLst/>
+          </a:prstGeom>
+          <a:noFill/>
+        </p:spPr>
+        <p:txBody>
+          <a:bodyPr wrap="square">
+            <a:spAutoFit/>
+          </a:bodyPr>
+          <a:lstStyle/>
+          <a:p>
+            <a:pPr algn="l"/>
+            <a:r>
+              <a:rPr sz="1400" b="0">
+                <a:solidFill>
+                  <a:srgbClr val="60A5FA"/>
+                </a:solidFill>
+                <a:latin typeface="Calibri"/>
+              </a:rPr>
+              <a:t>⏱ 10 minutos  •  Solo git (sin gh CLI)</a:t>
+            </a:r>
+          </a:p>
+        </p:txBody>
+      </p:sp>
+      <p:sp>
+        <p:nvSpPr>
+          <p:cNvPr id="6" name="TextBox 5"/>
+          <p:cNvSpPr txBox="1"/>
+          <p:nvPr/>
+        </p:nvSpPr>
+        <p:spPr>
+          <a:xfrm>
+            <a:off x="640080" y="1097280"/>
+            <a:ext cx="10972800" cy="365760"/>
+          </a:xfrm>
+          <a:prstGeom prst="rect">
+            <a:avLst/>
+          </a:prstGeom>
+          <a:noFill/>
+        </p:spPr>
+        <p:txBody>
+          <a:bodyPr wrap="square">
+            <a:spAutoFit/>
+          </a:bodyPr>
+          <a:lstStyle/>
+          <a:p>
+            <a:pPr algn="l"/>
+            <a:r>
+              <a:rPr sz="1600" b="1">
+                <a:solidFill>
+                  <a:srgbClr val="065A82"/>
+                </a:solidFill>
+                <a:latin typeface="Calibri"/>
+              </a:rPr>
+              <a:t>1️⃣  Clonar el repositorio del docente</a:t>
+            </a:r>
+          </a:p>
+        </p:txBody>
+      </p:sp>
+      <p:sp>
+        <p:nvSpPr>
+          <p:cNvPr id="7" name="Rounded Rectangle 6"/>
+          <p:cNvSpPr/>
+          <p:nvPr/>
+        </p:nvSpPr>
+        <p:spPr>
+          <a:xfrm>
+            <a:off x="640080" y="1463040"/>
+            <a:ext cx="10972800" cy="502920"/>
+          </a:xfrm>
+          <a:prstGeom prst="roundRect">
+            <a:avLst/>
+          </a:prstGeom>
+          <a:solidFill>
+            <a:srgbClr val="2A2A2A"/>
+          </a:solidFill>
+          <a:ln>
+            <a:solidFill>
+              <a:srgbClr val="1C7293"/>
+            </a:solidFill>
+          </a:ln>
+        </p:spPr>
+        <p:style>
+          <a:lnRef idx="1">
+            <a:schemeClr val="accent1"/>
+          </a:lnRef>
+          <a:fillRef idx="3">
+            <a:schemeClr val="accent1"/>
+          </a:fillRef>
+          <a:effectRef idx="2">
+            <a:schemeClr val="accent1"/>
+          </a:effectRef>
+          <a:fontRef idx="minor">
+            <a:schemeClr val="lt1"/>
+          </a:fontRef>
+        </p:style>
+        <p:txBody>
+          <a:bodyPr rtlCol="0" anchor="ctr"/>
+          <a:lstStyle/>
+          <a:p>
+            <a:pPr algn="ctr"/>
+          </a:p>
+        </p:txBody>
+      </p:sp>
+      <p:sp>
+        <p:nvSpPr>
+          <p:cNvPr id="8" name="TextBox 7"/>
+          <p:cNvSpPr txBox="1"/>
+          <p:nvPr/>
+        </p:nvSpPr>
+        <p:spPr>
+          <a:xfrm>
+            <a:off x="822960" y="1508760"/>
+            <a:ext cx="10607040" cy="365760"/>
+          </a:xfrm>
+          <a:prstGeom prst="rect">
+            <a:avLst/>
+          </a:prstGeom>
+          <a:noFill/>
+        </p:spPr>
+        <p:txBody>
+          <a:bodyPr wrap="square">
+            <a:spAutoFit/>
+          </a:bodyPr>
+          <a:lstStyle/>
+          <a:p>
+            <a:pPr algn="l"/>
+            <a:r>
+              <a:rPr sz="1200" b="0">
+                <a:solidFill>
+                  <a:srgbClr val="FFFFFF"/>
+                </a:solidFill>
+                <a:latin typeface="Consolas"/>
+              </a:rPr>
+              <a:t>$ git clone https://github.com/KrizRoMe/evaluacion-administracion-web.git   &amp;&amp;   cd evaluacion-administracion-web</a:t>
+            </a:r>
+          </a:p>
+        </p:txBody>
+      </p:sp>
+      <p:sp>
+        <p:nvSpPr>
+          <p:cNvPr id="9" name="TextBox 8"/>
+          <p:cNvSpPr txBox="1"/>
+          <p:nvPr/>
+        </p:nvSpPr>
+        <p:spPr>
+          <a:xfrm>
+            <a:off x="640080" y="2103120"/>
+            <a:ext cx="10972800" cy="365760"/>
+          </a:xfrm>
+          <a:prstGeom prst="rect">
+            <a:avLst/>
+          </a:prstGeom>
+          <a:noFill/>
+        </p:spPr>
+        <p:txBody>
+          <a:bodyPr wrap="square">
+            <a:spAutoFit/>
+          </a:bodyPr>
+          <a:lstStyle/>
+          <a:p>
+            <a:pPr algn="l"/>
+            <a:r>
+              <a:rPr sz="1600" b="1">
+                <a:solidFill>
+                  <a:srgbClr val="065A82"/>
+                </a:solidFill>
+                <a:latin typeface="Calibri"/>
+              </a:rPr>
+              <a:t>2️⃣  Verificar que el sitio funciona localmente</a:t>
+            </a:r>
+          </a:p>
+        </p:txBody>
+      </p:sp>
+      <p:sp>
+        <p:nvSpPr>
+          <p:cNvPr id="10" name="Rounded Rectangle 9"/>
+          <p:cNvSpPr/>
+          <p:nvPr/>
+        </p:nvSpPr>
+        <p:spPr>
+          <a:xfrm>
+            <a:off x="640080" y="2468880"/>
+            <a:ext cx="10972800" cy="640080"/>
+          </a:xfrm>
+          <a:prstGeom prst="roundRect">
+            <a:avLst/>
+          </a:prstGeom>
+          <a:solidFill>
+            <a:srgbClr val="E6F7F1"/>
+          </a:solidFill>
+          <a:ln>
+            <a:solidFill>
+              <a:srgbClr val="10B981"/>
+            </a:solidFill>
+          </a:ln>
+        </p:spPr>
+        <p:style>
+          <a:lnRef idx="1">
+            <a:schemeClr val="accent1"/>
+          </a:lnRef>
+          <a:fillRef idx="3">
+            <a:schemeClr val="accent1"/>
+          </a:fillRef>
+          <a:effectRef idx="2">
+            <a:schemeClr val="accent1"/>
+          </a:effectRef>
+          <a:fontRef idx="minor">
+            <a:schemeClr val="lt1"/>
+          </a:fontRef>
+        </p:style>
+        <p:txBody>
+          <a:bodyPr rtlCol="0" anchor="ctr"/>
+          <a:lstStyle/>
+          <a:p>
+            <a:pPr algn="ctr"/>
+          </a:p>
+        </p:txBody>
+      </p:sp>
+      <p:sp>
+        <p:nvSpPr>
+          <p:cNvPr id="11" name="TextBox 10"/>
+          <p:cNvSpPr txBox="1"/>
+          <p:nvPr/>
+        </p:nvSpPr>
+        <p:spPr>
+          <a:xfrm>
+            <a:off x="822960" y="2560320"/>
+            <a:ext cx="10607040" cy="457200"/>
+          </a:xfrm>
+          <a:prstGeom prst="rect">
+            <a:avLst/>
+          </a:prstGeom>
+          <a:noFill/>
+        </p:spPr>
+        <p:txBody>
+          <a:bodyPr wrap="square">
+            <a:spAutoFit/>
+          </a:bodyPr>
+          <a:lstStyle/>
+          <a:p>
+            <a:pPr algn="ctr"/>
+            <a:r>
+              <a:rPr sz="1200" b="0">
+                <a:solidFill>
+                  <a:srgbClr val="2A2A2A"/>
+                </a:solidFill>
+                <a:latin typeface="Calibri"/>
+              </a:rPr>
+              <a:t>Doble clic en index.html  →  debe verse la tienda ECOMARKET con productos, carrito y modo oscuro</a:t>
+            </a:r>
+          </a:p>
+        </p:txBody>
+      </p:sp>
+      <p:sp>
+        <p:nvSpPr>
+          <p:cNvPr id="12" name="TextBox 11"/>
+          <p:cNvSpPr txBox="1"/>
+          <p:nvPr/>
+        </p:nvSpPr>
+        <p:spPr>
+          <a:xfrm>
+            <a:off x="640080" y="3246120"/>
+            <a:ext cx="10972800" cy="365760"/>
+          </a:xfrm>
+          <a:prstGeom prst="rect">
+            <a:avLst/>
+          </a:prstGeom>
+          <a:noFill/>
+        </p:spPr>
+        <p:txBody>
+          <a:bodyPr wrap="square">
+            <a:spAutoFit/>
+          </a:bodyPr>
+          <a:lstStyle/>
+          <a:p>
+            <a:pPr algn="l"/>
+            <a:r>
+              <a:rPr sz="1600" b="1">
+                <a:solidFill>
+                  <a:srgbClr val="065A82"/>
+                </a:solidFill>
+                <a:latin typeface="Calibri"/>
+              </a:rPr>
+              <a:t>3️⃣  Crear tu repositorio personal (manual, en la web)</a:t>
+            </a:r>
+          </a:p>
+        </p:txBody>
+      </p:sp>
+      <p:sp>
+        <p:nvSpPr>
+          <p:cNvPr id="13" name="Rounded Rectangle 12"/>
+          <p:cNvSpPr/>
+          <p:nvPr/>
+        </p:nvSpPr>
+        <p:spPr>
+          <a:xfrm>
+            <a:off x="640080" y="3611880"/>
+            <a:ext cx="10972800" cy="1188720"/>
+          </a:xfrm>
+          <a:prstGeom prst="roundRect">
+            <a:avLst/>
+          </a:prstGeom>
+          <a:solidFill>
+            <a:srgbClr val="FEF3E6"/>
+          </a:solidFill>
+          <a:ln>
+            <a:solidFill>
+              <a:srgbClr val="EA580C"/>
+            </a:solidFill>
+          </a:ln>
+        </p:spPr>
+        <p:style>
+          <a:lnRef idx="1">
+            <a:schemeClr val="accent1"/>
+          </a:lnRef>
+          <a:fillRef idx="3">
+            <a:schemeClr val="accent1"/>
+          </a:fillRef>
+          <a:effectRef idx="2">
+            <a:schemeClr val="accent1"/>
+          </a:effectRef>
+          <a:fontRef idx="minor">
+            <a:schemeClr val="lt1"/>
+          </a:fontRef>
+        </p:style>
+        <p:txBody>
+          <a:bodyPr rtlCol="0" anchor="ctr"/>
+          <a:lstStyle/>
+          <a:p>
+            <a:pPr algn="ctr"/>
+          </a:p>
+        </p:txBody>
+      </p:sp>
+      <p:sp>
+        <p:nvSpPr>
+          <p:cNvPr id="14" name="TextBox 13"/>
+          <p:cNvSpPr txBox="1"/>
+          <p:nvPr/>
+        </p:nvSpPr>
+        <p:spPr>
+          <a:xfrm>
+            <a:off x="822960" y="3657600"/>
+            <a:ext cx="10607040" cy="1097280"/>
+          </a:xfrm>
+          <a:prstGeom prst="rect">
+            <a:avLst/>
+          </a:prstGeom>
+          <a:noFill/>
+        </p:spPr>
+        <p:txBody>
+          <a:bodyPr wrap="square">
+            <a:spAutoFit/>
+          </a:bodyPr>
+          <a:lstStyle/>
+          <a:p>
+            <a:pPr algn="l"/>
+            <a:r>
+              <a:rPr sz="1000" b="0">
+                <a:solidFill>
+                  <a:srgbClr val="2A2A2A"/>
+                </a:solidFill>
+                <a:latin typeface="Calibri"/>
+              </a:rPr>
+              <a:t>1. Abre https://github.com/new en tu navegador</a:t>
+            </a:r>
+          </a:p>
+          <a:p>
+            <a:pPr algn="l"/>
+            <a:r>
+              <a:rPr sz="1000" b="0">
+                <a:solidFill>
+                  <a:srgbClr val="2A2A2A"/>
+                </a:solidFill>
+                <a:latin typeface="Calibri"/>
+              </a:rPr>
+              <a:t>2. Repository name:  evaluacion-administracion-web-TU-NOMBRE     3. Visibility:  Public</a:t>
+            </a:r>
+          </a:p>
+          <a:p>
+            <a:pPr algn="l"/>
+            <a:r>
+              <a:rPr sz="1000" b="0">
+                <a:solidFill>
+                  <a:srgbClr val="2A2A2A"/>
+                </a:solidFill>
+                <a:latin typeface="Calibri"/>
+              </a:rPr>
+              <a:t>4. NO inicialices con README, .gitignore ni license (déjalo vacío)     5. Clic en Create repository → copia la URL HTTPS</a:t>
+            </a:r>
+          </a:p>
+        </p:txBody>
+      </p:sp>
+      <p:sp>
+        <p:nvSpPr>
+          <p:cNvPr id="15" name="TextBox 14"/>
+          <p:cNvSpPr txBox="1"/>
+          <p:nvPr/>
+        </p:nvSpPr>
+        <p:spPr>
+          <a:xfrm>
+            <a:off x="640080" y="4937760"/>
+            <a:ext cx="10972800" cy="365760"/>
+          </a:xfrm>
+          <a:prstGeom prst="rect">
+            <a:avLst/>
+          </a:prstGeom>
+          <a:noFill/>
+        </p:spPr>
+        <p:txBody>
+          <a:bodyPr wrap="square">
+            <a:spAutoFit/>
+          </a:bodyPr>
+          <a:lstStyle/>
+          <a:p>
+            <a:pPr algn="l"/>
+            <a:r>
+              <a:rPr sz="1600" b="1">
+                <a:solidFill>
+                  <a:srgbClr val="065A82"/>
+                </a:solidFill>
+                <a:latin typeface="Calibri"/>
+              </a:rPr>
+              <a:t>4️⃣  Configurar git, conectar y subir</a:t>
+            </a:r>
+          </a:p>
+        </p:txBody>
+      </p:sp>
+      <p:sp>
+        <p:nvSpPr>
+          <p:cNvPr id="16" name="Rounded Rectangle 15"/>
+          <p:cNvSpPr/>
+          <p:nvPr/>
+        </p:nvSpPr>
+        <p:spPr>
+          <a:xfrm>
+            <a:off x="640080" y="5303520"/>
+            <a:ext cx="10972800" cy="1325880"/>
+          </a:xfrm>
+          <a:prstGeom prst="roundRect">
+            <a:avLst/>
+          </a:prstGeom>
+          <a:solidFill>
+            <a:srgbClr val="2A2A2A"/>
+          </a:solidFill>
+          <a:ln>
+            <a:solidFill>
+              <a:srgbClr val="1C7293"/>
+            </a:solidFill>
+          </a:ln>
+        </p:spPr>
+        <p:style>
+          <a:lnRef idx="1">
+            <a:schemeClr val="accent1"/>
+          </a:lnRef>
+          <a:fillRef idx="3">
+            <a:schemeClr val="accent1"/>
+          </a:fillRef>
+          <a:effectRef idx="2">
+            <a:schemeClr val="accent1"/>
+          </a:effectRef>
+          <a:fontRef idx="minor">
+            <a:schemeClr val="lt1"/>
+          </a:fontRef>
+        </p:style>
+        <p:txBody>
+          <a:bodyPr rtlCol="0" anchor="ctr"/>
+          <a:lstStyle/>
+          <a:p>
+            <a:pPr algn="ctr"/>
+          </a:p>
+        </p:txBody>
+      </p:sp>
+      <p:sp>
+        <p:nvSpPr>
+          <p:cNvPr id="17" name="TextBox 16"/>
+          <p:cNvSpPr txBox="1"/>
+          <p:nvPr/>
+        </p:nvSpPr>
+        <p:spPr>
+          <a:xfrm>
+            <a:off x="822960" y="5349240"/>
+            <a:ext cx="10607040" cy="1280160"/>
+          </a:xfrm>
+          <a:prstGeom prst="rect">
+            <a:avLst/>
+          </a:prstGeom>
+          <a:noFill/>
+        </p:spPr>
+        <p:txBody>
+          <a:bodyPr wrap="square">
+            <a:spAutoFit/>
+          </a:bodyPr>
+          <a:lstStyle/>
+          <a:p>
+            <a:pPr algn="l"/>
+            <a:r>
+              <a:rPr sz="1000" b="1">
+                <a:solidFill>
+                  <a:srgbClr val="FFFFFF"/>
+                </a:solidFill>
+                <a:latin typeface="Consolas"/>
+              </a:rPr>
+              <a:t># Identidad de git (solo la primera vez en tu PC)</a:t>
+            </a:r>
+          </a:p>
+          <a:p>
+            <a:pPr algn="l"/>
+            <a:r>
+              <a:rPr sz="1000" b="0">
+                <a:solidFill>
+                  <a:srgbClr val="FFFFFF"/>
+                </a:solidFill>
+                <a:latin typeface="Consolas"/>
+              </a:rPr>
+              <a:t>$ git config --global user.name "Tu Nombre Completo"</a:t>
+            </a:r>
+          </a:p>
+          <a:p>
+            <a:pPr algn="l"/>
+            <a:r>
+              <a:rPr sz="1000" b="0">
+                <a:solidFill>
+                  <a:srgbClr val="FFFFFF"/>
+                </a:solidFill>
+                <a:latin typeface="Consolas"/>
+              </a:rPr>
+              <a:t>$ git config --global user.email "tu@correo.com"</a:t>
+            </a:r>
+          </a:p>
+          <a:p>
+            <a:pPr algn="l"/>
+            <a:r>
+              <a:rPr sz="1000" b="1">
+                <a:solidFill>
+                  <a:srgbClr val="FFFFFF"/>
+                </a:solidFill>
+                <a:latin typeface="Consolas"/>
+              </a:rPr>
+              <a:t># Conectar y subir a tu repo (no add: set-url porque ya existe por git clone)</a:t>
+            </a:r>
+          </a:p>
+          <a:p>
+            <a:pPr algn="l"/>
+            <a:r>
+              <a:rPr sz="1000" b="0">
+                <a:solidFill>
+                  <a:srgbClr val="FFFFFF"/>
+                </a:solidFill>
+                <a:latin typeface="Consolas"/>
+              </a:rPr>
+              <a:t>$ git remote set-url origin https://github.com/TU-USUARIO/evaluacion-administracion-web-TU-NOMBRE.git</a:t>
+            </a:r>
+          </a:p>
+          <a:p>
+            <a:pPr algn="l"/>
+            <a:r>
+              <a:rPr sz="1000" b="0">
+                <a:solidFill>
+                  <a:srgbClr val="FFFFFF"/>
+                </a:solidFill>
+                <a:latin typeface="Consolas"/>
+              </a:rPr>
+              <a:t>$ git branch -M main   &amp;&amp;   $ git push -u origin main</a:t>
+            </a:r>
+          </a:p>
+        </p:txBody>
+      </p:sp>
+      <p:sp>
+        <p:nvSpPr>
+          <p:cNvPr id="18" name="TextBox 17"/>
+          <p:cNvSpPr txBox="1"/>
+          <p:nvPr/>
+        </p:nvSpPr>
+        <p:spPr>
+          <a:xfrm>
+            <a:off x="457200" y="6446520"/>
+            <a:ext cx="10515600" cy="274320"/>
+          </a:xfrm>
+          <a:prstGeom prst="rect">
+            <a:avLst/>
+          </a:prstGeom>
+          <a:noFill/>
+        </p:spPr>
+        <p:txBody>
+          <a:bodyPr wrap="square">
+            <a:spAutoFit/>
+          </a:bodyPr>
+          <a:lstStyle/>
+          <a:p>
+            <a:pPr algn="l"/>
+            <a:r>
+              <a:rPr sz="800" b="0">
+                <a:solidFill>
+                  <a:srgbClr val="666666"/>
+                </a:solidFill>
+                <a:latin typeface="Calibri"/>
+              </a:rPr>
+              <a:t>📦 Repo del docente: github.com/KrizRoMe/evaluacion-administracion-web   •   🌐 Sitio público: krizrome.github.io/evaluacion-administracion-web   •   📋 Issues: github.com/KrizRoMe/evaluacion-administracion-web/issues</a:t>
+            </a:r>
+          </a:p>
+        </p:txBody>
+      </p:sp>
+      <p:sp>
+        <p:nvSpPr>
+          <p:cNvPr id="19" name="TextBox 18"/>
+          <p:cNvSpPr txBox="1"/>
+          <p:nvPr/>
+        </p:nvSpPr>
+        <p:spPr>
+          <a:xfrm>
+            <a:off x="11155680" y="6446520"/>
+            <a:ext cx="731520" cy="274320"/>
+          </a:xfrm>
+          <a:prstGeom prst="rect">
+            <a:avLst/>
+          </a:prstGeom>
+          <a:noFill/>
+        </p:spPr>
+        <p:txBody>
+          <a:bodyPr wrap="square">
+            <a:spAutoFit/>
+          </a:bodyPr>
+          <a:lstStyle/>
+          <a:p>
+            <a:pPr algn="r"/>
+            <a:r>
+              <a:rPr sz="1000" b="0">
+                <a:solidFill>
+                  <a:srgbClr val="999999"/>
+                </a:solidFill>
+                <a:latin typeface="Calibri"/>
+              </a:rPr>
+              <a:t>5 / 11</a:t>
+            </a:r>
+          </a:p>
+        </p:txBody>
+      </p:sp>
+    </p:spTree>
+  </p:cSld>
+  <p:clrMapOvr>
+    <a:masterClrMapping/>
+  </p:clrMapOvr>
+</p:sld>
 </file>
 
 <file path=ppt/slides/slide6.xml><?xml version="1.0" encoding="utf-8"?>
@@ -8251,56 +9035,21 @@
                 </a:solidFill>
                 <a:latin typeface="Calibri"/>
               </a:rPr>
-              <a:t>🛠 Herramientas a usar:</a:t>
-            </a:r>
-          </a:p>
-        </p:txBody>
-      </p:sp>
-      <p:sp>
-        <p:nvSpPr>
-          <p:cNvPr id="7" name="TextBox 6"/>
-          <p:cNvSpPr txBox="1"/>
-          <p:nvPr/>
-        </p:nvSpPr>
-        <p:spPr>
-          <a:xfrm>
-            <a:off x="640080" y="1554480"/>
-            <a:ext cx="10972800" cy="731520"/>
-          </a:xfrm>
-          <a:prstGeom prst="rect">
-            <a:avLst/>
-          </a:prstGeom>
-          <a:noFill/>
-        </p:spPr>
-        <p:txBody>
-          <a:bodyPr wrap="square">
-            <a:spAutoFit/>
-          </a:bodyPr>
-          <a:lstStyle/>
-          <a:p>
-            <a:pPr algn="l"/>
-            <a:r>
-              <a:rPr sz="1400" b="0">
-                <a:solidFill>
-                  <a:srgbClr val="2A2A2A"/>
-                </a:solidFill>
-                <a:latin typeface="Calibri"/>
-              </a:rPr>
-              <a:t>Chrome DevTools (F12)  •  Lighthouse (rendimiento)  •  axe DevTools (accesibilidad)  •  package.json (mantenimiento)</a:t>
-            </a:r>
-          </a:p>
-        </p:txBody>
-      </p:sp>
-      <p:sp>
-        <p:nvSpPr>
-          <p:cNvPr id="8" name="Rounded Rectangle 7"/>
+              <a:t>🛠 Herramientas a usar (y comandos de pista):</a:t>
+            </a:r>
+          </a:p>
+        </p:txBody>
+      </p:sp>
+      <p:sp>
+        <p:nvSpPr>
+          <p:cNvPr id="7" name="Rounded Rectangle 6"/>
           <p:cNvSpPr/>
           <p:nvPr/>
         </p:nvSpPr>
         <p:spPr>
           <a:xfrm>
-            <a:off x="426567" y="2286000"/>
-            <a:ext cx="3657600" cy="3108960"/>
+            <a:off x="426567" y="1691640"/>
+            <a:ext cx="3657600" cy="3840480"/>
           </a:xfrm>
           <a:prstGeom prst="roundRect">
             <a:avLst/>
@@ -8338,14 +9087,14 @@
       </p:sp>
       <p:sp>
         <p:nvSpPr>
-          <p:cNvPr id="9" name="Rectangle 8"/>
+          <p:cNvPr id="8" name="Rectangle 7"/>
           <p:cNvSpPr/>
           <p:nvPr/>
         </p:nvSpPr>
         <p:spPr>
           <a:xfrm>
-            <a:off x="426567" y="2286000"/>
-            <a:ext cx="3657600" cy="548640"/>
+            <a:off x="426567" y="1691640"/>
+            <a:ext cx="3657600" cy="457200"/>
           </a:xfrm>
           <a:prstGeom prst="rect">
             <a:avLst/>
@@ -8381,35 +9130,70 @@
       </p:sp>
       <p:sp>
         <p:nvSpPr>
+          <p:cNvPr id="9" name="TextBox 8"/>
+          <p:cNvSpPr txBox="1"/>
+          <p:nvPr/>
+        </p:nvSpPr>
+        <p:spPr>
+          <a:xfrm>
+            <a:off x="426567" y="1737360"/>
+            <a:ext cx="3657600" cy="365760"/>
+          </a:xfrm>
+          <a:prstGeom prst="rect">
+            <a:avLst/>
+          </a:prstGeom>
+          <a:noFill/>
+        </p:spPr>
+        <p:txBody>
+          <a:bodyPr wrap="square">
+            <a:spAutoFit/>
+          </a:bodyPr>
+          <a:lstStyle/>
+          <a:p>
+            <a:pPr algn="ctr"/>
+            <a:r>
+              <a:rPr sz="1600" b="1">
+                <a:solidFill>
+                  <a:srgbClr val="FFFFFF"/>
+                </a:solidFill>
+                <a:latin typeface="Calibri"/>
+              </a:rPr>
+              <a:t>📊 RENDIMIENTO</a:t>
+            </a:r>
+          </a:p>
+        </p:txBody>
+      </p:sp>
+      <p:sp>
+        <p:nvSpPr>
           <p:cNvPr id="10" name="TextBox 9"/>
           <p:cNvSpPr txBox="1"/>
           <p:nvPr/>
         </p:nvSpPr>
         <p:spPr>
           <a:xfrm>
-            <a:off x="426567" y="2331720"/>
-            <a:ext cx="3657600" cy="457200"/>
-          </a:xfrm>
-          <a:prstGeom prst="rect">
-            <a:avLst/>
-          </a:prstGeom>
-          <a:noFill/>
-        </p:spPr>
-        <p:txBody>
-          <a:bodyPr wrap="square">
-            <a:spAutoFit/>
-          </a:bodyPr>
-          <a:lstStyle/>
-          <a:p>
-            <a:pPr algn="ctr"/>
-            <a:r>
-              <a:rPr sz="1800" b="1">
-                <a:solidFill>
-                  <a:srgbClr val="FFFFFF"/>
-                </a:solidFill>
-                <a:latin typeface="Calibri"/>
-              </a:rPr>
-              <a:t>📊 RENDIMIENTO</a:t>
+            <a:off x="563727" y="2194560"/>
+            <a:ext cx="3383280" cy="274320"/>
+          </a:xfrm>
+          <a:prstGeom prst="rect">
+            <a:avLst/>
+          </a:prstGeom>
+          <a:noFill/>
+        </p:spPr>
+        <p:txBody>
+          <a:bodyPr wrap="square">
+            <a:spAutoFit/>
+          </a:bodyPr>
+          <a:lstStyle/>
+          <a:p>
+            <a:pPr algn="l"/>
+            <a:r>
+              <a:rPr sz="1100" b="1">
+                <a:solidFill>
+                  <a:srgbClr val="1C7293"/>
+                </a:solidFill>
+                <a:latin typeface="Calibri"/>
+              </a:rPr>
+              <a:t>Herramientas:</a:t>
             </a:r>
           </a:p>
         </p:txBody>
@@ -8422,23 +9206,23 @@
         </p:nvSpPr>
         <p:spPr>
           <a:xfrm>
-            <a:off x="563727" y="2926080"/>
-            <a:ext cx="3383280" cy="1463040"/>
-          </a:xfrm>
-          <a:prstGeom prst="rect">
-            <a:avLst/>
-          </a:prstGeom>
-          <a:noFill/>
-        </p:spPr>
-        <p:txBody>
-          <a:bodyPr wrap="square">
-            <a:spAutoFit/>
-          </a:bodyPr>
-          <a:lstStyle/>
-          <a:p>
-            <a:pPr algn="l"/>
-            <a:r>
-              <a:rPr sz="1200" b="1">
+            <a:off x="563727" y="2468880"/>
+            <a:ext cx="3383280" cy="274320"/>
+          </a:xfrm>
+          <a:prstGeom prst="rect">
+            <a:avLst/>
+          </a:prstGeom>
+          <a:noFill/>
+        </p:spPr>
+        <p:txBody>
+          <a:bodyPr wrap="square">
+            <a:spAutoFit/>
+          </a:bodyPr>
+          <a:lstStyle/>
+          <a:p>
+            <a:pPr algn="l"/>
+            <a:r>
+              <a:rPr sz="1100" b="0">
                 <a:solidFill>
                   <a:srgbClr val="2A2A2A"/>
                 </a:solidFill>
@@ -8447,29 +9231,74 @@
               <a:t>Chrome DevTools + Lighthouse</a:t>
             </a:r>
           </a:p>
-          <a:p>
-            <a:pPr algn="l"/>
-            <a:r>
-              <a:rPr sz="1200" b="0">
+        </p:txBody>
+      </p:sp>
+      <p:sp>
+        <p:nvSpPr>
+          <p:cNvPr id="12" name="TextBox 11"/>
+          <p:cNvSpPr txBox="1"/>
+          <p:nvPr/>
+        </p:nvSpPr>
+        <p:spPr>
+          <a:xfrm>
+            <a:off x="563727" y="2788920"/>
+            <a:ext cx="3383280" cy="274320"/>
+          </a:xfrm>
+          <a:prstGeom prst="rect">
+            <a:avLst/>
+          </a:prstGeom>
+          <a:noFill/>
+        </p:spPr>
+        <p:txBody>
+          <a:bodyPr wrap="square">
+            <a:spAutoFit/>
+          </a:bodyPr>
+          <a:lstStyle/>
+          <a:p>
+            <a:pPr algn="l"/>
+            <a:r>
+              <a:rPr sz="1100" b="1">
+                <a:solidFill>
+                  <a:srgbClr val="1C7293"/>
+                </a:solidFill>
+                <a:latin typeface="Calibri"/>
+              </a:rPr>
+              <a:t>Ejemplos:</a:t>
+            </a:r>
+          </a:p>
+        </p:txBody>
+      </p:sp>
+      <p:sp>
+        <p:nvSpPr>
+          <p:cNvPr id="13" name="TextBox 12"/>
+          <p:cNvSpPr txBox="1"/>
+          <p:nvPr/>
+        </p:nvSpPr>
+        <p:spPr>
+          <a:xfrm>
+            <a:off x="563727" y="3017520"/>
+            <a:ext cx="3383280" cy="1005840"/>
+          </a:xfrm>
+          <a:prstGeom prst="rect">
+            <a:avLst/>
+          </a:prstGeom>
+          <a:noFill/>
+        </p:spPr>
+        <p:txBody>
+          <a:bodyPr wrap="square">
+            <a:spAutoFit/>
+          </a:bodyPr>
+          <a:lstStyle/>
+          <a:p>
+            <a:pPr algn="l"/>
+            <a:r>
+              <a:rPr sz="900" b="0">
                 <a:solidFill>
                   <a:srgbClr val="2A2A2A"/>
                 </a:solidFill>
                 <a:latin typeface="Calibri"/>
               </a:rPr>
-              <a:t/>
-            </a:r>
-          </a:p>
-          <a:p>
-            <a:pPr algn="l"/>
-            <a:r>
-              <a:rPr sz="1200" b="0">
-                <a:solidFill>
-                  <a:srgbClr val="2A2A2A"/>
-                </a:solidFill>
-                <a:latin typeface="Calibri"/>
-              </a:rPr>
-              <a:t>Ejemplos:
-• Imagen sin width/height (CLS)
+              <a:t>• Imagen sin width/height (CLS)
 • Imágenes sin loading='lazy'
 • &lt;script&gt; sin defer
 • SVGs innecesariamente pesados
@@ -8480,13 +9309,91 @@
       </p:sp>
       <p:sp>
         <p:nvSpPr>
-          <p:cNvPr id="12" name="TextBox 11"/>
-          <p:cNvSpPr txBox="1"/>
-          <p:nvPr/>
-        </p:nvSpPr>
-        <p:spPr>
-          <a:xfrm>
-            <a:off x="426567" y="5166360"/>
+          <p:cNvPr id="14" name="Rectangle 13"/>
+          <p:cNvSpPr/>
+          <p:nvPr/>
+        </p:nvSpPr>
+        <p:spPr>
+          <a:xfrm>
+            <a:off x="518007" y="4114800"/>
+            <a:ext cx="3474720" cy="457200"/>
+          </a:xfrm>
+          <a:prstGeom prst="rect">
+            <a:avLst/>
+          </a:prstGeom>
+          <a:solidFill>
+            <a:srgbClr val="FFF3CD"/>
+          </a:solidFill>
+          <a:ln>
+            <a:noFill/>
+          </a:ln>
+        </p:spPr>
+        <p:style>
+          <a:lnRef idx="1">
+            <a:schemeClr val="accent1"/>
+          </a:lnRef>
+          <a:fillRef idx="3">
+            <a:schemeClr val="accent1"/>
+          </a:fillRef>
+          <a:effectRef idx="2">
+            <a:schemeClr val="accent1"/>
+          </a:effectRef>
+          <a:fontRef idx="minor">
+            <a:schemeClr val="lt1"/>
+          </a:fontRef>
+        </p:style>
+        <p:txBody>
+          <a:bodyPr rtlCol="0" anchor="ctr"/>
+          <a:lstStyle/>
+          <a:p>
+            <a:pPr algn="ctr"/>
+          </a:p>
+        </p:txBody>
+      </p:sp>
+      <p:sp>
+        <p:nvSpPr>
+          <p:cNvPr id="15" name="TextBox 14"/>
+          <p:cNvSpPr txBox="1"/>
+          <p:nvPr/>
+        </p:nvSpPr>
+        <p:spPr>
+          <a:xfrm>
+            <a:off x="563727" y="4133087"/>
+            <a:ext cx="3383280" cy="411480"/>
+          </a:xfrm>
+          <a:prstGeom prst="rect">
+            <a:avLst/>
+          </a:prstGeom>
+          <a:noFill/>
+        </p:spPr>
+        <p:txBody>
+          <a:bodyPr wrap="square">
+            <a:spAutoFit/>
+          </a:bodyPr>
+          <a:lstStyle/>
+          <a:p>
+            <a:pPr algn="ctr"/>
+            <a:r>
+              <a:rPr sz="900" b="0">
+                <a:solidFill>
+                  <a:srgbClr val="2A2A2A"/>
+                </a:solidFill>
+                <a:latin typeface="Consolas"/>
+              </a:rPr>
+              <a:t>💡 Pista: F12 → Lighthouse → Analyze</a:t>
+            </a:r>
+          </a:p>
+        </p:txBody>
+      </p:sp>
+      <p:sp>
+        <p:nvSpPr>
+          <p:cNvPr id="16" name="TextBox 15"/>
+          <p:cNvSpPr txBox="1"/>
+          <p:nvPr/>
+        </p:nvSpPr>
+        <p:spPr>
+          <a:xfrm>
+            <a:off x="426567" y="4663440"/>
             <a:ext cx="3657600" cy="274320"/>
           </a:xfrm>
           <a:prstGeom prst="rect">
@@ -8502,7 +9409,7 @@
           <a:p>
             <a:pPr algn="ctr"/>
             <a:r>
-              <a:rPr sz="1100" b="1">
+              <a:rPr sz="1000" b="1">
                 <a:solidFill>
                   <a:srgbClr val="1C7293"/>
                 </a:solidFill>
@@ -8515,14 +9422,14 @@
       </p:sp>
       <p:sp>
         <p:nvSpPr>
-          <p:cNvPr id="13" name="Rounded Rectangle 12"/>
+          <p:cNvPr id="17" name="Rounded Rectangle 16"/>
           <p:cNvSpPr/>
           <p:nvPr/>
         </p:nvSpPr>
         <p:spPr>
           <a:xfrm>
-            <a:off x="4267047" y="2286000"/>
-            <a:ext cx="3657600" cy="3108960"/>
+            <a:off x="4267047" y="1691640"/>
+            <a:ext cx="3657600" cy="3840480"/>
           </a:xfrm>
           <a:prstGeom prst="roundRect">
             <a:avLst/>
@@ -8560,14 +9467,14 @@
       </p:sp>
       <p:sp>
         <p:nvSpPr>
-          <p:cNvPr id="14" name="Rectangle 13"/>
+          <p:cNvPr id="18" name="Rectangle 17"/>
           <p:cNvSpPr/>
           <p:nvPr/>
         </p:nvSpPr>
         <p:spPr>
           <a:xfrm>
-            <a:off x="4267047" y="2286000"/>
-            <a:ext cx="3657600" cy="548640"/>
+            <a:off x="4267047" y="1691640"/>
+            <a:ext cx="3657600" cy="457200"/>
           </a:xfrm>
           <a:prstGeom prst="rect">
             <a:avLst/>
@@ -8603,14 +9510,14 @@
       </p:sp>
       <p:sp>
         <p:nvSpPr>
-          <p:cNvPr id="15" name="TextBox 14"/>
-          <p:cNvSpPr txBox="1"/>
-          <p:nvPr/>
-        </p:nvSpPr>
-        <p:spPr>
-          <a:xfrm>
-            <a:off x="4267047" y="2331720"/>
-            <a:ext cx="3657600" cy="457200"/>
+          <p:cNvPr id="19" name="TextBox 18"/>
+          <p:cNvSpPr txBox="1"/>
+          <p:nvPr/>
+        </p:nvSpPr>
+        <p:spPr>
+          <a:xfrm>
+            <a:off x="4267047" y="1737360"/>
+            <a:ext cx="3657600" cy="365760"/>
           </a:xfrm>
           <a:prstGeom prst="rect">
             <a:avLst/>
@@ -8625,7 +9532,7 @@
           <a:p>
             <a:pPr algn="ctr"/>
             <a:r>
-              <a:rPr sz="1800" b="1">
+              <a:rPr sz="1600" b="1">
                 <a:solidFill>
                   <a:srgbClr val="FFFFFF"/>
                 </a:solidFill>
@@ -8638,29 +9545,64 @@
       </p:sp>
       <p:sp>
         <p:nvSpPr>
-          <p:cNvPr id="16" name="TextBox 15"/>
-          <p:cNvSpPr txBox="1"/>
-          <p:nvPr/>
-        </p:nvSpPr>
-        <p:spPr>
-          <a:xfrm>
-            <a:off x="4404207" y="2926080"/>
-            <a:ext cx="3383280" cy="1463040"/>
-          </a:xfrm>
-          <a:prstGeom prst="rect">
-            <a:avLst/>
-          </a:prstGeom>
-          <a:noFill/>
-        </p:spPr>
-        <p:txBody>
-          <a:bodyPr wrap="square">
-            <a:spAutoFit/>
-          </a:bodyPr>
-          <a:lstStyle/>
-          <a:p>
-            <a:pPr algn="l"/>
-            <a:r>
-              <a:rPr sz="1200" b="1">
+          <p:cNvPr id="20" name="TextBox 19"/>
+          <p:cNvSpPr txBox="1"/>
+          <p:nvPr/>
+        </p:nvSpPr>
+        <p:spPr>
+          <a:xfrm>
+            <a:off x="4404207" y="2194560"/>
+            <a:ext cx="3383280" cy="274320"/>
+          </a:xfrm>
+          <a:prstGeom prst="rect">
+            <a:avLst/>
+          </a:prstGeom>
+          <a:noFill/>
+        </p:spPr>
+        <p:txBody>
+          <a:bodyPr wrap="square">
+            <a:spAutoFit/>
+          </a:bodyPr>
+          <a:lstStyle/>
+          <a:p>
+            <a:pPr algn="l"/>
+            <a:r>
+              <a:rPr sz="1100" b="1">
+                <a:solidFill>
+                  <a:srgbClr val="10B981"/>
+                </a:solidFill>
+                <a:latin typeface="Calibri"/>
+              </a:rPr>
+              <a:t>Herramientas:</a:t>
+            </a:r>
+          </a:p>
+        </p:txBody>
+      </p:sp>
+      <p:sp>
+        <p:nvSpPr>
+          <p:cNvPr id="21" name="TextBox 20"/>
+          <p:cNvSpPr txBox="1"/>
+          <p:nvPr/>
+        </p:nvSpPr>
+        <p:spPr>
+          <a:xfrm>
+            <a:off x="4404207" y="2468880"/>
+            <a:ext cx="3383280" cy="274320"/>
+          </a:xfrm>
+          <a:prstGeom prst="rect">
+            <a:avLst/>
+          </a:prstGeom>
+          <a:noFill/>
+        </p:spPr>
+        <p:txBody>
+          <a:bodyPr wrap="square">
+            <a:spAutoFit/>
+          </a:bodyPr>
+          <a:lstStyle/>
+          <a:p>
+            <a:pPr algn="l"/>
+            <a:r>
+              <a:rPr sz="1100" b="0">
                 <a:solidFill>
                   <a:srgbClr val="2A2A2A"/>
                 </a:solidFill>
@@ -8669,29 +9611,74 @@
               <a:t>axe DevTools</a:t>
             </a:r>
           </a:p>
-          <a:p>
-            <a:pPr algn="l"/>
-            <a:r>
-              <a:rPr sz="1200" b="0">
+        </p:txBody>
+      </p:sp>
+      <p:sp>
+        <p:nvSpPr>
+          <p:cNvPr id="22" name="TextBox 21"/>
+          <p:cNvSpPr txBox="1"/>
+          <p:nvPr/>
+        </p:nvSpPr>
+        <p:spPr>
+          <a:xfrm>
+            <a:off x="4404207" y="2788920"/>
+            <a:ext cx="3383280" cy="274320"/>
+          </a:xfrm>
+          <a:prstGeom prst="rect">
+            <a:avLst/>
+          </a:prstGeom>
+          <a:noFill/>
+        </p:spPr>
+        <p:txBody>
+          <a:bodyPr wrap="square">
+            <a:spAutoFit/>
+          </a:bodyPr>
+          <a:lstStyle/>
+          <a:p>
+            <a:pPr algn="l"/>
+            <a:r>
+              <a:rPr sz="1100" b="1">
+                <a:solidFill>
+                  <a:srgbClr val="10B981"/>
+                </a:solidFill>
+                <a:latin typeface="Calibri"/>
+              </a:rPr>
+              <a:t>Ejemplos:</a:t>
+            </a:r>
+          </a:p>
+        </p:txBody>
+      </p:sp>
+      <p:sp>
+        <p:nvSpPr>
+          <p:cNvPr id="23" name="TextBox 22"/>
+          <p:cNvSpPr txBox="1"/>
+          <p:nvPr/>
+        </p:nvSpPr>
+        <p:spPr>
+          <a:xfrm>
+            <a:off x="4404207" y="3017520"/>
+            <a:ext cx="3383280" cy="1005840"/>
+          </a:xfrm>
+          <a:prstGeom prst="rect">
+            <a:avLst/>
+          </a:prstGeom>
+          <a:noFill/>
+        </p:spPr>
+        <p:txBody>
+          <a:bodyPr wrap="square">
+            <a:spAutoFit/>
+          </a:bodyPr>
+          <a:lstStyle/>
+          <a:p>
+            <a:pPr algn="l"/>
+            <a:r>
+              <a:rPr sz="900" b="0">
                 <a:solidFill>
                   <a:srgbClr val="2A2A2A"/>
                 </a:solidFill>
                 <a:latin typeface="Calibri"/>
               </a:rPr>
-              <a:t/>
-            </a:r>
-          </a:p>
-          <a:p>
-            <a:pPr algn="l"/>
-            <a:r>
-              <a:rPr sz="1200" b="0">
-                <a:solidFill>
-                  <a:srgbClr val="2A2A2A"/>
-                </a:solidFill>
-                <a:latin typeface="Calibri"/>
-              </a:rPr>
-              <a:t>Ejemplos:
-• Imágenes sin alt
+              <a:t>• Imágenes sin alt
 • Botones sin aria-label
 • Contraste insuficiente
 • Inputs sin &lt;label&gt;
@@ -8702,13 +9689,91 @@
       </p:sp>
       <p:sp>
         <p:nvSpPr>
-          <p:cNvPr id="17" name="TextBox 16"/>
-          <p:cNvSpPr txBox="1"/>
-          <p:nvPr/>
-        </p:nvSpPr>
-        <p:spPr>
-          <a:xfrm>
-            <a:off x="4267047" y="5166360"/>
+          <p:cNvPr id="24" name="Rectangle 23"/>
+          <p:cNvSpPr/>
+          <p:nvPr/>
+        </p:nvSpPr>
+        <p:spPr>
+          <a:xfrm>
+            <a:off x="4358487" y="4114800"/>
+            <a:ext cx="3474720" cy="457200"/>
+          </a:xfrm>
+          <a:prstGeom prst="rect">
+            <a:avLst/>
+          </a:prstGeom>
+          <a:solidFill>
+            <a:srgbClr val="FFF3CD"/>
+          </a:solidFill>
+          <a:ln>
+            <a:noFill/>
+          </a:ln>
+        </p:spPr>
+        <p:style>
+          <a:lnRef idx="1">
+            <a:schemeClr val="accent1"/>
+          </a:lnRef>
+          <a:fillRef idx="3">
+            <a:schemeClr val="accent1"/>
+          </a:fillRef>
+          <a:effectRef idx="2">
+            <a:schemeClr val="accent1"/>
+          </a:effectRef>
+          <a:fontRef idx="minor">
+            <a:schemeClr val="lt1"/>
+          </a:fontRef>
+        </p:style>
+        <p:txBody>
+          <a:bodyPr rtlCol="0" anchor="ctr"/>
+          <a:lstStyle/>
+          <a:p>
+            <a:pPr algn="ctr"/>
+          </a:p>
+        </p:txBody>
+      </p:sp>
+      <p:sp>
+        <p:nvSpPr>
+          <p:cNvPr id="25" name="TextBox 24"/>
+          <p:cNvSpPr txBox="1"/>
+          <p:nvPr/>
+        </p:nvSpPr>
+        <p:spPr>
+          <a:xfrm>
+            <a:off x="4404207" y="4133087"/>
+            <a:ext cx="3383280" cy="411480"/>
+          </a:xfrm>
+          <a:prstGeom prst="rect">
+            <a:avLst/>
+          </a:prstGeom>
+          <a:noFill/>
+        </p:spPr>
+        <p:txBody>
+          <a:bodyPr wrap="square">
+            <a:spAutoFit/>
+          </a:bodyPr>
+          <a:lstStyle/>
+          <a:p>
+            <a:pPr algn="ctr"/>
+            <a:r>
+              <a:rPr sz="900" b="0">
+                <a:solidFill>
+                  <a:srgbClr val="2A2A2A"/>
+                </a:solidFill>
+                <a:latin typeface="Consolas"/>
+              </a:rPr>
+              <a:t>💡 Pista: F12 → axe DevTools → Scan</a:t>
+            </a:r>
+          </a:p>
+        </p:txBody>
+      </p:sp>
+      <p:sp>
+        <p:nvSpPr>
+          <p:cNvPr id="26" name="TextBox 25"/>
+          <p:cNvSpPr txBox="1"/>
+          <p:nvPr/>
+        </p:nvSpPr>
+        <p:spPr>
+          <a:xfrm>
+            <a:off x="4267047" y="4663440"/>
             <a:ext cx="3657600" cy="274320"/>
           </a:xfrm>
           <a:prstGeom prst="rect">
@@ -8724,7 +9789,7 @@
           <a:p>
             <a:pPr algn="ctr"/>
             <a:r>
-              <a:rPr sz="1100" b="1">
+              <a:rPr sz="1000" b="1">
                 <a:solidFill>
                   <a:srgbClr val="10B981"/>
                 </a:solidFill>
@@ -8737,14 +9802,14 @@
       </p:sp>
       <p:sp>
         <p:nvSpPr>
-          <p:cNvPr id="18" name="Rounded Rectangle 17"/>
+          <p:cNvPr id="27" name="Rounded Rectangle 26"/>
           <p:cNvSpPr/>
           <p:nvPr/>
         </p:nvSpPr>
         <p:spPr>
           <a:xfrm>
-            <a:off x="8107527" y="2286000"/>
-            <a:ext cx="3657600" cy="3108960"/>
+            <a:off x="8107527" y="1691640"/>
+            <a:ext cx="3657600" cy="3840480"/>
           </a:xfrm>
           <a:prstGeom prst="roundRect">
             <a:avLst/>
@@ -8782,14 +9847,14 @@
       </p:sp>
       <p:sp>
         <p:nvSpPr>
-          <p:cNvPr id="19" name="Rectangle 18"/>
+          <p:cNvPr id="28" name="Rectangle 27"/>
           <p:cNvSpPr/>
           <p:nvPr/>
         </p:nvSpPr>
         <p:spPr>
           <a:xfrm>
-            <a:off x="8107527" y="2286000"/>
-            <a:ext cx="3657600" cy="548640"/>
+            <a:off x="8107527" y="1691640"/>
+            <a:ext cx="3657600" cy="457200"/>
           </a:xfrm>
           <a:prstGeom prst="rect">
             <a:avLst/>
@@ -8825,14 +9890,14 @@
       </p:sp>
       <p:sp>
         <p:nvSpPr>
-          <p:cNvPr id="20" name="TextBox 19"/>
-          <p:cNvSpPr txBox="1"/>
-          <p:nvPr/>
-        </p:nvSpPr>
-        <p:spPr>
-          <a:xfrm>
-            <a:off x="8107527" y="2331720"/>
-            <a:ext cx="3657600" cy="457200"/>
+          <p:cNvPr id="29" name="TextBox 28"/>
+          <p:cNvSpPr txBox="1"/>
+          <p:nvPr/>
+        </p:nvSpPr>
+        <p:spPr>
+          <a:xfrm>
+            <a:off x="8107527" y="1737360"/>
+            <a:ext cx="3657600" cy="365760"/>
           </a:xfrm>
           <a:prstGeom prst="rect">
             <a:avLst/>
@@ -8847,7 +9912,7 @@
           <a:p>
             <a:pPr algn="ctr"/>
             <a:r>
-              <a:rPr sz="1800" b="1">
+              <a:rPr sz="1600" b="1">
                 <a:solidFill>
                   <a:srgbClr val="FFFFFF"/>
                 </a:solidFill>
@@ -8860,29 +9925,64 @@
       </p:sp>
       <p:sp>
         <p:nvSpPr>
-          <p:cNvPr id="21" name="TextBox 20"/>
-          <p:cNvSpPr txBox="1"/>
-          <p:nvPr/>
-        </p:nvSpPr>
-        <p:spPr>
-          <a:xfrm>
-            <a:off x="8244687" y="2926080"/>
-            <a:ext cx="3383280" cy="1463040"/>
-          </a:xfrm>
-          <a:prstGeom prst="rect">
-            <a:avLst/>
-          </a:prstGeom>
-          <a:noFill/>
-        </p:spPr>
-        <p:txBody>
-          <a:bodyPr wrap="square">
-            <a:spAutoFit/>
-          </a:bodyPr>
-          <a:lstStyle/>
-          <a:p>
-            <a:pPr algn="l"/>
-            <a:r>
-              <a:rPr sz="1200" b="1">
+          <p:cNvPr id="30" name="TextBox 29"/>
+          <p:cNvSpPr txBox="1"/>
+          <p:nvPr/>
+        </p:nvSpPr>
+        <p:spPr>
+          <a:xfrm>
+            <a:off x="8244687" y="2194560"/>
+            <a:ext cx="3383280" cy="274320"/>
+          </a:xfrm>
+          <a:prstGeom prst="rect">
+            <a:avLst/>
+          </a:prstGeom>
+          <a:noFill/>
+        </p:spPr>
+        <p:txBody>
+          <a:bodyPr wrap="square">
+            <a:spAutoFit/>
+          </a:bodyPr>
+          <a:lstStyle/>
+          <a:p>
+            <a:pPr algn="l"/>
+            <a:r>
+              <a:rPr sz="1100" b="1">
+                <a:solidFill>
+                  <a:srgbClr val="EA580C"/>
+                </a:solidFill>
+                <a:latin typeface="Calibri"/>
+              </a:rPr>
+              <a:t>Herramientas:</a:t>
+            </a:r>
+          </a:p>
+        </p:txBody>
+      </p:sp>
+      <p:sp>
+        <p:nvSpPr>
+          <p:cNvPr id="31" name="TextBox 30"/>
+          <p:cNvSpPr txBox="1"/>
+          <p:nvPr/>
+        </p:nvSpPr>
+        <p:spPr>
+          <a:xfrm>
+            <a:off x="8244687" y="2468880"/>
+            <a:ext cx="3383280" cy="274320"/>
+          </a:xfrm>
+          <a:prstGeom prst="rect">
+            <a:avLst/>
+          </a:prstGeom>
+          <a:noFill/>
+        </p:spPr>
+        <p:txBody>
+          <a:bodyPr wrap="square">
+            <a:spAutoFit/>
+          </a:bodyPr>
+          <a:lstStyle/>
+          <a:p>
+            <a:pPr algn="l"/>
+            <a:r>
+              <a:rPr sz="1100" b="0">
                 <a:solidFill>
                   <a:srgbClr val="2A2A2A"/>
                 </a:solidFill>
@@ -8891,29 +9991,74 @@
               <a:t>package.json + código</a:t>
             </a:r>
           </a:p>
-          <a:p>
-            <a:pPr algn="l"/>
-            <a:r>
-              <a:rPr sz="1200" b="0">
+        </p:txBody>
+      </p:sp>
+      <p:sp>
+        <p:nvSpPr>
+          <p:cNvPr id="32" name="TextBox 31"/>
+          <p:cNvSpPr txBox="1"/>
+          <p:nvPr/>
+        </p:nvSpPr>
+        <p:spPr>
+          <a:xfrm>
+            <a:off x="8244687" y="2788920"/>
+            <a:ext cx="3383280" cy="274320"/>
+          </a:xfrm>
+          <a:prstGeom prst="rect">
+            <a:avLst/>
+          </a:prstGeom>
+          <a:noFill/>
+        </p:spPr>
+        <p:txBody>
+          <a:bodyPr wrap="square">
+            <a:spAutoFit/>
+          </a:bodyPr>
+          <a:lstStyle/>
+          <a:p>
+            <a:pPr algn="l"/>
+            <a:r>
+              <a:rPr sz="1100" b="1">
+                <a:solidFill>
+                  <a:srgbClr val="EA580C"/>
+                </a:solidFill>
+                <a:latin typeface="Calibri"/>
+              </a:rPr>
+              <a:t>Ejemplos:</a:t>
+            </a:r>
+          </a:p>
+        </p:txBody>
+      </p:sp>
+      <p:sp>
+        <p:nvSpPr>
+          <p:cNvPr id="33" name="TextBox 32"/>
+          <p:cNvSpPr txBox="1"/>
+          <p:nvPr/>
+        </p:nvSpPr>
+        <p:spPr>
+          <a:xfrm>
+            <a:off x="8244687" y="3017520"/>
+            <a:ext cx="3383280" cy="1005840"/>
+          </a:xfrm>
+          <a:prstGeom prst="rect">
+            <a:avLst/>
+          </a:prstGeom>
+          <a:noFill/>
+        </p:spPr>
+        <p:txBody>
+          <a:bodyPr wrap="square">
+            <a:spAutoFit/>
+          </a:bodyPr>
+          <a:lstStyle/>
+          <a:p>
+            <a:pPr algn="l"/>
+            <a:r>
+              <a:rPr sz="900" b="0">
                 <a:solidFill>
                   <a:srgbClr val="2A2A2A"/>
                 </a:solidFill>
                 <a:latin typeface="Calibri"/>
               </a:rPr>
-              <a:t/>
-            </a:r>
-          </a:p>
-          <a:p>
-            <a:pPr algn="l"/>
-            <a:r>
-              <a:rPr sz="1200" b="0">
-                <a:solidFill>
-                  <a:srgbClr val="2A2A2A"/>
-                </a:solidFill>
-                <a:latin typeface="Calibri"/>
-              </a:rPr>
-              <a:t>Ejemplos:
-• jQuery 2.1.4 (versión antigua)
+              <a:t>• jQuery 2.1.4 (versión antigua)
 • Meta tags de seguridad faltantes
 • Comentarios TODO/FIXME
 • Footer desactualizado
@@ -8924,13 +10069,91 @@
       </p:sp>
       <p:sp>
         <p:nvSpPr>
-          <p:cNvPr id="22" name="TextBox 21"/>
-          <p:cNvSpPr txBox="1"/>
-          <p:nvPr/>
-        </p:nvSpPr>
-        <p:spPr>
-          <a:xfrm>
-            <a:off x="8107527" y="5166360"/>
+          <p:cNvPr id="34" name="Rectangle 33"/>
+          <p:cNvSpPr/>
+          <p:nvPr/>
+        </p:nvSpPr>
+        <p:spPr>
+          <a:xfrm>
+            <a:off x="8198967" y="4114800"/>
+            <a:ext cx="3474720" cy="457200"/>
+          </a:xfrm>
+          <a:prstGeom prst="rect">
+            <a:avLst/>
+          </a:prstGeom>
+          <a:solidFill>
+            <a:srgbClr val="FFF3CD"/>
+          </a:solidFill>
+          <a:ln>
+            <a:noFill/>
+          </a:ln>
+        </p:spPr>
+        <p:style>
+          <a:lnRef idx="1">
+            <a:schemeClr val="accent1"/>
+          </a:lnRef>
+          <a:fillRef idx="3">
+            <a:schemeClr val="accent1"/>
+          </a:fillRef>
+          <a:effectRef idx="2">
+            <a:schemeClr val="accent1"/>
+          </a:effectRef>
+          <a:fontRef idx="minor">
+            <a:schemeClr val="lt1"/>
+          </a:fontRef>
+        </p:style>
+        <p:txBody>
+          <a:bodyPr rtlCol="0" anchor="ctr"/>
+          <a:lstStyle/>
+          <a:p>
+            <a:pPr algn="ctr"/>
+          </a:p>
+        </p:txBody>
+      </p:sp>
+      <p:sp>
+        <p:nvSpPr>
+          <p:cNvPr id="35" name="TextBox 34"/>
+          <p:cNvSpPr txBox="1"/>
+          <p:nvPr/>
+        </p:nvSpPr>
+        <p:spPr>
+          <a:xfrm>
+            <a:off x="8244687" y="4133087"/>
+            <a:ext cx="3383280" cy="411480"/>
+          </a:xfrm>
+          <a:prstGeom prst="rect">
+            <a:avLst/>
+          </a:prstGeom>
+          <a:noFill/>
+        </p:spPr>
+        <p:txBody>
+          <a:bodyPr wrap="square">
+            <a:spAutoFit/>
+          </a:bodyPr>
+          <a:lstStyle/>
+          <a:p>
+            <a:pPr algn="ctr"/>
+            <a:r>
+              <a:rPr sz="900" b="0">
+                <a:solidFill>
+                  <a:srgbClr val="2A2A2A"/>
+                </a:solidFill>
+                <a:latin typeface="Consolas"/>
+              </a:rPr>
+              <a:t>💡 Pista: cat package.json  |  grep -r TODO  |  curl -I URL</a:t>
+            </a:r>
+          </a:p>
+        </p:txBody>
+      </p:sp>
+      <p:sp>
+        <p:nvSpPr>
+          <p:cNvPr id="36" name="TextBox 35"/>
+          <p:cNvSpPr txBox="1"/>
+          <p:nvPr/>
+        </p:nvSpPr>
+        <p:spPr>
+          <a:xfrm>
+            <a:off x="8107527" y="4663440"/>
             <a:ext cx="3657600" cy="274320"/>
           </a:xfrm>
           <a:prstGeom prst="rect">
@@ -8946,7 +10169,7 @@
           <a:p>
             <a:pPr algn="ctr"/>
             <a:r>
-              <a:rPr sz="1100" b="1">
+              <a:rPr sz="1000" b="1">
                 <a:solidFill>
                   <a:srgbClr val="EA580C"/>
                 </a:solidFill>
@@ -8959,14 +10182,14 @@
       </p:sp>
       <p:sp>
         <p:nvSpPr>
-          <p:cNvPr id="23" name="Rounded Rectangle 22"/>
+          <p:cNvPr id="37" name="Rounded Rectangle 36"/>
           <p:cNvSpPr/>
           <p:nvPr/>
         </p:nvSpPr>
         <p:spPr>
           <a:xfrm>
-            <a:off x="640080" y="5669280"/>
-            <a:ext cx="10972800" cy="548640"/>
+            <a:off x="640080" y="5760720"/>
+            <a:ext cx="10972800" cy="457200"/>
           </a:xfrm>
           <a:prstGeom prst="roundRect">
             <a:avLst/>
@@ -9004,13 +10227,13 @@
       </p:sp>
       <p:sp>
         <p:nvSpPr>
-          <p:cNvPr id="24" name="TextBox 23"/>
-          <p:cNvSpPr txBox="1"/>
-          <p:nvPr/>
-        </p:nvSpPr>
-        <p:spPr>
-          <a:xfrm>
-            <a:off x="640080" y="5760720"/>
+          <p:cNvPr id="38" name="TextBox 37"/>
+          <p:cNvSpPr txBox="1"/>
+          <p:nvPr/>
+        </p:nvSpPr>
+        <p:spPr>
+          <a:xfrm>
+            <a:off x="640080" y="5806440"/>
             <a:ext cx="10972800" cy="365760"/>
           </a:xfrm>
           <a:prstGeom prst="rect">
@@ -9039,7 +10262,7 @@
       </p:sp>
       <p:sp>
         <p:nvSpPr>
-          <p:cNvPr id="25" name="TextBox 24"/>
+          <p:cNvPr id="39" name="TextBox 38"/>
           <p:cNvSpPr txBox="1"/>
           <p:nvPr/>
         </p:nvSpPr>
@@ -9074,7 +10297,7 @@
       </p:sp>
       <p:sp>
         <p:nvSpPr>
-          <p:cNvPr id="26" name="TextBox 25"/>
+          <p:cNvPr id="40" name="TextBox 39"/>
           <p:cNvSpPr txBox="1"/>
           <p:nvPr/>
         </p:nvSpPr>

</xml_diff>